<commit_message>
Extend presentation with cotton series 2015-2025, district data and 2026 crop placement
Co-Authored-By: Claude Sonnet 5.5 <noreply@anthropic.com>
Claude-Session: https://claude.ai/code/session_01M4MZatV28utL9zTp7saaUz
</commit_message>
<xml_diff>
--- a/Garbiy_Farg_ona_tuproqlari_GAT_asosida_bashoratlash.pptx
+++ b/Garbiy_Farg_ona_tuproqlari_GAT_asosida_bashoratlash.pptx
@@ -16,6 +16,7 @@
     <p:sldId id="264" r:id="rId10"/>
     <p:sldId id="272" r:id="rId23"/>
     <p:sldId id="273" r:id="rId24"/>
+    <p:sldId id="274" r:id="rId25"/>
     <p:sldId id="265" r:id="rId11"/>
     <p:sldId id="266" r:id="rId12"/>
     <p:sldId id="267" r:id="rId13"/>
@@ -378,7 +379,7 @@
             </a:solidFill>
           </c:spPr>
           <c:dPt>
-            <c:idx val="4"/>
+            <c:idx val="10"/>
             <c:spPr>
               <a:solidFill>
                 <a:srgbClr val="A4521D"/>
@@ -387,47 +388,83 @@
           </c:dPt>
           <c:cat>
             <c:strRef>
-              <c:f>Sheet1!$A$2:$A$6</c:f>
+              <c:f>Sheet1!$A$2:$A$12</c:f>
               <c:strCache>
-                <c:ptCount val="5"/>
+                <c:ptCount val="11"/>
                 <c:pt idx="0">
+                  <c:v>2015</c:v>
+                </c:pt>
+                <c:pt idx="1">
+                  <c:v>2016</c:v>
+                </c:pt>
+                <c:pt idx="2">
+                  <c:v>2017</c:v>
+                </c:pt>
+                <c:pt idx="3">
+                  <c:v>2018</c:v>
+                </c:pt>
+                <c:pt idx="4">
+                  <c:v>2019</c:v>
+                </c:pt>
+                <c:pt idx="5">
                   <c:v>2020</c:v>
                 </c:pt>
-                <c:pt idx="1">
+                <c:pt idx="6">
                   <c:v>2021</c:v>
                 </c:pt>
-                <c:pt idx="2">
+                <c:pt idx="7">
                   <c:v>2022</c:v>
                 </c:pt>
-                <c:pt idx="3">
+                <c:pt idx="8">
                   <c:v>2023</c:v>
                 </c:pt>
-                <c:pt idx="4">
+                <c:pt idx="9">
                   <c:v>2024</c:v>
+                </c:pt>
+                <c:pt idx="10">
+                  <c:v>2025</c:v>
                 </c:pt>
               </c:strCache>
             </c:strRef>
           </c:cat>
           <c:val>
             <c:numRef>
-              <c:f>Sheet1!$B$2:$B$6</c:f>
+              <c:f>Sheet1!$B$2:$B$12</c:f>
               <c:numCache>
                 <c:formatCode>General</c:formatCode>
-                <c:ptCount val="5"/>
+                <c:ptCount val="11"/>
                 <c:pt idx="0">
+                  <c:v>30.5</c:v>
+                </c:pt>
+                <c:pt idx="1">
+                  <c:v>24.8</c:v>
+                </c:pt>
+                <c:pt idx="2">
+                  <c:v>26.8</c:v>
+                </c:pt>
+                <c:pt idx="3">
+                  <c:v>26.6</c:v>
+                </c:pt>
+                <c:pt idx="4">
+                  <c:v>32.6</c:v>
+                </c:pt>
+                <c:pt idx="5">
                   <c:v>33.8</c:v>
                 </c:pt>
-                <c:pt idx="1">
-                  <c:v>35.2</c:v>
+                <c:pt idx="6">
+                  <c:v>35.4</c:v>
                 </c:pt>
-                <c:pt idx="2">
+                <c:pt idx="7">
                   <c:v>37.0</c:v>
                 </c:pt>
-                <c:pt idx="3">
+                <c:pt idx="8">
                   <c:v>39.3</c:v>
                 </c:pt>
-                <c:pt idx="4">
+                <c:pt idx="9">
                   <c:v>35.1</c:v>
+                </c:pt>
+                <c:pt idx="10">
+                  <c:v>46.6</c:v>
                 </c:pt>
               </c:numCache>
             </c:numRef>
@@ -503,7 +540,7 @@
       <c:valAx>
         <c:axId val="-2113994440"/>
         <c:scaling>
-          <c:max val="46.0"/>
+          <c:max val="56.0"/>
           <c:min val="0.0"/>
         </c:scaling>
         <c:delete/>
@@ -695,6 +732,243 @@
         </c:scaling>
         <c:delete/>
         <c:axPos val="l"/>
+        <c:majorTickMark val="out"/>
+        <c:minorTickMark val="none"/>
+        <c:tickLblPos val="nextTo"/>
+        <c:crossAx val="-2068027336"/>
+        <c:crosses val="autoZero"/>
+      </c:valAx>
+    </c:plotArea>
+    <c:dispBlanksAs val="gap"/>
+  </c:chart>
+  <c:txPr>
+    <a:bodyPr/>
+    <a:lstStyle/>
+    <a:p>
+      <a:pPr>
+        <a:defRPr sz="1200">
+          <a:solidFill>
+            <a:srgbClr val="4C5852"/>
+          </a:solidFill>
+          <a:latin typeface="Inter"/>
+        </a:defRPr>
+      </a:pPr>
+      <a:endParaRPr lang="en-US"/>
+    </a:p>
+  </c:txPr>
+  <c:externalData r:id="rId1">
+    <c:autoUpdate val="0"/>
+  </c:externalData>
+</c:chartSpace>
+</file>
+
+<file path=ppt/charts/chart4.xml><?xml version="1.0" encoding="utf-8"?>
+<c:chartSpace xmlns:c="http://schemas.openxmlformats.org/drawingml/2006/chart" xmlns:a="http://schemas.openxmlformats.org/drawingml/2006/main" xmlns:r="http://schemas.openxmlformats.org/officeDocument/2006/relationships">
+  <c:date1904 val="0"/>
+  <c:chart>
+    <c:autoTitleDeleted val="1"/>
+    <c:plotArea>
+      <c:barChart>
+        <c:barDir val="bar"/>
+        <c:grouping val="clustered"/>
+        <c:ser>
+          <c:idx val="0"/>
+          <c:order val="0"/>
+          <c:tx>
+            <c:strRef>
+              <c:f>Sheet1!$B$1</c:f>
+              <c:strCache>
+                <c:ptCount val="1"/>
+                <c:pt idx="0">
+                  <c:v>Paxta</c:v>
+                </c:pt>
+              </c:strCache>
+            </c:strRef>
+          </c:tx>
+          <c:spPr>
+            <a:solidFill>
+              <a:srgbClr val="2C6A85"/>
+            </a:solidFill>
+          </c:spPr>
+          <c:dPt>
+            <c:idx val="11"/>
+            <c:spPr>
+              <a:solidFill>
+                <a:srgbClr val="A4521D"/>
+              </a:solidFill>
+            </c:spPr>
+          </c:dPt>
+          <c:cat>
+            <c:strRef>
+              <c:f>Sheet1!$A$2:$A$14</c:f>
+              <c:strCache>
+                <c:ptCount val="13"/>
+                <c:pt idx="0">
+                  <c:v>Jalaquduq</c:v>
+                </c:pt>
+                <c:pt idx="1">
+                  <c:v>Qoʻrgʻontepa</c:v>
+                </c:pt>
+                <c:pt idx="2">
+                  <c:v>Baliqchi</c:v>
+                </c:pt>
+                <c:pt idx="3">
+                  <c:v>Marhamat</c:v>
+                </c:pt>
+                <c:pt idx="4">
+                  <c:v>Oltinkoʻl</c:v>
+                </c:pt>
+                <c:pt idx="5">
+                  <c:v>Xoʻjaobod</c:v>
+                </c:pt>
+                <c:pt idx="6">
+                  <c:v>Paxtaobod</c:v>
+                </c:pt>
+                <c:pt idx="7">
+                  <c:v>Buloqboshi</c:v>
+                </c:pt>
+                <c:pt idx="8">
+                  <c:v>Andijon</c:v>
+                </c:pt>
+                <c:pt idx="9">
+                  <c:v>Izboskan</c:v>
+                </c:pt>
+                <c:pt idx="10">
+                  <c:v>Shahrixon</c:v>
+                </c:pt>
+                <c:pt idx="11">
+                  <c:v>Ulugʻnor</c:v>
+                </c:pt>
+                <c:pt idx="12">
+                  <c:v>Boʻston</c:v>
+                </c:pt>
+              </c:strCache>
+            </c:strRef>
+          </c:cat>
+          <c:val>
+            <c:numRef>
+              <c:f>Sheet1!$B$2:$B$14</c:f>
+              <c:numCache>
+                <c:formatCode>General</c:formatCode>
+                <c:ptCount val="13"/>
+                <c:pt idx="0">
+                  <c:v>50.0</c:v>
+                </c:pt>
+                <c:pt idx="1">
+                  <c:v>48.5</c:v>
+                </c:pt>
+                <c:pt idx="2">
+                  <c:v>48.0</c:v>
+                </c:pt>
+                <c:pt idx="3">
+                  <c:v>48.0</c:v>
+                </c:pt>
+                <c:pt idx="4">
+                  <c:v>48.0</c:v>
+                </c:pt>
+                <c:pt idx="5">
+                  <c:v>47.2</c:v>
+                </c:pt>
+                <c:pt idx="6">
+                  <c:v>47.0</c:v>
+                </c:pt>
+                <c:pt idx="7">
+                  <c:v>46.4</c:v>
+                </c:pt>
+                <c:pt idx="8">
+                  <c:v>46.3</c:v>
+                </c:pt>
+                <c:pt idx="9">
+                  <c:v>45.9</c:v>
+                </c:pt>
+                <c:pt idx="10">
+                  <c:v>45.9</c:v>
+                </c:pt>
+                <c:pt idx="11">
+                  <c:v>43.2</c:v>
+                </c:pt>
+                <c:pt idx="12">
+                  <c:v>42.9</c:v>
+                </c:pt>
+              </c:numCache>
+            </c:numRef>
+          </c:val>
+        </c:ser>
+        <c:dLbls>
+          <c:numFmt formatCode="0.0" sourceLinked="0"/>
+          <c:txPr>
+            <a:bodyPr/>
+            <a:lstStyle/>
+            <a:p>
+              <a:pPr>
+                <a:defRPr sz="1200">
+                  <a:solidFill>
+                    <a:srgbClr val="1D2A24"/>
+                  </a:solidFill>
+                  <a:latin typeface="Inter"/>
+                </a:defRPr>
+              </a:pPr>
+            </a:p>
+          </c:txPr>
+          <c:dLblPos val="outEnd"/>
+          <c:showLegendKey val="0"/>
+          <c:showVal val="1"/>
+          <c:showCatName val="0"/>
+          <c:showSerName val="0"/>
+          <c:showPercent val="0"/>
+          <c:showBubbleSize val="0"/>
+          <c:showLeaderLines val="1"/>
+        </c:dLbls>
+        <c:gapWidth val="35"/>
+        <c:axId val="-2068027336"/>
+        <c:axId val="-2113994440"/>
+      </c:barChart>
+      <c:catAx>
+        <c:axId val="-2068027336"/>
+        <c:scaling>
+          <c:orientation val="maxMin"/>
+        </c:scaling>
+        <c:delete val="0"/>
+        <c:axPos val="l"/>
+        <c:majorTickMark val="out"/>
+        <c:minorTickMark val="none"/>
+        <c:tickLblPos val="nextTo"/>
+        <c:spPr>
+          <a:ln>
+            <a:solidFill>
+              <a:srgbClr val="B5B2AD"/>
+            </a:solidFill>
+          </a:ln>
+        </c:spPr>
+        <c:txPr>
+          <a:bodyPr/>
+          <a:lstStyle/>
+          <a:p>
+            <a:pPr>
+              <a:defRPr sz="1200">
+                <a:solidFill>
+                  <a:srgbClr val="4C5852"/>
+                </a:solidFill>
+                <a:latin typeface="Inter"/>
+              </a:defRPr>
+            </a:pPr>
+          </a:p>
+        </c:txPr>
+        <c:crossAx val="-2113994440"/>
+        <c:crosses val="autoZero"/>
+        <c:auto val="1"/>
+        <c:lblAlgn val="ctr"/>
+        <c:lblOffset val="100"/>
+        <c:noMultiLvlLbl val="0"/>
+      </c:catAx>
+      <c:valAx>
+        <c:axId val="-2113994440"/>
+        <c:scaling>
+          <c:max val="56.0"/>
+          <c:min val="0.0"/>
+        </c:scaling>
+        <c:delete/>
+        <c:axPos val="b"/>
         <c:majorTickMark val="out"/>
         <c:minorTickMark val="none"/>
         <c:tickLblPos val="nextTo"/>
@@ -3647,7 +3921,7 @@
                 <a:ea typeface="Inter" pitchFamily="34" charset="-122"/>
                 <a:cs typeface="Inter" pitchFamily="34" charset="-120"/>
               </a:rPr>
-              <a:t>11 · DISSERTATSIYA TUZILISHI</a:t>
+              <a:t>12 · DISSERTATSIYA TUZILISHI</a:t>
             </a:r>
             <a:endParaRPr lang="en-US" sz="1200" dirty="0"/>
           </a:p>
@@ -4446,7 +4720,7 @@
                 <a:ea typeface="Inter" pitchFamily="34" charset="-122"/>
                 <a:cs typeface="Inter" pitchFamily="34" charset="-120"/>
               </a:rPr>
-              <a:t>12</a:t>
+              <a:t>13</a:t>
             </a:r>
             <a:endParaRPr lang="en-US" sz="1200" dirty="0"/>
           </a:p>
@@ -4522,7 +4796,7 @@
                 <a:ea typeface="Inter" pitchFamily="34" charset="-122"/>
                 <a:cs typeface="Inter" pitchFamily="34" charset="-120"/>
               </a:rPr>
-              <a:t>12 · DISSERTATSIYA TUZILISHI</a:t>
+              <a:t>13 · DISSERTATSIYA TUZILISHI</a:t>
             </a:r>
             <a:endParaRPr lang="en-US" sz="1200" dirty="0"/>
           </a:p>
@@ -5554,7 +5828,7 @@
                 <a:ea typeface="Inter" pitchFamily="34" charset="-122"/>
                 <a:cs typeface="Inter" pitchFamily="34" charset="-120"/>
               </a:rPr>
-              <a:t>13</a:t>
+              <a:t>14</a:t>
             </a:r>
             <a:endParaRPr lang="en-US" sz="1200" dirty="0"/>
           </a:p>
@@ -5630,7 +5904,7 @@
                 <a:ea typeface="Inter" pitchFamily="34" charset="-122"/>
                 <a:cs typeface="Inter" pitchFamily="34" charset="-120"/>
               </a:rPr>
-              <a:t>13 · DISSERTATSIYA TUZILISHI</a:t>
+              <a:t>14 · DISSERTATSIYA TUZILISHI</a:t>
             </a:r>
             <a:endParaRPr lang="en-US" sz="1200" dirty="0"/>
           </a:p>
@@ -6657,7 +6931,7 @@
                 <a:ea typeface="Inter" pitchFamily="34" charset="-122"/>
                 <a:cs typeface="Inter" pitchFamily="34" charset="-120"/>
               </a:rPr>
-              <a:t>14</a:t>
+              <a:t>15</a:t>
             </a:r>
             <a:endParaRPr lang="en-US" sz="1200" dirty="0"/>
           </a:p>
@@ -6733,7 +7007,7 @@
                 <a:ea typeface="Inter" pitchFamily="34" charset="-122"/>
                 <a:cs typeface="Inter" pitchFamily="34" charset="-120"/>
               </a:rPr>
-              <a:t>14 · NATIJALAR VA REJA</a:t>
+              <a:t>15 · NATIJALAR VA REJA</a:t>
             </a:r>
             <a:endParaRPr lang="en-US" sz="1200" dirty="0"/>
           </a:p>
@@ -7471,7 +7745,7 @@
                 <a:ea typeface="Inter" pitchFamily="34" charset="-122"/>
                 <a:cs typeface="Inter" pitchFamily="34" charset="-120"/>
               </a:rPr>
-              <a:t>15</a:t>
+              <a:t>16</a:t>
             </a:r>
             <a:endParaRPr lang="en-US" sz="1200" dirty="0"/>
           </a:p>
@@ -7547,7 +7821,7 @@
                 <a:ea typeface="Inter" pitchFamily="34" charset="-122"/>
                 <a:cs typeface="Inter" pitchFamily="34" charset="-120"/>
               </a:rPr>
-              <a:t>15 · NATIJALAR VA REJA</a:t>
+              <a:t>16 · NATIJALAR VA REJA</a:t>
             </a:r>
             <a:endParaRPr lang="en-US" sz="1200" dirty="0"/>
           </a:p>
@@ -8573,7 +8847,7 @@
                 <a:ea typeface="Inter" pitchFamily="34" charset="-122"/>
                 <a:cs typeface="Inter" pitchFamily="34" charset="-120"/>
               </a:rPr>
-              <a:t>16</a:t>
+              <a:t>17</a:t>
             </a:r>
             <a:endParaRPr lang="en-US" sz="1200" dirty="0"/>
           </a:p>
@@ -8649,7 +8923,7 @@
                 <a:ea typeface="Inter" pitchFamily="34" charset="-122"/>
                 <a:cs typeface="Inter" pitchFamily="34" charset="-120"/>
               </a:rPr>
-              <a:t>16 · NATIJALAR VA REJA</a:t>
+              <a:t>17 · NATIJALAR VA REJA</a:t>
             </a:r>
             <a:endParaRPr lang="en-US" sz="1200" dirty="0"/>
           </a:p>
@@ -9261,7 +9535,7 @@
                 <a:ea typeface="Inter" pitchFamily="34" charset="-122"/>
                 <a:cs typeface="Inter" pitchFamily="34" charset="-120"/>
               </a:rPr>
-              <a:t>17</a:t>
+              <a:t>18</a:t>
             </a:r>
             <a:endParaRPr lang="en-US" sz="1200" dirty="0"/>
           </a:p>
@@ -10269,7 +10543,7 @@
         <p:spPr>
           <a:xfrm>
             <a:off x="812800" y="1830000"/>
-            <a:ext cx="5300000" cy="260000"/>
+            <a:ext cx="6350000" cy="260000"/>
           </a:xfrm>
           <a:prstGeom prst="rect">
             <a:avLst/>
@@ -10290,7 +10564,7 @@
                 </a:solidFill>
                 <a:latin typeface="Inter"/>
               </a:rPr>
-              <a:t>Paxta hosildorligi (amalda), s/ga</a:t>
+              <a:t>Paxta hosildorligi (amalda), s/ga, 2015–2025</a:t>
             </a:r>
           </a:p>
         </p:txBody>
@@ -10305,7 +10579,7 @@
         </p:nvGraphicFramePr>
         <p:xfrm>
           <a:off x="752800" y="2130000"/>
-          <a:ext cx="5300000" cy="2950000"/>
+          <a:ext cx="6350000" cy="2950000"/>
         </p:xfrm>
         <a:graphic>
           <a:graphicData uri="http://schemas.openxmlformats.org/drawingml/2006/chart">
@@ -10321,8 +10595,8 @@
         </p:nvSpPr>
         <p:spPr>
           <a:xfrm>
-            <a:off x="6396192" y="1830000"/>
-            <a:ext cx="5300000" cy="260000"/>
+            <a:off x="7396192" y="1830000"/>
+            <a:ext cx="4300000" cy="260000"/>
           </a:xfrm>
           <a:prstGeom prst="rect">
             <a:avLst/>
@@ -10357,8 +10631,8 @@
           <p:nvPr/>
         </p:nvGraphicFramePr>
         <p:xfrm>
-          <a:off x="6336192" y="2130000"/>
-          <a:ext cx="5300000" cy="2950000"/>
+          <a:off x="7336192" y="2130000"/>
+          <a:ext cx="4300000" cy="2950000"/>
         </p:xfrm>
         <a:graphic>
           <a:graphicData uri="http://schemas.openxmlformats.org/drawingml/2006/chart">
@@ -10444,7 +10718,7 @@
                 </a:solidFill>
                 <a:latin typeface="Inter"/>
               </a:rPr>
-              <a:t>Tuman kesimida: Ulugʻnor tumanida paxta hosildorligi 2020–2024 yillarda har yili viloyat oʻrtachasidan past (2024 yilda 25,7 s/ga; viloyat — 35,1). Farqning tuproq-meliorativ omillar bilan bogʻliqligi 3.3-boʻlimda tahlil qilinadi.</a:t>
+              <a:t>Tuman kesimida: Ulugʻnor tumanida paxta hosildorligi 2020–2025 yillarda har yili viloyat oʻrtachasidan past (2024 yilda 25,7 s/ga; viloyat — 35,1). Farqning tuproq-meliorativ omillar bilan bogʻliqligi 3.3-boʻlimda tahlil qilinadi.</a:t>
             </a:r>
           </a:p>
         </p:txBody>
@@ -10479,7 +10753,875 @@
                 </a:solidFill>
                 <a:latin typeface="Inter"/>
               </a:rPr>
-              <a:t>Manba: Andijon viloyati boʻyicha paxta (2020–2024) va gʻalla (2017–2022) hosili toʻgʻrisidagi maʼlumotlar</a:t>
+              <a:t>Manba: Andijon viloyati boʻyicha paxta (2015–2025) va gʻalla (2017–2022) hosili toʻgʻrisidagi maʼlumotlar</a:t>
+            </a:r>
+          </a:p>
+        </p:txBody>
+      </p:sp>
+    </p:spTree>
+  </p:cSld>
+  <p:clrMapOvr>
+    <a:masterClrMapping/>
+  </p:clrMapOvr>
+</p:sld>
+</file>
+
+<file path=ppt/slides/slide19.xml><?xml version="1.0" encoding="utf-8"?>
+<p:sld xmlns:a="http://schemas.openxmlformats.org/drawingml/2006/main" xmlns:p="http://schemas.openxmlformats.org/presentationml/2006/main" xmlns:r="http://schemas.openxmlformats.org/officeDocument/2006/relationships">
+  <p:cSld>
+    <p:bg>
+      <p:bgPr>
+        <a:solidFill>
+          <a:srgbClr val="F4F1EA"/>
+        </a:solidFill>
+      </p:bgPr>
+    </p:bg>
+    <p:spTree>
+      <p:nvGrpSpPr>
+        <p:cNvPr id="1" name=""/>
+        <p:cNvGrpSpPr/>
+        <p:nvPr/>
+      </p:nvGrpSpPr>
+      <p:grpSpPr/>
+      <p:sp>
+        <p:nvSpPr>
+          <p:cNvPr id="2" name="Text 0"/>
+          <p:cNvSpPr/>
+          <p:nvPr/>
+        </p:nvSpPr>
+        <p:spPr>
+          <a:xfrm>
+            <a:off x="812800" y="812800"/>
+            <a:ext cx="10883392" cy="238720"/>
+          </a:xfrm>
+          <a:prstGeom prst="rect">
+            <a:avLst/>
+          </a:prstGeom>
+          <a:noFill/>
+          <a:ln/>
+        </p:spPr>
+        <p:txBody>
+          <a:bodyPr wrap="square" lIns="0" tIns="0" rIns="0" bIns="0" rtlCol="0" anchor="t">
+            <a:normAutofit/>
+          </a:bodyPr>
+          <a:lstStyle/>
+          <a:p>
+            <a:pPr algn="l" indent="0" marL="0">
+              <a:lnSpc>
+                <a:spcPts val="1680"/>
+              </a:lnSpc>
+              <a:buNone/>
+            </a:pPr>
+            <a:r>
+              <a:rPr lang="en-US" sz="1200" b="1" spc="150" kern="0" dirty="0">
+                <a:solidFill>
+                  <a:srgbClr val="2C6A85"/>
+                </a:solidFill>
+                <a:latin typeface="Inter" pitchFamily="34" charset="0"/>
+                <a:ea typeface="Inter" pitchFamily="34" charset="-122"/>
+                <a:cs typeface="Inter" pitchFamily="34" charset="-120"/>
+              </a:rPr>
+              <a:t>11 · DASTLABKI MAʼLUMOTLAR</a:t>
+            </a:r>
+            <a:endParaRPr lang="en-US" sz="1200" dirty="0"/>
+          </a:p>
+        </p:txBody>
+      </p:sp>
+      <p:sp>
+        <p:nvSpPr>
+          <p:cNvPr id="3" name="Text 1"/>
+          <p:cNvSpPr/>
+          <p:nvPr>
+            <p:ph type="title"/>
+          </p:nvPr>
+        </p:nvSpPr>
+        <p:spPr>
+          <a:xfrm>
+            <a:off x="812800" y="1127720"/>
+            <a:ext cx="10883392" cy="472430"/>
+          </a:xfrm>
+          <a:prstGeom prst="rect">
+            <a:avLst/>
+          </a:prstGeom>
+          <a:noFill/>
+          <a:ln/>
+        </p:spPr>
+        <p:txBody>
+          <a:bodyPr wrap="square" lIns="0" tIns="0" rIns="0" bIns="0" rtlCol="0" anchor="t">
+            <a:normAutofit/>
+          </a:bodyPr>
+          <a:lstStyle/>
+          <a:p>
+            <a:pPr algn="l" indent="0" marL="0">
+              <a:lnSpc>
+                <a:spcPts val="3520"/>
+              </a:lnSpc>
+              <a:buNone/>
+            </a:pPr>
+            <a:r>
+              <a:rPr lang="en-US" sz="3200" b="0" i="0" dirty="0">
+                <a:solidFill>
+                  <a:srgbClr val="1D2A24"/>
+                </a:solidFill>
+                <a:latin typeface="Source Serif 4" pitchFamily="18" charset="0"/>
+                <a:ea typeface="Source Serif 4" pitchFamily="18" charset="-122"/>
+                <a:cs typeface="Source Serif 4" pitchFamily="18" charset="-120"/>
+              </a:rPr>
+              <a:t>Tumanlar kesimidagi maʼlumotlar</a:t>
+            </a:r>
+            <a:endParaRPr lang="en-US" sz="3200" dirty="0"/>
+          </a:p>
+        </p:txBody>
+      </p:sp>
+      <p:sp>
+        <p:nvSpPr>
+          <p:cNvPr id="6" name="Text 3"/>
+          <p:cNvSpPr/>
+          <p:nvPr/>
+        </p:nvSpPr>
+        <p:spPr>
+          <a:xfrm>
+            <a:off x="11137950" y="6238280"/>
+            <a:ext cx="241250" cy="238720"/>
+          </a:xfrm>
+          <a:prstGeom prst="rect">
+            <a:avLst/>
+          </a:prstGeom>
+          <a:noFill/>
+          <a:ln/>
+        </p:spPr>
+        <p:txBody>
+          <a:bodyPr wrap="square" lIns="0" tIns="0" rIns="0" bIns="0" rtlCol="0" anchor="t">
+            <a:normAutofit/>
+          </a:bodyPr>
+          <a:lstStyle/>
+          <a:p>
+            <a:pPr algn="r" indent="0" marL="0">
+              <a:lnSpc>
+                <a:spcPts val="1680"/>
+              </a:lnSpc>
+              <a:buNone/>
+            </a:pPr>
+            <a:r>
+              <a:rPr lang="en-US" sz="1200" dirty="0">
+                <a:solidFill>
+                  <a:srgbClr val="5F6B64"/>
+                </a:solidFill>
+                <a:latin typeface="Inter" pitchFamily="34" charset="0"/>
+                <a:ea typeface="Inter" pitchFamily="34" charset="-122"/>
+                <a:cs typeface="Inter" pitchFamily="34" charset="-120"/>
+              </a:rPr>
+              <a:t>12</a:t>
+            </a:r>
+            <a:endParaRPr lang="en-US" sz="1200" dirty="0"/>
+          </a:p>
+        </p:txBody>
+      </p:sp>
+      <p:sp>
+        <p:nvSpPr>
+          <p:cNvPr id="7" name="TextBox 6"/>
+          <p:cNvSpPr txBox="1"/>
+          <p:nvPr/>
+        </p:nvSpPr>
+        <p:spPr>
+          <a:xfrm>
+            <a:off x="812800" y="1830000"/>
+            <a:ext cx="6200000" cy="260000"/>
+          </a:xfrm>
+          <a:prstGeom prst="rect">
+            <a:avLst/>
+          </a:prstGeom>
+          <a:noFill/>
+        </p:spPr>
+        <p:txBody>
+          <a:bodyPr wrap="square" lIns="0" rIns="0" tIns="0" bIns="0" anchor="t">
+            <a:spAutoFit/>
+          </a:bodyPr>
+          <a:lstStyle/>
+          <a:p>
+            <a:pPr algn="l"/>
+            <a:r>
+              <a:rPr sz="1300" b="1">
+                <a:solidFill>
+                  <a:srgbClr val="2C6A85"/>
+                </a:solidFill>
+                <a:latin typeface="Inter"/>
+              </a:rPr>
+              <a:t>Paxta hosildorligi, 2025 yil, s/ga (tumanlar)</a:t>
+            </a:r>
+          </a:p>
+        </p:txBody>
+      </p:sp>
+      <p:graphicFrame>
+        <p:nvGraphicFramePr>
+          <p:cNvPr id="8" name="Chart 7"/>
+          <p:cNvGraphicFramePr>
+            <a:graphicFrameLocks noGrp="1"/>
+          </p:cNvGraphicFramePr>
+          <p:nvPr/>
+        </p:nvGraphicFramePr>
+        <p:xfrm>
+          <a:off x="752800" y="2100000"/>
+          <a:ext cx="6300000" cy="3800000"/>
+        </p:xfrm>
+        <a:graphic>
+          <a:graphicData uri="http://schemas.openxmlformats.org/drawingml/2006/chart">
+            <c:chart xmlns:c="http://schemas.openxmlformats.org/drawingml/2006/chart" r:id="rId2"/>
+          </a:graphicData>
+        </a:graphic>
+      </p:graphicFrame>
+      <p:sp>
+        <p:nvSpPr>
+          <p:cNvPr id="9" name="TextBox 8"/>
+          <p:cNvSpPr txBox="1"/>
+          <p:nvPr/>
+        </p:nvSpPr>
+        <p:spPr>
+          <a:xfrm>
+            <a:off x="7400000" y="1830000"/>
+            <a:ext cx="4296192" cy="260000"/>
+          </a:xfrm>
+          <a:prstGeom prst="rect">
+            <a:avLst/>
+          </a:prstGeom>
+          <a:noFill/>
+        </p:spPr>
+        <p:txBody>
+          <a:bodyPr wrap="square" lIns="0" rIns="0" tIns="0" bIns="0" anchor="t">
+            <a:spAutoFit/>
+          </a:bodyPr>
+          <a:lstStyle/>
+          <a:p>
+            <a:pPr algn="l"/>
+            <a:r>
+              <a:rPr sz="1300" b="1">
+                <a:solidFill>
+                  <a:srgbClr val="2C6A85"/>
+                </a:solidFill>
+                <a:latin typeface="Inter"/>
+              </a:rPr>
+              <a:t>Ekin joylashtirish rejasi, 2026 yil</a:t>
+            </a:r>
+          </a:p>
+        </p:txBody>
+      </p:sp>
+      <p:sp>
+        <p:nvSpPr>
+          <p:cNvPr id="10" name="Rounded Rectangle 9"/>
+          <p:cNvSpPr/>
+          <p:nvPr/>
+        </p:nvSpPr>
+        <p:spPr>
+          <a:xfrm>
+            <a:off x="7400000" y="2150000"/>
+            <a:ext cx="4296192" cy="1830000"/>
+          </a:xfrm>
+          <a:prstGeom prst="roundRect">
+            <a:avLst>
+              <a:gd name="adj" fmla="val 5000"/>
+            </a:avLst>
+          </a:prstGeom>
+          <a:solidFill>
+            <a:srgbClr val="FBF9F4"/>
+          </a:solidFill>
+          <a:ln w="6350">
+            <a:solidFill>
+              <a:srgbClr val="D9D2C3"/>
+            </a:solidFill>
+          </a:ln>
+          <a:effectLst/>
+        </p:spPr>
+        <p:style>
+          <a:lnRef idx="1">
+            <a:schemeClr val="accent1"/>
+          </a:lnRef>
+          <a:fillRef idx="3">
+            <a:schemeClr val="accent1"/>
+          </a:fillRef>
+          <a:effectRef idx="2">
+            <a:schemeClr val="accent1"/>
+          </a:effectRef>
+          <a:fontRef idx="minor">
+            <a:schemeClr val="lt1"/>
+          </a:fontRef>
+        </p:style>
+        <p:txBody>
+          <a:bodyPr rtlCol="0" anchor="ctr"/>
+          <a:lstStyle/>
+          <a:p>
+            <a:pPr algn="ctr"/>
+          </a:p>
+        </p:txBody>
+      </p:sp>
+      <p:sp>
+        <p:nvSpPr>
+          <p:cNvPr id="11" name="TextBox 10"/>
+          <p:cNvSpPr txBox="1"/>
+          <p:nvPr/>
+        </p:nvSpPr>
+        <p:spPr>
+          <a:xfrm>
+            <a:off x="7630000" y="2320000"/>
+            <a:ext cx="3836192" cy="300000"/>
+          </a:xfrm>
+          <a:prstGeom prst="rect">
+            <a:avLst/>
+          </a:prstGeom>
+          <a:noFill/>
+        </p:spPr>
+        <p:txBody>
+          <a:bodyPr wrap="square" lIns="0" rIns="0" tIns="0" bIns="0" anchor="t">
+            <a:spAutoFit/>
+          </a:bodyPr>
+          <a:lstStyle/>
+          <a:p>
+            <a:pPr algn="l"/>
+            <a:r>
+              <a:rPr sz="1600" b="1">
+                <a:solidFill>
+                  <a:srgbClr val="1D2A24"/>
+                </a:solidFill>
+                <a:latin typeface="Inter"/>
+              </a:rPr>
+              <a:t>Jalaquduq tumani</a:t>
+            </a:r>
+          </a:p>
+        </p:txBody>
+      </p:sp>
+      <p:sp>
+        <p:nvSpPr>
+          <p:cNvPr id="12" name="TextBox 11"/>
+          <p:cNvSpPr txBox="1"/>
+          <p:nvPr/>
+        </p:nvSpPr>
+        <p:spPr>
+          <a:xfrm>
+            <a:off x="7630000" y="2800000"/>
+            <a:ext cx="1700000" cy="300000"/>
+          </a:xfrm>
+          <a:prstGeom prst="rect">
+            <a:avLst/>
+          </a:prstGeom>
+          <a:noFill/>
+        </p:spPr>
+        <p:txBody>
+          <a:bodyPr wrap="square" lIns="0" rIns="0" tIns="0" bIns="0" anchor="t">
+            <a:spAutoFit/>
+          </a:bodyPr>
+          <a:lstStyle/>
+          <a:p>
+            <a:pPr algn="l"/>
+            <a:r>
+              <a:rPr sz="1200" b="0">
+                <a:solidFill>
+                  <a:srgbClr val="4C5852"/>
+                </a:solidFill>
+                <a:latin typeface="Inter"/>
+              </a:rPr>
+              <a:t>Jami ekin maydoni</a:t>
+            </a:r>
+          </a:p>
+        </p:txBody>
+      </p:sp>
+      <p:sp>
+        <p:nvSpPr>
+          <p:cNvPr id="13" name="TextBox 12"/>
+          <p:cNvSpPr txBox="1"/>
+          <p:nvPr/>
+        </p:nvSpPr>
+        <p:spPr>
+          <a:xfrm>
+            <a:off x="9300000" y="2800000"/>
+            <a:ext cx="2166192" cy="300000"/>
+          </a:xfrm>
+          <a:prstGeom prst="rect">
+            <a:avLst/>
+          </a:prstGeom>
+          <a:noFill/>
+        </p:spPr>
+        <p:txBody>
+          <a:bodyPr wrap="square" lIns="0" rIns="0" tIns="0" bIns="0" anchor="t">
+            <a:spAutoFit/>
+          </a:bodyPr>
+          <a:lstStyle/>
+          <a:p>
+            <a:pPr algn="r"/>
+            <a:r>
+              <a:rPr sz="1300" b="1">
+                <a:solidFill>
+                  <a:srgbClr val="1D2A24"/>
+                </a:solidFill>
+                <a:latin typeface="Inter"/>
+              </a:rPr>
+              <a:t>17 485 ga</a:t>
+            </a:r>
+          </a:p>
+        </p:txBody>
+      </p:sp>
+      <p:sp>
+        <p:nvSpPr>
+          <p:cNvPr id="14" name="TextBox 13"/>
+          <p:cNvSpPr txBox="1"/>
+          <p:nvPr/>
+        </p:nvSpPr>
+        <p:spPr>
+          <a:xfrm>
+            <a:off x="7630000" y="3170000"/>
+            <a:ext cx="1700000" cy="300000"/>
+          </a:xfrm>
+          <a:prstGeom prst="rect">
+            <a:avLst/>
+          </a:prstGeom>
+          <a:noFill/>
+        </p:spPr>
+        <p:txBody>
+          <a:bodyPr wrap="square" lIns="0" rIns="0" tIns="0" bIns="0" anchor="t">
+            <a:spAutoFit/>
+          </a:bodyPr>
+          <a:lstStyle/>
+          <a:p>
+            <a:pPr algn="l"/>
+            <a:r>
+              <a:rPr sz="1200" b="0">
+                <a:solidFill>
+                  <a:srgbClr val="4C5852"/>
+                </a:solidFill>
+                <a:latin typeface="Inter"/>
+              </a:rPr>
+              <a:t>Gʻoʻza</a:t>
+            </a:r>
+          </a:p>
+        </p:txBody>
+      </p:sp>
+      <p:sp>
+        <p:nvSpPr>
+          <p:cNvPr id="15" name="TextBox 14"/>
+          <p:cNvSpPr txBox="1"/>
+          <p:nvPr/>
+        </p:nvSpPr>
+        <p:spPr>
+          <a:xfrm>
+            <a:off x="9300000" y="3170000"/>
+            <a:ext cx="2166192" cy="300000"/>
+          </a:xfrm>
+          <a:prstGeom prst="rect">
+            <a:avLst/>
+          </a:prstGeom>
+          <a:noFill/>
+        </p:spPr>
+        <p:txBody>
+          <a:bodyPr wrap="square" lIns="0" rIns="0" tIns="0" bIns="0" anchor="t">
+            <a:spAutoFit/>
+          </a:bodyPr>
+          <a:lstStyle/>
+          <a:p>
+            <a:pPr algn="r"/>
+            <a:r>
+              <a:rPr sz="1300" b="1">
+                <a:solidFill>
+                  <a:srgbClr val="1D2A24"/>
+                </a:solidFill>
+                <a:latin typeface="Inter"/>
+              </a:rPr>
+              <a:t>4 073 ga · 23%</a:t>
+            </a:r>
+          </a:p>
+        </p:txBody>
+      </p:sp>
+      <p:sp>
+        <p:nvSpPr>
+          <p:cNvPr id="16" name="TextBox 15"/>
+          <p:cNvSpPr txBox="1"/>
+          <p:nvPr/>
+        </p:nvSpPr>
+        <p:spPr>
+          <a:xfrm>
+            <a:off x="7630000" y="3540000"/>
+            <a:ext cx="1700000" cy="300000"/>
+          </a:xfrm>
+          <a:prstGeom prst="rect">
+            <a:avLst/>
+          </a:prstGeom>
+          <a:noFill/>
+        </p:spPr>
+        <p:txBody>
+          <a:bodyPr wrap="square" lIns="0" rIns="0" tIns="0" bIns="0" anchor="t">
+            <a:spAutoFit/>
+          </a:bodyPr>
+          <a:lstStyle/>
+          <a:p>
+            <a:pPr algn="l"/>
+            <a:r>
+              <a:rPr sz="1200" b="0">
+                <a:solidFill>
+                  <a:srgbClr val="4C5852"/>
+                </a:solidFill>
+                <a:latin typeface="Inter"/>
+              </a:rPr>
+              <a:t>Bugʻdoy</a:t>
+            </a:r>
+          </a:p>
+        </p:txBody>
+      </p:sp>
+      <p:sp>
+        <p:nvSpPr>
+          <p:cNvPr id="17" name="TextBox 16"/>
+          <p:cNvSpPr txBox="1"/>
+          <p:nvPr/>
+        </p:nvSpPr>
+        <p:spPr>
+          <a:xfrm>
+            <a:off x="9300000" y="3540000"/>
+            <a:ext cx="2166192" cy="300000"/>
+          </a:xfrm>
+          <a:prstGeom prst="rect">
+            <a:avLst/>
+          </a:prstGeom>
+          <a:noFill/>
+        </p:spPr>
+        <p:txBody>
+          <a:bodyPr wrap="square" lIns="0" rIns="0" tIns="0" bIns="0" anchor="t">
+            <a:spAutoFit/>
+          </a:bodyPr>
+          <a:lstStyle/>
+          <a:p>
+            <a:pPr algn="r"/>
+            <a:r>
+              <a:rPr sz="1300" b="1">
+                <a:solidFill>
+                  <a:srgbClr val="1D2A24"/>
+                </a:solidFill>
+                <a:latin typeface="Inter"/>
+              </a:rPr>
+              <a:t>6 166 ga · 35%</a:t>
+            </a:r>
+          </a:p>
+        </p:txBody>
+      </p:sp>
+      <p:sp>
+        <p:nvSpPr>
+          <p:cNvPr id="18" name="Rounded Rectangle 17"/>
+          <p:cNvSpPr/>
+          <p:nvPr/>
+        </p:nvSpPr>
+        <p:spPr>
+          <a:xfrm>
+            <a:off x="7400000" y="4130000"/>
+            <a:ext cx="4296192" cy="1830000"/>
+          </a:xfrm>
+          <a:prstGeom prst="roundRect">
+            <a:avLst>
+              <a:gd name="adj" fmla="val 5000"/>
+            </a:avLst>
+          </a:prstGeom>
+          <a:solidFill>
+            <a:srgbClr val="FBF9F4"/>
+          </a:solidFill>
+          <a:ln w="6350">
+            <a:solidFill>
+              <a:srgbClr val="D9D2C3"/>
+            </a:solidFill>
+          </a:ln>
+          <a:effectLst/>
+        </p:spPr>
+        <p:style>
+          <a:lnRef idx="1">
+            <a:schemeClr val="accent1"/>
+          </a:lnRef>
+          <a:fillRef idx="3">
+            <a:schemeClr val="accent1"/>
+          </a:fillRef>
+          <a:effectRef idx="2">
+            <a:schemeClr val="accent1"/>
+          </a:effectRef>
+          <a:fontRef idx="minor">
+            <a:schemeClr val="lt1"/>
+          </a:fontRef>
+        </p:style>
+        <p:txBody>
+          <a:bodyPr rtlCol="0" anchor="ctr"/>
+          <a:lstStyle/>
+          <a:p>
+            <a:pPr algn="ctr"/>
+          </a:p>
+        </p:txBody>
+      </p:sp>
+      <p:sp>
+        <p:nvSpPr>
+          <p:cNvPr id="19" name="TextBox 18"/>
+          <p:cNvSpPr txBox="1"/>
+          <p:nvPr/>
+        </p:nvSpPr>
+        <p:spPr>
+          <a:xfrm>
+            <a:off x="7630000" y="4300000"/>
+            <a:ext cx="3836192" cy="300000"/>
+          </a:xfrm>
+          <a:prstGeom prst="rect">
+            <a:avLst/>
+          </a:prstGeom>
+          <a:noFill/>
+        </p:spPr>
+        <p:txBody>
+          <a:bodyPr wrap="square" lIns="0" rIns="0" tIns="0" bIns="0" anchor="t">
+            <a:spAutoFit/>
+          </a:bodyPr>
+          <a:lstStyle/>
+          <a:p>
+            <a:pPr algn="l"/>
+            <a:r>
+              <a:rPr sz="1600" b="1">
+                <a:solidFill>
+                  <a:srgbClr val="1D2A24"/>
+                </a:solidFill>
+                <a:latin typeface="Inter"/>
+              </a:rPr>
+              <a:t>Shahrixon tumani</a:t>
+            </a:r>
+          </a:p>
+        </p:txBody>
+      </p:sp>
+      <p:sp>
+        <p:nvSpPr>
+          <p:cNvPr id="20" name="TextBox 19"/>
+          <p:cNvSpPr txBox="1"/>
+          <p:nvPr/>
+        </p:nvSpPr>
+        <p:spPr>
+          <a:xfrm>
+            <a:off x="7630000" y="4780000"/>
+            <a:ext cx="1700000" cy="300000"/>
+          </a:xfrm>
+          <a:prstGeom prst="rect">
+            <a:avLst/>
+          </a:prstGeom>
+          <a:noFill/>
+        </p:spPr>
+        <p:txBody>
+          <a:bodyPr wrap="square" lIns="0" rIns="0" tIns="0" bIns="0" anchor="t">
+            <a:spAutoFit/>
+          </a:bodyPr>
+          <a:lstStyle/>
+          <a:p>
+            <a:pPr algn="l"/>
+            <a:r>
+              <a:rPr sz="1200" b="0">
+                <a:solidFill>
+                  <a:srgbClr val="4C5852"/>
+                </a:solidFill>
+                <a:latin typeface="Inter"/>
+              </a:rPr>
+              <a:t>Jami ekin maydoni</a:t>
+            </a:r>
+          </a:p>
+        </p:txBody>
+      </p:sp>
+      <p:sp>
+        <p:nvSpPr>
+          <p:cNvPr id="21" name="TextBox 20"/>
+          <p:cNvSpPr txBox="1"/>
+          <p:nvPr/>
+        </p:nvSpPr>
+        <p:spPr>
+          <a:xfrm>
+            <a:off x="9300000" y="4780000"/>
+            <a:ext cx="2166192" cy="300000"/>
+          </a:xfrm>
+          <a:prstGeom prst="rect">
+            <a:avLst/>
+          </a:prstGeom>
+          <a:noFill/>
+        </p:spPr>
+        <p:txBody>
+          <a:bodyPr wrap="square" lIns="0" rIns="0" tIns="0" bIns="0" anchor="t">
+            <a:spAutoFit/>
+          </a:bodyPr>
+          <a:lstStyle/>
+          <a:p>
+            <a:pPr algn="r"/>
+            <a:r>
+              <a:rPr sz="1300" b="1">
+                <a:solidFill>
+                  <a:srgbClr val="1D2A24"/>
+                </a:solidFill>
+                <a:latin typeface="Inter"/>
+              </a:rPr>
+              <a:t>16 065 ga</a:t>
+            </a:r>
+          </a:p>
+        </p:txBody>
+      </p:sp>
+      <p:sp>
+        <p:nvSpPr>
+          <p:cNvPr id="22" name="TextBox 21"/>
+          <p:cNvSpPr txBox="1"/>
+          <p:nvPr/>
+        </p:nvSpPr>
+        <p:spPr>
+          <a:xfrm>
+            <a:off x="7630000" y="5150000"/>
+            <a:ext cx="1700000" cy="300000"/>
+          </a:xfrm>
+          <a:prstGeom prst="rect">
+            <a:avLst/>
+          </a:prstGeom>
+          <a:noFill/>
+        </p:spPr>
+        <p:txBody>
+          <a:bodyPr wrap="square" lIns="0" rIns="0" tIns="0" bIns="0" anchor="t">
+            <a:spAutoFit/>
+          </a:bodyPr>
+          <a:lstStyle/>
+          <a:p>
+            <a:pPr algn="l"/>
+            <a:r>
+              <a:rPr sz="1200" b="0">
+                <a:solidFill>
+                  <a:srgbClr val="4C5852"/>
+                </a:solidFill>
+                <a:latin typeface="Inter"/>
+              </a:rPr>
+              <a:t>Gʻoʻza</a:t>
+            </a:r>
+          </a:p>
+        </p:txBody>
+      </p:sp>
+      <p:sp>
+        <p:nvSpPr>
+          <p:cNvPr id="23" name="TextBox 22"/>
+          <p:cNvSpPr txBox="1"/>
+          <p:nvPr/>
+        </p:nvSpPr>
+        <p:spPr>
+          <a:xfrm>
+            <a:off x="9300000" y="5150000"/>
+            <a:ext cx="2166192" cy="300000"/>
+          </a:xfrm>
+          <a:prstGeom prst="rect">
+            <a:avLst/>
+          </a:prstGeom>
+          <a:noFill/>
+        </p:spPr>
+        <p:txBody>
+          <a:bodyPr wrap="square" lIns="0" rIns="0" tIns="0" bIns="0" anchor="t">
+            <a:spAutoFit/>
+          </a:bodyPr>
+          <a:lstStyle/>
+          <a:p>
+            <a:pPr algn="r"/>
+            <a:r>
+              <a:rPr sz="1300" b="1">
+                <a:solidFill>
+                  <a:srgbClr val="1D2A24"/>
+                </a:solidFill>
+                <a:latin typeface="Inter"/>
+              </a:rPr>
+              <a:t>5 650 ga · 35%</a:t>
+            </a:r>
+          </a:p>
+        </p:txBody>
+      </p:sp>
+      <p:sp>
+        <p:nvSpPr>
+          <p:cNvPr id="24" name="TextBox 23"/>
+          <p:cNvSpPr txBox="1"/>
+          <p:nvPr/>
+        </p:nvSpPr>
+        <p:spPr>
+          <a:xfrm>
+            <a:off x="7630000" y="5520000"/>
+            <a:ext cx="1700000" cy="300000"/>
+          </a:xfrm>
+          <a:prstGeom prst="rect">
+            <a:avLst/>
+          </a:prstGeom>
+          <a:noFill/>
+        </p:spPr>
+        <p:txBody>
+          <a:bodyPr wrap="square" lIns="0" rIns="0" tIns="0" bIns="0" anchor="t">
+            <a:spAutoFit/>
+          </a:bodyPr>
+          <a:lstStyle/>
+          <a:p>
+            <a:pPr algn="l"/>
+            <a:r>
+              <a:rPr sz="1200" b="0">
+                <a:solidFill>
+                  <a:srgbClr val="4C5852"/>
+                </a:solidFill>
+                <a:latin typeface="Inter"/>
+              </a:rPr>
+              <a:t>Bugʻdoy</a:t>
+            </a:r>
+          </a:p>
+        </p:txBody>
+      </p:sp>
+      <p:sp>
+        <p:nvSpPr>
+          <p:cNvPr id="25" name="TextBox 24"/>
+          <p:cNvSpPr txBox="1"/>
+          <p:nvPr/>
+        </p:nvSpPr>
+        <p:spPr>
+          <a:xfrm>
+            <a:off x="9300000" y="5520000"/>
+            <a:ext cx="2166192" cy="300000"/>
+          </a:xfrm>
+          <a:prstGeom prst="rect">
+            <a:avLst/>
+          </a:prstGeom>
+          <a:noFill/>
+        </p:spPr>
+        <p:txBody>
+          <a:bodyPr wrap="square" lIns="0" rIns="0" tIns="0" bIns="0" anchor="t">
+            <a:spAutoFit/>
+          </a:bodyPr>
+          <a:lstStyle/>
+          <a:p>
+            <a:pPr algn="r"/>
+            <a:r>
+              <a:rPr sz="1300" b="1">
+                <a:solidFill>
+                  <a:srgbClr val="1D2A24"/>
+                </a:solidFill>
+                <a:latin typeface="Inter"/>
+              </a:rPr>
+              <a:t>6 402 ga · 40%</a:t>
+            </a:r>
+          </a:p>
+        </p:txBody>
+      </p:sp>
+      <p:sp>
+        <p:nvSpPr>
+          <p:cNvPr id="26" name="TextBox 25"/>
+          <p:cNvSpPr txBox="1"/>
+          <p:nvPr/>
+        </p:nvSpPr>
+        <p:spPr>
+          <a:xfrm>
+            <a:off x="812800" y="6238280"/>
+            <a:ext cx="9800000" cy="240000"/>
+          </a:xfrm>
+          <a:prstGeom prst="rect">
+            <a:avLst/>
+          </a:prstGeom>
+          <a:noFill/>
+        </p:spPr>
+        <p:txBody>
+          <a:bodyPr wrap="square" lIns="0" rIns="0" tIns="0" bIns="0" anchor="t">
+            <a:spAutoFit/>
+          </a:bodyPr>
+          <a:lstStyle/>
+          <a:p>
+            <a:pPr algn="l"/>
+            <a:r>
+              <a:rPr sz="1200" b="0">
+                <a:solidFill>
+                  <a:srgbClr val="5F6B64"/>
+                </a:solidFill>
+                <a:latin typeface="Inter"/>
+              </a:rPr>
+              <a:t>Manba: 2025 yil paxta hosili hisoboti; Jalaquduq va Shahrixon 2026 yil ekin joylashtirish rejalari</a:t>
             </a:r>
           </a:p>
         </p:txBody>
@@ -14110,7 +15252,7 @@
         </p:nvGraphicFramePr>
         <p:xfrm>
           <a:off x="825500" y="1841450"/>
-          <a:ext cx="10553700" cy="3071217"/>
+          <a:ext cx="10553700" cy="3509962"/>
         </p:xfrm>
         <a:graphic>
           <a:graphicData uri="http://schemas.openxmlformats.org/drawingml/2006/table">
@@ -15572,6 +16714,212 @@
                   </a:tcPr>
                 </a:tc>
               </a:tr>
+              <a:tr h="438745">
+                <a:tc>
+                  <a:txBody>
+                    <a:bodyPr/>
+                    <a:lstStyle/>
+                    <a:p>
+                      <a:pPr indent="0" marL="0">
+                        <a:lnSpc>
+                          <a:spcPts val="1820"/>
+                        </a:lnSpc>
+                        <a:buNone/>
+                      </a:pPr>
+                      <a:r>
+                        <a:rPr lang="en-US" sz="1300" dirty="0">
+                          <a:solidFill>
+                            <a:srgbClr val="22302A"/>
+                          </a:solidFill>
+                          <a:latin typeface="Inter" pitchFamily="34" charset="0"/>
+                          <a:ea typeface="Inter" pitchFamily="34" charset="-122"/>
+                          <a:cs typeface="Inter" pitchFamily="34" charset="-120"/>
+                        </a:rPr>
+                        <a:t>Ekin joylashtirish rejalari (2026)</a:t>
+                      </a:r>
+                      <a:endParaRPr lang="en-US" sz="1300" dirty="0">
+                        <a:latin typeface="Inter" charset="0"/>
+                        <a:ea typeface="Inter" charset="0"/>
+                        <a:cs typeface="Inter" charset="0"/>
+                      </a:endParaRPr>
+                    </a:p>
+                  </a:txBody>
+                  <a:tcPr marL="152400" marR="152400" marT="101600" marB="101600" anchor="t">
+                    <a:lnL w="12700" cap="flat" cmpd="sng" algn="ctr">
+                      <a:solidFill>
+                        <a:srgbClr val="C3C0BB"/>
+                      </a:solidFill>
+                      <a:prstDash val="solid"/>
+                      <a:round/>
+                      <a:headEnd type="none" w="med" len="med"/>
+                      <a:tailEnd type="none" w="med" len="med"/>
+                    </a:lnL>
+                    <a:lnR w="12700" cap="flat" cmpd="sng" algn="ctr">
+                      <a:solidFill>
+                        <a:srgbClr val="C3C0BB"/>
+                      </a:solidFill>
+                      <a:prstDash val="solid"/>
+                      <a:round/>
+                      <a:headEnd type="none" w="med" len="med"/>
+                      <a:tailEnd type="none" w="med" len="med"/>
+                    </a:lnR>
+                    <a:lnT w="12700" cap="flat" cmpd="sng" algn="ctr">
+                      <a:solidFill>
+                        <a:srgbClr val="C3C0BB"/>
+                      </a:solidFill>
+                      <a:prstDash val="solid"/>
+                      <a:round/>
+                      <a:headEnd type="none" w="med" len="med"/>
+                      <a:tailEnd type="none" w="med" len="med"/>
+                    </a:lnT>
+                    <a:lnB w="12700" cap="flat" cmpd="sng" algn="ctr">
+                      <a:solidFill>
+                        <a:srgbClr val="C3C0BB"/>
+                      </a:solidFill>
+                      <a:prstDash val="solid"/>
+                      <a:round/>
+                      <a:headEnd type="none" w="med" len="med"/>
+                      <a:tailEnd type="none" w="med" len="med"/>
+                    </a:lnB>
+                  </a:tcPr>
+                </a:tc>
+                <a:tc>
+                  <a:txBody>
+                    <a:bodyPr/>
+                    <a:lstStyle/>
+                    <a:p>
+                      <a:pPr indent="0" marL="0">
+                        <a:lnSpc>
+                          <a:spcPts val="1820"/>
+                        </a:lnSpc>
+                        <a:buNone/>
+                      </a:pPr>
+                      <a:r>
+                        <a:rPr lang="en-US" sz="1300" dirty="0">
+                          <a:solidFill>
+                            <a:srgbClr val="22302A"/>
+                          </a:solidFill>
+                          <a:latin typeface="Inter" pitchFamily="34" charset="0"/>
+                          <a:ea typeface="Inter" pitchFamily="34" charset="-122"/>
+                          <a:cs typeface="Inter" pitchFamily="34" charset="-120"/>
+                        </a:rPr>
+                        <a:t>Jalaquduq va Shahrixon tumanlari: kontur va fermer kesimida ekin maydonlari</a:t>
+                      </a:r>
+                      <a:endParaRPr lang="en-US" sz="1300" dirty="0">
+                        <a:latin typeface="Inter" charset="0"/>
+                        <a:ea typeface="Inter" charset="0"/>
+                        <a:cs typeface="Inter" charset="0"/>
+                      </a:endParaRPr>
+                    </a:p>
+                  </a:txBody>
+                  <a:tcPr marL="152400" marR="152400" marT="101600" marB="101600" anchor="t">
+                    <a:lnL w="12700" cap="flat" cmpd="sng" algn="ctr">
+                      <a:solidFill>
+                        <a:srgbClr val="C3C0BB"/>
+                      </a:solidFill>
+                      <a:prstDash val="solid"/>
+                      <a:round/>
+                      <a:headEnd type="none" w="med" len="med"/>
+                      <a:tailEnd type="none" w="med" len="med"/>
+                    </a:lnL>
+                    <a:lnR w="12700" cap="flat" cmpd="sng" algn="ctr">
+                      <a:solidFill>
+                        <a:srgbClr val="C3C0BB"/>
+                      </a:solidFill>
+                      <a:prstDash val="solid"/>
+                      <a:round/>
+                      <a:headEnd type="none" w="med" len="med"/>
+                      <a:tailEnd type="none" w="med" len="med"/>
+                    </a:lnR>
+                    <a:lnT w="12700" cap="flat" cmpd="sng" algn="ctr">
+                      <a:solidFill>
+                        <a:srgbClr val="C3C0BB"/>
+                      </a:solidFill>
+                      <a:prstDash val="solid"/>
+                      <a:round/>
+                      <a:headEnd type="none" w="med" len="med"/>
+                      <a:tailEnd type="none" w="med" len="med"/>
+                    </a:lnT>
+                    <a:lnB w="12700" cap="flat" cmpd="sng" algn="ctr">
+                      <a:solidFill>
+                        <a:srgbClr val="C3C0BB"/>
+                      </a:solidFill>
+                      <a:prstDash val="solid"/>
+                      <a:round/>
+                      <a:headEnd type="none" w="med" len="med"/>
+                      <a:tailEnd type="none" w="med" len="med"/>
+                    </a:lnB>
+                  </a:tcPr>
+                </a:tc>
+                <a:tc>
+                  <a:txBody>
+                    <a:bodyPr/>
+                    <a:lstStyle/>
+                    <a:p>
+                      <a:pPr indent="0" marL="0">
+                        <a:lnSpc>
+                          <a:spcPts val="1820"/>
+                        </a:lnSpc>
+                        <a:buNone/>
+                      </a:pPr>
+                      <a:r>
+                        <a:rPr lang="en-US" sz="1300" dirty="0">
+                          <a:solidFill>
+                            <a:srgbClr val="22302A"/>
+                          </a:solidFill>
+                          <a:latin typeface="Inter" pitchFamily="34" charset="0"/>
+                          <a:ea typeface="Inter" pitchFamily="34" charset="-122"/>
+                          <a:cs typeface="Inter" pitchFamily="34" charset="-120"/>
+                        </a:rPr>
+                        <a:t>Kontur asosida GAT qatlami, ekin–tuproq bogʻliqligi</a:t>
+                      </a:r>
+                      <a:endParaRPr lang="en-US" sz="1300" dirty="0">
+                        <a:latin typeface="Inter" charset="0"/>
+                        <a:ea typeface="Inter" charset="0"/>
+                        <a:cs typeface="Inter" charset="0"/>
+                      </a:endParaRPr>
+                    </a:p>
+                  </a:txBody>
+                  <a:tcPr marL="152400" marR="152400" marT="101600" marB="101600" anchor="t">
+                    <a:lnL w="12700" cap="flat" cmpd="sng" algn="ctr">
+                      <a:solidFill>
+                        <a:srgbClr val="C3C0BB"/>
+                      </a:solidFill>
+                      <a:prstDash val="solid"/>
+                      <a:round/>
+                      <a:headEnd type="none" w="med" len="med"/>
+                      <a:tailEnd type="none" w="med" len="med"/>
+                    </a:lnL>
+                    <a:lnR w="12700" cap="flat" cmpd="sng" algn="ctr">
+                      <a:solidFill>
+                        <a:srgbClr val="C3C0BB"/>
+                      </a:solidFill>
+                      <a:prstDash val="solid"/>
+                      <a:round/>
+                      <a:headEnd type="none" w="med" len="med"/>
+                      <a:tailEnd type="none" w="med" len="med"/>
+                    </a:lnR>
+                    <a:lnT w="12700" cap="flat" cmpd="sng" algn="ctr">
+                      <a:solidFill>
+                        <a:srgbClr val="C3C0BB"/>
+                      </a:solidFill>
+                      <a:prstDash val="solid"/>
+                      <a:round/>
+                      <a:headEnd type="none" w="med" len="med"/>
+                      <a:tailEnd type="none" w="med" len="med"/>
+                    </a:lnT>
+                    <a:lnB w="12700" cap="flat" cmpd="sng" algn="ctr">
+                      <a:solidFill>
+                        <a:srgbClr val="C3C0BB"/>
+                      </a:solidFill>
+                      <a:prstDash val="solid"/>
+                      <a:round/>
+                      <a:headEnd type="none" w="med" len="med"/>
+                      <a:tailEnd type="none" w="med" len="med"/>
+                    </a:lnB>
+                  </a:tcPr>
+                </a:tc>
+              </a:tr>
             </a:tbl>
           </a:graphicData>
         </a:graphic>
@@ -15584,7 +16932,7 @@
         </p:nvSpPr>
         <p:spPr>
           <a:xfrm>
-            <a:off x="812800" y="5286667"/>
+            <a:off x="812800" y="6305412"/>
             <a:ext cx="10883392" cy="256530"/>
           </a:xfrm>
           <a:prstGeom prst="rect">

</xml_diff>

<commit_message>
Add crop placement plans for five districts to presentation
Co-Authored-By: Claude Sonnet 5.5 <noreply@anthropic.com>
Claude-Session: https://claude.ai/code/session_01M4MZatV28utL9zTp7saaUz
</commit_message>
<xml_diff>
--- a/Garbiy_Farg_ona_tuproqlari_GAT_asosida_bashoratlash.pptx
+++ b/Garbiy_Farg_ona_tuproqlari_GAT_asosida_bashoratlash.pptx
@@ -10926,7 +10926,7 @@
         <p:spPr>
           <a:xfrm>
             <a:off x="812800" y="1830000"/>
-            <a:ext cx="6200000" cy="260000"/>
+            <a:ext cx="4900000" cy="260000"/>
           </a:xfrm>
           <a:prstGeom prst="rect">
             <a:avLst/>
@@ -10962,7 +10962,7 @@
         </p:nvGraphicFramePr>
         <p:xfrm>
           <a:off x="752800" y="2100000"/>
-          <a:ext cx="6300000" cy="3800000"/>
+          <a:ext cx="4900000" cy="3800000"/>
         </p:xfrm>
         <a:graphic>
           <a:graphicData uri="http://schemas.openxmlformats.org/drawingml/2006/chart">
@@ -10978,8 +10978,8 @@
         </p:nvSpPr>
         <p:spPr>
           <a:xfrm>
-            <a:off x="7400000" y="1830000"/>
-            <a:ext cx="4296192" cy="260000"/>
+            <a:off x="6200000" y="1830000"/>
+            <a:ext cx="5496192" cy="260000"/>
           </a:xfrm>
           <a:prstGeom prst="rect">
             <a:avLst/>
@@ -11000,7 +11000,7 @@
                 </a:solidFill>
                 <a:latin typeface="Inter"/>
               </a:rPr>
-              <a:t>Ekin joylashtirish rejasi, 2026 yil</a:t>
+              <a:t>Ekin joylashtirish rejasi, ga (ekin maydoniga ulushi)</a:t>
             </a:r>
           </a:p>
         </p:txBody>
@@ -11013,8 +11013,8 @@
         </p:nvSpPr>
         <p:spPr>
           <a:xfrm>
-            <a:off x="7400000" y="2150000"/>
-            <a:ext cx="4296192" cy="1830000"/>
+            <a:off x="6200000" y="2150000"/>
+            <a:ext cx="5496192" cy="3700000"/>
           </a:xfrm>
           <a:prstGeom prst="roundRect">
             <a:avLst>
@@ -11061,8 +11061,8 @@
         </p:nvSpPr>
         <p:spPr>
           <a:xfrm>
-            <a:off x="7630000" y="2320000"/>
-            <a:ext cx="3836192" cy="300000"/>
+            <a:off x="6400000" y="2350000"/>
+            <a:ext cx="1800000" cy="250000"/>
           </a:xfrm>
           <a:prstGeom prst="rect">
             <a:avLst/>
@@ -11077,13 +11077,13 @@
           <a:p>
             <a:pPr algn="l"/>
             <a:r>
-              <a:rPr sz="1600" b="1">
-                <a:solidFill>
-                  <a:srgbClr val="1D2A24"/>
+              <a:rPr sz="1200" b="1">
+                <a:solidFill>
+                  <a:srgbClr val="5F6B64"/>
                 </a:solidFill>
                 <a:latin typeface="Inter"/>
               </a:rPr>
-              <a:t>Jalaquduq tumani</a:t>
+              <a:t>Tuman</a:t>
             </a:r>
           </a:p>
         </p:txBody>
@@ -11096,8 +11096,8 @@
         </p:nvSpPr>
         <p:spPr>
           <a:xfrm>
-            <a:off x="7630000" y="2800000"/>
-            <a:ext cx="1700000" cy="300000"/>
+            <a:off x="8200000" y="2350000"/>
+            <a:ext cx="750000" cy="250000"/>
           </a:xfrm>
           <a:prstGeom prst="rect">
             <a:avLst/>
@@ -11110,15 +11110,15 @@
           </a:bodyPr>
           <a:lstStyle/>
           <a:p>
-            <a:pPr algn="l"/>
-            <a:r>
-              <a:rPr sz="1200" b="0">
-                <a:solidFill>
-                  <a:srgbClr val="4C5852"/>
+            <a:pPr algn="r"/>
+            <a:r>
+              <a:rPr sz="1200" b="1">
+                <a:solidFill>
+                  <a:srgbClr val="5F6B64"/>
                 </a:solidFill>
                 <a:latin typeface="Inter"/>
               </a:rPr>
-              <a:t>Jami ekin maydoni</a:t>
+              <a:t>Jami</a:t>
             </a:r>
           </a:p>
         </p:txBody>
@@ -11131,8 +11131,8 @@
         </p:nvSpPr>
         <p:spPr>
           <a:xfrm>
-            <a:off x="9300000" y="2800000"/>
-            <a:ext cx="2166192" cy="300000"/>
+            <a:off x="9100000" y="2350000"/>
+            <a:ext cx="1200000" cy="250000"/>
           </a:xfrm>
           <a:prstGeom prst="rect">
             <a:avLst/>
@@ -11147,13 +11147,13 @@
           <a:p>
             <a:pPr algn="r"/>
             <a:r>
-              <a:rPr sz="1300" b="1">
-                <a:solidFill>
-                  <a:srgbClr val="1D2A24"/>
+              <a:rPr sz="1200" b="1">
+                <a:solidFill>
+                  <a:srgbClr val="5F6B64"/>
                 </a:solidFill>
                 <a:latin typeface="Inter"/>
               </a:rPr>
-              <a:t>17 485 ga</a:t>
+              <a:t>Gʻoʻza</a:t>
             </a:r>
           </a:p>
         </p:txBody>
@@ -11166,8 +11166,8 @@
         </p:nvSpPr>
         <p:spPr>
           <a:xfrm>
-            <a:off x="7630000" y="3170000"/>
-            <a:ext cx="1700000" cy="300000"/>
+            <a:off x="10350000" y="2350000"/>
+            <a:ext cx="1146192" cy="250000"/>
           </a:xfrm>
           <a:prstGeom prst="rect">
             <a:avLst/>
@@ -11180,15 +11180,15 @@
           </a:bodyPr>
           <a:lstStyle/>
           <a:p>
-            <a:pPr algn="l"/>
-            <a:r>
-              <a:rPr sz="1200" b="0">
-                <a:solidFill>
-                  <a:srgbClr val="4C5852"/>
+            <a:pPr algn="r"/>
+            <a:r>
+              <a:rPr sz="1200" b="1">
+                <a:solidFill>
+                  <a:srgbClr val="5F6B64"/>
                 </a:solidFill>
                 <a:latin typeface="Inter"/>
               </a:rPr>
-              <a:t>Gʻoʻza</a:t>
+              <a:t>Bugʻdoy</a:t>
             </a:r>
           </a:p>
         </p:txBody>
@@ -11201,8 +11201,8 @@
         </p:nvSpPr>
         <p:spPr>
           <a:xfrm>
-            <a:off x="9300000" y="3170000"/>
-            <a:ext cx="2166192" cy="300000"/>
+            <a:off x="6400000" y="2800000"/>
+            <a:ext cx="1800000" cy="300000"/>
           </a:xfrm>
           <a:prstGeom prst="rect">
             <a:avLst/>
@@ -11215,15 +11215,15 @@
           </a:bodyPr>
           <a:lstStyle/>
           <a:p>
-            <a:pPr algn="r"/>
-            <a:r>
-              <a:rPr sz="1300" b="1">
+            <a:pPr algn="l"/>
+            <a:r>
+              <a:rPr sz="1200" b="1">
                 <a:solidFill>
                   <a:srgbClr val="1D2A24"/>
                 </a:solidFill>
                 <a:latin typeface="Inter"/>
               </a:rPr>
-              <a:t>4 073 ga · 23%</a:t>
+              <a:t>Jalaquduq (2026)</a:t>
             </a:r>
           </a:p>
         </p:txBody>
@@ -11236,8 +11236,8 @@
         </p:nvSpPr>
         <p:spPr>
           <a:xfrm>
-            <a:off x="7630000" y="3540000"/>
-            <a:ext cx="1700000" cy="300000"/>
+            <a:off x="8200000" y="2800000"/>
+            <a:ext cx="750000" cy="300000"/>
           </a:xfrm>
           <a:prstGeom prst="rect">
             <a:avLst/>
@@ -11250,15 +11250,15 @@
           </a:bodyPr>
           <a:lstStyle/>
           <a:p>
-            <a:pPr algn="l"/>
-            <a:r>
-              <a:rPr sz="1200" b="0">
-                <a:solidFill>
-                  <a:srgbClr val="4C5852"/>
+            <a:pPr algn="r"/>
+            <a:r>
+              <a:rPr sz="1300" b="0">
+                <a:solidFill>
+                  <a:srgbClr val="1D2A24"/>
                 </a:solidFill>
                 <a:latin typeface="Inter"/>
               </a:rPr>
-              <a:t>Bugʻdoy</a:t>
+              <a:t>17 485</a:t>
             </a:r>
           </a:p>
         </p:txBody>
@@ -11271,8 +11271,8 @@
         </p:nvSpPr>
         <p:spPr>
           <a:xfrm>
-            <a:off x="9300000" y="3540000"/>
-            <a:ext cx="2166192" cy="300000"/>
+            <a:off x="9100000" y="2800000"/>
+            <a:ext cx="1200000" cy="300000"/>
           </a:xfrm>
           <a:prstGeom prst="rect">
             <a:avLst/>
@@ -11287,62 +11287,49 @@
           <a:p>
             <a:pPr algn="r"/>
             <a:r>
-              <a:rPr sz="1300" b="1">
+              <a:rPr sz="1300" b="0">
                 <a:solidFill>
                   <a:srgbClr val="1D2A24"/>
                 </a:solidFill>
                 <a:latin typeface="Inter"/>
               </a:rPr>
-              <a:t>6 166 ga · 35%</a:t>
-            </a:r>
-          </a:p>
-        </p:txBody>
-      </p:sp>
-      <p:sp>
-        <p:nvSpPr>
-          <p:cNvPr id="18" name="Rounded Rectangle 17"/>
-          <p:cNvSpPr/>
-          <p:nvPr/>
-        </p:nvSpPr>
-        <p:spPr>
-          <a:xfrm>
-            <a:off x="7400000" y="4130000"/>
-            <a:ext cx="4296192" cy="1830000"/>
-          </a:xfrm>
-          <a:prstGeom prst="roundRect">
-            <a:avLst>
-              <a:gd name="adj" fmla="val 5000"/>
-            </a:avLst>
-          </a:prstGeom>
-          <a:solidFill>
-            <a:srgbClr val="FBF9F4"/>
-          </a:solidFill>
-          <a:ln w="6350">
-            <a:solidFill>
-              <a:srgbClr val="D9D2C3"/>
-            </a:solidFill>
-          </a:ln>
-          <a:effectLst/>
-        </p:spPr>
-        <p:style>
-          <a:lnRef idx="1">
-            <a:schemeClr val="accent1"/>
-          </a:lnRef>
-          <a:fillRef idx="3">
-            <a:schemeClr val="accent1"/>
-          </a:fillRef>
-          <a:effectRef idx="2">
-            <a:schemeClr val="accent1"/>
-          </a:effectRef>
-          <a:fontRef idx="minor">
-            <a:schemeClr val="lt1"/>
-          </a:fontRef>
-        </p:style>
-        <p:txBody>
-          <a:bodyPr rtlCol="0" anchor="ctr"/>
-          <a:lstStyle/>
-          <a:p>
-            <a:pPr algn="ctr"/>
+              <a:t>4 073 · 23%</a:t>
+            </a:r>
+          </a:p>
+        </p:txBody>
+      </p:sp>
+      <p:sp>
+        <p:nvSpPr>
+          <p:cNvPr id="18" name="TextBox 17"/>
+          <p:cNvSpPr txBox="1"/>
+          <p:nvPr/>
+        </p:nvSpPr>
+        <p:spPr>
+          <a:xfrm>
+            <a:off x="10350000" y="2800000"/>
+            <a:ext cx="1146192" cy="300000"/>
+          </a:xfrm>
+          <a:prstGeom prst="rect">
+            <a:avLst/>
+          </a:prstGeom>
+          <a:noFill/>
+        </p:spPr>
+        <p:txBody>
+          <a:bodyPr wrap="square" lIns="0" rIns="0" tIns="0" bIns="0" anchor="t">
+            <a:spAutoFit/>
+          </a:bodyPr>
+          <a:lstStyle/>
+          <a:p>
+            <a:pPr algn="r"/>
+            <a:r>
+              <a:rPr sz="1300" b="0">
+                <a:solidFill>
+                  <a:srgbClr val="1D2A24"/>
+                </a:solidFill>
+                <a:latin typeface="Inter"/>
+              </a:rPr>
+              <a:t>6 166 · 35%</a:t>
+            </a:r>
           </a:p>
         </p:txBody>
       </p:sp>
@@ -11354,8 +11341,8 @@
         </p:nvSpPr>
         <p:spPr>
           <a:xfrm>
-            <a:off x="7630000" y="4300000"/>
-            <a:ext cx="3836192" cy="300000"/>
+            <a:off x="6400000" y="3390000"/>
+            <a:ext cx="1800000" cy="300000"/>
           </a:xfrm>
           <a:prstGeom prst="rect">
             <a:avLst/>
@@ -11370,13 +11357,13 @@
           <a:p>
             <a:pPr algn="l"/>
             <a:r>
-              <a:rPr sz="1600" b="1">
+              <a:rPr sz="1200" b="1">
                 <a:solidFill>
                   <a:srgbClr val="1D2A24"/>
                 </a:solidFill>
                 <a:latin typeface="Inter"/>
               </a:rPr>
-              <a:t>Shahrixon tumani</a:t>
+              <a:t>Shahrixon (2026)</a:t>
             </a:r>
           </a:p>
         </p:txBody>
@@ -11389,8 +11376,8 @@
         </p:nvSpPr>
         <p:spPr>
           <a:xfrm>
-            <a:off x="7630000" y="4780000"/>
-            <a:ext cx="1700000" cy="300000"/>
+            <a:off x="8200000" y="3390000"/>
+            <a:ext cx="750000" cy="300000"/>
           </a:xfrm>
           <a:prstGeom prst="rect">
             <a:avLst/>
@@ -11403,15 +11390,15 @@
           </a:bodyPr>
           <a:lstStyle/>
           <a:p>
-            <a:pPr algn="l"/>
-            <a:r>
-              <a:rPr sz="1200" b="0">
-                <a:solidFill>
-                  <a:srgbClr val="4C5852"/>
+            <a:pPr algn="r"/>
+            <a:r>
+              <a:rPr sz="1300" b="0">
+                <a:solidFill>
+                  <a:srgbClr val="1D2A24"/>
                 </a:solidFill>
                 <a:latin typeface="Inter"/>
               </a:rPr>
-              <a:t>Jami ekin maydoni</a:t>
+              <a:t>16 065</a:t>
             </a:r>
           </a:p>
         </p:txBody>
@@ -11424,8 +11411,8 @@
         </p:nvSpPr>
         <p:spPr>
           <a:xfrm>
-            <a:off x="9300000" y="4780000"/>
-            <a:ext cx="2166192" cy="300000"/>
+            <a:off x="9100000" y="3390000"/>
+            <a:ext cx="1200000" cy="300000"/>
           </a:xfrm>
           <a:prstGeom prst="rect">
             <a:avLst/>
@@ -11440,13 +11427,13 @@
           <a:p>
             <a:pPr algn="r"/>
             <a:r>
-              <a:rPr sz="1300" b="1">
+              <a:rPr sz="1300" b="0">
                 <a:solidFill>
                   <a:srgbClr val="1D2A24"/>
                 </a:solidFill>
                 <a:latin typeface="Inter"/>
               </a:rPr>
-              <a:t>16 065 ga</a:t>
+              <a:t>5 650 · 35%</a:t>
             </a:r>
           </a:p>
         </p:txBody>
@@ -11459,8 +11446,8 @@
         </p:nvSpPr>
         <p:spPr>
           <a:xfrm>
-            <a:off x="7630000" y="5150000"/>
-            <a:ext cx="1700000" cy="300000"/>
+            <a:off x="10350000" y="3390000"/>
+            <a:ext cx="1146192" cy="300000"/>
           </a:xfrm>
           <a:prstGeom prst="rect">
             <a:avLst/>
@@ -11473,15 +11460,15 @@
           </a:bodyPr>
           <a:lstStyle/>
           <a:p>
-            <a:pPr algn="l"/>
-            <a:r>
-              <a:rPr sz="1200" b="0">
-                <a:solidFill>
-                  <a:srgbClr val="4C5852"/>
+            <a:pPr algn="r"/>
+            <a:r>
+              <a:rPr sz="1300" b="0">
+                <a:solidFill>
+                  <a:srgbClr val="1D2A24"/>
                 </a:solidFill>
                 <a:latin typeface="Inter"/>
               </a:rPr>
-              <a:t>Gʻoʻza</a:t>
+              <a:t>6 402 · 40%</a:t>
             </a:r>
           </a:p>
         </p:txBody>
@@ -11494,8 +11481,8 @@
         </p:nvSpPr>
         <p:spPr>
           <a:xfrm>
-            <a:off x="9300000" y="5150000"/>
-            <a:ext cx="2166192" cy="300000"/>
+            <a:off x="6400000" y="3980000"/>
+            <a:ext cx="1800000" cy="300000"/>
           </a:xfrm>
           <a:prstGeom prst="rect">
             <a:avLst/>
@@ -11508,15 +11495,15 @@
           </a:bodyPr>
           <a:lstStyle/>
           <a:p>
-            <a:pPr algn="r"/>
-            <a:r>
-              <a:rPr sz="1300" b="1">
+            <a:pPr algn="l"/>
+            <a:r>
+              <a:rPr sz="1200" b="1">
                 <a:solidFill>
                   <a:srgbClr val="1D2A24"/>
                 </a:solidFill>
                 <a:latin typeface="Inter"/>
               </a:rPr>
-              <a:t>5 650 ga · 35%</a:t>
+              <a:t>Qoʻrgʻontepa (2026)</a:t>
             </a:r>
           </a:p>
         </p:txBody>
@@ -11529,8 +11516,8 @@
         </p:nvSpPr>
         <p:spPr>
           <a:xfrm>
-            <a:off x="7630000" y="5520000"/>
-            <a:ext cx="1700000" cy="300000"/>
+            <a:off x="8200000" y="3980000"/>
+            <a:ext cx="750000" cy="300000"/>
           </a:xfrm>
           <a:prstGeom prst="rect">
             <a:avLst/>
@@ -11543,15 +11530,15 @@
           </a:bodyPr>
           <a:lstStyle/>
           <a:p>
-            <a:pPr algn="l"/>
-            <a:r>
-              <a:rPr sz="1200" b="0">
-                <a:solidFill>
-                  <a:srgbClr val="4C5852"/>
+            <a:pPr algn="r"/>
+            <a:r>
+              <a:rPr sz="1300" b="0">
+                <a:solidFill>
+                  <a:srgbClr val="1D2A24"/>
                 </a:solidFill>
                 <a:latin typeface="Inter"/>
               </a:rPr>
-              <a:t>Bugʻdoy</a:t>
+              <a:t>21 542</a:t>
             </a:r>
           </a:p>
         </p:txBody>
@@ -11564,8 +11551,8 @@
         </p:nvSpPr>
         <p:spPr>
           <a:xfrm>
-            <a:off x="9300000" y="5520000"/>
-            <a:ext cx="2166192" cy="300000"/>
+            <a:off x="9100000" y="3980000"/>
+            <a:ext cx="1200000" cy="300000"/>
           </a:xfrm>
           <a:prstGeom prst="rect">
             <a:avLst/>
@@ -11580,13 +11567,13 @@
           <a:p>
             <a:pPr algn="r"/>
             <a:r>
-              <a:rPr sz="1300" b="1">
+              <a:rPr sz="1300" b="0">
                 <a:solidFill>
                   <a:srgbClr val="1D2A24"/>
                 </a:solidFill>
                 <a:latin typeface="Inter"/>
               </a:rPr>
-              <a:t>6 402 ga · 40%</a:t>
+              <a:t>6 618 · 31%</a:t>
             </a:r>
           </a:p>
         </p:txBody>
@@ -11599,6 +11586,321 @@
         </p:nvSpPr>
         <p:spPr>
           <a:xfrm>
+            <a:off x="10350000" y="3980000"/>
+            <a:ext cx="1146192" cy="300000"/>
+          </a:xfrm>
+          <a:prstGeom prst="rect">
+            <a:avLst/>
+          </a:prstGeom>
+          <a:noFill/>
+        </p:spPr>
+        <p:txBody>
+          <a:bodyPr wrap="square" lIns="0" rIns="0" tIns="0" bIns="0" anchor="t">
+            <a:spAutoFit/>
+          </a:bodyPr>
+          <a:lstStyle/>
+          <a:p>
+            <a:pPr algn="r"/>
+            <a:r>
+              <a:rPr sz="1300" b="0">
+                <a:solidFill>
+                  <a:srgbClr val="1D2A24"/>
+                </a:solidFill>
+                <a:latin typeface="Inter"/>
+              </a:rPr>
+              <a:t>7 324 · 34%</a:t>
+            </a:r>
+          </a:p>
+        </p:txBody>
+      </p:sp>
+      <p:sp>
+        <p:nvSpPr>
+          <p:cNvPr id="27" name="TextBox 26"/>
+          <p:cNvSpPr txBox="1"/>
+          <p:nvPr/>
+        </p:nvSpPr>
+        <p:spPr>
+          <a:xfrm>
+            <a:off x="6400000" y="4570000"/>
+            <a:ext cx="1800000" cy="300000"/>
+          </a:xfrm>
+          <a:prstGeom prst="rect">
+            <a:avLst/>
+          </a:prstGeom>
+          <a:noFill/>
+        </p:spPr>
+        <p:txBody>
+          <a:bodyPr wrap="square" lIns="0" rIns="0" tIns="0" bIns="0" anchor="t">
+            <a:spAutoFit/>
+          </a:bodyPr>
+          <a:lstStyle/>
+          <a:p>
+            <a:pPr algn="l"/>
+            <a:r>
+              <a:rPr sz="1200" b="1">
+                <a:solidFill>
+                  <a:srgbClr val="1D2A24"/>
+                </a:solidFill>
+                <a:latin typeface="Inter"/>
+              </a:rPr>
+              <a:t>Paxtaobod (2026)</a:t>
+            </a:r>
+          </a:p>
+        </p:txBody>
+      </p:sp>
+      <p:sp>
+        <p:nvSpPr>
+          <p:cNvPr id="28" name="TextBox 27"/>
+          <p:cNvSpPr txBox="1"/>
+          <p:nvPr/>
+        </p:nvSpPr>
+        <p:spPr>
+          <a:xfrm>
+            <a:off x="8200000" y="4570000"/>
+            <a:ext cx="750000" cy="300000"/>
+          </a:xfrm>
+          <a:prstGeom prst="rect">
+            <a:avLst/>
+          </a:prstGeom>
+          <a:noFill/>
+        </p:spPr>
+        <p:txBody>
+          <a:bodyPr wrap="square" lIns="0" rIns="0" tIns="0" bIns="0" anchor="t">
+            <a:spAutoFit/>
+          </a:bodyPr>
+          <a:lstStyle/>
+          <a:p>
+            <a:pPr algn="r"/>
+            <a:r>
+              <a:rPr sz="1300" b="0">
+                <a:solidFill>
+                  <a:srgbClr val="1D2A24"/>
+                </a:solidFill>
+                <a:latin typeface="Inter"/>
+              </a:rPr>
+              <a:t>15 511</a:t>
+            </a:r>
+          </a:p>
+        </p:txBody>
+      </p:sp>
+      <p:sp>
+        <p:nvSpPr>
+          <p:cNvPr id="29" name="TextBox 28"/>
+          <p:cNvSpPr txBox="1"/>
+          <p:nvPr/>
+        </p:nvSpPr>
+        <p:spPr>
+          <a:xfrm>
+            <a:off x="9100000" y="4570000"/>
+            <a:ext cx="1200000" cy="300000"/>
+          </a:xfrm>
+          <a:prstGeom prst="rect">
+            <a:avLst/>
+          </a:prstGeom>
+          <a:noFill/>
+        </p:spPr>
+        <p:txBody>
+          <a:bodyPr wrap="square" lIns="0" rIns="0" tIns="0" bIns="0" anchor="t">
+            <a:spAutoFit/>
+          </a:bodyPr>
+          <a:lstStyle/>
+          <a:p>
+            <a:pPr algn="r"/>
+            <a:r>
+              <a:rPr sz="1300" b="0">
+                <a:solidFill>
+                  <a:srgbClr val="1D2A24"/>
+                </a:solidFill>
+                <a:latin typeface="Inter"/>
+              </a:rPr>
+              <a:t>4 450 · 29%</a:t>
+            </a:r>
+          </a:p>
+        </p:txBody>
+      </p:sp>
+      <p:sp>
+        <p:nvSpPr>
+          <p:cNvPr id="30" name="TextBox 29"/>
+          <p:cNvSpPr txBox="1"/>
+          <p:nvPr/>
+        </p:nvSpPr>
+        <p:spPr>
+          <a:xfrm>
+            <a:off x="10350000" y="4570000"/>
+            <a:ext cx="1146192" cy="300000"/>
+          </a:xfrm>
+          <a:prstGeom prst="rect">
+            <a:avLst/>
+          </a:prstGeom>
+          <a:noFill/>
+        </p:spPr>
+        <p:txBody>
+          <a:bodyPr wrap="square" lIns="0" rIns="0" tIns="0" bIns="0" anchor="t">
+            <a:spAutoFit/>
+          </a:bodyPr>
+          <a:lstStyle/>
+          <a:p>
+            <a:pPr algn="r"/>
+            <a:r>
+              <a:rPr sz="1300" b="0">
+                <a:solidFill>
+                  <a:srgbClr val="1D2A24"/>
+                </a:solidFill>
+                <a:latin typeface="Inter"/>
+              </a:rPr>
+              <a:t>6 492 · 42%</a:t>
+            </a:r>
+          </a:p>
+        </p:txBody>
+      </p:sp>
+      <p:sp>
+        <p:nvSpPr>
+          <p:cNvPr id="31" name="TextBox 30"/>
+          <p:cNvSpPr txBox="1"/>
+          <p:nvPr/>
+        </p:nvSpPr>
+        <p:spPr>
+          <a:xfrm>
+            <a:off x="6400000" y="5160000"/>
+            <a:ext cx="1800000" cy="300000"/>
+          </a:xfrm>
+          <a:prstGeom prst="rect">
+            <a:avLst/>
+          </a:prstGeom>
+          <a:noFill/>
+        </p:spPr>
+        <p:txBody>
+          <a:bodyPr wrap="square" lIns="0" rIns="0" tIns="0" bIns="0" anchor="t">
+            <a:spAutoFit/>
+          </a:bodyPr>
+          <a:lstStyle/>
+          <a:p>
+            <a:pPr algn="l"/>
+            <a:r>
+              <a:rPr sz="1200" b="1">
+                <a:solidFill>
+                  <a:srgbClr val="1D2A24"/>
+                </a:solidFill>
+                <a:latin typeface="Inter"/>
+              </a:rPr>
+              <a:t>Oltinkoʻl (2025)</a:t>
+            </a:r>
+          </a:p>
+        </p:txBody>
+      </p:sp>
+      <p:sp>
+        <p:nvSpPr>
+          <p:cNvPr id="32" name="TextBox 31"/>
+          <p:cNvSpPr txBox="1"/>
+          <p:nvPr/>
+        </p:nvSpPr>
+        <p:spPr>
+          <a:xfrm>
+            <a:off x="8200000" y="5160000"/>
+            <a:ext cx="750000" cy="300000"/>
+          </a:xfrm>
+          <a:prstGeom prst="rect">
+            <a:avLst/>
+          </a:prstGeom>
+          <a:noFill/>
+        </p:spPr>
+        <p:txBody>
+          <a:bodyPr wrap="square" lIns="0" rIns="0" tIns="0" bIns="0" anchor="t">
+            <a:spAutoFit/>
+          </a:bodyPr>
+          <a:lstStyle/>
+          <a:p>
+            <a:pPr algn="r"/>
+            <a:r>
+              <a:rPr sz="1300" b="0">
+                <a:solidFill>
+                  <a:srgbClr val="1D2A24"/>
+                </a:solidFill>
+                <a:latin typeface="Inter"/>
+              </a:rPr>
+              <a:t>11 147</a:t>
+            </a:r>
+          </a:p>
+        </p:txBody>
+      </p:sp>
+      <p:sp>
+        <p:nvSpPr>
+          <p:cNvPr id="33" name="TextBox 32"/>
+          <p:cNvSpPr txBox="1"/>
+          <p:nvPr/>
+        </p:nvSpPr>
+        <p:spPr>
+          <a:xfrm>
+            <a:off x="9100000" y="5160000"/>
+            <a:ext cx="1200000" cy="300000"/>
+          </a:xfrm>
+          <a:prstGeom prst="rect">
+            <a:avLst/>
+          </a:prstGeom>
+          <a:noFill/>
+        </p:spPr>
+        <p:txBody>
+          <a:bodyPr wrap="square" lIns="0" rIns="0" tIns="0" bIns="0" anchor="t">
+            <a:spAutoFit/>
+          </a:bodyPr>
+          <a:lstStyle/>
+          <a:p>
+            <a:pPr algn="r"/>
+            <a:r>
+              <a:rPr sz="1300" b="0">
+                <a:solidFill>
+                  <a:srgbClr val="1D2A24"/>
+                </a:solidFill>
+                <a:latin typeface="Inter"/>
+              </a:rPr>
+              <a:t>3 740 · 34%</a:t>
+            </a:r>
+          </a:p>
+        </p:txBody>
+      </p:sp>
+      <p:sp>
+        <p:nvSpPr>
+          <p:cNvPr id="34" name="TextBox 33"/>
+          <p:cNvSpPr txBox="1"/>
+          <p:nvPr/>
+        </p:nvSpPr>
+        <p:spPr>
+          <a:xfrm>
+            <a:off x="10350000" y="5160000"/>
+            <a:ext cx="1146192" cy="300000"/>
+          </a:xfrm>
+          <a:prstGeom prst="rect">
+            <a:avLst/>
+          </a:prstGeom>
+          <a:noFill/>
+        </p:spPr>
+        <p:txBody>
+          <a:bodyPr wrap="square" lIns="0" rIns="0" tIns="0" bIns="0" anchor="t">
+            <a:spAutoFit/>
+          </a:bodyPr>
+          <a:lstStyle/>
+          <a:p>
+            <a:pPr algn="r"/>
+            <a:r>
+              <a:rPr sz="1300" b="0">
+                <a:solidFill>
+                  <a:srgbClr val="1D2A24"/>
+                </a:solidFill>
+                <a:latin typeface="Inter"/>
+              </a:rPr>
+              <a:t>4 144 · 37%</a:t>
+            </a:r>
+          </a:p>
+        </p:txBody>
+      </p:sp>
+      <p:sp>
+        <p:nvSpPr>
+          <p:cNvPr id="35" name="TextBox 34"/>
+          <p:cNvSpPr txBox="1"/>
+          <p:nvPr/>
+        </p:nvSpPr>
+        <p:spPr>
+          <a:xfrm>
             <a:off x="812800" y="6238280"/>
             <a:ext cx="9800000" cy="240000"/>
           </a:xfrm>
@@ -11621,7 +11923,7 @@
                 </a:solidFill>
                 <a:latin typeface="Inter"/>
               </a:rPr>
-              <a:t>Manba: 2025 yil paxta hosili hisoboti; Jalaquduq va Shahrixon 2026 yil ekin joylashtirish rejalari</a:t>
+              <a:t>Manba: 2025 yil paxta hosili hisoboti; tumanlar ekin joylashtirish rejalari (Oltinkoʻl — 2025 yil hosili)</a:t>
             </a:r>
           </a:p>
         </p:txBody>
@@ -16803,7 +17105,7 @@
                           <a:ea typeface="Inter" pitchFamily="34" charset="-122"/>
                           <a:cs typeface="Inter" pitchFamily="34" charset="-120"/>
                         </a:rPr>
-                        <a:t>Jalaquduq va Shahrixon tumanlari: kontur va fermer kesimida ekin maydonlari</a:t>
+                        <a:t>5 ta tuman: kontur va fermer kesimida ekin maydonlari</a:t>
                       </a:r>
                       <a:endParaRPr lang="en-US" sz="1300" dirty="0">
                         <a:latin typeface="Inter" charset="0"/>

</xml_diff>

<commit_message>
Add cotton area change slide (2015-2025 and 2024 vs 2026 by district)
Co-Authored-By: Claude Sonnet 5.5 <noreply@anthropic.com>
Claude-Session: https://claude.ai/code/session_01M4MZatV28utL9zTp7saaUz
</commit_message>
<xml_diff>
--- a/Garbiy_Farg_ona_tuproqlari_GAT_asosida_bashoratlash.pptx
+++ b/Garbiy_Farg_ona_tuproqlari_GAT_asosida_bashoratlash.pptx
@@ -17,6 +17,7 @@
     <p:sldId id="272" r:id="rId23"/>
     <p:sldId id="273" r:id="rId24"/>
     <p:sldId id="274" r:id="rId25"/>
+    <p:sldId id="275" r:id="rId26"/>
     <p:sldId id="265" r:id="rId11"/>
     <p:sldId id="266" r:id="rId12"/>
     <p:sldId id="267" r:id="rId13"/>
@@ -976,6 +977,486 @@
         <c:crosses val="autoZero"/>
       </c:valAx>
     </c:plotArea>
+    <c:dispBlanksAs val="gap"/>
+  </c:chart>
+  <c:txPr>
+    <a:bodyPr/>
+    <a:lstStyle/>
+    <a:p>
+      <a:pPr>
+        <a:defRPr sz="1200">
+          <a:solidFill>
+            <a:srgbClr val="4C5852"/>
+          </a:solidFill>
+          <a:latin typeface="Inter"/>
+        </a:defRPr>
+      </a:pPr>
+      <a:endParaRPr lang="en-US"/>
+    </a:p>
+  </c:txPr>
+  <c:externalData r:id="rId1">
+    <c:autoUpdate val="0"/>
+  </c:externalData>
+</c:chartSpace>
+</file>
+
+<file path=ppt/charts/chart5.xml><?xml version="1.0" encoding="utf-8"?>
+<c:chartSpace xmlns:c="http://schemas.openxmlformats.org/drawingml/2006/chart" xmlns:a="http://schemas.openxmlformats.org/drawingml/2006/main" xmlns:r="http://schemas.openxmlformats.org/officeDocument/2006/relationships">
+  <c:date1904 val="0"/>
+  <c:chart>
+    <c:autoTitleDeleted val="1"/>
+    <c:plotArea>
+      <c:barChart>
+        <c:barDir val="col"/>
+        <c:grouping val="clustered"/>
+        <c:ser>
+          <c:idx val="0"/>
+          <c:order val="0"/>
+          <c:tx>
+            <c:strRef>
+              <c:f>Sheet1!$B$1</c:f>
+              <c:strCache>
+                <c:ptCount val="1"/>
+                <c:pt idx="0">
+                  <c:v>Paxta maydoni</c:v>
+                </c:pt>
+              </c:strCache>
+            </c:strRef>
+          </c:tx>
+          <c:spPr>
+            <a:solidFill>
+              <a:srgbClr val="2C6A85"/>
+            </a:solidFill>
+          </c:spPr>
+          <c:dPt>
+            <c:idx val="10"/>
+            <c:spPr>
+              <a:solidFill>
+                <a:srgbClr val="A4521D"/>
+              </a:solidFill>
+            </c:spPr>
+          </c:dPt>
+          <c:cat>
+            <c:strRef>
+              <c:f>Sheet1!$A$2:$A$12</c:f>
+              <c:strCache>
+                <c:ptCount val="11"/>
+                <c:pt idx="0">
+                  <c:v>2015</c:v>
+                </c:pt>
+                <c:pt idx="1">
+                  <c:v>2016</c:v>
+                </c:pt>
+                <c:pt idx="2">
+                  <c:v>2017</c:v>
+                </c:pt>
+                <c:pt idx="3">
+                  <c:v>2018</c:v>
+                </c:pt>
+                <c:pt idx="4">
+                  <c:v>2019</c:v>
+                </c:pt>
+                <c:pt idx="5">
+                  <c:v>2020</c:v>
+                </c:pt>
+                <c:pt idx="6">
+                  <c:v>2021</c:v>
+                </c:pt>
+                <c:pt idx="7">
+                  <c:v>2022</c:v>
+                </c:pt>
+                <c:pt idx="8">
+                  <c:v>2023</c:v>
+                </c:pt>
+                <c:pt idx="9">
+                  <c:v>2024</c:v>
+                </c:pt>
+                <c:pt idx="10">
+                  <c:v>2025</c:v>
+                </c:pt>
+              </c:strCache>
+            </c:strRef>
+          </c:cat>
+          <c:val>
+            <c:numRef>
+              <c:f>Sheet1!$B$2:$B$12</c:f>
+              <c:numCache>
+                <c:formatCode>General</c:formatCode>
+                <c:ptCount val="11"/>
+                <c:pt idx="0">
+                  <c:v>93.4</c:v>
+                </c:pt>
+                <c:pt idx="1">
+                  <c:v>91.4</c:v>
+                </c:pt>
+                <c:pt idx="2">
+                  <c:v>89.2</c:v>
+                </c:pt>
+                <c:pt idx="3">
+                  <c:v>81.8</c:v>
+                </c:pt>
+                <c:pt idx="4">
+                  <c:v>79.4</c:v>
+                </c:pt>
+                <c:pt idx="5">
+                  <c:v>79.4</c:v>
+                </c:pt>
+                <c:pt idx="6">
+                  <c:v>79.0</c:v>
+                </c:pt>
+                <c:pt idx="7">
+                  <c:v>75.0</c:v>
+                </c:pt>
+                <c:pt idx="8">
+                  <c:v>71.3</c:v>
+                </c:pt>
+                <c:pt idx="9">
+                  <c:v>70.0</c:v>
+                </c:pt>
+                <c:pt idx="10">
+                  <c:v>60.0</c:v>
+                </c:pt>
+              </c:numCache>
+            </c:numRef>
+          </c:val>
+        </c:ser>
+        <c:dLbls>
+          <c:numFmt formatCode="0.0" sourceLinked="0"/>
+          <c:txPr>
+            <a:bodyPr/>
+            <a:lstStyle/>
+            <a:p>
+              <a:pPr>
+                <a:defRPr sz="1200">
+                  <a:solidFill>
+                    <a:srgbClr val="1D2A24"/>
+                  </a:solidFill>
+                  <a:latin typeface="Inter"/>
+                </a:defRPr>
+              </a:pPr>
+            </a:p>
+          </c:txPr>
+          <c:dLblPos val="outEnd"/>
+          <c:showLegendKey val="0"/>
+          <c:showVal val="1"/>
+          <c:showCatName val="0"/>
+          <c:showSerName val="0"/>
+          <c:showPercent val="0"/>
+          <c:showBubbleSize val="0"/>
+          <c:showLeaderLines val="1"/>
+        </c:dLbls>
+        <c:gapWidth val="45"/>
+        <c:axId val="-2068027336"/>
+        <c:axId val="-2113994440"/>
+      </c:barChart>
+      <c:catAx>
+        <c:axId val="-2068027336"/>
+        <c:scaling>
+          <c:orientation val="minMax"/>
+        </c:scaling>
+        <c:delete val="0"/>
+        <c:axPos val="b"/>
+        <c:majorTickMark val="out"/>
+        <c:minorTickMark val="none"/>
+        <c:tickLblPos val="nextTo"/>
+        <c:spPr>
+          <a:ln>
+            <a:solidFill>
+              <a:srgbClr val="B5B2AD"/>
+            </a:solidFill>
+          </a:ln>
+        </c:spPr>
+        <c:txPr>
+          <a:bodyPr/>
+          <a:lstStyle/>
+          <a:p>
+            <a:pPr>
+              <a:defRPr sz="1200">
+                <a:solidFill>
+                  <a:srgbClr val="4C5852"/>
+                </a:solidFill>
+                <a:latin typeface="Inter"/>
+              </a:defRPr>
+            </a:pPr>
+          </a:p>
+        </c:txPr>
+        <c:crossAx val="-2113994440"/>
+        <c:crosses val="autoZero"/>
+        <c:auto val="1"/>
+        <c:lblAlgn val="ctr"/>
+        <c:lblOffset val="100"/>
+        <c:noMultiLvlLbl val="0"/>
+      </c:catAx>
+      <c:valAx>
+        <c:axId val="-2113994440"/>
+        <c:scaling>
+          <c:max val="110.0"/>
+          <c:min val="0.0"/>
+        </c:scaling>
+        <c:delete/>
+        <c:axPos val="l"/>
+        <c:majorTickMark val="out"/>
+        <c:minorTickMark val="none"/>
+        <c:tickLblPos val="nextTo"/>
+        <c:crossAx val="-2068027336"/>
+        <c:crosses val="autoZero"/>
+      </c:valAx>
+    </c:plotArea>
+    <c:dispBlanksAs val="gap"/>
+  </c:chart>
+  <c:txPr>
+    <a:bodyPr/>
+    <a:lstStyle/>
+    <a:p>
+      <a:pPr>
+        <a:defRPr sz="1200">
+          <a:solidFill>
+            <a:srgbClr val="4C5852"/>
+          </a:solidFill>
+          <a:latin typeface="Inter"/>
+        </a:defRPr>
+      </a:pPr>
+      <a:endParaRPr lang="en-US"/>
+    </a:p>
+  </c:txPr>
+  <c:externalData r:id="rId1">
+    <c:autoUpdate val="0"/>
+  </c:externalData>
+</c:chartSpace>
+</file>
+
+<file path=ppt/charts/chart6.xml><?xml version="1.0" encoding="utf-8"?>
+<c:chartSpace xmlns:c="http://schemas.openxmlformats.org/drawingml/2006/chart" xmlns:a="http://schemas.openxmlformats.org/drawingml/2006/main" xmlns:r="http://schemas.openxmlformats.org/officeDocument/2006/relationships">
+  <c:date1904 val="0"/>
+  <c:chart>
+    <c:autoTitleDeleted val="1"/>
+    <c:plotArea>
+      <c:barChart>
+        <c:barDir val="col"/>
+        <c:grouping val="clustered"/>
+        <c:ser>
+          <c:idx val="0"/>
+          <c:order val="0"/>
+          <c:tx>
+            <c:strRef>
+              <c:f>Sheet1!$B$1</c:f>
+              <c:strCache>
+                <c:ptCount val="1"/>
+                <c:pt idx="0">
+                  <c:v>2024</c:v>
+                </c:pt>
+              </c:strCache>
+            </c:strRef>
+          </c:tx>
+          <c:spPr>
+            <a:solidFill>
+              <a:srgbClr val="A9B5AE"/>
+            </a:solidFill>
+          </c:spPr>
+          <c:cat>
+            <c:strRef>
+              <c:f>Sheet1!$A$2:$A$5</c:f>
+              <c:strCache>
+                <c:ptCount val="4"/>
+                <c:pt idx="0">
+                  <c:v>Jalaquduq</c:v>
+                </c:pt>
+                <c:pt idx="1">
+                  <c:v>Shahrixon</c:v>
+                </c:pt>
+                <c:pt idx="2">
+                  <c:v>Qoʻrgʻontepa</c:v>
+                </c:pt>
+                <c:pt idx="3">
+                  <c:v>Paxtaobod</c:v>
+                </c:pt>
+              </c:strCache>
+            </c:strRef>
+          </c:cat>
+          <c:val>
+            <c:numRef>
+              <c:f>Sheet1!$B$2:$B$5</c:f>
+              <c:numCache>
+                <c:formatCode>General</c:formatCode>
+                <c:ptCount val="4"/>
+                <c:pt idx="0">
+                  <c:v>5330</c:v>
+                </c:pt>
+                <c:pt idx="1">
+                  <c:v>6341</c:v>
+                </c:pt>
+                <c:pt idx="2">
+                  <c:v>7414</c:v>
+                </c:pt>
+                <c:pt idx="3">
+                  <c:v>5275</c:v>
+                </c:pt>
+              </c:numCache>
+            </c:numRef>
+          </c:val>
+        </c:ser>
+        <c:ser>
+          <c:idx val="1"/>
+          <c:order val="1"/>
+          <c:tx>
+            <c:strRef>
+              <c:f>Sheet1!$C$1</c:f>
+              <c:strCache>
+                <c:ptCount val="1"/>
+                <c:pt idx="0">
+                  <c:v>2026</c:v>
+                </c:pt>
+              </c:strCache>
+            </c:strRef>
+          </c:tx>
+          <c:spPr>
+            <a:solidFill>
+              <a:srgbClr val="2C6A85"/>
+            </a:solidFill>
+          </c:spPr>
+          <c:cat>
+            <c:strRef>
+              <c:f>Sheet1!$A$2:$A$5</c:f>
+              <c:strCache>
+                <c:ptCount val="4"/>
+                <c:pt idx="0">
+                  <c:v>Jalaquduq</c:v>
+                </c:pt>
+                <c:pt idx="1">
+                  <c:v>Shahrixon</c:v>
+                </c:pt>
+                <c:pt idx="2">
+                  <c:v>Qoʻrgʻontepa</c:v>
+                </c:pt>
+                <c:pt idx="3">
+                  <c:v>Paxtaobod</c:v>
+                </c:pt>
+              </c:strCache>
+            </c:strRef>
+          </c:cat>
+          <c:val>
+            <c:numRef>
+              <c:f>Sheet1!$C$2:$C$5</c:f>
+              <c:numCache>
+                <c:formatCode>General</c:formatCode>
+                <c:ptCount val="4"/>
+                <c:pt idx="0">
+                  <c:v>4073</c:v>
+                </c:pt>
+                <c:pt idx="1">
+                  <c:v>5650</c:v>
+                </c:pt>
+                <c:pt idx="2">
+                  <c:v>6618</c:v>
+                </c:pt>
+                <c:pt idx="3">
+                  <c:v>4450</c:v>
+                </c:pt>
+              </c:numCache>
+            </c:numRef>
+          </c:val>
+        </c:ser>
+        <c:dLbls>
+          <c:numFmt formatCode="#,##0" sourceLinked="0"/>
+          <c:txPr>
+            <a:bodyPr/>
+            <a:lstStyle/>
+            <a:p>
+              <a:pPr>
+                <a:defRPr sz="1200">
+                  <a:solidFill>
+                    <a:srgbClr val="1D2A24"/>
+                  </a:solidFill>
+                  <a:latin typeface="Inter"/>
+                </a:defRPr>
+              </a:pPr>
+            </a:p>
+          </c:txPr>
+          <c:dLblPos val="outEnd"/>
+          <c:showLegendKey val="0"/>
+          <c:showVal val="1"/>
+          <c:showCatName val="0"/>
+          <c:showSerName val="0"/>
+          <c:showPercent val="0"/>
+          <c:showBubbleSize val="0"/>
+          <c:showLeaderLines val="1"/>
+        </c:dLbls>
+        <c:gapWidth val="60"/>
+        <c:overlap val="-5"/>
+        <c:axId val="-2068027336"/>
+        <c:axId val="-2113994440"/>
+      </c:barChart>
+      <c:catAx>
+        <c:axId val="-2068027336"/>
+        <c:scaling>
+          <c:orientation val="minMax"/>
+        </c:scaling>
+        <c:delete val="0"/>
+        <c:axPos val="b"/>
+        <c:majorTickMark val="out"/>
+        <c:minorTickMark val="none"/>
+        <c:tickLblPos val="nextTo"/>
+        <c:spPr>
+          <a:ln>
+            <a:solidFill>
+              <a:srgbClr val="B5B2AD"/>
+            </a:solidFill>
+          </a:ln>
+        </c:spPr>
+        <c:txPr>
+          <a:bodyPr/>
+          <a:lstStyle/>
+          <a:p>
+            <a:pPr>
+              <a:defRPr sz="1100">
+                <a:solidFill>
+                  <a:srgbClr val="4C5852"/>
+                </a:solidFill>
+                <a:latin typeface="Inter"/>
+              </a:defRPr>
+            </a:pPr>
+          </a:p>
+        </c:txPr>
+        <c:crossAx val="-2113994440"/>
+        <c:crosses val="autoZero"/>
+        <c:auto val="1"/>
+        <c:lblAlgn val="ctr"/>
+        <c:lblOffset val="100"/>
+        <c:noMultiLvlLbl val="0"/>
+      </c:catAx>
+      <c:valAx>
+        <c:axId val="-2113994440"/>
+        <c:scaling>
+          <c:max val="9000.0"/>
+          <c:min val="0.0"/>
+        </c:scaling>
+        <c:delete/>
+        <c:axPos val="l"/>
+        <c:majorTickMark val="out"/>
+        <c:minorTickMark val="none"/>
+        <c:tickLblPos val="nextTo"/>
+        <c:crossAx val="-2068027336"/>
+        <c:crosses val="autoZero"/>
+      </c:valAx>
+    </c:plotArea>
+    <c:legend>
+      <c:legendPos val="t"/>
+      <c:overlay val="0"/>
+      <c:txPr>
+        <a:bodyPr/>
+        <a:lstStyle/>
+        <a:p>
+          <a:pPr>
+            <a:defRPr sz="1200">
+              <a:solidFill>
+                <a:srgbClr val="4C5852"/>
+              </a:solidFill>
+              <a:latin typeface="Inter"/>
+            </a:defRPr>
+          </a:pPr>
+        </a:p>
+      </c:txPr>
+    </c:legend>
     <c:dispBlanksAs val="gap"/>
   </c:chart>
   <c:txPr>
@@ -3921,7 +4402,7 @@
                 <a:ea typeface="Inter" pitchFamily="34" charset="-122"/>
                 <a:cs typeface="Inter" pitchFamily="34" charset="-120"/>
               </a:rPr>
-              <a:t>12 · DISSERTATSIYA TUZILISHI</a:t>
+              <a:t>13 · DISSERTATSIYA TUZILISHI</a:t>
             </a:r>
             <a:endParaRPr lang="en-US" sz="1200" dirty="0"/>
           </a:p>
@@ -4720,7 +5201,7 @@
                 <a:ea typeface="Inter" pitchFamily="34" charset="-122"/>
                 <a:cs typeface="Inter" pitchFamily="34" charset="-120"/>
               </a:rPr>
-              <a:t>13</a:t>
+              <a:t>14</a:t>
             </a:r>
             <a:endParaRPr lang="en-US" sz="1200" dirty="0"/>
           </a:p>
@@ -4796,7 +5277,7 @@
                 <a:ea typeface="Inter" pitchFamily="34" charset="-122"/>
                 <a:cs typeface="Inter" pitchFamily="34" charset="-120"/>
               </a:rPr>
-              <a:t>13 · DISSERTATSIYA TUZILISHI</a:t>
+              <a:t>14 · DISSERTATSIYA TUZILISHI</a:t>
             </a:r>
             <a:endParaRPr lang="en-US" sz="1200" dirty="0"/>
           </a:p>
@@ -5828,7 +6309,7 @@
                 <a:ea typeface="Inter" pitchFamily="34" charset="-122"/>
                 <a:cs typeface="Inter" pitchFamily="34" charset="-120"/>
               </a:rPr>
-              <a:t>14</a:t>
+              <a:t>15</a:t>
             </a:r>
             <a:endParaRPr lang="en-US" sz="1200" dirty="0"/>
           </a:p>
@@ -5904,7 +6385,7 @@
                 <a:ea typeface="Inter" pitchFamily="34" charset="-122"/>
                 <a:cs typeface="Inter" pitchFamily="34" charset="-120"/>
               </a:rPr>
-              <a:t>14 · DISSERTATSIYA TUZILISHI</a:t>
+              <a:t>15 · DISSERTATSIYA TUZILISHI</a:t>
             </a:r>
             <a:endParaRPr lang="en-US" sz="1200" dirty="0"/>
           </a:p>
@@ -6931,7 +7412,7 @@
                 <a:ea typeface="Inter" pitchFamily="34" charset="-122"/>
                 <a:cs typeface="Inter" pitchFamily="34" charset="-120"/>
               </a:rPr>
-              <a:t>15</a:t>
+              <a:t>16</a:t>
             </a:r>
             <a:endParaRPr lang="en-US" sz="1200" dirty="0"/>
           </a:p>
@@ -7007,7 +7488,7 @@
                 <a:ea typeface="Inter" pitchFamily="34" charset="-122"/>
                 <a:cs typeface="Inter" pitchFamily="34" charset="-120"/>
               </a:rPr>
-              <a:t>15 · NATIJALAR VA REJA</a:t>
+              <a:t>16 · NATIJALAR VA REJA</a:t>
             </a:r>
             <a:endParaRPr lang="en-US" sz="1200" dirty="0"/>
           </a:p>
@@ -7745,7 +8226,7 @@
                 <a:ea typeface="Inter" pitchFamily="34" charset="-122"/>
                 <a:cs typeface="Inter" pitchFamily="34" charset="-120"/>
               </a:rPr>
-              <a:t>16</a:t>
+              <a:t>17</a:t>
             </a:r>
             <a:endParaRPr lang="en-US" sz="1200" dirty="0"/>
           </a:p>
@@ -7821,7 +8302,7 @@
                 <a:ea typeface="Inter" pitchFamily="34" charset="-122"/>
                 <a:cs typeface="Inter" pitchFamily="34" charset="-120"/>
               </a:rPr>
-              <a:t>16 · NATIJALAR VA REJA</a:t>
+              <a:t>17 · NATIJALAR VA REJA</a:t>
             </a:r>
             <a:endParaRPr lang="en-US" sz="1200" dirty="0"/>
           </a:p>
@@ -8847,7 +9328,7 @@
                 <a:ea typeface="Inter" pitchFamily="34" charset="-122"/>
                 <a:cs typeface="Inter" pitchFamily="34" charset="-120"/>
               </a:rPr>
-              <a:t>17</a:t>
+              <a:t>18</a:t>
             </a:r>
             <a:endParaRPr lang="en-US" sz="1200" dirty="0"/>
           </a:p>
@@ -8923,7 +9404,7 @@
                 <a:ea typeface="Inter" pitchFamily="34" charset="-122"/>
                 <a:cs typeface="Inter" pitchFamily="34" charset="-120"/>
               </a:rPr>
-              <a:t>17 · NATIJALAR VA REJA</a:t>
+              <a:t>18 · NATIJALAR VA REJA</a:t>
             </a:r>
             <a:endParaRPr lang="en-US" sz="1200" dirty="0"/>
           </a:p>
@@ -9535,7 +10016,7 @@
                 <a:ea typeface="Inter" pitchFamily="34" charset="-122"/>
                 <a:cs typeface="Inter" pitchFamily="34" charset="-120"/>
               </a:rPr>
-              <a:t>18</a:t>
+              <a:t>19</a:t>
             </a:r>
             <a:endParaRPr lang="en-US" sz="1200" dirty="0"/>
           </a:p>
@@ -12584,6 +13065,389 @@
               <a:t>02</a:t>
             </a:r>
             <a:endParaRPr lang="en-US" sz="1200" dirty="0"/>
+          </a:p>
+        </p:txBody>
+      </p:sp>
+    </p:spTree>
+  </p:cSld>
+  <p:clrMapOvr>
+    <a:masterClrMapping/>
+  </p:clrMapOvr>
+</p:sld>
+</file>
+
+<file path=ppt/slides/slide20.xml><?xml version="1.0" encoding="utf-8"?>
+<p:sld xmlns:a="http://schemas.openxmlformats.org/drawingml/2006/main" xmlns:p="http://schemas.openxmlformats.org/presentationml/2006/main" xmlns:r="http://schemas.openxmlformats.org/officeDocument/2006/relationships">
+  <p:cSld>
+    <p:bg>
+      <p:bgPr>
+        <a:solidFill>
+          <a:srgbClr val="F4F1EA"/>
+        </a:solidFill>
+      </p:bgPr>
+    </p:bg>
+    <p:spTree>
+      <p:nvGrpSpPr>
+        <p:cNvPr id="1" name=""/>
+        <p:cNvGrpSpPr/>
+        <p:nvPr/>
+      </p:nvGrpSpPr>
+      <p:grpSpPr/>
+      <p:sp>
+        <p:nvSpPr>
+          <p:cNvPr id="2" name="Text 0"/>
+          <p:cNvSpPr/>
+          <p:nvPr/>
+        </p:nvSpPr>
+        <p:spPr>
+          <a:xfrm>
+            <a:off x="812800" y="812800"/>
+            <a:ext cx="10883392" cy="238720"/>
+          </a:xfrm>
+          <a:prstGeom prst="rect">
+            <a:avLst/>
+          </a:prstGeom>
+          <a:noFill/>
+          <a:ln/>
+        </p:spPr>
+        <p:txBody>
+          <a:bodyPr wrap="square" lIns="0" tIns="0" rIns="0" bIns="0" rtlCol="0" anchor="t">
+            <a:normAutofit/>
+          </a:bodyPr>
+          <a:lstStyle/>
+          <a:p>
+            <a:pPr algn="l" indent="0" marL="0">
+              <a:lnSpc>
+                <a:spcPts val="1680"/>
+              </a:lnSpc>
+              <a:buNone/>
+            </a:pPr>
+            <a:r>
+              <a:rPr lang="en-US" sz="1200" b="1" spc="150" kern="0" dirty="0">
+                <a:solidFill>
+                  <a:srgbClr val="2C6A85"/>
+                </a:solidFill>
+                <a:latin typeface="Inter" pitchFamily="34" charset="0"/>
+                <a:ea typeface="Inter" pitchFamily="34" charset="-122"/>
+                <a:cs typeface="Inter" pitchFamily="34" charset="-120"/>
+              </a:rPr>
+              <a:t>12 · DASTLABKI MAʼLUMOTLAR</a:t>
+            </a:r>
+            <a:endParaRPr lang="en-US" sz="1200" dirty="0"/>
+          </a:p>
+        </p:txBody>
+      </p:sp>
+      <p:sp>
+        <p:nvSpPr>
+          <p:cNvPr id="3" name="Text 1"/>
+          <p:cNvSpPr/>
+          <p:nvPr>
+            <p:ph type="title"/>
+          </p:nvPr>
+        </p:nvSpPr>
+        <p:spPr>
+          <a:xfrm>
+            <a:off x="812800" y="1127720"/>
+            <a:ext cx="10883392" cy="472430"/>
+          </a:xfrm>
+          <a:prstGeom prst="rect">
+            <a:avLst/>
+          </a:prstGeom>
+          <a:noFill/>
+          <a:ln/>
+        </p:spPr>
+        <p:txBody>
+          <a:bodyPr wrap="square" lIns="0" tIns="0" rIns="0" bIns="0" rtlCol="0" anchor="t">
+            <a:normAutofit/>
+          </a:bodyPr>
+          <a:lstStyle/>
+          <a:p>
+            <a:pPr algn="l" indent="0" marL="0">
+              <a:lnSpc>
+                <a:spcPts val="3520"/>
+              </a:lnSpc>
+              <a:buNone/>
+            </a:pPr>
+            <a:r>
+              <a:rPr lang="en-US" sz="3200" b="0" i="0" dirty="0">
+                <a:solidFill>
+                  <a:srgbClr val="1D2A24"/>
+                </a:solidFill>
+                <a:latin typeface="Source Serif 4" pitchFamily="18" charset="0"/>
+                <a:ea typeface="Source Serif 4" pitchFamily="18" charset="-122"/>
+                <a:cs typeface="Source Serif 4" pitchFamily="18" charset="-120"/>
+              </a:rPr>
+              <a:t>Paxta maydonining oʻzgarishi</a:t>
+            </a:r>
+            <a:endParaRPr lang="en-US" sz="3200" dirty="0"/>
+          </a:p>
+        </p:txBody>
+      </p:sp>
+      <p:sp>
+        <p:nvSpPr>
+          <p:cNvPr id="6" name="Text 3"/>
+          <p:cNvSpPr/>
+          <p:nvPr/>
+        </p:nvSpPr>
+        <p:spPr>
+          <a:xfrm>
+            <a:off x="11137950" y="6238280"/>
+            <a:ext cx="241250" cy="238720"/>
+          </a:xfrm>
+          <a:prstGeom prst="rect">
+            <a:avLst/>
+          </a:prstGeom>
+          <a:noFill/>
+          <a:ln/>
+        </p:spPr>
+        <p:txBody>
+          <a:bodyPr wrap="square" lIns="0" tIns="0" rIns="0" bIns="0" rtlCol="0" anchor="t">
+            <a:normAutofit/>
+          </a:bodyPr>
+          <a:lstStyle/>
+          <a:p>
+            <a:pPr algn="r" indent="0" marL="0">
+              <a:lnSpc>
+                <a:spcPts val="1680"/>
+              </a:lnSpc>
+              <a:buNone/>
+            </a:pPr>
+            <a:r>
+              <a:rPr lang="en-US" sz="1200" dirty="0">
+                <a:solidFill>
+                  <a:srgbClr val="5F6B64"/>
+                </a:solidFill>
+                <a:latin typeface="Inter" pitchFamily="34" charset="0"/>
+                <a:ea typeface="Inter" pitchFamily="34" charset="-122"/>
+                <a:cs typeface="Inter" pitchFamily="34" charset="-120"/>
+              </a:rPr>
+              <a:t>13</a:t>
+            </a:r>
+            <a:endParaRPr lang="en-US" sz="1200" dirty="0"/>
+          </a:p>
+        </p:txBody>
+      </p:sp>
+      <p:sp>
+        <p:nvSpPr>
+          <p:cNvPr id="7" name="TextBox 6"/>
+          <p:cNvSpPr txBox="1"/>
+          <p:nvPr/>
+        </p:nvSpPr>
+        <p:spPr>
+          <a:xfrm>
+            <a:off x="812800" y="1830000"/>
+            <a:ext cx="6000000" cy="260000"/>
+          </a:xfrm>
+          <a:prstGeom prst="rect">
+            <a:avLst/>
+          </a:prstGeom>
+          <a:noFill/>
+        </p:spPr>
+        <p:txBody>
+          <a:bodyPr wrap="square" lIns="0" rIns="0" tIns="0" bIns="0" anchor="t">
+            <a:spAutoFit/>
+          </a:bodyPr>
+          <a:lstStyle/>
+          <a:p>
+            <a:pPr algn="l"/>
+            <a:r>
+              <a:rPr sz="1300" b="1">
+                <a:solidFill>
+                  <a:srgbClr val="2C6A85"/>
+                </a:solidFill>
+                <a:latin typeface="Inter"/>
+              </a:rPr>
+              <a:t>Paxta ekin maydoni, ming ga (viloyat), 2015–2025</a:t>
+            </a:r>
+          </a:p>
+        </p:txBody>
+      </p:sp>
+      <p:graphicFrame>
+        <p:nvGraphicFramePr>
+          <p:cNvPr id="8" name="Chart 7"/>
+          <p:cNvGraphicFramePr>
+            <a:graphicFrameLocks noGrp="1"/>
+          </p:cNvGraphicFramePr>
+          <p:nvPr/>
+        </p:nvGraphicFramePr>
+        <p:xfrm>
+          <a:off x="752800" y="2130000"/>
+          <a:ext cx="6000000" cy="2950000"/>
+        </p:xfrm>
+        <a:graphic>
+          <a:graphicData uri="http://schemas.openxmlformats.org/drawingml/2006/chart">
+            <c:chart xmlns:c="http://schemas.openxmlformats.org/drawingml/2006/chart" r:id="rId2"/>
+          </a:graphicData>
+        </a:graphic>
+      </p:graphicFrame>
+      <p:sp>
+        <p:nvSpPr>
+          <p:cNvPr id="9" name="TextBox 8"/>
+          <p:cNvSpPr txBox="1"/>
+          <p:nvPr/>
+        </p:nvSpPr>
+        <p:spPr>
+          <a:xfrm>
+            <a:off x="7196192" y="1830000"/>
+            <a:ext cx="4500000" cy="260000"/>
+          </a:xfrm>
+          <a:prstGeom prst="rect">
+            <a:avLst/>
+          </a:prstGeom>
+          <a:noFill/>
+        </p:spPr>
+        <p:txBody>
+          <a:bodyPr wrap="square" lIns="0" rIns="0" tIns="0" bIns="0" anchor="t">
+            <a:spAutoFit/>
+          </a:bodyPr>
+          <a:lstStyle/>
+          <a:p>
+            <a:pPr algn="l"/>
+            <a:r>
+              <a:rPr sz="1300" b="1">
+                <a:solidFill>
+                  <a:srgbClr val="2C6A85"/>
+                </a:solidFill>
+                <a:latin typeface="Inter"/>
+              </a:rPr>
+              <a:t>Gʻoʻza maydoni, ga: 2024 va 2026 reja</a:t>
+            </a:r>
+          </a:p>
+        </p:txBody>
+      </p:sp>
+      <p:graphicFrame>
+        <p:nvGraphicFramePr>
+          <p:cNvPr id="10" name="Chart 9"/>
+          <p:cNvGraphicFramePr>
+            <a:graphicFrameLocks noGrp="1"/>
+          </p:cNvGraphicFramePr>
+          <p:nvPr/>
+        </p:nvGraphicFramePr>
+        <p:xfrm>
+          <a:off x="7136192" y="2130000"/>
+          <a:ext cx="4500000" cy="2950000"/>
+        </p:xfrm>
+        <a:graphic>
+          <a:graphicData uri="http://schemas.openxmlformats.org/drawingml/2006/chart">
+            <c:chart xmlns:c="http://schemas.openxmlformats.org/drawingml/2006/chart" r:id="rId3"/>
+          </a:graphicData>
+        </a:graphic>
+      </p:graphicFrame>
+      <p:sp>
+        <p:nvSpPr>
+          <p:cNvPr id="11" name="Rounded Rectangle 10"/>
+          <p:cNvSpPr/>
+          <p:nvPr/>
+        </p:nvSpPr>
+        <p:spPr>
+          <a:xfrm>
+            <a:off x="812800" y="5260000"/>
+            <a:ext cx="10883392" cy="800000"/>
+          </a:xfrm>
+          <a:prstGeom prst="roundRect">
+            <a:avLst>
+              <a:gd name="adj" fmla="val 5000"/>
+            </a:avLst>
+          </a:prstGeom>
+          <a:solidFill>
+            <a:srgbClr val="FBF9F4"/>
+          </a:solidFill>
+          <a:ln w="6350">
+            <a:solidFill>
+              <a:srgbClr val="D9D2C3"/>
+            </a:solidFill>
+          </a:ln>
+          <a:effectLst/>
+        </p:spPr>
+        <p:style>
+          <a:lnRef idx="1">
+            <a:schemeClr val="accent1"/>
+          </a:lnRef>
+          <a:fillRef idx="3">
+            <a:schemeClr val="accent1"/>
+          </a:fillRef>
+          <a:effectRef idx="2">
+            <a:schemeClr val="accent1"/>
+          </a:effectRef>
+          <a:fontRef idx="minor">
+            <a:schemeClr val="lt1"/>
+          </a:fontRef>
+        </p:style>
+        <p:txBody>
+          <a:bodyPr rtlCol="0" anchor="ctr"/>
+          <a:lstStyle/>
+          <a:p>
+            <a:pPr algn="ctr"/>
+          </a:p>
+        </p:txBody>
+      </p:sp>
+      <p:sp>
+        <p:nvSpPr>
+          <p:cNvPr id="12" name="TextBox 11"/>
+          <p:cNvSpPr txBox="1"/>
+          <p:nvPr/>
+        </p:nvSpPr>
+        <p:spPr>
+          <a:xfrm>
+            <a:off x="1042800" y="5260000"/>
+            <a:ext cx="10423392" cy="800000"/>
+          </a:xfrm>
+          <a:prstGeom prst="rect">
+            <a:avLst/>
+          </a:prstGeom>
+          <a:noFill/>
+        </p:spPr>
+        <p:txBody>
+          <a:bodyPr wrap="square" lIns="0" rIns="0" tIns="0" bIns="0" anchor="ctr">
+            <a:spAutoFit/>
+          </a:bodyPr>
+          <a:lstStyle/>
+          <a:p>
+            <a:pPr algn="l"/>
+            <a:r>
+              <a:rPr sz="1200" b="0">
+                <a:solidFill>
+                  <a:srgbClr val="4C5852"/>
+                </a:solidFill>
+                <a:latin typeface="Inter"/>
+              </a:rPr>
+              <a:t>Viloyatda paxta maydoni 10 yilda 93,4 dan 60,0 ming gagacha (−36%) qisqardi; tuman rejalarida 2026 yil uchun ham pasayish davom etadi: Jalaquduq −24%, Paxtaobod −16%, Shahrixon va Qoʻrgʻontepa −11%. Boʻshagan yerlardagi meliorativ holat 3.3-boʻlimda tahlil qilinadi.</a:t>
+            </a:r>
+          </a:p>
+        </p:txBody>
+      </p:sp>
+      <p:sp>
+        <p:nvSpPr>
+          <p:cNvPr id="13" name="TextBox 12"/>
+          <p:cNvSpPr txBox="1"/>
+          <p:nvPr/>
+        </p:nvSpPr>
+        <p:spPr>
+          <a:xfrm>
+            <a:off x="812800" y="6238280"/>
+            <a:ext cx="9800000" cy="240000"/>
+          </a:xfrm>
+          <a:prstGeom prst="rect">
+            <a:avLst/>
+          </a:prstGeom>
+          <a:noFill/>
+        </p:spPr>
+        <p:txBody>
+          <a:bodyPr wrap="square" lIns="0" rIns="0" tIns="0" bIns="0" anchor="t">
+            <a:spAutoFit/>
+          </a:bodyPr>
+          <a:lstStyle/>
+          <a:p>
+            <a:pPr algn="l"/>
+            <a:r>
+              <a:rPr sz="1200" b="0">
+                <a:solidFill>
+                  <a:srgbClr val="5F6B64"/>
+                </a:solidFill>
+                <a:latin typeface="Inter"/>
+              </a:rPr>
+              <a:t>Manba: viloyat paxta hisobotlari (reja va amaldagi maydon aralash); tumanlar ekin joylashtirish rejalari</a:t>
+            </a:r>
           </a:p>
         </p:txBody>
       </p:sp>

</xml_diff>

<commit_message>
Add crop structure and Ulugnor contour bonitet slides
Co-Authored-By: Claude Sonnet 5.5 <noreply@anthropic.com>
Claude-Session: https://claude.ai/code/session_01M4MZatV28utL9zTp7saaUz
</commit_message>
<xml_diff>
--- a/Garbiy_Farg_ona_tuproqlari_GAT_asosida_bashoratlash.pptx
+++ b/Garbiy_Farg_ona_tuproqlari_GAT_asosida_bashoratlash.pptx
@@ -18,6 +18,8 @@
     <p:sldId id="273" r:id="rId24"/>
     <p:sldId id="274" r:id="rId25"/>
     <p:sldId id="275" r:id="rId26"/>
+    <p:sldId id="276" r:id="rId27"/>
+    <p:sldId id="277" r:id="rId28"/>
     <p:sldId id="265" r:id="rId11"/>
     <p:sldId id="266" r:id="rId12"/>
     <p:sldId id="267" r:id="rId13"/>
@@ -1457,6 +1459,402 @@
         </a:p>
       </c:txPr>
     </c:legend>
+    <c:dispBlanksAs val="gap"/>
+  </c:chart>
+  <c:txPr>
+    <a:bodyPr/>
+    <a:lstStyle/>
+    <a:p>
+      <a:pPr>
+        <a:defRPr sz="1200">
+          <a:solidFill>
+            <a:srgbClr val="4C5852"/>
+          </a:solidFill>
+          <a:latin typeface="Inter"/>
+        </a:defRPr>
+      </a:pPr>
+      <a:endParaRPr lang="en-US"/>
+    </a:p>
+  </c:txPr>
+  <c:externalData r:id="rId1">
+    <c:autoUpdate val="0"/>
+  </c:externalData>
+</c:chartSpace>
+</file>
+
+<file path=ppt/charts/chart7.xml><?xml version="1.0" encoding="utf-8"?>
+<c:chartSpace xmlns:c="http://schemas.openxmlformats.org/drawingml/2006/chart" xmlns:a="http://schemas.openxmlformats.org/drawingml/2006/main" xmlns:r="http://schemas.openxmlformats.org/officeDocument/2006/relationships">
+  <c:date1904 val="0"/>
+  <c:chart>
+    <c:autoTitleDeleted val="1"/>
+    <c:plotArea>
+      <c:barChart>
+        <c:barDir val="bar"/>
+        <c:grouping val="clustered"/>
+        <c:ser>
+          <c:idx val="0"/>
+          <c:order val="0"/>
+          <c:tx>
+            <c:strRef>
+              <c:f>Sheet1!$B$1</c:f>
+              <c:strCache>
+                <c:ptCount val="1"/>
+                <c:pt idx="0">
+                  <c:v>Maydon</c:v>
+                </c:pt>
+              </c:strCache>
+            </c:strRef>
+          </c:tx>
+          <c:spPr>
+            <a:solidFill>
+              <a:srgbClr val="2C6A85"/>
+            </a:solidFill>
+          </c:spPr>
+          <c:dPt>
+            <c:idx val="0"/>
+            <c:spPr>
+              <a:solidFill>
+                <a:srgbClr val="A4521D"/>
+              </a:solidFill>
+            </c:spPr>
+          </c:dPt>
+          <c:cat>
+            <c:strRef>
+              <c:f>Sheet1!$A$2:$A$11</c:f>
+              <c:strCache>
+                <c:ptCount val="10"/>
+                <c:pt idx="0">
+                  <c:v>Texnik (gʻoʻza)</c:v>
+                </c:pt>
+                <c:pt idx="1">
+                  <c:v>Bugʻdoy va boshqa donli</c:v>
+                </c:pt>
+                <c:pt idx="2">
+                  <c:v>Sabzavot</c:v>
+                </c:pt>
+                <c:pt idx="3">
+                  <c:v>Ozuqa (em-xashak)</c:v>
+                </c:pt>
+                <c:pt idx="4">
+                  <c:v>Kartoshka</c:v>
+                </c:pt>
+                <c:pt idx="5">
+                  <c:v>Moyli ekinlar</c:v>
+                </c:pt>
+                <c:pt idx="6">
+                  <c:v>Dukkakli donli</c:v>
+                </c:pt>
+                <c:pt idx="7">
+                  <c:v>Sholi</c:v>
+                </c:pt>
+                <c:pt idx="8">
+                  <c:v>Poliz</c:v>
+                </c:pt>
+                <c:pt idx="9">
+                  <c:v>Boshqalar</c:v>
+                </c:pt>
+              </c:strCache>
+            </c:strRef>
+          </c:cat>
+          <c:val>
+            <c:numRef>
+              <c:f>Sheet1!$B$2:$B$11</c:f>
+              <c:numCache>
+                <c:formatCode>General</c:formatCode>
+                <c:ptCount val="10"/>
+                <c:pt idx="0">
+                  <c:v>71.3</c:v>
+                </c:pt>
+                <c:pt idx="1">
+                  <c:v>70.2</c:v>
+                </c:pt>
+                <c:pt idx="2">
+                  <c:v>45.5</c:v>
+                </c:pt>
+                <c:pt idx="3">
+                  <c:v>35.8</c:v>
+                </c:pt>
+                <c:pt idx="4">
+                  <c:v>14.6</c:v>
+                </c:pt>
+                <c:pt idx="5">
+                  <c:v>14.3</c:v>
+                </c:pt>
+                <c:pt idx="6">
+                  <c:v>13.5</c:v>
+                </c:pt>
+                <c:pt idx="7">
+                  <c:v>10.9</c:v>
+                </c:pt>
+                <c:pt idx="8">
+                  <c:v>3.1</c:v>
+                </c:pt>
+                <c:pt idx="9">
+                  <c:v>2.3</c:v>
+                </c:pt>
+              </c:numCache>
+            </c:numRef>
+          </c:val>
+        </c:ser>
+        <c:dLbls>
+          <c:numFmt formatCode="0.0" sourceLinked="0"/>
+          <c:txPr>
+            <a:bodyPr/>
+            <a:lstStyle/>
+            <a:p>
+              <a:pPr>
+                <a:defRPr sz="1200">
+                  <a:solidFill>
+                    <a:srgbClr val="1D2A24"/>
+                  </a:solidFill>
+                  <a:latin typeface="Inter"/>
+                </a:defRPr>
+              </a:pPr>
+            </a:p>
+          </c:txPr>
+          <c:dLblPos val="outEnd"/>
+          <c:showLegendKey val="0"/>
+          <c:showVal val="1"/>
+          <c:showCatName val="0"/>
+          <c:showSerName val="0"/>
+          <c:showPercent val="0"/>
+          <c:showBubbleSize val="0"/>
+          <c:showLeaderLines val="1"/>
+        </c:dLbls>
+        <c:gapWidth val="35"/>
+        <c:axId val="-2068027336"/>
+        <c:axId val="-2113994440"/>
+      </c:barChart>
+      <c:catAx>
+        <c:axId val="-2068027336"/>
+        <c:scaling>
+          <c:orientation val="maxMin"/>
+        </c:scaling>
+        <c:delete val="0"/>
+        <c:axPos val="l"/>
+        <c:majorTickMark val="out"/>
+        <c:minorTickMark val="none"/>
+        <c:tickLblPos val="nextTo"/>
+        <c:spPr>
+          <a:ln>
+            <a:solidFill>
+              <a:srgbClr val="B5B2AD"/>
+            </a:solidFill>
+          </a:ln>
+        </c:spPr>
+        <c:txPr>
+          <a:bodyPr/>
+          <a:lstStyle/>
+          <a:p>
+            <a:pPr>
+              <a:defRPr sz="1200">
+                <a:solidFill>
+                  <a:srgbClr val="4C5852"/>
+                </a:solidFill>
+                <a:latin typeface="Inter"/>
+              </a:defRPr>
+            </a:pPr>
+          </a:p>
+        </c:txPr>
+        <c:crossAx val="-2113994440"/>
+        <c:crosses val="autoZero"/>
+        <c:auto val="1"/>
+        <c:lblAlgn val="ctr"/>
+        <c:lblOffset val="100"/>
+        <c:noMultiLvlLbl val="0"/>
+      </c:catAx>
+      <c:valAx>
+        <c:axId val="-2113994440"/>
+        <c:scaling>
+          <c:max val="85.0"/>
+          <c:min val="0.0"/>
+        </c:scaling>
+        <c:delete/>
+        <c:axPos val="b"/>
+        <c:majorTickMark val="out"/>
+        <c:minorTickMark val="none"/>
+        <c:tickLblPos val="nextTo"/>
+        <c:crossAx val="-2068027336"/>
+        <c:crosses val="autoZero"/>
+      </c:valAx>
+    </c:plotArea>
+    <c:dispBlanksAs val="gap"/>
+  </c:chart>
+  <c:txPr>
+    <a:bodyPr/>
+    <a:lstStyle/>
+    <a:p>
+      <a:pPr>
+        <a:defRPr sz="1200">
+          <a:solidFill>
+            <a:srgbClr val="4C5852"/>
+          </a:solidFill>
+          <a:latin typeface="Inter"/>
+        </a:defRPr>
+      </a:pPr>
+      <a:endParaRPr lang="en-US"/>
+    </a:p>
+  </c:txPr>
+  <c:externalData r:id="rId1">
+    <c:autoUpdate val="0"/>
+  </c:externalData>
+</c:chartSpace>
+</file>
+
+<file path=ppt/charts/chart8.xml><?xml version="1.0" encoding="utf-8"?>
+<c:chartSpace xmlns:c="http://schemas.openxmlformats.org/drawingml/2006/chart" xmlns:a="http://schemas.openxmlformats.org/drawingml/2006/main" xmlns:r="http://schemas.openxmlformats.org/officeDocument/2006/relationships">
+  <c:date1904 val="0"/>
+  <c:chart>
+    <c:autoTitleDeleted val="1"/>
+    <c:plotArea>
+      <c:barChart>
+        <c:barDir val="col"/>
+        <c:grouping val="clustered"/>
+        <c:ser>
+          <c:idx val="0"/>
+          <c:order val="0"/>
+          <c:tx>
+            <c:strRef>
+              <c:f>Sheet1!$B$1</c:f>
+              <c:strCache>
+                <c:ptCount val="1"/>
+                <c:pt idx="0">
+                  <c:v>Maydon</c:v>
+                </c:pt>
+              </c:strCache>
+            </c:strRef>
+          </c:tx>
+          <c:spPr>
+            <a:solidFill>
+              <a:srgbClr val="2C6A85"/>
+            </a:solidFill>
+          </c:spPr>
+          <c:dPt>
+            <c:idx val="0"/>
+            <c:spPr>
+              <a:solidFill>
+                <a:srgbClr val="A4521D"/>
+              </a:solidFill>
+            </c:spPr>
+          </c:dPt>
+          <c:cat>
+            <c:strRef>
+              <c:f>Sheet1!$A$2:$A$4</c:f>
+              <c:strCache>
+                <c:ptCount val="3"/>
+                <c:pt idx="0">
+                  <c:v>Past (≤40 ball)</c:v>
+                </c:pt>
+                <c:pt idx="1">
+                  <c:v>Oʻrta (41–60)</c:v>
+                </c:pt>
+                <c:pt idx="2">
+                  <c:v>Yuqori (&gt;60)</c:v>
+                </c:pt>
+              </c:strCache>
+            </c:strRef>
+          </c:cat>
+          <c:val>
+            <c:numRef>
+              <c:f>Sheet1!$B$2:$B$4</c:f>
+              <c:numCache>
+                <c:formatCode>General</c:formatCode>
+                <c:ptCount val="3"/>
+                <c:pt idx="0">
+                  <c:v>5811</c:v>
+                </c:pt>
+                <c:pt idx="1">
+                  <c:v>12771</c:v>
+                </c:pt>
+                <c:pt idx="2">
+                  <c:v>2425</c:v>
+                </c:pt>
+              </c:numCache>
+            </c:numRef>
+          </c:val>
+        </c:ser>
+        <c:dLbls>
+          <c:numFmt formatCode="#,##0" sourceLinked="0"/>
+          <c:txPr>
+            <a:bodyPr/>
+            <a:lstStyle/>
+            <a:p>
+              <a:pPr>
+                <a:defRPr sz="1200">
+                  <a:solidFill>
+                    <a:srgbClr val="1D2A24"/>
+                  </a:solidFill>
+                  <a:latin typeface="Inter"/>
+                </a:defRPr>
+              </a:pPr>
+            </a:p>
+          </c:txPr>
+          <c:dLblPos val="outEnd"/>
+          <c:showLegendKey val="0"/>
+          <c:showVal val="1"/>
+          <c:showCatName val="0"/>
+          <c:showSerName val="0"/>
+          <c:showPercent val="0"/>
+          <c:showBubbleSize val="0"/>
+          <c:showLeaderLines val="1"/>
+        </c:dLbls>
+        <c:gapWidth val="45"/>
+        <c:axId val="-2068027336"/>
+        <c:axId val="-2113994440"/>
+      </c:barChart>
+      <c:catAx>
+        <c:axId val="-2068027336"/>
+        <c:scaling>
+          <c:orientation val="minMax"/>
+        </c:scaling>
+        <c:delete val="0"/>
+        <c:axPos val="b"/>
+        <c:majorTickMark val="out"/>
+        <c:minorTickMark val="none"/>
+        <c:tickLblPos val="nextTo"/>
+        <c:spPr>
+          <a:ln>
+            <a:solidFill>
+              <a:srgbClr val="B5B2AD"/>
+            </a:solidFill>
+          </a:ln>
+        </c:spPr>
+        <c:txPr>
+          <a:bodyPr/>
+          <a:lstStyle/>
+          <a:p>
+            <a:pPr>
+              <a:defRPr sz="1200">
+                <a:solidFill>
+                  <a:srgbClr val="4C5852"/>
+                </a:solidFill>
+                <a:latin typeface="Inter"/>
+              </a:defRPr>
+            </a:pPr>
+          </a:p>
+        </c:txPr>
+        <c:crossAx val="-2113994440"/>
+        <c:crosses val="autoZero"/>
+        <c:auto val="1"/>
+        <c:lblAlgn val="ctr"/>
+        <c:lblOffset val="100"/>
+        <c:noMultiLvlLbl val="0"/>
+      </c:catAx>
+      <c:valAx>
+        <c:axId val="-2113994440"/>
+        <c:scaling>
+          <c:max val="15500.0"/>
+          <c:min val="0.0"/>
+        </c:scaling>
+        <c:delete/>
+        <c:axPos val="l"/>
+        <c:majorTickMark val="out"/>
+        <c:minorTickMark val="none"/>
+        <c:tickLblPos val="nextTo"/>
+        <c:crossAx val="-2068027336"/>
+        <c:crosses val="autoZero"/>
+      </c:valAx>
+    </c:plotArea>
     <c:dispBlanksAs val="gap"/>
   </c:chart>
   <c:txPr>
@@ -4402,7 +4800,7 @@
                 <a:ea typeface="Inter" pitchFamily="34" charset="-122"/>
                 <a:cs typeface="Inter" pitchFamily="34" charset="-120"/>
               </a:rPr>
-              <a:t>13 · DISSERTATSIYA TUZILISHI</a:t>
+              <a:t>15 · DISSERTATSIYA TUZILISHI</a:t>
             </a:r>
             <a:endParaRPr lang="en-US" sz="1200" dirty="0"/>
           </a:p>
@@ -5201,7 +5599,7 @@
                 <a:ea typeface="Inter" pitchFamily="34" charset="-122"/>
                 <a:cs typeface="Inter" pitchFamily="34" charset="-120"/>
               </a:rPr>
-              <a:t>14</a:t>
+              <a:t>16</a:t>
             </a:r>
             <a:endParaRPr lang="en-US" sz="1200" dirty="0"/>
           </a:p>
@@ -5277,7 +5675,7 @@
                 <a:ea typeface="Inter" pitchFamily="34" charset="-122"/>
                 <a:cs typeface="Inter" pitchFamily="34" charset="-120"/>
               </a:rPr>
-              <a:t>14 · DISSERTATSIYA TUZILISHI</a:t>
+              <a:t>16 · DISSERTATSIYA TUZILISHI</a:t>
             </a:r>
             <a:endParaRPr lang="en-US" sz="1200" dirty="0"/>
           </a:p>
@@ -6309,7 +6707,7 @@
                 <a:ea typeface="Inter" pitchFamily="34" charset="-122"/>
                 <a:cs typeface="Inter" pitchFamily="34" charset="-120"/>
               </a:rPr>
-              <a:t>15</a:t>
+              <a:t>17</a:t>
             </a:r>
             <a:endParaRPr lang="en-US" sz="1200" dirty="0"/>
           </a:p>
@@ -6385,7 +6783,7 @@
                 <a:ea typeface="Inter" pitchFamily="34" charset="-122"/>
                 <a:cs typeface="Inter" pitchFamily="34" charset="-120"/>
               </a:rPr>
-              <a:t>15 · DISSERTATSIYA TUZILISHI</a:t>
+              <a:t>17 · DISSERTATSIYA TUZILISHI</a:t>
             </a:r>
             <a:endParaRPr lang="en-US" sz="1200" dirty="0"/>
           </a:p>
@@ -7412,7 +7810,7 @@
                 <a:ea typeface="Inter" pitchFamily="34" charset="-122"/>
                 <a:cs typeface="Inter" pitchFamily="34" charset="-120"/>
               </a:rPr>
-              <a:t>16</a:t>
+              <a:t>18</a:t>
             </a:r>
             <a:endParaRPr lang="en-US" sz="1200" dirty="0"/>
           </a:p>
@@ -7488,7 +7886,7 @@
                 <a:ea typeface="Inter" pitchFamily="34" charset="-122"/>
                 <a:cs typeface="Inter" pitchFamily="34" charset="-120"/>
               </a:rPr>
-              <a:t>16 · NATIJALAR VA REJA</a:t>
+              <a:t>18 · NATIJALAR VA REJA</a:t>
             </a:r>
             <a:endParaRPr lang="en-US" sz="1200" dirty="0"/>
           </a:p>
@@ -8226,7 +8624,7 @@
                 <a:ea typeface="Inter" pitchFamily="34" charset="-122"/>
                 <a:cs typeface="Inter" pitchFamily="34" charset="-120"/>
               </a:rPr>
-              <a:t>17</a:t>
+              <a:t>19</a:t>
             </a:r>
             <a:endParaRPr lang="en-US" sz="1200" dirty="0"/>
           </a:p>
@@ -8302,7 +8700,7 @@
                 <a:ea typeface="Inter" pitchFamily="34" charset="-122"/>
                 <a:cs typeface="Inter" pitchFamily="34" charset="-120"/>
               </a:rPr>
-              <a:t>17 · NATIJALAR VA REJA</a:t>
+              <a:t>19 · NATIJALAR VA REJA</a:t>
             </a:r>
             <a:endParaRPr lang="en-US" sz="1200" dirty="0"/>
           </a:p>
@@ -9328,7 +9726,7 @@
                 <a:ea typeface="Inter" pitchFamily="34" charset="-122"/>
                 <a:cs typeface="Inter" pitchFamily="34" charset="-120"/>
               </a:rPr>
-              <a:t>18</a:t>
+              <a:t>20</a:t>
             </a:r>
             <a:endParaRPr lang="en-US" sz="1200" dirty="0"/>
           </a:p>
@@ -9404,7 +9802,7 @@
                 <a:ea typeface="Inter" pitchFamily="34" charset="-122"/>
                 <a:cs typeface="Inter" pitchFamily="34" charset="-120"/>
               </a:rPr>
-              <a:t>18 · NATIJALAR VA REJA</a:t>
+              <a:t>20 · NATIJALAR VA REJA</a:t>
             </a:r>
             <a:endParaRPr lang="en-US" sz="1200" dirty="0"/>
           </a:p>
@@ -10016,7 +10414,7 @@
                 <a:ea typeface="Inter" pitchFamily="34" charset="-122"/>
                 <a:cs typeface="Inter" pitchFamily="34" charset="-120"/>
               </a:rPr>
-              <a:t>19</a:t>
+              <a:t>21</a:t>
             </a:r>
             <a:endParaRPr lang="en-US" sz="1200" dirty="0"/>
           </a:p>
@@ -13447,6 +13845,1243 @@
                 <a:latin typeface="Inter"/>
               </a:rPr>
               <a:t>Manba: viloyat paxta hisobotlari (reja va amaldagi maydon aralash); tumanlar ekin joylashtirish rejalari</a:t>
+            </a:r>
+          </a:p>
+        </p:txBody>
+      </p:sp>
+    </p:spTree>
+  </p:cSld>
+  <p:clrMapOvr>
+    <a:masterClrMapping/>
+  </p:clrMapOvr>
+</p:sld>
+</file>
+
+<file path=ppt/slides/slide21.xml><?xml version="1.0" encoding="utf-8"?>
+<p:sld xmlns:a="http://schemas.openxmlformats.org/drawingml/2006/main" xmlns:p="http://schemas.openxmlformats.org/presentationml/2006/main" xmlns:r="http://schemas.openxmlformats.org/officeDocument/2006/relationships">
+  <p:cSld>
+    <p:bg>
+      <p:bgPr>
+        <a:solidFill>
+          <a:srgbClr val="F4F1EA"/>
+        </a:solidFill>
+      </p:bgPr>
+    </p:bg>
+    <p:spTree>
+      <p:nvGrpSpPr>
+        <p:cNvPr id="1" name=""/>
+        <p:cNvGrpSpPr/>
+        <p:nvPr/>
+      </p:nvGrpSpPr>
+      <p:grpSpPr/>
+      <p:sp>
+        <p:nvSpPr>
+          <p:cNvPr id="2" name="Text 0"/>
+          <p:cNvSpPr/>
+          <p:nvPr/>
+        </p:nvSpPr>
+        <p:spPr>
+          <a:xfrm>
+            <a:off x="812800" y="812800"/>
+            <a:ext cx="10883392" cy="238720"/>
+          </a:xfrm>
+          <a:prstGeom prst="rect">
+            <a:avLst/>
+          </a:prstGeom>
+          <a:noFill/>
+          <a:ln/>
+        </p:spPr>
+        <p:txBody>
+          <a:bodyPr wrap="square" lIns="0" tIns="0" rIns="0" bIns="0" rtlCol="0" anchor="t">
+            <a:normAutofit/>
+          </a:bodyPr>
+          <a:lstStyle/>
+          <a:p>
+            <a:pPr algn="l" indent="0" marL="0">
+              <a:lnSpc>
+                <a:spcPts val="1680"/>
+              </a:lnSpc>
+              <a:buNone/>
+            </a:pPr>
+            <a:r>
+              <a:rPr lang="en-US" sz="1200" b="1" spc="150" kern="0" dirty="0">
+                <a:solidFill>
+                  <a:srgbClr val="2C6A85"/>
+                </a:solidFill>
+                <a:latin typeface="Inter" pitchFamily="34" charset="0"/>
+                <a:ea typeface="Inter" pitchFamily="34" charset="-122"/>
+                <a:cs typeface="Inter" pitchFamily="34" charset="-120"/>
+              </a:rPr>
+              <a:t>13 · DASTLABKI MAʼLUMOTLAR</a:t>
+            </a:r>
+            <a:endParaRPr lang="en-US" sz="1200" dirty="0"/>
+          </a:p>
+        </p:txBody>
+      </p:sp>
+      <p:sp>
+        <p:nvSpPr>
+          <p:cNvPr id="3" name="Text 1"/>
+          <p:cNvSpPr/>
+          <p:nvPr>
+            <p:ph type="title"/>
+          </p:nvPr>
+        </p:nvSpPr>
+        <p:spPr>
+          <a:xfrm>
+            <a:off x="812800" y="1127720"/>
+            <a:ext cx="10883392" cy="472430"/>
+          </a:xfrm>
+          <a:prstGeom prst="rect">
+            <a:avLst/>
+          </a:prstGeom>
+          <a:noFill/>
+          <a:ln/>
+        </p:spPr>
+        <p:txBody>
+          <a:bodyPr wrap="square" lIns="0" tIns="0" rIns="0" bIns="0" rtlCol="0" anchor="t">
+            <a:normAutofit/>
+          </a:bodyPr>
+          <a:lstStyle/>
+          <a:p>
+            <a:pPr algn="l" indent="0" marL="0">
+              <a:lnSpc>
+                <a:spcPts val="3520"/>
+              </a:lnSpc>
+              <a:buNone/>
+            </a:pPr>
+            <a:r>
+              <a:rPr lang="en-US" sz="3200" b="0" i="0" dirty="0">
+                <a:solidFill>
+                  <a:srgbClr val="1D2A24"/>
+                </a:solidFill>
+                <a:latin typeface="Source Serif 4" pitchFamily="18" charset="0"/>
+                <a:ea typeface="Source Serif 4" pitchFamily="18" charset="-122"/>
+                <a:cs typeface="Source Serif 4" pitchFamily="18" charset="-120"/>
+              </a:rPr>
+              <a:t>Ekin tarkibi: Andijon viloyati</a:t>
+            </a:r>
+            <a:endParaRPr lang="en-US" sz="3200" dirty="0"/>
+          </a:p>
+        </p:txBody>
+      </p:sp>
+      <p:sp>
+        <p:nvSpPr>
+          <p:cNvPr id="6" name="Text 3"/>
+          <p:cNvSpPr/>
+          <p:nvPr/>
+        </p:nvSpPr>
+        <p:spPr>
+          <a:xfrm>
+            <a:off x="11137950" y="6238280"/>
+            <a:ext cx="241250" cy="238720"/>
+          </a:xfrm>
+          <a:prstGeom prst="rect">
+            <a:avLst/>
+          </a:prstGeom>
+          <a:noFill/>
+          <a:ln/>
+        </p:spPr>
+        <p:txBody>
+          <a:bodyPr wrap="square" lIns="0" tIns="0" rIns="0" bIns="0" rtlCol="0" anchor="t">
+            <a:normAutofit/>
+          </a:bodyPr>
+          <a:lstStyle/>
+          <a:p>
+            <a:pPr algn="r" indent="0" marL="0">
+              <a:lnSpc>
+                <a:spcPts val="1680"/>
+              </a:lnSpc>
+              <a:buNone/>
+            </a:pPr>
+            <a:r>
+              <a:rPr lang="en-US" sz="1200" dirty="0">
+                <a:solidFill>
+                  <a:srgbClr val="5F6B64"/>
+                </a:solidFill>
+                <a:latin typeface="Inter" pitchFamily="34" charset="0"/>
+                <a:ea typeface="Inter" pitchFamily="34" charset="-122"/>
+                <a:cs typeface="Inter" pitchFamily="34" charset="-120"/>
+              </a:rPr>
+              <a:t>14</a:t>
+            </a:r>
+            <a:endParaRPr lang="en-US" sz="1200" dirty="0"/>
+          </a:p>
+        </p:txBody>
+      </p:sp>
+      <p:sp>
+        <p:nvSpPr>
+          <p:cNvPr id="7" name="TextBox 6"/>
+          <p:cNvSpPr txBox="1"/>
+          <p:nvPr/>
+        </p:nvSpPr>
+        <p:spPr>
+          <a:xfrm>
+            <a:off x="812800" y="1830000"/>
+            <a:ext cx="6200000" cy="260000"/>
+          </a:xfrm>
+          <a:prstGeom prst="rect">
+            <a:avLst/>
+          </a:prstGeom>
+          <a:noFill/>
+        </p:spPr>
+        <p:txBody>
+          <a:bodyPr wrap="square" lIns="0" rIns="0" tIns="0" bIns="0" anchor="t">
+            <a:spAutoFit/>
+          </a:bodyPr>
+          <a:lstStyle/>
+          <a:p>
+            <a:pPr algn="l"/>
+            <a:r>
+              <a:rPr sz="1300" b="1">
+                <a:solidFill>
+                  <a:srgbClr val="2C6A85"/>
+                </a:solidFill>
+                <a:latin typeface="Inter"/>
+              </a:rPr>
+              <a:t>Ekin joylashtirish, ming ga (2024 yil hosili uchun reja)</a:t>
+            </a:r>
+          </a:p>
+        </p:txBody>
+      </p:sp>
+      <p:graphicFrame>
+        <p:nvGraphicFramePr>
+          <p:cNvPr id="8" name="Chart 7"/>
+          <p:cNvGraphicFramePr>
+            <a:graphicFrameLocks noGrp="1"/>
+          </p:cNvGraphicFramePr>
+          <p:nvPr/>
+        </p:nvGraphicFramePr>
+        <p:xfrm>
+          <a:off x="752800" y="2100000"/>
+          <a:ext cx="6500000" cy="3950000"/>
+        </p:xfrm>
+        <a:graphic>
+          <a:graphicData uri="http://schemas.openxmlformats.org/drawingml/2006/chart">
+            <c:chart xmlns:c="http://schemas.openxmlformats.org/drawingml/2006/chart" r:id="rId2"/>
+          </a:graphicData>
+        </a:graphic>
+      </p:graphicFrame>
+      <p:sp>
+        <p:nvSpPr>
+          <p:cNvPr id="9" name="Rounded Rectangle 8"/>
+          <p:cNvSpPr/>
+          <p:nvPr/>
+        </p:nvSpPr>
+        <p:spPr>
+          <a:xfrm>
+            <a:off x="7700000" y="1830000"/>
+            <a:ext cx="3996192" cy="1230000"/>
+          </a:xfrm>
+          <a:prstGeom prst="roundRect">
+            <a:avLst>
+              <a:gd name="adj" fmla="val 5000"/>
+            </a:avLst>
+          </a:prstGeom>
+          <a:solidFill>
+            <a:srgbClr val="FBF9F4"/>
+          </a:solidFill>
+          <a:ln w="6350">
+            <a:solidFill>
+              <a:srgbClr val="D9D2C3"/>
+            </a:solidFill>
+          </a:ln>
+          <a:effectLst/>
+        </p:spPr>
+        <p:style>
+          <a:lnRef idx="1">
+            <a:schemeClr val="accent1"/>
+          </a:lnRef>
+          <a:fillRef idx="3">
+            <a:schemeClr val="accent1"/>
+          </a:fillRef>
+          <a:effectRef idx="2">
+            <a:schemeClr val="accent1"/>
+          </a:effectRef>
+          <a:fontRef idx="minor">
+            <a:schemeClr val="lt1"/>
+          </a:fontRef>
+        </p:style>
+        <p:txBody>
+          <a:bodyPr rtlCol="0" anchor="ctr"/>
+          <a:lstStyle/>
+          <a:p>
+            <a:pPr algn="ctr"/>
+          </a:p>
+        </p:txBody>
+      </p:sp>
+      <p:sp>
+        <p:nvSpPr>
+          <p:cNvPr id="10" name="TextBox 9"/>
+          <p:cNvSpPr txBox="1"/>
+          <p:nvPr/>
+        </p:nvSpPr>
+        <p:spPr>
+          <a:xfrm>
+            <a:off x="7930000" y="1950000"/>
+            <a:ext cx="3536192" cy="420000"/>
+          </a:xfrm>
+          <a:prstGeom prst="rect">
+            <a:avLst/>
+          </a:prstGeom>
+          <a:noFill/>
+        </p:spPr>
+        <p:txBody>
+          <a:bodyPr wrap="square" lIns="0" rIns="0" tIns="0" bIns="0" anchor="t">
+            <a:spAutoFit/>
+          </a:bodyPr>
+          <a:lstStyle/>
+          <a:p>
+            <a:pPr algn="l"/>
+            <a:r>
+              <a:rPr sz="2400" b="0">
+                <a:solidFill>
+                  <a:srgbClr val="A4521D"/>
+                </a:solidFill>
+                <a:latin typeface="Source Serif 4"/>
+              </a:rPr>
+              <a:t>281,5 ming ga</a:t>
+            </a:r>
+          </a:p>
+        </p:txBody>
+      </p:sp>
+      <p:sp>
+        <p:nvSpPr>
+          <p:cNvPr id="11" name="TextBox 10"/>
+          <p:cNvSpPr txBox="1"/>
+          <p:nvPr/>
+        </p:nvSpPr>
+        <p:spPr>
+          <a:xfrm>
+            <a:off x="7930000" y="2390000"/>
+            <a:ext cx="3536192" cy="620000"/>
+          </a:xfrm>
+          <a:prstGeom prst="rect">
+            <a:avLst/>
+          </a:prstGeom>
+          <a:noFill/>
+        </p:spPr>
+        <p:txBody>
+          <a:bodyPr wrap="square" lIns="0" rIns="0" tIns="0" bIns="0" anchor="t">
+            <a:spAutoFit/>
+          </a:bodyPr>
+          <a:lstStyle/>
+          <a:p>
+            <a:pPr algn="l"/>
+            <a:r>
+              <a:rPr sz="1200" b="0">
+                <a:solidFill>
+                  <a:srgbClr val="4C5852"/>
+                </a:solidFill>
+                <a:latin typeface="Inter"/>
+              </a:rPr>
+              <a:t>Jami ekin joylashtirish (asosiy, takroriy ekin va qator oralari bilan)</a:t>
+            </a:r>
+          </a:p>
+        </p:txBody>
+      </p:sp>
+      <p:sp>
+        <p:nvSpPr>
+          <p:cNvPr id="12" name="Rounded Rectangle 11"/>
+          <p:cNvSpPr/>
+          <p:nvPr/>
+        </p:nvSpPr>
+        <p:spPr>
+          <a:xfrm>
+            <a:off x="7700000" y="3210000"/>
+            <a:ext cx="3996192" cy="1230000"/>
+          </a:xfrm>
+          <a:prstGeom prst="roundRect">
+            <a:avLst>
+              <a:gd name="adj" fmla="val 5000"/>
+            </a:avLst>
+          </a:prstGeom>
+          <a:solidFill>
+            <a:srgbClr val="FBF9F4"/>
+          </a:solidFill>
+          <a:ln w="6350">
+            <a:solidFill>
+              <a:srgbClr val="D9D2C3"/>
+            </a:solidFill>
+          </a:ln>
+          <a:effectLst/>
+        </p:spPr>
+        <p:style>
+          <a:lnRef idx="1">
+            <a:schemeClr val="accent1"/>
+          </a:lnRef>
+          <a:fillRef idx="3">
+            <a:schemeClr val="accent1"/>
+          </a:fillRef>
+          <a:effectRef idx="2">
+            <a:schemeClr val="accent1"/>
+          </a:effectRef>
+          <a:fontRef idx="minor">
+            <a:schemeClr val="lt1"/>
+          </a:fontRef>
+        </p:style>
+        <p:txBody>
+          <a:bodyPr rtlCol="0" anchor="ctr"/>
+          <a:lstStyle/>
+          <a:p>
+            <a:pPr algn="ctr"/>
+          </a:p>
+        </p:txBody>
+      </p:sp>
+      <p:sp>
+        <p:nvSpPr>
+          <p:cNvPr id="13" name="TextBox 12"/>
+          <p:cNvSpPr txBox="1"/>
+          <p:nvPr/>
+        </p:nvSpPr>
+        <p:spPr>
+          <a:xfrm>
+            <a:off x="7930000" y="3330000"/>
+            <a:ext cx="3536192" cy="420000"/>
+          </a:xfrm>
+          <a:prstGeom prst="rect">
+            <a:avLst/>
+          </a:prstGeom>
+          <a:noFill/>
+        </p:spPr>
+        <p:txBody>
+          <a:bodyPr wrap="square" lIns="0" rIns="0" tIns="0" bIns="0" anchor="t">
+            <a:spAutoFit/>
+          </a:bodyPr>
+          <a:lstStyle/>
+          <a:p>
+            <a:pPr algn="l"/>
+            <a:r>
+              <a:rPr sz="2400" b="0">
+                <a:solidFill>
+                  <a:srgbClr val="2C6A85"/>
+                </a:solidFill>
+                <a:latin typeface="Source Serif 4"/>
+              </a:rPr>
+              <a:t>25% + 25%</a:t>
+            </a:r>
+          </a:p>
+        </p:txBody>
+      </p:sp>
+      <p:sp>
+        <p:nvSpPr>
+          <p:cNvPr id="14" name="TextBox 13"/>
+          <p:cNvSpPr txBox="1"/>
+          <p:nvPr/>
+        </p:nvSpPr>
+        <p:spPr>
+          <a:xfrm>
+            <a:off x="7930000" y="3770000"/>
+            <a:ext cx="3536192" cy="620000"/>
+          </a:xfrm>
+          <a:prstGeom prst="rect">
+            <a:avLst/>
+          </a:prstGeom>
+          <a:noFill/>
+        </p:spPr>
+        <p:txBody>
+          <a:bodyPr wrap="square" lIns="0" rIns="0" tIns="0" bIns="0" anchor="t">
+            <a:spAutoFit/>
+          </a:bodyPr>
+          <a:lstStyle/>
+          <a:p>
+            <a:pPr algn="l"/>
+            <a:r>
+              <a:rPr sz="1200" b="0">
+                <a:solidFill>
+                  <a:srgbClr val="4C5852"/>
+                </a:solidFill>
+                <a:latin typeface="Inter"/>
+              </a:rPr>
+              <a:t>Gʻoʻza (71,3 ming ga) va donli ekinlar (70,2 ming ga) tarkibning yarmini tashkil etadi</a:t>
+            </a:r>
+          </a:p>
+        </p:txBody>
+      </p:sp>
+      <p:sp>
+        <p:nvSpPr>
+          <p:cNvPr id="15" name="Rounded Rectangle 14"/>
+          <p:cNvSpPr/>
+          <p:nvPr/>
+        </p:nvSpPr>
+        <p:spPr>
+          <a:xfrm>
+            <a:off x="7700000" y="4590000"/>
+            <a:ext cx="3996192" cy="1230000"/>
+          </a:xfrm>
+          <a:prstGeom prst="roundRect">
+            <a:avLst>
+              <a:gd name="adj" fmla="val 5000"/>
+            </a:avLst>
+          </a:prstGeom>
+          <a:solidFill>
+            <a:srgbClr val="FBF9F4"/>
+          </a:solidFill>
+          <a:ln w="6350">
+            <a:solidFill>
+              <a:srgbClr val="D9D2C3"/>
+            </a:solidFill>
+          </a:ln>
+          <a:effectLst/>
+        </p:spPr>
+        <p:style>
+          <a:lnRef idx="1">
+            <a:schemeClr val="accent1"/>
+          </a:lnRef>
+          <a:fillRef idx="3">
+            <a:schemeClr val="accent1"/>
+          </a:fillRef>
+          <a:effectRef idx="2">
+            <a:schemeClr val="accent1"/>
+          </a:effectRef>
+          <a:fontRef idx="minor">
+            <a:schemeClr val="lt1"/>
+          </a:fontRef>
+        </p:style>
+        <p:txBody>
+          <a:bodyPr rtlCol="0" anchor="ctr"/>
+          <a:lstStyle/>
+          <a:p>
+            <a:pPr algn="ctr"/>
+          </a:p>
+        </p:txBody>
+      </p:sp>
+      <p:sp>
+        <p:nvSpPr>
+          <p:cNvPr id="16" name="TextBox 15"/>
+          <p:cNvSpPr txBox="1"/>
+          <p:nvPr/>
+        </p:nvSpPr>
+        <p:spPr>
+          <a:xfrm>
+            <a:off x="7930000" y="4710000"/>
+            <a:ext cx="3536192" cy="420000"/>
+          </a:xfrm>
+          <a:prstGeom prst="rect">
+            <a:avLst/>
+          </a:prstGeom>
+          <a:noFill/>
+        </p:spPr>
+        <p:txBody>
+          <a:bodyPr wrap="square" lIns="0" rIns="0" tIns="0" bIns="0" anchor="t">
+            <a:spAutoFit/>
+          </a:bodyPr>
+          <a:lstStyle/>
+          <a:p>
+            <a:pPr algn="l"/>
+            <a:r>
+              <a:rPr sz="2400" b="0">
+                <a:solidFill>
+                  <a:srgbClr val="A4521D"/>
+                </a:solidFill>
+                <a:latin typeface="Source Serif 4"/>
+              </a:rPr>
+              <a:t>10,9 ming ga</a:t>
+            </a:r>
+          </a:p>
+        </p:txBody>
+      </p:sp>
+      <p:sp>
+        <p:nvSpPr>
+          <p:cNvPr id="17" name="TextBox 16"/>
+          <p:cNvSpPr txBox="1"/>
+          <p:nvPr/>
+        </p:nvSpPr>
+        <p:spPr>
+          <a:xfrm>
+            <a:off x="7930000" y="5150000"/>
+            <a:ext cx="3536192" cy="620000"/>
+          </a:xfrm>
+          <a:prstGeom prst="rect">
+            <a:avLst/>
+          </a:prstGeom>
+          <a:noFill/>
+        </p:spPr>
+        <p:txBody>
+          <a:bodyPr wrap="square" lIns="0" rIns="0" tIns="0" bIns="0" anchor="t">
+            <a:spAutoFit/>
+          </a:bodyPr>
+          <a:lstStyle/>
+          <a:p>
+            <a:pPr algn="l"/>
+            <a:r>
+              <a:rPr sz="1200" b="0">
+                <a:solidFill>
+                  <a:srgbClr val="4C5852"/>
+                </a:solidFill>
+                <a:latin typeface="Inter"/>
+              </a:rPr>
+              <a:t>Sholi — eng koʻp sugʻorish talab qiladigan ekin; asosan Paxtaobod (2 565 ga) va Jalaquduq (1 456 ga)</a:t>
+            </a:r>
+          </a:p>
+        </p:txBody>
+      </p:sp>
+      <p:sp>
+        <p:nvSpPr>
+          <p:cNvPr id="18" name="TextBox 17"/>
+          <p:cNvSpPr txBox="1"/>
+          <p:nvPr/>
+        </p:nvSpPr>
+        <p:spPr>
+          <a:xfrm>
+            <a:off x="812800" y="6238280"/>
+            <a:ext cx="9800000" cy="240000"/>
+          </a:xfrm>
+          <a:prstGeom prst="rect">
+            <a:avLst/>
+          </a:prstGeom>
+          <a:noFill/>
+        </p:spPr>
+        <p:txBody>
+          <a:bodyPr wrap="square" lIns="0" rIns="0" tIns="0" bIns="0" anchor="t">
+            <a:spAutoFit/>
+          </a:bodyPr>
+          <a:lstStyle/>
+          <a:p>
+            <a:pPr algn="l"/>
+            <a:r>
+              <a:rPr sz="1200" b="0">
+                <a:solidFill>
+                  <a:srgbClr val="5F6B64"/>
+                </a:solidFill>
+                <a:latin typeface="Inter"/>
+              </a:rPr>
+              <a:t>Manba: Andijon viloyati tumanlari boʻyicha ekin joylashtirish prognozi (2024 yil hosili)</a:t>
+            </a:r>
+          </a:p>
+        </p:txBody>
+      </p:sp>
+    </p:spTree>
+  </p:cSld>
+  <p:clrMapOvr>
+    <a:masterClrMapping/>
+  </p:clrMapOvr>
+</p:sld>
+</file>
+
+<file path=ppt/slides/slide22.xml><?xml version="1.0" encoding="utf-8"?>
+<p:sld xmlns:a="http://schemas.openxmlformats.org/drawingml/2006/main" xmlns:p="http://schemas.openxmlformats.org/presentationml/2006/main" xmlns:r="http://schemas.openxmlformats.org/officeDocument/2006/relationships">
+  <p:cSld>
+    <p:bg>
+      <p:bgPr>
+        <a:solidFill>
+          <a:srgbClr val="F4F1EA"/>
+        </a:solidFill>
+      </p:bgPr>
+    </p:bg>
+    <p:spTree>
+      <p:nvGrpSpPr>
+        <p:cNvPr id="1" name=""/>
+        <p:cNvGrpSpPr/>
+        <p:nvPr/>
+      </p:nvGrpSpPr>
+      <p:grpSpPr/>
+      <p:sp>
+        <p:nvSpPr>
+          <p:cNvPr id="2" name="Text 0"/>
+          <p:cNvSpPr/>
+          <p:nvPr/>
+        </p:nvSpPr>
+        <p:spPr>
+          <a:xfrm>
+            <a:off x="812800" y="812800"/>
+            <a:ext cx="10883392" cy="238720"/>
+          </a:xfrm>
+          <a:prstGeom prst="rect">
+            <a:avLst/>
+          </a:prstGeom>
+          <a:noFill/>
+          <a:ln/>
+        </p:spPr>
+        <p:txBody>
+          <a:bodyPr wrap="square" lIns="0" tIns="0" rIns="0" bIns="0" rtlCol="0" anchor="t">
+            <a:normAutofit/>
+          </a:bodyPr>
+          <a:lstStyle/>
+          <a:p>
+            <a:pPr algn="l" indent="0" marL="0">
+              <a:lnSpc>
+                <a:spcPts val="1680"/>
+              </a:lnSpc>
+              <a:buNone/>
+            </a:pPr>
+            <a:r>
+              <a:rPr lang="en-US" sz="1200" b="1" spc="150" kern="0" dirty="0">
+                <a:solidFill>
+                  <a:srgbClr val="2C6A85"/>
+                </a:solidFill>
+                <a:latin typeface="Inter" pitchFamily="34" charset="0"/>
+                <a:ea typeface="Inter" pitchFamily="34" charset="-122"/>
+                <a:cs typeface="Inter" pitchFamily="34" charset="-120"/>
+              </a:rPr>
+              <a:t>14 · DASTLABKI MAʼLUMOTLAR</a:t>
+            </a:r>
+            <a:endParaRPr lang="en-US" sz="1200" dirty="0"/>
+          </a:p>
+        </p:txBody>
+      </p:sp>
+      <p:sp>
+        <p:nvSpPr>
+          <p:cNvPr id="3" name="Text 1"/>
+          <p:cNvSpPr/>
+          <p:nvPr>
+            <p:ph type="title"/>
+          </p:nvPr>
+        </p:nvSpPr>
+        <p:spPr>
+          <a:xfrm>
+            <a:off x="812800" y="1127720"/>
+            <a:ext cx="10883392" cy="472430"/>
+          </a:xfrm>
+          <a:prstGeom prst="rect">
+            <a:avLst/>
+          </a:prstGeom>
+          <a:noFill/>
+          <a:ln/>
+        </p:spPr>
+        <p:txBody>
+          <a:bodyPr wrap="square" lIns="0" tIns="0" rIns="0" bIns="0" rtlCol="0" anchor="t">
+            <a:normAutofit/>
+          </a:bodyPr>
+          <a:lstStyle/>
+          <a:p>
+            <a:pPr algn="l" indent="0" marL="0">
+              <a:lnSpc>
+                <a:spcPts val="3520"/>
+              </a:lnSpc>
+              <a:buNone/>
+            </a:pPr>
+            <a:r>
+              <a:rPr lang="en-US" sz="3200" b="0" i="0" dirty="0">
+                <a:solidFill>
+                  <a:srgbClr val="1D2A24"/>
+                </a:solidFill>
+                <a:latin typeface="Source Serif 4" pitchFamily="18" charset="0"/>
+                <a:ea typeface="Source Serif 4" pitchFamily="18" charset="-122"/>
+                <a:cs typeface="Source Serif 4" pitchFamily="18" charset="-120"/>
+              </a:rPr>
+              <a:t>Ulugʻnor tumani: kontur bonitet ballari</a:t>
+            </a:r>
+            <a:endParaRPr lang="en-US" sz="3200" dirty="0"/>
+          </a:p>
+        </p:txBody>
+      </p:sp>
+      <p:sp>
+        <p:nvSpPr>
+          <p:cNvPr id="6" name="Text 3"/>
+          <p:cNvSpPr/>
+          <p:nvPr/>
+        </p:nvSpPr>
+        <p:spPr>
+          <a:xfrm>
+            <a:off x="11137950" y="6238280"/>
+            <a:ext cx="241250" cy="238720"/>
+          </a:xfrm>
+          <a:prstGeom prst="rect">
+            <a:avLst/>
+          </a:prstGeom>
+          <a:noFill/>
+          <a:ln/>
+        </p:spPr>
+        <p:txBody>
+          <a:bodyPr wrap="square" lIns="0" tIns="0" rIns="0" bIns="0" rtlCol="0" anchor="t">
+            <a:normAutofit/>
+          </a:bodyPr>
+          <a:lstStyle/>
+          <a:p>
+            <a:pPr algn="r" indent="0" marL="0">
+              <a:lnSpc>
+                <a:spcPts val="1680"/>
+              </a:lnSpc>
+              <a:buNone/>
+            </a:pPr>
+            <a:r>
+              <a:rPr lang="en-US" sz="1200" dirty="0">
+                <a:solidFill>
+                  <a:srgbClr val="5F6B64"/>
+                </a:solidFill>
+                <a:latin typeface="Inter" pitchFamily="34" charset="0"/>
+                <a:ea typeface="Inter" pitchFamily="34" charset="-122"/>
+                <a:cs typeface="Inter" pitchFamily="34" charset="-120"/>
+              </a:rPr>
+              <a:t>15</a:t>
+            </a:r>
+            <a:endParaRPr lang="en-US" sz="1200" dirty="0"/>
+          </a:p>
+        </p:txBody>
+      </p:sp>
+      <p:sp>
+        <p:nvSpPr>
+          <p:cNvPr id="7" name="TextBox 6"/>
+          <p:cNvSpPr txBox="1"/>
+          <p:nvPr/>
+        </p:nvSpPr>
+        <p:spPr>
+          <a:xfrm>
+            <a:off x="812800" y="1830000"/>
+            <a:ext cx="6200000" cy="260000"/>
+          </a:xfrm>
+          <a:prstGeom prst="rect">
+            <a:avLst/>
+          </a:prstGeom>
+          <a:noFill/>
+        </p:spPr>
+        <p:txBody>
+          <a:bodyPr wrap="square" lIns="0" rIns="0" tIns="0" bIns="0" anchor="t">
+            <a:spAutoFit/>
+          </a:bodyPr>
+          <a:lstStyle/>
+          <a:p>
+            <a:pPr algn="l"/>
+            <a:r>
+              <a:rPr sz="1300" b="1">
+                <a:solidFill>
+                  <a:srgbClr val="2C6A85"/>
+                </a:solidFill>
+                <a:latin typeface="Inter"/>
+              </a:rPr>
+              <a:t>Sugʻoriladigan yer maydoni bonitet sinflari boʻyicha, ga</a:t>
+            </a:r>
+          </a:p>
+        </p:txBody>
+      </p:sp>
+      <p:graphicFrame>
+        <p:nvGraphicFramePr>
+          <p:cNvPr id="8" name="Chart 7"/>
+          <p:cNvGraphicFramePr>
+            <a:graphicFrameLocks noGrp="1"/>
+          </p:cNvGraphicFramePr>
+          <p:nvPr/>
+        </p:nvGraphicFramePr>
+        <p:xfrm>
+          <a:off x="752800" y="2130000"/>
+          <a:ext cx="6300000" cy="3000000"/>
+        </p:xfrm>
+        <a:graphic>
+          <a:graphicData uri="http://schemas.openxmlformats.org/drawingml/2006/chart">
+            <c:chart xmlns:c="http://schemas.openxmlformats.org/drawingml/2006/chart" r:id="rId2"/>
+          </a:graphicData>
+        </a:graphic>
+      </p:graphicFrame>
+      <p:sp>
+        <p:nvSpPr>
+          <p:cNvPr id="9" name="Rounded Rectangle 8"/>
+          <p:cNvSpPr/>
+          <p:nvPr/>
+        </p:nvSpPr>
+        <p:spPr>
+          <a:xfrm>
+            <a:off x="7700000" y="1830000"/>
+            <a:ext cx="3996192" cy="1230000"/>
+          </a:xfrm>
+          <a:prstGeom prst="roundRect">
+            <a:avLst>
+              <a:gd name="adj" fmla="val 5000"/>
+            </a:avLst>
+          </a:prstGeom>
+          <a:solidFill>
+            <a:srgbClr val="FBF9F4"/>
+          </a:solidFill>
+          <a:ln w="6350">
+            <a:solidFill>
+              <a:srgbClr val="D9D2C3"/>
+            </a:solidFill>
+          </a:ln>
+          <a:effectLst/>
+        </p:spPr>
+        <p:style>
+          <a:lnRef idx="1">
+            <a:schemeClr val="accent1"/>
+          </a:lnRef>
+          <a:fillRef idx="3">
+            <a:schemeClr val="accent1"/>
+          </a:fillRef>
+          <a:effectRef idx="2">
+            <a:schemeClr val="accent1"/>
+          </a:effectRef>
+          <a:fontRef idx="minor">
+            <a:schemeClr val="lt1"/>
+          </a:fontRef>
+        </p:style>
+        <p:txBody>
+          <a:bodyPr rtlCol="0" anchor="ctr"/>
+          <a:lstStyle/>
+          <a:p>
+            <a:pPr algn="ctr"/>
+          </a:p>
+        </p:txBody>
+      </p:sp>
+      <p:sp>
+        <p:nvSpPr>
+          <p:cNvPr id="10" name="TextBox 9"/>
+          <p:cNvSpPr txBox="1"/>
+          <p:nvPr/>
+        </p:nvSpPr>
+        <p:spPr>
+          <a:xfrm>
+            <a:off x="7930000" y="1950000"/>
+            <a:ext cx="3536192" cy="420000"/>
+          </a:xfrm>
+          <a:prstGeom prst="rect">
+            <a:avLst/>
+          </a:prstGeom>
+          <a:noFill/>
+        </p:spPr>
+        <p:txBody>
+          <a:bodyPr wrap="square" lIns="0" rIns="0" tIns="0" bIns="0" anchor="t">
+            <a:spAutoFit/>
+          </a:bodyPr>
+          <a:lstStyle/>
+          <a:p>
+            <a:pPr algn="l"/>
+            <a:r>
+              <a:rPr sz="2400" b="0">
+                <a:solidFill>
+                  <a:srgbClr val="A4521D"/>
+                </a:solidFill>
+                <a:latin typeface="Source Serif 4"/>
+              </a:rPr>
+              <a:t>47,4 ball</a:t>
+            </a:r>
+          </a:p>
+        </p:txBody>
+      </p:sp>
+      <p:sp>
+        <p:nvSpPr>
+          <p:cNvPr id="11" name="TextBox 10"/>
+          <p:cNvSpPr txBox="1"/>
+          <p:nvPr/>
+        </p:nvSpPr>
+        <p:spPr>
+          <a:xfrm>
+            <a:off x="7930000" y="2390000"/>
+            <a:ext cx="3536192" cy="620000"/>
+          </a:xfrm>
+          <a:prstGeom prst="rect">
+            <a:avLst/>
+          </a:prstGeom>
+          <a:noFill/>
+        </p:spPr>
+        <p:txBody>
+          <a:bodyPr wrap="square" lIns="0" rIns="0" tIns="0" bIns="0" anchor="t">
+            <a:spAutoFit/>
+          </a:bodyPr>
+          <a:lstStyle/>
+          <a:p>
+            <a:pPr algn="l"/>
+            <a:r>
+              <a:rPr sz="1200" b="0">
+                <a:solidFill>
+                  <a:srgbClr val="4C5852"/>
+                </a:solidFill>
+                <a:latin typeface="Inter"/>
+              </a:rPr>
+              <a:t>Maydon boʻyicha oʻrtacha bonitet (kontur ballari 28 dan 69 gacha)</a:t>
+            </a:r>
+          </a:p>
+        </p:txBody>
+      </p:sp>
+      <p:sp>
+        <p:nvSpPr>
+          <p:cNvPr id="12" name="Rounded Rectangle 11"/>
+          <p:cNvSpPr/>
+          <p:nvPr/>
+        </p:nvSpPr>
+        <p:spPr>
+          <a:xfrm>
+            <a:off x="7700000" y="3210000"/>
+            <a:ext cx="3996192" cy="1230000"/>
+          </a:xfrm>
+          <a:prstGeom prst="roundRect">
+            <a:avLst>
+              <a:gd name="adj" fmla="val 5000"/>
+            </a:avLst>
+          </a:prstGeom>
+          <a:solidFill>
+            <a:srgbClr val="FBF9F4"/>
+          </a:solidFill>
+          <a:ln w="6350">
+            <a:solidFill>
+              <a:srgbClr val="D9D2C3"/>
+            </a:solidFill>
+          </a:ln>
+          <a:effectLst/>
+        </p:spPr>
+        <p:style>
+          <a:lnRef idx="1">
+            <a:schemeClr val="accent1"/>
+          </a:lnRef>
+          <a:fillRef idx="3">
+            <a:schemeClr val="accent1"/>
+          </a:fillRef>
+          <a:effectRef idx="2">
+            <a:schemeClr val="accent1"/>
+          </a:effectRef>
+          <a:fontRef idx="minor">
+            <a:schemeClr val="lt1"/>
+          </a:fontRef>
+        </p:style>
+        <p:txBody>
+          <a:bodyPr rtlCol="0" anchor="ctr"/>
+          <a:lstStyle/>
+          <a:p>
+            <a:pPr algn="ctr"/>
+          </a:p>
+        </p:txBody>
+      </p:sp>
+      <p:sp>
+        <p:nvSpPr>
+          <p:cNvPr id="13" name="TextBox 12"/>
+          <p:cNvSpPr txBox="1"/>
+          <p:nvPr/>
+        </p:nvSpPr>
+        <p:spPr>
+          <a:xfrm>
+            <a:off x="7930000" y="3330000"/>
+            <a:ext cx="3536192" cy="420000"/>
+          </a:xfrm>
+          <a:prstGeom prst="rect">
+            <a:avLst/>
+          </a:prstGeom>
+          <a:noFill/>
+        </p:spPr>
+        <p:txBody>
+          <a:bodyPr wrap="square" lIns="0" rIns="0" tIns="0" bIns="0" anchor="t">
+            <a:spAutoFit/>
+          </a:bodyPr>
+          <a:lstStyle/>
+          <a:p>
+            <a:pPr algn="l"/>
+            <a:r>
+              <a:rPr sz="2400" b="0">
+                <a:solidFill>
+                  <a:srgbClr val="2C6A85"/>
+                </a:solidFill>
+                <a:latin typeface="Source Serif 4"/>
+              </a:rPr>
+              <a:t>2 337 kontur</a:t>
+            </a:r>
+          </a:p>
+        </p:txBody>
+      </p:sp>
+      <p:sp>
+        <p:nvSpPr>
+          <p:cNvPr id="14" name="TextBox 13"/>
+          <p:cNvSpPr txBox="1"/>
+          <p:nvPr/>
+        </p:nvSpPr>
+        <p:spPr>
+          <a:xfrm>
+            <a:off x="7930000" y="3770000"/>
+            <a:ext cx="3536192" cy="620000"/>
+          </a:xfrm>
+          <a:prstGeom prst="rect">
+            <a:avLst/>
+          </a:prstGeom>
+          <a:noFill/>
+        </p:spPr>
+        <p:txBody>
+          <a:bodyPr wrap="square" lIns="0" rIns="0" tIns="0" bIns="0" anchor="t">
+            <a:spAutoFit/>
+          </a:bodyPr>
+          <a:lstStyle/>
+          <a:p>
+            <a:pPr algn="l"/>
+            <a:r>
+              <a:rPr sz="1200" b="0">
+                <a:solidFill>
+                  <a:srgbClr val="4C5852"/>
+                </a:solidFill>
+                <a:latin typeface="Inter"/>
+              </a:rPr>
+              <a:t>21,0 ming ga ekin maydoni kontur kesimida raqamlangan</a:t>
+            </a:r>
+          </a:p>
+        </p:txBody>
+      </p:sp>
+      <p:sp>
+        <p:nvSpPr>
+          <p:cNvPr id="15" name="Rounded Rectangle 14"/>
+          <p:cNvSpPr/>
+          <p:nvPr/>
+        </p:nvSpPr>
+        <p:spPr>
+          <a:xfrm>
+            <a:off x="7700000" y="4590000"/>
+            <a:ext cx="3996192" cy="1230000"/>
+          </a:xfrm>
+          <a:prstGeom prst="roundRect">
+            <a:avLst>
+              <a:gd name="adj" fmla="val 5000"/>
+            </a:avLst>
+          </a:prstGeom>
+          <a:solidFill>
+            <a:srgbClr val="FBF9F4"/>
+          </a:solidFill>
+          <a:ln w="6350">
+            <a:solidFill>
+              <a:srgbClr val="D9D2C3"/>
+            </a:solidFill>
+          </a:ln>
+          <a:effectLst/>
+        </p:spPr>
+        <p:style>
+          <a:lnRef idx="1">
+            <a:schemeClr val="accent1"/>
+          </a:lnRef>
+          <a:fillRef idx="3">
+            <a:schemeClr val="accent1"/>
+          </a:fillRef>
+          <a:effectRef idx="2">
+            <a:schemeClr val="accent1"/>
+          </a:effectRef>
+          <a:fontRef idx="minor">
+            <a:schemeClr val="lt1"/>
+          </a:fontRef>
+        </p:style>
+        <p:txBody>
+          <a:bodyPr rtlCol="0" anchor="ctr"/>
+          <a:lstStyle/>
+          <a:p>
+            <a:pPr algn="ctr"/>
+          </a:p>
+        </p:txBody>
+      </p:sp>
+      <p:sp>
+        <p:nvSpPr>
+          <p:cNvPr id="16" name="TextBox 15"/>
+          <p:cNvSpPr txBox="1"/>
+          <p:nvPr/>
+        </p:nvSpPr>
+        <p:spPr>
+          <a:xfrm>
+            <a:off x="7930000" y="4710000"/>
+            <a:ext cx="3536192" cy="420000"/>
+          </a:xfrm>
+          <a:prstGeom prst="rect">
+            <a:avLst/>
+          </a:prstGeom>
+          <a:noFill/>
+        </p:spPr>
+        <p:txBody>
+          <a:bodyPr wrap="square" lIns="0" rIns="0" tIns="0" bIns="0" anchor="t">
+            <a:spAutoFit/>
+          </a:bodyPr>
+          <a:lstStyle/>
+          <a:p>
+            <a:pPr algn="l"/>
+            <a:r>
+              <a:rPr sz="2400" b="0">
+                <a:solidFill>
+                  <a:srgbClr val="A4521D"/>
+                </a:solidFill>
+                <a:latin typeface="Source Serif 4"/>
+              </a:rPr>
+              <a:t>28%</a:t>
+            </a:r>
+          </a:p>
+        </p:txBody>
+      </p:sp>
+      <p:sp>
+        <p:nvSpPr>
+          <p:cNvPr id="17" name="TextBox 16"/>
+          <p:cNvSpPr txBox="1"/>
+          <p:nvPr/>
+        </p:nvSpPr>
+        <p:spPr>
+          <a:xfrm>
+            <a:off x="7930000" y="5150000"/>
+            <a:ext cx="3536192" cy="620000"/>
+          </a:xfrm>
+          <a:prstGeom prst="rect">
+            <a:avLst/>
+          </a:prstGeom>
+          <a:noFill/>
+        </p:spPr>
+        <p:txBody>
+          <a:bodyPr wrap="square" lIns="0" rIns="0" tIns="0" bIns="0" anchor="t">
+            <a:spAutoFit/>
+          </a:bodyPr>
+          <a:lstStyle/>
+          <a:p>
+            <a:pPr algn="l"/>
+            <a:r>
+              <a:rPr sz="1200" b="0">
+                <a:solidFill>
+                  <a:srgbClr val="4C5852"/>
+                </a:solidFill>
+                <a:latin typeface="Inter"/>
+              </a:rPr>
+              <a:t>Maydonning ulushi past bonitetli (≤40 ball) yerlarda</a:t>
+            </a:r>
+          </a:p>
+        </p:txBody>
+      </p:sp>
+      <p:sp>
+        <p:nvSpPr>
+          <p:cNvPr id="18" name="TextBox 17"/>
+          <p:cNvSpPr txBox="1"/>
+          <p:nvPr/>
+        </p:nvSpPr>
+        <p:spPr>
+          <a:xfrm>
+            <a:off x="812800" y="5350000"/>
+            <a:ext cx="6300000" cy="700000"/>
+          </a:xfrm>
+          <a:prstGeom prst="rect">
+            <a:avLst/>
+          </a:prstGeom>
+          <a:noFill/>
+        </p:spPr>
+        <p:txBody>
+          <a:bodyPr wrap="square" lIns="0" rIns="0" tIns="0" bIns="0" anchor="t">
+            <a:spAutoFit/>
+          </a:bodyPr>
+          <a:lstStyle/>
+          <a:p>
+            <a:pPr algn="l"/>
+            <a:r>
+              <a:rPr sz="1200" b="0">
+                <a:solidFill>
+                  <a:srgbClr val="4C5852"/>
+                </a:solidFill>
+                <a:latin typeface="Inter"/>
+              </a:rPr>
+              <a:t>Ulugʻnor tumanida paxta hosildorligi viloyat oʻrtachasidan past. Kontur ballari GAT qatlami sifatida 3.3-boʻlimdagi omillar tahlilida ishlatiladi.</a:t>
+            </a:r>
+          </a:p>
+        </p:txBody>
+      </p:sp>
+      <p:sp>
+        <p:nvSpPr>
+          <p:cNvPr id="19" name="TextBox 18"/>
+          <p:cNvSpPr txBox="1"/>
+          <p:nvPr/>
+        </p:nvSpPr>
+        <p:spPr>
+          <a:xfrm>
+            <a:off x="812800" y="6238280"/>
+            <a:ext cx="9800000" cy="240000"/>
+          </a:xfrm>
+          <a:prstGeom prst="rect">
+            <a:avLst/>
+          </a:prstGeom>
+          <a:noFill/>
+        </p:spPr>
+        <p:txBody>
+          <a:bodyPr wrap="square" lIns="0" rIns="0" tIns="0" bIns="0" anchor="t">
+            <a:spAutoFit/>
+          </a:bodyPr>
+          <a:lstStyle/>
+          <a:p>
+            <a:pPr algn="l"/>
+            <a:r>
+              <a:rPr sz="1200" b="0">
+                <a:solidFill>
+                  <a:srgbClr val="5F6B64"/>
+                </a:solidFill>
+                <a:latin typeface="Inter"/>
+              </a:rPr>
+              <a:t>Manba: Ulugʻnor tumani ekin joylashtirish rejasi (2022 yil hosili), kontur kesimida</a:t>
             </a:r>
           </a:p>
         </p:txBody>
@@ -17901,7 +19536,7 @@
                           <a:ea typeface="Inter" pitchFamily="34" charset="-122"/>
                           <a:cs typeface="Inter" pitchFamily="34" charset="-120"/>
                         </a:rPr>
-                        <a:t>Ekin joylashtirish rejalari (2026)</a:t>
+                        <a:t>Ekin joylashtirish rejalari (2022–2026)</a:t>
                       </a:r>
                       <a:endParaRPr lang="en-US" sz="1300" dirty="0">
                         <a:latin typeface="Inter" charset="0"/>
@@ -17969,7 +19604,7 @@
                           <a:ea typeface="Inter" pitchFamily="34" charset="-122"/>
                           <a:cs typeface="Inter" pitchFamily="34" charset="-120"/>
                         </a:rPr>
-                        <a:t>5 ta tuman: kontur va fermer kesimida ekin maydonlari</a:t>
+                        <a:t>Tuman va kontur kesimida ekin maydonlari, tuproq bonitet ballari</a:t>
                       </a:r>
                       <a:endParaRPr lang="en-US" sz="1300" dirty="0">
                         <a:latin typeface="Inter" charset="0"/>

</xml_diff>

<commit_message>
Add Namangan water supply and salt-leaching slide
Co-Authored-By: Claude Sonnet 5.5 <noreply@anthropic.com>
Claude-Session: https://claude.ai/code/session_01M4MZatV28utL9zTp7saaUz
</commit_message>
<xml_diff>
--- a/Garbiy_Farg_ona_tuproqlari_GAT_asosida_bashoratlash.pptx
+++ b/Garbiy_Farg_ona_tuproqlari_GAT_asosida_bashoratlash.pptx
@@ -20,6 +20,7 @@
     <p:sldId id="275" r:id="rId26"/>
     <p:sldId id="276" r:id="rId27"/>
     <p:sldId id="277" r:id="rId28"/>
+    <p:sldId id="278" r:id="rId29"/>
     <p:sldId id="265" r:id="rId11"/>
     <p:sldId id="266" r:id="rId12"/>
     <p:sldId id="267" r:id="rId13"/>
@@ -1848,6 +1849,189 @@
         </c:scaling>
         <c:delete/>
         <c:axPos val="l"/>
+        <c:majorTickMark val="out"/>
+        <c:minorTickMark val="none"/>
+        <c:tickLblPos val="nextTo"/>
+        <c:crossAx val="-2068027336"/>
+        <c:crosses val="autoZero"/>
+      </c:valAx>
+    </c:plotArea>
+    <c:dispBlanksAs val="gap"/>
+  </c:chart>
+  <c:txPr>
+    <a:bodyPr/>
+    <a:lstStyle/>
+    <a:p>
+      <a:pPr>
+        <a:defRPr sz="1200">
+          <a:solidFill>
+            <a:srgbClr val="4C5852"/>
+          </a:solidFill>
+          <a:latin typeface="Inter"/>
+        </a:defRPr>
+      </a:pPr>
+      <a:endParaRPr lang="en-US"/>
+    </a:p>
+  </c:txPr>
+  <c:externalData r:id="rId1">
+    <c:autoUpdate val="0"/>
+  </c:externalData>
+</c:chartSpace>
+</file>
+
+<file path=ppt/charts/chart9.xml><?xml version="1.0" encoding="utf-8"?>
+<c:chartSpace xmlns:c="http://schemas.openxmlformats.org/drawingml/2006/chart" xmlns:a="http://schemas.openxmlformats.org/drawingml/2006/main" xmlns:r="http://schemas.openxmlformats.org/officeDocument/2006/relationships">
+  <c:date1904 val="0"/>
+  <c:chart>
+    <c:autoTitleDeleted val="1"/>
+    <c:plotArea>
+      <c:barChart>
+        <c:barDir val="bar"/>
+        <c:grouping val="clustered"/>
+        <c:ser>
+          <c:idx val="0"/>
+          <c:order val="0"/>
+          <c:tx>
+            <c:strRef>
+              <c:f>Sheet1!$B$1</c:f>
+              <c:strCache>
+                <c:ptCount val="1"/>
+                <c:pt idx="0">
+                  <c:v>Suv</c:v>
+                </c:pt>
+              </c:strCache>
+            </c:strRef>
+          </c:tx>
+          <c:spPr>
+            <a:solidFill>
+              <a:srgbClr val="2C6A85"/>
+            </a:solidFill>
+          </c:spPr>
+          <c:dPt>
+            <c:idx val="2"/>
+            <c:spPr>
+              <a:solidFill>
+                <a:srgbClr val="A4521D"/>
+              </a:solidFill>
+            </c:spPr>
+          </c:dPt>
+          <c:cat>
+            <c:strRef>
+              <c:f>Sheet1!$A$2:$A$5</c:f>
+              <c:strCache>
+                <c:ptCount val="4"/>
+                <c:pt idx="0">
+                  <c:v>Daryo uzanidan</c:v>
+                </c:pt>
+                <c:pt idx="1">
+                  <c:v>Ichki soy va daryolar</c:v>
+                </c:pt>
+                <c:pt idx="2">
+                  <c:v>Zovurlar</c:v>
+                </c:pt>
+                <c:pt idx="3">
+                  <c:v>Yer osti suvlari</c:v>
+                </c:pt>
+              </c:strCache>
+            </c:strRef>
+          </c:cat>
+          <c:val>
+            <c:numRef>
+              <c:f>Sheet1!$B$2:$B$5</c:f>
+              <c:numCache>
+                <c:formatCode>General</c:formatCode>
+                <c:ptCount val="4"/>
+                <c:pt idx="0">
+                  <c:v>2831.7</c:v>
+                </c:pt>
+                <c:pt idx="1">
+                  <c:v>491.3</c:v>
+                </c:pt>
+                <c:pt idx="2">
+                  <c:v>53.9</c:v>
+                </c:pt>
+                <c:pt idx="3">
+                  <c:v>53.7</c:v>
+                </c:pt>
+              </c:numCache>
+            </c:numRef>
+          </c:val>
+        </c:ser>
+        <c:dLbls>
+          <c:numFmt formatCode="#,##0.0" sourceLinked="0"/>
+          <c:txPr>
+            <a:bodyPr/>
+            <a:lstStyle/>
+            <a:p>
+              <a:pPr>
+                <a:defRPr sz="1200">
+                  <a:solidFill>
+                    <a:srgbClr val="1D2A24"/>
+                  </a:solidFill>
+                  <a:latin typeface="Inter"/>
+                </a:defRPr>
+              </a:pPr>
+            </a:p>
+          </c:txPr>
+          <c:dLblPos val="outEnd"/>
+          <c:showLegendKey val="0"/>
+          <c:showVal val="1"/>
+          <c:showCatName val="0"/>
+          <c:showSerName val="0"/>
+          <c:showPercent val="0"/>
+          <c:showBubbleSize val="0"/>
+          <c:showLeaderLines val="1"/>
+        </c:dLbls>
+        <c:gapWidth val="45"/>
+        <c:axId val="-2068027336"/>
+        <c:axId val="-2113994440"/>
+      </c:barChart>
+      <c:catAx>
+        <c:axId val="-2068027336"/>
+        <c:scaling>
+          <c:orientation val="maxMin"/>
+        </c:scaling>
+        <c:delete val="0"/>
+        <c:axPos val="l"/>
+        <c:majorTickMark val="out"/>
+        <c:minorTickMark val="none"/>
+        <c:tickLblPos val="nextTo"/>
+        <c:spPr>
+          <a:ln>
+            <a:solidFill>
+              <a:srgbClr val="B5B2AD"/>
+            </a:solidFill>
+          </a:ln>
+        </c:spPr>
+        <c:txPr>
+          <a:bodyPr/>
+          <a:lstStyle/>
+          <a:p>
+            <a:pPr>
+              <a:defRPr sz="1200">
+                <a:solidFill>
+                  <a:srgbClr val="4C5852"/>
+                </a:solidFill>
+                <a:latin typeface="Inter"/>
+              </a:defRPr>
+            </a:pPr>
+          </a:p>
+        </c:txPr>
+        <c:crossAx val="-2113994440"/>
+        <c:crosses val="autoZero"/>
+        <c:auto val="1"/>
+        <c:lblAlgn val="ctr"/>
+        <c:lblOffset val="100"/>
+        <c:noMultiLvlLbl val="0"/>
+      </c:catAx>
+      <c:valAx>
+        <c:axId val="-2113994440"/>
+        <c:scaling>
+          <c:max val="3400.0"/>
+          <c:min val="0.0"/>
+        </c:scaling>
+        <c:delete/>
+        <c:axPos val="b"/>
         <c:majorTickMark val="out"/>
         <c:minorTickMark val="none"/>
         <c:tickLblPos val="nextTo"/>
@@ -4800,7 +4984,7 @@
                 <a:ea typeface="Inter" pitchFamily="34" charset="-122"/>
                 <a:cs typeface="Inter" pitchFamily="34" charset="-120"/>
               </a:rPr>
-              <a:t>15 · DISSERTATSIYA TUZILISHI</a:t>
+              <a:t>16 · DISSERTATSIYA TUZILISHI</a:t>
             </a:r>
             <a:endParaRPr lang="en-US" sz="1200" dirty="0"/>
           </a:p>
@@ -5599,7 +5783,7 @@
                 <a:ea typeface="Inter" pitchFamily="34" charset="-122"/>
                 <a:cs typeface="Inter" pitchFamily="34" charset="-120"/>
               </a:rPr>
-              <a:t>16</a:t>
+              <a:t>17</a:t>
             </a:r>
             <a:endParaRPr lang="en-US" sz="1200" dirty="0"/>
           </a:p>
@@ -5675,7 +5859,7 @@
                 <a:ea typeface="Inter" pitchFamily="34" charset="-122"/>
                 <a:cs typeface="Inter" pitchFamily="34" charset="-120"/>
               </a:rPr>
-              <a:t>16 · DISSERTATSIYA TUZILISHI</a:t>
+              <a:t>17 · DISSERTATSIYA TUZILISHI</a:t>
             </a:r>
             <a:endParaRPr lang="en-US" sz="1200" dirty="0"/>
           </a:p>
@@ -6707,7 +6891,7 @@
                 <a:ea typeface="Inter" pitchFamily="34" charset="-122"/>
                 <a:cs typeface="Inter" pitchFamily="34" charset="-120"/>
               </a:rPr>
-              <a:t>17</a:t>
+              <a:t>18</a:t>
             </a:r>
             <a:endParaRPr lang="en-US" sz="1200" dirty="0"/>
           </a:p>
@@ -6783,7 +6967,7 @@
                 <a:ea typeface="Inter" pitchFamily="34" charset="-122"/>
                 <a:cs typeface="Inter" pitchFamily="34" charset="-120"/>
               </a:rPr>
-              <a:t>17 · DISSERTATSIYA TUZILISHI</a:t>
+              <a:t>18 · DISSERTATSIYA TUZILISHI</a:t>
             </a:r>
             <a:endParaRPr lang="en-US" sz="1200" dirty="0"/>
           </a:p>
@@ -7810,7 +7994,7 @@
                 <a:ea typeface="Inter" pitchFamily="34" charset="-122"/>
                 <a:cs typeface="Inter" pitchFamily="34" charset="-120"/>
               </a:rPr>
-              <a:t>18</a:t>
+              <a:t>19</a:t>
             </a:r>
             <a:endParaRPr lang="en-US" sz="1200" dirty="0"/>
           </a:p>
@@ -7886,7 +8070,7 @@
                 <a:ea typeface="Inter" pitchFamily="34" charset="-122"/>
                 <a:cs typeface="Inter" pitchFamily="34" charset="-120"/>
               </a:rPr>
-              <a:t>18 · NATIJALAR VA REJA</a:t>
+              <a:t>19 · NATIJALAR VA REJA</a:t>
             </a:r>
             <a:endParaRPr lang="en-US" sz="1200" dirty="0"/>
           </a:p>
@@ -8624,7 +8808,7 @@
                 <a:ea typeface="Inter" pitchFamily="34" charset="-122"/>
                 <a:cs typeface="Inter" pitchFamily="34" charset="-120"/>
               </a:rPr>
-              <a:t>19</a:t>
+              <a:t>20</a:t>
             </a:r>
             <a:endParaRPr lang="en-US" sz="1200" dirty="0"/>
           </a:p>
@@ -8700,7 +8884,7 @@
                 <a:ea typeface="Inter" pitchFamily="34" charset="-122"/>
                 <a:cs typeface="Inter" pitchFamily="34" charset="-120"/>
               </a:rPr>
-              <a:t>19 · NATIJALAR VA REJA</a:t>
+              <a:t>20 · NATIJALAR VA REJA</a:t>
             </a:r>
             <a:endParaRPr lang="en-US" sz="1200" dirty="0"/>
           </a:p>
@@ -9726,7 +9910,7 @@
                 <a:ea typeface="Inter" pitchFamily="34" charset="-122"/>
                 <a:cs typeface="Inter" pitchFamily="34" charset="-120"/>
               </a:rPr>
-              <a:t>20</a:t>
+              <a:t>21</a:t>
             </a:r>
             <a:endParaRPr lang="en-US" sz="1200" dirty="0"/>
           </a:p>
@@ -9802,7 +9986,7 @@
                 <a:ea typeface="Inter" pitchFamily="34" charset="-122"/>
                 <a:cs typeface="Inter" pitchFamily="34" charset="-120"/>
               </a:rPr>
-              <a:t>20 · NATIJALAR VA REJA</a:t>
+              <a:t>21 · NATIJALAR VA REJA</a:t>
             </a:r>
             <a:endParaRPr lang="en-US" sz="1200" dirty="0"/>
           </a:p>
@@ -10414,7 +10598,7 @@
                 <a:ea typeface="Inter" pitchFamily="34" charset="-122"/>
                 <a:cs typeface="Inter" pitchFamily="34" charset="-120"/>
               </a:rPr>
-              <a:t>21</a:t>
+              <a:t>22</a:t>
             </a:r>
             <a:endParaRPr lang="en-US" sz="1200" dirty="0"/>
           </a:p>
@@ -15082,6 +15266,642 @@
                 <a:latin typeface="Inter"/>
               </a:rPr>
               <a:t>Manba: Ulugʻnor tumani ekin joylashtirish rejasi (2022 yil hosili), kontur kesimida</a:t>
+            </a:r>
+          </a:p>
+        </p:txBody>
+      </p:sp>
+    </p:spTree>
+  </p:cSld>
+  <p:clrMapOvr>
+    <a:masterClrMapping/>
+  </p:clrMapOvr>
+</p:sld>
+</file>
+
+<file path=ppt/slides/slide23.xml><?xml version="1.0" encoding="utf-8"?>
+<p:sld xmlns:a="http://schemas.openxmlformats.org/drawingml/2006/main" xmlns:p="http://schemas.openxmlformats.org/presentationml/2006/main" xmlns:r="http://schemas.openxmlformats.org/officeDocument/2006/relationships">
+  <p:cSld>
+    <p:bg>
+      <p:bgPr>
+        <a:solidFill>
+          <a:srgbClr val="F4F1EA"/>
+        </a:solidFill>
+      </p:bgPr>
+    </p:bg>
+    <p:spTree>
+      <p:nvGrpSpPr>
+        <p:cNvPr id="1" name=""/>
+        <p:cNvGrpSpPr/>
+        <p:nvPr/>
+      </p:nvGrpSpPr>
+      <p:grpSpPr/>
+      <p:sp>
+        <p:nvSpPr>
+          <p:cNvPr id="2" name="Text 0"/>
+          <p:cNvSpPr/>
+          <p:nvPr/>
+        </p:nvSpPr>
+        <p:spPr>
+          <a:xfrm>
+            <a:off x="812800" y="812800"/>
+            <a:ext cx="10883392" cy="238720"/>
+          </a:xfrm>
+          <a:prstGeom prst="rect">
+            <a:avLst/>
+          </a:prstGeom>
+          <a:noFill/>
+          <a:ln/>
+        </p:spPr>
+        <p:txBody>
+          <a:bodyPr wrap="square" lIns="0" tIns="0" rIns="0" bIns="0" rtlCol="0" anchor="t">
+            <a:normAutofit/>
+          </a:bodyPr>
+          <a:lstStyle/>
+          <a:p>
+            <a:pPr algn="l" indent="0" marL="0">
+              <a:lnSpc>
+                <a:spcPts val="1680"/>
+              </a:lnSpc>
+              <a:buNone/>
+            </a:pPr>
+            <a:r>
+              <a:rPr lang="en-US" sz="1200" b="1" spc="150" kern="0" dirty="0">
+                <a:solidFill>
+                  <a:srgbClr val="2C6A85"/>
+                </a:solidFill>
+                <a:latin typeface="Inter" pitchFamily="34" charset="0"/>
+                <a:ea typeface="Inter" pitchFamily="34" charset="-122"/>
+                <a:cs typeface="Inter" pitchFamily="34" charset="-120"/>
+              </a:rPr>
+              <a:t>15 · DASTLABKI MAʼLUMOTLAR</a:t>
+            </a:r>
+            <a:endParaRPr lang="en-US" sz="1200" dirty="0"/>
+          </a:p>
+        </p:txBody>
+      </p:sp>
+      <p:sp>
+        <p:nvSpPr>
+          <p:cNvPr id="3" name="Text 1"/>
+          <p:cNvSpPr/>
+          <p:nvPr>
+            <p:ph type="title"/>
+          </p:nvPr>
+        </p:nvSpPr>
+        <p:spPr>
+          <a:xfrm>
+            <a:off x="812800" y="1127720"/>
+            <a:ext cx="10883392" cy="472430"/>
+          </a:xfrm>
+          <a:prstGeom prst="rect">
+            <a:avLst/>
+          </a:prstGeom>
+          <a:noFill/>
+          <a:ln/>
+        </p:spPr>
+        <p:txBody>
+          <a:bodyPr wrap="square" lIns="0" tIns="0" rIns="0" bIns="0" rtlCol="0" anchor="t">
+            <a:normAutofit/>
+          </a:bodyPr>
+          <a:lstStyle/>
+          <a:p>
+            <a:pPr algn="l" indent="0" marL="0">
+              <a:lnSpc>
+                <a:spcPts val="3520"/>
+              </a:lnSpc>
+              <a:buNone/>
+            </a:pPr>
+            <a:r>
+              <a:rPr lang="en-US" sz="3200" b="0" i="0" dirty="0">
+                <a:solidFill>
+                  <a:srgbClr val="1D2A24"/>
+                </a:solidFill>
+                <a:latin typeface="Source Serif 4" pitchFamily="18" charset="0"/>
+                <a:ea typeface="Source Serif 4" pitchFamily="18" charset="-122"/>
+                <a:cs typeface="Source Serif 4" pitchFamily="18" charset="-120"/>
+              </a:rPr>
+              <a:t>Namangan viloyati: suv taʼminoti va shoʻr yuvish</a:t>
+            </a:r>
+            <a:endParaRPr lang="en-US" sz="3200" dirty="0"/>
+          </a:p>
+        </p:txBody>
+      </p:sp>
+      <p:sp>
+        <p:nvSpPr>
+          <p:cNvPr id="6" name="Text 3"/>
+          <p:cNvSpPr/>
+          <p:nvPr/>
+        </p:nvSpPr>
+        <p:spPr>
+          <a:xfrm>
+            <a:off x="11137950" y="6238280"/>
+            <a:ext cx="241250" cy="238720"/>
+          </a:xfrm>
+          <a:prstGeom prst="rect">
+            <a:avLst/>
+          </a:prstGeom>
+          <a:noFill/>
+          <a:ln/>
+        </p:spPr>
+        <p:txBody>
+          <a:bodyPr wrap="square" lIns="0" tIns="0" rIns="0" bIns="0" rtlCol="0" anchor="t">
+            <a:normAutofit/>
+          </a:bodyPr>
+          <a:lstStyle/>
+          <a:p>
+            <a:pPr algn="r" indent="0" marL="0">
+              <a:lnSpc>
+                <a:spcPts val="1680"/>
+              </a:lnSpc>
+              <a:buNone/>
+            </a:pPr>
+            <a:r>
+              <a:rPr lang="en-US" sz="1200" dirty="0">
+                <a:solidFill>
+                  <a:srgbClr val="5F6B64"/>
+                </a:solidFill>
+                <a:latin typeface="Inter" pitchFamily="34" charset="0"/>
+                <a:ea typeface="Inter" pitchFamily="34" charset="-122"/>
+                <a:cs typeface="Inter" pitchFamily="34" charset="-120"/>
+              </a:rPr>
+              <a:t>16</a:t>
+            </a:r>
+            <a:endParaRPr lang="en-US" sz="1200" dirty="0"/>
+          </a:p>
+        </p:txBody>
+      </p:sp>
+      <p:sp>
+        <p:nvSpPr>
+          <p:cNvPr id="7" name="TextBox 6"/>
+          <p:cNvSpPr txBox="1"/>
+          <p:nvPr/>
+        </p:nvSpPr>
+        <p:spPr>
+          <a:xfrm>
+            <a:off x="812800" y="1830000"/>
+            <a:ext cx="6200000" cy="260000"/>
+          </a:xfrm>
+          <a:prstGeom prst="rect">
+            <a:avLst/>
+          </a:prstGeom>
+          <a:noFill/>
+        </p:spPr>
+        <p:txBody>
+          <a:bodyPr wrap="square" lIns="0" rIns="0" tIns="0" bIns="0" anchor="t">
+            <a:spAutoFit/>
+          </a:bodyPr>
+          <a:lstStyle/>
+          <a:p>
+            <a:pPr algn="l"/>
+            <a:r>
+              <a:rPr sz="1300" b="1">
+                <a:solidFill>
+                  <a:srgbClr val="2C6A85"/>
+                </a:solidFill>
+                <a:latin typeface="Inter"/>
+              </a:rPr>
+              <a:t>Suv manbalari boʻyicha olingan suv, mln m³ (jami 3 430,6)</a:t>
+            </a:r>
+          </a:p>
+        </p:txBody>
+      </p:sp>
+      <p:graphicFrame>
+        <p:nvGraphicFramePr>
+          <p:cNvPr id="8" name="Chart 7"/>
+          <p:cNvGraphicFramePr>
+            <a:graphicFrameLocks noGrp="1"/>
+          </p:cNvGraphicFramePr>
+          <p:nvPr/>
+        </p:nvGraphicFramePr>
+        <p:xfrm>
+          <a:off x="752800" y="2150000"/>
+          <a:ext cx="6500000" cy="3200000"/>
+        </p:xfrm>
+        <a:graphic>
+          <a:graphicData uri="http://schemas.openxmlformats.org/drawingml/2006/chart">
+            <c:chart xmlns:c="http://schemas.openxmlformats.org/drawingml/2006/chart" r:id="rId2"/>
+          </a:graphicData>
+        </a:graphic>
+      </p:graphicFrame>
+      <p:sp>
+        <p:nvSpPr>
+          <p:cNvPr id="9" name="TextBox 8"/>
+          <p:cNvSpPr txBox="1"/>
+          <p:nvPr/>
+        </p:nvSpPr>
+        <p:spPr>
+          <a:xfrm>
+            <a:off x="812800" y="5450000"/>
+            <a:ext cx="6500000" cy="600000"/>
+          </a:xfrm>
+          <a:prstGeom prst="rect">
+            <a:avLst/>
+          </a:prstGeom>
+          <a:noFill/>
+        </p:spPr>
+        <p:txBody>
+          <a:bodyPr wrap="square" lIns="0" rIns="0" tIns="0" bIns="0" anchor="t">
+            <a:spAutoFit/>
+          </a:bodyPr>
+          <a:lstStyle/>
+          <a:p>
+            <a:pPr algn="l"/>
+            <a:r>
+              <a:rPr sz="1200" b="0">
+                <a:solidFill>
+                  <a:srgbClr val="4C5852"/>
+                </a:solidFill>
+                <a:latin typeface="Inter"/>
+              </a:rPr>
+              <a:t>Zovur suvi (53,9 mln m³) — qaytariladigan suvning sugʻorishda qayta ishlatilishi; u olingan suvning atigi 1,6% ini tashkil etadi.</a:t>
+            </a:r>
+          </a:p>
+        </p:txBody>
+      </p:sp>
+      <p:sp>
+        <p:nvSpPr>
+          <p:cNvPr id="10" name="Rounded Rectangle 9"/>
+          <p:cNvSpPr/>
+          <p:nvPr/>
+        </p:nvSpPr>
+        <p:spPr>
+          <a:xfrm>
+            <a:off x="7700000" y="1830000"/>
+            <a:ext cx="3996192" cy="1230000"/>
+          </a:xfrm>
+          <a:prstGeom prst="roundRect">
+            <a:avLst>
+              <a:gd name="adj" fmla="val 5000"/>
+            </a:avLst>
+          </a:prstGeom>
+          <a:solidFill>
+            <a:srgbClr val="FBF9F4"/>
+          </a:solidFill>
+          <a:ln w="6350">
+            <a:solidFill>
+              <a:srgbClr val="D9D2C3"/>
+            </a:solidFill>
+          </a:ln>
+          <a:effectLst/>
+        </p:spPr>
+        <p:style>
+          <a:lnRef idx="1">
+            <a:schemeClr val="accent1"/>
+          </a:lnRef>
+          <a:fillRef idx="3">
+            <a:schemeClr val="accent1"/>
+          </a:fillRef>
+          <a:effectRef idx="2">
+            <a:schemeClr val="accent1"/>
+          </a:effectRef>
+          <a:fontRef idx="minor">
+            <a:schemeClr val="lt1"/>
+          </a:fontRef>
+        </p:style>
+        <p:txBody>
+          <a:bodyPr rtlCol="0" anchor="ctr"/>
+          <a:lstStyle/>
+          <a:p>
+            <a:pPr algn="ctr"/>
+          </a:p>
+        </p:txBody>
+      </p:sp>
+      <p:sp>
+        <p:nvSpPr>
+          <p:cNvPr id="11" name="TextBox 10"/>
+          <p:cNvSpPr txBox="1"/>
+          <p:nvPr/>
+        </p:nvSpPr>
+        <p:spPr>
+          <a:xfrm>
+            <a:off x="7930000" y="1950000"/>
+            <a:ext cx="3536192" cy="420000"/>
+          </a:xfrm>
+          <a:prstGeom prst="rect">
+            <a:avLst/>
+          </a:prstGeom>
+          <a:noFill/>
+        </p:spPr>
+        <p:txBody>
+          <a:bodyPr wrap="square" lIns="0" rIns="0" tIns="0" bIns="0" anchor="t">
+            <a:spAutoFit/>
+          </a:bodyPr>
+          <a:lstStyle/>
+          <a:p>
+            <a:pPr algn="l"/>
+            <a:r>
+              <a:rPr sz="2400" b="0">
+                <a:solidFill>
+                  <a:srgbClr val="A4521D"/>
+                </a:solidFill>
+                <a:latin typeface="Source Serif 4"/>
+              </a:rPr>
+              <a:t>23,2 ming ga</a:t>
+            </a:r>
+          </a:p>
+        </p:txBody>
+      </p:sp>
+      <p:sp>
+        <p:nvSpPr>
+          <p:cNvPr id="12" name="TextBox 11"/>
+          <p:cNvSpPr txBox="1"/>
+          <p:nvPr/>
+        </p:nvSpPr>
+        <p:spPr>
+          <a:xfrm>
+            <a:off x="7930000" y="2390000"/>
+            <a:ext cx="3536192" cy="620000"/>
+          </a:xfrm>
+          <a:prstGeom prst="rect">
+            <a:avLst/>
+          </a:prstGeom>
+          <a:noFill/>
+        </p:spPr>
+        <p:txBody>
+          <a:bodyPr wrap="square" lIns="0" rIns="0" tIns="0" bIns="0" anchor="t">
+            <a:spAutoFit/>
+          </a:bodyPr>
+          <a:lstStyle/>
+          <a:p>
+            <a:pPr algn="l"/>
+            <a:r>
+              <a:rPr sz="1200" b="0">
+                <a:solidFill>
+                  <a:srgbClr val="4C5852"/>
+                </a:solidFill>
+                <a:latin typeface="Inter"/>
+              </a:rPr>
+              <a:t>Shoʻr yuvish maydoni (sugʻoriladigan 257,9 ming ganing 9%); asosan Mingbuloq (15,2) va Pop (7,7) tumanlari</a:t>
+            </a:r>
+          </a:p>
+        </p:txBody>
+      </p:sp>
+      <p:sp>
+        <p:nvSpPr>
+          <p:cNvPr id="13" name="Rounded Rectangle 12"/>
+          <p:cNvSpPr/>
+          <p:nvPr/>
+        </p:nvSpPr>
+        <p:spPr>
+          <a:xfrm>
+            <a:off x="7700000" y="3210000"/>
+            <a:ext cx="3996192" cy="1230000"/>
+          </a:xfrm>
+          <a:prstGeom prst="roundRect">
+            <a:avLst>
+              <a:gd name="adj" fmla="val 5000"/>
+            </a:avLst>
+          </a:prstGeom>
+          <a:solidFill>
+            <a:srgbClr val="FBF9F4"/>
+          </a:solidFill>
+          <a:ln w="6350">
+            <a:solidFill>
+              <a:srgbClr val="D9D2C3"/>
+            </a:solidFill>
+          </a:ln>
+          <a:effectLst/>
+        </p:spPr>
+        <p:style>
+          <a:lnRef idx="1">
+            <a:schemeClr val="accent1"/>
+          </a:lnRef>
+          <a:fillRef idx="3">
+            <a:schemeClr val="accent1"/>
+          </a:fillRef>
+          <a:effectRef idx="2">
+            <a:schemeClr val="accent1"/>
+          </a:effectRef>
+          <a:fontRef idx="minor">
+            <a:schemeClr val="lt1"/>
+          </a:fontRef>
+        </p:style>
+        <p:txBody>
+          <a:bodyPr rtlCol="0" anchor="ctr"/>
+          <a:lstStyle/>
+          <a:p>
+            <a:pPr algn="ctr"/>
+          </a:p>
+        </p:txBody>
+      </p:sp>
+      <p:sp>
+        <p:nvSpPr>
+          <p:cNvPr id="14" name="TextBox 13"/>
+          <p:cNvSpPr txBox="1"/>
+          <p:nvPr/>
+        </p:nvSpPr>
+        <p:spPr>
+          <a:xfrm>
+            <a:off x="7930000" y="3330000"/>
+            <a:ext cx="3536192" cy="420000"/>
+          </a:xfrm>
+          <a:prstGeom prst="rect">
+            <a:avLst/>
+          </a:prstGeom>
+          <a:noFill/>
+        </p:spPr>
+        <p:txBody>
+          <a:bodyPr wrap="square" lIns="0" rIns="0" tIns="0" bIns="0" anchor="t">
+            <a:spAutoFit/>
+          </a:bodyPr>
+          <a:lstStyle/>
+          <a:p>
+            <a:pPr algn="l"/>
+            <a:r>
+              <a:rPr sz="2400" b="0">
+                <a:solidFill>
+                  <a:srgbClr val="2C6A85"/>
+                </a:solidFill>
+                <a:latin typeface="Source Serif 4"/>
+              </a:rPr>
+              <a:t>+30%</a:t>
+            </a:r>
+          </a:p>
+        </p:txBody>
+      </p:sp>
+      <p:sp>
+        <p:nvSpPr>
+          <p:cNvPr id="15" name="TextBox 14"/>
+          <p:cNvSpPr txBox="1"/>
+          <p:nvPr/>
+        </p:nvSpPr>
+        <p:spPr>
+          <a:xfrm>
+            <a:off x="7930000" y="3770000"/>
+            <a:ext cx="3536192" cy="620000"/>
+          </a:xfrm>
+          <a:prstGeom prst="rect">
+            <a:avLst/>
+          </a:prstGeom>
+          <a:noFill/>
+        </p:spPr>
+        <p:txBody>
+          <a:bodyPr wrap="square" lIns="0" rIns="0" tIns="0" bIns="0" anchor="t">
+            <a:spAutoFit/>
+          </a:bodyPr>
+          <a:lstStyle/>
+          <a:p>
+            <a:pPr algn="l"/>
+            <a:r>
+              <a:rPr sz="1200" b="0">
+                <a:solidFill>
+                  <a:srgbClr val="4C5852"/>
+                </a:solidFill>
+                <a:latin typeface="Inter"/>
+              </a:rPr>
+              <a:t>Suv limiti 2 441 dan 3 181,6 mln m³ gacha oshirilgan; amalda olingan suv oshirilgan limitga teng</a:t>
+            </a:r>
+          </a:p>
+        </p:txBody>
+      </p:sp>
+      <p:sp>
+        <p:nvSpPr>
+          <p:cNvPr id="16" name="Rounded Rectangle 15"/>
+          <p:cNvSpPr/>
+          <p:nvPr/>
+        </p:nvSpPr>
+        <p:spPr>
+          <a:xfrm>
+            <a:off x="7700000" y="4590000"/>
+            <a:ext cx="3996192" cy="1230000"/>
+          </a:xfrm>
+          <a:prstGeom prst="roundRect">
+            <a:avLst>
+              <a:gd name="adj" fmla="val 5000"/>
+            </a:avLst>
+          </a:prstGeom>
+          <a:solidFill>
+            <a:srgbClr val="FBF9F4"/>
+          </a:solidFill>
+          <a:ln w="6350">
+            <a:solidFill>
+              <a:srgbClr val="D9D2C3"/>
+            </a:solidFill>
+          </a:ln>
+          <a:effectLst/>
+        </p:spPr>
+        <p:style>
+          <a:lnRef idx="1">
+            <a:schemeClr val="accent1"/>
+          </a:lnRef>
+          <a:fillRef idx="3">
+            <a:schemeClr val="accent1"/>
+          </a:fillRef>
+          <a:effectRef idx="2">
+            <a:schemeClr val="accent1"/>
+          </a:effectRef>
+          <a:fontRef idx="minor">
+            <a:schemeClr val="lt1"/>
+          </a:fontRef>
+        </p:style>
+        <p:txBody>
+          <a:bodyPr rtlCol="0" anchor="ctr"/>
+          <a:lstStyle/>
+          <a:p>
+            <a:pPr algn="ctr"/>
+          </a:p>
+        </p:txBody>
+      </p:sp>
+      <p:sp>
+        <p:nvSpPr>
+          <p:cNvPr id="17" name="TextBox 16"/>
+          <p:cNvSpPr txBox="1"/>
+          <p:nvPr/>
+        </p:nvSpPr>
+        <p:spPr>
+          <a:xfrm>
+            <a:off x="7930000" y="4710000"/>
+            <a:ext cx="3536192" cy="420000"/>
+          </a:xfrm>
+          <a:prstGeom prst="rect">
+            <a:avLst/>
+          </a:prstGeom>
+          <a:noFill/>
+        </p:spPr>
+        <p:txBody>
+          <a:bodyPr wrap="square" lIns="0" rIns="0" tIns="0" bIns="0" anchor="t">
+            <a:spAutoFit/>
+          </a:bodyPr>
+          <a:lstStyle/>
+          <a:p>
+            <a:pPr algn="l"/>
+            <a:r>
+              <a:rPr sz="2400" b="0">
+                <a:solidFill>
+                  <a:srgbClr val="A4521D"/>
+                </a:solidFill>
+                <a:latin typeface="Source Serif 4"/>
+              </a:rPr>
+              <a:t>115,4 mln m³</a:t>
+            </a:r>
+          </a:p>
+        </p:txBody>
+      </p:sp>
+      <p:sp>
+        <p:nvSpPr>
+          <p:cNvPr id="18" name="TextBox 17"/>
+          <p:cNvSpPr txBox="1"/>
+          <p:nvPr/>
+        </p:nvSpPr>
+        <p:spPr>
+          <a:xfrm>
+            <a:off x="7930000" y="5150000"/>
+            <a:ext cx="3536192" cy="620000"/>
+          </a:xfrm>
+          <a:prstGeom prst="rect">
+            <a:avLst/>
+          </a:prstGeom>
+          <a:noFill/>
+        </p:spPr>
+        <p:txBody>
+          <a:bodyPr wrap="square" lIns="0" rIns="0" tIns="0" bIns="0" anchor="t">
+            <a:spAutoFit/>
+          </a:bodyPr>
+          <a:lstStyle/>
+          <a:p>
+            <a:pPr algn="l"/>
+            <a:r>
+              <a:rPr sz="1200" b="0">
+                <a:solidFill>
+                  <a:srgbClr val="4C5852"/>
+                </a:solidFill>
+                <a:latin typeface="Inter"/>
+              </a:rPr>
+              <a:t>Rezaksoy suv ombori hajmi: 127,5 (2022) → 121,9 (2023) → 115,4 (2024)</a:t>
+            </a:r>
+          </a:p>
+        </p:txBody>
+      </p:sp>
+      <p:sp>
+        <p:nvSpPr>
+          <p:cNvPr id="19" name="TextBox 18"/>
+          <p:cNvSpPr txBox="1"/>
+          <p:nvPr/>
+        </p:nvSpPr>
+        <p:spPr>
+          <a:xfrm>
+            <a:off x="812800" y="6238280"/>
+            <a:ext cx="9800000" cy="240000"/>
+          </a:xfrm>
+          <a:prstGeom prst="rect">
+            <a:avLst/>
+          </a:prstGeom>
+          <a:noFill/>
+        </p:spPr>
+        <p:txBody>
+          <a:bodyPr wrap="square" lIns="0" rIns="0" tIns="0" bIns="0" anchor="t">
+            <a:spAutoFit/>
+          </a:bodyPr>
+          <a:lstStyle/>
+          <a:p>
+            <a:pPr algn="l"/>
+            <a:r>
+              <a:rPr sz="1200" b="0">
+                <a:solidFill>
+                  <a:srgbClr val="5F6B64"/>
+                </a:solidFill>
+                <a:latin typeface="Inter"/>
+              </a:rPr>
+              <a:t>Manba: Norin-Sirdaryo IT_HB hisoboti (2019–2020 yillar) va suv omborlari hajmi (2022–2024)</a:t>
             </a:r>
           </a:p>
         </p:txBody>
@@ -19398,7 +20218,7 @@
                           <a:ea typeface="Inter" pitchFamily="34" charset="-122"/>
                           <a:cs typeface="Inter" pitchFamily="34" charset="-120"/>
                         </a:rPr>
-                        <a:t>Shoʻrlanish darajasi, paxta va gʻalla hosildorligi (tumanlar kesimida)</a:t>
+                        <a:t>Shoʻrlanish, paxta va gʻalla hosildorligi, suv olish va shoʻr yuvish maydoni</a:t>
                       </a:r>
                       <a:endParaRPr lang="en-US" sz="1300" dirty="0">
                         <a:latin typeface="Inter" charset="0"/>
@@ -19466,7 +20286,7 @@
                           <a:ea typeface="Inter" pitchFamily="34" charset="-122"/>
                           <a:cs typeface="Inter" pitchFamily="34" charset="-120"/>
                         </a:rPr>
-                        <a:t>Dinamika va omillar tahlili, modelni kalibrlash</a:t>
+                        <a:t>Dinamika va omillar tahlili, suv balansi, kalibrlash</a:t>
                       </a:r>
                       <a:endParaRPr lang="en-US" sz="1300" dirty="0">
                         <a:latin typeface="Inter" charset="0"/>

</xml_diff>

<commit_message>
Add reservoir regime slide for 2025
Co-Authored-By: Claude Sonnet 5.5 <noreply@anthropic.com>
Claude-Session: https://claude.ai/code/session_01M4MZatV28utL9zTp7saaUz
</commit_message>
<xml_diff>
--- a/Garbiy_Farg_ona_tuproqlari_GAT_asosida_bashoratlash.pptx
+++ b/Garbiy_Farg_ona_tuproqlari_GAT_asosida_bashoratlash.pptx
@@ -21,6 +21,7 @@
     <p:sldId id="276" r:id="rId27"/>
     <p:sldId id="277" r:id="rId28"/>
     <p:sldId id="278" r:id="rId29"/>
+    <p:sldId id="279" r:id="rId30"/>
     <p:sldId id="265" r:id="rId11"/>
     <p:sldId id="266" r:id="rId12"/>
     <p:sldId id="267" r:id="rId13"/>
@@ -332,6 +333,394 @@
       </c:valAx>
     </c:plotArea>
     <c:dispBlanksAs val="gap"/>
+  </c:chart>
+  <c:txPr>
+    <a:bodyPr/>
+    <a:lstStyle/>
+    <a:p>
+      <a:pPr>
+        <a:defRPr sz="1200">
+          <a:solidFill>
+            <a:srgbClr val="4C5852"/>
+          </a:solidFill>
+          <a:latin typeface="Inter"/>
+        </a:defRPr>
+      </a:pPr>
+      <a:endParaRPr lang="en-US"/>
+    </a:p>
+  </c:txPr>
+  <c:externalData r:id="rId1">
+    <c:autoUpdate val="0"/>
+  </c:externalData>
+</c:chartSpace>
+</file>
+
+<file path=ppt/charts/chart10.xml><?xml version="1.0" encoding="utf-8"?>
+<c:chartSpace xmlns:c="http://schemas.openxmlformats.org/drawingml/2006/chart" xmlns:a="http://schemas.openxmlformats.org/drawingml/2006/main" xmlns:r="http://schemas.openxmlformats.org/officeDocument/2006/relationships">
+  <c:date1904 val="0"/>
+  <c:chart>
+    <c:autoTitleDeleted val="1"/>
+    <c:plotArea>
+      <c:lineChart>
+        <c:grouping val="standard"/>
+        <c:varyColors val="0"/>
+        <c:ser>
+          <c:idx val="0"/>
+          <c:order val="0"/>
+          <c:tx>
+            <c:strRef>
+              <c:f>Sheet1!$B$1</c:f>
+              <c:strCache>
+                <c:ptCount val="1"/>
+                <c:pt idx="0">
+                  <c:v>Rezaksoy</c:v>
+                </c:pt>
+              </c:strCache>
+            </c:strRef>
+          </c:tx>
+          <c:spPr>
+            <a:ln w="31750">
+              <a:solidFill>
+                <a:srgbClr val="2C6A85"/>
+              </a:solidFill>
+            </a:ln>
+          </c:spPr>
+          <c:marker>
+            <c:spPr>
+              <a:solidFill>
+                <a:srgbClr val="2C6A85"/>
+              </a:solidFill>
+              <a:ln>
+                <a:solidFill>
+                  <a:srgbClr val="2C6A85"/>
+                </a:solidFill>
+              </a:ln>
+            </c:spPr>
+          </c:marker>
+          <c:cat>
+            <c:strRef>
+              <c:f>Sheet1!$A$2:$A$13</c:f>
+              <c:strCache>
+                <c:ptCount val="12"/>
+                <c:pt idx="0">
+                  <c:v>Yan</c:v>
+                </c:pt>
+                <c:pt idx="1">
+                  <c:v>Fev</c:v>
+                </c:pt>
+                <c:pt idx="2">
+                  <c:v>Mar</c:v>
+                </c:pt>
+                <c:pt idx="3">
+                  <c:v>Apr</c:v>
+                </c:pt>
+                <c:pt idx="4">
+                  <c:v>May</c:v>
+                </c:pt>
+                <c:pt idx="5">
+                  <c:v>Iyn</c:v>
+                </c:pt>
+                <c:pt idx="6">
+                  <c:v>Iyl</c:v>
+                </c:pt>
+                <c:pt idx="7">
+                  <c:v>Avg</c:v>
+                </c:pt>
+                <c:pt idx="8">
+                  <c:v>Sen</c:v>
+                </c:pt>
+                <c:pt idx="9">
+                  <c:v>Okt</c:v>
+                </c:pt>
+                <c:pt idx="10">
+                  <c:v>Noy</c:v>
+                </c:pt>
+                <c:pt idx="11">
+                  <c:v>Dek</c:v>
+                </c:pt>
+              </c:strCache>
+            </c:strRef>
+          </c:cat>
+          <c:val>
+            <c:numRef>
+              <c:f>Sheet1!$B$2:$B$13</c:f>
+              <c:numCache>
+                <c:formatCode>General</c:formatCode>
+                <c:ptCount val="12"/>
+                <c:pt idx="0">
+                  <c:v>128.3</c:v>
+                </c:pt>
+                <c:pt idx="1">
+                  <c:v>134.5</c:v>
+                </c:pt>
+                <c:pt idx="2">
+                  <c:v>138.7</c:v>
+                </c:pt>
+                <c:pt idx="3">
+                  <c:v>144.4</c:v>
+                </c:pt>
+                <c:pt idx="4">
+                  <c:v>138.4</c:v>
+                </c:pt>
+                <c:pt idx="5">
+                  <c:v>127.9</c:v>
+                </c:pt>
+                <c:pt idx="6">
+                  <c:v>103.3</c:v>
+                </c:pt>
+                <c:pt idx="7">
+                  <c:v>91.6</c:v>
+                </c:pt>
+                <c:pt idx="8">
+                  <c:v>90.4</c:v>
+                </c:pt>
+                <c:pt idx="9">
+                  <c:v>92.6</c:v>
+                </c:pt>
+                <c:pt idx="10">
+                  <c:v>105.5</c:v>
+                </c:pt>
+                <c:pt idx="11">
+                  <c:v>110.4</c:v>
+                </c:pt>
+              </c:numCache>
+            </c:numRef>
+          </c:val>
+          <c:smooth val="0"/>
+        </c:ser>
+        <c:ser>
+          <c:idx val="1"/>
+          <c:order val="1"/>
+          <c:tx>
+            <c:strRef>
+              <c:f>Sheet1!$C$1</c:f>
+              <c:strCache>
+                <c:ptCount val="1"/>
+                <c:pt idx="0">
+                  <c:v>Kosonsoy</c:v>
+                </c:pt>
+              </c:strCache>
+            </c:strRef>
+          </c:tx>
+          <c:spPr>
+            <a:ln w="31750">
+              <a:solidFill>
+                <a:srgbClr val="A4521D"/>
+              </a:solidFill>
+            </a:ln>
+          </c:spPr>
+          <c:marker>
+            <c:spPr>
+              <a:solidFill>
+                <a:srgbClr val="A4521D"/>
+              </a:solidFill>
+              <a:ln>
+                <a:solidFill>
+                  <a:srgbClr val="A4521D"/>
+                </a:solidFill>
+              </a:ln>
+            </c:spPr>
+          </c:marker>
+          <c:cat>
+            <c:strRef>
+              <c:f>Sheet1!$A$2:$A$13</c:f>
+              <c:strCache>
+                <c:ptCount val="12"/>
+                <c:pt idx="0">
+                  <c:v>Yan</c:v>
+                </c:pt>
+                <c:pt idx="1">
+                  <c:v>Fev</c:v>
+                </c:pt>
+                <c:pt idx="2">
+                  <c:v>Mar</c:v>
+                </c:pt>
+                <c:pt idx="3">
+                  <c:v>Apr</c:v>
+                </c:pt>
+                <c:pt idx="4">
+                  <c:v>May</c:v>
+                </c:pt>
+                <c:pt idx="5">
+                  <c:v>Iyn</c:v>
+                </c:pt>
+                <c:pt idx="6">
+                  <c:v>Iyl</c:v>
+                </c:pt>
+                <c:pt idx="7">
+                  <c:v>Avg</c:v>
+                </c:pt>
+                <c:pt idx="8">
+                  <c:v>Sen</c:v>
+                </c:pt>
+                <c:pt idx="9">
+                  <c:v>Okt</c:v>
+                </c:pt>
+                <c:pt idx="10">
+                  <c:v>Noy</c:v>
+                </c:pt>
+                <c:pt idx="11">
+                  <c:v>Dek</c:v>
+                </c:pt>
+              </c:strCache>
+            </c:strRef>
+          </c:cat>
+          <c:val>
+            <c:numRef>
+              <c:f>Sheet1!$C$2:$C$13</c:f>
+              <c:numCache>
+                <c:formatCode>General</c:formatCode>
+                <c:ptCount val="12"/>
+                <c:pt idx="0">
+                  <c:v>71.2</c:v>
+                </c:pt>
+                <c:pt idx="1">
+                  <c:v>77.8</c:v>
+                </c:pt>
+                <c:pt idx="2">
+                  <c:v>62.6</c:v>
+                </c:pt>
+                <c:pt idx="3">
+                  <c:v>71.5</c:v>
+                </c:pt>
+                <c:pt idx="4">
+                  <c:v>88.1</c:v>
+                </c:pt>
+                <c:pt idx="5">
+                  <c:v>80.1</c:v>
+                </c:pt>
+                <c:pt idx="6">
+                  <c:v>47.6</c:v>
+                </c:pt>
+                <c:pt idx="7">
+                  <c:v>27.4</c:v>
+                </c:pt>
+                <c:pt idx="8">
+                  <c:v>24.1</c:v>
+                </c:pt>
+                <c:pt idx="9">
+                  <c:v>18.0</c:v>
+                </c:pt>
+                <c:pt idx="10">
+                  <c:v>15.9</c:v>
+                </c:pt>
+                <c:pt idx="11">
+                  <c:v>20.7</c:v>
+                </c:pt>
+              </c:numCache>
+            </c:numRef>
+          </c:val>
+          <c:smooth val="0"/>
+        </c:ser>
+        <c:marker val="1"/>
+        <c:smooth val="0"/>
+        <c:axId val="2118791784"/>
+        <c:axId val="2140495176"/>
+      </c:lineChart>
+      <c:catAx>
+        <c:axId val="2118791784"/>
+        <c:scaling>
+          <c:orientation val="minMax"/>
+        </c:scaling>
+        <c:delete val="0"/>
+        <c:axPos val="b"/>
+        <c:majorTickMark val="out"/>
+        <c:minorTickMark val="none"/>
+        <c:tickLblPos val="nextTo"/>
+        <c:spPr>
+          <a:ln>
+            <a:solidFill>
+              <a:srgbClr val="B5B2AD"/>
+            </a:solidFill>
+          </a:ln>
+        </c:spPr>
+        <c:txPr>
+          <a:bodyPr/>
+          <a:lstStyle/>
+          <a:p>
+            <a:pPr>
+              <a:defRPr sz="1200">
+                <a:solidFill>
+                  <a:srgbClr val="4C5852"/>
+                </a:solidFill>
+                <a:latin typeface="Inter"/>
+              </a:defRPr>
+            </a:pPr>
+          </a:p>
+        </c:txPr>
+        <c:crossAx val="2140495176"/>
+        <c:crosses val="autoZero"/>
+        <c:auto val="1"/>
+        <c:lblAlgn val="ctr"/>
+        <c:lblOffset val="100"/>
+        <c:noMultiLvlLbl val="0"/>
+      </c:catAx>
+      <c:valAx>
+        <c:axId val="2140495176"/>
+        <c:scaling>
+          <c:max val="160.0"/>
+          <c:min val="0.0"/>
+        </c:scaling>
+        <c:delete val="0"/>
+        <c:axPos val="l"/>
+        <c:majorGridlines>
+          <c:spPr>
+            <a:ln>
+              <a:solidFill>
+                <a:srgbClr val="D9D2C3"/>
+              </a:solidFill>
+            </a:ln>
+          </c:spPr>
+        </c:majorGridlines>
+        <c:majorTickMark val="out"/>
+        <c:minorTickMark val="none"/>
+        <c:tickLblPos val="nextTo"/>
+        <c:spPr>
+          <a:ln>
+            <a:noFill/>
+          </a:ln>
+        </c:spPr>
+        <c:txPr>
+          <a:bodyPr/>
+          <a:lstStyle/>
+          <a:p>
+            <a:pPr>
+              <a:defRPr sz="1200">
+                <a:solidFill>
+                  <a:srgbClr val="4C5852"/>
+                </a:solidFill>
+                <a:latin typeface="Inter"/>
+              </a:defRPr>
+            </a:pPr>
+          </a:p>
+        </c:txPr>
+        <c:crossAx val="2118791784"/>
+        <c:crosses val="autoZero"/>
+        <c:majorUnit val="40.0"/>
+      </c:valAx>
+    </c:plotArea>
+    <c:legend>
+      <c:legendPos val="t"/>
+      <c:layout/>
+      <c:overlay val="0"/>
+      <c:txPr>
+        <a:bodyPr/>
+        <a:lstStyle/>
+        <a:p>
+          <a:pPr>
+            <a:defRPr sz="1200">
+              <a:solidFill>
+                <a:srgbClr val="4C5852"/>
+              </a:solidFill>
+              <a:latin typeface="Inter"/>
+            </a:defRPr>
+          </a:pPr>
+        </a:p>
+      </c:txPr>
+    </c:legend>
+    <c:plotVisOnly val="1"/>
+    <c:dispBlanksAs val="gap"/>
+    <c:showDLblsOverMax val="0"/>
   </c:chart>
   <c:txPr>
     <a:bodyPr/>
@@ -4984,7 +5373,7 @@
                 <a:ea typeface="Inter" pitchFamily="34" charset="-122"/>
                 <a:cs typeface="Inter" pitchFamily="34" charset="-120"/>
               </a:rPr>
-              <a:t>16 · DISSERTATSIYA TUZILISHI</a:t>
+              <a:t>17 · DISSERTATSIYA TUZILISHI</a:t>
             </a:r>
             <a:endParaRPr lang="en-US" sz="1200" dirty="0"/>
           </a:p>
@@ -5783,7 +6172,7 @@
                 <a:ea typeface="Inter" pitchFamily="34" charset="-122"/>
                 <a:cs typeface="Inter" pitchFamily="34" charset="-120"/>
               </a:rPr>
-              <a:t>17</a:t>
+              <a:t>18</a:t>
             </a:r>
             <a:endParaRPr lang="en-US" sz="1200" dirty="0"/>
           </a:p>
@@ -5859,7 +6248,7 @@
                 <a:ea typeface="Inter" pitchFamily="34" charset="-122"/>
                 <a:cs typeface="Inter" pitchFamily="34" charset="-120"/>
               </a:rPr>
-              <a:t>17 · DISSERTATSIYA TUZILISHI</a:t>
+              <a:t>18 · DISSERTATSIYA TUZILISHI</a:t>
             </a:r>
             <a:endParaRPr lang="en-US" sz="1200" dirty="0"/>
           </a:p>
@@ -6891,7 +7280,7 @@
                 <a:ea typeface="Inter" pitchFamily="34" charset="-122"/>
                 <a:cs typeface="Inter" pitchFamily="34" charset="-120"/>
               </a:rPr>
-              <a:t>18</a:t>
+              <a:t>19</a:t>
             </a:r>
             <a:endParaRPr lang="en-US" sz="1200" dirty="0"/>
           </a:p>
@@ -6967,7 +7356,7 @@
                 <a:ea typeface="Inter" pitchFamily="34" charset="-122"/>
                 <a:cs typeface="Inter" pitchFamily="34" charset="-120"/>
               </a:rPr>
-              <a:t>18 · DISSERTATSIYA TUZILISHI</a:t>
+              <a:t>19 · DISSERTATSIYA TUZILISHI</a:t>
             </a:r>
             <a:endParaRPr lang="en-US" sz="1200" dirty="0"/>
           </a:p>
@@ -7994,7 +8383,7 @@
                 <a:ea typeface="Inter" pitchFamily="34" charset="-122"/>
                 <a:cs typeface="Inter" pitchFamily="34" charset="-120"/>
               </a:rPr>
-              <a:t>19</a:t>
+              <a:t>20</a:t>
             </a:r>
             <a:endParaRPr lang="en-US" sz="1200" dirty="0"/>
           </a:p>
@@ -8070,7 +8459,7 @@
                 <a:ea typeface="Inter" pitchFamily="34" charset="-122"/>
                 <a:cs typeface="Inter" pitchFamily="34" charset="-120"/>
               </a:rPr>
-              <a:t>19 · NATIJALAR VA REJA</a:t>
+              <a:t>20 · NATIJALAR VA REJA</a:t>
             </a:r>
             <a:endParaRPr lang="en-US" sz="1200" dirty="0"/>
           </a:p>
@@ -8808,7 +9197,7 @@
                 <a:ea typeface="Inter" pitchFamily="34" charset="-122"/>
                 <a:cs typeface="Inter" pitchFamily="34" charset="-120"/>
               </a:rPr>
-              <a:t>20</a:t>
+              <a:t>21</a:t>
             </a:r>
             <a:endParaRPr lang="en-US" sz="1200" dirty="0"/>
           </a:p>
@@ -8884,7 +9273,7 @@
                 <a:ea typeface="Inter" pitchFamily="34" charset="-122"/>
                 <a:cs typeface="Inter" pitchFamily="34" charset="-120"/>
               </a:rPr>
-              <a:t>20 · NATIJALAR VA REJA</a:t>
+              <a:t>21 · NATIJALAR VA REJA</a:t>
             </a:r>
             <a:endParaRPr lang="en-US" sz="1200" dirty="0"/>
           </a:p>
@@ -9910,7 +10299,7 @@
                 <a:ea typeface="Inter" pitchFamily="34" charset="-122"/>
                 <a:cs typeface="Inter" pitchFamily="34" charset="-120"/>
               </a:rPr>
-              <a:t>21</a:t>
+              <a:t>22</a:t>
             </a:r>
             <a:endParaRPr lang="en-US" sz="1200" dirty="0"/>
           </a:p>
@@ -9986,7 +10375,7 @@
                 <a:ea typeface="Inter" pitchFamily="34" charset="-122"/>
                 <a:cs typeface="Inter" pitchFamily="34" charset="-120"/>
               </a:rPr>
-              <a:t>21 · NATIJALAR VA REJA</a:t>
+              <a:t>22 · NATIJALAR VA REJA</a:t>
             </a:r>
             <a:endParaRPr lang="en-US" sz="1200" dirty="0"/>
           </a:p>
@@ -10598,7 +10987,7 @@
                 <a:ea typeface="Inter" pitchFamily="34" charset="-122"/>
                 <a:cs typeface="Inter" pitchFamily="34" charset="-120"/>
               </a:rPr>
-              <a:t>22</a:t>
+              <a:t>23</a:t>
             </a:r>
             <a:endParaRPr lang="en-US" sz="1200" dirty="0"/>
           </a:p>
@@ -15902,6 +16291,607 @@
                 <a:latin typeface="Inter"/>
               </a:rPr>
               <a:t>Manba: Norin-Sirdaryo IT_HB hisoboti (2019–2020 yillar) va suv omborlari hajmi (2022–2024)</a:t>
+            </a:r>
+          </a:p>
+        </p:txBody>
+      </p:sp>
+    </p:spTree>
+  </p:cSld>
+  <p:clrMapOvr>
+    <a:masterClrMapping/>
+  </p:clrMapOvr>
+</p:sld>
+</file>
+
+<file path=ppt/slides/slide24.xml><?xml version="1.0" encoding="utf-8"?>
+<p:sld xmlns:a="http://schemas.openxmlformats.org/drawingml/2006/main" xmlns:p="http://schemas.openxmlformats.org/presentationml/2006/main" xmlns:r="http://schemas.openxmlformats.org/officeDocument/2006/relationships">
+  <p:cSld>
+    <p:bg>
+      <p:bgPr>
+        <a:solidFill>
+          <a:srgbClr val="F4F1EA"/>
+        </a:solidFill>
+      </p:bgPr>
+    </p:bg>
+    <p:spTree>
+      <p:nvGrpSpPr>
+        <p:cNvPr id="1" name=""/>
+        <p:cNvGrpSpPr/>
+        <p:nvPr/>
+      </p:nvGrpSpPr>
+      <p:grpSpPr/>
+      <p:sp>
+        <p:nvSpPr>
+          <p:cNvPr id="2" name="Text 0"/>
+          <p:cNvSpPr/>
+          <p:nvPr/>
+        </p:nvSpPr>
+        <p:spPr>
+          <a:xfrm>
+            <a:off x="812800" y="812800"/>
+            <a:ext cx="10883392" cy="238720"/>
+          </a:xfrm>
+          <a:prstGeom prst="rect">
+            <a:avLst/>
+          </a:prstGeom>
+          <a:noFill/>
+          <a:ln/>
+        </p:spPr>
+        <p:txBody>
+          <a:bodyPr wrap="square" lIns="0" tIns="0" rIns="0" bIns="0" rtlCol="0" anchor="t">
+            <a:normAutofit/>
+          </a:bodyPr>
+          <a:lstStyle/>
+          <a:p>
+            <a:pPr algn="l" indent="0" marL="0">
+              <a:lnSpc>
+                <a:spcPts val="1680"/>
+              </a:lnSpc>
+              <a:buNone/>
+            </a:pPr>
+            <a:r>
+              <a:rPr lang="en-US" sz="1200" b="1" spc="150" kern="0" dirty="0">
+                <a:solidFill>
+                  <a:srgbClr val="2C6A85"/>
+                </a:solidFill>
+                <a:latin typeface="Inter" pitchFamily="34" charset="0"/>
+                <a:ea typeface="Inter" pitchFamily="34" charset="-122"/>
+                <a:cs typeface="Inter" pitchFamily="34" charset="-120"/>
+              </a:rPr>
+              <a:t>16 · DASTLABKI MAʼLUMOTLAR</a:t>
+            </a:r>
+            <a:endParaRPr lang="en-US" sz="1200" dirty="0"/>
+          </a:p>
+        </p:txBody>
+      </p:sp>
+      <p:sp>
+        <p:nvSpPr>
+          <p:cNvPr id="3" name="Text 1"/>
+          <p:cNvSpPr/>
+          <p:nvPr>
+            <p:ph type="title"/>
+          </p:nvPr>
+        </p:nvSpPr>
+        <p:spPr>
+          <a:xfrm>
+            <a:off x="812800" y="1127720"/>
+            <a:ext cx="10883392" cy="472430"/>
+          </a:xfrm>
+          <a:prstGeom prst="rect">
+            <a:avLst/>
+          </a:prstGeom>
+          <a:noFill/>
+          <a:ln/>
+        </p:spPr>
+        <p:txBody>
+          <a:bodyPr wrap="square" lIns="0" tIns="0" rIns="0" bIns="0" rtlCol="0" anchor="t">
+            <a:normAutofit/>
+          </a:bodyPr>
+          <a:lstStyle/>
+          <a:p>
+            <a:pPr algn="l" indent="0" marL="0">
+              <a:lnSpc>
+                <a:spcPts val="3520"/>
+              </a:lnSpc>
+              <a:buNone/>
+            </a:pPr>
+            <a:r>
+              <a:rPr lang="en-US" sz="3200" b="0" i="0" dirty="0">
+                <a:solidFill>
+                  <a:srgbClr val="1D2A24"/>
+                </a:solidFill>
+                <a:latin typeface="Source Serif 4" pitchFamily="18" charset="0"/>
+                <a:ea typeface="Source Serif 4" pitchFamily="18" charset="-122"/>
+                <a:cs typeface="Source Serif 4" pitchFamily="18" charset="-120"/>
+              </a:rPr>
+              <a:t>Suv omborlari rejimi, 2025 yil</a:t>
+            </a:r>
+            <a:endParaRPr lang="en-US" sz="3200" dirty="0"/>
+          </a:p>
+        </p:txBody>
+      </p:sp>
+      <p:sp>
+        <p:nvSpPr>
+          <p:cNvPr id="6" name="Text 3"/>
+          <p:cNvSpPr/>
+          <p:nvPr/>
+        </p:nvSpPr>
+        <p:spPr>
+          <a:xfrm>
+            <a:off x="11137950" y="6238280"/>
+            <a:ext cx="241250" cy="238720"/>
+          </a:xfrm>
+          <a:prstGeom prst="rect">
+            <a:avLst/>
+          </a:prstGeom>
+          <a:noFill/>
+          <a:ln/>
+        </p:spPr>
+        <p:txBody>
+          <a:bodyPr wrap="square" lIns="0" tIns="0" rIns="0" bIns="0" rtlCol="0" anchor="t">
+            <a:normAutofit/>
+          </a:bodyPr>
+          <a:lstStyle/>
+          <a:p>
+            <a:pPr algn="r" indent="0" marL="0">
+              <a:lnSpc>
+                <a:spcPts val="1680"/>
+              </a:lnSpc>
+              <a:buNone/>
+            </a:pPr>
+            <a:r>
+              <a:rPr lang="en-US" sz="1200" dirty="0">
+                <a:solidFill>
+                  <a:srgbClr val="5F6B64"/>
+                </a:solidFill>
+                <a:latin typeface="Inter" pitchFamily="34" charset="0"/>
+                <a:ea typeface="Inter" pitchFamily="34" charset="-122"/>
+                <a:cs typeface="Inter" pitchFamily="34" charset="-120"/>
+              </a:rPr>
+              <a:t>17</a:t>
+            </a:r>
+            <a:endParaRPr lang="en-US" sz="1200" dirty="0"/>
+          </a:p>
+        </p:txBody>
+      </p:sp>
+      <p:sp>
+        <p:nvSpPr>
+          <p:cNvPr id="7" name="TextBox 6"/>
+          <p:cNvSpPr txBox="1"/>
+          <p:nvPr/>
+        </p:nvSpPr>
+        <p:spPr>
+          <a:xfrm>
+            <a:off x="812800" y="1830000"/>
+            <a:ext cx="6600000" cy="260000"/>
+          </a:xfrm>
+          <a:prstGeom prst="rect">
+            <a:avLst/>
+          </a:prstGeom>
+          <a:noFill/>
+        </p:spPr>
+        <p:txBody>
+          <a:bodyPr wrap="square" lIns="0" rIns="0" tIns="0" bIns="0" anchor="t">
+            <a:spAutoFit/>
+          </a:bodyPr>
+          <a:lstStyle/>
+          <a:p>
+            <a:pPr algn="l"/>
+            <a:r>
+              <a:rPr sz="1300" b="1">
+                <a:solidFill>
+                  <a:srgbClr val="2C6A85"/>
+                </a:solidFill>
+                <a:latin typeface="Inter"/>
+              </a:rPr>
+              <a:t>Suv ombori hajmi, mln m³ (oy oxiriga)</a:t>
+            </a:r>
+          </a:p>
+        </p:txBody>
+      </p:sp>
+      <p:graphicFrame>
+        <p:nvGraphicFramePr>
+          <p:cNvPr id="8" name="Chart 7"/>
+          <p:cNvGraphicFramePr>
+            <a:graphicFrameLocks noGrp="1"/>
+          </p:cNvGraphicFramePr>
+          <p:nvPr/>
+        </p:nvGraphicFramePr>
+        <p:xfrm>
+          <a:off x="752800" y="2100000"/>
+          <a:ext cx="6700000" cy="3950000"/>
+        </p:xfrm>
+        <a:graphic>
+          <a:graphicData uri="http://schemas.openxmlformats.org/drawingml/2006/chart">
+            <c:chart xmlns:c="http://schemas.openxmlformats.org/drawingml/2006/chart" r:id="rId2"/>
+          </a:graphicData>
+        </a:graphic>
+      </p:graphicFrame>
+      <p:sp>
+        <p:nvSpPr>
+          <p:cNvPr id="9" name="Rounded Rectangle 8"/>
+          <p:cNvSpPr/>
+          <p:nvPr/>
+        </p:nvSpPr>
+        <p:spPr>
+          <a:xfrm>
+            <a:off x="7700000" y="1830000"/>
+            <a:ext cx="3996192" cy="1230000"/>
+          </a:xfrm>
+          <a:prstGeom prst="roundRect">
+            <a:avLst>
+              <a:gd name="adj" fmla="val 5000"/>
+            </a:avLst>
+          </a:prstGeom>
+          <a:solidFill>
+            <a:srgbClr val="FBF9F4"/>
+          </a:solidFill>
+          <a:ln w="6350">
+            <a:solidFill>
+              <a:srgbClr val="D9D2C3"/>
+            </a:solidFill>
+          </a:ln>
+          <a:effectLst/>
+        </p:spPr>
+        <p:style>
+          <a:lnRef idx="1">
+            <a:schemeClr val="accent1"/>
+          </a:lnRef>
+          <a:fillRef idx="3">
+            <a:schemeClr val="accent1"/>
+          </a:fillRef>
+          <a:effectRef idx="2">
+            <a:schemeClr val="accent1"/>
+          </a:effectRef>
+          <a:fontRef idx="minor">
+            <a:schemeClr val="lt1"/>
+          </a:fontRef>
+        </p:style>
+        <p:txBody>
+          <a:bodyPr rtlCol="0" anchor="ctr"/>
+          <a:lstStyle/>
+          <a:p>
+            <a:pPr algn="ctr"/>
+          </a:p>
+        </p:txBody>
+      </p:sp>
+      <p:sp>
+        <p:nvSpPr>
+          <p:cNvPr id="10" name="TextBox 9"/>
+          <p:cNvSpPr txBox="1"/>
+          <p:nvPr/>
+        </p:nvSpPr>
+        <p:spPr>
+          <a:xfrm>
+            <a:off x="7930000" y="1950000"/>
+            <a:ext cx="3536192" cy="420000"/>
+          </a:xfrm>
+          <a:prstGeom prst="rect">
+            <a:avLst/>
+          </a:prstGeom>
+          <a:noFill/>
+        </p:spPr>
+        <p:txBody>
+          <a:bodyPr wrap="square" lIns="0" rIns="0" tIns="0" bIns="0" anchor="t">
+            <a:spAutoFit/>
+          </a:bodyPr>
+          <a:lstStyle/>
+          <a:p>
+            <a:pPr algn="l"/>
+            <a:r>
+              <a:rPr sz="2400" b="0">
+                <a:solidFill>
+                  <a:srgbClr val="A4521D"/>
+                </a:solidFill>
+                <a:latin typeface="Source Serif 4"/>
+              </a:rPr>
+              <a:t>144,4 mln m³</a:t>
+            </a:r>
+          </a:p>
+        </p:txBody>
+      </p:sp>
+      <p:sp>
+        <p:nvSpPr>
+          <p:cNvPr id="11" name="TextBox 10"/>
+          <p:cNvSpPr txBox="1"/>
+          <p:nvPr/>
+        </p:nvSpPr>
+        <p:spPr>
+          <a:xfrm>
+            <a:off x="7930000" y="2390000"/>
+            <a:ext cx="3536192" cy="620000"/>
+          </a:xfrm>
+          <a:prstGeom prst="rect">
+            <a:avLst/>
+          </a:prstGeom>
+          <a:noFill/>
+        </p:spPr>
+        <p:txBody>
+          <a:bodyPr wrap="square" lIns="0" rIns="0" tIns="0" bIns="0" anchor="t">
+            <a:spAutoFit/>
+          </a:bodyPr>
+          <a:lstStyle/>
+          <a:p>
+            <a:pPr algn="l"/>
+            <a:r>
+              <a:rPr sz="1200" b="0">
+                <a:solidFill>
+                  <a:srgbClr val="4C5852"/>
+                </a:solidFill>
+                <a:latin typeface="Inter"/>
+              </a:rPr>
+              <a:t>Rezaksoy hajmining eng yuqori qiymati (aprel); eng past — 91,6 mln m³ (avgust)</a:t>
+            </a:r>
+          </a:p>
+        </p:txBody>
+      </p:sp>
+      <p:sp>
+        <p:nvSpPr>
+          <p:cNvPr id="12" name="Rounded Rectangle 11"/>
+          <p:cNvSpPr/>
+          <p:nvPr/>
+        </p:nvSpPr>
+        <p:spPr>
+          <a:xfrm>
+            <a:off x="7700000" y="3210000"/>
+            <a:ext cx="3996192" cy="1230000"/>
+          </a:xfrm>
+          <a:prstGeom prst="roundRect">
+            <a:avLst>
+              <a:gd name="adj" fmla="val 5000"/>
+            </a:avLst>
+          </a:prstGeom>
+          <a:solidFill>
+            <a:srgbClr val="FBF9F4"/>
+          </a:solidFill>
+          <a:ln w="6350">
+            <a:solidFill>
+              <a:srgbClr val="D9D2C3"/>
+            </a:solidFill>
+          </a:ln>
+          <a:effectLst/>
+        </p:spPr>
+        <p:style>
+          <a:lnRef idx="1">
+            <a:schemeClr val="accent1"/>
+          </a:lnRef>
+          <a:fillRef idx="3">
+            <a:schemeClr val="accent1"/>
+          </a:fillRef>
+          <a:effectRef idx="2">
+            <a:schemeClr val="accent1"/>
+          </a:effectRef>
+          <a:fontRef idx="minor">
+            <a:schemeClr val="lt1"/>
+          </a:fontRef>
+        </p:style>
+        <p:txBody>
+          <a:bodyPr rtlCol="0" anchor="ctr"/>
+          <a:lstStyle/>
+          <a:p>
+            <a:pPr algn="ctr"/>
+          </a:p>
+        </p:txBody>
+      </p:sp>
+      <p:sp>
+        <p:nvSpPr>
+          <p:cNvPr id="13" name="TextBox 12"/>
+          <p:cNvSpPr txBox="1"/>
+          <p:nvPr/>
+        </p:nvSpPr>
+        <p:spPr>
+          <a:xfrm>
+            <a:off x="7930000" y="3330000"/>
+            <a:ext cx="3536192" cy="420000"/>
+          </a:xfrm>
+          <a:prstGeom prst="rect">
+            <a:avLst/>
+          </a:prstGeom>
+          <a:noFill/>
+        </p:spPr>
+        <p:txBody>
+          <a:bodyPr wrap="square" lIns="0" rIns="0" tIns="0" bIns="0" anchor="t">
+            <a:spAutoFit/>
+          </a:bodyPr>
+          <a:lstStyle/>
+          <a:p>
+            <a:pPr algn="l"/>
+            <a:r>
+              <a:rPr sz="2400" b="0">
+                <a:solidFill>
+                  <a:srgbClr val="2C6A85"/>
+                </a:solidFill>
+                <a:latin typeface="Source Serif 4"/>
+              </a:rPr>
+              <a:t>88,1 → 15,9</a:t>
+            </a:r>
+          </a:p>
+        </p:txBody>
+      </p:sp>
+      <p:sp>
+        <p:nvSpPr>
+          <p:cNvPr id="14" name="TextBox 13"/>
+          <p:cNvSpPr txBox="1"/>
+          <p:nvPr/>
+        </p:nvSpPr>
+        <p:spPr>
+          <a:xfrm>
+            <a:off x="7930000" y="3770000"/>
+            <a:ext cx="3536192" cy="620000"/>
+          </a:xfrm>
+          <a:prstGeom prst="rect">
+            <a:avLst/>
+          </a:prstGeom>
+          <a:noFill/>
+        </p:spPr>
+        <p:txBody>
+          <a:bodyPr wrap="square" lIns="0" rIns="0" tIns="0" bIns="0" anchor="t">
+            <a:spAutoFit/>
+          </a:bodyPr>
+          <a:lstStyle/>
+          <a:p>
+            <a:pPr algn="l"/>
+            <a:r>
+              <a:rPr sz="1200" b="0">
+                <a:solidFill>
+                  <a:srgbClr val="4C5852"/>
+                </a:solidFill>
+                <a:latin typeface="Inter"/>
+              </a:rPr>
+              <a:t>Kosonsoy hajmi maydan noyabrgacha, mln m³: ekin mavsumida hajm keskin kamayadi</a:t>
+            </a:r>
+          </a:p>
+        </p:txBody>
+      </p:sp>
+      <p:sp>
+        <p:nvSpPr>
+          <p:cNvPr id="15" name="Rounded Rectangle 14"/>
+          <p:cNvSpPr/>
+          <p:nvPr/>
+        </p:nvSpPr>
+        <p:spPr>
+          <a:xfrm>
+            <a:off x="7700000" y="4590000"/>
+            <a:ext cx="3996192" cy="1230000"/>
+          </a:xfrm>
+          <a:prstGeom prst="roundRect">
+            <a:avLst>
+              <a:gd name="adj" fmla="val 5000"/>
+            </a:avLst>
+          </a:prstGeom>
+          <a:solidFill>
+            <a:srgbClr val="FBF9F4"/>
+          </a:solidFill>
+          <a:ln w="6350">
+            <a:solidFill>
+              <a:srgbClr val="D9D2C3"/>
+            </a:solidFill>
+          </a:ln>
+          <a:effectLst/>
+        </p:spPr>
+        <p:style>
+          <a:lnRef idx="1">
+            <a:schemeClr val="accent1"/>
+          </a:lnRef>
+          <a:fillRef idx="3">
+            <a:schemeClr val="accent1"/>
+          </a:fillRef>
+          <a:effectRef idx="2">
+            <a:schemeClr val="accent1"/>
+          </a:effectRef>
+          <a:fontRef idx="minor">
+            <a:schemeClr val="lt1"/>
+          </a:fontRef>
+        </p:style>
+        <p:txBody>
+          <a:bodyPr rtlCol="0" anchor="ctr"/>
+          <a:lstStyle/>
+          <a:p>
+            <a:pPr algn="ctr"/>
+          </a:p>
+        </p:txBody>
+      </p:sp>
+      <p:sp>
+        <p:nvSpPr>
+          <p:cNvPr id="16" name="TextBox 15"/>
+          <p:cNvSpPr txBox="1"/>
+          <p:nvPr/>
+        </p:nvSpPr>
+        <p:spPr>
+          <a:xfrm>
+            <a:off x="7930000" y="4710000"/>
+            <a:ext cx="3536192" cy="420000"/>
+          </a:xfrm>
+          <a:prstGeom prst="rect">
+            <a:avLst/>
+          </a:prstGeom>
+          <a:noFill/>
+        </p:spPr>
+        <p:txBody>
+          <a:bodyPr wrap="square" lIns="0" rIns="0" tIns="0" bIns="0" anchor="t">
+            <a:spAutoFit/>
+          </a:bodyPr>
+          <a:lstStyle/>
+          <a:p>
+            <a:pPr algn="l"/>
+            <a:r>
+              <a:rPr sz="2400" b="0">
+                <a:solidFill>
+                  <a:srgbClr val="A4521D"/>
+                </a:solidFill>
+                <a:latin typeface="Source Serif 4"/>
+              </a:rPr>
+              <a:t>457 mln m³</a:t>
+            </a:r>
+          </a:p>
+        </p:txBody>
+      </p:sp>
+      <p:sp>
+        <p:nvSpPr>
+          <p:cNvPr id="17" name="TextBox 16"/>
+          <p:cNvSpPr txBox="1"/>
+          <p:nvPr/>
+        </p:nvSpPr>
+        <p:spPr>
+          <a:xfrm>
+            <a:off x="7930000" y="5150000"/>
+            <a:ext cx="3536192" cy="620000"/>
+          </a:xfrm>
+          <a:prstGeom prst="rect">
+            <a:avLst/>
+          </a:prstGeom>
+          <a:noFill/>
+        </p:spPr>
+        <p:txBody>
+          <a:bodyPr wrap="square" lIns="0" rIns="0" tIns="0" bIns="0" anchor="t">
+            <a:spAutoFit/>
+          </a:bodyPr>
+          <a:lstStyle/>
+          <a:p>
+            <a:pPr algn="l"/>
+            <a:r>
+              <a:rPr sz="1200" b="0">
+                <a:solidFill>
+                  <a:srgbClr val="4C5852"/>
+                </a:solidFill>
+                <a:latin typeface="Inter"/>
+              </a:rPr>
+              <a:t>Texnik tavsifnomadagi 9 ta suv omborining toʻla hajmi (foydali — 439,8 mln m³)</a:t>
+            </a:r>
+          </a:p>
+        </p:txBody>
+      </p:sp>
+      <p:sp>
+        <p:nvSpPr>
+          <p:cNvPr id="18" name="TextBox 17"/>
+          <p:cNvSpPr txBox="1"/>
+          <p:nvPr/>
+        </p:nvSpPr>
+        <p:spPr>
+          <a:xfrm>
+            <a:off x="812800" y="6238280"/>
+            <a:ext cx="9800000" cy="240000"/>
+          </a:xfrm>
+          <a:prstGeom prst="rect">
+            <a:avLst/>
+          </a:prstGeom>
+          <a:noFill/>
+        </p:spPr>
+        <p:txBody>
+          <a:bodyPr wrap="square" lIns="0" rIns="0" tIns="0" bIns="0" anchor="t">
+            <a:spAutoFit/>
+          </a:bodyPr>
+          <a:lstStyle/>
+          <a:p>
+            <a:pPr algn="l"/>
+            <a:r>
+              <a:rPr sz="1200" b="0">
+                <a:solidFill>
+                  <a:srgbClr val="5F6B64"/>
+                </a:solidFill>
+                <a:latin typeface="Inter"/>
+              </a:rPr>
+              <a:t>Manba: Norin-Sirdaryo IT_HB suv omborlari kunlik maʼlumotlari (2025) va texnik tavsifnoma</a:t>
             </a:r>
           </a:p>
         </p:txBody>
@@ -20218,7 +21208,7 @@
                           <a:ea typeface="Inter" pitchFamily="34" charset="-122"/>
                           <a:cs typeface="Inter" pitchFamily="34" charset="-120"/>
                         </a:rPr>
-                        <a:t>Shoʻrlanish, paxta va gʻalla hosildorligi, suv olish va shoʻr yuvish maydoni</a:t>
+                        <a:t>Shoʻrlanish, hosildorlik, suv olish, shoʻr yuvish va suv omborlari rejimi</a:t>
                       </a:r>
                       <a:endParaRPr lang="en-US" sz="1300" dirty="0">
                         <a:latin typeface="Inter" charset="0"/>

</xml_diff>

<commit_message>
Update water slides with 2019-2024 Namangan series and Rezaksoy trend
Co-Authored-By: Claude Sonnet 5.5 <noreply@anthropic.com>
Claude-Session: https://claude.ai/code/session_01M4MZatV28utL9zTp7saaUz
</commit_message>
<xml_diff>
--- a/Garbiy_Farg_ona_tuproqlari_GAT_asosida_bashoratlash.pptx
+++ b/Garbiy_Farg_ona_tuproqlari_GAT_asosida_bashoratlash.pptx
@@ -2275,7 +2275,7 @@
     <c:autoTitleDeleted val="1"/>
     <c:plotArea>
       <c:barChart>
-        <c:barDir val="bar"/>
+        <c:barDir val="col"/>
         <c:grouping val="clustered"/>
         <c:ser>
           <c:idx val="0"/>
@@ -2297,7 +2297,7 @@
             </a:solidFill>
           </c:spPr>
           <c:dPt>
-            <c:idx val="2"/>
+            <c:idx val="0"/>
             <c:spPr>
               <a:solidFill>
                 <a:srgbClr val="A4521D"/>
@@ -2306,48 +2306,54 @@
           </c:dPt>
           <c:cat>
             <c:strRef>
-              <c:f>Sheet1!$A$2:$A$5</c:f>
+              <c:f>Sheet1!$A$2:$A$6</c:f>
               <c:strCache>
-                <c:ptCount val="4"/>
+                <c:ptCount val="5"/>
                 <c:pt idx="0">
-                  <c:v>Daryo uzanidan</c:v>
+                  <c:v>2019–20</c:v>
                 </c:pt>
                 <c:pt idx="1">
-                  <c:v>Ichki soy va daryolar</c:v>
+                  <c:v>2020–21</c:v>
                 </c:pt>
                 <c:pt idx="2">
-                  <c:v>Zovurlar</c:v>
+                  <c:v>2021–22</c:v>
                 </c:pt>
                 <c:pt idx="3">
-                  <c:v>Yer osti suvlari</c:v>
+                  <c:v>2022–23</c:v>
+                </c:pt>
+                <c:pt idx="4">
+                  <c:v>2023–24</c:v>
                 </c:pt>
               </c:strCache>
             </c:strRef>
           </c:cat>
           <c:val>
             <c:numRef>
-              <c:f>Sheet1!$B$2:$B$5</c:f>
+              <c:f>Sheet1!$B$2:$B$6</c:f>
               <c:numCache>
                 <c:formatCode>General</c:formatCode>
-                <c:ptCount val="4"/>
+                <c:ptCount val="5"/>
                 <c:pt idx="0">
-                  <c:v>2831.7</c:v>
+                  <c:v>3181.6</c:v>
                 </c:pt>
                 <c:pt idx="1">
-                  <c:v>491.3</c:v>
+                  <c:v>2366.1</c:v>
                 </c:pt>
                 <c:pt idx="2">
-                  <c:v>53.9</c:v>
+                  <c:v>2414.9</c:v>
                 </c:pt>
                 <c:pt idx="3">
-                  <c:v>53.7</c:v>
+                  <c:v>2414.9</c:v>
+                </c:pt>
+                <c:pt idx="4">
+                  <c:v>2226.0</c:v>
                 </c:pt>
               </c:numCache>
             </c:numRef>
           </c:val>
         </c:ser>
         <c:dLbls>
-          <c:numFmt formatCode="#,##0.0" sourceLinked="0"/>
+          <c:numFmt formatCode="#,##0" sourceLinked="0"/>
           <c:txPr>
             <a:bodyPr/>
             <a:lstStyle/>
@@ -2378,10 +2384,10 @@
       <c:catAx>
         <c:axId val="-2068027336"/>
         <c:scaling>
-          <c:orientation val="maxMin"/>
+          <c:orientation val="minMax"/>
         </c:scaling>
         <c:delete val="0"/>
-        <c:axPos val="l"/>
+        <c:axPos val="b"/>
         <c:majorTickMark val="out"/>
         <c:minorTickMark val="none"/>
         <c:tickLblPos val="nextTo"/>
@@ -2416,11 +2422,11 @@
       <c:valAx>
         <c:axId val="-2113994440"/>
         <c:scaling>
-          <c:max val="3400.0"/>
+          <c:max val="3800.0"/>
           <c:min val="0.0"/>
         </c:scaling>
         <c:delete/>
-        <c:axPos val="b"/>
+        <c:axPos val="l"/>
         <c:majorTickMark val="out"/>
         <c:minorTickMark val="none"/>
         <c:tickLblPos val="nextTo"/>
@@ -15848,7 +15854,7 @@
                 </a:solidFill>
                 <a:latin typeface="Inter"/>
               </a:rPr>
-              <a:t>Suv manbalari boʻyicha olingan suv, mln m³ (jami 3 430,6)</a:t>
+              <a:t>Sugʻorishga amalda olingan suv, mln m³ (Namangan viloyati)</a:t>
             </a:r>
           </a:p>
         </p:txBody>
@@ -15862,8 +15868,8 @@
           <p:nvPr/>
         </p:nvGraphicFramePr>
         <p:xfrm>
-          <a:off x="752800" y="2150000"/>
-          <a:ext cx="6500000" cy="3200000"/>
+          <a:off x="752800" y="2130000"/>
+          <a:ext cx="6500000" cy="3000000"/>
         </p:xfrm>
         <a:graphic>
           <a:graphicData uri="http://schemas.openxmlformats.org/drawingml/2006/chart">
@@ -15879,8 +15885,8 @@
         </p:nvSpPr>
         <p:spPr>
           <a:xfrm>
-            <a:off x="812800" y="5450000"/>
-            <a:ext cx="6500000" cy="600000"/>
+            <a:off x="812800" y="5300000"/>
+            <a:ext cx="6500000" cy="700000"/>
           </a:xfrm>
           <a:prstGeom prst="rect">
             <a:avLst/>
@@ -15901,7 +15907,7 @@
                 </a:solidFill>
                 <a:latin typeface="Inter"/>
               </a:rPr>
-              <a:t>Zovur suvi (53,9 mln m³) — qaytariladigan suvning sugʻorishda qayta ishlatilishi; u olingan suvning atigi 1,6% ini tashkil etadi.</a:t>
+              <a:t>2023–24 yilda olingan 2 484,9 mln m³ suvning 77% i daryo uzanidan, 19% i ichki soy va daryolardan, 2% dan zovur va yer osti suvlaridan. 2019–20 yilda limit 2 441 dan 3 181,6 mln m³ gacha oshirilgan.</a:t>
             </a:r>
           </a:p>
         </p:txBody>
@@ -15984,7 +15990,7 @@
                 </a:solidFill>
                 <a:latin typeface="Source Serif 4"/>
               </a:rPr>
-              <a:t>23,2 ming ga</a:t>
+              <a:t>23,2 → 22,7</a:t>
             </a:r>
           </a:p>
         </p:txBody>
@@ -16019,7 +16025,7 @@
                 </a:solidFill>
                 <a:latin typeface="Inter"/>
               </a:rPr>
-              <a:t>Shoʻr yuvish maydoni (sugʻoriladigan 257,9 ming ganing 9%); asosan Mingbuloq (15,2) va Pop (7,7) tumanlari</a:t>
+              <a:t>Shoʻr yuvish maydoni, ming ga (2019–20 → 2023–24); asosan Mingbuloq (15,0 ming ga) tumani</a:t>
             </a:r>
           </a:p>
         </p:txBody>
@@ -16102,7 +16108,7 @@
                 </a:solidFill>
                 <a:latin typeface="Source Serif 4"/>
               </a:rPr>
-              <a:t>+30%</a:t>
+              <a:t>−30%</a:t>
             </a:r>
           </a:p>
         </p:txBody>
@@ -16137,7 +16143,7 @@
                 </a:solidFill>
                 <a:latin typeface="Inter"/>
               </a:rPr>
-              <a:t>Suv limiti 2 441 dan 3 181,6 mln m³ gacha oshirilgan; amalda olingan suv oshirilgan limitga teng</a:t>
+              <a:t>Sugʻorishga olingan suv 3 181,6 dan 2 226,0 mln m³ gacha kamaygan (2019–20 → 2023–24)</a:t>
             </a:r>
           </a:p>
         </p:txBody>
@@ -16220,7 +16226,7 @@
                 </a:solidFill>
                 <a:latin typeface="Source Serif 4"/>
               </a:rPr>
-              <a:t>115,4 mln m³</a:t>
+              <a:t>63,4 → 61,0</a:t>
             </a:r>
           </a:p>
         </p:txBody>
@@ -16255,7 +16261,7 @@
                 </a:solidFill>
                 <a:latin typeface="Inter"/>
               </a:rPr>
-              <a:t>Rezaksoy suv ombori hajmi: 127,5 (2022) → 121,9 (2023) → 115,4 (2024)</a:t>
+              <a:t>Paxta maydoni, ming ga; gʻalla esa 74,0 dan 78,0 ming gaga oshgan (2019–20 → 2023–24)</a:t>
             </a:r>
           </a:p>
         </p:txBody>
@@ -16290,7 +16296,7 @@
                 </a:solidFill>
                 <a:latin typeface="Inter"/>
               </a:rPr>
-              <a:t>Manba: Norin-Sirdaryo IT_HB hisoboti (2019–2020 yillar) va suv omborlari hajmi (2022–2024)</a:t>
+              <a:t>Manba: Norin-Sirdaryo IT_HB yillik hisobotlari (2019–2024)</a:t>
             </a:r>
           </a:p>
         </p:txBody>
@@ -16821,7 +16827,7 @@
                 </a:solidFill>
                 <a:latin typeface="Source Serif 4"/>
               </a:rPr>
-              <a:t>457 mln m³</a:t>
+              <a:t>−35%</a:t>
             </a:r>
           </a:p>
         </p:txBody>
@@ -16856,7 +16862,7 @@
                 </a:solidFill>
                 <a:latin typeface="Inter"/>
               </a:rPr>
-              <a:t>Texnik tavsifnomadagi 9 ta suv omborining toʻla hajmi (foydali — 439,8 mln m³)</a:t>
+              <a:t>Rezaksoy yillik eng yuqori hajmi 2018 yildagi 194,0 dan 2024 yilda 126,2 mln m³ gacha kamaygan; 2025 yilda — 143,8</a:t>
             </a:r>
           </a:p>
         </p:txBody>
@@ -16891,7 +16897,7 @@
                 </a:solidFill>
                 <a:latin typeface="Inter"/>
               </a:rPr>
-              <a:t>Manba: Norin-Sirdaryo IT_HB suv omborlari kunlik maʼlumotlari (2025) va texnik tavsifnoma</a:t>
+              <a:t>Manba: Norin-Sirdaryo IT_HB suv omborlari kunlik va dekadalik maʼlumotlari (2009–2025)</a:t>
             </a:r>
           </a:p>
         </p:txBody>

</xml_diff>

<commit_message>
Add Namangan water infrastructure slide
Co-Authored-By: Claude Sonnet 5.5 <noreply@anthropic.com>
Claude-Session: https://claude.ai/code/session_01M4MZatV28utL9zTp7saaUz
</commit_message>
<xml_diff>
--- a/Garbiy_Farg_ona_tuproqlari_GAT_asosida_bashoratlash.pptx
+++ b/Garbiy_Farg_ona_tuproqlari_GAT_asosida_bashoratlash.pptx
@@ -22,6 +22,7 @@
     <p:sldId id="277" r:id="rId28"/>
     <p:sldId id="278" r:id="rId29"/>
     <p:sldId id="279" r:id="rId30"/>
+    <p:sldId id="280" r:id="rId31"/>
     <p:sldId id="265" r:id="rId11"/>
     <p:sldId id="266" r:id="rId12"/>
     <p:sldId id="267" r:id="rId13"/>
@@ -721,6 +722,229 @@
     <c:plotVisOnly val="1"/>
     <c:dispBlanksAs val="gap"/>
     <c:showDLblsOverMax val="0"/>
+  </c:chart>
+  <c:txPr>
+    <a:bodyPr/>
+    <a:lstStyle/>
+    <a:p>
+      <a:pPr>
+        <a:defRPr sz="1200">
+          <a:solidFill>
+            <a:srgbClr val="4C5852"/>
+          </a:solidFill>
+          <a:latin typeface="Inter"/>
+        </a:defRPr>
+      </a:pPr>
+      <a:endParaRPr lang="en-US"/>
+    </a:p>
+  </c:txPr>
+  <c:externalData r:id="rId1">
+    <c:autoUpdate val="0"/>
+  </c:externalData>
+</c:chartSpace>
+</file>
+
+<file path=ppt/charts/chart11.xml><?xml version="1.0" encoding="utf-8"?>
+<c:chartSpace xmlns:c="http://schemas.openxmlformats.org/drawingml/2006/chart" xmlns:a="http://schemas.openxmlformats.org/drawingml/2006/main" xmlns:r="http://schemas.openxmlformats.org/officeDocument/2006/relationships">
+  <c:date1904 val="0"/>
+  <c:chart>
+    <c:autoTitleDeleted val="1"/>
+    <c:plotArea>
+      <c:barChart>
+        <c:barDir val="bar"/>
+        <c:grouping val="clustered"/>
+        <c:ser>
+          <c:idx val="0"/>
+          <c:order val="0"/>
+          <c:tx>
+            <c:strRef>
+              <c:f>Sheet1!$B$1</c:f>
+              <c:strCache>
+                <c:ptCount val="1"/>
+                <c:pt idx="0">
+                  <c:v>Ulush</c:v>
+                </c:pt>
+              </c:strCache>
+            </c:strRef>
+          </c:tx>
+          <c:spPr>
+            <a:solidFill>
+              <a:srgbClr val="2C6A85"/>
+            </a:solidFill>
+          </c:spPr>
+          <c:dPt>
+            <c:idx val="5"/>
+            <c:spPr>
+              <a:solidFill>
+                <a:srgbClr val="A4521D"/>
+              </a:solidFill>
+            </c:spPr>
+          </c:dPt>
+          <c:dPt>
+            <c:idx val="6"/>
+            <c:spPr>
+              <a:solidFill>
+                <a:srgbClr val="A4521D"/>
+              </a:solidFill>
+            </c:spPr>
+          </c:dPt>
+          <c:dPt>
+            <c:idx val="7"/>
+            <c:spPr>
+              <a:solidFill>
+                <a:srgbClr val="A4521D"/>
+              </a:solidFill>
+            </c:spPr>
+          </c:dPt>
+          <c:cat>
+            <c:strRef>
+              <c:f>Sheet1!$A$2:$A$9</c:f>
+              <c:strCache>
+                <c:ptCount val="8"/>
+                <c:pt idx="0">
+                  <c:v>Nasos stansiyalari</c:v>
+                </c:pt>
+                <c:pt idx="1">
+                  <c:v>Daryolar</c:v>
+                </c:pt>
+                <c:pt idx="2">
+                  <c:v>Suv va sel omborlari</c:v>
+                </c:pt>
+                <c:pt idx="3">
+                  <c:v>Tik quduqlar</c:v>
+                </c:pt>
+                <c:pt idx="4">
+                  <c:v>Kanallar</c:v>
+                </c:pt>
+                <c:pt idx="5">
+                  <c:v>Soylar</c:v>
+                </c:pt>
+                <c:pt idx="6">
+                  <c:v>Kollektorlar (zovur)</c:v>
+                </c:pt>
+                <c:pt idx="7">
+                  <c:v>Ichki zovurlar</c:v>
+                </c:pt>
+              </c:strCache>
+            </c:strRef>
+          </c:cat>
+          <c:val>
+            <c:numRef>
+              <c:f>Sheet1!$B$2:$B$9</c:f>
+              <c:numCache>
+                <c:formatCode>General</c:formatCode>
+                <c:ptCount val="8"/>
+                <c:pt idx="0">
+                  <c:v>100</c:v>
+                </c:pt>
+                <c:pt idx="1">
+                  <c:v>93</c:v>
+                </c:pt>
+                <c:pt idx="2">
+                  <c:v>81</c:v>
+                </c:pt>
+                <c:pt idx="3">
+                  <c:v>64</c:v>
+                </c:pt>
+                <c:pt idx="4">
+                  <c:v>62</c:v>
+                </c:pt>
+                <c:pt idx="5">
+                  <c:v>32</c:v>
+                </c:pt>
+                <c:pt idx="6">
+                  <c:v>27</c:v>
+                </c:pt>
+                <c:pt idx="7">
+                  <c:v>0</c:v>
+                </c:pt>
+              </c:numCache>
+            </c:numRef>
+          </c:val>
+        </c:ser>
+        <c:dLbls>
+          <c:numFmt formatCode="0&quot;%&quot;" sourceLinked="0"/>
+          <c:txPr>
+            <a:bodyPr/>
+            <a:lstStyle/>
+            <a:p>
+              <a:pPr>
+                <a:defRPr sz="1200">
+                  <a:solidFill>
+                    <a:srgbClr val="1D2A24"/>
+                  </a:solidFill>
+                  <a:latin typeface="Inter"/>
+                </a:defRPr>
+              </a:pPr>
+            </a:p>
+          </c:txPr>
+          <c:dLblPos val="outEnd"/>
+          <c:showLegendKey val="0"/>
+          <c:showVal val="1"/>
+          <c:showCatName val="0"/>
+          <c:showSerName val="0"/>
+          <c:showPercent val="0"/>
+          <c:showBubbleSize val="0"/>
+          <c:showLeaderLines val="1"/>
+        </c:dLbls>
+        <c:gapWidth val="35"/>
+        <c:axId val="-2068027336"/>
+        <c:axId val="-2113994440"/>
+      </c:barChart>
+      <c:catAx>
+        <c:axId val="-2068027336"/>
+        <c:scaling>
+          <c:orientation val="maxMin"/>
+        </c:scaling>
+        <c:delete val="0"/>
+        <c:axPos val="l"/>
+        <c:majorTickMark val="out"/>
+        <c:minorTickMark val="none"/>
+        <c:tickLblPos val="nextTo"/>
+        <c:spPr>
+          <a:ln>
+            <a:solidFill>
+              <a:srgbClr val="B5B2AD"/>
+            </a:solidFill>
+          </a:ln>
+        </c:spPr>
+        <c:txPr>
+          <a:bodyPr/>
+          <a:lstStyle/>
+          <a:p>
+            <a:pPr>
+              <a:defRPr sz="1200">
+                <a:solidFill>
+                  <a:srgbClr val="4C5852"/>
+                </a:solidFill>
+                <a:latin typeface="Inter"/>
+              </a:defRPr>
+            </a:pPr>
+          </a:p>
+        </c:txPr>
+        <c:crossAx val="-2113994440"/>
+        <c:crosses val="autoZero"/>
+        <c:auto val="1"/>
+        <c:lblAlgn val="ctr"/>
+        <c:lblOffset val="100"/>
+        <c:noMultiLvlLbl val="0"/>
+      </c:catAx>
+      <c:valAx>
+        <c:axId val="-2113994440"/>
+        <c:scaling>
+          <c:max val="115.0"/>
+          <c:min val="0.0"/>
+        </c:scaling>
+        <c:delete/>
+        <c:axPos val="b"/>
+        <c:majorTickMark val="out"/>
+        <c:minorTickMark val="none"/>
+        <c:tickLblPos val="nextTo"/>
+        <c:crossAx val="-2068027336"/>
+        <c:crosses val="autoZero"/>
+      </c:valAx>
+    </c:plotArea>
+    <c:dispBlanksAs val="gap"/>
   </c:chart>
   <c:txPr>
     <a:bodyPr/>
@@ -5379,7 +5603,7 @@
                 <a:ea typeface="Inter" pitchFamily="34" charset="-122"/>
                 <a:cs typeface="Inter" pitchFamily="34" charset="-120"/>
               </a:rPr>
-              <a:t>17 · DISSERTATSIYA TUZILISHI</a:t>
+              <a:t>18 · DISSERTATSIYA TUZILISHI</a:t>
             </a:r>
             <a:endParaRPr lang="en-US" sz="1200" dirty="0"/>
           </a:p>
@@ -6178,7 +6402,7 @@
                 <a:ea typeface="Inter" pitchFamily="34" charset="-122"/>
                 <a:cs typeface="Inter" pitchFamily="34" charset="-120"/>
               </a:rPr>
-              <a:t>18</a:t>
+              <a:t>19</a:t>
             </a:r>
             <a:endParaRPr lang="en-US" sz="1200" dirty="0"/>
           </a:p>
@@ -6254,7 +6478,7 @@
                 <a:ea typeface="Inter" pitchFamily="34" charset="-122"/>
                 <a:cs typeface="Inter" pitchFamily="34" charset="-120"/>
               </a:rPr>
-              <a:t>18 · DISSERTATSIYA TUZILISHI</a:t>
+              <a:t>19 · DISSERTATSIYA TUZILISHI</a:t>
             </a:r>
             <a:endParaRPr lang="en-US" sz="1200" dirty="0"/>
           </a:p>
@@ -7286,7 +7510,7 @@
                 <a:ea typeface="Inter" pitchFamily="34" charset="-122"/>
                 <a:cs typeface="Inter" pitchFamily="34" charset="-120"/>
               </a:rPr>
-              <a:t>19</a:t>
+              <a:t>20</a:t>
             </a:r>
             <a:endParaRPr lang="en-US" sz="1200" dirty="0"/>
           </a:p>
@@ -7362,7 +7586,7 @@
                 <a:ea typeface="Inter" pitchFamily="34" charset="-122"/>
                 <a:cs typeface="Inter" pitchFamily="34" charset="-120"/>
               </a:rPr>
-              <a:t>19 · DISSERTATSIYA TUZILISHI</a:t>
+              <a:t>20 · DISSERTATSIYA TUZILISHI</a:t>
             </a:r>
             <a:endParaRPr lang="en-US" sz="1200" dirty="0"/>
           </a:p>
@@ -8389,7 +8613,7 @@
                 <a:ea typeface="Inter" pitchFamily="34" charset="-122"/>
                 <a:cs typeface="Inter" pitchFamily="34" charset="-120"/>
               </a:rPr>
-              <a:t>20</a:t>
+              <a:t>21</a:t>
             </a:r>
             <a:endParaRPr lang="en-US" sz="1200" dirty="0"/>
           </a:p>
@@ -8465,7 +8689,7 @@
                 <a:ea typeface="Inter" pitchFamily="34" charset="-122"/>
                 <a:cs typeface="Inter" pitchFamily="34" charset="-120"/>
               </a:rPr>
-              <a:t>20 · NATIJALAR VA REJA</a:t>
+              <a:t>21 · NATIJALAR VA REJA</a:t>
             </a:r>
             <a:endParaRPr lang="en-US" sz="1200" dirty="0"/>
           </a:p>
@@ -9203,7 +9427,7 @@
                 <a:ea typeface="Inter" pitchFamily="34" charset="-122"/>
                 <a:cs typeface="Inter" pitchFamily="34" charset="-120"/>
               </a:rPr>
-              <a:t>21</a:t>
+              <a:t>22</a:t>
             </a:r>
             <a:endParaRPr lang="en-US" sz="1200" dirty="0"/>
           </a:p>
@@ -9279,7 +9503,7 @@
                 <a:ea typeface="Inter" pitchFamily="34" charset="-122"/>
                 <a:cs typeface="Inter" pitchFamily="34" charset="-120"/>
               </a:rPr>
-              <a:t>21 · NATIJALAR VA REJA</a:t>
+              <a:t>22 · NATIJALAR VA REJA</a:t>
             </a:r>
             <a:endParaRPr lang="en-US" sz="1200" dirty="0"/>
           </a:p>
@@ -10305,7 +10529,7 @@
                 <a:ea typeface="Inter" pitchFamily="34" charset="-122"/>
                 <a:cs typeface="Inter" pitchFamily="34" charset="-120"/>
               </a:rPr>
-              <a:t>22</a:t>
+              <a:t>23</a:t>
             </a:r>
             <a:endParaRPr lang="en-US" sz="1200" dirty="0"/>
           </a:p>
@@ -10381,7 +10605,7 @@
                 <a:ea typeface="Inter" pitchFamily="34" charset="-122"/>
                 <a:cs typeface="Inter" pitchFamily="34" charset="-120"/>
               </a:rPr>
-              <a:t>22 · NATIJALAR VA REJA</a:t>
+              <a:t>23 · NATIJALAR VA REJA</a:t>
             </a:r>
             <a:endParaRPr lang="en-US" sz="1200" dirty="0"/>
           </a:p>
@@ -10993,7 +11217,7 @@
                 <a:ea typeface="Inter" pitchFamily="34" charset="-122"/>
                 <a:cs typeface="Inter" pitchFamily="34" charset="-120"/>
               </a:rPr>
-              <a:t>23</a:t>
+              <a:t>24</a:t>
             </a:r>
             <a:endParaRPr lang="en-US" sz="1200" dirty="0"/>
           </a:p>
@@ -16898,6 +17122,607 @@
                 <a:latin typeface="Inter"/>
               </a:rPr>
               <a:t>Manba: Norin-Sirdaryo IT_HB suv omborlari kunlik va dekadalik maʼlumotlari (2009–2025)</a:t>
+            </a:r>
+          </a:p>
+        </p:txBody>
+      </p:sp>
+    </p:spTree>
+  </p:cSld>
+  <p:clrMapOvr>
+    <a:masterClrMapping/>
+  </p:clrMapOvr>
+</p:sld>
+</file>
+
+<file path=ppt/slides/slide25.xml><?xml version="1.0" encoding="utf-8"?>
+<p:sld xmlns:a="http://schemas.openxmlformats.org/drawingml/2006/main" xmlns:p="http://schemas.openxmlformats.org/presentationml/2006/main" xmlns:r="http://schemas.openxmlformats.org/officeDocument/2006/relationships">
+  <p:cSld>
+    <p:bg>
+      <p:bgPr>
+        <a:solidFill>
+          <a:srgbClr val="F4F1EA"/>
+        </a:solidFill>
+      </p:bgPr>
+    </p:bg>
+    <p:spTree>
+      <p:nvGrpSpPr>
+        <p:cNvPr id="1" name=""/>
+        <p:cNvGrpSpPr/>
+        <p:nvPr/>
+      </p:nvGrpSpPr>
+      <p:grpSpPr/>
+      <p:sp>
+        <p:nvSpPr>
+          <p:cNvPr id="2" name="Text 0"/>
+          <p:cNvSpPr/>
+          <p:nvPr/>
+        </p:nvSpPr>
+        <p:spPr>
+          <a:xfrm>
+            <a:off x="812800" y="812800"/>
+            <a:ext cx="10883392" cy="238720"/>
+          </a:xfrm>
+          <a:prstGeom prst="rect">
+            <a:avLst/>
+          </a:prstGeom>
+          <a:noFill/>
+          <a:ln/>
+        </p:spPr>
+        <p:txBody>
+          <a:bodyPr wrap="square" lIns="0" tIns="0" rIns="0" bIns="0" rtlCol="0" anchor="t">
+            <a:normAutofit/>
+          </a:bodyPr>
+          <a:lstStyle/>
+          <a:p>
+            <a:pPr algn="l" indent="0" marL="0">
+              <a:lnSpc>
+                <a:spcPts val="1680"/>
+              </a:lnSpc>
+              <a:buNone/>
+            </a:pPr>
+            <a:r>
+              <a:rPr lang="en-US" sz="1200" b="1" spc="150" kern="0" dirty="0">
+                <a:solidFill>
+                  <a:srgbClr val="2C6A85"/>
+                </a:solidFill>
+                <a:latin typeface="Inter" pitchFamily="34" charset="0"/>
+                <a:ea typeface="Inter" pitchFamily="34" charset="-122"/>
+                <a:cs typeface="Inter" pitchFamily="34" charset="-120"/>
+              </a:rPr>
+              <a:t>17 · DASTLABKI MAʼLUMOTLAR</a:t>
+            </a:r>
+            <a:endParaRPr lang="en-US" sz="1200" dirty="0"/>
+          </a:p>
+        </p:txBody>
+      </p:sp>
+      <p:sp>
+        <p:nvSpPr>
+          <p:cNvPr id="3" name="Text 1"/>
+          <p:cNvSpPr/>
+          <p:nvPr>
+            <p:ph type="title"/>
+          </p:nvPr>
+        </p:nvSpPr>
+        <p:spPr>
+          <a:xfrm>
+            <a:off x="812800" y="1127720"/>
+            <a:ext cx="10883392" cy="472430"/>
+          </a:xfrm>
+          <a:prstGeom prst="rect">
+            <a:avLst/>
+          </a:prstGeom>
+          <a:noFill/>
+          <a:ln/>
+        </p:spPr>
+        <p:txBody>
+          <a:bodyPr wrap="square" lIns="0" tIns="0" rIns="0" bIns="0" rtlCol="0" anchor="t">
+            <a:normAutofit/>
+          </a:bodyPr>
+          <a:lstStyle/>
+          <a:p>
+            <a:pPr algn="l" indent="0" marL="0">
+              <a:lnSpc>
+                <a:spcPts val="3520"/>
+              </a:lnSpc>
+              <a:buNone/>
+            </a:pPr>
+            <a:r>
+              <a:rPr lang="en-US" sz="3200" b="0" i="0" dirty="0">
+                <a:solidFill>
+                  <a:srgbClr val="1D2A24"/>
+                </a:solidFill>
+                <a:latin typeface="Source Serif 4" pitchFamily="18" charset="0"/>
+                <a:ea typeface="Source Serif 4" pitchFamily="18" charset="-122"/>
+                <a:cs typeface="Source Serif 4" pitchFamily="18" charset="-120"/>
+              </a:rPr>
+              <a:t>Namangan viloyati: suv xoʻjaligi obyektlari</a:t>
+            </a:r>
+            <a:endParaRPr lang="en-US" sz="3200" dirty="0"/>
+          </a:p>
+        </p:txBody>
+      </p:sp>
+      <p:sp>
+        <p:nvSpPr>
+          <p:cNvPr id="6" name="Text 3"/>
+          <p:cNvSpPr/>
+          <p:nvPr/>
+        </p:nvSpPr>
+        <p:spPr>
+          <a:xfrm>
+            <a:off x="11137950" y="6238280"/>
+            <a:ext cx="241250" cy="238720"/>
+          </a:xfrm>
+          <a:prstGeom prst="rect">
+            <a:avLst/>
+          </a:prstGeom>
+          <a:noFill/>
+          <a:ln/>
+        </p:spPr>
+        <p:txBody>
+          <a:bodyPr wrap="square" lIns="0" tIns="0" rIns="0" bIns="0" rtlCol="0" anchor="t">
+            <a:normAutofit/>
+          </a:bodyPr>
+          <a:lstStyle/>
+          <a:p>
+            <a:pPr algn="r" indent="0" marL="0">
+              <a:lnSpc>
+                <a:spcPts val="1680"/>
+              </a:lnSpc>
+              <a:buNone/>
+            </a:pPr>
+            <a:r>
+              <a:rPr lang="en-US" sz="1200" dirty="0">
+                <a:solidFill>
+                  <a:srgbClr val="5F6B64"/>
+                </a:solidFill>
+                <a:latin typeface="Inter" pitchFamily="34" charset="0"/>
+                <a:ea typeface="Inter" pitchFamily="34" charset="-122"/>
+                <a:cs typeface="Inter" pitchFamily="34" charset="-120"/>
+              </a:rPr>
+              <a:t>18</a:t>
+            </a:r>
+            <a:endParaRPr lang="en-US" sz="1200" dirty="0"/>
+          </a:p>
+        </p:txBody>
+      </p:sp>
+      <p:sp>
+        <p:nvSpPr>
+          <p:cNvPr id="7" name="TextBox 6"/>
+          <p:cNvSpPr txBox="1"/>
+          <p:nvPr/>
+        </p:nvSpPr>
+        <p:spPr>
+          <a:xfrm>
+            <a:off x="812800" y="1830000"/>
+            <a:ext cx="6200000" cy="260000"/>
+          </a:xfrm>
+          <a:prstGeom prst="rect">
+            <a:avLst/>
+          </a:prstGeom>
+          <a:noFill/>
+        </p:spPr>
+        <p:txBody>
+          <a:bodyPr wrap="square" lIns="0" rIns="0" tIns="0" bIns="0" anchor="t">
+            <a:spAutoFit/>
+          </a:bodyPr>
+          <a:lstStyle/>
+          <a:p>
+            <a:pPr algn="l"/>
+            <a:r>
+              <a:rPr sz="1300" b="1">
+                <a:solidFill>
+                  <a:srgbClr val="2C6A85"/>
+                </a:solidFill>
+                <a:latin typeface="Inter"/>
+              </a:rPr>
+              <a:t>Davlat roʻyxatidan oʻtgan ulushi (maydon boʻyicha), %</a:t>
+            </a:r>
+          </a:p>
+        </p:txBody>
+      </p:sp>
+      <p:graphicFrame>
+        <p:nvGraphicFramePr>
+          <p:cNvPr id="8" name="Chart 7"/>
+          <p:cNvGraphicFramePr>
+            <a:graphicFrameLocks noGrp="1"/>
+          </p:cNvGraphicFramePr>
+          <p:nvPr/>
+        </p:nvGraphicFramePr>
+        <p:xfrm>
+          <a:off x="752800" y="2100000"/>
+          <a:ext cx="6500000" cy="3950000"/>
+        </p:xfrm>
+        <a:graphic>
+          <a:graphicData uri="http://schemas.openxmlformats.org/drawingml/2006/chart">
+            <c:chart xmlns:c="http://schemas.openxmlformats.org/drawingml/2006/chart" r:id="rId2"/>
+          </a:graphicData>
+        </a:graphic>
+      </p:graphicFrame>
+      <p:sp>
+        <p:nvSpPr>
+          <p:cNvPr id="9" name="Rounded Rectangle 8"/>
+          <p:cNvSpPr/>
+          <p:nvPr/>
+        </p:nvSpPr>
+        <p:spPr>
+          <a:xfrm>
+            <a:off x="7700000" y="1830000"/>
+            <a:ext cx="3996192" cy="1230000"/>
+          </a:xfrm>
+          <a:prstGeom prst="roundRect">
+            <a:avLst>
+              <a:gd name="adj" fmla="val 5000"/>
+            </a:avLst>
+          </a:prstGeom>
+          <a:solidFill>
+            <a:srgbClr val="FBF9F4"/>
+          </a:solidFill>
+          <a:ln w="6350">
+            <a:solidFill>
+              <a:srgbClr val="D9D2C3"/>
+            </a:solidFill>
+          </a:ln>
+          <a:effectLst/>
+        </p:spPr>
+        <p:style>
+          <a:lnRef idx="1">
+            <a:schemeClr val="accent1"/>
+          </a:lnRef>
+          <a:fillRef idx="3">
+            <a:schemeClr val="accent1"/>
+          </a:fillRef>
+          <a:effectRef idx="2">
+            <a:schemeClr val="accent1"/>
+          </a:effectRef>
+          <a:fontRef idx="minor">
+            <a:schemeClr val="lt1"/>
+          </a:fontRef>
+        </p:style>
+        <p:txBody>
+          <a:bodyPr rtlCol="0" anchor="ctr"/>
+          <a:lstStyle/>
+          <a:p>
+            <a:pPr algn="ctr"/>
+          </a:p>
+        </p:txBody>
+      </p:sp>
+      <p:sp>
+        <p:nvSpPr>
+          <p:cNvPr id="10" name="TextBox 9"/>
+          <p:cNvSpPr txBox="1"/>
+          <p:nvPr/>
+        </p:nvSpPr>
+        <p:spPr>
+          <a:xfrm>
+            <a:off x="7930000" y="1950000"/>
+            <a:ext cx="3536192" cy="420000"/>
+          </a:xfrm>
+          <a:prstGeom prst="rect">
+            <a:avLst/>
+          </a:prstGeom>
+          <a:noFill/>
+        </p:spPr>
+        <p:txBody>
+          <a:bodyPr wrap="square" lIns="0" rIns="0" tIns="0" bIns="0" anchor="t">
+            <a:spAutoFit/>
+          </a:bodyPr>
+          <a:lstStyle/>
+          <a:p>
+            <a:pPr algn="l"/>
+            <a:r>
+              <a:rPr sz="2400" b="0">
+                <a:solidFill>
+                  <a:srgbClr val="A4521D"/>
+                </a:solidFill>
+                <a:latin typeface="Source Serif 4"/>
+              </a:rPr>
+              <a:t>6 527 obyekt</a:t>
+            </a:r>
+          </a:p>
+        </p:txBody>
+      </p:sp>
+      <p:sp>
+        <p:nvSpPr>
+          <p:cNvPr id="11" name="TextBox 10"/>
+          <p:cNvSpPr txBox="1"/>
+          <p:nvPr/>
+        </p:nvSpPr>
+        <p:spPr>
+          <a:xfrm>
+            <a:off x="7930000" y="2390000"/>
+            <a:ext cx="3536192" cy="620000"/>
+          </a:xfrm>
+          <a:prstGeom prst="rect">
+            <a:avLst/>
+          </a:prstGeom>
+          <a:noFill/>
+        </p:spPr>
+        <p:txBody>
+          <a:bodyPr wrap="square" lIns="0" rIns="0" tIns="0" bIns="0" anchor="t">
+            <a:spAutoFit/>
+          </a:bodyPr>
+          <a:lstStyle/>
+          <a:p>
+            <a:pPr algn="l"/>
+            <a:r>
+              <a:rPr sz="1200" b="0">
+                <a:solidFill>
+                  <a:srgbClr val="4C5852"/>
+                </a:solidFill>
+                <a:latin typeface="Inter"/>
+              </a:rPr>
+              <a:t>Jami uzunligi 8 937 km, yer maydoni 28 605,6 ga (29.01.2026 holati)</a:t>
+            </a:r>
+          </a:p>
+        </p:txBody>
+      </p:sp>
+      <p:sp>
+        <p:nvSpPr>
+          <p:cNvPr id="12" name="Rounded Rectangle 11"/>
+          <p:cNvSpPr/>
+          <p:nvPr/>
+        </p:nvSpPr>
+        <p:spPr>
+          <a:xfrm>
+            <a:off x="7700000" y="3210000"/>
+            <a:ext cx="3996192" cy="1230000"/>
+          </a:xfrm>
+          <a:prstGeom prst="roundRect">
+            <a:avLst>
+              <a:gd name="adj" fmla="val 5000"/>
+            </a:avLst>
+          </a:prstGeom>
+          <a:solidFill>
+            <a:srgbClr val="FBF9F4"/>
+          </a:solidFill>
+          <a:ln w="6350">
+            <a:solidFill>
+              <a:srgbClr val="D9D2C3"/>
+            </a:solidFill>
+          </a:ln>
+          <a:effectLst/>
+        </p:spPr>
+        <p:style>
+          <a:lnRef idx="1">
+            <a:schemeClr val="accent1"/>
+          </a:lnRef>
+          <a:fillRef idx="3">
+            <a:schemeClr val="accent1"/>
+          </a:fillRef>
+          <a:effectRef idx="2">
+            <a:schemeClr val="accent1"/>
+          </a:effectRef>
+          <a:fontRef idx="minor">
+            <a:schemeClr val="lt1"/>
+          </a:fontRef>
+        </p:style>
+        <p:txBody>
+          <a:bodyPr rtlCol="0" anchor="ctr"/>
+          <a:lstStyle/>
+          <a:p>
+            <a:pPr algn="ctr"/>
+          </a:p>
+        </p:txBody>
+      </p:sp>
+      <p:sp>
+        <p:nvSpPr>
+          <p:cNvPr id="13" name="TextBox 12"/>
+          <p:cNvSpPr txBox="1"/>
+          <p:nvPr/>
+        </p:nvSpPr>
+        <p:spPr>
+          <a:xfrm>
+            <a:off x="7930000" y="3330000"/>
+            <a:ext cx="3536192" cy="420000"/>
+          </a:xfrm>
+          <a:prstGeom prst="rect">
+            <a:avLst/>
+          </a:prstGeom>
+          <a:noFill/>
+        </p:spPr>
+        <p:txBody>
+          <a:bodyPr wrap="square" lIns="0" rIns="0" tIns="0" bIns="0" anchor="t">
+            <a:spAutoFit/>
+          </a:bodyPr>
+          <a:lstStyle/>
+          <a:p>
+            <a:pPr algn="l"/>
+            <a:r>
+              <a:rPr sz="2400" b="0">
+                <a:solidFill>
+                  <a:srgbClr val="2C6A85"/>
+                </a:solidFill>
+                <a:latin typeface="Source Serif 4"/>
+              </a:rPr>
+              <a:t>53%</a:t>
+            </a:r>
+          </a:p>
+        </p:txBody>
+      </p:sp>
+      <p:sp>
+        <p:nvSpPr>
+          <p:cNvPr id="14" name="TextBox 13"/>
+          <p:cNvSpPr txBox="1"/>
+          <p:nvPr/>
+        </p:nvSpPr>
+        <p:spPr>
+          <a:xfrm>
+            <a:off x="7930000" y="3770000"/>
+            <a:ext cx="3536192" cy="620000"/>
+          </a:xfrm>
+          <a:prstGeom prst="rect">
+            <a:avLst/>
+          </a:prstGeom>
+          <a:noFill/>
+        </p:spPr>
+        <p:txBody>
+          <a:bodyPr wrap="square" lIns="0" rIns="0" tIns="0" bIns="0" anchor="t">
+            <a:spAutoFit/>
+          </a:bodyPr>
+          <a:lstStyle/>
+          <a:p>
+            <a:pPr algn="l"/>
+            <a:r>
+              <a:rPr sz="1200" b="0">
+                <a:solidFill>
+                  <a:srgbClr val="4C5852"/>
+                </a:solidFill>
+                <a:latin typeface="Inter"/>
+              </a:rPr>
+              <a:t>Maydonning 15 273 ga qismi davlat roʻyxatidan oʻtgan; 39,5% (11 300 ga) hali oʻtmagan</a:t>
+            </a:r>
+          </a:p>
+        </p:txBody>
+      </p:sp>
+      <p:sp>
+        <p:nvSpPr>
+          <p:cNvPr id="15" name="Rounded Rectangle 14"/>
+          <p:cNvSpPr/>
+          <p:nvPr/>
+        </p:nvSpPr>
+        <p:spPr>
+          <a:xfrm>
+            <a:off x="7700000" y="4590000"/>
+            <a:ext cx="3996192" cy="1230000"/>
+          </a:xfrm>
+          <a:prstGeom prst="roundRect">
+            <a:avLst>
+              <a:gd name="adj" fmla="val 5000"/>
+            </a:avLst>
+          </a:prstGeom>
+          <a:solidFill>
+            <a:srgbClr val="FBF9F4"/>
+          </a:solidFill>
+          <a:ln w="6350">
+            <a:solidFill>
+              <a:srgbClr val="D9D2C3"/>
+            </a:solidFill>
+          </a:ln>
+          <a:effectLst/>
+        </p:spPr>
+        <p:style>
+          <a:lnRef idx="1">
+            <a:schemeClr val="accent1"/>
+          </a:lnRef>
+          <a:fillRef idx="3">
+            <a:schemeClr val="accent1"/>
+          </a:fillRef>
+          <a:effectRef idx="2">
+            <a:schemeClr val="accent1"/>
+          </a:effectRef>
+          <a:fontRef idx="minor">
+            <a:schemeClr val="lt1"/>
+          </a:fontRef>
+        </p:style>
+        <p:txBody>
+          <a:bodyPr rtlCol="0" anchor="ctr"/>
+          <a:lstStyle/>
+          <a:p>
+            <a:pPr algn="ctr"/>
+          </a:p>
+        </p:txBody>
+      </p:sp>
+      <p:sp>
+        <p:nvSpPr>
+          <p:cNvPr id="16" name="TextBox 15"/>
+          <p:cNvSpPr txBox="1"/>
+          <p:nvPr/>
+        </p:nvSpPr>
+        <p:spPr>
+          <a:xfrm>
+            <a:off x="7930000" y="4710000"/>
+            <a:ext cx="3536192" cy="420000"/>
+          </a:xfrm>
+          <a:prstGeom prst="rect">
+            <a:avLst/>
+          </a:prstGeom>
+          <a:noFill/>
+        </p:spPr>
+        <p:txBody>
+          <a:bodyPr wrap="square" lIns="0" rIns="0" tIns="0" bIns="0" anchor="t">
+            <a:spAutoFit/>
+          </a:bodyPr>
+          <a:lstStyle/>
+          <a:p>
+            <a:pPr algn="l"/>
+            <a:r>
+              <a:rPr sz="2400" b="0">
+                <a:solidFill>
+                  <a:srgbClr val="A4521D"/>
+                </a:solidFill>
+                <a:latin typeface="Source Serif 4"/>
+              </a:rPr>
+              <a:t>5 044 km</a:t>
+            </a:r>
+          </a:p>
+        </p:txBody>
+      </p:sp>
+      <p:sp>
+        <p:nvSpPr>
+          <p:cNvPr id="17" name="TextBox 16"/>
+          <p:cNvSpPr txBox="1"/>
+          <p:nvPr/>
+        </p:nvSpPr>
+        <p:spPr>
+          <a:xfrm>
+            <a:off x="7930000" y="5150000"/>
+            <a:ext cx="3536192" cy="620000"/>
+          </a:xfrm>
+          <a:prstGeom prst="rect">
+            <a:avLst/>
+          </a:prstGeom>
+          <a:noFill/>
+        </p:spPr>
+        <p:txBody>
+          <a:bodyPr wrap="square" lIns="0" rIns="0" tIns="0" bIns="0" anchor="t">
+            <a:spAutoFit/>
+          </a:bodyPr>
+          <a:lstStyle/>
+          <a:p>
+            <a:pPr algn="l"/>
+            <a:r>
+              <a:rPr sz="1200" b="0">
+                <a:solidFill>
+                  <a:srgbClr val="4C5852"/>
+                </a:solidFill>
+                <a:latin typeface="Inter"/>
+              </a:rPr>
+              <a:t>Zovur tarmogʻi: 344 kollektor (1 814 km) va 4 384 ichki zovur (3 230 km); ichki zovurlar roʻyxatdan oʻtmagan</a:t>
+            </a:r>
+          </a:p>
+        </p:txBody>
+      </p:sp>
+      <p:sp>
+        <p:nvSpPr>
+          <p:cNvPr id="18" name="TextBox 17"/>
+          <p:cNvSpPr txBox="1"/>
+          <p:nvPr/>
+        </p:nvSpPr>
+        <p:spPr>
+          <a:xfrm>
+            <a:off x="812800" y="6238280"/>
+            <a:ext cx="9800000" cy="240000"/>
+          </a:xfrm>
+          <a:prstGeom prst="rect">
+            <a:avLst/>
+          </a:prstGeom>
+          <a:noFill/>
+        </p:spPr>
+        <p:txBody>
+          <a:bodyPr wrap="square" lIns="0" rIns="0" tIns="0" bIns="0" anchor="t">
+            <a:spAutoFit/>
+          </a:bodyPr>
+          <a:lstStyle/>
+          <a:p>
+            <a:pPr algn="l"/>
+            <a:r>
+              <a:rPr sz="1200" b="0">
+                <a:solidFill>
+                  <a:srgbClr val="5F6B64"/>
+                </a:solidFill>
+                <a:latin typeface="Inter"/>
+              </a:rPr>
+              <a:t>Manba: Namangan viloyati suv xoʻjaligi obyektlarini davlat roʻyxatidan oʻtkazish toʻgʻrisida maʼlumot, 29.01.2026</a:t>
             </a:r>
           </a:p>
         </p:txBody>
@@ -21214,7 +22039,7 @@
                           <a:ea typeface="Inter" pitchFamily="34" charset="-122"/>
                           <a:cs typeface="Inter" pitchFamily="34" charset="-120"/>
                         </a:rPr>
-                        <a:t>Shoʻrlanish, hosildorlik, suv olish, shoʻr yuvish va suv omborlari rejimi</a:t>
+                        <a:t>Shoʻrlanish, hosildorlik, suv olish, shoʻr yuvish, suv omborlari, zovur tarmogʻi</a:t>
                       </a:r>
                       <a:endParaRPr lang="en-US" sz="1300" dirty="0">
                         <a:latin typeface="Inter" charset="0"/>

</xml_diff>

<commit_message>
Add Fergana crop placement and salt-leaching slides for Fergana and Andijan
Co-Authored-By: Claude Sonnet 5.5 <noreply@anthropic.com>
Claude-Session: https://claude.ai/code/session_01M4MZatV28utL9zTp7saaUz
</commit_message>
<xml_diff>
--- a/Garbiy_Farg_ona_tuproqlari_GAT_asosida_bashoratlash.pptx
+++ b/Garbiy_Farg_ona_tuproqlari_GAT_asosida_bashoratlash.pptx
@@ -23,6 +23,9 @@
     <p:sldId id="278" r:id="rId29"/>
     <p:sldId id="279" r:id="rId30"/>
     <p:sldId id="280" r:id="rId31"/>
+    <p:sldId id="281" r:id="rId32"/>
+    <p:sldId id="282" r:id="rId33"/>
+    <p:sldId id="283" r:id="rId34"/>
     <p:sldId id="265" r:id="rId11"/>
     <p:sldId id="266" r:id="rId12"/>
     <p:sldId id="267" r:id="rId13"/>
@@ -944,6 +947,942 @@
         <c:crosses val="autoZero"/>
       </c:valAx>
     </c:plotArea>
+    <c:dispBlanksAs val="gap"/>
+  </c:chart>
+  <c:txPr>
+    <a:bodyPr/>
+    <a:lstStyle/>
+    <a:p>
+      <a:pPr>
+        <a:defRPr sz="1200">
+          <a:solidFill>
+            <a:srgbClr val="4C5852"/>
+          </a:solidFill>
+          <a:latin typeface="Inter"/>
+        </a:defRPr>
+      </a:pPr>
+      <a:endParaRPr lang="en-US"/>
+    </a:p>
+  </c:txPr>
+  <c:externalData r:id="rId1">
+    <c:autoUpdate val="0"/>
+  </c:externalData>
+</c:chartSpace>
+</file>
+
+<file path=ppt/charts/chart12.xml><?xml version="1.0" encoding="utf-8"?>
+<c:chartSpace xmlns:c="http://schemas.openxmlformats.org/drawingml/2006/chart" xmlns:a="http://schemas.openxmlformats.org/drawingml/2006/main" xmlns:r="http://schemas.openxmlformats.org/officeDocument/2006/relationships">
+  <c:date1904 val="0"/>
+  <c:chart>
+    <c:autoTitleDeleted val="1"/>
+    <c:plotArea>
+      <c:barChart>
+        <c:barDir val="bar"/>
+        <c:grouping val="clustered"/>
+        <c:ser>
+          <c:idx val="0"/>
+          <c:order val="0"/>
+          <c:tx>
+            <c:strRef>
+              <c:f>Sheet1!$B$1</c:f>
+              <c:strCache>
+                <c:ptCount val="1"/>
+                <c:pt idx="0">
+                  <c:v>Gʻoʻza</c:v>
+                </c:pt>
+              </c:strCache>
+            </c:strRef>
+          </c:tx>
+          <c:spPr>
+            <a:solidFill>
+              <a:srgbClr val="2C6A85"/>
+            </a:solidFill>
+          </c:spPr>
+          <c:dPt>
+            <c:idx val="0"/>
+            <c:spPr>
+              <a:solidFill>
+                <a:srgbClr val="A4521D"/>
+              </a:solidFill>
+            </c:spPr>
+          </c:dPt>
+          <c:cat>
+            <c:strRef>
+              <c:f>Sheet1!$A$2:$A$15</c:f>
+              <c:strCache>
+                <c:ptCount val="14"/>
+                <c:pt idx="0">
+                  <c:v>Beshariq</c:v>
+                </c:pt>
+                <c:pt idx="1">
+                  <c:v>Qoʻshtepa</c:v>
+                </c:pt>
+                <c:pt idx="2">
+                  <c:v>Quva</c:v>
+                </c:pt>
+                <c:pt idx="3">
+                  <c:v>Oltiariq</c:v>
+                </c:pt>
+                <c:pt idx="4">
+                  <c:v>Dangʻara</c:v>
+                </c:pt>
+                <c:pt idx="5">
+                  <c:v>Rishton</c:v>
+                </c:pt>
+                <c:pt idx="6">
+                  <c:v>Fargʻona</c:v>
+                </c:pt>
+                <c:pt idx="7">
+                  <c:v>Uchkoʻprik</c:v>
+                </c:pt>
+                <c:pt idx="8">
+                  <c:v>Furqat</c:v>
+                </c:pt>
+                <c:pt idx="9">
+                  <c:v>Yozyovon</c:v>
+                </c:pt>
+                <c:pt idx="10">
+                  <c:v>Bogʻdod</c:v>
+                </c:pt>
+                <c:pt idx="11">
+                  <c:v>Buvayda</c:v>
+                </c:pt>
+                <c:pt idx="12">
+                  <c:v>Toshloq</c:v>
+                </c:pt>
+                <c:pt idx="13">
+                  <c:v>Oʻzbekiston</c:v>
+                </c:pt>
+              </c:strCache>
+            </c:strRef>
+          </c:cat>
+          <c:val>
+            <c:numRef>
+              <c:f>Sheet1!$B$2:$B$15</c:f>
+              <c:numCache>
+                <c:formatCode>General</c:formatCode>
+                <c:ptCount val="14"/>
+                <c:pt idx="0">
+                  <c:v>7995</c:v>
+                </c:pt>
+                <c:pt idx="1">
+                  <c:v>7240</c:v>
+                </c:pt>
+                <c:pt idx="2">
+                  <c:v>6225</c:v>
+                </c:pt>
+                <c:pt idx="3">
+                  <c:v>6220</c:v>
+                </c:pt>
+                <c:pt idx="4">
+                  <c:v>6190</c:v>
+                </c:pt>
+                <c:pt idx="5">
+                  <c:v>5950</c:v>
+                </c:pt>
+                <c:pt idx="6">
+                  <c:v>5815</c:v>
+                </c:pt>
+                <c:pt idx="7">
+                  <c:v>5720</c:v>
+                </c:pt>
+                <c:pt idx="8">
+                  <c:v>5425</c:v>
+                </c:pt>
+                <c:pt idx="9">
+                  <c:v>5210</c:v>
+                </c:pt>
+                <c:pt idx="10">
+                  <c:v>5200</c:v>
+                </c:pt>
+                <c:pt idx="11">
+                  <c:v>5120</c:v>
+                </c:pt>
+                <c:pt idx="12">
+                  <c:v>5120</c:v>
+                </c:pt>
+                <c:pt idx="13">
+                  <c:v>4650</c:v>
+                </c:pt>
+              </c:numCache>
+            </c:numRef>
+          </c:val>
+        </c:ser>
+        <c:dLbls>
+          <c:numFmt formatCode="#,##0" sourceLinked="0"/>
+          <c:txPr>
+            <a:bodyPr/>
+            <a:lstStyle/>
+            <a:p>
+              <a:pPr>
+                <a:defRPr sz="1200">
+                  <a:solidFill>
+                    <a:srgbClr val="1D2A24"/>
+                  </a:solidFill>
+                  <a:latin typeface="Inter"/>
+                </a:defRPr>
+              </a:pPr>
+            </a:p>
+          </c:txPr>
+          <c:dLblPos val="outEnd"/>
+          <c:showLegendKey val="0"/>
+          <c:showVal val="1"/>
+          <c:showCatName val="0"/>
+          <c:showSerName val="0"/>
+          <c:showPercent val="0"/>
+          <c:showBubbleSize val="0"/>
+          <c:showLeaderLines val="1"/>
+        </c:dLbls>
+        <c:gapWidth val="30"/>
+        <c:axId val="-2068027336"/>
+        <c:axId val="-2113994440"/>
+      </c:barChart>
+      <c:catAx>
+        <c:axId val="-2068027336"/>
+        <c:scaling>
+          <c:orientation val="maxMin"/>
+        </c:scaling>
+        <c:delete val="0"/>
+        <c:axPos val="l"/>
+        <c:majorTickMark val="out"/>
+        <c:minorTickMark val="none"/>
+        <c:tickLblPos val="nextTo"/>
+        <c:spPr>
+          <a:ln>
+            <a:solidFill>
+              <a:srgbClr val="B5B2AD"/>
+            </a:solidFill>
+          </a:ln>
+        </c:spPr>
+        <c:txPr>
+          <a:bodyPr/>
+          <a:lstStyle/>
+          <a:p>
+            <a:pPr>
+              <a:defRPr sz="1200">
+                <a:solidFill>
+                  <a:srgbClr val="4C5852"/>
+                </a:solidFill>
+                <a:latin typeface="Inter"/>
+              </a:defRPr>
+            </a:pPr>
+          </a:p>
+        </c:txPr>
+        <c:crossAx val="-2113994440"/>
+        <c:crosses val="autoZero"/>
+        <c:auto val="1"/>
+        <c:lblAlgn val="ctr"/>
+        <c:lblOffset val="100"/>
+        <c:noMultiLvlLbl val="0"/>
+      </c:catAx>
+      <c:valAx>
+        <c:axId val="-2113994440"/>
+        <c:scaling>
+          <c:max val="9500.0"/>
+          <c:min val="0.0"/>
+        </c:scaling>
+        <c:delete/>
+        <c:axPos val="b"/>
+        <c:majorTickMark val="out"/>
+        <c:minorTickMark val="none"/>
+        <c:tickLblPos val="nextTo"/>
+        <c:crossAx val="-2068027336"/>
+        <c:crosses val="autoZero"/>
+      </c:valAx>
+    </c:plotArea>
+    <c:dispBlanksAs val="gap"/>
+  </c:chart>
+  <c:txPr>
+    <a:bodyPr/>
+    <a:lstStyle/>
+    <a:p>
+      <a:pPr>
+        <a:defRPr sz="1200">
+          <a:solidFill>
+            <a:srgbClr val="4C5852"/>
+          </a:solidFill>
+          <a:latin typeface="Inter"/>
+        </a:defRPr>
+      </a:pPr>
+      <a:endParaRPr lang="en-US"/>
+    </a:p>
+  </c:txPr>
+  <c:externalData r:id="rId1">
+    <c:autoUpdate val="0"/>
+  </c:externalData>
+</c:chartSpace>
+</file>
+
+<file path=ppt/charts/chart13.xml><?xml version="1.0" encoding="utf-8"?>
+<c:chartSpace xmlns:c="http://schemas.openxmlformats.org/drawingml/2006/chart" xmlns:a="http://schemas.openxmlformats.org/drawingml/2006/main" xmlns:r="http://schemas.openxmlformats.org/officeDocument/2006/relationships">
+  <c:date1904 val="0"/>
+  <c:chart>
+    <c:autoTitleDeleted val="1"/>
+    <c:plotArea>
+      <c:barChart>
+        <c:barDir val="bar"/>
+        <c:grouping val="stacked"/>
+        <c:ser>
+          <c:idx val="0"/>
+          <c:order val="0"/>
+          <c:tx>
+            <c:strRef>
+              <c:f>Sheet1!$B$1</c:f>
+              <c:strCache>
+                <c:ptCount val="1"/>
+                <c:pt idx="0">
+                  <c:v>Kuchsiz shoʻrlangan</c:v>
+                </c:pt>
+              </c:strCache>
+            </c:strRef>
+          </c:tx>
+          <c:spPr>
+            <a:solidFill>
+              <a:srgbClr val="A9C4D1"/>
+            </a:solidFill>
+          </c:spPr>
+          <c:cat>
+            <c:strRef>
+              <c:f>Sheet1!$A$2:$A$12</c:f>
+              <c:strCache>
+                <c:ptCount val="11"/>
+                <c:pt idx="0">
+                  <c:v>Beshariq</c:v>
+                </c:pt>
+                <c:pt idx="1">
+                  <c:v>Dangʻara</c:v>
+                </c:pt>
+                <c:pt idx="2">
+                  <c:v>Furqat</c:v>
+                </c:pt>
+                <c:pt idx="3">
+                  <c:v>Buvayda</c:v>
+                </c:pt>
+                <c:pt idx="4">
+                  <c:v>Qoʻshtepa</c:v>
+                </c:pt>
+                <c:pt idx="5">
+                  <c:v>Bogʻdod</c:v>
+                </c:pt>
+                <c:pt idx="6">
+                  <c:v>Rishton</c:v>
+                </c:pt>
+                <c:pt idx="7">
+                  <c:v>Yozyovon</c:v>
+                </c:pt>
+                <c:pt idx="8">
+                  <c:v>Uchkoʻprik</c:v>
+                </c:pt>
+                <c:pt idx="9">
+                  <c:v>Oʻzbekiston</c:v>
+                </c:pt>
+                <c:pt idx="10">
+                  <c:v>Oltiariq</c:v>
+                </c:pt>
+              </c:strCache>
+            </c:strRef>
+          </c:cat>
+          <c:val>
+            <c:numRef>
+              <c:f>Sheet1!$B$2:$B$12</c:f>
+              <c:numCache>
+                <c:formatCode>General</c:formatCode>
+                <c:ptCount val="11"/>
+                <c:pt idx="0">
+                  <c:v>3914</c:v>
+                </c:pt>
+                <c:pt idx="1">
+                  <c:v>4782</c:v>
+                </c:pt>
+                <c:pt idx="2">
+                  <c:v>4253</c:v>
+                </c:pt>
+                <c:pt idx="3">
+                  <c:v>3483</c:v>
+                </c:pt>
+                <c:pt idx="4">
+                  <c:v>1760</c:v>
+                </c:pt>
+                <c:pt idx="5">
+                  <c:v>2770</c:v>
+                </c:pt>
+                <c:pt idx="6">
+                  <c:v>1930</c:v>
+                </c:pt>
+                <c:pt idx="7">
+                  <c:v>1777</c:v>
+                </c:pt>
+                <c:pt idx="8">
+                  <c:v>1790</c:v>
+                </c:pt>
+                <c:pt idx="9">
+                  <c:v>1611</c:v>
+                </c:pt>
+                <c:pt idx="10">
+                  <c:v>848</c:v>
+                </c:pt>
+              </c:numCache>
+            </c:numRef>
+          </c:val>
+        </c:ser>
+        <c:ser>
+          <c:idx val="1"/>
+          <c:order val="1"/>
+          <c:tx>
+            <c:strRef>
+              <c:f>Sheet1!$C$1</c:f>
+              <c:strCache>
+                <c:ptCount val="1"/>
+                <c:pt idx="0">
+                  <c:v>Oʻrta shoʻrlangan</c:v>
+                </c:pt>
+              </c:strCache>
+            </c:strRef>
+          </c:tx>
+          <c:spPr>
+            <a:solidFill>
+              <a:srgbClr val="2C6A85"/>
+            </a:solidFill>
+          </c:spPr>
+          <c:cat>
+            <c:strRef>
+              <c:f>Sheet1!$A$2:$A$12</c:f>
+              <c:strCache>
+                <c:ptCount val="11"/>
+                <c:pt idx="0">
+                  <c:v>Beshariq</c:v>
+                </c:pt>
+                <c:pt idx="1">
+                  <c:v>Dangʻara</c:v>
+                </c:pt>
+                <c:pt idx="2">
+                  <c:v>Furqat</c:v>
+                </c:pt>
+                <c:pt idx="3">
+                  <c:v>Buvayda</c:v>
+                </c:pt>
+                <c:pt idx="4">
+                  <c:v>Qoʻshtepa</c:v>
+                </c:pt>
+                <c:pt idx="5">
+                  <c:v>Bogʻdod</c:v>
+                </c:pt>
+                <c:pt idx="6">
+                  <c:v>Rishton</c:v>
+                </c:pt>
+                <c:pt idx="7">
+                  <c:v>Yozyovon</c:v>
+                </c:pt>
+                <c:pt idx="8">
+                  <c:v>Uchkoʻprik</c:v>
+                </c:pt>
+                <c:pt idx="9">
+                  <c:v>Oʻzbekiston</c:v>
+                </c:pt>
+                <c:pt idx="10">
+                  <c:v>Oltiariq</c:v>
+                </c:pt>
+              </c:strCache>
+            </c:strRef>
+          </c:cat>
+          <c:val>
+            <c:numRef>
+              <c:f>Sheet1!$C$2:$C$12</c:f>
+              <c:numCache>
+                <c:formatCode>General</c:formatCode>
+                <c:ptCount val="11"/>
+                <c:pt idx="0">
+                  <c:v>1946</c:v>
+                </c:pt>
+                <c:pt idx="1">
+                  <c:v>409</c:v>
+                </c:pt>
+                <c:pt idx="2">
+                  <c:v>97</c:v>
+                </c:pt>
+                <c:pt idx="3">
+                  <c:v>330</c:v>
+                </c:pt>
+                <c:pt idx="4">
+                  <c:v>890</c:v>
+                </c:pt>
+                <c:pt idx="5">
+                  <c:v>0</c:v>
+                </c:pt>
+                <c:pt idx="6">
+                  <c:v>0</c:v>
+                </c:pt>
+                <c:pt idx="7">
+                  <c:v>143</c:v>
+                </c:pt>
+                <c:pt idx="8">
+                  <c:v>0</c:v>
+                </c:pt>
+                <c:pt idx="9">
+                  <c:v>41</c:v>
+                </c:pt>
+                <c:pt idx="10">
+                  <c:v>11</c:v>
+                </c:pt>
+              </c:numCache>
+            </c:numRef>
+          </c:val>
+        </c:ser>
+        <c:ser>
+          <c:idx val="2"/>
+          <c:order val="2"/>
+          <c:tx>
+            <c:strRef>
+              <c:f>Sheet1!$D$1</c:f>
+              <c:strCache>
+                <c:ptCount val="1"/>
+                <c:pt idx="0">
+                  <c:v>Kuchli shoʻrlangan</c:v>
+                </c:pt>
+              </c:strCache>
+            </c:strRef>
+          </c:tx>
+          <c:spPr>
+            <a:solidFill>
+              <a:srgbClr val="A4521D"/>
+            </a:solidFill>
+          </c:spPr>
+          <c:cat>
+            <c:strRef>
+              <c:f>Sheet1!$A$2:$A$12</c:f>
+              <c:strCache>
+                <c:ptCount val="11"/>
+                <c:pt idx="0">
+                  <c:v>Beshariq</c:v>
+                </c:pt>
+                <c:pt idx="1">
+                  <c:v>Dangʻara</c:v>
+                </c:pt>
+                <c:pt idx="2">
+                  <c:v>Furqat</c:v>
+                </c:pt>
+                <c:pt idx="3">
+                  <c:v>Buvayda</c:v>
+                </c:pt>
+                <c:pt idx="4">
+                  <c:v>Qoʻshtepa</c:v>
+                </c:pt>
+                <c:pt idx="5">
+                  <c:v>Bogʻdod</c:v>
+                </c:pt>
+                <c:pt idx="6">
+                  <c:v>Rishton</c:v>
+                </c:pt>
+                <c:pt idx="7">
+                  <c:v>Yozyovon</c:v>
+                </c:pt>
+                <c:pt idx="8">
+                  <c:v>Uchkoʻprik</c:v>
+                </c:pt>
+                <c:pt idx="9">
+                  <c:v>Oʻzbekiston</c:v>
+                </c:pt>
+                <c:pt idx="10">
+                  <c:v>Oltiariq</c:v>
+                </c:pt>
+              </c:strCache>
+            </c:strRef>
+          </c:cat>
+          <c:val>
+            <c:numRef>
+              <c:f>Sheet1!$D$2:$D$12</c:f>
+              <c:numCache>
+                <c:formatCode>General</c:formatCode>
+                <c:ptCount val="11"/>
+                <c:pt idx="0">
+                  <c:v>0</c:v>
+                </c:pt>
+                <c:pt idx="1">
+                  <c:v>109</c:v>
+                </c:pt>
+                <c:pt idx="2">
+                  <c:v>88</c:v>
+                </c:pt>
+                <c:pt idx="3">
+                  <c:v>0</c:v>
+                </c:pt>
+                <c:pt idx="4">
+                  <c:v>122</c:v>
+                </c:pt>
+                <c:pt idx="5">
+                  <c:v>0</c:v>
+                </c:pt>
+                <c:pt idx="6">
+                  <c:v>0</c:v>
+                </c:pt>
+                <c:pt idx="7">
+                  <c:v>0</c:v>
+                </c:pt>
+                <c:pt idx="8">
+                  <c:v>0</c:v>
+                </c:pt>
+                <c:pt idx="9">
+                  <c:v>0</c:v>
+                </c:pt>
+                <c:pt idx="10">
+                  <c:v>0</c:v>
+                </c:pt>
+              </c:numCache>
+            </c:numRef>
+          </c:val>
+        </c:ser>
+        <c:gapWidth val="40"/>
+        <c:overlap val="100"/>
+        <c:axId val="-2068027336"/>
+        <c:axId val="-2113994440"/>
+      </c:barChart>
+      <c:catAx>
+        <c:axId val="-2068027336"/>
+        <c:scaling>
+          <c:orientation val="maxMin"/>
+        </c:scaling>
+        <c:delete val="0"/>
+        <c:axPos val="l"/>
+        <c:majorTickMark val="out"/>
+        <c:minorTickMark val="none"/>
+        <c:tickLblPos val="nextTo"/>
+        <c:spPr>
+          <a:ln>
+            <a:solidFill>
+              <a:srgbClr val="B5B2AD"/>
+            </a:solidFill>
+          </a:ln>
+        </c:spPr>
+        <c:txPr>
+          <a:bodyPr/>
+          <a:lstStyle/>
+          <a:p>
+            <a:pPr>
+              <a:defRPr sz="1200">
+                <a:solidFill>
+                  <a:srgbClr val="4C5852"/>
+                </a:solidFill>
+                <a:latin typeface="Inter"/>
+              </a:defRPr>
+            </a:pPr>
+          </a:p>
+        </c:txPr>
+        <c:crossAx val="-2113994440"/>
+        <c:crosses val="autoZero"/>
+        <c:auto val="1"/>
+        <c:lblAlgn val="ctr"/>
+        <c:lblOffset val="100"/>
+        <c:noMultiLvlLbl val="0"/>
+      </c:catAx>
+      <c:valAx>
+        <c:axId val="-2113994440"/>
+        <c:scaling>
+          <c:max val="6000.0"/>
+          <c:min val="0.0"/>
+        </c:scaling>
+        <c:delete val="0"/>
+        <c:axPos val="b"/>
+        <c:majorGridlines>
+          <c:spPr>
+            <a:ln>
+              <a:solidFill>
+                <a:srgbClr val="D9D2C3"/>
+              </a:solidFill>
+            </a:ln>
+          </c:spPr>
+        </c:majorGridlines>
+        <c:numFmt formatCode="#,##0" sourceLinked="0"/>
+        <c:majorTickMark val="out"/>
+        <c:minorTickMark val="none"/>
+        <c:tickLblPos val="nextTo"/>
+        <c:spPr>
+          <a:ln>
+            <a:noFill/>
+          </a:ln>
+        </c:spPr>
+        <c:txPr>
+          <a:bodyPr/>
+          <a:lstStyle/>
+          <a:p>
+            <a:pPr>
+              <a:defRPr sz="1200">
+                <a:solidFill>
+                  <a:srgbClr val="4C5852"/>
+                </a:solidFill>
+                <a:latin typeface="Inter"/>
+              </a:defRPr>
+            </a:pPr>
+          </a:p>
+        </c:txPr>
+        <c:crossAx val="-2068027336"/>
+        <c:crosses val="autoZero"/>
+      </c:valAx>
+    </c:plotArea>
+    <c:legend>
+      <c:legendPos val="t"/>
+      <c:overlay val="0"/>
+      <c:txPr>
+        <a:bodyPr/>
+        <a:lstStyle/>
+        <a:p>
+          <a:pPr>
+            <a:defRPr sz="1200">
+              <a:solidFill>
+                <a:srgbClr val="4C5852"/>
+              </a:solidFill>
+              <a:latin typeface="Inter"/>
+            </a:defRPr>
+          </a:pPr>
+        </a:p>
+      </c:txPr>
+    </c:legend>
+    <c:dispBlanksAs val="gap"/>
+  </c:chart>
+  <c:txPr>
+    <a:bodyPr/>
+    <a:lstStyle/>
+    <a:p>
+      <a:pPr>
+        <a:defRPr sz="1200">
+          <a:solidFill>
+            <a:srgbClr val="4C5852"/>
+          </a:solidFill>
+          <a:latin typeface="Inter"/>
+        </a:defRPr>
+      </a:pPr>
+      <a:endParaRPr lang="en-US"/>
+    </a:p>
+  </c:txPr>
+  <c:externalData r:id="rId1">
+    <c:autoUpdate val="0"/>
+  </c:externalData>
+</c:chartSpace>
+</file>
+
+<file path=ppt/charts/chart14.xml><?xml version="1.0" encoding="utf-8"?>
+<c:chartSpace xmlns:c="http://schemas.openxmlformats.org/drawingml/2006/chart" xmlns:a="http://schemas.openxmlformats.org/drawingml/2006/main" xmlns:r="http://schemas.openxmlformats.org/officeDocument/2006/relationships">
+  <c:date1904 val="0"/>
+  <c:chart>
+    <c:autoTitleDeleted val="1"/>
+    <c:plotArea>
+      <c:barChart>
+        <c:barDir val="col"/>
+        <c:grouping val="stacked"/>
+        <c:ser>
+          <c:idx val="0"/>
+          <c:order val="0"/>
+          <c:tx>
+            <c:strRef>
+              <c:f>Sheet1!$B$1</c:f>
+              <c:strCache>
+                <c:ptCount val="1"/>
+                <c:pt idx="0">
+                  <c:v>Kuchsiz shoʻrlangan</c:v>
+                </c:pt>
+              </c:strCache>
+            </c:strRef>
+          </c:tx>
+          <c:spPr>
+            <a:solidFill>
+              <a:srgbClr val="A9C4D1"/>
+            </a:solidFill>
+          </c:spPr>
+          <c:cat>
+            <c:strRef>
+              <c:f>Sheet1!$A$2:$A$4</c:f>
+              <c:strCache>
+                <c:ptCount val="3"/>
+                <c:pt idx="0">
+                  <c:v>Ulugʻnor</c:v>
+                </c:pt>
+                <c:pt idx="1">
+                  <c:v>Baliqchi</c:v>
+                </c:pt>
+                <c:pt idx="2">
+                  <c:v>Boʻston</c:v>
+                </c:pt>
+              </c:strCache>
+            </c:strRef>
+          </c:cat>
+          <c:val>
+            <c:numRef>
+              <c:f>Sheet1!$B$2:$B$4</c:f>
+              <c:numCache>
+                <c:formatCode>General</c:formatCode>
+                <c:ptCount val="3"/>
+                <c:pt idx="0">
+                  <c:v>2202</c:v>
+                </c:pt>
+                <c:pt idx="1">
+                  <c:v>956</c:v>
+                </c:pt>
+                <c:pt idx="2">
+                  <c:v>297</c:v>
+                </c:pt>
+              </c:numCache>
+            </c:numRef>
+          </c:val>
+        </c:ser>
+        <c:ser>
+          <c:idx val="1"/>
+          <c:order val="1"/>
+          <c:tx>
+            <c:strRef>
+              <c:f>Sheet1!$C$1</c:f>
+              <c:strCache>
+                <c:ptCount val="1"/>
+                <c:pt idx="0">
+                  <c:v>Oʻrta shoʻrlangan</c:v>
+                </c:pt>
+              </c:strCache>
+            </c:strRef>
+          </c:tx>
+          <c:spPr>
+            <a:solidFill>
+              <a:srgbClr val="2C6A85"/>
+            </a:solidFill>
+          </c:spPr>
+          <c:cat>
+            <c:strRef>
+              <c:f>Sheet1!$A$2:$A$4</c:f>
+              <c:strCache>
+                <c:ptCount val="3"/>
+                <c:pt idx="0">
+                  <c:v>Ulugʻnor</c:v>
+                </c:pt>
+                <c:pt idx="1">
+                  <c:v>Baliqchi</c:v>
+                </c:pt>
+                <c:pt idx="2">
+                  <c:v>Boʻston</c:v>
+                </c:pt>
+              </c:strCache>
+            </c:strRef>
+          </c:cat>
+          <c:val>
+            <c:numRef>
+              <c:f>Sheet1!$C$2:$C$4</c:f>
+              <c:numCache>
+                <c:formatCode>General</c:formatCode>
+                <c:ptCount val="3"/>
+                <c:pt idx="0">
+                  <c:v>1627</c:v>
+                </c:pt>
+                <c:pt idx="1">
+                  <c:v>293</c:v>
+                </c:pt>
+                <c:pt idx="2">
+                  <c:v>305</c:v>
+                </c:pt>
+              </c:numCache>
+            </c:numRef>
+          </c:val>
+        </c:ser>
+        <c:gapWidth val="40"/>
+        <c:overlap val="100"/>
+        <c:axId val="-2068027336"/>
+        <c:axId val="-2113994440"/>
+      </c:barChart>
+      <c:catAx>
+        <c:axId val="-2068027336"/>
+        <c:scaling>
+          <c:orientation val="minMax"/>
+        </c:scaling>
+        <c:delete val="0"/>
+        <c:axPos val="b"/>
+        <c:majorTickMark val="out"/>
+        <c:minorTickMark val="none"/>
+        <c:tickLblPos val="nextTo"/>
+        <c:spPr>
+          <a:ln>
+            <a:solidFill>
+              <a:srgbClr val="B5B2AD"/>
+            </a:solidFill>
+          </a:ln>
+        </c:spPr>
+        <c:txPr>
+          <a:bodyPr/>
+          <a:lstStyle/>
+          <a:p>
+            <a:pPr>
+              <a:defRPr sz="1200">
+                <a:solidFill>
+                  <a:srgbClr val="4C5852"/>
+                </a:solidFill>
+                <a:latin typeface="Inter"/>
+              </a:defRPr>
+            </a:pPr>
+          </a:p>
+        </c:txPr>
+        <c:crossAx val="-2113994440"/>
+        <c:crosses val="autoZero"/>
+        <c:auto val="1"/>
+        <c:lblAlgn val="ctr"/>
+        <c:lblOffset val="100"/>
+        <c:noMultiLvlLbl val="0"/>
+      </c:catAx>
+      <c:valAx>
+        <c:axId val="-2113994440"/>
+        <c:scaling>
+          <c:max val="4500.0"/>
+          <c:min val="0.0"/>
+        </c:scaling>
+        <c:delete val="0"/>
+        <c:axPos val="l"/>
+        <c:majorGridlines>
+          <c:spPr>
+            <a:ln>
+              <a:solidFill>
+                <a:srgbClr val="D9D2C3"/>
+              </a:solidFill>
+            </a:ln>
+          </c:spPr>
+        </c:majorGridlines>
+        <c:numFmt formatCode="#,##0" sourceLinked="0"/>
+        <c:majorTickMark val="out"/>
+        <c:minorTickMark val="none"/>
+        <c:tickLblPos val="nextTo"/>
+        <c:spPr>
+          <a:ln>
+            <a:noFill/>
+          </a:ln>
+        </c:spPr>
+        <c:txPr>
+          <a:bodyPr/>
+          <a:lstStyle/>
+          <a:p>
+            <a:pPr>
+              <a:defRPr sz="1200">
+                <a:solidFill>
+                  <a:srgbClr val="4C5852"/>
+                </a:solidFill>
+                <a:latin typeface="Inter"/>
+              </a:defRPr>
+            </a:pPr>
+          </a:p>
+        </c:txPr>
+        <c:crossAx val="-2068027336"/>
+        <c:crosses val="autoZero"/>
+      </c:valAx>
+    </c:plotArea>
+    <c:legend>
+      <c:legendPos val="t"/>
+      <c:overlay val="0"/>
+      <c:txPr>
+        <a:bodyPr/>
+        <a:lstStyle/>
+        <a:p>
+          <a:pPr>
+            <a:defRPr sz="1200">
+              <a:solidFill>
+                <a:srgbClr val="4C5852"/>
+              </a:solidFill>
+              <a:latin typeface="Inter"/>
+            </a:defRPr>
+          </a:pPr>
+        </a:p>
+      </c:txPr>
+    </c:legend>
     <c:dispBlanksAs val="gap"/>
   </c:chart>
   <c:txPr>
@@ -5603,7 +6542,7 @@
                 <a:ea typeface="Inter" pitchFamily="34" charset="-122"/>
                 <a:cs typeface="Inter" pitchFamily="34" charset="-120"/>
               </a:rPr>
-              <a:t>18 · DISSERTATSIYA TUZILISHI</a:t>
+              <a:t>21 · DISSERTATSIYA TUZILISHI</a:t>
             </a:r>
             <a:endParaRPr lang="en-US" sz="1200" dirty="0"/>
           </a:p>
@@ -6402,7 +7341,7 @@
                 <a:ea typeface="Inter" pitchFamily="34" charset="-122"/>
                 <a:cs typeface="Inter" pitchFamily="34" charset="-120"/>
               </a:rPr>
-              <a:t>19</a:t>
+              <a:t>22</a:t>
             </a:r>
             <a:endParaRPr lang="en-US" sz="1200" dirty="0"/>
           </a:p>
@@ -6478,7 +7417,7 @@
                 <a:ea typeface="Inter" pitchFamily="34" charset="-122"/>
                 <a:cs typeface="Inter" pitchFamily="34" charset="-120"/>
               </a:rPr>
-              <a:t>19 · DISSERTATSIYA TUZILISHI</a:t>
+              <a:t>22 · DISSERTATSIYA TUZILISHI</a:t>
             </a:r>
             <a:endParaRPr lang="en-US" sz="1200" dirty="0"/>
           </a:p>
@@ -7510,7 +8449,7 @@
                 <a:ea typeface="Inter" pitchFamily="34" charset="-122"/>
                 <a:cs typeface="Inter" pitchFamily="34" charset="-120"/>
               </a:rPr>
-              <a:t>20</a:t>
+              <a:t>23</a:t>
             </a:r>
             <a:endParaRPr lang="en-US" sz="1200" dirty="0"/>
           </a:p>
@@ -7586,7 +8525,7 @@
                 <a:ea typeface="Inter" pitchFamily="34" charset="-122"/>
                 <a:cs typeface="Inter" pitchFamily="34" charset="-120"/>
               </a:rPr>
-              <a:t>20 · DISSERTATSIYA TUZILISHI</a:t>
+              <a:t>23 · DISSERTATSIYA TUZILISHI</a:t>
             </a:r>
             <a:endParaRPr lang="en-US" sz="1200" dirty="0"/>
           </a:p>
@@ -8613,7 +9552,7 @@
                 <a:ea typeface="Inter" pitchFamily="34" charset="-122"/>
                 <a:cs typeface="Inter" pitchFamily="34" charset="-120"/>
               </a:rPr>
-              <a:t>21</a:t>
+              <a:t>24</a:t>
             </a:r>
             <a:endParaRPr lang="en-US" sz="1200" dirty="0"/>
           </a:p>
@@ -8689,7 +9628,7 @@
                 <a:ea typeface="Inter" pitchFamily="34" charset="-122"/>
                 <a:cs typeface="Inter" pitchFamily="34" charset="-120"/>
               </a:rPr>
-              <a:t>21 · NATIJALAR VA REJA</a:t>
+              <a:t>24 · NATIJALAR VA REJA</a:t>
             </a:r>
             <a:endParaRPr lang="en-US" sz="1200" dirty="0"/>
           </a:p>
@@ -9427,7 +10366,7 @@
                 <a:ea typeface="Inter" pitchFamily="34" charset="-122"/>
                 <a:cs typeface="Inter" pitchFamily="34" charset="-120"/>
               </a:rPr>
-              <a:t>22</a:t>
+              <a:t>25</a:t>
             </a:r>
             <a:endParaRPr lang="en-US" sz="1200" dirty="0"/>
           </a:p>
@@ -9503,7 +10442,7 @@
                 <a:ea typeface="Inter" pitchFamily="34" charset="-122"/>
                 <a:cs typeface="Inter" pitchFamily="34" charset="-120"/>
               </a:rPr>
-              <a:t>22 · NATIJALAR VA REJA</a:t>
+              <a:t>25 · NATIJALAR VA REJA</a:t>
             </a:r>
             <a:endParaRPr lang="en-US" sz="1200" dirty="0"/>
           </a:p>
@@ -10529,7 +11468,7 @@
                 <a:ea typeface="Inter" pitchFamily="34" charset="-122"/>
                 <a:cs typeface="Inter" pitchFamily="34" charset="-120"/>
               </a:rPr>
-              <a:t>23</a:t>
+              <a:t>26</a:t>
             </a:r>
             <a:endParaRPr lang="en-US" sz="1200" dirty="0"/>
           </a:p>
@@ -10605,7 +11544,7 @@
                 <a:ea typeface="Inter" pitchFamily="34" charset="-122"/>
                 <a:cs typeface="Inter" pitchFamily="34" charset="-120"/>
               </a:rPr>
-              <a:t>23 · NATIJALAR VA REJA</a:t>
+              <a:t>26 · NATIJALAR VA REJA</a:t>
             </a:r>
             <a:endParaRPr lang="en-US" sz="1200" dirty="0"/>
           </a:p>
@@ -11217,7 +12156,7 @@
                 <a:ea typeface="Inter" pitchFamily="34" charset="-122"/>
                 <a:cs typeface="Inter" pitchFamily="34" charset="-120"/>
               </a:rPr>
-              <a:t>24</a:t>
+              <a:t>27</a:t>
             </a:r>
             <a:endParaRPr lang="en-US" sz="1200" dirty="0"/>
           </a:p>
@@ -17723,6 +18662,1809 @@
                 <a:latin typeface="Inter"/>
               </a:rPr>
               <a:t>Manba: Namangan viloyati suv xoʻjaligi obyektlarini davlat roʻyxatidan oʻtkazish toʻgʻrisida maʼlumot, 29.01.2026</a:t>
+            </a:r>
+          </a:p>
+        </p:txBody>
+      </p:sp>
+    </p:spTree>
+  </p:cSld>
+  <p:clrMapOvr>
+    <a:masterClrMapping/>
+  </p:clrMapOvr>
+</p:sld>
+</file>
+
+<file path=ppt/slides/slide26.xml><?xml version="1.0" encoding="utf-8"?>
+<p:sld xmlns:a="http://schemas.openxmlformats.org/drawingml/2006/main" xmlns:p="http://schemas.openxmlformats.org/presentationml/2006/main" xmlns:r="http://schemas.openxmlformats.org/officeDocument/2006/relationships">
+  <p:cSld>
+    <p:bg>
+      <p:bgPr>
+        <a:solidFill>
+          <a:srgbClr val="F4F1EA"/>
+        </a:solidFill>
+      </p:bgPr>
+    </p:bg>
+    <p:spTree>
+      <p:nvGrpSpPr>
+        <p:cNvPr id="1" name=""/>
+        <p:cNvGrpSpPr/>
+        <p:nvPr/>
+      </p:nvGrpSpPr>
+      <p:grpSpPr/>
+      <p:sp>
+        <p:nvSpPr>
+          <p:cNvPr id="2" name="Text 0"/>
+          <p:cNvSpPr/>
+          <p:nvPr/>
+        </p:nvSpPr>
+        <p:spPr>
+          <a:xfrm>
+            <a:off x="812800" y="812800"/>
+            <a:ext cx="10883392" cy="238720"/>
+          </a:xfrm>
+          <a:prstGeom prst="rect">
+            <a:avLst/>
+          </a:prstGeom>
+          <a:noFill/>
+          <a:ln/>
+        </p:spPr>
+        <p:txBody>
+          <a:bodyPr wrap="square" lIns="0" tIns="0" rIns="0" bIns="0" rtlCol="0" anchor="t">
+            <a:normAutofit/>
+          </a:bodyPr>
+          <a:lstStyle/>
+          <a:p>
+            <a:pPr algn="l" indent="0" marL="0">
+              <a:lnSpc>
+                <a:spcPts val="1680"/>
+              </a:lnSpc>
+              <a:buNone/>
+            </a:pPr>
+            <a:r>
+              <a:rPr lang="en-US" sz="1200" b="1" spc="150" kern="0" dirty="0">
+                <a:solidFill>
+                  <a:srgbClr val="2C6A85"/>
+                </a:solidFill>
+                <a:latin typeface="Inter" pitchFamily="34" charset="0"/>
+                <a:ea typeface="Inter" pitchFamily="34" charset="-122"/>
+                <a:cs typeface="Inter" pitchFamily="34" charset="-120"/>
+              </a:rPr>
+              <a:t>18 · DASTLABKI MAʼLUMOTLAR</a:t>
+            </a:r>
+            <a:endParaRPr lang="en-US" sz="1200" dirty="0"/>
+          </a:p>
+        </p:txBody>
+      </p:sp>
+      <p:sp>
+        <p:nvSpPr>
+          <p:cNvPr id="3" name="Text 1"/>
+          <p:cNvSpPr/>
+          <p:nvPr>
+            <p:ph type="title"/>
+          </p:nvPr>
+        </p:nvSpPr>
+        <p:spPr>
+          <a:xfrm>
+            <a:off x="812800" y="1127720"/>
+            <a:ext cx="10883392" cy="472430"/>
+          </a:xfrm>
+          <a:prstGeom prst="rect">
+            <a:avLst/>
+          </a:prstGeom>
+          <a:noFill/>
+          <a:ln/>
+        </p:spPr>
+        <p:txBody>
+          <a:bodyPr wrap="square" lIns="0" tIns="0" rIns="0" bIns="0" rtlCol="0" anchor="t">
+            <a:normAutofit/>
+          </a:bodyPr>
+          <a:lstStyle/>
+          <a:p>
+            <a:pPr algn="l" indent="0" marL="0">
+              <a:lnSpc>
+                <a:spcPts val="3520"/>
+              </a:lnSpc>
+              <a:buNone/>
+            </a:pPr>
+            <a:r>
+              <a:rPr lang="en-US" sz="3200" b="0" i="0" dirty="0">
+                <a:solidFill>
+                  <a:srgbClr val="1D2A24"/>
+                </a:solidFill>
+                <a:latin typeface="Source Serif 4" pitchFamily="18" charset="0"/>
+                <a:ea typeface="Source Serif 4" pitchFamily="18" charset="-122"/>
+                <a:cs typeface="Source Serif 4" pitchFamily="18" charset="-120"/>
+              </a:rPr>
+              <a:t>Fargʻona viloyati: ekin joylashtirish</a:t>
+            </a:r>
+            <a:endParaRPr lang="en-US" sz="3200" dirty="0"/>
+          </a:p>
+        </p:txBody>
+      </p:sp>
+      <p:sp>
+        <p:nvSpPr>
+          <p:cNvPr id="6" name="Text 3"/>
+          <p:cNvSpPr/>
+          <p:nvPr/>
+        </p:nvSpPr>
+        <p:spPr>
+          <a:xfrm>
+            <a:off x="11137950" y="6238280"/>
+            <a:ext cx="241250" cy="238720"/>
+          </a:xfrm>
+          <a:prstGeom prst="rect">
+            <a:avLst/>
+          </a:prstGeom>
+          <a:noFill/>
+          <a:ln/>
+        </p:spPr>
+        <p:txBody>
+          <a:bodyPr wrap="square" lIns="0" tIns="0" rIns="0" bIns="0" rtlCol="0" anchor="t">
+            <a:normAutofit/>
+          </a:bodyPr>
+          <a:lstStyle/>
+          <a:p>
+            <a:pPr algn="r" indent="0" marL="0">
+              <a:lnSpc>
+                <a:spcPts val="1680"/>
+              </a:lnSpc>
+              <a:buNone/>
+            </a:pPr>
+            <a:r>
+              <a:rPr lang="en-US" sz="1200" dirty="0">
+                <a:solidFill>
+                  <a:srgbClr val="5F6B64"/>
+                </a:solidFill>
+                <a:latin typeface="Inter" pitchFamily="34" charset="0"/>
+                <a:ea typeface="Inter" pitchFamily="34" charset="-122"/>
+                <a:cs typeface="Inter" pitchFamily="34" charset="-120"/>
+              </a:rPr>
+              <a:t>19</a:t>
+            </a:r>
+            <a:endParaRPr lang="en-US" sz="1200" dirty="0"/>
+          </a:p>
+        </p:txBody>
+      </p:sp>
+      <p:sp>
+        <p:nvSpPr>
+          <p:cNvPr id="7" name="TextBox 6"/>
+          <p:cNvSpPr txBox="1"/>
+          <p:nvPr/>
+        </p:nvSpPr>
+        <p:spPr>
+          <a:xfrm>
+            <a:off x="812800" y="1830000"/>
+            <a:ext cx="6200000" cy="260000"/>
+          </a:xfrm>
+          <a:prstGeom prst="rect">
+            <a:avLst/>
+          </a:prstGeom>
+          <a:noFill/>
+        </p:spPr>
+        <p:txBody>
+          <a:bodyPr wrap="square" lIns="0" rIns="0" tIns="0" bIns="0" anchor="t">
+            <a:spAutoFit/>
+          </a:bodyPr>
+          <a:lstStyle/>
+          <a:p>
+            <a:pPr algn="l"/>
+            <a:r>
+              <a:rPr sz="1300" b="1">
+                <a:solidFill>
+                  <a:srgbClr val="2C6A85"/>
+                </a:solidFill>
+                <a:latin typeface="Inter"/>
+              </a:rPr>
+              <a:t>Gʻoʻza maydoni tumanlar boʻyicha, ga (2022 yil hosili)</a:t>
+            </a:r>
+          </a:p>
+        </p:txBody>
+      </p:sp>
+      <p:graphicFrame>
+        <p:nvGraphicFramePr>
+          <p:cNvPr id="8" name="Chart 7"/>
+          <p:cNvGraphicFramePr>
+            <a:graphicFrameLocks noGrp="1"/>
+          </p:cNvGraphicFramePr>
+          <p:nvPr/>
+        </p:nvGraphicFramePr>
+        <p:xfrm>
+          <a:off x="752800" y="2100000"/>
+          <a:ext cx="6500000" cy="3950000"/>
+        </p:xfrm>
+        <a:graphic>
+          <a:graphicData uri="http://schemas.openxmlformats.org/drawingml/2006/chart">
+            <c:chart xmlns:c="http://schemas.openxmlformats.org/drawingml/2006/chart" r:id="rId2"/>
+          </a:graphicData>
+        </a:graphic>
+      </p:graphicFrame>
+      <p:sp>
+        <p:nvSpPr>
+          <p:cNvPr id="9" name="Rounded Rectangle 8"/>
+          <p:cNvSpPr/>
+          <p:nvPr/>
+        </p:nvSpPr>
+        <p:spPr>
+          <a:xfrm>
+            <a:off x="7700000" y="1830000"/>
+            <a:ext cx="3996192" cy="1230000"/>
+          </a:xfrm>
+          <a:prstGeom prst="roundRect">
+            <a:avLst>
+              <a:gd name="adj" fmla="val 5000"/>
+            </a:avLst>
+          </a:prstGeom>
+          <a:solidFill>
+            <a:srgbClr val="FBF9F4"/>
+          </a:solidFill>
+          <a:ln w="6350">
+            <a:solidFill>
+              <a:srgbClr val="D9D2C3"/>
+            </a:solidFill>
+          </a:ln>
+          <a:effectLst/>
+        </p:spPr>
+        <p:style>
+          <a:lnRef idx="1">
+            <a:schemeClr val="accent1"/>
+          </a:lnRef>
+          <a:fillRef idx="3">
+            <a:schemeClr val="accent1"/>
+          </a:fillRef>
+          <a:effectRef idx="2">
+            <a:schemeClr val="accent1"/>
+          </a:effectRef>
+          <a:fontRef idx="minor">
+            <a:schemeClr val="lt1"/>
+          </a:fontRef>
+        </p:style>
+        <p:txBody>
+          <a:bodyPr rtlCol="0" anchor="ctr"/>
+          <a:lstStyle/>
+          <a:p>
+            <a:pPr algn="ctr"/>
+          </a:p>
+        </p:txBody>
+      </p:sp>
+      <p:sp>
+        <p:nvSpPr>
+          <p:cNvPr id="10" name="TextBox 9"/>
+          <p:cNvSpPr txBox="1"/>
+          <p:nvPr/>
+        </p:nvSpPr>
+        <p:spPr>
+          <a:xfrm>
+            <a:off x="7930000" y="1950000"/>
+            <a:ext cx="3536192" cy="420000"/>
+          </a:xfrm>
+          <a:prstGeom prst="rect">
+            <a:avLst/>
+          </a:prstGeom>
+          <a:noFill/>
+        </p:spPr>
+        <p:txBody>
+          <a:bodyPr wrap="square" lIns="0" rIns="0" tIns="0" bIns="0" anchor="t">
+            <a:spAutoFit/>
+          </a:bodyPr>
+          <a:lstStyle/>
+          <a:p>
+            <a:pPr algn="l"/>
+            <a:r>
+              <a:rPr sz="2400" b="0">
+                <a:solidFill>
+                  <a:srgbClr val="A4521D"/>
+                </a:solidFill>
+                <a:latin typeface="Source Serif 4"/>
+              </a:rPr>
+              <a:t>242,1 ming ga</a:t>
+            </a:r>
+          </a:p>
+        </p:txBody>
+      </p:sp>
+      <p:sp>
+        <p:nvSpPr>
+          <p:cNvPr id="11" name="TextBox 10"/>
+          <p:cNvSpPr txBox="1"/>
+          <p:nvPr/>
+        </p:nvSpPr>
+        <p:spPr>
+          <a:xfrm>
+            <a:off x="7930000" y="2390000"/>
+            <a:ext cx="3536192" cy="620000"/>
+          </a:xfrm>
+          <a:prstGeom prst="rect">
+            <a:avLst/>
+          </a:prstGeom>
+          <a:noFill/>
+        </p:spPr>
+        <p:txBody>
+          <a:bodyPr wrap="square" lIns="0" rIns="0" tIns="0" bIns="0" anchor="t">
+            <a:spAutoFit/>
+          </a:bodyPr>
+          <a:lstStyle/>
+          <a:p>
+            <a:pPr algn="l"/>
+            <a:r>
+              <a:rPr sz="1200" b="0">
+                <a:solidFill>
+                  <a:srgbClr val="4C5852"/>
+                </a:solidFill>
+                <a:latin typeface="Inter"/>
+              </a:rPr>
+              <a:t>Jami ekin joylashtirish (2022 yil hosili); gʻoʻza — 82,1 ming ga (34%), donli ekinlar — 99,5 ming ga (41%)</a:t>
+            </a:r>
+          </a:p>
+        </p:txBody>
+      </p:sp>
+      <p:sp>
+        <p:nvSpPr>
+          <p:cNvPr id="12" name="Rounded Rectangle 11"/>
+          <p:cNvSpPr/>
+          <p:nvPr/>
+        </p:nvSpPr>
+        <p:spPr>
+          <a:xfrm>
+            <a:off x="7700000" y="3210000"/>
+            <a:ext cx="3996192" cy="1230000"/>
+          </a:xfrm>
+          <a:prstGeom prst="roundRect">
+            <a:avLst>
+              <a:gd name="adj" fmla="val 5000"/>
+            </a:avLst>
+          </a:prstGeom>
+          <a:solidFill>
+            <a:srgbClr val="FBF9F4"/>
+          </a:solidFill>
+          <a:ln w="6350">
+            <a:solidFill>
+              <a:srgbClr val="D9D2C3"/>
+            </a:solidFill>
+          </a:ln>
+          <a:effectLst/>
+        </p:spPr>
+        <p:style>
+          <a:lnRef idx="1">
+            <a:schemeClr val="accent1"/>
+          </a:lnRef>
+          <a:fillRef idx="3">
+            <a:schemeClr val="accent1"/>
+          </a:fillRef>
+          <a:effectRef idx="2">
+            <a:schemeClr val="accent1"/>
+          </a:effectRef>
+          <a:fontRef idx="minor">
+            <a:schemeClr val="lt1"/>
+          </a:fontRef>
+        </p:style>
+        <p:txBody>
+          <a:bodyPr rtlCol="0" anchor="ctr"/>
+          <a:lstStyle/>
+          <a:p>
+            <a:pPr algn="ctr"/>
+          </a:p>
+        </p:txBody>
+      </p:sp>
+      <p:sp>
+        <p:nvSpPr>
+          <p:cNvPr id="13" name="TextBox 12"/>
+          <p:cNvSpPr txBox="1"/>
+          <p:nvPr/>
+        </p:nvSpPr>
+        <p:spPr>
+          <a:xfrm>
+            <a:off x="7930000" y="3330000"/>
+            <a:ext cx="3536192" cy="420000"/>
+          </a:xfrm>
+          <a:prstGeom prst="rect">
+            <a:avLst/>
+          </a:prstGeom>
+          <a:noFill/>
+        </p:spPr>
+        <p:txBody>
+          <a:bodyPr wrap="square" lIns="0" rIns="0" tIns="0" bIns="0" anchor="t">
+            <a:spAutoFit/>
+          </a:bodyPr>
+          <a:lstStyle/>
+          <a:p>
+            <a:pPr algn="l"/>
+            <a:r>
+              <a:rPr sz="2400" b="0">
+                <a:solidFill>
+                  <a:srgbClr val="2C6A85"/>
+                </a:solidFill>
+                <a:latin typeface="Source Serif 4"/>
+              </a:rPr>
+              <a:t>11 177 fermer</a:t>
+            </a:r>
+          </a:p>
+        </p:txBody>
+      </p:sp>
+      <p:sp>
+        <p:nvSpPr>
+          <p:cNvPr id="14" name="TextBox 13"/>
+          <p:cNvSpPr txBox="1"/>
+          <p:nvPr/>
+        </p:nvSpPr>
+        <p:spPr>
+          <a:xfrm>
+            <a:off x="7930000" y="3770000"/>
+            <a:ext cx="3536192" cy="620000"/>
+          </a:xfrm>
+          <a:prstGeom prst="rect">
+            <a:avLst/>
+          </a:prstGeom>
+          <a:noFill/>
+        </p:spPr>
+        <p:txBody>
+          <a:bodyPr wrap="square" lIns="0" rIns="0" tIns="0" bIns="0" anchor="t">
+            <a:spAutoFit/>
+          </a:bodyPr>
+          <a:lstStyle/>
+          <a:p>
+            <a:pPr algn="l"/>
+            <a:r>
+              <a:rPr sz="1200" b="0">
+                <a:solidFill>
+                  <a:srgbClr val="4C5852"/>
+                </a:solidFill>
+                <a:latin typeface="Inter"/>
+              </a:rPr>
+              <a:t>Fermer xoʻjaliklari (2023-yil 1-yanvar): umumiy yer 350,0 ming ga, shundan ekin yeri 241,3 ming ga</a:t>
+            </a:r>
+          </a:p>
+        </p:txBody>
+      </p:sp>
+      <p:sp>
+        <p:nvSpPr>
+          <p:cNvPr id="15" name="Rounded Rectangle 14"/>
+          <p:cNvSpPr/>
+          <p:nvPr/>
+        </p:nvSpPr>
+        <p:spPr>
+          <a:xfrm>
+            <a:off x="7700000" y="4590000"/>
+            <a:ext cx="3996192" cy="1230000"/>
+          </a:xfrm>
+          <a:prstGeom prst="roundRect">
+            <a:avLst>
+              <a:gd name="adj" fmla="val 5000"/>
+            </a:avLst>
+          </a:prstGeom>
+          <a:solidFill>
+            <a:srgbClr val="FBF9F4"/>
+          </a:solidFill>
+          <a:ln w="6350">
+            <a:solidFill>
+              <a:srgbClr val="D9D2C3"/>
+            </a:solidFill>
+          </a:ln>
+          <a:effectLst/>
+        </p:spPr>
+        <p:style>
+          <a:lnRef idx="1">
+            <a:schemeClr val="accent1"/>
+          </a:lnRef>
+          <a:fillRef idx="3">
+            <a:schemeClr val="accent1"/>
+          </a:fillRef>
+          <a:effectRef idx="2">
+            <a:schemeClr val="accent1"/>
+          </a:effectRef>
+          <a:fontRef idx="minor">
+            <a:schemeClr val="lt1"/>
+          </a:fontRef>
+        </p:style>
+        <p:txBody>
+          <a:bodyPr rtlCol="0" anchor="ctr"/>
+          <a:lstStyle/>
+          <a:p>
+            <a:pPr algn="ctr"/>
+          </a:p>
+        </p:txBody>
+      </p:sp>
+      <p:sp>
+        <p:nvSpPr>
+          <p:cNvPr id="16" name="TextBox 15"/>
+          <p:cNvSpPr txBox="1"/>
+          <p:nvPr/>
+        </p:nvSpPr>
+        <p:spPr>
+          <a:xfrm>
+            <a:off x="7930000" y="4710000"/>
+            <a:ext cx="3536192" cy="420000"/>
+          </a:xfrm>
+          <a:prstGeom prst="rect">
+            <a:avLst/>
+          </a:prstGeom>
+          <a:noFill/>
+        </p:spPr>
+        <p:txBody>
+          <a:bodyPr wrap="square" lIns="0" rIns="0" tIns="0" bIns="0" anchor="t">
+            <a:spAutoFit/>
+          </a:bodyPr>
+          <a:lstStyle/>
+          <a:p>
+            <a:pPr algn="l"/>
+            <a:r>
+              <a:rPr sz="2400" b="0">
+                <a:solidFill>
+                  <a:srgbClr val="A4521D"/>
+                </a:solidFill>
+                <a:latin typeface="Source Serif 4"/>
+              </a:rPr>
+              <a:t>2 587 fermer</a:t>
+            </a:r>
+          </a:p>
+        </p:txBody>
+      </p:sp>
+      <p:sp>
+        <p:nvSpPr>
+          <p:cNvPr id="17" name="TextBox 16"/>
+          <p:cNvSpPr txBox="1"/>
+          <p:nvPr/>
+        </p:nvSpPr>
+        <p:spPr>
+          <a:xfrm>
+            <a:off x="7930000" y="5150000"/>
+            <a:ext cx="3536192" cy="620000"/>
+          </a:xfrm>
+          <a:prstGeom prst="rect">
+            <a:avLst/>
+          </a:prstGeom>
+          <a:noFill/>
+        </p:spPr>
+        <p:txBody>
+          <a:bodyPr wrap="square" lIns="0" rIns="0" tIns="0" bIns="0" anchor="t">
+            <a:spAutoFit/>
+          </a:bodyPr>
+          <a:lstStyle/>
+          <a:p>
+            <a:pPr algn="l"/>
+            <a:r>
+              <a:rPr sz="1200" b="0">
+                <a:solidFill>
+                  <a:srgbClr val="4C5852"/>
+                </a:solidFill>
+                <a:latin typeface="Inter"/>
+              </a:rPr>
+              <a:t>Paxta-gʻallachilik yoʻnalishidagi xoʻjaliklar: 217,0 ming ga yer</a:t>
+            </a:r>
+          </a:p>
+        </p:txBody>
+      </p:sp>
+      <p:sp>
+        <p:nvSpPr>
+          <p:cNvPr id="18" name="TextBox 17"/>
+          <p:cNvSpPr txBox="1"/>
+          <p:nvPr/>
+        </p:nvSpPr>
+        <p:spPr>
+          <a:xfrm>
+            <a:off x="812800" y="6238280"/>
+            <a:ext cx="9800000" cy="240000"/>
+          </a:xfrm>
+          <a:prstGeom prst="rect">
+            <a:avLst/>
+          </a:prstGeom>
+          <a:noFill/>
+        </p:spPr>
+        <p:txBody>
+          <a:bodyPr wrap="square" lIns="0" rIns="0" tIns="0" bIns="0" anchor="t">
+            <a:spAutoFit/>
+          </a:bodyPr>
+          <a:lstStyle/>
+          <a:p>
+            <a:pPr algn="l"/>
+            <a:r>
+              <a:rPr sz="1200" b="0">
+                <a:solidFill>
+                  <a:srgbClr val="5F6B64"/>
+                </a:solidFill>
+                <a:latin typeface="Inter"/>
+              </a:rPr>
+              <a:t>Manba: Fargʻona viloyati ekin joylashtirish rejasi (2022) va fermer xoʻjaliklari ixtisosligi toʻgʻrisida maʼlumot</a:t>
+            </a:r>
+          </a:p>
+        </p:txBody>
+      </p:sp>
+    </p:spTree>
+  </p:cSld>
+  <p:clrMapOvr>
+    <a:masterClrMapping/>
+  </p:clrMapOvr>
+</p:sld>
+</file>
+
+<file path=ppt/slides/slide27.xml><?xml version="1.0" encoding="utf-8"?>
+<p:sld xmlns:a="http://schemas.openxmlformats.org/drawingml/2006/main" xmlns:p="http://schemas.openxmlformats.org/presentationml/2006/main" xmlns:r="http://schemas.openxmlformats.org/officeDocument/2006/relationships">
+  <p:cSld>
+    <p:bg>
+      <p:bgPr>
+        <a:solidFill>
+          <a:srgbClr val="F4F1EA"/>
+        </a:solidFill>
+      </p:bgPr>
+    </p:bg>
+    <p:spTree>
+      <p:nvGrpSpPr>
+        <p:cNvPr id="1" name=""/>
+        <p:cNvGrpSpPr/>
+        <p:nvPr/>
+      </p:nvGrpSpPr>
+      <p:grpSpPr/>
+      <p:sp>
+        <p:nvSpPr>
+          <p:cNvPr id="2" name="Text 0"/>
+          <p:cNvSpPr/>
+          <p:nvPr/>
+        </p:nvSpPr>
+        <p:spPr>
+          <a:xfrm>
+            <a:off x="812800" y="812800"/>
+            <a:ext cx="10883392" cy="238720"/>
+          </a:xfrm>
+          <a:prstGeom prst="rect">
+            <a:avLst/>
+          </a:prstGeom>
+          <a:noFill/>
+          <a:ln/>
+        </p:spPr>
+        <p:txBody>
+          <a:bodyPr wrap="square" lIns="0" tIns="0" rIns="0" bIns="0" rtlCol="0" anchor="t">
+            <a:normAutofit/>
+          </a:bodyPr>
+          <a:lstStyle/>
+          <a:p>
+            <a:pPr algn="l" indent="0" marL="0">
+              <a:lnSpc>
+                <a:spcPts val="1680"/>
+              </a:lnSpc>
+              <a:buNone/>
+            </a:pPr>
+            <a:r>
+              <a:rPr lang="en-US" sz="1200" b="1" spc="150" kern="0" dirty="0">
+                <a:solidFill>
+                  <a:srgbClr val="2C6A85"/>
+                </a:solidFill>
+                <a:latin typeface="Inter" pitchFamily="34" charset="0"/>
+                <a:ea typeface="Inter" pitchFamily="34" charset="-122"/>
+                <a:cs typeface="Inter" pitchFamily="34" charset="-120"/>
+              </a:rPr>
+              <a:t>19 · DASTLABKI MAʼLUMOTLAR</a:t>
+            </a:r>
+            <a:endParaRPr lang="en-US" sz="1200" dirty="0"/>
+          </a:p>
+        </p:txBody>
+      </p:sp>
+      <p:sp>
+        <p:nvSpPr>
+          <p:cNvPr id="3" name="Text 1"/>
+          <p:cNvSpPr/>
+          <p:nvPr>
+            <p:ph type="title"/>
+          </p:nvPr>
+        </p:nvSpPr>
+        <p:spPr>
+          <a:xfrm>
+            <a:off x="812800" y="1127720"/>
+            <a:ext cx="10883392" cy="472430"/>
+          </a:xfrm>
+          <a:prstGeom prst="rect">
+            <a:avLst/>
+          </a:prstGeom>
+          <a:noFill/>
+          <a:ln/>
+        </p:spPr>
+        <p:txBody>
+          <a:bodyPr wrap="square" lIns="0" tIns="0" rIns="0" bIns="0" rtlCol="0" anchor="t">
+            <a:normAutofit/>
+          </a:bodyPr>
+          <a:lstStyle/>
+          <a:p>
+            <a:pPr algn="l" indent="0" marL="0">
+              <a:lnSpc>
+                <a:spcPts val="3520"/>
+              </a:lnSpc>
+              <a:buNone/>
+            </a:pPr>
+            <a:r>
+              <a:rPr lang="en-US" sz="3200" b="0" i="0" dirty="0">
+                <a:solidFill>
+                  <a:srgbClr val="1D2A24"/>
+                </a:solidFill>
+                <a:latin typeface="Source Serif 4" pitchFamily="18" charset="0"/>
+                <a:ea typeface="Source Serif 4" pitchFamily="18" charset="-122"/>
+                <a:cs typeface="Source Serif 4" pitchFamily="18" charset="-120"/>
+              </a:rPr>
+              <a:t>Fargʻona viloyati: shoʻr yuvish</a:t>
+            </a:r>
+            <a:endParaRPr lang="en-US" sz="3200" dirty="0"/>
+          </a:p>
+        </p:txBody>
+      </p:sp>
+      <p:sp>
+        <p:nvSpPr>
+          <p:cNvPr id="6" name="Text 3"/>
+          <p:cNvSpPr/>
+          <p:nvPr/>
+        </p:nvSpPr>
+        <p:spPr>
+          <a:xfrm>
+            <a:off x="11137950" y="6238280"/>
+            <a:ext cx="241250" cy="238720"/>
+          </a:xfrm>
+          <a:prstGeom prst="rect">
+            <a:avLst/>
+          </a:prstGeom>
+          <a:noFill/>
+          <a:ln/>
+        </p:spPr>
+        <p:txBody>
+          <a:bodyPr wrap="square" lIns="0" tIns="0" rIns="0" bIns="0" rtlCol="0" anchor="t">
+            <a:normAutofit/>
+          </a:bodyPr>
+          <a:lstStyle/>
+          <a:p>
+            <a:pPr algn="r" indent="0" marL="0">
+              <a:lnSpc>
+                <a:spcPts val="1680"/>
+              </a:lnSpc>
+              <a:buNone/>
+            </a:pPr>
+            <a:r>
+              <a:rPr lang="en-US" sz="1200" dirty="0">
+                <a:solidFill>
+                  <a:srgbClr val="5F6B64"/>
+                </a:solidFill>
+                <a:latin typeface="Inter" pitchFamily="34" charset="0"/>
+                <a:ea typeface="Inter" pitchFamily="34" charset="-122"/>
+                <a:cs typeface="Inter" pitchFamily="34" charset="-120"/>
+              </a:rPr>
+              <a:t>20</a:t>
+            </a:r>
+            <a:endParaRPr lang="en-US" sz="1200" dirty="0"/>
+          </a:p>
+        </p:txBody>
+      </p:sp>
+      <p:sp>
+        <p:nvSpPr>
+          <p:cNvPr id="7" name="TextBox 6"/>
+          <p:cNvSpPr txBox="1"/>
+          <p:nvPr/>
+        </p:nvSpPr>
+        <p:spPr>
+          <a:xfrm>
+            <a:off x="812800" y="1830000"/>
+            <a:ext cx="6200000" cy="260000"/>
+          </a:xfrm>
+          <a:prstGeom prst="rect">
+            <a:avLst/>
+          </a:prstGeom>
+          <a:noFill/>
+        </p:spPr>
+        <p:txBody>
+          <a:bodyPr wrap="square" lIns="0" rIns="0" tIns="0" bIns="0" anchor="t">
+            <a:spAutoFit/>
+          </a:bodyPr>
+          <a:lstStyle/>
+          <a:p>
+            <a:pPr algn="l"/>
+            <a:r>
+              <a:rPr sz="1300" b="1">
+                <a:solidFill>
+                  <a:srgbClr val="2C6A85"/>
+                </a:solidFill>
+                <a:latin typeface="Inter"/>
+              </a:rPr>
+              <a:t>Shoʻr yuviladigan maydon, ga (2024–2025 yillar)</a:t>
+            </a:r>
+          </a:p>
+        </p:txBody>
+      </p:sp>
+      <p:graphicFrame>
+        <p:nvGraphicFramePr>
+          <p:cNvPr id="8" name="Chart 7"/>
+          <p:cNvGraphicFramePr>
+            <a:graphicFrameLocks noGrp="1"/>
+          </p:cNvGraphicFramePr>
+          <p:nvPr/>
+        </p:nvGraphicFramePr>
+        <p:xfrm>
+          <a:off x="752800" y="2080000"/>
+          <a:ext cx="6600000" cy="4000000"/>
+        </p:xfrm>
+        <a:graphic>
+          <a:graphicData uri="http://schemas.openxmlformats.org/drawingml/2006/chart">
+            <c:chart xmlns:c="http://schemas.openxmlformats.org/drawingml/2006/chart" r:id="rId2"/>
+          </a:graphicData>
+        </a:graphic>
+      </p:graphicFrame>
+      <p:sp>
+        <p:nvSpPr>
+          <p:cNvPr id="9" name="Rounded Rectangle 8"/>
+          <p:cNvSpPr/>
+          <p:nvPr/>
+        </p:nvSpPr>
+        <p:spPr>
+          <a:xfrm>
+            <a:off x="7700000" y="1830000"/>
+            <a:ext cx="3996192" cy="1230000"/>
+          </a:xfrm>
+          <a:prstGeom prst="roundRect">
+            <a:avLst>
+              <a:gd name="adj" fmla="val 5000"/>
+            </a:avLst>
+          </a:prstGeom>
+          <a:solidFill>
+            <a:srgbClr val="FBF9F4"/>
+          </a:solidFill>
+          <a:ln w="6350">
+            <a:solidFill>
+              <a:srgbClr val="D9D2C3"/>
+            </a:solidFill>
+          </a:ln>
+          <a:effectLst/>
+        </p:spPr>
+        <p:style>
+          <a:lnRef idx="1">
+            <a:schemeClr val="accent1"/>
+          </a:lnRef>
+          <a:fillRef idx="3">
+            <a:schemeClr val="accent1"/>
+          </a:fillRef>
+          <a:effectRef idx="2">
+            <a:schemeClr val="accent1"/>
+          </a:effectRef>
+          <a:fontRef idx="minor">
+            <a:schemeClr val="lt1"/>
+          </a:fontRef>
+        </p:style>
+        <p:txBody>
+          <a:bodyPr rtlCol="0" anchor="ctr"/>
+          <a:lstStyle/>
+          <a:p>
+            <a:pPr algn="ctr"/>
+          </a:p>
+        </p:txBody>
+      </p:sp>
+      <p:sp>
+        <p:nvSpPr>
+          <p:cNvPr id="10" name="TextBox 9"/>
+          <p:cNvSpPr txBox="1"/>
+          <p:nvPr/>
+        </p:nvSpPr>
+        <p:spPr>
+          <a:xfrm>
+            <a:off x="7930000" y="1950000"/>
+            <a:ext cx="3536192" cy="420000"/>
+          </a:xfrm>
+          <a:prstGeom prst="rect">
+            <a:avLst/>
+          </a:prstGeom>
+          <a:noFill/>
+        </p:spPr>
+        <p:txBody>
+          <a:bodyPr wrap="square" lIns="0" rIns="0" tIns="0" bIns="0" anchor="t">
+            <a:spAutoFit/>
+          </a:bodyPr>
+          <a:lstStyle/>
+          <a:p>
+            <a:pPr algn="l"/>
+            <a:r>
+              <a:rPr sz="2400" b="0">
+                <a:solidFill>
+                  <a:srgbClr val="A4521D"/>
+                </a:solidFill>
+                <a:latin typeface="Source Serif 4"/>
+              </a:rPr>
+              <a:t>33 104 ga</a:t>
+            </a:r>
+          </a:p>
+        </p:txBody>
+      </p:sp>
+      <p:sp>
+        <p:nvSpPr>
+          <p:cNvPr id="11" name="TextBox 10"/>
+          <p:cNvSpPr txBox="1"/>
+          <p:nvPr/>
+        </p:nvSpPr>
+        <p:spPr>
+          <a:xfrm>
+            <a:off x="7930000" y="2390000"/>
+            <a:ext cx="3536192" cy="620000"/>
+          </a:xfrm>
+          <a:prstGeom prst="rect">
+            <a:avLst/>
+          </a:prstGeom>
+          <a:noFill/>
+        </p:spPr>
+        <p:txBody>
+          <a:bodyPr wrap="square" lIns="0" rIns="0" tIns="0" bIns="0" anchor="t">
+            <a:spAutoFit/>
+          </a:bodyPr>
+          <a:lstStyle/>
+          <a:p>
+            <a:pPr algn="l"/>
+            <a:r>
+              <a:rPr sz="1200" b="0">
+                <a:solidFill>
+                  <a:srgbClr val="4C5852"/>
+                </a:solidFill>
+                <a:latin typeface="Inter"/>
+              </a:rPr>
+              <a:t>Shoʻr yuvish rejasi (11 tuman); kuchli shoʻrlangan yerlar qayta yuvilgani uchun jami ish hajmi 33 423 ga</a:t>
+            </a:r>
+          </a:p>
+        </p:txBody>
+      </p:sp>
+      <p:sp>
+        <p:nvSpPr>
+          <p:cNvPr id="12" name="Rounded Rectangle 11"/>
+          <p:cNvSpPr/>
+          <p:nvPr/>
+        </p:nvSpPr>
+        <p:spPr>
+          <a:xfrm>
+            <a:off x="7700000" y="3210000"/>
+            <a:ext cx="3996192" cy="1230000"/>
+          </a:xfrm>
+          <a:prstGeom prst="roundRect">
+            <a:avLst>
+              <a:gd name="adj" fmla="val 5000"/>
+            </a:avLst>
+          </a:prstGeom>
+          <a:solidFill>
+            <a:srgbClr val="FBF9F4"/>
+          </a:solidFill>
+          <a:ln w="6350">
+            <a:solidFill>
+              <a:srgbClr val="D9D2C3"/>
+            </a:solidFill>
+          </a:ln>
+          <a:effectLst/>
+        </p:spPr>
+        <p:style>
+          <a:lnRef idx="1">
+            <a:schemeClr val="accent1"/>
+          </a:lnRef>
+          <a:fillRef idx="3">
+            <a:schemeClr val="accent1"/>
+          </a:fillRef>
+          <a:effectRef idx="2">
+            <a:schemeClr val="accent1"/>
+          </a:effectRef>
+          <a:fontRef idx="minor">
+            <a:schemeClr val="lt1"/>
+          </a:fontRef>
+        </p:style>
+        <p:txBody>
+          <a:bodyPr rtlCol="0" anchor="ctr"/>
+          <a:lstStyle/>
+          <a:p>
+            <a:pPr algn="ctr"/>
+          </a:p>
+        </p:txBody>
+      </p:sp>
+      <p:sp>
+        <p:nvSpPr>
+          <p:cNvPr id="13" name="TextBox 12"/>
+          <p:cNvSpPr txBox="1"/>
+          <p:nvPr/>
+        </p:nvSpPr>
+        <p:spPr>
+          <a:xfrm>
+            <a:off x="7930000" y="3330000"/>
+            <a:ext cx="3536192" cy="420000"/>
+          </a:xfrm>
+          <a:prstGeom prst="rect">
+            <a:avLst/>
+          </a:prstGeom>
+          <a:noFill/>
+        </p:spPr>
+        <p:txBody>
+          <a:bodyPr wrap="square" lIns="0" rIns="0" tIns="0" bIns="0" anchor="t">
+            <a:spAutoFit/>
+          </a:bodyPr>
+          <a:lstStyle/>
+          <a:p>
+            <a:pPr algn="l"/>
+            <a:r>
+              <a:rPr sz="2400" b="0">
+                <a:solidFill>
+                  <a:srgbClr val="2C6A85"/>
+                </a:solidFill>
+                <a:latin typeface="Source Serif 4"/>
+              </a:rPr>
+              <a:t>86,5%</a:t>
+            </a:r>
+          </a:p>
+        </p:txBody>
+      </p:sp>
+      <p:sp>
+        <p:nvSpPr>
+          <p:cNvPr id="14" name="TextBox 13"/>
+          <p:cNvSpPr txBox="1"/>
+          <p:nvPr/>
+        </p:nvSpPr>
+        <p:spPr>
+          <a:xfrm>
+            <a:off x="7930000" y="3770000"/>
+            <a:ext cx="3536192" cy="620000"/>
+          </a:xfrm>
+          <a:prstGeom prst="rect">
+            <a:avLst/>
+          </a:prstGeom>
+          <a:noFill/>
+        </p:spPr>
+        <p:txBody>
+          <a:bodyPr wrap="square" lIns="0" rIns="0" tIns="0" bIns="0" anchor="t">
+            <a:spAutoFit/>
+          </a:bodyPr>
+          <a:lstStyle/>
+          <a:p>
+            <a:pPr algn="l"/>
+            <a:r>
+              <a:rPr sz="1200" b="0">
+                <a:solidFill>
+                  <a:srgbClr val="4C5852"/>
+                </a:solidFill>
+                <a:latin typeface="Inter"/>
+              </a:rPr>
+              <a:t>Kuchsiz shoʻrlangan yerlar (28 918 ga); oʻrta shoʻrlangan — 3 867 ga (11,7%)</a:t>
+            </a:r>
+          </a:p>
+        </p:txBody>
+      </p:sp>
+      <p:sp>
+        <p:nvSpPr>
+          <p:cNvPr id="15" name="Rounded Rectangle 14"/>
+          <p:cNvSpPr/>
+          <p:nvPr/>
+        </p:nvSpPr>
+        <p:spPr>
+          <a:xfrm>
+            <a:off x="7700000" y="4590000"/>
+            <a:ext cx="3996192" cy="1230000"/>
+          </a:xfrm>
+          <a:prstGeom prst="roundRect">
+            <a:avLst>
+              <a:gd name="adj" fmla="val 5000"/>
+            </a:avLst>
+          </a:prstGeom>
+          <a:solidFill>
+            <a:srgbClr val="FBF9F4"/>
+          </a:solidFill>
+          <a:ln w="6350">
+            <a:solidFill>
+              <a:srgbClr val="D9D2C3"/>
+            </a:solidFill>
+          </a:ln>
+          <a:effectLst/>
+        </p:spPr>
+        <p:style>
+          <a:lnRef idx="1">
+            <a:schemeClr val="accent1"/>
+          </a:lnRef>
+          <a:fillRef idx="3">
+            <a:schemeClr val="accent1"/>
+          </a:fillRef>
+          <a:effectRef idx="2">
+            <a:schemeClr val="accent1"/>
+          </a:effectRef>
+          <a:fontRef idx="minor">
+            <a:schemeClr val="lt1"/>
+          </a:fontRef>
+        </p:style>
+        <p:txBody>
+          <a:bodyPr rtlCol="0" anchor="ctr"/>
+          <a:lstStyle/>
+          <a:p>
+            <a:pPr algn="ctr"/>
+          </a:p>
+        </p:txBody>
+      </p:sp>
+      <p:sp>
+        <p:nvSpPr>
+          <p:cNvPr id="16" name="TextBox 15"/>
+          <p:cNvSpPr txBox="1"/>
+          <p:nvPr/>
+        </p:nvSpPr>
+        <p:spPr>
+          <a:xfrm>
+            <a:off x="7930000" y="4710000"/>
+            <a:ext cx="3536192" cy="420000"/>
+          </a:xfrm>
+          <a:prstGeom prst="rect">
+            <a:avLst/>
+          </a:prstGeom>
+          <a:noFill/>
+        </p:spPr>
+        <p:txBody>
+          <a:bodyPr wrap="square" lIns="0" rIns="0" tIns="0" bIns="0" anchor="t">
+            <a:spAutoFit/>
+          </a:bodyPr>
+          <a:lstStyle/>
+          <a:p>
+            <a:pPr algn="l"/>
+            <a:r>
+              <a:rPr sz="2400" b="0">
+                <a:solidFill>
+                  <a:srgbClr val="A4521D"/>
+                </a:solidFill>
+                <a:latin typeface="Source Serif 4"/>
+              </a:rPr>
+              <a:t>319 ga</a:t>
+            </a:r>
+          </a:p>
+        </p:txBody>
+      </p:sp>
+      <p:sp>
+        <p:nvSpPr>
+          <p:cNvPr id="17" name="TextBox 16"/>
+          <p:cNvSpPr txBox="1"/>
+          <p:nvPr/>
+        </p:nvSpPr>
+        <p:spPr>
+          <a:xfrm>
+            <a:off x="7930000" y="5150000"/>
+            <a:ext cx="3536192" cy="620000"/>
+          </a:xfrm>
+          <a:prstGeom prst="rect">
+            <a:avLst/>
+          </a:prstGeom>
+          <a:noFill/>
+        </p:spPr>
+        <p:txBody>
+          <a:bodyPr wrap="square" lIns="0" rIns="0" tIns="0" bIns="0" anchor="t">
+            <a:spAutoFit/>
+          </a:bodyPr>
+          <a:lstStyle/>
+          <a:p>
+            <a:pPr algn="l"/>
+            <a:r>
+              <a:rPr sz="1200" b="0">
+                <a:solidFill>
+                  <a:srgbClr val="4C5852"/>
+                </a:solidFill>
+                <a:latin typeface="Inter"/>
+              </a:rPr>
+              <a:t>Kuchli shoʻrlangan maydon: Dangʻara (109), Qoʻshtepa (122) va Furqat (88) tumanlarida</a:t>
+            </a:r>
+          </a:p>
+        </p:txBody>
+      </p:sp>
+      <p:sp>
+        <p:nvSpPr>
+          <p:cNvPr id="18" name="TextBox 17"/>
+          <p:cNvSpPr txBox="1"/>
+          <p:nvPr/>
+        </p:nvSpPr>
+        <p:spPr>
+          <a:xfrm>
+            <a:off x="812800" y="6238280"/>
+            <a:ext cx="9800000" cy="240000"/>
+          </a:xfrm>
+          <a:prstGeom prst="rect">
+            <a:avLst/>
+          </a:prstGeom>
+          <a:noFill/>
+        </p:spPr>
+        <p:txBody>
+          <a:bodyPr wrap="square" lIns="0" rIns="0" tIns="0" bIns="0" anchor="t">
+            <a:spAutoFit/>
+          </a:bodyPr>
+          <a:lstStyle/>
+          <a:p>
+            <a:pPr algn="l"/>
+            <a:r>
+              <a:rPr sz="1200" b="0">
+                <a:solidFill>
+                  <a:srgbClr val="5F6B64"/>
+                </a:solidFill>
+                <a:latin typeface="Inter"/>
+              </a:rPr>
+              <a:t>Manba: Fargʻona viloyati tumanlarida 2024–2025 yillarda shoʻr yuviladigan maydonlar toʻgʻrisida maʼlumot</a:t>
+            </a:r>
+          </a:p>
+        </p:txBody>
+      </p:sp>
+    </p:spTree>
+  </p:cSld>
+  <p:clrMapOvr>
+    <a:masterClrMapping/>
+  </p:clrMapOvr>
+</p:sld>
+</file>
+
+<file path=ppt/slides/slide28.xml><?xml version="1.0" encoding="utf-8"?>
+<p:sld xmlns:a="http://schemas.openxmlformats.org/drawingml/2006/main" xmlns:p="http://schemas.openxmlformats.org/presentationml/2006/main" xmlns:r="http://schemas.openxmlformats.org/officeDocument/2006/relationships">
+  <p:cSld>
+    <p:bg>
+      <p:bgPr>
+        <a:solidFill>
+          <a:srgbClr val="F4F1EA"/>
+        </a:solidFill>
+      </p:bgPr>
+    </p:bg>
+    <p:spTree>
+      <p:nvGrpSpPr>
+        <p:cNvPr id="1" name=""/>
+        <p:cNvGrpSpPr/>
+        <p:nvPr/>
+      </p:nvGrpSpPr>
+      <p:grpSpPr/>
+      <p:sp>
+        <p:nvSpPr>
+          <p:cNvPr id="2" name="Text 0"/>
+          <p:cNvSpPr/>
+          <p:nvPr/>
+        </p:nvSpPr>
+        <p:spPr>
+          <a:xfrm>
+            <a:off x="812800" y="812800"/>
+            <a:ext cx="10883392" cy="238720"/>
+          </a:xfrm>
+          <a:prstGeom prst="rect">
+            <a:avLst/>
+          </a:prstGeom>
+          <a:noFill/>
+          <a:ln/>
+        </p:spPr>
+        <p:txBody>
+          <a:bodyPr wrap="square" lIns="0" tIns="0" rIns="0" bIns="0" rtlCol="0" anchor="t">
+            <a:normAutofit/>
+          </a:bodyPr>
+          <a:lstStyle/>
+          <a:p>
+            <a:pPr algn="l" indent="0" marL="0">
+              <a:lnSpc>
+                <a:spcPts val="1680"/>
+              </a:lnSpc>
+              <a:buNone/>
+            </a:pPr>
+            <a:r>
+              <a:rPr lang="en-US" sz="1200" b="1" spc="150" kern="0" dirty="0">
+                <a:solidFill>
+                  <a:srgbClr val="2C6A85"/>
+                </a:solidFill>
+                <a:latin typeface="Inter" pitchFamily="34" charset="0"/>
+                <a:ea typeface="Inter" pitchFamily="34" charset="-122"/>
+                <a:cs typeface="Inter" pitchFamily="34" charset="-120"/>
+              </a:rPr>
+              <a:t>20 · DASTLABKI MAʼLUMOTLAR</a:t>
+            </a:r>
+            <a:endParaRPr lang="en-US" sz="1200" dirty="0"/>
+          </a:p>
+        </p:txBody>
+      </p:sp>
+      <p:sp>
+        <p:nvSpPr>
+          <p:cNvPr id="3" name="Text 1"/>
+          <p:cNvSpPr/>
+          <p:nvPr>
+            <p:ph type="title"/>
+          </p:nvPr>
+        </p:nvSpPr>
+        <p:spPr>
+          <a:xfrm>
+            <a:off x="812800" y="1127720"/>
+            <a:ext cx="10883392" cy="472430"/>
+          </a:xfrm>
+          <a:prstGeom prst="rect">
+            <a:avLst/>
+          </a:prstGeom>
+          <a:noFill/>
+          <a:ln/>
+        </p:spPr>
+        <p:txBody>
+          <a:bodyPr wrap="square" lIns="0" tIns="0" rIns="0" bIns="0" rtlCol="0" anchor="t">
+            <a:normAutofit/>
+          </a:bodyPr>
+          <a:lstStyle/>
+          <a:p>
+            <a:pPr algn="l" indent="0" marL="0">
+              <a:lnSpc>
+                <a:spcPts val="3520"/>
+              </a:lnSpc>
+              <a:buNone/>
+            </a:pPr>
+            <a:r>
+              <a:rPr lang="en-US" sz="3200" b="0" i="0" dirty="0">
+                <a:solidFill>
+                  <a:srgbClr val="1D2A24"/>
+                </a:solidFill>
+                <a:latin typeface="Source Serif 4" pitchFamily="18" charset="0"/>
+                <a:ea typeface="Source Serif 4" pitchFamily="18" charset="-122"/>
+                <a:cs typeface="Source Serif 4" pitchFamily="18" charset="-120"/>
+              </a:rPr>
+              <a:t>Andijon viloyati: shoʻr yuvish</a:t>
+            </a:r>
+            <a:endParaRPr lang="en-US" sz="3200" dirty="0"/>
+          </a:p>
+        </p:txBody>
+      </p:sp>
+      <p:sp>
+        <p:nvSpPr>
+          <p:cNvPr id="6" name="Text 3"/>
+          <p:cNvSpPr/>
+          <p:nvPr/>
+        </p:nvSpPr>
+        <p:spPr>
+          <a:xfrm>
+            <a:off x="11137950" y="6238280"/>
+            <a:ext cx="241250" cy="238720"/>
+          </a:xfrm>
+          <a:prstGeom prst="rect">
+            <a:avLst/>
+          </a:prstGeom>
+          <a:noFill/>
+          <a:ln/>
+        </p:spPr>
+        <p:txBody>
+          <a:bodyPr wrap="square" lIns="0" tIns="0" rIns="0" bIns="0" rtlCol="0" anchor="t">
+            <a:normAutofit/>
+          </a:bodyPr>
+          <a:lstStyle/>
+          <a:p>
+            <a:pPr algn="r" indent="0" marL="0">
+              <a:lnSpc>
+                <a:spcPts val="1680"/>
+              </a:lnSpc>
+              <a:buNone/>
+            </a:pPr>
+            <a:r>
+              <a:rPr lang="en-US" sz="1200" dirty="0">
+                <a:solidFill>
+                  <a:srgbClr val="5F6B64"/>
+                </a:solidFill>
+                <a:latin typeface="Inter" pitchFamily="34" charset="0"/>
+                <a:ea typeface="Inter" pitchFamily="34" charset="-122"/>
+                <a:cs typeface="Inter" pitchFamily="34" charset="-120"/>
+              </a:rPr>
+              <a:t>21</a:t>
+            </a:r>
+            <a:endParaRPr lang="en-US" sz="1200" dirty="0"/>
+          </a:p>
+        </p:txBody>
+      </p:sp>
+      <p:sp>
+        <p:nvSpPr>
+          <p:cNvPr id="7" name="TextBox 6"/>
+          <p:cNvSpPr txBox="1"/>
+          <p:nvPr/>
+        </p:nvSpPr>
+        <p:spPr>
+          <a:xfrm>
+            <a:off x="812800" y="1830000"/>
+            <a:ext cx="6200000" cy="260000"/>
+          </a:xfrm>
+          <a:prstGeom prst="rect">
+            <a:avLst/>
+          </a:prstGeom>
+          <a:noFill/>
+        </p:spPr>
+        <p:txBody>
+          <a:bodyPr wrap="square" lIns="0" rIns="0" tIns="0" bIns="0" anchor="t">
+            <a:spAutoFit/>
+          </a:bodyPr>
+          <a:lstStyle/>
+          <a:p>
+            <a:pPr algn="l"/>
+            <a:r>
+              <a:rPr sz="1300" b="1">
+                <a:solidFill>
+                  <a:srgbClr val="2C6A85"/>
+                </a:solidFill>
+                <a:latin typeface="Inter"/>
+              </a:rPr>
+              <a:t>Shoʻr yuviladigan maydon, ga (2023–2024 yillar)</a:t>
+            </a:r>
+          </a:p>
+        </p:txBody>
+      </p:sp>
+      <p:graphicFrame>
+        <p:nvGraphicFramePr>
+          <p:cNvPr id="8" name="Chart 7"/>
+          <p:cNvGraphicFramePr>
+            <a:graphicFrameLocks noGrp="1"/>
+          </p:cNvGraphicFramePr>
+          <p:nvPr/>
+        </p:nvGraphicFramePr>
+        <p:xfrm>
+          <a:off x="752800" y="2080000"/>
+          <a:ext cx="6600000" cy="4000000"/>
+        </p:xfrm>
+        <a:graphic>
+          <a:graphicData uri="http://schemas.openxmlformats.org/drawingml/2006/chart">
+            <c:chart xmlns:c="http://schemas.openxmlformats.org/drawingml/2006/chart" r:id="rId2"/>
+          </a:graphicData>
+        </a:graphic>
+      </p:graphicFrame>
+      <p:sp>
+        <p:nvSpPr>
+          <p:cNvPr id="9" name="Rounded Rectangle 8"/>
+          <p:cNvSpPr/>
+          <p:nvPr/>
+        </p:nvSpPr>
+        <p:spPr>
+          <a:xfrm>
+            <a:off x="7700000" y="1830000"/>
+            <a:ext cx="3996192" cy="1230000"/>
+          </a:xfrm>
+          <a:prstGeom prst="roundRect">
+            <a:avLst>
+              <a:gd name="adj" fmla="val 5000"/>
+            </a:avLst>
+          </a:prstGeom>
+          <a:solidFill>
+            <a:srgbClr val="FBF9F4"/>
+          </a:solidFill>
+          <a:ln w="6350">
+            <a:solidFill>
+              <a:srgbClr val="D9D2C3"/>
+            </a:solidFill>
+          </a:ln>
+          <a:effectLst/>
+        </p:spPr>
+        <p:style>
+          <a:lnRef idx="1">
+            <a:schemeClr val="accent1"/>
+          </a:lnRef>
+          <a:fillRef idx="3">
+            <a:schemeClr val="accent1"/>
+          </a:fillRef>
+          <a:effectRef idx="2">
+            <a:schemeClr val="accent1"/>
+          </a:effectRef>
+          <a:fontRef idx="minor">
+            <a:schemeClr val="lt1"/>
+          </a:fontRef>
+        </p:style>
+        <p:txBody>
+          <a:bodyPr rtlCol="0" anchor="ctr"/>
+          <a:lstStyle/>
+          <a:p>
+            <a:pPr algn="ctr"/>
+          </a:p>
+        </p:txBody>
+      </p:sp>
+      <p:sp>
+        <p:nvSpPr>
+          <p:cNvPr id="10" name="TextBox 9"/>
+          <p:cNvSpPr txBox="1"/>
+          <p:nvPr/>
+        </p:nvSpPr>
+        <p:spPr>
+          <a:xfrm>
+            <a:off x="7930000" y="1950000"/>
+            <a:ext cx="3536192" cy="420000"/>
+          </a:xfrm>
+          <a:prstGeom prst="rect">
+            <a:avLst/>
+          </a:prstGeom>
+          <a:noFill/>
+        </p:spPr>
+        <p:txBody>
+          <a:bodyPr wrap="square" lIns="0" rIns="0" tIns="0" bIns="0" anchor="t">
+            <a:spAutoFit/>
+          </a:bodyPr>
+          <a:lstStyle/>
+          <a:p>
+            <a:pPr algn="l"/>
+            <a:r>
+              <a:rPr sz="2400" b="0">
+                <a:solidFill>
+                  <a:srgbClr val="A4521D"/>
+                </a:solidFill>
+                <a:latin typeface="Source Serif 4"/>
+              </a:rPr>
+              <a:t>5 680 ga</a:t>
+            </a:r>
+          </a:p>
+        </p:txBody>
+      </p:sp>
+      <p:sp>
+        <p:nvSpPr>
+          <p:cNvPr id="11" name="TextBox 10"/>
+          <p:cNvSpPr txBox="1"/>
+          <p:nvPr/>
+        </p:nvSpPr>
+        <p:spPr>
+          <a:xfrm>
+            <a:off x="7930000" y="2390000"/>
+            <a:ext cx="3536192" cy="620000"/>
+          </a:xfrm>
+          <a:prstGeom prst="rect">
+            <a:avLst/>
+          </a:prstGeom>
+          <a:noFill/>
+        </p:spPr>
+        <p:txBody>
+          <a:bodyPr wrap="square" lIns="0" rIns="0" tIns="0" bIns="0" anchor="t">
+            <a:spAutoFit/>
+          </a:bodyPr>
+          <a:lstStyle/>
+          <a:p>
+            <a:pPr algn="l"/>
+            <a:r>
+              <a:rPr sz="1200" b="0">
+                <a:solidFill>
+                  <a:srgbClr val="4C5852"/>
+                </a:solidFill>
+                <a:latin typeface="Inter"/>
+              </a:rPr>
+              <a:t>Shoʻr yuviladigan maydon: Ulugʻnor 3 829, Baliqchi 1 249, Boʻston 602 ga</a:t>
+            </a:r>
+          </a:p>
+        </p:txBody>
+      </p:sp>
+      <p:sp>
+        <p:nvSpPr>
+          <p:cNvPr id="12" name="Rounded Rectangle 11"/>
+          <p:cNvSpPr/>
+          <p:nvPr/>
+        </p:nvSpPr>
+        <p:spPr>
+          <a:xfrm>
+            <a:off x="7700000" y="3210000"/>
+            <a:ext cx="3996192" cy="1230000"/>
+          </a:xfrm>
+          <a:prstGeom prst="roundRect">
+            <a:avLst>
+              <a:gd name="adj" fmla="val 5000"/>
+            </a:avLst>
+          </a:prstGeom>
+          <a:solidFill>
+            <a:srgbClr val="FBF9F4"/>
+          </a:solidFill>
+          <a:ln w="6350">
+            <a:solidFill>
+              <a:srgbClr val="D9D2C3"/>
+            </a:solidFill>
+          </a:ln>
+          <a:effectLst/>
+        </p:spPr>
+        <p:style>
+          <a:lnRef idx="1">
+            <a:schemeClr val="accent1"/>
+          </a:lnRef>
+          <a:fillRef idx="3">
+            <a:schemeClr val="accent1"/>
+          </a:fillRef>
+          <a:effectRef idx="2">
+            <a:schemeClr val="accent1"/>
+          </a:effectRef>
+          <a:fontRef idx="minor">
+            <a:schemeClr val="lt1"/>
+          </a:fontRef>
+        </p:style>
+        <p:txBody>
+          <a:bodyPr rtlCol="0" anchor="ctr"/>
+          <a:lstStyle/>
+          <a:p>
+            <a:pPr algn="ctr"/>
+          </a:p>
+        </p:txBody>
+      </p:sp>
+      <p:sp>
+        <p:nvSpPr>
+          <p:cNvPr id="13" name="TextBox 12"/>
+          <p:cNvSpPr txBox="1"/>
+          <p:nvPr/>
+        </p:nvSpPr>
+        <p:spPr>
+          <a:xfrm>
+            <a:off x="7930000" y="3330000"/>
+            <a:ext cx="3536192" cy="420000"/>
+          </a:xfrm>
+          <a:prstGeom prst="rect">
+            <a:avLst/>
+          </a:prstGeom>
+          <a:noFill/>
+        </p:spPr>
+        <p:txBody>
+          <a:bodyPr wrap="square" lIns="0" rIns="0" tIns="0" bIns="0" anchor="t">
+            <a:spAutoFit/>
+          </a:bodyPr>
+          <a:lstStyle/>
+          <a:p>
+            <a:pPr algn="l"/>
+            <a:r>
+              <a:rPr sz="2400" b="0">
+                <a:solidFill>
+                  <a:srgbClr val="2C6A85"/>
+                </a:solidFill>
+                <a:latin typeface="Source Serif 4"/>
+              </a:rPr>
+              <a:t>67%</a:t>
+            </a:r>
+          </a:p>
+        </p:txBody>
+      </p:sp>
+      <p:sp>
+        <p:nvSpPr>
+          <p:cNvPr id="14" name="TextBox 13"/>
+          <p:cNvSpPr txBox="1"/>
+          <p:nvPr/>
+        </p:nvSpPr>
+        <p:spPr>
+          <a:xfrm>
+            <a:off x="7930000" y="3770000"/>
+            <a:ext cx="3536192" cy="620000"/>
+          </a:xfrm>
+          <a:prstGeom prst="rect">
+            <a:avLst/>
+          </a:prstGeom>
+          <a:noFill/>
+        </p:spPr>
+        <p:txBody>
+          <a:bodyPr wrap="square" lIns="0" rIns="0" tIns="0" bIns="0" anchor="t">
+            <a:spAutoFit/>
+          </a:bodyPr>
+          <a:lstStyle/>
+          <a:p>
+            <a:pPr algn="l"/>
+            <a:r>
+              <a:rPr sz="1200" b="0">
+                <a:solidFill>
+                  <a:srgbClr val="4C5852"/>
+                </a:solidFill>
+                <a:latin typeface="Inter"/>
+              </a:rPr>
+              <a:t>Ulugʻnor ulushi (3 829 ga); paxta hosildorligi ham viloyat oʻrtachasidan past tuman</a:t>
+            </a:r>
+          </a:p>
+        </p:txBody>
+      </p:sp>
+      <p:sp>
+        <p:nvSpPr>
+          <p:cNvPr id="15" name="Rounded Rectangle 14"/>
+          <p:cNvSpPr/>
+          <p:nvPr/>
+        </p:nvSpPr>
+        <p:spPr>
+          <a:xfrm>
+            <a:off x="7700000" y="4590000"/>
+            <a:ext cx="3996192" cy="1230000"/>
+          </a:xfrm>
+          <a:prstGeom prst="roundRect">
+            <a:avLst>
+              <a:gd name="adj" fmla="val 5000"/>
+            </a:avLst>
+          </a:prstGeom>
+          <a:solidFill>
+            <a:srgbClr val="FBF9F4"/>
+          </a:solidFill>
+          <a:ln w="6350">
+            <a:solidFill>
+              <a:srgbClr val="D9D2C3"/>
+            </a:solidFill>
+          </a:ln>
+          <a:effectLst/>
+        </p:spPr>
+        <p:style>
+          <a:lnRef idx="1">
+            <a:schemeClr val="accent1"/>
+          </a:lnRef>
+          <a:fillRef idx="3">
+            <a:schemeClr val="accent1"/>
+          </a:fillRef>
+          <a:effectRef idx="2">
+            <a:schemeClr val="accent1"/>
+          </a:effectRef>
+          <a:fontRef idx="minor">
+            <a:schemeClr val="lt1"/>
+          </a:fontRef>
+        </p:style>
+        <p:txBody>
+          <a:bodyPr rtlCol="0" anchor="ctr"/>
+          <a:lstStyle/>
+          <a:p>
+            <a:pPr algn="ctr"/>
+          </a:p>
+        </p:txBody>
+      </p:sp>
+      <p:sp>
+        <p:nvSpPr>
+          <p:cNvPr id="16" name="TextBox 15"/>
+          <p:cNvSpPr txBox="1"/>
+          <p:nvPr/>
+        </p:nvSpPr>
+        <p:spPr>
+          <a:xfrm>
+            <a:off x="7930000" y="4710000"/>
+            <a:ext cx="3536192" cy="420000"/>
+          </a:xfrm>
+          <a:prstGeom prst="rect">
+            <a:avLst/>
+          </a:prstGeom>
+          <a:noFill/>
+        </p:spPr>
+        <p:txBody>
+          <a:bodyPr wrap="square" lIns="0" rIns="0" tIns="0" bIns="0" anchor="t">
+            <a:spAutoFit/>
+          </a:bodyPr>
+          <a:lstStyle/>
+          <a:p>
+            <a:pPr algn="l"/>
+            <a:r>
+              <a:rPr sz="2400" b="0">
+                <a:solidFill>
+                  <a:srgbClr val="A4521D"/>
+                </a:solidFill>
+                <a:latin typeface="Source Serif 4"/>
+              </a:rPr>
+              <a:t>18,6 mln m³</a:t>
+            </a:r>
+          </a:p>
+        </p:txBody>
+      </p:sp>
+      <p:sp>
+        <p:nvSpPr>
+          <p:cNvPr id="17" name="TextBox 16"/>
+          <p:cNvSpPr txBox="1"/>
+          <p:nvPr/>
+        </p:nvSpPr>
+        <p:spPr>
+          <a:xfrm>
+            <a:off x="7930000" y="5150000"/>
+            <a:ext cx="3536192" cy="620000"/>
+          </a:xfrm>
+          <a:prstGeom prst="rect">
+            <a:avLst/>
+          </a:prstGeom>
+          <a:noFill/>
+        </p:spPr>
+        <p:txBody>
+          <a:bodyPr wrap="square" lIns="0" rIns="0" tIns="0" bIns="0" anchor="t">
+            <a:spAutoFit/>
+          </a:bodyPr>
+          <a:lstStyle/>
+          <a:p>
+            <a:pPr algn="l"/>
+            <a:r>
+              <a:rPr sz="1200" b="0">
+                <a:solidFill>
+                  <a:srgbClr val="4C5852"/>
+                </a:solidFill>
+                <a:latin typeface="Inter"/>
+              </a:rPr>
+              <a:t>Talab etiladigan suv (Ulugʻnor — 12,5); ishlar 15.11.2023 dan 25.01.2024 gacha rejalashtirilgan</a:t>
+            </a:r>
+          </a:p>
+        </p:txBody>
+      </p:sp>
+      <p:sp>
+        <p:nvSpPr>
+          <p:cNvPr id="18" name="TextBox 17"/>
+          <p:cNvSpPr txBox="1"/>
+          <p:nvPr/>
+        </p:nvSpPr>
+        <p:spPr>
+          <a:xfrm>
+            <a:off x="812800" y="6238280"/>
+            <a:ext cx="9800000" cy="240000"/>
+          </a:xfrm>
+          <a:prstGeom prst="rect">
+            <a:avLst/>
+          </a:prstGeom>
+          <a:noFill/>
+        </p:spPr>
+        <p:txBody>
+          <a:bodyPr wrap="square" lIns="0" rIns="0" tIns="0" bIns="0" anchor="t">
+            <a:spAutoFit/>
+          </a:bodyPr>
+          <a:lstStyle/>
+          <a:p>
+            <a:pPr algn="l"/>
+            <a:r>
+              <a:rPr sz="1200" b="0">
+                <a:solidFill>
+                  <a:srgbClr val="5F6B64"/>
+                </a:solidFill>
+                <a:latin typeface="Inter"/>
+              </a:rPr>
+              <a:t>Manba: Andijon viloyati tumanlarida 2023–2024 yillar kuzgi-qishki shoʻr yuvish grafigi</a:t>
             </a:r>
           </a:p>
         </p:txBody>
@@ -21421,7 +24163,7 @@
                           <a:ea typeface="Inter" pitchFamily="34" charset="-122"/>
                           <a:cs typeface="Inter" pitchFamily="34" charset="-120"/>
                         </a:rPr>
-                        <a:t>Sizot suvlari sathi va minerallashuvi</a:t>
+                        <a:t>Sizot suvlari, minerallashuv, shoʻr yuvish maydoni</a:t>
                       </a:r>
                       <a:endParaRPr lang="en-US" sz="1300" dirty="0">
                         <a:latin typeface="Inter" charset="0"/>
@@ -22374,7 +25116,7 @@
         </p:nvSpPr>
         <p:spPr>
           <a:xfrm>
-            <a:off x="812800" y="6305412"/>
+            <a:off x="812800" y="6165412"/>
             <a:ext cx="10883392" cy="256530"/>
           </a:xfrm>
           <a:prstGeom prst="rect">

</xml_diff>

<commit_message>
Add Namangan salt-leaching progress, Fergana water intake; update Fergana crop slide with 2023
Co-Authored-By: Claude Sonnet 5.5 <noreply@anthropic.com>
Claude-Session: https://claude.ai/code/session_01M4MZatV28utL9zTp7saaUz
</commit_message>
<xml_diff>
--- a/Garbiy_Farg_ona_tuproqlari_GAT_asosida_bashoratlash.pptx
+++ b/Garbiy_Farg_ona_tuproqlari_GAT_asosida_bashoratlash.pptx
@@ -26,6 +26,8 @@
     <p:sldId id="281" r:id="rId32"/>
     <p:sldId id="282" r:id="rId33"/>
     <p:sldId id="283" r:id="rId34"/>
+    <p:sldId id="284" r:id="rId35"/>
+    <p:sldId id="285" r:id="rId36"/>
     <p:sldId id="265" r:id="rId11"/>
     <p:sldId id="266" r:id="rId12"/>
     <p:sldId id="267" r:id="rId13"/>
@@ -988,24 +990,16 @@
               <c:strCache>
                 <c:ptCount val="1"/>
                 <c:pt idx="0">
-                  <c:v>Gʻoʻza</c:v>
+                  <c:v>2022</c:v>
                 </c:pt>
               </c:strCache>
             </c:strRef>
           </c:tx>
           <c:spPr>
             <a:solidFill>
-              <a:srgbClr val="2C6A85"/>
+              <a:srgbClr val="A9C4D1"/>
             </a:solidFill>
           </c:spPr>
-          <c:dPt>
-            <c:idx val="0"/>
-            <c:spPr>
-              <a:solidFill>
-                <a:srgbClr val="A4521D"/>
-              </a:solidFill>
-            </c:spPr>
-          </c:dPt>
           <c:cat>
             <c:strRef>
               <c:f>Sheet1!$A$2:$A$15</c:f>
@@ -1108,32 +1102,129 @@
             </c:numRef>
           </c:val>
         </c:ser>
-        <c:dLbls>
-          <c:numFmt formatCode="#,##0" sourceLinked="0"/>
-          <c:txPr>
-            <a:bodyPr/>
-            <a:lstStyle/>
-            <a:p>
-              <a:pPr>
-                <a:defRPr sz="1200">
-                  <a:solidFill>
-                    <a:srgbClr val="1D2A24"/>
-                  </a:solidFill>
-                  <a:latin typeface="Inter"/>
-                </a:defRPr>
-              </a:pPr>
-            </a:p>
-          </c:txPr>
-          <c:dLblPos val="outEnd"/>
-          <c:showLegendKey val="0"/>
-          <c:showVal val="1"/>
-          <c:showCatName val="0"/>
-          <c:showSerName val="0"/>
-          <c:showPercent val="0"/>
-          <c:showBubbleSize val="0"/>
-          <c:showLeaderLines val="1"/>
-        </c:dLbls>
-        <c:gapWidth val="30"/>
+        <c:ser>
+          <c:idx val="1"/>
+          <c:order val="1"/>
+          <c:tx>
+            <c:strRef>
+              <c:f>Sheet1!$C$1</c:f>
+              <c:strCache>
+                <c:ptCount val="1"/>
+                <c:pt idx="0">
+                  <c:v>2023</c:v>
+                </c:pt>
+              </c:strCache>
+            </c:strRef>
+          </c:tx>
+          <c:spPr>
+            <a:solidFill>
+              <a:srgbClr val="2C6A85"/>
+            </a:solidFill>
+          </c:spPr>
+          <c:cat>
+            <c:strRef>
+              <c:f>Sheet1!$A$2:$A$15</c:f>
+              <c:strCache>
+                <c:ptCount val="14"/>
+                <c:pt idx="0">
+                  <c:v>Beshariq</c:v>
+                </c:pt>
+                <c:pt idx="1">
+                  <c:v>Qoʻshtepa</c:v>
+                </c:pt>
+                <c:pt idx="2">
+                  <c:v>Quva</c:v>
+                </c:pt>
+                <c:pt idx="3">
+                  <c:v>Oltiariq</c:v>
+                </c:pt>
+                <c:pt idx="4">
+                  <c:v>Dangʻara</c:v>
+                </c:pt>
+                <c:pt idx="5">
+                  <c:v>Rishton</c:v>
+                </c:pt>
+                <c:pt idx="6">
+                  <c:v>Fargʻona</c:v>
+                </c:pt>
+                <c:pt idx="7">
+                  <c:v>Uchkoʻprik</c:v>
+                </c:pt>
+                <c:pt idx="8">
+                  <c:v>Furqat</c:v>
+                </c:pt>
+                <c:pt idx="9">
+                  <c:v>Yozyovon</c:v>
+                </c:pt>
+                <c:pt idx="10">
+                  <c:v>Bogʻdod</c:v>
+                </c:pt>
+                <c:pt idx="11">
+                  <c:v>Buvayda</c:v>
+                </c:pt>
+                <c:pt idx="12">
+                  <c:v>Toshloq</c:v>
+                </c:pt>
+                <c:pt idx="13">
+                  <c:v>Oʻzbekiston</c:v>
+                </c:pt>
+              </c:strCache>
+            </c:strRef>
+          </c:cat>
+          <c:val>
+            <c:numRef>
+              <c:f>Sheet1!$C$2:$C$15</c:f>
+              <c:numCache>
+                <c:formatCode>General</c:formatCode>
+                <c:ptCount val="14"/>
+                <c:pt idx="0">
+                  <c:v>7650</c:v>
+                </c:pt>
+                <c:pt idx="1">
+                  <c:v>6890</c:v>
+                </c:pt>
+                <c:pt idx="2">
+                  <c:v>5900</c:v>
+                </c:pt>
+                <c:pt idx="3">
+                  <c:v>5920</c:v>
+                </c:pt>
+                <c:pt idx="4">
+                  <c:v>5860</c:v>
+                </c:pt>
+                <c:pt idx="5">
+                  <c:v>5700</c:v>
+                </c:pt>
+                <c:pt idx="6">
+                  <c:v>5500</c:v>
+                </c:pt>
+                <c:pt idx="7">
+                  <c:v>5451</c:v>
+                </c:pt>
+                <c:pt idx="8">
+                  <c:v>5200</c:v>
+                </c:pt>
+                <c:pt idx="9">
+                  <c:v>4900</c:v>
+                </c:pt>
+                <c:pt idx="10">
+                  <c:v>4850</c:v>
+                </c:pt>
+                <c:pt idx="11">
+                  <c:v>4800</c:v>
+                </c:pt>
+                <c:pt idx="12">
+                  <c:v>4800</c:v>
+                </c:pt>
+                <c:pt idx="13">
+                  <c:v>4400</c:v>
+                </c:pt>
+              </c:numCache>
+            </c:numRef>
+          </c:val>
+        </c:ser>
+        <c:gapWidth val="40"/>
+        <c:overlap val="-5"/>
         <c:axId val="-2068027336"/>
         <c:axId val="-2113994440"/>
       </c:barChart>
@@ -1178,18 +1269,65 @@
       <c:valAx>
         <c:axId val="-2113994440"/>
         <c:scaling>
-          <c:max val="9500.0"/>
+          <c:max val="9000.0"/>
           <c:min val="0.0"/>
         </c:scaling>
-        <c:delete/>
+        <c:delete val="0"/>
         <c:axPos val="b"/>
+        <c:majorGridlines>
+          <c:spPr>
+            <a:ln>
+              <a:solidFill>
+                <a:srgbClr val="D9D2C3"/>
+              </a:solidFill>
+            </a:ln>
+          </c:spPr>
+        </c:majorGridlines>
+        <c:numFmt formatCode="#,##0" sourceLinked="0"/>
         <c:majorTickMark val="out"/>
         <c:minorTickMark val="none"/>
         <c:tickLblPos val="nextTo"/>
+        <c:spPr>
+          <a:ln>
+            <a:noFill/>
+          </a:ln>
+        </c:spPr>
+        <c:txPr>
+          <a:bodyPr/>
+          <a:lstStyle/>
+          <a:p>
+            <a:pPr>
+              <a:defRPr sz="1200">
+                <a:solidFill>
+                  <a:srgbClr val="4C5852"/>
+                </a:solidFill>
+                <a:latin typeface="Inter"/>
+              </a:defRPr>
+            </a:pPr>
+          </a:p>
+        </c:txPr>
         <c:crossAx val="-2068027336"/>
         <c:crosses val="autoZero"/>
       </c:valAx>
     </c:plotArea>
+    <c:legend>
+      <c:legendPos val="t"/>
+      <c:overlay val="0"/>
+      <c:txPr>
+        <a:bodyPr/>
+        <a:lstStyle/>
+        <a:p>
+          <a:pPr>
+            <a:defRPr sz="1200">
+              <a:solidFill>
+                <a:srgbClr val="4C5852"/>
+              </a:solidFill>
+              <a:latin typeface="Inter"/>
+            </a:defRPr>
+          </a:pPr>
+        </a:p>
+      </c:txPr>
+    </c:legend>
     <c:dispBlanksAs val="gap"/>
   </c:chart>
   <c:txPr>
@@ -1839,6 +1977,628 @@
           </c:spPr>
         </c:majorGridlines>
         <c:numFmt formatCode="#,##0" sourceLinked="0"/>
+        <c:majorTickMark val="out"/>
+        <c:minorTickMark val="none"/>
+        <c:tickLblPos val="nextTo"/>
+        <c:spPr>
+          <a:ln>
+            <a:noFill/>
+          </a:ln>
+        </c:spPr>
+        <c:txPr>
+          <a:bodyPr/>
+          <a:lstStyle/>
+          <a:p>
+            <a:pPr>
+              <a:defRPr sz="1200">
+                <a:solidFill>
+                  <a:srgbClr val="4C5852"/>
+                </a:solidFill>
+                <a:latin typeface="Inter"/>
+              </a:defRPr>
+            </a:pPr>
+          </a:p>
+        </c:txPr>
+        <c:crossAx val="-2068027336"/>
+        <c:crosses val="autoZero"/>
+      </c:valAx>
+    </c:plotArea>
+    <c:legend>
+      <c:legendPos val="t"/>
+      <c:overlay val="0"/>
+      <c:txPr>
+        <a:bodyPr/>
+        <a:lstStyle/>
+        <a:p>
+          <a:pPr>
+            <a:defRPr sz="1200">
+              <a:solidFill>
+                <a:srgbClr val="4C5852"/>
+              </a:solidFill>
+              <a:latin typeface="Inter"/>
+            </a:defRPr>
+          </a:pPr>
+        </a:p>
+      </c:txPr>
+    </c:legend>
+    <c:dispBlanksAs val="gap"/>
+  </c:chart>
+  <c:txPr>
+    <a:bodyPr/>
+    <a:lstStyle/>
+    <a:p>
+      <a:pPr>
+        <a:defRPr sz="1200">
+          <a:solidFill>
+            <a:srgbClr val="4C5852"/>
+          </a:solidFill>
+          <a:latin typeface="Inter"/>
+        </a:defRPr>
+      </a:pPr>
+      <a:endParaRPr lang="en-US"/>
+    </a:p>
+  </c:txPr>
+  <c:externalData r:id="rId1">
+    <c:autoUpdate val="0"/>
+  </c:externalData>
+</c:chartSpace>
+</file>
+
+<file path=ppt/charts/chart15.xml><?xml version="1.0" encoding="utf-8"?>
+<c:chartSpace xmlns:c="http://schemas.openxmlformats.org/drawingml/2006/chart" xmlns:a="http://schemas.openxmlformats.org/drawingml/2006/main" xmlns:r="http://schemas.openxmlformats.org/officeDocument/2006/relationships">
+  <c:date1904 val="0"/>
+  <c:chart>
+    <c:autoTitleDeleted val="1"/>
+    <c:plotArea>
+      <c:barChart>
+        <c:barDir val="col"/>
+        <c:grouping val="clustered"/>
+        <c:ser>
+          <c:idx val="0"/>
+          <c:order val="0"/>
+          <c:tx>
+            <c:strRef>
+              <c:f>Sheet1!$B$1</c:f>
+              <c:strCache>
+                <c:ptCount val="1"/>
+                <c:pt idx="0">
+                  <c:v>Reja</c:v>
+                </c:pt>
+              </c:strCache>
+            </c:strRef>
+          </c:tx>
+          <c:spPr>
+            <a:solidFill>
+              <a:srgbClr val="A9C4D1"/>
+            </a:solidFill>
+          </c:spPr>
+          <c:cat>
+            <c:strRef>
+              <c:f>Sheet1!$A$2:$A$4</c:f>
+              <c:strCache>
+                <c:ptCount val="3"/>
+                <c:pt idx="0">
+                  <c:v>Mingbuloq</c:v>
+                </c:pt>
+                <c:pt idx="1">
+                  <c:v>Pop</c:v>
+                </c:pt>
+                <c:pt idx="2">
+                  <c:v>Toʻraqoʻrgʻon</c:v>
+                </c:pt>
+              </c:strCache>
+            </c:strRef>
+          </c:cat>
+          <c:val>
+            <c:numRef>
+              <c:f>Sheet1!$B$2:$B$4</c:f>
+              <c:numCache>
+                <c:formatCode>General</c:formatCode>
+                <c:ptCount val="3"/>
+                <c:pt idx="0">
+                  <c:v>17674.7</c:v>
+                </c:pt>
+                <c:pt idx="1">
+                  <c:v>10466.1</c:v>
+                </c:pt>
+                <c:pt idx="2">
+                  <c:v>257.9</c:v>
+                </c:pt>
+              </c:numCache>
+            </c:numRef>
+          </c:val>
+        </c:ser>
+        <c:ser>
+          <c:idx val="1"/>
+          <c:order val="1"/>
+          <c:tx>
+            <c:strRef>
+              <c:f>Sheet1!$C$1</c:f>
+              <c:strCache>
+                <c:ptCount val="1"/>
+                <c:pt idx="0">
+                  <c:v>Amalda</c:v>
+                </c:pt>
+              </c:strCache>
+            </c:strRef>
+          </c:tx>
+          <c:spPr>
+            <a:solidFill>
+              <a:srgbClr val="2C6A85"/>
+            </a:solidFill>
+          </c:spPr>
+          <c:cat>
+            <c:strRef>
+              <c:f>Sheet1!$A$2:$A$4</c:f>
+              <c:strCache>
+                <c:ptCount val="3"/>
+                <c:pt idx="0">
+                  <c:v>Mingbuloq</c:v>
+                </c:pt>
+                <c:pt idx="1">
+                  <c:v>Pop</c:v>
+                </c:pt>
+                <c:pt idx="2">
+                  <c:v>Toʻraqoʻrgʻon</c:v>
+                </c:pt>
+              </c:strCache>
+            </c:strRef>
+          </c:cat>
+          <c:val>
+            <c:numRef>
+              <c:f>Sheet1!$C$2:$C$4</c:f>
+              <c:numCache>
+                <c:formatCode>General</c:formatCode>
+                <c:ptCount val="3"/>
+                <c:pt idx="0">
+                  <c:v>17004.0</c:v>
+                </c:pt>
+                <c:pt idx="1">
+                  <c:v>7160.8</c:v>
+                </c:pt>
+                <c:pt idx="2">
+                  <c:v>246.0</c:v>
+                </c:pt>
+              </c:numCache>
+            </c:numRef>
+          </c:val>
+        </c:ser>
+        <c:dLbls>
+          <c:numFmt formatCode="#,##0" sourceLinked="0"/>
+          <c:txPr>
+            <a:bodyPr/>
+            <a:lstStyle/>
+            <a:p>
+              <a:pPr>
+                <a:defRPr sz="1200">
+                  <a:solidFill>
+                    <a:srgbClr val="1D2A24"/>
+                  </a:solidFill>
+                  <a:latin typeface="Inter"/>
+                </a:defRPr>
+              </a:pPr>
+            </a:p>
+          </c:txPr>
+          <c:dLblPos val="outEnd"/>
+          <c:showLegendKey val="0"/>
+          <c:showVal val="1"/>
+          <c:showCatName val="0"/>
+          <c:showSerName val="0"/>
+          <c:showPercent val="0"/>
+          <c:showBubbleSize val="0"/>
+          <c:showLeaderLines val="1"/>
+        </c:dLbls>
+        <c:gapWidth val="60"/>
+        <c:overlap val="-5"/>
+        <c:axId val="-2068027336"/>
+        <c:axId val="-2113994440"/>
+      </c:barChart>
+      <c:catAx>
+        <c:axId val="-2068027336"/>
+        <c:scaling>
+          <c:orientation val="minMax"/>
+        </c:scaling>
+        <c:delete val="0"/>
+        <c:axPos val="b"/>
+        <c:majorTickMark val="out"/>
+        <c:minorTickMark val="none"/>
+        <c:tickLblPos val="nextTo"/>
+        <c:spPr>
+          <a:ln>
+            <a:solidFill>
+              <a:srgbClr val="B5B2AD"/>
+            </a:solidFill>
+          </a:ln>
+        </c:spPr>
+        <c:txPr>
+          <a:bodyPr/>
+          <a:lstStyle/>
+          <a:p>
+            <a:pPr>
+              <a:defRPr sz="1200">
+                <a:solidFill>
+                  <a:srgbClr val="4C5852"/>
+                </a:solidFill>
+                <a:latin typeface="Inter"/>
+              </a:defRPr>
+            </a:pPr>
+          </a:p>
+        </c:txPr>
+        <c:crossAx val="-2113994440"/>
+        <c:crosses val="autoZero"/>
+        <c:auto val="1"/>
+        <c:lblAlgn val="ctr"/>
+        <c:lblOffset val="100"/>
+        <c:noMultiLvlLbl val="0"/>
+      </c:catAx>
+      <c:valAx>
+        <c:axId val="-2113994440"/>
+        <c:scaling>
+          <c:max val="21000.0"/>
+          <c:min val="0.0"/>
+        </c:scaling>
+        <c:delete/>
+        <c:axPos val="l"/>
+        <c:majorTickMark val="out"/>
+        <c:minorTickMark val="none"/>
+        <c:tickLblPos val="nextTo"/>
+        <c:crossAx val="-2068027336"/>
+        <c:crosses val="autoZero"/>
+      </c:valAx>
+    </c:plotArea>
+    <c:legend>
+      <c:legendPos val="t"/>
+      <c:overlay val="0"/>
+      <c:txPr>
+        <a:bodyPr/>
+        <a:lstStyle/>
+        <a:p>
+          <a:pPr>
+            <a:defRPr sz="1200">
+              <a:solidFill>
+                <a:srgbClr val="4C5852"/>
+              </a:solidFill>
+              <a:latin typeface="Inter"/>
+            </a:defRPr>
+          </a:pPr>
+        </a:p>
+      </c:txPr>
+    </c:legend>
+    <c:dispBlanksAs val="gap"/>
+  </c:chart>
+  <c:txPr>
+    <a:bodyPr/>
+    <a:lstStyle/>
+    <a:p>
+      <a:pPr>
+        <a:defRPr sz="1200">
+          <a:solidFill>
+            <a:srgbClr val="4C5852"/>
+          </a:solidFill>
+          <a:latin typeface="Inter"/>
+        </a:defRPr>
+      </a:pPr>
+      <a:endParaRPr lang="en-US"/>
+    </a:p>
+  </c:txPr>
+  <c:externalData r:id="rId1">
+    <c:autoUpdate val="0"/>
+  </c:externalData>
+</c:chartSpace>
+</file>
+
+<file path=ppt/charts/chart16.xml><?xml version="1.0" encoding="utf-8"?>
+<c:chartSpace xmlns:c="http://schemas.openxmlformats.org/drawingml/2006/chart" xmlns:a="http://schemas.openxmlformats.org/drawingml/2006/main" xmlns:r="http://schemas.openxmlformats.org/officeDocument/2006/relationships">
+  <c:date1904 val="0"/>
+  <c:chart>
+    <c:autoTitleDeleted val="1"/>
+    <c:plotArea>
+      <c:barChart>
+        <c:barDir val="bar"/>
+        <c:grouping val="clustered"/>
+        <c:ser>
+          <c:idx val="0"/>
+          <c:order val="0"/>
+          <c:tx>
+            <c:strRef>
+              <c:f>Sheet1!$B$1</c:f>
+              <c:strCache>
+                <c:ptCount val="1"/>
+                <c:pt idx="0">
+                  <c:v>Reja</c:v>
+                </c:pt>
+              </c:strCache>
+            </c:strRef>
+          </c:tx>
+          <c:spPr>
+            <a:solidFill>
+              <a:srgbClr val="A9C4D1"/>
+            </a:solidFill>
+          </c:spPr>
+          <c:cat>
+            <c:strRef>
+              <c:f>Sheet1!$A$2:$A$15</c:f>
+              <c:strCache>
+                <c:ptCount val="14"/>
+                <c:pt idx="0">
+                  <c:v>Buvayda</c:v>
+                </c:pt>
+                <c:pt idx="1">
+                  <c:v>Dangʻara</c:v>
+                </c:pt>
+                <c:pt idx="2">
+                  <c:v>Furqat</c:v>
+                </c:pt>
+                <c:pt idx="3">
+                  <c:v>Oʻzbekiston</c:v>
+                </c:pt>
+                <c:pt idx="4">
+                  <c:v>Uchkoʻprik</c:v>
+                </c:pt>
+                <c:pt idx="5">
+                  <c:v>Bogʻdod</c:v>
+                </c:pt>
+                <c:pt idx="6">
+                  <c:v>Beshariq</c:v>
+                </c:pt>
+                <c:pt idx="7">
+                  <c:v>Rishton</c:v>
+                </c:pt>
+                <c:pt idx="8">
+                  <c:v>Yozyovon</c:v>
+                </c:pt>
+                <c:pt idx="9">
+                  <c:v>Qoʻshtepa</c:v>
+                </c:pt>
+                <c:pt idx="10">
+                  <c:v>Toshloq</c:v>
+                </c:pt>
+                <c:pt idx="11">
+                  <c:v>Fargʻona</c:v>
+                </c:pt>
+                <c:pt idx="12">
+                  <c:v>Oltiariq</c:v>
+                </c:pt>
+                <c:pt idx="13">
+                  <c:v>Quva</c:v>
+                </c:pt>
+              </c:strCache>
+            </c:strRef>
+          </c:cat>
+          <c:val>
+            <c:numRef>
+              <c:f>Sheet1!$B$2:$B$15</c:f>
+              <c:numCache>
+                <c:formatCode>General</c:formatCode>
+                <c:ptCount val="14"/>
+                <c:pt idx="0">
+                  <c:v>4.7</c:v>
+                </c:pt>
+                <c:pt idx="1">
+                  <c:v>4.0</c:v>
+                </c:pt>
+                <c:pt idx="2">
+                  <c:v>3.0</c:v>
+                </c:pt>
+                <c:pt idx="3">
+                  <c:v>1.5</c:v>
+                </c:pt>
+                <c:pt idx="4">
+                  <c:v>2.4</c:v>
+                </c:pt>
+                <c:pt idx="5">
+                  <c:v>3.5</c:v>
+                </c:pt>
+                <c:pt idx="6">
+                  <c:v>5.2</c:v>
+                </c:pt>
+                <c:pt idx="7">
+                  <c:v>2.2</c:v>
+                </c:pt>
+                <c:pt idx="8">
+                  <c:v>2.0</c:v>
+                </c:pt>
+                <c:pt idx="9">
+                  <c:v>2.7</c:v>
+                </c:pt>
+                <c:pt idx="10">
+                  <c:v>0.2</c:v>
+                </c:pt>
+                <c:pt idx="11">
+                  <c:v>0.6</c:v>
+                </c:pt>
+                <c:pt idx="12">
+                  <c:v>1.2</c:v>
+                </c:pt>
+                <c:pt idx="13">
+                  <c:v>0.2</c:v>
+                </c:pt>
+              </c:numCache>
+            </c:numRef>
+          </c:val>
+        </c:ser>
+        <c:ser>
+          <c:idx val="1"/>
+          <c:order val="1"/>
+          <c:tx>
+            <c:strRef>
+              <c:f>Sheet1!$C$1</c:f>
+              <c:strCache>
+                <c:ptCount val="1"/>
+                <c:pt idx="0">
+                  <c:v>Amalda</c:v>
+                </c:pt>
+              </c:strCache>
+            </c:strRef>
+          </c:tx>
+          <c:spPr>
+            <a:solidFill>
+              <a:srgbClr val="2C6A85"/>
+            </a:solidFill>
+          </c:spPr>
+          <c:cat>
+            <c:strRef>
+              <c:f>Sheet1!$A$2:$A$15</c:f>
+              <c:strCache>
+                <c:ptCount val="14"/>
+                <c:pt idx="0">
+                  <c:v>Buvayda</c:v>
+                </c:pt>
+                <c:pt idx="1">
+                  <c:v>Dangʻara</c:v>
+                </c:pt>
+                <c:pt idx="2">
+                  <c:v>Furqat</c:v>
+                </c:pt>
+                <c:pt idx="3">
+                  <c:v>Oʻzbekiston</c:v>
+                </c:pt>
+                <c:pt idx="4">
+                  <c:v>Uchkoʻprik</c:v>
+                </c:pt>
+                <c:pt idx="5">
+                  <c:v>Bogʻdod</c:v>
+                </c:pt>
+                <c:pt idx="6">
+                  <c:v>Beshariq</c:v>
+                </c:pt>
+                <c:pt idx="7">
+                  <c:v>Rishton</c:v>
+                </c:pt>
+                <c:pt idx="8">
+                  <c:v>Yozyovon</c:v>
+                </c:pt>
+                <c:pt idx="9">
+                  <c:v>Qoʻshtepa</c:v>
+                </c:pt>
+                <c:pt idx="10">
+                  <c:v>Toshloq</c:v>
+                </c:pt>
+                <c:pt idx="11">
+                  <c:v>Fargʻona</c:v>
+                </c:pt>
+                <c:pt idx="12">
+                  <c:v>Oltiariq</c:v>
+                </c:pt>
+                <c:pt idx="13">
+                  <c:v>Quva</c:v>
+                </c:pt>
+              </c:strCache>
+            </c:strRef>
+          </c:cat>
+          <c:val>
+            <c:numRef>
+              <c:f>Sheet1!$C$2:$C$15</c:f>
+              <c:numCache>
+                <c:formatCode>General</c:formatCode>
+                <c:ptCount val="14"/>
+                <c:pt idx="0">
+                  <c:v>9.4</c:v>
+                </c:pt>
+                <c:pt idx="1">
+                  <c:v>8.4</c:v>
+                </c:pt>
+                <c:pt idx="2">
+                  <c:v>6.4</c:v>
+                </c:pt>
+                <c:pt idx="3">
+                  <c:v>6.0</c:v>
+                </c:pt>
+                <c:pt idx="4">
+                  <c:v>5.5</c:v>
+                </c:pt>
+                <c:pt idx="5">
+                  <c:v>5.0</c:v>
+                </c:pt>
+                <c:pt idx="6">
+                  <c:v>4.5</c:v>
+                </c:pt>
+                <c:pt idx="7">
+                  <c:v>4.4</c:v>
+                </c:pt>
+                <c:pt idx="8">
+                  <c:v>3.8</c:v>
+                </c:pt>
+                <c:pt idx="9">
+                  <c:v>3.6</c:v>
+                </c:pt>
+                <c:pt idx="10">
+                  <c:v>2.5</c:v>
+                </c:pt>
+                <c:pt idx="11">
+                  <c:v>2.4</c:v>
+                </c:pt>
+                <c:pt idx="12">
+                  <c:v>1.8</c:v>
+                </c:pt>
+                <c:pt idx="13">
+                  <c:v>1.2</c:v>
+                </c:pt>
+              </c:numCache>
+            </c:numRef>
+          </c:val>
+        </c:ser>
+        <c:gapWidth val="40"/>
+        <c:overlap val="-5"/>
+        <c:axId val="-2068027336"/>
+        <c:axId val="-2113994440"/>
+      </c:barChart>
+      <c:catAx>
+        <c:axId val="-2068027336"/>
+        <c:scaling>
+          <c:orientation val="maxMin"/>
+        </c:scaling>
+        <c:delete val="0"/>
+        <c:axPos val="l"/>
+        <c:majorTickMark val="out"/>
+        <c:minorTickMark val="none"/>
+        <c:tickLblPos val="nextTo"/>
+        <c:spPr>
+          <a:ln>
+            <a:solidFill>
+              <a:srgbClr val="B5B2AD"/>
+            </a:solidFill>
+          </a:ln>
+        </c:spPr>
+        <c:txPr>
+          <a:bodyPr/>
+          <a:lstStyle/>
+          <a:p>
+            <a:pPr>
+              <a:defRPr sz="1200">
+                <a:solidFill>
+                  <a:srgbClr val="4C5852"/>
+                </a:solidFill>
+                <a:latin typeface="Inter"/>
+              </a:defRPr>
+            </a:pPr>
+          </a:p>
+        </c:txPr>
+        <c:crossAx val="-2113994440"/>
+        <c:crosses val="autoZero"/>
+        <c:auto val="1"/>
+        <c:lblAlgn val="ctr"/>
+        <c:lblOffset val="100"/>
+        <c:noMultiLvlLbl val="0"/>
+      </c:catAx>
+      <c:valAx>
+        <c:axId val="-2113994440"/>
+        <c:scaling>
+          <c:max val="10.0"/>
+          <c:min val="0.0"/>
+        </c:scaling>
+        <c:delete val="0"/>
+        <c:axPos val="b"/>
+        <c:majorGridlines>
+          <c:spPr>
+            <a:ln>
+              <a:solidFill>
+                <a:srgbClr val="D9D2C3"/>
+              </a:solidFill>
+            </a:ln>
+          </c:spPr>
+        </c:majorGridlines>
+        <c:numFmt formatCode="0" sourceLinked="0"/>
         <c:majorTickMark val="out"/>
         <c:minorTickMark val="none"/>
         <c:tickLblPos val="nextTo"/>
@@ -6542,7 +7302,7 @@
                 <a:ea typeface="Inter" pitchFamily="34" charset="-122"/>
                 <a:cs typeface="Inter" pitchFamily="34" charset="-120"/>
               </a:rPr>
-              <a:t>21 · DISSERTATSIYA TUZILISHI</a:t>
+              <a:t>23 · DISSERTATSIYA TUZILISHI</a:t>
             </a:r>
             <a:endParaRPr lang="en-US" sz="1200" dirty="0"/>
           </a:p>
@@ -7341,7 +8101,7 @@
                 <a:ea typeface="Inter" pitchFamily="34" charset="-122"/>
                 <a:cs typeface="Inter" pitchFamily="34" charset="-120"/>
               </a:rPr>
-              <a:t>22</a:t>
+              <a:t>24</a:t>
             </a:r>
             <a:endParaRPr lang="en-US" sz="1200" dirty="0"/>
           </a:p>
@@ -7417,7 +8177,7 @@
                 <a:ea typeface="Inter" pitchFamily="34" charset="-122"/>
                 <a:cs typeface="Inter" pitchFamily="34" charset="-120"/>
               </a:rPr>
-              <a:t>22 · DISSERTATSIYA TUZILISHI</a:t>
+              <a:t>24 · DISSERTATSIYA TUZILISHI</a:t>
             </a:r>
             <a:endParaRPr lang="en-US" sz="1200" dirty="0"/>
           </a:p>
@@ -8449,7 +9209,7 @@
                 <a:ea typeface="Inter" pitchFamily="34" charset="-122"/>
                 <a:cs typeface="Inter" pitchFamily="34" charset="-120"/>
               </a:rPr>
-              <a:t>23</a:t>
+              <a:t>25</a:t>
             </a:r>
             <a:endParaRPr lang="en-US" sz="1200" dirty="0"/>
           </a:p>
@@ -8525,7 +9285,7 @@
                 <a:ea typeface="Inter" pitchFamily="34" charset="-122"/>
                 <a:cs typeface="Inter" pitchFamily="34" charset="-120"/>
               </a:rPr>
-              <a:t>23 · DISSERTATSIYA TUZILISHI</a:t>
+              <a:t>25 · DISSERTATSIYA TUZILISHI</a:t>
             </a:r>
             <a:endParaRPr lang="en-US" sz="1200" dirty="0"/>
           </a:p>
@@ -9552,7 +10312,7 @@
                 <a:ea typeface="Inter" pitchFamily="34" charset="-122"/>
                 <a:cs typeface="Inter" pitchFamily="34" charset="-120"/>
               </a:rPr>
-              <a:t>24</a:t>
+              <a:t>26</a:t>
             </a:r>
             <a:endParaRPr lang="en-US" sz="1200" dirty="0"/>
           </a:p>
@@ -9628,7 +10388,7 @@
                 <a:ea typeface="Inter" pitchFamily="34" charset="-122"/>
                 <a:cs typeface="Inter" pitchFamily="34" charset="-120"/>
               </a:rPr>
-              <a:t>24 · NATIJALAR VA REJA</a:t>
+              <a:t>26 · NATIJALAR VA REJA</a:t>
             </a:r>
             <a:endParaRPr lang="en-US" sz="1200" dirty="0"/>
           </a:p>
@@ -10366,7 +11126,7 @@
                 <a:ea typeface="Inter" pitchFamily="34" charset="-122"/>
                 <a:cs typeface="Inter" pitchFamily="34" charset="-120"/>
               </a:rPr>
-              <a:t>25</a:t>
+              <a:t>27</a:t>
             </a:r>
             <a:endParaRPr lang="en-US" sz="1200" dirty="0"/>
           </a:p>
@@ -10442,7 +11202,7 @@
                 <a:ea typeface="Inter" pitchFamily="34" charset="-122"/>
                 <a:cs typeface="Inter" pitchFamily="34" charset="-120"/>
               </a:rPr>
-              <a:t>25 · NATIJALAR VA REJA</a:t>
+              <a:t>27 · NATIJALAR VA REJA</a:t>
             </a:r>
             <a:endParaRPr lang="en-US" sz="1200" dirty="0"/>
           </a:p>
@@ -11468,7 +12228,7 @@
                 <a:ea typeface="Inter" pitchFamily="34" charset="-122"/>
                 <a:cs typeface="Inter" pitchFamily="34" charset="-120"/>
               </a:rPr>
-              <a:t>26</a:t>
+              <a:t>28</a:t>
             </a:r>
             <a:endParaRPr lang="en-US" sz="1200" dirty="0"/>
           </a:p>
@@ -11544,7 +12304,7 @@
                 <a:ea typeface="Inter" pitchFamily="34" charset="-122"/>
                 <a:cs typeface="Inter" pitchFamily="34" charset="-120"/>
               </a:rPr>
-              <a:t>26 · NATIJALAR VA REJA</a:t>
+              <a:t>28 · NATIJALAR VA REJA</a:t>
             </a:r>
             <a:endParaRPr lang="en-US" sz="1200" dirty="0"/>
           </a:p>
@@ -12156,7 +12916,7 @@
                 <a:ea typeface="Inter" pitchFamily="34" charset="-122"/>
                 <a:cs typeface="Inter" pitchFamily="34" charset="-120"/>
               </a:rPr>
-              <a:t>27</a:t>
+              <a:t>29</a:t>
             </a:r>
             <a:endParaRPr lang="en-US" sz="1200" dirty="0"/>
           </a:p>
@@ -17153,7 +17913,7 @@
                 </a:solidFill>
                 <a:latin typeface="Source Serif 4"/>
               </a:rPr>
-              <a:t>23,2 → 22,7</a:t>
+              <a:t>23,2 → 22,6</a:t>
             </a:r>
           </a:p>
         </p:txBody>
@@ -17188,7 +17948,7 @@
                 </a:solidFill>
                 <a:latin typeface="Inter"/>
               </a:rPr>
-              <a:t>Shoʻr yuvish maydoni, ming ga (2019–20 → 2023–24); asosan Mingbuloq (15,0 ming ga) tumani</a:t>
+              <a:t>Shoʻr yuvish maydoni, ming ga (2019–20 → 2025–26); asosan Mingbuloq tumani (14,7 ming ga)</a:t>
             </a:r>
           </a:p>
         </p:txBody>
@@ -18855,7 +19615,7 @@
                 </a:solidFill>
                 <a:latin typeface="Inter"/>
               </a:rPr>
-              <a:t>Gʻoʻza maydoni tumanlar boʻyicha, ga (2022 yil hosili)</a:t>
+              <a:t>Gʻoʻza maydoni tumanlar boʻyicha, ga (2022 va 2023 yil hosili)</a:t>
             </a:r>
           </a:p>
         </p:txBody>
@@ -18869,8 +19629,8 @@
           <p:nvPr/>
         </p:nvGraphicFramePr>
         <p:xfrm>
-          <a:off x="752800" y="2100000"/>
-          <a:ext cx="6500000" cy="3950000"/>
+          <a:off x="752800" y="2080000"/>
+          <a:ext cx="6500000" cy="4000000"/>
         </p:xfrm>
         <a:graphic>
           <a:graphicData uri="http://schemas.openxmlformats.org/drawingml/2006/chart">
@@ -18956,7 +19716,7 @@
                 </a:solidFill>
                 <a:latin typeface="Source Serif 4"/>
               </a:rPr>
-              <a:t>242,1 ming ga</a:t>
+              <a:t>−5%</a:t>
             </a:r>
           </a:p>
         </p:txBody>
@@ -18991,7 +19751,7 @@
                 </a:solidFill>
                 <a:latin typeface="Inter"/>
               </a:rPr>
-              <a:t>Jami ekin joylashtirish (2022 yil hosili); gʻoʻza — 82,1 ming ga (34%), donli ekinlar — 99,5 ming ga (41%)</a:t>
+              <a:t>Fargʻona viloyatida gʻoʻza maydoni 82,1 dan 77,8 ming gaga kamaygan (2022 → 2023); donli ekinlar 99,5 dan 95,7 ming gaga</a:t>
             </a:r>
           </a:p>
         </p:txBody>
@@ -19074,7 +19834,7 @@
                 </a:solidFill>
                 <a:latin typeface="Source Serif 4"/>
               </a:rPr>
-              <a:t>11 177 fermer</a:t>
+              <a:t>242,1 ming ga</a:t>
             </a:r>
           </a:p>
         </p:txBody>
@@ -19109,7 +19869,7 @@
                 </a:solidFill>
                 <a:latin typeface="Inter"/>
               </a:rPr>
-              <a:t>Fermer xoʻjaliklari (2023-yil 1-yanvar): umumiy yer 350,0 ming ga, shundan ekin yeri 241,3 ming ga</a:t>
+              <a:t>Jami ekin joylashtirish 2022 va 2023 yillarda deyarli oʻzgarmagan; tarkib oʻzgargan</a:t>
             </a:r>
           </a:p>
         </p:txBody>
@@ -19192,7 +19952,7 @@
                 </a:solidFill>
                 <a:latin typeface="Source Serif 4"/>
               </a:rPr>
-              <a:t>2 587 fermer</a:t>
+              <a:t>11 177 fermer</a:t>
             </a:r>
           </a:p>
         </p:txBody>
@@ -19227,7 +19987,7 @@
                 </a:solidFill>
                 <a:latin typeface="Inter"/>
               </a:rPr>
-              <a:t>Paxta-gʻallachilik yoʻnalishidagi xoʻjaliklar: 217,0 ming ga yer</a:t>
+              <a:t>Fermer xoʻjaliklari (2023-yil 1-yanvar): umumiy yer 350,0 ming ga; 2 587 paxta-gʻallachilik xoʻjaligi — 217,0 ming ga</a:t>
             </a:r>
           </a:p>
         </p:txBody>
@@ -19262,7 +20022,7 @@
                 </a:solidFill>
                 <a:latin typeface="Inter"/>
               </a:rPr>
-              <a:t>Manba: Fargʻona viloyati ekin joylashtirish rejasi (2022) va fermer xoʻjaliklari ixtisosligi toʻgʻrisida maʼlumot</a:t>
+              <a:t>Manba: Fargʻona viloyati ekin joylashtirish rejalari (2022, 2023) va fermer xoʻjaliklari ixtisosligi</a:t>
             </a:r>
           </a:p>
         </p:txBody>
@@ -20465,6 +21225,607 @@
                 <a:latin typeface="Inter"/>
               </a:rPr>
               <a:t>Manba: Andijon viloyati tumanlarida 2023–2024 yillar kuzgi-qishki shoʻr yuvish grafigi</a:t>
+            </a:r>
+          </a:p>
+        </p:txBody>
+      </p:sp>
+    </p:spTree>
+  </p:cSld>
+  <p:clrMapOvr>
+    <a:masterClrMapping/>
+  </p:clrMapOvr>
+</p:sld>
+</file>
+
+<file path=ppt/slides/slide29.xml><?xml version="1.0" encoding="utf-8"?>
+<p:sld xmlns:a="http://schemas.openxmlformats.org/drawingml/2006/main" xmlns:p="http://schemas.openxmlformats.org/presentationml/2006/main" xmlns:r="http://schemas.openxmlformats.org/officeDocument/2006/relationships">
+  <p:cSld>
+    <p:bg>
+      <p:bgPr>
+        <a:solidFill>
+          <a:srgbClr val="F4F1EA"/>
+        </a:solidFill>
+      </p:bgPr>
+    </p:bg>
+    <p:spTree>
+      <p:nvGrpSpPr>
+        <p:cNvPr id="1" name=""/>
+        <p:cNvGrpSpPr/>
+        <p:nvPr/>
+      </p:nvGrpSpPr>
+      <p:grpSpPr/>
+      <p:sp>
+        <p:nvSpPr>
+          <p:cNvPr id="2" name="Text 0"/>
+          <p:cNvSpPr/>
+          <p:nvPr/>
+        </p:nvSpPr>
+        <p:spPr>
+          <a:xfrm>
+            <a:off x="812800" y="812800"/>
+            <a:ext cx="10883392" cy="238720"/>
+          </a:xfrm>
+          <a:prstGeom prst="rect">
+            <a:avLst/>
+          </a:prstGeom>
+          <a:noFill/>
+          <a:ln/>
+        </p:spPr>
+        <p:txBody>
+          <a:bodyPr wrap="square" lIns="0" tIns="0" rIns="0" bIns="0" rtlCol="0" anchor="t">
+            <a:normAutofit/>
+          </a:bodyPr>
+          <a:lstStyle/>
+          <a:p>
+            <a:pPr algn="l" indent="0" marL="0">
+              <a:lnSpc>
+                <a:spcPts val="1680"/>
+              </a:lnSpc>
+              <a:buNone/>
+            </a:pPr>
+            <a:r>
+              <a:rPr lang="en-US" sz="1200" b="1" spc="150" kern="0" dirty="0">
+                <a:solidFill>
+                  <a:srgbClr val="2C6A85"/>
+                </a:solidFill>
+                <a:latin typeface="Inter" pitchFamily="34" charset="0"/>
+                <a:ea typeface="Inter" pitchFamily="34" charset="-122"/>
+                <a:cs typeface="Inter" pitchFamily="34" charset="-120"/>
+              </a:rPr>
+              <a:t>21 · DASTLABKI MAʼLUMOTLAR</a:t>
+            </a:r>
+            <a:endParaRPr lang="en-US" sz="1200" dirty="0"/>
+          </a:p>
+        </p:txBody>
+      </p:sp>
+      <p:sp>
+        <p:nvSpPr>
+          <p:cNvPr id="3" name="Text 1"/>
+          <p:cNvSpPr/>
+          <p:nvPr>
+            <p:ph type="title"/>
+          </p:nvPr>
+        </p:nvSpPr>
+        <p:spPr>
+          <a:xfrm>
+            <a:off x="812800" y="1127720"/>
+            <a:ext cx="10883392" cy="472430"/>
+          </a:xfrm>
+          <a:prstGeom prst="rect">
+            <a:avLst/>
+          </a:prstGeom>
+          <a:noFill/>
+          <a:ln/>
+        </p:spPr>
+        <p:txBody>
+          <a:bodyPr wrap="square" lIns="0" tIns="0" rIns="0" bIns="0" rtlCol="0" anchor="t">
+            <a:normAutofit/>
+          </a:bodyPr>
+          <a:lstStyle/>
+          <a:p>
+            <a:pPr algn="l" indent="0" marL="0">
+              <a:lnSpc>
+                <a:spcPts val="3520"/>
+              </a:lnSpc>
+              <a:buNone/>
+            </a:pPr>
+            <a:r>
+              <a:rPr lang="en-US" sz="3200" b="0" i="0" dirty="0">
+                <a:solidFill>
+                  <a:srgbClr val="1D2A24"/>
+                </a:solidFill>
+                <a:latin typeface="Source Serif 4" pitchFamily="18" charset="0"/>
+                <a:ea typeface="Source Serif 4" pitchFamily="18" charset="-122"/>
+                <a:cs typeface="Source Serif 4" pitchFamily="18" charset="-120"/>
+              </a:rPr>
+              <a:t>Namangan viloyati: shoʻr yuvish bajarilishi</a:t>
+            </a:r>
+            <a:endParaRPr lang="en-US" sz="3200" dirty="0"/>
+          </a:p>
+        </p:txBody>
+      </p:sp>
+      <p:sp>
+        <p:nvSpPr>
+          <p:cNvPr id="6" name="Text 3"/>
+          <p:cNvSpPr/>
+          <p:nvPr/>
+        </p:nvSpPr>
+        <p:spPr>
+          <a:xfrm>
+            <a:off x="11137950" y="6238280"/>
+            <a:ext cx="241250" cy="238720"/>
+          </a:xfrm>
+          <a:prstGeom prst="rect">
+            <a:avLst/>
+          </a:prstGeom>
+          <a:noFill/>
+          <a:ln/>
+        </p:spPr>
+        <p:txBody>
+          <a:bodyPr wrap="square" lIns="0" tIns="0" rIns="0" bIns="0" rtlCol="0" anchor="t">
+            <a:normAutofit/>
+          </a:bodyPr>
+          <a:lstStyle/>
+          <a:p>
+            <a:pPr algn="r" indent="0" marL="0">
+              <a:lnSpc>
+                <a:spcPts val="1680"/>
+              </a:lnSpc>
+              <a:buNone/>
+            </a:pPr>
+            <a:r>
+              <a:rPr lang="en-US" sz="1200" dirty="0">
+                <a:solidFill>
+                  <a:srgbClr val="5F6B64"/>
+                </a:solidFill>
+                <a:latin typeface="Inter" pitchFamily="34" charset="0"/>
+                <a:ea typeface="Inter" pitchFamily="34" charset="-122"/>
+                <a:cs typeface="Inter" pitchFamily="34" charset="-120"/>
+              </a:rPr>
+              <a:t>22</a:t>
+            </a:r>
+            <a:endParaRPr lang="en-US" sz="1200" dirty="0"/>
+          </a:p>
+        </p:txBody>
+      </p:sp>
+      <p:sp>
+        <p:nvSpPr>
+          <p:cNvPr id="7" name="TextBox 6"/>
+          <p:cNvSpPr txBox="1"/>
+          <p:nvPr/>
+        </p:nvSpPr>
+        <p:spPr>
+          <a:xfrm>
+            <a:off x="812800" y="1830000"/>
+            <a:ext cx="6200000" cy="260000"/>
+          </a:xfrm>
+          <a:prstGeom prst="rect">
+            <a:avLst/>
+          </a:prstGeom>
+          <a:noFill/>
+        </p:spPr>
+        <p:txBody>
+          <a:bodyPr wrap="square" lIns="0" rIns="0" tIns="0" bIns="0" anchor="t">
+            <a:spAutoFit/>
+          </a:bodyPr>
+          <a:lstStyle/>
+          <a:p>
+            <a:pPr algn="l"/>
+            <a:r>
+              <a:rPr sz="1300" b="1">
+                <a:solidFill>
+                  <a:srgbClr val="2C6A85"/>
+                </a:solidFill>
+                <a:latin typeface="Inter"/>
+              </a:rPr>
+              <a:t>Shoʻr yuvish, ga: reja va amalda (2025–26, 16.01.2026 holati)</a:t>
+            </a:r>
+          </a:p>
+        </p:txBody>
+      </p:sp>
+      <p:graphicFrame>
+        <p:nvGraphicFramePr>
+          <p:cNvPr id="8" name="Chart 7"/>
+          <p:cNvGraphicFramePr>
+            <a:graphicFrameLocks noGrp="1"/>
+          </p:cNvGraphicFramePr>
+          <p:nvPr/>
+        </p:nvGraphicFramePr>
+        <p:xfrm>
+          <a:off x="752800" y="2080000"/>
+          <a:ext cx="6600000" cy="4000000"/>
+        </p:xfrm>
+        <a:graphic>
+          <a:graphicData uri="http://schemas.openxmlformats.org/drawingml/2006/chart">
+            <c:chart xmlns:c="http://schemas.openxmlformats.org/drawingml/2006/chart" r:id="rId2"/>
+          </a:graphicData>
+        </a:graphic>
+      </p:graphicFrame>
+      <p:sp>
+        <p:nvSpPr>
+          <p:cNvPr id="9" name="Rounded Rectangle 8"/>
+          <p:cNvSpPr/>
+          <p:nvPr/>
+        </p:nvSpPr>
+        <p:spPr>
+          <a:xfrm>
+            <a:off x="7700000" y="1830000"/>
+            <a:ext cx="3996192" cy="1230000"/>
+          </a:xfrm>
+          <a:prstGeom prst="roundRect">
+            <a:avLst>
+              <a:gd name="adj" fmla="val 5000"/>
+            </a:avLst>
+          </a:prstGeom>
+          <a:solidFill>
+            <a:srgbClr val="FBF9F4"/>
+          </a:solidFill>
+          <a:ln w="6350">
+            <a:solidFill>
+              <a:srgbClr val="D9D2C3"/>
+            </a:solidFill>
+          </a:ln>
+          <a:effectLst/>
+        </p:spPr>
+        <p:style>
+          <a:lnRef idx="1">
+            <a:schemeClr val="accent1"/>
+          </a:lnRef>
+          <a:fillRef idx="3">
+            <a:schemeClr val="accent1"/>
+          </a:fillRef>
+          <a:effectRef idx="2">
+            <a:schemeClr val="accent1"/>
+          </a:effectRef>
+          <a:fontRef idx="minor">
+            <a:schemeClr val="lt1"/>
+          </a:fontRef>
+        </p:style>
+        <p:txBody>
+          <a:bodyPr rtlCol="0" anchor="ctr"/>
+          <a:lstStyle/>
+          <a:p>
+            <a:pPr algn="ctr"/>
+          </a:p>
+        </p:txBody>
+      </p:sp>
+      <p:sp>
+        <p:nvSpPr>
+          <p:cNvPr id="10" name="TextBox 9"/>
+          <p:cNvSpPr txBox="1"/>
+          <p:nvPr/>
+        </p:nvSpPr>
+        <p:spPr>
+          <a:xfrm>
+            <a:off x="7930000" y="1950000"/>
+            <a:ext cx="3536192" cy="420000"/>
+          </a:xfrm>
+          <a:prstGeom prst="rect">
+            <a:avLst/>
+          </a:prstGeom>
+          <a:noFill/>
+        </p:spPr>
+        <p:txBody>
+          <a:bodyPr wrap="square" lIns="0" rIns="0" tIns="0" bIns="0" anchor="t">
+            <a:spAutoFit/>
+          </a:bodyPr>
+          <a:lstStyle/>
+          <a:p>
+            <a:pPr algn="l"/>
+            <a:r>
+              <a:rPr sz="2400" b="0">
+                <a:solidFill>
+                  <a:srgbClr val="A4521D"/>
+                </a:solidFill>
+                <a:latin typeface="Source Serif 4"/>
+              </a:rPr>
+              <a:t>22 560 ga</a:t>
+            </a:r>
+          </a:p>
+        </p:txBody>
+      </p:sp>
+      <p:sp>
+        <p:nvSpPr>
+          <p:cNvPr id="11" name="TextBox 10"/>
+          <p:cNvSpPr txBox="1"/>
+          <p:nvPr/>
+        </p:nvSpPr>
+        <p:spPr>
+          <a:xfrm>
+            <a:off x="7930000" y="2390000"/>
+            <a:ext cx="3536192" cy="620000"/>
+          </a:xfrm>
+          <a:prstGeom prst="rect">
+            <a:avLst/>
+          </a:prstGeom>
+          <a:noFill/>
+        </p:spPr>
+        <p:txBody>
+          <a:bodyPr wrap="square" lIns="0" rIns="0" tIns="0" bIns="0" anchor="t">
+            <a:spAutoFit/>
+          </a:bodyPr>
+          <a:lstStyle/>
+          <a:p>
+            <a:pPr algn="l"/>
+            <a:r>
+              <a:rPr sz="1200" b="0">
+                <a:solidFill>
+                  <a:srgbClr val="4C5852"/>
+                </a:solidFill>
+                <a:latin typeface="Inter"/>
+              </a:rPr>
+              <a:t>Shoʻr yuvishga tayyorlangan yer (2024–25 yilda — 22 657 ga); 100% bajarilgan</a:t>
+            </a:r>
+          </a:p>
+        </p:txBody>
+      </p:sp>
+      <p:sp>
+        <p:nvSpPr>
+          <p:cNvPr id="12" name="Rounded Rectangle 11"/>
+          <p:cNvSpPr/>
+          <p:nvPr/>
+        </p:nvSpPr>
+        <p:spPr>
+          <a:xfrm>
+            <a:off x="7700000" y="3210000"/>
+            <a:ext cx="3996192" cy="1230000"/>
+          </a:xfrm>
+          <a:prstGeom prst="roundRect">
+            <a:avLst>
+              <a:gd name="adj" fmla="val 5000"/>
+            </a:avLst>
+          </a:prstGeom>
+          <a:solidFill>
+            <a:srgbClr val="FBF9F4"/>
+          </a:solidFill>
+          <a:ln w="6350">
+            <a:solidFill>
+              <a:srgbClr val="D9D2C3"/>
+            </a:solidFill>
+          </a:ln>
+          <a:effectLst/>
+        </p:spPr>
+        <p:style>
+          <a:lnRef idx="1">
+            <a:schemeClr val="accent1"/>
+          </a:lnRef>
+          <a:fillRef idx="3">
+            <a:schemeClr val="accent1"/>
+          </a:fillRef>
+          <a:effectRef idx="2">
+            <a:schemeClr val="accent1"/>
+          </a:effectRef>
+          <a:fontRef idx="minor">
+            <a:schemeClr val="lt1"/>
+          </a:fontRef>
+        </p:style>
+        <p:txBody>
+          <a:bodyPr rtlCol="0" anchor="ctr"/>
+          <a:lstStyle/>
+          <a:p>
+            <a:pPr algn="ctr"/>
+          </a:p>
+        </p:txBody>
+      </p:sp>
+      <p:sp>
+        <p:nvSpPr>
+          <p:cNvPr id="13" name="TextBox 12"/>
+          <p:cNvSpPr txBox="1"/>
+          <p:nvPr/>
+        </p:nvSpPr>
+        <p:spPr>
+          <a:xfrm>
+            <a:off x="7930000" y="3330000"/>
+            <a:ext cx="3536192" cy="420000"/>
+          </a:xfrm>
+          <a:prstGeom prst="rect">
+            <a:avLst/>
+          </a:prstGeom>
+          <a:noFill/>
+        </p:spPr>
+        <p:txBody>
+          <a:bodyPr wrap="square" lIns="0" rIns="0" tIns="0" bIns="0" anchor="t">
+            <a:spAutoFit/>
+          </a:bodyPr>
+          <a:lstStyle/>
+          <a:p>
+            <a:pPr algn="l"/>
+            <a:r>
+              <a:rPr sz="2400" b="0">
+                <a:solidFill>
+                  <a:srgbClr val="2C6A85"/>
+                </a:solidFill>
+                <a:latin typeface="Source Serif 4"/>
+              </a:rPr>
+              <a:t>86,0%</a:t>
+            </a:r>
+          </a:p>
+        </p:txBody>
+      </p:sp>
+      <p:sp>
+        <p:nvSpPr>
+          <p:cNvPr id="14" name="TextBox 13"/>
+          <p:cNvSpPr txBox="1"/>
+          <p:nvPr/>
+        </p:nvSpPr>
+        <p:spPr>
+          <a:xfrm>
+            <a:off x="7930000" y="3770000"/>
+            <a:ext cx="3536192" cy="620000"/>
+          </a:xfrm>
+          <a:prstGeom prst="rect">
+            <a:avLst/>
+          </a:prstGeom>
+          <a:noFill/>
+        </p:spPr>
+        <p:txBody>
+          <a:bodyPr wrap="square" lIns="0" rIns="0" tIns="0" bIns="0" anchor="t">
+            <a:spAutoFit/>
+          </a:bodyPr>
+          <a:lstStyle/>
+          <a:p>
+            <a:pPr algn="l"/>
+            <a:r>
+              <a:rPr sz="1200" b="0">
+                <a:solidFill>
+                  <a:srgbClr val="4C5852"/>
+                </a:solidFill>
+                <a:latin typeface="Inter"/>
+              </a:rPr>
+              <a:t>Shoʻr yuvish bajarilishi: 24 411 dan 28 399 ga (16.01.2026); 2024–25 yilda mavsum oxirida — 100%</a:t>
+            </a:r>
+          </a:p>
+        </p:txBody>
+      </p:sp>
+      <p:sp>
+        <p:nvSpPr>
+          <p:cNvPr id="15" name="Rounded Rectangle 14"/>
+          <p:cNvSpPr/>
+          <p:nvPr/>
+        </p:nvSpPr>
+        <p:spPr>
+          <a:xfrm>
+            <a:off x="7700000" y="4590000"/>
+            <a:ext cx="3996192" cy="1230000"/>
+          </a:xfrm>
+          <a:prstGeom prst="roundRect">
+            <a:avLst>
+              <a:gd name="adj" fmla="val 5000"/>
+            </a:avLst>
+          </a:prstGeom>
+          <a:solidFill>
+            <a:srgbClr val="FBF9F4"/>
+          </a:solidFill>
+          <a:ln w="6350">
+            <a:solidFill>
+              <a:srgbClr val="D9D2C3"/>
+            </a:solidFill>
+          </a:ln>
+          <a:effectLst/>
+        </p:spPr>
+        <p:style>
+          <a:lnRef idx="1">
+            <a:schemeClr val="accent1"/>
+          </a:lnRef>
+          <a:fillRef idx="3">
+            <a:schemeClr val="accent1"/>
+          </a:fillRef>
+          <a:effectRef idx="2">
+            <a:schemeClr val="accent1"/>
+          </a:effectRef>
+          <a:fontRef idx="minor">
+            <a:schemeClr val="lt1"/>
+          </a:fontRef>
+        </p:style>
+        <p:txBody>
+          <a:bodyPr rtlCol="0" anchor="ctr"/>
+          <a:lstStyle/>
+          <a:p>
+            <a:pPr algn="ctr"/>
+          </a:p>
+        </p:txBody>
+      </p:sp>
+      <p:sp>
+        <p:nvSpPr>
+          <p:cNvPr id="16" name="TextBox 15"/>
+          <p:cNvSpPr txBox="1"/>
+          <p:nvPr/>
+        </p:nvSpPr>
+        <p:spPr>
+          <a:xfrm>
+            <a:off x="7930000" y="4710000"/>
+            <a:ext cx="3536192" cy="420000"/>
+          </a:xfrm>
+          <a:prstGeom prst="rect">
+            <a:avLst/>
+          </a:prstGeom>
+          <a:noFill/>
+        </p:spPr>
+        <p:txBody>
+          <a:bodyPr wrap="square" lIns="0" rIns="0" tIns="0" bIns="0" anchor="t">
+            <a:spAutoFit/>
+          </a:bodyPr>
+          <a:lstStyle/>
+          <a:p>
+            <a:pPr algn="l"/>
+            <a:r>
+              <a:rPr sz="2400" b="0">
+                <a:solidFill>
+                  <a:srgbClr val="A4521D"/>
+                </a:solidFill>
+                <a:latin typeface="Source Serif 4"/>
+              </a:rPr>
+              <a:t>68,4%</a:t>
+            </a:r>
+          </a:p>
+        </p:txBody>
+      </p:sp>
+      <p:sp>
+        <p:nvSpPr>
+          <p:cNvPr id="17" name="TextBox 16"/>
+          <p:cNvSpPr txBox="1"/>
+          <p:nvPr/>
+        </p:nvSpPr>
+        <p:spPr>
+          <a:xfrm>
+            <a:off x="7930000" y="5150000"/>
+            <a:ext cx="3536192" cy="620000"/>
+          </a:xfrm>
+          <a:prstGeom prst="rect">
+            <a:avLst/>
+          </a:prstGeom>
+          <a:noFill/>
+        </p:spPr>
+        <p:txBody>
+          <a:bodyPr wrap="square" lIns="0" rIns="0" tIns="0" bIns="0" anchor="t">
+            <a:spAutoFit/>
+          </a:bodyPr>
+          <a:lstStyle/>
+          <a:p>
+            <a:pPr algn="l"/>
+            <a:r>
+              <a:rPr sz="1200" b="0">
+                <a:solidFill>
+                  <a:srgbClr val="4C5852"/>
+                </a:solidFill>
+                <a:latin typeface="Inter"/>
+              </a:rPr>
+              <a:t>Pop tumanida bajarilish eng past (7 161 dan 10 466 ga); Mingbuloqda — 96,2%</a:t>
+            </a:r>
+          </a:p>
+        </p:txBody>
+      </p:sp>
+      <p:sp>
+        <p:nvSpPr>
+          <p:cNvPr id="18" name="TextBox 17"/>
+          <p:cNvSpPr txBox="1"/>
+          <p:nvPr/>
+        </p:nvSpPr>
+        <p:spPr>
+          <a:xfrm>
+            <a:off x="812800" y="6238280"/>
+            <a:ext cx="9800000" cy="240000"/>
+          </a:xfrm>
+          <a:prstGeom prst="rect">
+            <a:avLst/>
+          </a:prstGeom>
+          <a:noFill/>
+        </p:spPr>
+        <p:txBody>
+          <a:bodyPr wrap="square" lIns="0" rIns="0" tIns="0" bIns="0" anchor="t">
+            <a:spAutoFit/>
+          </a:bodyPr>
+          <a:lstStyle/>
+          <a:p>
+            <a:pPr algn="l"/>
+            <a:r>
+              <a:rPr sz="1200" b="0">
+                <a:solidFill>
+                  <a:srgbClr val="5F6B64"/>
+                </a:solidFill>
+                <a:latin typeface="Inter"/>
+              </a:rPr>
+              <a:t>Manba: Namangan viloyati shoʻr yuvish hisobotlari (11.02.2025 va 16.01.2026)</a:t>
             </a:r>
           </a:p>
         </p:txBody>
@@ -20676,6 +22037,607 @@
               <a:t>03</a:t>
             </a:r>
             <a:endParaRPr lang="en-US" sz="1200" dirty="0"/>
+          </a:p>
+        </p:txBody>
+      </p:sp>
+    </p:spTree>
+  </p:cSld>
+  <p:clrMapOvr>
+    <a:masterClrMapping/>
+  </p:clrMapOvr>
+</p:sld>
+</file>
+
+<file path=ppt/slides/slide30.xml><?xml version="1.0" encoding="utf-8"?>
+<p:sld xmlns:a="http://schemas.openxmlformats.org/drawingml/2006/main" xmlns:p="http://schemas.openxmlformats.org/presentationml/2006/main" xmlns:r="http://schemas.openxmlformats.org/officeDocument/2006/relationships">
+  <p:cSld>
+    <p:bg>
+      <p:bgPr>
+        <a:solidFill>
+          <a:srgbClr val="F4F1EA"/>
+        </a:solidFill>
+      </p:bgPr>
+    </p:bg>
+    <p:spTree>
+      <p:nvGrpSpPr>
+        <p:cNvPr id="1" name=""/>
+        <p:cNvGrpSpPr/>
+        <p:nvPr/>
+      </p:nvGrpSpPr>
+      <p:grpSpPr/>
+      <p:sp>
+        <p:nvSpPr>
+          <p:cNvPr id="2" name="Text 0"/>
+          <p:cNvSpPr/>
+          <p:nvPr/>
+        </p:nvSpPr>
+        <p:spPr>
+          <a:xfrm>
+            <a:off x="812800" y="812800"/>
+            <a:ext cx="10883392" cy="238720"/>
+          </a:xfrm>
+          <a:prstGeom prst="rect">
+            <a:avLst/>
+          </a:prstGeom>
+          <a:noFill/>
+          <a:ln/>
+        </p:spPr>
+        <p:txBody>
+          <a:bodyPr wrap="square" lIns="0" tIns="0" rIns="0" bIns="0" rtlCol="0" anchor="t">
+            <a:normAutofit/>
+          </a:bodyPr>
+          <a:lstStyle/>
+          <a:p>
+            <a:pPr algn="l" indent="0" marL="0">
+              <a:lnSpc>
+                <a:spcPts val="1680"/>
+              </a:lnSpc>
+              <a:buNone/>
+            </a:pPr>
+            <a:r>
+              <a:rPr lang="en-US" sz="1200" b="1" spc="150" kern="0" dirty="0">
+                <a:solidFill>
+                  <a:srgbClr val="2C6A85"/>
+                </a:solidFill>
+                <a:latin typeface="Inter" pitchFamily="34" charset="0"/>
+                <a:ea typeface="Inter" pitchFamily="34" charset="-122"/>
+                <a:cs typeface="Inter" pitchFamily="34" charset="-120"/>
+              </a:rPr>
+              <a:t>22 · DASTLABKI MAʼLUMOTLAR</a:t>
+            </a:r>
+            <a:endParaRPr lang="en-US" sz="1200" dirty="0"/>
+          </a:p>
+        </p:txBody>
+      </p:sp>
+      <p:sp>
+        <p:nvSpPr>
+          <p:cNvPr id="3" name="Text 1"/>
+          <p:cNvSpPr/>
+          <p:nvPr>
+            <p:ph type="title"/>
+          </p:nvPr>
+        </p:nvSpPr>
+        <p:spPr>
+          <a:xfrm>
+            <a:off x="812800" y="1127720"/>
+            <a:ext cx="10883392" cy="472430"/>
+          </a:xfrm>
+          <a:prstGeom prst="rect">
+            <a:avLst/>
+          </a:prstGeom>
+          <a:noFill/>
+          <a:ln/>
+        </p:spPr>
+        <p:txBody>
+          <a:bodyPr wrap="square" lIns="0" tIns="0" rIns="0" bIns="0" rtlCol="0" anchor="t">
+            <a:normAutofit/>
+          </a:bodyPr>
+          <a:lstStyle/>
+          <a:p>
+            <a:pPr algn="l" indent="0" marL="0">
+              <a:lnSpc>
+                <a:spcPts val="3520"/>
+              </a:lnSpc>
+              <a:buNone/>
+            </a:pPr>
+            <a:r>
+              <a:rPr lang="en-US" sz="3200" b="0" i="0" dirty="0">
+                <a:solidFill>
+                  <a:srgbClr val="1D2A24"/>
+                </a:solidFill>
+                <a:latin typeface="Source Serif 4" pitchFamily="18" charset="0"/>
+                <a:ea typeface="Source Serif 4" pitchFamily="18" charset="-122"/>
+                <a:cs typeface="Source Serif 4" pitchFamily="18" charset="-120"/>
+              </a:rPr>
+              <a:t>Fargʻona viloyati: suv olish</a:t>
+            </a:r>
+            <a:endParaRPr lang="en-US" sz="3200" dirty="0"/>
+          </a:p>
+        </p:txBody>
+      </p:sp>
+      <p:sp>
+        <p:nvSpPr>
+          <p:cNvPr id="6" name="Text 3"/>
+          <p:cNvSpPr/>
+          <p:nvPr/>
+        </p:nvSpPr>
+        <p:spPr>
+          <a:xfrm>
+            <a:off x="11137950" y="6238280"/>
+            <a:ext cx="241250" cy="238720"/>
+          </a:xfrm>
+          <a:prstGeom prst="rect">
+            <a:avLst/>
+          </a:prstGeom>
+          <a:noFill/>
+          <a:ln/>
+        </p:spPr>
+        <p:txBody>
+          <a:bodyPr wrap="square" lIns="0" tIns="0" rIns="0" bIns="0" rtlCol="0" anchor="t">
+            <a:normAutofit/>
+          </a:bodyPr>
+          <a:lstStyle/>
+          <a:p>
+            <a:pPr algn="r" indent="0" marL="0">
+              <a:lnSpc>
+                <a:spcPts val="1680"/>
+              </a:lnSpc>
+              <a:buNone/>
+            </a:pPr>
+            <a:r>
+              <a:rPr lang="en-US" sz="1200" dirty="0">
+                <a:solidFill>
+                  <a:srgbClr val="5F6B64"/>
+                </a:solidFill>
+                <a:latin typeface="Inter" pitchFamily="34" charset="0"/>
+                <a:ea typeface="Inter" pitchFamily="34" charset="-122"/>
+                <a:cs typeface="Inter" pitchFamily="34" charset="-120"/>
+              </a:rPr>
+              <a:t>23</a:t>
+            </a:r>
+            <a:endParaRPr lang="en-US" sz="1200" dirty="0"/>
+          </a:p>
+        </p:txBody>
+      </p:sp>
+      <p:sp>
+        <p:nvSpPr>
+          <p:cNvPr id="7" name="TextBox 6"/>
+          <p:cNvSpPr txBox="1"/>
+          <p:nvPr/>
+        </p:nvSpPr>
+        <p:spPr>
+          <a:xfrm>
+            <a:off x="812800" y="1830000"/>
+            <a:ext cx="6200000" cy="260000"/>
+          </a:xfrm>
+          <a:prstGeom prst="rect">
+            <a:avLst/>
+          </a:prstGeom>
+          <a:noFill/>
+        </p:spPr>
+        <p:txBody>
+          <a:bodyPr wrap="square" lIns="0" rIns="0" tIns="0" bIns="0" anchor="t">
+            <a:spAutoFit/>
+          </a:bodyPr>
+          <a:lstStyle/>
+          <a:p>
+            <a:pPr algn="l"/>
+            <a:r>
+              <a:rPr sz="1300" b="1">
+                <a:solidFill>
+                  <a:srgbClr val="2C6A85"/>
+                </a:solidFill>
+                <a:latin typeface="Inter"/>
+              </a:rPr>
+              <a:t>Tumanlarga ajratilgan suv sarfi, m³/s (10.01.2026): reja va amalda</a:t>
+            </a:r>
+          </a:p>
+        </p:txBody>
+      </p:sp>
+      <p:graphicFrame>
+        <p:nvGraphicFramePr>
+          <p:cNvPr id="8" name="Chart 7"/>
+          <p:cNvGraphicFramePr>
+            <a:graphicFrameLocks noGrp="1"/>
+          </p:cNvGraphicFramePr>
+          <p:nvPr/>
+        </p:nvGraphicFramePr>
+        <p:xfrm>
+          <a:off x="752800" y="2080000"/>
+          <a:ext cx="6500000" cy="4000000"/>
+        </p:xfrm>
+        <a:graphic>
+          <a:graphicData uri="http://schemas.openxmlformats.org/drawingml/2006/chart">
+            <c:chart xmlns:c="http://schemas.openxmlformats.org/drawingml/2006/chart" r:id="rId2"/>
+          </a:graphicData>
+        </a:graphic>
+      </p:graphicFrame>
+      <p:sp>
+        <p:nvSpPr>
+          <p:cNvPr id="9" name="Rounded Rectangle 8"/>
+          <p:cNvSpPr/>
+          <p:nvPr/>
+        </p:nvSpPr>
+        <p:spPr>
+          <a:xfrm>
+            <a:off x="7700000" y="1830000"/>
+            <a:ext cx="3996192" cy="1230000"/>
+          </a:xfrm>
+          <a:prstGeom prst="roundRect">
+            <a:avLst>
+              <a:gd name="adj" fmla="val 5000"/>
+            </a:avLst>
+          </a:prstGeom>
+          <a:solidFill>
+            <a:srgbClr val="FBF9F4"/>
+          </a:solidFill>
+          <a:ln w="6350">
+            <a:solidFill>
+              <a:srgbClr val="D9D2C3"/>
+            </a:solidFill>
+          </a:ln>
+          <a:effectLst/>
+        </p:spPr>
+        <p:style>
+          <a:lnRef idx="1">
+            <a:schemeClr val="accent1"/>
+          </a:lnRef>
+          <a:fillRef idx="3">
+            <a:schemeClr val="accent1"/>
+          </a:fillRef>
+          <a:effectRef idx="2">
+            <a:schemeClr val="accent1"/>
+          </a:effectRef>
+          <a:fontRef idx="minor">
+            <a:schemeClr val="lt1"/>
+          </a:fontRef>
+        </p:style>
+        <p:txBody>
+          <a:bodyPr rtlCol="0" anchor="ctr"/>
+          <a:lstStyle/>
+          <a:p>
+            <a:pPr algn="ctr"/>
+          </a:p>
+        </p:txBody>
+      </p:sp>
+      <p:sp>
+        <p:nvSpPr>
+          <p:cNvPr id="10" name="TextBox 9"/>
+          <p:cNvSpPr txBox="1"/>
+          <p:nvPr/>
+        </p:nvSpPr>
+        <p:spPr>
+          <a:xfrm>
+            <a:off x="7930000" y="1950000"/>
+            <a:ext cx="3536192" cy="420000"/>
+          </a:xfrm>
+          <a:prstGeom prst="rect">
+            <a:avLst/>
+          </a:prstGeom>
+          <a:noFill/>
+        </p:spPr>
+        <p:txBody>
+          <a:bodyPr wrap="square" lIns="0" rIns="0" tIns="0" bIns="0" anchor="t">
+            <a:spAutoFit/>
+          </a:bodyPr>
+          <a:lstStyle/>
+          <a:p>
+            <a:pPr algn="l"/>
+            <a:r>
+              <a:rPr sz="2400" b="0">
+                <a:solidFill>
+                  <a:srgbClr val="A4521D"/>
+                </a:solidFill>
+                <a:latin typeface="Source Serif 4"/>
+              </a:rPr>
+              <a:t>65,5 m³/s</a:t>
+            </a:r>
+          </a:p>
+        </p:txBody>
+      </p:sp>
+      <p:sp>
+        <p:nvSpPr>
+          <p:cNvPr id="11" name="TextBox 10"/>
+          <p:cNvSpPr txBox="1"/>
+          <p:nvPr/>
+        </p:nvSpPr>
+        <p:spPr>
+          <a:xfrm>
+            <a:off x="7930000" y="2390000"/>
+            <a:ext cx="3536192" cy="620000"/>
+          </a:xfrm>
+          <a:prstGeom prst="rect">
+            <a:avLst/>
+          </a:prstGeom>
+          <a:noFill/>
+        </p:spPr>
+        <p:txBody>
+          <a:bodyPr wrap="square" lIns="0" rIns="0" tIns="0" bIns="0" anchor="t">
+            <a:spAutoFit/>
+          </a:bodyPr>
+          <a:lstStyle/>
+          <a:p>
+            <a:pPr algn="l"/>
+            <a:r>
+              <a:rPr sz="1200" b="0">
+                <a:solidFill>
+                  <a:srgbClr val="4C5852"/>
+                </a:solidFill>
+                <a:latin typeface="Inter"/>
+              </a:rPr>
+              <a:t>Viloyat boʻyicha amalda olingan suv; kunlik reja — 34,5 m³/s (+90%)</a:t>
+            </a:r>
+          </a:p>
+        </p:txBody>
+      </p:sp>
+      <p:sp>
+        <p:nvSpPr>
+          <p:cNvPr id="12" name="Rounded Rectangle 11"/>
+          <p:cNvSpPr/>
+          <p:nvPr/>
+        </p:nvSpPr>
+        <p:spPr>
+          <a:xfrm>
+            <a:off x="7700000" y="3210000"/>
+            <a:ext cx="3996192" cy="1230000"/>
+          </a:xfrm>
+          <a:prstGeom prst="roundRect">
+            <a:avLst>
+              <a:gd name="adj" fmla="val 5000"/>
+            </a:avLst>
+          </a:prstGeom>
+          <a:solidFill>
+            <a:srgbClr val="FBF9F4"/>
+          </a:solidFill>
+          <a:ln w="6350">
+            <a:solidFill>
+              <a:srgbClr val="D9D2C3"/>
+            </a:solidFill>
+          </a:ln>
+          <a:effectLst/>
+        </p:spPr>
+        <p:style>
+          <a:lnRef idx="1">
+            <a:schemeClr val="accent1"/>
+          </a:lnRef>
+          <a:fillRef idx="3">
+            <a:schemeClr val="accent1"/>
+          </a:fillRef>
+          <a:effectRef idx="2">
+            <a:schemeClr val="accent1"/>
+          </a:effectRef>
+          <a:fontRef idx="minor">
+            <a:schemeClr val="lt1"/>
+          </a:fontRef>
+        </p:style>
+        <p:txBody>
+          <a:bodyPr rtlCol="0" anchor="ctr"/>
+          <a:lstStyle/>
+          <a:p>
+            <a:pPr algn="ctr"/>
+          </a:p>
+        </p:txBody>
+      </p:sp>
+      <p:sp>
+        <p:nvSpPr>
+          <p:cNvPr id="13" name="TextBox 12"/>
+          <p:cNvSpPr txBox="1"/>
+          <p:nvPr/>
+        </p:nvSpPr>
+        <p:spPr>
+          <a:xfrm>
+            <a:off x="7930000" y="3330000"/>
+            <a:ext cx="3536192" cy="420000"/>
+          </a:xfrm>
+          <a:prstGeom prst="rect">
+            <a:avLst/>
+          </a:prstGeom>
+          <a:noFill/>
+        </p:spPr>
+        <p:txBody>
+          <a:bodyPr wrap="square" lIns="0" rIns="0" tIns="0" bIns="0" anchor="t">
+            <a:spAutoFit/>
+          </a:bodyPr>
+          <a:lstStyle/>
+          <a:p>
+            <a:pPr algn="l"/>
+            <a:r>
+              <a:rPr sz="2400" b="0">
+                <a:solidFill>
+                  <a:srgbClr val="2C6A85"/>
+                </a:solidFill>
+                <a:latin typeface="Source Serif 4"/>
+              </a:rPr>
+              <a:t>13 ta tuman</a:t>
+            </a:r>
+          </a:p>
+        </p:txBody>
+      </p:sp>
+      <p:sp>
+        <p:nvSpPr>
+          <p:cNvPr id="14" name="TextBox 13"/>
+          <p:cNvSpPr txBox="1"/>
+          <p:nvPr/>
+        </p:nvSpPr>
+        <p:spPr>
+          <a:xfrm>
+            <a:off x="7930000" y="3770000"/>
+            <a:ext cx="3536192" cy="620000"/>
+          </a:xfrm>
+          <a:prstGeom prst="rect">
+            <a:avLst/>
+          </a:prstGeom>
+          <a:noFill/>
+        </p:spPr>
+        <p:txBody>
+          <a:bodyPr wrap="square" lIns="0" rIns="0" tIns="0" bIns="0" anchor="t">
+            <a:spAutoFit/>
+          </a:bodyPr>
+          <a:lstStyle/>
+          <a:p>
+            <a:pPr algn="l"/>
+            <a:r>
+              <a:rPr sz="1200" b="0">
+                <a:solidFill>
+                  <a:srgbClr val="4C5852"/>
+                </a:solidFill>
+                <a:latin typeface="Inter"/>
+              </a:rPr>
+              <a:t>Amalda olingan suv rejadan yuqori; Oʻzbekiston tumanida 6,0 (reja 1,5), Buvayda va Dangʻarada ~2 barobar</a:t>
+            </a:r>
+          </a:p>
+        </p:txBody>
+      </p:sp>
+      <p:sp>
+        <p:nvSpPr>
+          <p:cNvPr id="15" name="Rounded Rectangle 14"/>
+          <p:cNvSpPr/>
+          <p:nvPr/>
+        </p:nvSpPr>
+        <p:spPr>
+          <a:xfrm>
+            <a:off x="7700000" y="4590000"/>
+            <a:ext cx="3996192" cy="1230000"/>
+          </a:xfrm>
+          <a:prstGeom prst="roundRect">
+            <a:avLst>
+              <a:gd name="adj" fmla="val 5000"/>
+            </a:avLst>
+          </a:prstGeom>
+          <a:solidFill>
+            <a:srgbClr val="FBF9F4"/>
+          </a:solidFill>
+          <a:ln w="6350">
+            <a:solidFill>
+              <a:srgbClr val="D9D2C3"/>
+            </a:solidFill>
+          </a:ln>
+          <a:effectLst/>
+        </p:spPr>
+        <p:style>
+          <a:lnRef idx="1">
+            <a:schemeClr val="accent1"/>
+          </a:lnRef>
+          <a:fillRef idx="3">
+            <a:schemeClr val="accent1"/>
+          </a:fillRef>
+          <a:effectRef idx="2">
+            <a:schemeClr val="accent1"/>
+          </a:effectRef>
+          <a:fontRef idx="minor">
+            <a:schemeClr val="lt1"/>
+          </a:fontRef>
+        </p:style>
+        <p:txBody>
+          <a:bodyPr rtlCol="0" anchor="ctr"/>
+          <a:lstStyle/>
+          <a:p>
+            <a:pPr algn="ctr"/>
+          </a:p>
+        </p:txBody>
+      </p:sp>
+      <p:sp>
+        <p:nvSpPr>
+          <p:cNvPr id="16" name="TextBox 15"/>
+          <p:cNvSpPr txBox="1"/>
+          <p:nvPr/>
+        </p:nvSpPr>
+        <p:spPr>
+          <a:xfrm>
+            <a:off x="7930000" y="4710000"/>
+            <a:ext cx="3536192" cy="420000"/>
+          </a:xfrm>
+          <a:prstGeom prst="rect">
+            <a:avLst/>
+          </a:prstGeom>
+          <a:noFill/>
+        </p:spPr>
+        <p:txBody>
+          <a:bodyPr wrap="square" lIns="0" rIns="0" tIns="0" bIns="0" anchor="t">
+            <a:spAutoFit/>
+          </a:bodyPr>
+          <a:lstStyle/>
+          <a:p>
+            <a:pPr algn="l"/>
+            <a:r>
+              <a:rPr sz="2400" b="0">
+                <a:solidFill>
+                  <a:srgbClr val="A4521D"/>
+                </a:solidFill>
+                <a:latin typeface="Source Serif 4"/>
+              </a:rPr>
+              <a:t>Yanvar</a:t>
+            </a:r>
+          </a:p>
+        </p:txBody>
+      </p:sp>
+      <p:sp>
+        <p:nvSpPr>
+          <p:cNvPr id="17" name="TextBox 16"/>
+          <p:cNvSpPr txBox="1"/>
+          <p:nvPr/>
+        </p:nvSpPr>
+        <p:spPr>
+          <a:xfrm>
+            <a:off x="7930000" y="5150000"/>
+            <a:ext cx="3536192" cy="620000"/>
+          </a:xfrm>
+          <a:prstGeom prst="rect">
+            <a:avLst/>
+          </a:prstGeom>
+          <a:noFill/>
+        </p:spPr>
+        <p:txBody>
+          <a:bodyPr wrap="square" lIns="0" rIns="0" tIns="0" bIns="0" anchor="t">
+            <a:spAutoFit/>
+          </a:bodyPr>
+          <a:lstStyle/>
+          <a:p>
+            <a:pPr algn="l"/>
+            <a:r>
+              <a:rPr sz="1200" b="0">
+                <a:solidFill>
+                  <a:srgbClr val="4C5852"/>
+                </a:solidFill>
+                <a:latin typeface="Inter"/>
+              </a:rPr>
+              <a:t>Hisobot sanasi (10.01.2026) shoʻr yuvish mavsumiga toʻgʻri keladi</a:t>
+            </a:r>
+          </a:p>
+        </p:txBody>
+      </p:sp>
+      <p:sp>
+        <p:nvSpPr>
+          <p:cNvPr id="18" name="TextBox 17"/>
+          <p:cNvSpPr txBox="1"/>
+          <p:nvPr/>
+        </p:nvSpPr>
+        <p:spPr>
+          <a:xfrm>
+            <a:off x="812800" y="6238280"/>
+            <a:ext cx="9800000" cy="240000"/>
+          </a:xfrm>
+          <a:prstGeom prst="rect">
+            <a:avLst/>
+          </a:prstGeom>
+          <a:noFill/>
+        </p:spPr>
+        <p:txBody>
+          <a:bodyPr wrap="square" lIns="0" rIns="0" tIns="0" bIns="0" anchor="t">
+            <a:spAutoFit/>
+          </a:bodyPr>
+          <a:lstStyle/>
+          <a:p>
+            <a:pPr algn="l"/>
+            <a:r>
+              <a:rPr sz="1200" b="0">
+                <a:solidFill>
+                  <a:srgbClr val="5F6B64"/>
+                </a:solidFill>
+                <a:latin typeface="Inter"/>
+              </a:rPr>
+              <a:t>Manba: tumanlarga suv manbalaridan ajratilayotgan suv sarflari toʻgʻrisida maʼlumot, 10.01.2026</a:t>
+            </a:r>
           </a:p>
         </p:txBody>
       </p:sp>

</xml_diff>

<commit_message>
Add Namangan crop placement and land degradation slides; fill normative basis
Co-Authored-By: Claude Sonnet 5.5 <noreply@anthropic.com>
Claude-Session: https://claude.ai/code/session_01M4MZatV28utL9zTp7saaUz
</commit_message>
<xml_diff>
--- a/Garbiy_Farg_ona_tuproqlari_GAT_asosida_bashoratlash.pptx
+++ b/Garbiy_Farg_ona_tuproqlari_GAT_asosida_bashoratlash.pptx
@@ -28,6 +28,8 @@
     <p:sldId id="283" r:id="rId34"/>
     <p:sldId id="284" r:id="rId35"/>
     <p:sldId id="285" r:id="rId36"/>
+    <p:sldId id="286" r:id="rId37"/>
+    <p:sldId id="287" r:id="rId38"/>
     <p:sldId id="265" r:id="rId11"/>
     <p:sldId id="266" r:id="rId12"/>
     <p:sldId id="267" r:id="rId13"/>
@@ -2585,6 +2587,520 @@
         <c:axId val="-2113994440"/>
         <c:scaling>
           <c:max val="10.0"/>
+          <c:min val="0.0"/>
+        </c:scaling>
+        <c:delete val="0"/>
+        <c:axPos val="b"/>
+        <c:majorGridlines>
+          <c:spPr>
+            <a:ln>
+              <a:solidFill>
+                <a:srgbClr val="D9D2C3"/>
+              </a:solidFill>
+            </a:ln>
+          </c:spPr>
+        </c:majorGridlines>
+        <c:numFmt formatCode="0" sourceLinked="0"/>
+        <c:majorTickMark val="out"/>
+        <c:minorTickMark val="none"/>
+        <c:tickLblPos val="nextTo"/>
+        <c:spPr>
+          <a:ln>
+            <a:noFill/>
+          </a:ln>
+        </c:spPr>
+        <c:txPr>
+          <a:bodyPr/>
+          <a:lstStyle/>
+          <a:p>
+            <a:pPr>
+              <a:defRPr sz="1200">
+                <a:solidFill>
+                  <a:srgbClr val="4C5852"/>
+                </a:solidFill>
+                <a:latin typeface="Inter"/>
+              </a:defRPr>
+            </a:pPr>
+          </a:p>
+        </c:txPr>
+        <c:crossAx val="-2068027336"/>
+        <c:crosses val="autoZero"/>
+      </c:valAx>
+    </c:plotArea>
+    <c:legend>
+      <c:legendPos val="t"/>
+      <c:overlay val="0"/>
+      <c:txPr>
+        <a:bodyPr/>
+        <a:lstStyle/>
+        <a:p>
+          <a:pPr>
+            <a:defRPr sz="1200">
+              <a:solidFill>
+                <a:srgbClr val="4C5852"/>
+              </a:solidFill>
+              <a:latin typeface="Inter"/>
+            </a:defRPr>
+          </a:pPr>
+        </a:p>
+      </c:txPr>
+    </c:legend>
+    <c:dispBlanksAs val="gap"/>
+  </c:chart>
+  <c:txPr>
+    <a:bodyPr/>
+    <a:lstStyle/>
+    <a:p>
+      <a:pPr>
+        <a:defRPr sz="1200">
+          <a:solidFill>
+            <a:srgbClr val="4C5852"/>
+          </a:solidFill>
+          <a:latin typeface="Inter"/>
+        </a:defRPr>
+      </a:pPr>
+      <a:endParaRPr lang="en-US"/>
+    </a:p>
+  </c:txPr>
+  <c:externalData r:id="rId1">
+    <c:autoUpdate val="0"/>
+  </c:externalData>
+</c:chartSpace>
+</file>
+
+<file path=ppt/charts/chart17.xml><?xml version="1.0" encoding="utf-8"?>
+<c:chartSpace xmlns:c="http://schemas.openxmlformats.org/drawingml/2006/chart" xmlns:a="http://schemas.openxmlformats.org/drawingml/2006/main" xmlns:r="http://schemas.openxmlformats.org/officeDocument/2006/relationships">
+  <c:date1904 val="0"/>
+  <c:chart>
+    <c:autoTitleDeleted val="1"/>
+    <c:plotArea>
+      <c:barChart>
+        <c:barDir val="col"/>
+        <c:grouping val="clustered"/>
+        <c:ser>
+          <c:idx val="0"/>
+          <c:order val="0"/>
+          <c:tx>
+            <c:strRef>
+              <c:f>Sheet1!$B$1</c:f>
+              <c:strCache>
+                <c:ptCount val="1"/>
+                <c:pt idx="0">
+                  <c:v>Gʻoʻza</c:v>
+                </c:pt>
+              </c:strCache>
+            </c:strRef>
+          </c:tx>
+          <c:spPr>
+            <a:solidFill>
+              <a:srgbClr val="A4521D"/>
+            </a:solidFill>
+          </c:spPr>
+          <c:cat>
+            <c:strRef>
+              <c:f>Sheet1!$A$2:$A$4</c:f>
+              <c:strCache>
+                <c:ptCount val="3"/>
+                <c:pt idx="0">
+                  <c:v>2024</c:v>
+                </c:pt>
+                <c:pt idx="1">
+                  <c:v>2025</c:v>
+                </c:pt>
+                <c:pt idx="2">
+                  <c:v>2026 (reja)</c:v>
+                </c:pt>
+              </c:strCache>
+            </c:strRef>
+          </c:cat>
+          <c:val>
+            <c:numRef>
+              <c:f>Sheet1!$B$2:$B$4</c:f>
+              <c:numCache>
+                <c:formatCode>General</c:formatCode>
+                <c:ptCount val="3"/>
+                <c:pt idx="0">
+                  <c:v>61.0</c:v>
+                </c:pt>
+                <c:pt idx="1">
+                  <c:v>48.9</c:v>
+                </c:pt>
+                <c:pt idx="2">
+                  <c:v>48.9</c:v>
+                </c:pt>
+              </c:numCache>
+            </c:numRef>
+          </c:val>
+        </c:ser>
+        <c:ser>
+          <c:idx val="1"/>
+          <c:order val="1"/>
+          <c:tx>
+            <c:strRef>
+              <c:f>Sheet1!$C$1</c:f>
+              <c:strCache>
+                <c:ptCount val="1"/>
+                <c:pt idx="0">
+                  <c:v>Bugʻdoy</c:v>
+                </c:pt>
+              </c:strCache>
+            </c:strRef>
+          </c:tx>
+          <c:spPr>
+            <a:solidFill>
+              <a:srgbClr val="2C6A85"/>
+            </a:solidFill>
+          </c:spPr>
+          <c:cat>
+            <c:strRef>
+              <c:f>Sheet1!$A$2:$A$4</c:f>
+              <c:strCache>
+                <c:ptCount val="3"/>
+                <c:pt idx="0">
+                  <c:v>2024</c:v>
+                </c:pt>
+                <c:pt idx="1">
+                  <c:v>2025</c:v>
+                </c:pt>
+                <c:pt idx="2">
+                  <c:v>2026 (reja)</c:v>
+                </c:pt>
+              </c:strCache>
+            </c:strRef>
+          </c:cat>
+          <c:val>
+            <c:numRef>
+              <c:f>Sheet1!$C$2:$C$4</c:f>
+              <c:numCache>
+                <c:formatCode>General</c:formatCode>
+                <c:ptCount val="3"/>
+                <c:pt idx="0">
+                  <c:v>68.0</c:v>
+                </c:pt>
+                <c:pt idx="1">
+                  <c:v>66.0</c:v>
+                </c:pt>
+                <c:pt idx="2">
+                  <c:v>64.4</c:v>
+                </c:pt>
+              </c:numCache>
+            </c:numRef>
+          </c:val>
+        </c:ser>
+        <c:dLbls>
+          <c:numFmt formatCode="0.0" sourceLinked="0"/>
+          <c:txPr>
+            <a:bodyPr/>
+            <a:lstStyle/>
+            <a:p>
+              <a:pPr>
+                <a:defRPr sz="1200">
+                  <a:solidFill>
+                    <a:srgbClr val="1D2A24"/>
+                  </a:solidFill>
+                  <a:latin typeface="Inter"/>
+                </a:defRPr>
+              </a:pPr>
+            </a:p>
+          </c:txPr>
+          <c:dLblPos val="outEnd"/>
+          <c:showLegendKey val="0"/>
+          <c:showVal val="1"/>
+          <c:showCatName val="0"/>
+          <c:showSerName val="0"/>
+          <c:showPercent val="0"/>
+          <c:showBubbleSize val="0"/>
+          <c:showLeaderLines val="1"/>
+        </c:dLbls>
+        <c:gapWidth val="60"/>
+        <c:overlap val="-5"/>
+        <c:axId val="-2068027336"/>
+        <c:axId val="-2113994440"/>
+      </c:barChart>
+      <c:catAx>
+        <c:axId val="-2068027336"/>
+        <c:scaling>
+          <c:orientation val="minMax"/>
+        </c:scaling>
+        <c:delete val="0"/>
+        <c:axPos val="b"/>
+        <c:majorTickMark val="out"/>
+        <c:minorTickMark val="none"/>
+        <c:tickLblPos val="nextTo"/>
+        <c:spPr>
+          <a:ln>
+            <a:solidFill>
+              <a:srgbClr val="B5B2AD"/>
+            </a:solidFill>
+          </a:ln>
+        </c:spPr>
+        <c:txPr>
+          <a:bodyPr/>
+          <a:lstStyle/>
+          <a:p>
+            <a:pPr>
+              <a:defRPr sz="1200">
+                <a:solidFill>
+                  <a:srgbClr val="4C5852"/>
+                </a:solidFill>
+                <a:latin typeface="Inter"/>
+              </a:defRPr>
+            </a:pPr>
+          </a:p>
+        </c:txPr>
+        <c:crossAx val="-2113994440"/>
+        <c:crosses val="autoZero"/>
+        <c:auto val="1"/>
+        <c:lblAlgn val="ctr"/>
+        <c:lblOffset val="100"/>
+        <c:noMultiLvlLbl val="0"/>
+      </c:catAx>
+      <c:valAx>
+        <c:axId val="-2113994440"/>
+        <c:scaling>
+          <c:max val="80.0"/>
+          <c:min val="0.0"/>
+        </c:scaling>
+        <c:delete/>
+        <c:axPos val="l"/>
+        <c:majorTickMark val="out"/>
+        <c:minorTickMark val="none"/>
+        <c:tickLblPos val="nextTo"/>
+        <c:crossAx val="-2068027336"/>
+        <c:crosses val="autoZero"/>
+      </c:valAx>
+    </c:plotArea>
+    <c:legend>
+      <c:legendPos val="t"/>
+      <c:overlay val="0"/>
+      <c:txPr>
+        <a:bodyPr/>
+        <a:lstStyle/>
+        <a:p>
+          <a:pPr>
+            <a:defRPr sz="1200">
+              <a:solidFill>
+                <a:srgbClr val="4C5852"/>
+              </a:solidFill>
+              <a:latin typeface="Inter"/>
+            </a:defRPr>
+          </a:pPr>
+        </a:p>
+      </c:txPr>
+    </c:legend>
+    <c:dispBlanksAs val="gap"/>
+  </c:chart>
+  <c:txPr>
+    <a:bodyPr/>
+    <a:lstStyle/>
+    <a:p>
+      <a:pPr>
+        <a:defRPr sz="1200">
+          <a:solidFill>
+            <a:srgbClr val="4C5852"/>
+          </a:solidFill>
+          <a:latin typeface="Inter"/>
+        </a:defRPr>
+      </a:pPr>
+      <a:endParaRPr lang="en-US"/>
+    </a:p>
+  </c:txPr>
+  <c:externalData r:id="rId1">
+    <c:autoUpdate val="0"/>
+  </c:externalData>
+</c:chartSpace>
+</file>
+
+<file path=ppt/charts/chart18.xml><?xml version="1.0" encoding="utf-8"?>
+<c:chartSpace xmlns:c="http://schemas.openxmlformats.org/drawingml/2006/chart" xmlns:a="http://schemas.openxmlformats.org/drawingml/2006/main" xmlns:r="http://schemas.openxmlformats.org/officeDocument/2006/relationships">
+  <c:date1904 val="0"/>
+  <c:chart>
+    <c:autoTitleDeleted val="1"/>
+    <c:plotArea>
+      <c:barChart>
+        <c:barDir val="bar"/>
+        <c:grouping val="clustered"/>
+        <c:ser>
+          <c:idx val="0"/>
+          <c:order val="0"/>
+          <c:tx>
+            <c:strRef>
+              <c:f>Sheet1!$B$1</c:f>
+              <c:strCache>
+                <c:ptCount val="1"/>
+                <c:pt idx="0">
+                  <c:v>Reja</c:v>
+                </c:pt>
+              </c:strCache>
+            </c:strRef>
+          </c:tx>
+          <c:spPr>
+            <a:solidFill>
+              <a:srgbClr val="A9C4D1"/>
+            </a:solidFill>
+          </c:spPr>
+          <c:cat>
+            <c:strRef>
+              <c:f>Sheet1!$A$2:$A$6</c:f>
+              <c:strCache>
+                <c:ptCount val="5"/>
+                <c:pt idx="0">
+                  <c:v>Gumusi ≤1% yerlar unumdorligini oshirish</c:v>
+                </c:pt>
+                <c:pt idx="1">
+                  <c:v>Oʻrmon mintaqalarini kengaytirish</c:v>
+                </c:pt>
+                <c:pt idx="2">
+                  <c:v>Degradatsiyaga uchragan yerlar holatini yaxshilash</c:v>
+                </c:pt>
+                <c:pt idx="3">
+                  <c:v>Ihotazor barpo qilish</c:v>
+                </c:pt>
+                <c:pt idx="4">
+                  <c:v>Tuproq shoʻrlanishini kamaytirish</c:v>
+                </c:pt>
+              </c:strCache>
+            </c:strRef>
+          </c:cat>
+          <c:val>
+            <c:numRef>
+              <c:f>Sheet1!$B$2:$B$6</c:f>
+              <c:numCache>
+                <c:formatCode>General</c:formatCode>
+                <c:ptCount val="5"/>
+                <c:pt idx="0">
+                  <c:v>11.1</c:v>
+                </c:pt>
+                <c:pt idx="1">
+                  <c:v>12.9</c:v>
+                </c:pt>
+                <c:pt idx="2">
+                  <c:v>2.7</c:v>
+                </c:pt>
+                <c:pt idx="3">
+                  <c:v>0.9</c:v>
+                </c:pt>
+                <c:pt idx="4">
+                  <c:v>0.3</c:v>
+                </c:pt>
+              </c:numCache>
+            </c:numRef>
+          </c:val>
+        </c:ser>
+        <c:ser>
+          <c:idx val="1"/>
+          <c:order val="1"/>
+          <c:tx>
+            <c:strRef>
+              <c:f>Sheet1!$C$1</c:f>
+              <c:strCache>
+                <c:ptCount val="1"/>
+                <c:pt idx="0">
+                  <c:v>Amalda</c:v>
+                </c:pt>
+              </c:strCache>
+            </c:strRef>
+          </c:tx>
+          <c:spPr>
+            <a:solidFill>
+              <a:srgbClr val="2C6A85"/>
+            </a:solidFill>
+          </c:spPr>
+          <c:cat>
+            <c:strRef>
+              <c:f>Sheet1!$A$2:$A$6</c:f>
+              <c:strCache>
+                <c:ptCount val="5"/>
+                <c:pt idx="0">
+                  <c:v>Gumusi ≤1% yerlar unumdorligini oshirish</c:v>
+                </c:pt>
+                <c:pt idx="1">
+                  <c:v>Oʻrmon mintaqalarini kengaytirish</c:v>
+                </c:pt>
+                <c:pt idx="2">
+                  <c:v>Degradatsiyaga uchragan yerlar holatini yaxshilash</c:v>
+                </c:pt>
+                <c:pt idx="3">
+                  <c:v>Ihotazor barpo qilish</c:v>
+                </c:pt>
+                <c:pt idx="4">
+                  <c:v>Tuproq shoʻrlanishini kamaytirish</c:v>
+                </c:pt>
+              </c:strCache>
+            </c:strRef>
+          </c:cat>
+          <c:val>
+            <c:numRef>
+              <c:f>Sheet1!$C$2:$C$6</c:f>
+              <c:numCache>
+                <c:formatCode>General</c:formatCode>
+                <c:ptCount val="5"/>
+                <c:pt idx="0">
+                  <c:v>11.7</c:v>
+                </c:pt>
+                <c:pt idx="1">
+                  <c:v>13.0</c:v>
+                </c:pt>
+                <c:pt idx="2">
+                  <c:v>2.9</c:v>
+                </c:pt>
+                <c:pt idx="3">
+                  <c:v>0.9</c:v>
+                </c:pt>
+                <c:pt idx="4">
+                  <c:v>0.3</c:v>
+                </c:pt>
+              </c:numCache>
+            </c:numRef>
+          </c:val>
+        </c:ser>
+        <c:gapWidth val="40"/>
+        <c:overlap val="-5"/>
+        <c:axId val="-2068027336"/>
+        <c:axId val="-2113994440"/>
+      </c:barChart>
+      <c:catAx>
+        <c:axId val="-2068027336"/>
+        <c:scaling>
+          <c:orientation val="maxMin"/>
+        </c:scaling>
+        <c:delete val="0"/>
+        <c:axPos val="l"/>
+        <c:majorTickMark val="out"/>
+        <c:minorTickMark val="none"/>
+        <c:tickLblPos val="nextTo"/>
+        <c:spPr>
+          <a:ln>
+            <a:solidFill>
+              <a:srgbClr val="B5B2AD"/>
+            </a:solidFill>
+          </a:ln>
+        </c:spPr>
+        <c:txPr>
+          <a:bodyPr/>
+          <a:lstStyle/>
+          <a:p>
+            <a:pPr>
+              <a:defRPr sz="1200">
+                <a:solidFill>
+                  <a:srgbClr val="4C5852"/>
+                </a:solidFill>
+                <a:latin typeface="Inter"/>
+              </a:defRPr>
+            </a:pPr>
+          </a:p>
+        </c:txPr>
+        <c:crossAx val="-2113994440"/>
+        <c:crosses val="autoZero"/>
+        <c:auto val="1"/>
+        <c:lblAlgn val="ctr"/>
+        <c:lblOffset val="100"/>
+        <c:noMultiLvlLbl val="0"/>
+      </c:catAx>
+      <c:valAx>
+        <c:axId val="-2113994440"/>
+        <c:scaling>
+          <c:max val="15.0"/>
           <c:min val="0.0"/>
         </c:scaling>
         <c:delete val="0"/>
@@ -7302,7 +7818,7 @@
                 <a:ea typeface="Inter" pitchFamily="34" charset="-122"/>
                 <a:cs typeface="Inter" pitchFamily="34" charset="-120"/>
               </a:rPr>
-              <a:t>23 · DISSERTATSIYA TUZILISHI</a:t>
+              <a:t>25 · DISSERTATSIYA TUZILISHI</a:t>
             </a:r>
             <a:endParaRPr lang="en-US" sz="1200" dirty="0"/>
           </a:p>
@@ -8101,7 +8617,7 @@
                 <a:ea typeface="Inter" pitchFamily="34" charset="-122"/>
                 <a:cs typeface="Inter" pitchFamily="34" charset="-120"/>
               </a:rPr>
-              <a:t>24</a:t>
+              <a:t>26</a:t>
             </a:r>
             <a:endParaRPr lang="en-US" sz="1200" dirty="0"/>
           </a:p>
@@ -8177,7 +8693,7 @@
                 <a:ea typeface="Inter" pitchFamily="34" charset="-122"/>
                 <a:cs typeface="Inter" pitchFamily="34" charset="-120"/>
               </a:rPr>
-              <a:t>24 · DISSERTATSIYA TUZILISHI</a:t>
+              <a:t>26 · DISSERTATSIYA TUZILISHI</a:t>
             </a:r>
             <a:endParaRPr lang="en-US" sz="1200" dirty="0"/>
           </a:p>
@@ -9209,7 +9725,7 @@
                 <a:ea typeface="Inter" pitchFamily="34" charset="-122"/>
                 <a:cs typeface="Inter" pitchFamily="34" charset="-120"/>
               </a:rPr>
-              <a:t>25</a:t>
+              <a:t>27</a:t>
             </a:r>
             <a:endParaRPr lang="en-US" sz="1200" dirty="0"/>
           </a:p>
@@ -9285,7 +9801,7 @@
                 <a:ea typeface="Inter" pitchFamily="34" charset="-122"/>
                 <a:cs typeface="Inter" pitchFamily="34" charset="-120"/>
               </a:rPr>
-              <a:t>25 · DISSERTATSIYA TUZILISHI</a:t>
+              <a:t>27 · DISSERTATSIYA TUZILISHI</a:t>
             </a:r>
             <a:endParaRPr lang="en-US" sz="1200" dirty="0"/>
           </a:p>
@@ -10312,7 +10828,7 @@
                 <a:ea typeface="Inter" pitchFamily="34" charset="-122"/>
                 <a:cs typeface="Inter" pitchFamily="34" charset="-120"/>
               </a:rPr>
-              <a:t>26</a:t>
+              <a:t>28</a:t>
             </a:r>
             <a:endParaRPr lang="en-US" sz="1200" dirty="0"/>
           </a:p>
@@ -10388,7 +10904,7 @@
                 <a:ea typeface="Inter" pitchFamily="34" charset="-122"/>
                 <a:cs typeface="Inter" pitchFamily="34" charset="-120"/>
               </a:rPr>
-              <a:t>26 · NATIJALAR VA REJA</a:t>
+              <a:t>28 · NATIJALAR VA REJA</a:t>
             </a:r>
             <a:endParaRPr lang="en-US" sz="1200" dirty="0"/>
           </a:p>
@@ -11126,7 +11642,7 @@
                 <a:ea typeface="Inter" pitchFamily="34" charset="-122"/>
                 <a:cs typeface="Inter" pitchFamily="34" charset="-120"/>
               </a:rPr>
-              <a:t>27</a:t>
+              <a:t>29</a:t>
             </a:r>
             <a:endParaRPr lang="en-US" sz="1200" dirty="0"/>
           </a:p>
@@ -11202,7 +11718,7 @@
                 <a:ea typeface="Inter" pitchFamily="34" charset="-122"/>
                 <a:cs typeface="Inter" pitchFamily="34" charset="-120"/>
               </a:rPr>
-              <a:t>27 · NATIJALAR VA REJA</a:t>
+              <a:t>29 · NATIJALAR VA REJA</a:t>
             </a:r>
             <a:endParaRPr lang="en-US" sz="1200" dirty="0"/>
           </a:p>
@@ -12228,7 +12744,7 @@
                 <a:ea typeface="Inter" pitchFamily="34" charset="-122"/>
                 <a:cs typeface="Inter" pitchFamily="34" charset="-120"/>
               </a:rPr>
-              <a:t>28</a:t>
+              <a:t>30</a:t>
             </a:r>
             <a:endParaRPr lang="en-US" sz="1200" dirty="0"/>
           </a:p>
@@ -12304,7 +12820,7 @@
                 <a:ea typeface="Inter" pitchFamily="34" charset="-122"/>
                 <a:cs typeface="Inter" pitchFamily="34" charset="-120"/>
               </a:rPr>
-              <a:t>28 · NATIJALAR VA REJA</a:t>
+              <a:t>30 · NATIJALAR VA REJA</a:t>
             </a:r>
             <a:endParaRPr lang="en-US" sz="1200" dirty="0"/>
           </a:p>
@@ -12916,7 +13432,7 @@
                 <a:ea typeface="Inter" pitchFamily="34" charset="-122"/>
                 <a:cs typeface="Inter" pitchFamily="34" charset="-120"/>
               </a:rPr>
-              <a:t>29</a:t>
+              <a:t>31</a:t>
             </a:r>
             <a:endParaRPr lang="en-US" sz="1200" dirty="0"/>
           </a:p>
@@ -15501,6 +16017,10 @@
             <a:prstDash val="solid"/>
           </a:ln>
         </p:spPr>
+        <p:txBody>
+          <a:bodyPr/>
+          <a:p/>
+        </p:txBody>
       </p:sp>
       <p:sp>
         <p:nvSpPr>
@@ -15521,6 +16041,10 @@
           </a:solidFill>
           <a:ln/>
         </p:spPr>
+        <p:txBody>
+          <a:bodyPr/>
+          <a:p/>
+        </p:txBody>
       </p:sp>
       <p:sp>
         <p:nvSpPr>
@@ -15636,6 +16160,10 @@
             <a:prstDash val="solid"/>
           </a:ln>
         </p:spPr>
+        <p:txBody>
+          <a:bodyPr/>
+          <a:p/>
+        </p:txBody>
       </p:sp>
       <p:sp>
         <p:nvSpPr>
@@ -15656,6 +16184,10 @@
           </a:solidFill>
           <a:ln/>
         </p:spPr>
+        <p:txBody>
+          <a:bodyPr/>
+          <a:p/>
+        </p:txBody>
       </p:sp>
       <p:sp>
         <p:nvSpPr>
@@ -15771,6 +16303,10 @@
             <a:prstDash val="solid"/>
           </a:ln>
         </p:spPr>
+        <p:txBody>
+          <a:bodyPr/>
+          <a:p/>
+        </p:txBody>
       </p:sp>
       <p:sp>
         <p:nvSpPr>
@@ -15791,6 +16327,10 @@
           </a:solidFill>
           <a:ln/>
         </p:spPr>
+        <p:txBody>
+          <a:bodyPr/>
+          <a:p/>
+        </p:txBody>
       </p:sp>
       <p:sp>
         <p:nvSpPr>
@@ -15889,7 +16429,7 @@
         <p:spPr>
           <a:xfrm>
             <a:off x="812800" y="6238280"/>
-            <a:ext cx="4894362" cy="238720"/>
+            <a:ext cx="9000000" cy="238720"/>
           </a:xfrm>
           <a:prstGeom prst="rect">
             <a:avLst/>
@@ -15918,7 +16458,7 @@
                 <a:ea typeface="Inter" pitchFamily="34" charset="-122"/>
                 <a:cs typeface="Inter" pitchFamily="34" charset="-120"/>
               </a:rPr>
-              <a:t>Normativ asos: [tegishli farmon / qaror raqami va sanasi]</a:t>
+              <a:t>Normativ asos: PQ-5006 (24.02.2021), PF-130 (12.08.2025)</a:t>
             </a:r>
             <a:endParaRPr lang="en-US" sz="1200" dirty="0"/>
           </a:p>
@@ -22637,6 +23177,1208 @@
                 <a:latin typeface="Inter"/>
               </a:rPr>
               <a:t>Manba: tumanlarga suv manbalaridan ajratilayotgan suv sarflari toʻgʻrisida maʼlumot, 10.01.2026</a:t>
+            </a:r>
+          </a:p>
+        </p:txBody>
+      </p:sp>
+    </p:spTree>
+  </p:cSld>
+  <p:clrMapOvr>
+    <a:masterClrMapping/>
+  </p:clrMapOvr>
+</p:sld>
+</file>
+
+<file path=ppt/slides/slide31.xml><?xml version="1.0" encoding="utf-8"?>
+<p:sld xmlns:a="http://schemas.openxmlformats.org/drawingml/2006/main" xmlns:p="http://schemas.openxmlformats.org/presentationml/2006/main" xmlns:r="http://schemas.openxmlformats.org/officeDocument/2006/relationships">
+  <p:cSld>
+    <p:bg>
+      <p:bgPr>
+        <a:solidFill>
+          <a:srgbClr val="F4F1EA"/>
+        </a:solidFill>
+      </p:bgPr>
+    </p:bg>
+    <p:spTree>
+      <p:nvGrpSpPr>
+        <p:cNvPr id="1" name=""/>
+        <p:cNvGrpSpPr/>
+        <p:nvPr/>
+      </p:nvGrpSpPr>
+      <p:grpSpPr/>
+      <p:sp>
+        <p:nvSpPr>
+          <p:cNvPr id="2" name="Text 0"/>
+          <p:cNvSpPr/>
+          <p:nvPr/>
+        </p:nvSpPr>
+        <p:spPr>
+          <a:xfrm>
+            <a:off x="812800" y="812800"/>
+            <a:ext cx="10883392" cy="238720"/>
+          </a:xfrm>
+          <a:prstGeom prst="rect">
+            <a:avLst/>
+          </a:prstGeom>
+          <a:noFill/>
+          <a:ln/>
+        </p:spPr>
+        <p:txBody>
+          <a:bodyPr wrap="square" lIns="0" tIns="0" rIns="0" bIns="0" rtlCol="0" anchor="t">
+            <a:normAutofit/>
+          </a:bodyPr>
+          <a:lstStyle/>
+          <a:p>
+            <a:pPr algn="l" indent="0" marL="0">
+              <a:lnSpc>
+                <a:spcPts val="1680"/>
+              </a:lnSpc>
+              <a:buNone/>
+            </a:pPr>
+            <a:r>
+              <a:rPr lang="en-US" sz="1200" b="1" spc="150" kern="0" dirty="0">
+                <a:solidFill>
+                  <a:srgbClr val="2C6A85"/>
+                </a:solidFill>
+                <a:latin typeface="Inter" pitchFamily="34" charset="0"/>
+                <a:ea typeface="Inter" pitchFamily="34" charset="-122"/>
+                <a:cs typeface="Inter" pitchFamily="34" charset="-120"/>
+              </a:rPr>
+              <a:t>23 · DASTLABKI MAʼLUMOTLAR</a:t>
+            </a:r>
+            <a:endParaRPr lang="en-US" sz="1200" dirty="0"/>
+          </a:p>
+        </p:txBody>
+      </p:sp>
+      <p:sp>
+        <p:nvSpPr>
+          <p:cNvPr id="3" name="Text 1"/>
+          <p:cNvSpPr/>
+          <p:nvPr>
+            <p:ph type="title"/>
+          </p:nvPr>
+        </p:nvSpPr>
+        <p:spPr>
+          <a:xfrm>
+            <a:off x="812800" y="1127720"/>
+            <a:ext cx="10883392" cy="472430"/>
+          </a:xfrm>
+          <a:prstGeom prst="rect">
+            <a:avLst/>
+          </a:prstGeom>
+          <a:noFill/>
+          <a:ln/>
+        </p:spPr>
+        <p:txBody>
+          <a:bodyPr wrap="square" lIns="0" tIns="0" rIns="0" bIns="0" rtlCol="0" anchor="t">
+            <a:normAutofit/>
+          </a:bodyPr>
+          <a:lstStyle/>
+          <a:p>
+            <a:pPr algn="l" indent="0" marL="0">
+              <a:lnSpc>
+                <a:spcPts val="3520"/>
+              </a:lnSpc>
+              <a:buNone/>
+            </a:pPr>
+            <a:r>
+              <a:rPr lang="en-US" sz="3200" b="0" i="0" dirty="0">
+                <a:solidFill>
+                  <a:srgbClr val="1D2A24"/>
+                </a:solidFill>
+                <a:latin typeface="Source Serif 4" pitchFamily="18" charset="0"/>
+                <a:ea typeface="Source Serif 4" pitchFamily="18" charset="-122"/>
+                <a:cs typeface="Source Serif 4" pitchFamily="18" charset="-120"/>
+              </a:rPr>
+              <a:t>Namangan viloyati: ekin joylashtirish</a:t>
+            </a:r>
+            <a:endParaRPr lang="en-US" sz="3200" dirty="0"/>
+          </a:p>
+        </p:txBody>
+      </p:sp>
+      <p:sp>
+        <p:nvSpPr>
+          <p:cNvPr id="6" name="Text 3"/>
+          <p:cNvSpPr/>
+          <p:nvPr/>
+        </p:nvSpPr>
+        <p:spPr>
+          <a:xfrm>
+            <a:off x="11137950" y="6238280"/>
+            <a:ext cx="241250" cy="238720"/>
+          </a:xfrm>
+          <a:prstGeom prst="rect">
+            <a:avLst/>
+          </a:prstGeom>
+          <a:noFill/>
+          <a:ln/>
+        </p:spPr>
+        <p:txBody>
+          <a:bodyPr wrap="square" lIns="0" tIns="0" rIns="0" bIns="0" rtlCol="0" anchor="t">
+            <a:normAutofit/>
+          </a:bodyPr>
+          <a:lstStyle/>
+          <a:p>
+            <a:pPr algn="r" indent="0" marL="0">
+              <a:lnSpc>
+                <a:spcPts val="1680"/>
+              </a:lnSpc>
+              <a:buNone/>
+            </a:pPr>
+            <a:r>
+              <a:rPr lang="en-US" sz="1200" dirty="0">
+                <a:solidFill>
+                  <a:srgbClr val="5F6B64"/>
+                </a:solidFill>
+                <a:latin typeface="Inter" pitchFamily="34" charset="0"/>
+                <a:ea typeface="Inter" pitchFamily="34" charset="-122"/>
+                <a:cs typeface="Inter" pitchFamily="34" charset="-120"/>
+              </a:rPr>
+              <a:t>24</a:t>
+            </a:r>
+            <a:endParaRPr lang="en-US" sz="1200" dirty="0"/>
+          </a:p>
+        </p:txBody>
+      </p:sp>
+      <p:sp>
+        <p:nvSpPr>
+          <p:cNvPr id="7" name="TextBox 6"/>
+          <p:cNvSpPr txBox="1"/>
+          <p:nvPr/>
+        </p:nvSpPr>
+        <p:spPr>
+          <a:xfrm>
+            <a:off x="812800" y="1830000"/>
+            <a:ext cx="6200000" cy="260000"/>
+          </a:xfrm>
+          <a:prstGeom prst="rect">
+            <a:avLst/>
+          </a:prstGeom>
+          <a:noFill/>
+        </p:spPr>
+        <p:txBody>
+          <a:bodyPr wrap="square" lIns="0" rIns="0" tIns="0" bIns="0" anchor="t">
+            <a:spAutoFit/>
+          </a:bodyPr>
+          <a:lstStyle/>
+          <a:p>
+            <a:pPr algn="l"/>
+            <a:r>
+              <a:rPr sz="1300" b="1">
+                <a:solidFill>
+                  <a:srgbClr val="2C6A85"/>
+                </a:solidFill>
+                <a:latin typeface="Inter"/>
+              </a:rPr>
+              <a:t>Gʻoʻza va bugʻdoy maydoni, ming ga (Namangan viloyati)</a:t>
+            </a:r>
+          </a:p>
+        </p:txBody>
+      </p:sp>
+      <p:graphicFrame>
+        <p:nvGraphicFramePr>
+          <p:cNvPr id="8" name="Chart 7"/>
+          <p:cNvGraphicFramePr>
+            <a:graphicFrameLocks noGrp="1"/>
+          </p:cNvGraphicFramePr>
+          <p:nvPr/>
+        </p:nvGraphicFramePr>
+        <p:xfrm>
+          <a:off x="752800" y="2080000"/>
+          <a:ext cx="6600000" cy="4000000"/>
+        </p:xfrm>
+        <a:graphic>
+          <a:graphicData uri="http://schemas.openxmlformats.org/drawingml/2006/chart">
+            <c:chart xmlns:c="http://schemas.openxmlformats.org/drawingml/2006/chart" r:id="rId2"/>
+          </a:graphicData>
+        </a:graphic>
+      </p:graphicFrame>
+      <p:sp>
+        <p:nvSpPr>
+          <p:cNvPr id="9" name="Rounded Rectangle 8"/>
+          <p:cNvSpPr/>
+          <p:nvPr/>
+        </p:nvSpPr>
+        <p:spPr>
+          <a:xfrm>
+            <a:off x="7700000" y="1830000"/>
+            <a:ext cx="3996192" cy="1230000"/>
+          </a:xfrm>
+          <a:prstGeom prst="roundRect">
+            <a:avLst>
+              <a:gd name="adj" fmla="val 5000"/>
+            </a:avLst>
+          </a:prstGeom>
+          <a:solidFill>
+            <a:srgbClr val="FBF9F4"/>
+          </a:solidFill>
+          <a:ln w="6350">
+            <a:solidFill>
+              <a:srgbClr val="D9D2C3"/>
+            </a:solidFill>
+          </a:ln>
+          <a:effectLst/>
+        </p:spPr>
+        <p:style>
+          <a:lnRef idx="1">
+            <a:schemeClr val="accent1"/>
+          </a:lnRef>
+          <a:fillRef idx="3">
+            <a:schemeClr val="accent1"/>
+          </a:fillRef>
+          <a:effectRef idx="2">
+            <a:schemeClr val="accent1"/>
+          </a:effectRef>
+          <a:fontRef idx="minor">
+            <a:schemeClr val="lt1"/>
+          </a:fontRef>
+        </p:style>
+        <p:txBody>
+          <a:bodyPr rtlCol="0" anchor="ctr"/>
+          <a:lstStyle/>
+          <a:p>
+            <a:pPr algn="ctr"/>
+          </a:p>
+        </p:txBody>
+      </p:sp>
+      <p:sp>
+        <p:nvSpPr>
+          <p:cNvPr id="10" name="TextBox 9"/>
+          <p:cNvSpPr txBox="1"/>
+          <p:nvPr/>
+        </p:nvSpPr>
+        <p:spPr>
+          <a:xfrm>
+            <a:off x="7930000" y="1950000"/>
+            <a:ext cx="3536192" cy="420000"/>
+          </a:xfrm>
+          <a:prstGeom prst="rect">
+            <a:avLst/>
+          </a:prstGeom>
+          <a:noFill/>
+        </p:spPr>
+        <p:txBody>
+          <a:bodyPr wrap="square" lIns="0" rIns="0" tIns="0" bIns="0" anchor="t">
+            <a:spAutoFit/>
+          </a:bodyPr>
+          <a:lstStyle/>
+          <a:p>
+            <a:pPr algn="l"/>
+            <a:r>
+              <a:rPr sz="2400" b="0">
+                <a:solidFill>
+                  <a:srgbClr val="A4521D"/>
+                </a:solidFill>
+                <a:latin typeface="Source Serif 4"/>
+              </a:rPr>
+              <a:t>−20%</a:t>
+            </a:r>
+          </a:p>
+        </p:txBody>
+      </p:sp>
+      <p:sp>
+        <p:nvSpPr>
+          <p:cNvPr id="11" name="TextBox 10"/>
+          <p:cNvSpPr txBox="1"/>
+          <p:nvPr/>
+        </p:nvSpPr>
+        <p:spPr>
+          <a:xfrm>
+            <a:off x="7930000" y="2390000"/>
+            <a:ext cx="3536192" cy="620000"/>
+          </a:xfrm>
+          <a:prstGeom prst="rect">
+            <a:avLst/>
+          </a:prstGeom>
+          <a:noFill/>
+        </p:spPr>
+        <p:txBody>
+          <a:bodyPr wrap="square" lIns="0" rIns="0" tIns="0" bIns="0" anchor="t">
+            <a:spAutoFit/>
+          </a:bodyPr>
+          <a:lstStyle/>
+          <a:p>
+            <a:pPr algn="l"/>
+            <a:r>
+              <a:rPr sz="1200" b="0">
+                <a:solidFill>
+                  <a:srgbClr val="4C5852"/>
+                </a:solidFill>
+                <a:latin typeface="Inter"/>
+              </a:rPr>
+              <a:t>Gʻoʻza maydoni 61,0 dan 48,9 ming gaga kamaygan (2024 → 2025); 2026 yil rejasida ham 48,9 ming ga</a:t>
+            </a:r>
+          </a:p>
+        </p:txBody>
+      </p:sp>
+      <p:sp>
+        <p:nvSpPr>
+          <p:cNvPr id="12" name="Rounded Rectangle 11"/>
+          <p:cNvSpPr/>
+          <p:nvPr/>
+        </p:nvSpPr>
+        <p:spPr>
+          <a:xfrm>
+            <a:off x="7700000" y="3210000"/>
+            <a:ext cx="3996192" cy="1230000"/>
+          </a:xfrm>
+          <a:prstGeom prst="roundRect">
+            <a:avLst>
+              <a:gd name="adj" fmla="val 5000"/>
+            </a:avLst>
+          </a:prstGeom>
+          <a:solidFill>
+            <a:srgbClr val="FBF9F4"/>
+          </a:solidFill>
+          <a:ln w="6350">
+            <a:solidFill>
+              <a:srgbClr val="D9D2C3"/>
+            </a:solidFill>
+          </a:ln>
+          <a:effectLst/>
+        </p:spPr>
+        <p:style>
+          <a:lnRef idx="1">
+            <a:schemeClr val="accent1"/>
+          </a:lnRef>
+          <a:fillRef idx="3">
+            <a:schemeClr val="accent1"/>
+          </a:fillRef>
+          <a:effectRef idx="2">
+            <a:schemeClr val="accent1"/>
+          </a:effectRef>
+          <a:fontRef idx="minor">
+            <a:schemeClr val="lt1"/>
+          </a:fontRef>
+        </p:style>
+        <p:txBody>
+          <a:bodyPr rtlCol="0" anchor="ctr"/>
+          <a:lstStyle/>
+          <a:p>
+            <a:pPr algn="ctr"/>
+          </a:p>
+        </p:txBody>
+      </p:sp>
+      <p:sp>
+        <p:nvSpPr>
+          <p:cNvPr id="13" name="TextBox 12"/>
+          <p:cNvSpPr txBox="1"/>
+          <p:nvPr/>
+        </p:nvSpPr>
+        <p:spPr>
+          <a:xfrm>
+            <a:off x="7930000" y="3330000"/>
+            <a:ext cx="3536192" cy="420000"/>
+          </a:xfrm>
+          <a:prstGeom prst="rect">
+            <a:avLst/>
+          </a:prstGeom>
+          <a:noFill/>
+        </p:spPr>
+        <p:txBody>
+          <a:bodyPr wrap="square" lIns="0" rIns="0" tIns="0" bIns="0" anchor="t">
+            <a:spAutoFit/>
+          </a:bodyPr>
+          <a:lstStyle/>
+          <a:p>
+            <a:pPr algn="l"/>
+            <a:r>
+              <a:rPr sz="2400" b="0">
+                <a:solidFill>
+                  <a:srgbClr val="2C6A85"/>
+                </a:solidFill>
+                <a:latin typeface="Source Serif 4"/>
+              </a:rPr>
+              <a:t>182,7 ming ga</a:t>
+            </a:r>
+          </a:p>
+        </p:txBody>
+      </p:sp>
+      <p:sp>
+        <p:nvSpPr>
+          <p:cNvPr id="14" name="TextBox 13"/>
+          <p:cNvSpPr txBox="1"/>
+          <p:nvPr/>
+        </p:nvSpPr>
+        <p:spPr>
+          <a:xfrm>
+            <a:off x="7930000" y="3770000"/>
+            <a:ext cx="3536192" cy="620000"/>
+          </a:xfrm>
+          <a:prstGeom prst="rect">
+            <a:avLst/>
+          </a:prstGeom>
+          <a:noFill/>
+        </p:spPr>
+        <p:txBody>
+          <a:bodyPr wrap="square" lIns="0" rIns="0" tIns="0" bIns="0" anchor="t">
+            <a:spAutoFit/>
+          </a:bodyPr>
+          <a:lstStyle/>
+          <a:p>
+            <a:pPr algn="l"/>
+            <a:r>
+              <a:rPr sz="1200" b="0">
+                <a:solidFill>
+                  <a:srgbClr val="4C5852"/>
+                </a:solidFill>
+                <a:latin typeface="Inter"/>
+              </a:rPr>
+              <a:t>2026 yil jami ekin joylashtirish (2025 yilda 196,7 ming ga, −7%); asosiy kamayish Pop tumanida: 37,6 → 27,9 ming ga</a:t>
+            </a:r>
+          </a:p>
+        </p:txBody>
+      </p:sp>
+      <p:sp>
+        <p:nvSpPr>
+          <p:cNvPr id="15" name="Rounded Rectangle 14"/>
+          <p:cNvSpPr/>
+          <p:nvPr/>
+        </p:nvSpPr>
+        <p:spPr>
+          <a:xfrm>
+            <a:off x="7700000" y="4590000"/>
+            <a:ext cx="3996192" cy="1230000"/>
+          </a:xfrm>
+          <a:prstGeom prst="roundRect">
+            <a:avLst>
+              <a:gd name="adj" fmla="val 5000"/>
+            </a:avLst>
+          </a:prstGeom>
+          <a:solidFill>
+            <a:srgbClr val="FBF9F4"/>
+          </a:solidFill>
+          <a:ln w="6350">
+            <a:solidFill>
+              <a:srgbClr val="D9D2C3"/>
+            </a:solidFill>
+          </a:ln>
+          <a:effectLst/>
+        </p:spPr>
+        <p:style>
+          <a:lnRef idx="1">
+            <a:schemeClr val="accent1"/>
+          </a:lnRef>
+          <a:fillRef idx="3">
+            <a:schemeClr val="accent1"/>
+          </a:fillRef>
+          <a:effectRef idx="2">
+            <a:schemeClr val="accent1"/>
+          </a:effectRef>
+          <a:fontRef idx="minor">
+            <a:schemeClr val="lt1"/>
+          </a:fontRef>
+        </p:style>
+        <p:txBody>
+          <a:bodyPr rtlCol="0" anchor="ctr"/>
+          <a:lstStyle/>
+          <a:p>
+            <a:pPr algn="ctr"/>
+          </a:p>
+        </p:txBody>
+      </p:sp>
+      <p:sp>
+        <p:nvSpPr>
+          <p:cNvPr id="16" name="TextBox 15"/>
+          <p:cNvSpPr txBox="1"/>
+          <p:nvPr/>
+        </p:nvSpPr>
+        <p:spPr>
+          <a:xfrm>
+            <a:off x="7930000" y="4710000"/>
+            <a:ext cx="3536192" cy="420000"/>
+          </a:xfrm>
+          <a:prstGeom prst="rect">
+            <a:avLst/>
+          </a:prstGeom>
+          <a:noFill/>
+        </p:spPr>
+        <p:txBody>
+          <a:bodyPr wrap="square" lIns="0" rIns="0" tIns="0" bIns="0" anchor="t">
+            <a:spAutoFit/>
+          </a:bodyPr>
+          <a:lstStyle/>
+          <a:p>
+            <a:pPr algn="l"/>
+            <a:r>
+              <a:rPr sz="2000" b="0">
+                <a:solidFill>
+                  <a:srgbClr val="A4521D"/>
+                </a:solidFill>
+                <a:latin typeface="Source Serif 4"/>
+              </a:rPr>
+              <a:t>Pop va Mingbuloq</a:t>
+            </a:r>
+          </a:p>
+        </p:txBody>
+      </p:sp>
+      <p:sp>
+        <p:nvSpPr>
+          <p:cNvPr id="17" name="TextBox 16"/>
+          <p:cNvSpPr txBox="1"/>
+          <p:nvPr/>
+        </p:nvSpPr>
+        <p:spPr>
+          <a:xfrm>
+            <a:off x="7930000" y="5150000"/>
+            <a:ext cx="3536192" cy="620000"/>
+          </a:xfrm>
+          <a:prstGeom prst="rect">
+            <a:avLst/>
+          </a:prstGeom>
+          <a:noFill/>
+        </p:spPr>
+        <p:txBody>
+          <a:bodyPr wrap="square" lIns="0" rIns="0" tIns="0" bIns="0" anchor="t">
+            <a:spAutoFit/>
+          </a:bodyPr>
+          <a:lstStyle/>
+          <a:p>
+            <a:pPr algn="l"/>
+            <a:r>
+              <a:rPr sz="1200" b="0">
+                <a:solidFill>
+                  <a:srgbClr val="4C5852"/>
+                </a:solidFill>
+                <a:latin typeface="Inter"/>
+              </a:rPr>
+              <a:t>Gʻoʻzaning eng katta maydonlari: 2025 yilda Mingbuloq 10,7 va Pop 6,3 ming ga</a:t>
+            </a:r>
+          </a:p>
+        </p:txBody>
+      </p:sp>
+      <p:sp>
+        <p:nvSpPr>
+          <p:cNvPr id="18" name="TextBox 17"/>
+          <p:cNvSpPr txBox="1"/>
+          <p:nvPr/>
+        </p:nvSpPr>
+        <p:spPr>
+          <a:xfrm>
+            <a:off x="812800" y="6238280"/>
+            <a:ext cx="9800000" cy="240000"/>
+          </a:xfrm>
+          <a:prstGeom prst="rect">
+            <a:avLst/>
+          </a:prstGeom>
+          <a:noFill/>
+        </p:spPr>
+        <p:txBody>
+          <a:bodyPr wrap="square" lIns="0" rIns="0" tIns="0" bIns="0" anchor="t">
+            <a:spAutoFit/>
+          </a:bodyPr>
+          <a:lstStyle/>
+          <a:p>
+            <a:pPr algn="l"/>
+            <a:r>
+              <a:rPr sz="1200" b="0">
+                <a:solidFill>
+                  <a:srgbClr val="5F6B64"/>
+                </a:solidFill>
+                <a:latin typeface="Inter"/>
+              </a:rPr>
+              <a:t>Manba: Namangan viloyati 2024, 2025 va 2026 yil hosili uchun ekin joylashtirish rejalari</a:t>
+            </a:r>
+          </a:p>
+        </p:txBody>
+      </p:sp>
+    </p:spTree>
+  </p:cSld>
+  <p:clrMapOvr>
+    <a:masterClrMapping/>
+  </p:clrMapOvr>
+</p:sld>
+</file>
+
+<file path=ppt/slides/slide32.xml><?xml version="1.0" encoding="utf-8"?>
+<p:sld xmlns:a="http://schemas.openxmlformats.org/drawingml/2006/main" xmlns:p="http://schemas.openxmlformats.org/presentationml/2006/main" xmlns:r="http://schemas.openxmlformats.org/officeDocument/2006/relationships">
+  <p:cSld>
+    <p:bg>
+      <p:bgPr>
+        <a:solidFill>
+          <a:srgbClr val="F4F1EA"/>
+        </a:solidFill>
+      </p:bgPr>
+    </p:bg>
+    <p:spTree>
+      <p:nvGrpSpPr>
+        <p:cNvPr id="1" name=""/>
+        <p:cNvGrpSpPr/>
+        <p:nvPr/>
+      </p:nvGrpSpPr>
+      <p:grpSpPr/>
+      <p:sp>
+        <p:nvSpPr>
+          <p:cNvPr id="2" name="Text 0"/>
+          <p:cNvSpPr/>
+          <p:nvPr/>
+        </p:nvSpPr>
+        <p:spPr>
+          <a:xfrm>
+            <a:off x="812800" y="812800"/>
+            <a:ext cx="10883392" cy="238720"/>
+          </a:xfrm>
+          <a:prstGeom prst="rect">
+            <a:avLst/>
+          </a:prstGeom>
+          <a:noFill/>
+          <a:ln/>
+        </p:spPr>
+        <p:txBody>
+          <a:bodyPr wrap="square" lIns="0" tIns="0" rIns="0" bIns="0" rtlCol="0" anchor="t">
+            <a:normAutofit/>
+          </a:bodyPr>
+          <a:lstStyle/>
+          <a:p>
+            <a:pPr algn="l" indent="0" marL="0">
+              <a:lnSpc>
+                <a:spcPts val="1680"/>
+              </a:lnSpc>
+              <a:buNone/>
+            </a:pPr>
+            <a:r>
+              <a:rPr lang="en-US" sz="1200" b="1" spc="150" kern="0" dirty="0">
+                <a:solidFill>
+                  <a:srgbClr val="2C6A85"/>
+                </a:solidFill>
+                <a:latin typeface="Inter" pitchFamily="34" charset="0"/>
+                <a:ea typeface="Inter" pitchFamily="34" charset="-122"/>
+                <a:cs typeface="Inter" pitchFamily="34" charset="-120"/>
+              </a:rPr>
+              <a:t>24 · DASTLABKI MAʼLUMOTLAR</a:t>
+            </a:r>
+            <a:endParaRPr lang="en-US" sz="1200" dirty="0"/>
+          </a:p>
+        </p:txBody>
+      </p:sp>
+      <p:sp>
+        <p:nvSpPr>
+          <p:cNvPr id="3" name="Text 1"/>
+          <p:cNvSpPr/>
+          <p:nvPr>
+            <p:ph type="title"/>
+          </p:nvPr>
+        </p:nvSpPr>
+        <p:spPr>
+          <a:xfrm>
+            <a:off x="812800" y="1127720"/>
+            <a:ext cx="10883392" cy="472430"/>
+          </a:xfrm>
+          <a:prstGeom prst="rect">
+            <a:avLst/>
+          </a:prstGeom>
+          <a:noFill/>
+          <a:ln/>
+        </p:spPr>
+        <p:txBody>
+          <a:bodyPr wrap="square" lIns="0" tIns="0" rIns="0" bIns="0" rtlCol="0" anchor="t">
+            <a:normAutofit/>
+          </a:bodyPr>
+          <a:lstStyle/>
+          <a:p>
+            <a:pPr algn="l" indent="0" marL="0">
+              <a:lnSpc>
+                <a:spcPts val="3520"/>
+              </a:lnSpc>
+              <a:buNone/>
+            </a:pPr>
+            <a:r>
+              <a:rPr lang="en-US" sz="3200" b="0" i="0" dirty="0">
+                <a:solidFill>
+                  <a:srgbClr val="1D2A24"/>
+                </a:solidFill>
+                <a:latin typeface="Source Serif 4" pitchFamily="18" charset="0"/>
+                <a:ea typeface="Source Serif 4" pitchFamily="18" charset="-122"/>
+                <a:cs typeface="Source Serif 4" pitchFamily="18" charset="-120"/>
+              </a:rPr>
+              <a:t>Namangan viloyati: yer degradatsiyasi</a:t>
+            </a:r>
+            <a:endParaRPr lang="en-US" sz="3200" dirty="0"/>
+          </a:p>
+        </p:txBody>
+      </p:sp>
+      <p:sp>
+        <p:nvSpPr>
+          <p:cNvPr id="6" name="Text 3"/>
+          <p:cNvSpPr/>
+          <p:nvPr/>
+        </p:nvSpPr>
+        <p:spPr>
+          <a:xfrm>
+            <a:off x="11137950" y="6238280"/>
+            <a:ext cx="241250" cy="238720"/>
+          </a:xfrm>
+          <a:prstGeom prst="rect">
+            <a:avLst/>
+          </a:prstGeom>
+          <a:noFill/>
+          <a:ln/>
+        </p:spPr>
+        <p:txBody>
+          <a:bodyPr wrap="square" lIns="0" tIns="0" rIns="0" bIns="0" rtlCol="0" anchor="t">
+            <a:normAutofit/>
+          </a:bodyPr>
+          <a:lstStyle/>
+          <a:p>
+            <a:pPr algn="r" indent="0" marL="0">
+              <a:lnSpc>
+                <a:spcPts val="1680"/>
+              </a:lnSpc>
+              <a:buNone/>
+            </a:pPr>
+            <a:r>
+              <a:rPr lang="en-US" sz="1200" dirty="0">
+                <a:solidFill>
+                  <a:srgbClr val="5F6B64"/>
+                </a:solidFill>
+                <a:latin typeface="Inter" pitchFamily="34" charset="0"/>
+                <a:ea typeface="Inter" pitchFamily="34" charset="-122"/>
+                <a:cs typeface="Inter" pitchFamily="34" charset="-120"/>
+              </a:rPr>
+              <a:t>25</a:t>
+            </a:r>
+            <a:endParaRPr lang="en-US" sz="1200" dirty="0"/>
+          </a:p>
+        </p:txBody>
+      </p:sp>
+      <p:sp>
+        <p:nvSpPr>
+          <p:cNvPr id="7" name="TextBox 6"/>
+          <p:cNvSpPr txBox="1"/>
+          <p:nvPr/>
+        </p:nvSpPr>
+        <p:spPr>
+          <a:xfrm>
+            <a:off x="812800" y="1830000"/>
+            <a:ext cx="6200000" cy="260000"/>
+          </a:xfrm>
+          <a:prstGeom prst="rect">
+            <a:avLst/>
+          </a:prstGeom>
+          <a:noFill/>
+        </p:spPr>
+        <p:txBody>
+          <a:bodyPr wrap="square" lIns="0" rIns="0" tIns="0" bIns="0" anchor="t">
+            <a:spAutoFit/>
+          </a:bodyPr>
+          <a:lstStyle/>
+          <a:p>
+            <a:pPr algn="l"/>
+            <a:r>
+              <a:rPr sz="1300" b="1">
+                <a:solidFill>
+                  <a:srgbClr val="2C6A85"/>
+                </a:solidFill>
+                <a:latin typeface="Inter"/>
+              </a:rPr>
+              <a:t>Degradatsiyani kamaytirish tadbirlari, ming ga (2025): reja va amalda</a:t>
+            </a:r>
+          </a:p>
+        </p:txBody>
+      </p:sp>
+      <p:graphicFrame>
+        <p:nvGraphicFramePr>
+          <p:cNvPr id="8" name="Chart 7"/>
+          <p:cNvGraphicFramePr>
+            <a:graphicFrameLocks noGrp="1"/>
+          </p:cNvGraphicFramePr>
+          <p:nvPr/>
+        </p:nvGraphicFramePr>
+        <p:xfrm>
+          <a:off x="752800" y="2080000"/>
+          <a:ext cx="6600000" cy="4000000"/>
+        </p:xfrm>
+        <a:graphic>
+          <a:graphicData uri="http://schemas.openxmlformats.org/drawingml/2006/chart">
+            <c:chart xmlns:c="http://schemas.openxmlformats.org/drawingml/2006/chart" r:id="rId2"/>
+          </a:graphicData>
+        </a:graphic>
+      </p:graphicFrame>
+      <p:sp>
+        <p:nvSpPr>
+          <p:cNvPr id="9" name="Rounded Rectangle 8"/>
+          <p:cNvSpPr/>
+          <p:nvPr/>
+        </p:nvSpPr>
+        <p:spPr>
+          <a:xfrm>
+            <a:off x="7700000" y="1830000"/>
+            <a:ext cx="3996192" cy="1230000"/>
+          </a:xfrm>
+          <a:prstGeom prst="roundRect">
+            <a:avLst>
+              <a:gd name="adj" fmla="val 5000"/>
+            </a:avLst>
+          </a:prstGeom>
+          <a:solidFill>
+            <a:srgbClr val="FBF9F4"/>
+          </a:solidFill>
+          <a:ln w="6350">
+            <a:solidFill>
+              <a:srgbClr val="D9D2C3"/>
+            </a:solidFill>
+          </a:ln>
+          <a:effectLst/>
+        </p:spPr>
+        <p:style>
+          <a:lnRef idx="1">
+            <a:schemeClr val="accent1"/>
+          </a:lnRef>
+          <a:fillRef idx="3">
+            <a:schemeClr val="accent1"/>
+          </a:fillRef>
+          <a:effectRef idx="2">
+            <a:schemeClr val="accent1"/>
+          </a:effectRef>
+          <a:fontRef idx="minor">
+            <a:schemeClr val="lt1"/>
+          </a:fontRef>
+        </p:style>
+        <p:txBody>
+          <a:bodyPr rtlCol="0" anchor="ctr"/>
+          <a:lstStyle/>
+          <a:p>
+            <a:pPr algn="ctr"/>
+          </a:p>
+        </p:txBody>
+      </p:sp>
+      <p:sp>
+        <p:nvSpPr>
+          <p:cNvPr id="10" name="TextBox 9"/>
+          <p:cNvSpPr txBox="1"/>
+          <p:nvPr/>
+        </p:nvSpPr>
+        <p:spPr>
+          <a:xfrm>
+            <a:off x="7930000" y="1950000"/>
+            <a:ext cx="3536192" cy="420000"/>
+          </a:xfrm>
+          <a:prstGeom prst="rect">
+            <a:avLst/>
+          </a:prstGeom>
+          <a:noFill/>
+        </p:spPr>
+        <p:txBody>
+          <a:bodyPr wrap="square" lIns="0" rIns="0" tIns="0" bIns="0" anchor="t">
+            <a:spAutoFit/>
+          </a:bodyPr>
+          <a:lstStyle/>
+          <a:p>
+            <a:pPr algn="l"/>
+            <a:r>
+              <a:rPr sz="2400" b="0">
+                <a:solidFill>
+                  <a:srgbClr val="A4521D"/>
+                </a:solidFill>
+                <a:latin typeface="Source Serif 4"/>
+              </a:rPr>
+              <a:t>11,7 ming ga</a:t>
+            </a:r>
+          </a:p>
+        </p:txBody>
+      </p:sp>
+      <p:sp>
+        <p:nvSpPr>
+          <p:cNvPr id="11" name="TextBox 10"/>
+          <p:cNvSpPr txBox="1"/>
+          <p:nvPr/>
+        </p:nvSpPr>
+        <p:spPr>
+          <a:xfrm>
+            <a:off x="7930000" y="2390000"/>
+            <a:ext cx="3536192" cy="620000"/>
+          </a:xfrm>
+          <a:prstGeom prst="rect">
+            <a:avLst/>
+          </a:prstGeom>
+          <a:noFill/>
+        </p:spPr>
+        <p:txBody>
+          <a:bodyPr wrap="square" lIns="0" rIns="0" tIns="0" bIns="0" anchor="t">
+            <a:spAutoFit/>
+          </a:bodyPr>
+          <a:lstStyle/>
+          <a:p>
+            <a:pPr algn="l"/>
+            <a:r>
+              <a:rPr sz="1200" b="0">
+                <a:solidFill>
+                  <a:srgbClr val="4C5852"/>
+                </a:solidFill>
+                <a:latin typeface="Inter"/>
+              </a:rPr>
+              <a:t>Gumus miqdori 1% gacha boʻlgan tuproqlarda unumdorlik oshirilgan (105,8%); asosan Pop (6,7) va Mingbuloq (1,8)</a:t>
+            </a:r>
+          </a:p>
+        </p:txBody>
+      </p:sp>
+      <p:sp>
+        <p:nvSpPr>
+          <p:cNvPr id="12" name="Rounded Rectangle 11"/>
+          <p:cNvSpPr/>
+          <p:nvPr/>
+        </p:nvSpPr>
+        <p:spPr>
+          <a:xfrm>
+            <a:off x="7700000" y="3210000"/>
+            <a:ext cx="3996192" cy="1230000"/>
+          </a:xfrm>
+          <a:prstGeom prst="roundRect">
+            <a:avLst>
+              <a:gd name="adj" fmla="val 5000"/>
+            </a:avLst>
+          </a:prstGeom>
+          <a:solidFill>
+            <a:srgbClr val="FBF9F4"/>
+          </a:solidFill>
+          <a:ln w="6350">
+            <a:solidFill>
+              <a:srgbClr val="D9D2C3"/>
+            </a:solidFill>
+          </a:ln>
+          <a:effectLst/>
+        </p:spPr>
+        <p:style>
+          <a:lnRef idx="1">
+            <a:schemeClr val="accent1"/>
+          </a:lnRef>
+          <a:fillRef idx="3">
+            <a:schemeClr val="accent1"/>
+          </a:fillRef>
+          <a:effectRef idx="2">
+            <a:schemeClr val="accent1"/>
+          </a:effectRef>
+          <a:fontRef idx="minor">
+            <a:schemeClr val="lt1"/>
+          </a:fontRef>
+        </p:style>
+        <p:txBody>
+          <a:bodyPr rtlCol="0" anchor="ctr"/>
+          <a:lstStyle/>
+          <a:p>
+            <a:pPr algn="ctr"/>
+          </a:p>
+        </p:txBody>
+      </p:sp>
+      <p:sp>
+        <p:nvSpPr>
+          <p:cNvPr id="13" name="TextBox 12"/>
+          <p:cNvSpPr txBox="1"/>
+          <p:nvPr/>
+        </p:nvSpPr>
+        <p:spPr>
+          <a:xfrm>
+            <a:off x="7930000" y="3330000"/>
+            <a:ext cx="3536192" cy="420000"/>
+          </a:xfrm>
+          <a:prstGeom prst="rect">
+            <a:avLst/>
+          </a:prstGeom>
+          <a:noFill/>
+        </p:spPr>
+        <p:txBody>
+          <a:bodyPr wrap="square" lIns="0" rIns="0" tIns="0" bIns="0" anchor="t">
+            <a:spAutoFit/>
+          </a:bodyPr>
+          <a:lstStyle/>
+          <a:p>
+            <a:pPr algn="l"/>
+            <a:r>
+              <a:rPr sz="2400" b="0">
+                <a:solidFill>
+                  <a:srgbClr val="2C6A85"/>
+                </a:solidFill>
+                <a:latin typeface="Source Serif 4"/>
+              </a:rPr>
+              <a:t>0,3 ming ga</a:t>
+            </a:r>
+          </a:p>
+        </p:txBody>
+      </p:sp>
+      <p:sp>
+        <p:nvSpPr>
+          <p:cNvPr id="14" name="TextBox 13"/>
+          <p:cNvSpPr txBox="1"/>
+          <p:nvPr/>
+        </p:nvSpPr>
+        <p:spPr>
+          <a:xfrm>
+            <a:off x="7930000" y="3770000"/>
+            <a:ext cx="3536192" cy="620000"/>
+          </a:xfrm>
+          <a:prstGeom prst="rect">
+            <a:avLst/>
+          </a:prstGeom>
+          <a:noFill/>
+        </p:spPr>
+        <p:txBody>
+          <a:bodyPr wrap="square" lIns="0" rIns="0" tIns="0" bIns="0" anchor="t">
+            <a:spAutoFit/>
+          </a:bodyPr>
+          <a:lstStyle/>
+          <a:p>
+            <a:pPr algn="l"/>
+            <a:r>
+              <a:rPr sz="1200" b="0">
+                <a:solidFill>
+                  <a:srgbClr val="4C5852"/>
+                </a:solidFill>
+                <a:latin typeface="Inter"/>
+              </a:rPr>
+              <a:t>Tuproq shoʻrlanishini kamaytirish: Mingbuloq 0,2, Pop 0,1 (reja 110% bajarilgan)</a:t>
+            </a:r>
+          </a:p>
+        </p:txBody>
+      </p:sp>
+      <p:sp>
+        <p:nvSpPr>
+          <p:cNvPr id="15" name="Rounded Rectangle 14"/>
+          <p:cNvSpPr/>
+          <p:nvPr/>
+        </p:nvSpPr>
+        <p:spPr>
+          <a:xfrm>
+            <a:off x="7700000" y="4590000"/>
+            <a:ext cx="3996192" cy="1230000"/>
+          </a:xfrm>
+          <a:prstGeom prst="roundRect">
+            <a:avLst>
+              <a:gd name="adj" fmla="val 5000"/>
+            </a:avLst>
+          </a:prstGeom>
+          <a:solidFill>
+            <a:srgbClr val="FBF9F4"/>
+          </a:solidFill>
+          <a:ln w="6350">
+            <a:solidFill>
+              <a:srgbClr val="D9D2C3"/>
+            </a:solidFill>
+          </a:ln>
+          <a:effectLst/>
+        </p:spPr>
+        <p:style>
+          <a:lnRef idx="1">
+            <a:schemeClr val="accent1"/>
+          </a:lnRef>
+          <a:fillRef idx="3">
+            <a:schemeClr val="accent1"/>
+          </a:fillRef>
+          <a:effectRef idx="2">
+            <a:schemeClr val="accent1"/>
+          </a:effectRef>
+          <a:fontRef idx="minor">
+            <a:schemeClr val="lt1"/>
+          </a:fontRef>
+        </p:style>
+        <p:txBody>
+          <a:bodyPr rtlCol="0" anchor="ctr"/>
+          <a:lstStyle/>
+          <a:p>
+            <a:pPr algn="ctr"/>
+          </a:p>
+        </p:txBody>
+      </p:sp>
+      <p:sp>
+        <p:nvSpPr>
+          <p:cNvPr id="16" name="TextBox 15"/>
+          <p:cNvSpPr txBox="1"/>
+          <p:nvPr/>
+        </p:nvSpPr>
+        <p:spPr>
+          <a:xfrm>
+            <a:off x="7930000" y="4710000"/>
+            <a:ext cx="3536192" cy="420000"/>
+          </a:xfrm>
+          <a:prstGeom prst="rect">
+            <a:avLst/>
+          </a:prstGeom>
+          <a:noFill/>
+        </p:spPr>
+        <p:txBody>
+          <a:bodyPr wrap="square" lIns="0" rIns="0" tIns="0" bIns="0" anchor="t">
+            <a:spAutoFit/>
+          </a:bodyPr>
+          <a:lstStyle/>
+          <a:p>
+            <a:pPr algn="l"/>
+            <a:r>
+              <a:rPr sz="2400" b="0">
+                <a:solidFill>
+                  <a:srgbClr val="A4521D"/>
+                </a:solidFill>
+                <a:latin typeface="Source Serif 4"/>
+              </a:rPr>
+              <a:t>2,9 ming ga</a:t>
+            </a:r>
+          </a:p>
+        </p:txBody>
+      </p:sp>
+      <p:sp>
+        <p:nvSpPr>
+          <p:cNvPr id="17" name="TextBox 16"/>
+          <p:cNvSpPr txBox="1"/>
+          <p:nvPr/>
+        </p:nvSpPr>
+        <p:spPr>
+          <a:xfrm>
+            <a:off x="7930000" y="5150000"/>
+            <a:ext cx="3536192" cy="620000"/>
+          </a:xfrm>
+          <a:prstGeom prst="rect">
+            <a:avLst/>
+          </a:prstGeom>
+          <a:noFill/>
+        </p:spPr>
+        <p:txBody>
+          <a:bodyPr wrap="square" lIns="0" rIns="0" tIns="0" bIns="0" anchor="t">
+            <a:spAutoFit/>
+          </a:bodyPr>
+          <a:lstStyle/>
+          <a:p>
+            <a:pPr algn="l"/>
+            <a:r>
+              <a:rPr sz="1200" b="0">
+                <a:solidFill>
+                  <a:srgbClr val="4C5852"/>
+                </a:solidFill>
+                <a:latin typeface="Inter"/>
+              </a:rPr>
+              <a:t>Degradatsiyaga uchragan yerlar holati yaxshilangan (108,3%); Pop tumanida — 2,3 ming ga</a:t>
+            </a:r>
+          </a:p>
+        </p:txBody>
+      </p:sp>
+      <p:sp>
+        <p:nvSpPr>
+          <p:cNvPr id="18" name="TextBox 17"/>
+          <p:cNvSpPr txBox="1"/>
+          <p:nvPr/>
+        </p:nvSpPr>
+        <p:spPr>
+          <a:xfrm>
+            <a:off x="812800" y="6238280"/>
+            <a:ext cx="9800000" cy="240000"/>
+          </a:xfrm>
+          <a:prstGeom prst="rect">
+            <a:avLst/>
+          </a:prstGeom>
+          <a:noFill/>
+        </p:spPr>
+        <p:txBody>
+          <a:bodyPr wrap="square" lIns="0" rIns="0" tIns="0" bIns="0" anchor="t">
+            <a:spAutoFit/>
+          </a:bodyPr>
+          <a:lstStyle/>
+          <a:p>
+            <a:pPr algn="l"/>
+            <a:r>
+              <a:rPr sz="1200" b="0">
+                <a:solidFill>
+                  <a:srgbClr val="5F6B64"/>
+                </a:solidFill>
+                <a:latin typeface="Inter"/>
+              </a:rPr>
+              <a:t>Manba: Namangan viloyatida 2025 yilda yer degradatsiyasini kamaytirish prognoz koʻrsatkichlarining bajarilishi</a:t>
             </a:r>
           </a:p>
         </p:txBody>

</xml_diff>

<commit_message>
Add Andijan water productivity and literature slides; extend normative basis
Co-Authored-By: Claude Sonnet 5.5 <noreply@anthropic.com>
Claude-Session: https://claude.ai/code/session_01M4MZatV28utL9zTp7saaUz
</commit_message>
<xml_diff>
--- a/Garbiy_Farg_ona_tuproqlari_GAT_asosida_bashoratlash.pptx
+++ b/Garbiy_Farg_ona_tuproqlari_GAT_asosida_bashoratlash.pptx
@@ -30,6 +30,8 @@
     <p:sldId id="285" r:id="rId36"/>
     <p:sldId id="286" r:id="rId37"/>
     <p:sldId id="287" r:id="rId38"/>
+    <p:sldId id="288" r:id="rId39"/>
+    <p:sldId id="289" r:id="rId40"/>
     <p:sldId id="265" r:id="rId11"/>
     <p:sldId id="266" r:id="rId12"/>
     <p:sldId id="267" r:id="rId13"/>
@@ -3137,6 +3139,273 @@
             </a:pPr>
           </a:p>
         </c:txPr>
+        <c:crossAx val="-2068027336"/>
+        <c:crosses val="autoZero"/>
+      </c:valAx>
+    </c:plotArea>
+    <c:legend>
+      <c:legendPos val="t"/>
+      <c:overlay val="0"/>
+      <c:txPr>
+        <a:bodyPr/>
+        <a:lstStyle/>
+        <a:p>
+          <a:pPr>
+            <a:defRPr sz="1200">
+              <a:solidFill>
+                <a:srgbClr val="4C5852"/>
+              </a:solidFill>
+              <a:latin typeface="Inter"/>
+            </a:defRPr>
+          </a:pPr>
+        </a:p>
+      </c:txPr>
+    </c:legend>
+    <c:dispBlanksAs val="gap"/>
+  </c:chart>
+  <c:txPr>
+    <a:bodyPr/>
+    <a:lstStyle/>
+    <a:p>
+      <a:pPr>
+        <a:defRPr sz="1200">
+          <a:solidFill>
+            <a:srgbClr val="4C5852"/>
+          </a:solidFill>
+          <a:latin typeface="Inter"/>
+        </a:defRPr>
+      </a:pPr>
+      <a:endParaRPr lang="en-US"/>
+    </a:p>
+  </c:txPr>
+  <c:externalData r:id="rId1">
+    <c:autoUpdate val="0"/>
+  </c:externalData>
+</c:chartSpace>
+</file>
+
+<file path=ppt/charts/chart19.xml><?xml version="1.0" encoding="utf-8"?>
+<c:chartSpace xmlns:c="http://schemas.openxmlformats.org/drawingml/2006/chart" xmlns:a="http://schemas.openxmlformats.org/drawingml/2006/main" xmlns:r="http://schemas.openxmlformats.org/officeDocument/2006/relationships">
+  <c:date1904 val="0"/>
+  <c:chart>
+    <c:autoTitleDeleted val="1"/>
+    <c:plotArea>
+      <c:barChart>
+        <c:barDir val="col"/>
+        <c:grouping val="clustered"/>
+        <c:ser>
+          <c:idx val="0"/>
+          <c:order val="0"/>
+          <c:tx>
+            <c:strRef>
+              <c:f>Sheet1!$B$1</c:f>
+              <c:strCache>
+                <c:ptCount val="1"/>
+                <c:pt idx="0">
+                  <c:v>Paxta</c:v>
+                </c:pt>
+              </c:strCache>
+            </c:strRef>
+          </c:tx>
+          <c:spPr>
+            <a:solidFill>
+              <a:srgbClr val="A4521D"/>
+            </a:solidFill>
+          </c:spPr>
+          <c:cat>
+            <c:strRef>
+              <c:f>Sheet1!$A$2:$A$6</c:f>
+              <c:strCache>
+                <c:ptCount val="5"/>
+                <c:pt idx="0">
+                  <c:v>2019</c:v>
+                </c:pt>
+                <c:pt idx="1">
+                  <c:v>2020</c:v>
+                </c:pt>
+                <c:pt idx="2">
+                  <c:v>2022</c:v>
+                </c:pt>
+                <c:pt idx="3">
+                  <c:v>2023</c:v>
+                </c:pt>
+                <c:pt idx="4">
+                  <c:v>2024</c:v>
+                </c:pt>
+              </c:strCache>
+            </c:strRef>
+          </c:cat>
+          <c:val>
+            <c:numRef>
+              <c:f>Sheet1!$B$2:$B$6</c:f>
+              <c:numCache>
+                <c:formatCode>General</c:formatCode>
+                <c:ptCount val="5"/>
+                <c:pt idx="0">
+                  <c:v>0.45</c:v>
+                </c:pt>
+                <c:pt idx="1">
+                  <c:v>0.48</c:v>
+                </c:pt>
+                <c:pt idx="2">
+                  <c:v>0.64</c:v>
+                </c:pt>
+                <c:pt idx="3">
+                  <c:v>0.57</c:v>
+                </c:pt>
+                <c:pt idx="4">
+                  <c:v>0.61</c:v>
+                </c:pt>
+              </c:numCache>
+            </c:numRef>
+          </c:val>
+        </c:ser>
+        <c:ser>
+          <c:idx val="1"/>
+          <c:order val="1"/>
+          <c:tx>
+            <c:strRef>
+              <c:f>Sheet1!$C$1</c:f>
+              <c:strCache>
+                <c:ptCount val="1"/>
+                <c:pt idx="0">
+                  <c:v>Don</c:v>
+                </c:pt>
+              </c:strCache>
+            </c:strRef>
+          </c:tx>
+          <c:spPr>
+            <a:solidFill>
+              <a:srgbClr val="2C6A85"/>
+            </a:solidFill>
+          </c:spPr>
+          <c:cat>
+            <c:strRef>
+              <c:f>Sheet1!$A$2:$A$6</c:f>
+              <c:strCache>
+                <c:ptCount val="5"/>
+                <c:pt idx="0">
+                  <c:v>2019</c:v>
+                </c:pt>
+                <c:pt idx="1">
+                  <c:v>2020</c:v>
+                </c:pt>
+                <c:pt idx="2">
+                  <c:v>2022</c:v>
+                </c:pt>
+                <c:pt idx="3">
+                  <c:v>2023</c:v>
+                </c:pt>
+                <c:pt idx="4">
+                  <c:v>2024</c:v>
+                </c:pt>
+              </c:strCache>
+            </c:strRef>
+          </c:cat>
+          <c:val>
+            <c:numRef>
+              <c:f>Sheet1!$C$2:$C$6</c:f>
+              <c:numCache>
+                <c:formatCode>General</c:formatCode>
+                <c:ptCount val="5"/>
+                <c:pt idx="0">
+                  <c:v>1.29</c:v>
+                </c:pt>
+                <c:pt idx="1">
+                  <c:v>1.39</c:v>
+                </c:pt>
+                <c:pt idx="2">
+                  <c:v>1.42</c:v>
+                </c:pt>
+                <c:pt idx="3">
+                  <c:v>1.31</c:v>
+                </c:pt>
+                <c:pt idx="4">
+                  <c:v>1.71</c:v>
+                </c:pt>
+              </c:numCache>
+            </c:numRef>
+          </c:val>
+        </c:ser>
+        <c:dLbls>
+          <c:numFmt formatCode="0.00" sourceLinked="0"/>
+          <c:txPr>
+            <a:bodyPr/>
+            <a:lstStyle/>
+            <a:p>
+              <a:pPr>
+                <a:defRPr sz="1200">
+                  <a:solidFill>
+                    <a:srgbClr val="1D2A24"/>
+                  </a:solidFill>
+                  <a:latin typeface="Inter"/>
+                </a:defRPr>
+              </a:pPr>
+            </a:p>
+          </c:txPr>
+          <c:dLblPos val="outEnd"/>
+          <c:showLegendKey val="0"/>
+          <c:showVal val="1"/>
+          <c:showCatName val="0"/>
+          <c:showSerName val="0"/>
+          <c:showPercent val="0"/>
+          <c:showBubbleSize val="0"/>
+          <c:showLeaderLines val="1"/>
+        </c:dLbls>
+        <c:gapWidth val="60"/>
+        <c:overlap val="-5"/>
+        <c:axId val="-2068027336"/>
+        <c:axId val="-2113994440"/>
+      </c:barChart>
+      <c:catAx>
+        <c:axId val="-2068027336"/>
+        <c:scaling>
+          <c:orientation val="minMax"/>
+        </c:scaling>
+        <c:delete val="0"/>
+        <c:axPos val="b"/>
+        <c:majorTickMark val="out"/>
+        <c:minorTickMark val="none"/>
+        <c:tickLblPos val="nextTo"/>
+        <c:spPr>
+          <a:ln>
+            <a:solidFill>
+              <a:srgbClr val="B5B2AD"/>
+            </a:solidFill>
+          </a:ln>
+        </c:spPr>
+        <c:txPr>
+          <a:bodyPr/>
+          <a:lstStyle/>
+          <a:p>
+            <a:pPr>
+              <a:defRPr sz="1200">
+                <a:solidFill>
+                  <a:srgbClr val="4C5852"/>
+                </a:solidFill>
+                <a:latin typeface="Inter"/>
+              </a:defRPr>
+            </a:pPr>
+          </a:p>
+        </c:txPr>
+        <c:crossAx val="-2113994440"/>
+        <c:crosses val="autoZero"/>
+        <c:auto val="1"/>
+        <c:lblAlgn val="ctr"/>
+        <c:lblOffset val="100"/>
+        <c:noMultiLvlLbl val="0"/>
+      </c:catAx>
+      <c:valAx>
+        <c:axId val="-2113994440"/>
+        <c:scaling>
+          <c:max val="2.1"/>
+          <c:min val="0.0"/>
+        </c:scaling>
+        <c:delete/>
+        <c:axPos val="l"/>
+        <c:majorTickMark val="out"/>
+        <c:minorTickMark val="none"/>
+        <c:tickLblPos val="nextTo"/>
         <c:crossAx val="-2068027336"/>
         <c:crosses val="autoZero"/>
       </c:valAx>
@@ -7818,7 +8087,7 @@
                 <a:ea typeface="Inter" pitchFamily="34" charset="-122"/>
                 <a:cs typeface="Inter" pitchFamily="34" charset="-120"/>
               </a:rPr>
-              <a:t>25 · DISSERTATSIYA TUZILISHI</a:t>
+              <a:t>27 · DISSERTATSIYA TUZILISHI</a:t>
             </a:r>
             <a:endParaRPr lang="en-US" sz="1200" dirty="0"/>
           </a:p>
@@ -8617,7 +8886,7 @@
                 <a:ea typeface="Inter" pitchFamily="34" charset="-122"/>
                 <a:cs typeface="Inter" pitchFamily="34" charset="-120"/>
               </a:rPr>
-              <a:t>26</a:t>
+              <a:t>28</a:t>
             </a:r>
             <a:endParaRPr lang="en-US" sz="1200" dirty="0"/>
           </a:p>
@@ -8693,7 +8962,7 @@
                 <a:ea typeface="Inter" pitchFamily="34" charset="-122"/>
                 <a:cs typeface="Inter" pitchFamily="34" charset="-120"/>
               </a:rPr>
-              <a:t>26 · DISSERTATSIYA TUZILISHI</a:t>
+              <a:t>28 · DISSERTATSIYA TUZILISHI</a:t>
             </a:r>
             <a:endParaRPr lang="en-US" sz="1200" dirty="0"/>
           </a:p>
@@ -9725,7 +9994,7 @@
                 <a:ea typeface="Inter" pitchFamily="34" charset="-122"/>
                 <a:cs typeface="Inter" pitchFamily="34" charset="-120"/>
               </a:rPr>
-              <a:t>27</a:t>
+              <a:t>29</a:t>
             </a:r>
             <a:endParaRPr lang="en-US" sz="1200" dirty="0"/>
           </a:p>
@@ -9801,7 +10070,7 @@
                 <a:ea typeface="Inter" pitchFamily="34" charset="-122"/>
                 <a:cs typeface="Inter" pitchFamily="34" charset="-120"/>
               </a:rPr>
-              <a:t>27 · DISSERTATSIYA TUZILISHI</a:t>
+              <a:t>29 · DISSERTATSIYA TUZILISHI</a:t>
             </a:r>
             <a:endParaRPr lang="en-US" sz="1200" dirty="0"/>
           </a:p>
@@ -10828,7 +11097,7 @@
                 <a:ea typeface="Inter" pitchFamily="34" charset="-122"/>
                 <a:cs typeface="Inter" pitchFamily="34" charset="-120"/>
               </a:rPr>
-              <a:t>28</a:t>
+              <a:t>30</a:t>
             </a:r>
             <a:endParaRPr lang="en-US" sz="1200" dirty="0"/>
           </a:p>
@@ -10904,7 +11173,7 @@
                 <a:ea typeface="Inter" pitchFamily="34" charset="-122"/>
                 <a:cs typeface="Inter" pitchFamily="34" charset="-120"/>
               </a:rPr>
-              <a:t>28 · NATIJALAR VA REJA</a:t>
+              <a:t>30 · NATIJALAR VA REJA</a:t>
             </a:r>
             <a:endParaRPr lang="en-US" sz="1200" dirty="0"/>
           </a:p>
@@ -11642,7 +11911,7 @@
                 <a:ea typeface="Inter" pitchFamily="34" charset="-122"/>
                 <a:cs typeface="Inter" pitchFamily="34" charset="-120"/>
               </a:rPr>
-              <a:t>29</a:t>
+              <a:t>31</a:t>
             </a:r>
             <a:endParaRPr lang="en-US" sz="1200" dirty="0"/>
           </a:p>
@@ -11718,7 +11987,7 @@
                 <a:ea typeface="Inter" pitchFamily="34" charset="-122"/>
                 <a:cs typeface="Inter" pitchFamily="34" charset="-120"/>
               </a:rPr>
-              <a:t>29 · NATIJALAR VA REJA</a:t>
+              <a:t>31 · NATIJALAR VA REJA</a:t>
             </a:r>
             <a:endParaRPr lang="en-US" sz="1200" dirty="0"/>
           </a:p>
@@ -12744,7 +13013,7 @@
                 <a:ea typeface="Inter" pitchFamily="34" charset="-122"/>
                 <a:cs typeface="Inter" pitchFamily="34" charset="-120"/>
               </a:rPr>
-              <a:t>30</a:t>
+              <a:t>32</a:t>
             </a:r>
             <a:endParaRPr lang="en-US" sz="1200" dirty="0"/>
           </a:p>
@@ -12820,7 +13089,7 @@
                 <a:ea typeface="Inter" pitchFamily="34" charset="-122"/>
                 <a:cs typeface="Inter" pitchFamily="34" charset="-120"/>
               </a:rPr>
-              <a:t>30 · NATIJALAR VA REJA</a:t>
+              <a:t>32 · NATIJALAR VA REJA</a:t>
             </a:r>
             <a:endParaRPr lang="en-US" sz="1200" dirty="0"/>
           </a:p>
@@ -13432,7 +13701,7 @@
                 <a:ea typeface="Inter" pitchFamily="34" charset="-122"/>
                 <a:cs typeface="Inter" pitchFamily="34" charset="-120"/>
               </a:rPr>
-              <a:t>31</a:t>
+              <a:t>33</a:t>
             </a:r>
             <a:endParaRPr lang="en-US" sz="1200" dirty="0"/>
           </a:p>
@@ -16458,7 +16727,7 @@
                 <a:ea typeface="Inter" pitchFamily="34" charset="-122"/>
                 <a:cs typeface="Inter" pitchFamily="34" charset="-120"/>
               </a:rPr>
-              <a:t>Normativ asos: PQ-5006 (24.02.2021), PF-130 (12.08.2025)</a:t>
+              <a:t>Normativ asos: PQ-277 (10.06.2022), PQ-5006 (24.02.2021), PF-130 (12.08.2025)</a:t>
             </a:r>
             <a:endParaRPr lang="en-US" sz="1200" dirty="0"/>
           </a:p>
@@ -24379,6 +24648,1308 @@
                 <a:latin typeface="Inter"/>
               </a:rPr>
               <a:t>Manba: Namangan viloyatida 2025 yilda yer degradatsiyasini kamaytirish prognoz koʻrsatkichlarining bajarilishi</a:t>
+            </a:r>
+          </a:p>
+        </p:txBody>
+      </p:sp>
+    </p:spTree>
+  </p:cSld>
+  <p:clrMapOvr>
+    <a:masterClrMapping/>
+  </p:clrMapOvr>
+</p:sld>
+</file>
+
+<file path=ppt/slides/slide33.xml><?xml version="1.0" encoding="utf-8"?>
+<p:sld xmlns:a="http://schemas.openxmlformats.org/drawingml/2006/main" xmlns:p="http://schemas.openxmlformats.org/presentationml/2006/main" xmlns:r="http://schemas.openxmlformats.org/officeDocument/2006/relationships">
+  <p:cSld>
+    <p:bg>
+      <p:bgPr>
+        <a:solidFill>
+          <a:srgbClr val="F4F1EA"/>
+        </a:solidFill>
+      </p:bgPr>
+    </p:bg>
+    <p:spTree>
+      <p:nvGrpSpPr>
+        <p:cNvPr id="1" name=""/>
+        <p:cNvGrpSpPr/>
+        <p:nvPr/>
+      </p:nvGrpSpPr>
+      <p:grpSpPr/>
+      <p:sp>
+        <p:nvSpPr>
+          <p:cNvPr id="2" name="Text 0"/>
+          <p:cNvSpPr/>
+          <p:nvPr/>
+        </p:nvSpPr>
+        <p:spPr>
+          <a:xfrm>
+            <a:off x="812800" y="812800"/>
+            <a:ext cx="10883392" cy="238720"/>
+          </a:xfrm>
+          <a:prstGeom prst="rect">
+            <a:avLst/>
+          </a:prstGeom>
+          <a:noFill/>
+          <a:ln/>
+        </p:spPr>
+        <p:txBody>
+          <a:bodyPr wrap="square" lIns="0" tIns="0" rIns="0" bIns="0" rtlCol="0" anchor="t">
+            <a:normAutofit/>
+          </a:bodyPr>
+          <a:lstStyle/>
+          <a:p>
+            <a:pPr algn="l" indent="0" marL="0">
+              <a:lnSpc>
+                <a:spcPts val="1680"/>
+              </a:lnSpc>
+              <a:buNone/>
+            </a:pPr>
+            <a:r>
+              <a:rPr lang="en-US" sz="1200" b="1" spc="150" kern="0" dirty="0">
+                <a:solidFill>
+                  <a:srgbClr val="2C6A85"/>
+                </a:solidFill>
+                <a:latin typeface="Inter" pitchFamily="34" charset="0"/>
+                <a:ea typeface="Inter" pitchFamily="34" charset="-122"/>
+                <a:cs typeface="Inter" pitchFamily="34" charset="-120"/>
+              </a:rPr>
+              <a:t>25 · DASTLABKI MAʼLUMOTLAR</a:t>
+            </a:r>
+            <a:endParaRPr lang="en-US" sz="1200" dirty="0"/>
+          </a:p>
+        </p:txBody>
+      </p:sp>
+      <p:sp>
+        <p:nvSpPr>
+          <p:cNvPr id="3" name="Text 1"/>
+          <p:cNvSpPr/>
+          <p:nvPr>
+            <p:ph type="title"/>
+          </p:nvPr>
+        </p:nvSpPr>
+        <p:spPr>
+          <a:xfrm>
+            <a:off x="812800" y="1127720"/>
+            <a:ext cx="10883392" cy="472430"/>
+          </a:xfrm>
+          <a:prstGeom prst="rect">
+            <a:avLst/>
+          </a:prstGeom>
+          <a:noFill/>
+          <a:ln/>
+        </p:spPr>
+        <p:txBody>
+          <a:bodyPr wrap="square" lIns="0" tIns="0" rIns="0" bIns="0" rtlCol="0" anchor="t">
+            <a:normAutofit/>
+          </a:bodyPr>
+          <a:lstStyle/>
+          <a:p>
+            <a:pPr algn="l" indent="0" marL="0">
+              <a:lnSpc>
+                <a:spcPts val="3520"/>
+              </a:lnSpc>
+              <a:buNone/>
+            </a:pPr>
+            <a:r>
+              <a:rPr lang="en-US" sz="3200" b="0" i="0" dirty="0">
+                <a:solidFill>
+                  <a:srgbClr val="1D2A24"/>
+                </a:solidFill>
+                <a:latin typeface="Source Serif 4" pitchFamily="18" charset="0"/>
+                <a:ea typeface="Source Serif 4" pitchFamily="18" charset="-122"/>
+                <a:cs typeface="Source Serif 4" pitchFamily="18" charset="-120"/>
+              </a:rPr>
+              <a:t>Andijon viloyati: suv unumdorligi</a:t>
+            </a:r>
+            <a:endParaRPr lang="en-US" sz="3200" dirty="0"/>
+          </a:p>
+        </p:txBody>
+      </p:sp>
+      <p:sp>
+        <p:nvSpPr>
+          <p:cNvPr id="6" name="Text 3"/>
+          <p:cNvSpPr/>
+          <p:nvPr/>
+        </p:nvSpPr>
+        <p:spPr>
+          <a:xfrm>
+            <a:off x="11137950" y="6238280"/>
+            <a:ext cx="241250" cy="238720"/>
+          </a:xfrm>
+          <a:prstGeom prst="rect">
+            <a:avLst/>
+          </a:prstGeom>
+          <a:noFill/>
+          <a:ln/>
+        </p:spPr>
+        <p:txBody>
+          <a:bodyPr wrap="square" lIns="0" tIns="0" rIns="0" bIns="0" rtlCol="0" anchor="t">
+            <a:normAutofit/>
+          </a:bodyPr>
+          <a:lstStyle/>
+          <a:p>
+            <a:pPr algn="r" indent="0" marL="0">
+              <a:lnSpc>
+                <a:spcPts val="1680"/>
+              </a:lnSpc>
+              <a:buNone/>
+            </a:pPr>
+            <a:r>
+              <a:rPr lang="en-US" sz="1200" dirty="0">
+                <a:solidFill>
+                  <a:srgbClr val="5F6B64"/>
+                </a:solidFill>
+                <a:latin typeface="Inter" pitchFamily="34" charset="0"/>
+                <a:ea typeface="Inter" pitchFamily="34" charset="-122"/>
+                <a:cs typeface="Inter" pitchFamily="34" charset="-120"/>
+              </a:rPr>
+              <a:t>26</a:t>
+            </a:r>
+            <a:endParaRPr lang="en-US" sz="1200" dirty="0"/>
+          </a:p>
+        </p:txBody>
+      </p:sp>
+      <p:sp>
+        <p:nvSpPr>
+          <p:cNvPr id="7" name="TextBox 6"/>
+          <p:cNvSpPr txBox="1"/>
+          <p:nvPr/>
+        </p:nvSpPr>
+        <p:spPr>
+          <a:xfrm>
+            <a:off x="812800" y="1830000"/>
+            <a:ext cx="6200000" cy="260000"/>
+          </a:xfrm>
+          <a:prstGeom prst="rect">
+            <a:avLst/>
+          </a:prstGeom>
+          <a:noFill/>
+        </p:spPr>
+        <p:txBody>
+          <a:bodyPr wrap="square" lIns="0" rIns="0" tIns="0" bIns="0" anchor="t">
+            <a:spAutoFit/>
+          </a:bodyPr>
+          <a:lstStyle/>
+          <a:p>
+            <a:pPr algn="l"/>
+            <a:r>
+              <a:rPr sz="1300" b="1">
+                <a:solidFill>
+                  <a:srgbClr val="2C6A85"/>
+                </a:solidFill>
+                <a:latin typeface="Inter"/>
+              </a:rPr>
+              <a:t>1 m³ sugʻorish suvidan olingan hosil, kg</a:t>
+            </a:r>
+          </a:p>
+        </p:txBody>
+      </p:sp>
+      <p:graphicFrame>
+        <p:nvGraphicFramePr>
+          <p:cNvPr id="8" name="Chart 7"/>
+          <p:cNvGraphicFramePr>
+            <a:graphicFrameLocks noGrp="1"/>
+          </p:cNvGraphicFramePr>
+          <p:nvPr/>
+        </p:nvGraphicFramePr>
+        <p:xfrm>
+          <a:off x="752800" y="2080000"/>
+          <a:ext cx="6600000" cy="4000000"/>
+        </p:xfrm>
+        <a:graphic>
+          <a:graphicData uri="http://schemas.openxmlformats.org/drawingml/2006/chart">
+            <c:chart xmlns:c="http://schemas.openxmlformats.org/drawingml/2006/chart" r:id="rId2"/>
+          </a:graphicData>
+        </a:graphic>
+      </p:graphicFrame>
+      <p:sp>
+        <p:nvSpPr>
+          <p:cNvPr id="9" name="Rounded Rectangle 8"/>
+          <p:cNvSpPr/>
+          <p:nvPr/>
+        </p:nvSpPr>
+        <p:spPr>
+          <a:xfrm>
+            <a:off x="7700000" y="1830000"/>
+            <a:ext cx="3996192" cy="1230000"/>
+          </a:xfrm>
+          <a:prstGeom prst="roundRect">
+            <a:avLst>
+              <a:gd name="adj" fmla="val 5000"/>
+            </a:avLst>
+          </a:prstGeom>
+          <a:solidFill>
+            <a:srgbClr val="FBF9F4"/>
+          </a:solidFill>
+          <a:ln w="6350">
+            <a:solidFill>
+              <a:srgbClr val="D9D2C3"/>
+            </a:solidFill>
+          </a:ln>
+          <a:effectLst/>
+        </p:spPr>
+        <p:style>
+          <a:lnRef idx="1">
+            <a:schemeClr val="accent1"/>
+          </a:lnRef>
+          <a:fillRef idx="3">
+            <a:schemeClr val="accent1"/>
+          </a:fillRef>
+          <a:effectRef idx="2">
+            <a:schemeClr val="accent1"/>
+          </a:effectRef>
+          <a:fontRef idx="minor">
+            <a:schemeClr val="lt1"/>
+          </a:fontRef>
+        </p:style>
+        <p:txBody>
+          <a:bodyPr rtlCol="0" anchor="ctr"/>
+          <a:lstStyle/>
+          <a:p>
+            <a:pPr algn="ctr"/>
+          </a:p>
+        </p:txBody>
+      </p:sp>
+      <p:sp>
+        <p:nvSpPr>
+          <p:cNvPr id="10" name="TextBox 9"/>
+          <p:cNvSpPr txBox="1"/>
+          <p:nvPr/>
+        </p:nvSpPr>
+        <p:spPr>
+          <a:xfrm>
+            <a:off x="7930000" y="1950000"/>
+            <a:ext cx="3536192" cy="420000"/>
+          </a:xfrm>
+          <a:prstGeom prst="rect">
+            <a:avLst/>
+          </a:prstGeom>
+          <a:noFill/>
+        </p:spPr>
+        <p:txBody>
+          <a:bodyPr wrap="square" lIns="0" rIns="0" tIns="0" bIns="0" anchor="t">
+            <a:spAutoFit/>
+          </a:bodyPr>
+          <a:lstStyle/>
+          <a:p>
+            <a:pPr algn="l"/>
+            <a:r>
+              <a:rPr sz="2400" b="0">
+                <a:solidFill>
+                  <a:srgbClr val="A4521D"/>
+                </a:solidFill>
+                <a:latin typeface="Source Serif 4"/>
+              </a:rPr>
+              <a:t>−22%</a:t>
+            </a:r>
+          </a:p>
+        </p:txBody>
+      </p:sp>
+      <p:sp>
+        <p:nvSpPr>
+          <p:cNvPr id="11" name="TextBox 10"/>
+          <p:cNvSpPr txBox="1"/>
+          <p:nvPr/>
+        </p:nvSpPr>
+        <p:spPr>
+          <a:xfrm>
+            <a:off x="7930000" y="2390000"/>
+            <a:ext cx="3536192" cy="620000"/>
+          </a:xfrm>
+          <a:prstGeom prst="rect">
+            <a:avLst/>
+          </a:prstGeom>
+          <a:noFill/>
+        </p:spPr>
+        <p:txBody>
+          <a:bodyPr wrap="square" lIns="0" rIns="0" tIns="0" bIns="0" anchor="t">
+            <a:spAutoFit/>
+          </a:bodyPr>
+          <a:lstStyle/>
+          <a:p>
+            <a:pPr algn="l"/>
+            <a:r>
+              <a:rPr sz="1200" b="0">
+                <a:solidFill>
+                  <a:srgbClr val="4C5852"/>
+                </a:solidFill>
+                <a:latin typeface="Inter"/>
+              </a:rPr>
+              <a:t>Paxtaga 1 ga uchun berilgan suv 7,31 dan 5,72 ming m³ gacha kamaygan (2019 → 2024); hosildorlik 32,6 dan 35,1 s/ga</a:t>
+            </a:r>
+          </a:p>
+        </p:txBody>
+      </p:sp>
+      <p:sp>
+        <p:nvSpPr>
+          <p:cNvPr id="12" name="Rounded Rectangle 11"/>
+          <p:cNvSpPr/>
+          <p:nvPr/>
+        </p:nvSpPr>
+        <p:spPr>
+          <a:xfrm>
+            <a:off x="7700000" y="3210000"/>
+            <a:ext cx="3996192" cy="1230000"/>
+          </a:xfrm>
+          <a:prstGeom prst="roundRect">
+            <a:avLst>
+              <a:gd name="adj" fmla="val 5000"/>
+            </a:avLst>
+          </a:prstGeom>
+          <a:solidFill>
+            <a:srgbClr val="FBF9F4"/>
+          </a:solidFill>
+          <a:ln w="6350">
+            <a:solidFill>
+              <a:srgbClr val="D9D2C3"/>
+            </a:solidFill>
+          </a:ln>
+          <a:effectLst/>
+        </p:spPr>
+        <p:style>
+          <a:lnRef idx="1">
+            <a:schemeClr val="accent1"/>
+          </a:lnRef>
+          <a:fillRef idx="3">
+            <a:schemeClr val="accent1"/>
+          </a:fillRef>
+          <a:effectRef idx="2">
+            <a:schemeClr val="accent1"/>
+          </a:effectRef>
+          <a:fontRef idx="minor">
+            <a:schemeClr val="lt1"/>
+          </a:fontRef>
+        </p:style>
+        <p:txBody>
+          <a:bodyPr rtlCol="0" anchor="ctr"/>
+          <a:lstStyle/>
+          <a:p>
+            <a:pPr algn="ctr"/>
+          </a:p>
+        </p:txBody>
+      </p:sp>
+      <p:sp>
+        <p:nvSpPr>
+          <p:cNvPr id="13" name="TextBox 12"/>
+          <p:cNvSpPr txBox="1"/>
+          <p:nvPr/>
+        </p:nvSpPr>
+        <p:spPr>
+          <a:xfrm>
+            <a:off x="7930000" y="3330000"/>
+            <a:ext cx="3536192" cy="420000"/>
+          </a:xfrm>
+          <a:prstGeom prst="rect">
+            <a:avLst/>
+          </a:prstGeom>
+          <a:noFill/>
+        </p:spPr>
+        <p:txBody>
+          <a:bodyPr wrap="square" lIns="0" rIns="0" tIns="0" bIns="0" anchor="t">
+            <a:spAutoFit/>
+          </a:bodyPr>
+          <a:lstStyle/>
+          <a:p>
+            <a:pPr algn="l"/>
+            <a:r>
+              <a:rPr sz="2400" b="0">
+                <a:solidFill>
+                  <a:srgbClr val="2C6A85"/>
+                </a:solidFill>
+                <a:latin typeface="Source Serif 4"/>
+              </a:rPr>
+              <a:t>+36%</a:t>
+            </a:r>
+          </a:p>
+        </p:txBody>
+      </p:sp>
+      <p:sp>
+        <p:nvSpPr>
+          <p:cNvPr id="14" name="TextBox 13"/>
+          <p:cNvSpPr txBox="1"/>
+          <p:nvPr/>
+        </p:nvSpPr>
+        <p:spPr>
+          <a:xfrm>
+            <a:off x="7930000" y="3770000"/>
+            <a:ext cx="3536192" cy="620000"/>
+          </a:xfrm>
+          <a:prstGeom prst="rect">
+            <a:avLst/>
+          </a:prstGeom>
+          <a:noFill/>
+        </p:spPr>
+        <p:txBody>
+          <a:bodyPr wrap="square" lIns="0" rIns="0" tIns="0" bIns="0" anchor="t">
+            <a:spAutoFit/>
+          </a:bodyPr>
+          <a:lstStyle/>
+          <a:p>
+            <a:pPr algn="l"/>
+            <a:r>
+              <a:rPr sz="1200" b="0">
+                <a:solidFill>
+                  <a:srgbClr val="4C5852"/>
+                </a:solidFill>
+                <a:latin typeface="Inter"/>
+              </a:rPr>
+              <a:t>Paxtada 1 m³ suvdan olingan hosil 0,45 dan 0,61 kg gacha oshgan; donda 1,29 dan 1,71 kg</a:t>
+            </a:r>
+          </a:p>
+        </p:txBody>
+      </p:sp>
+      <p:sp>
+        <p:nvSpPr>
+          <p:cNvPr id="15" name="Rounded Rectangle 14"/>
+          <p:cNvSpPr/>
+          <p:nvPr/>
+        </p:nvSpPr>
+        <p:spPr>
+          <a:xfrm>
+            <a:off x="7700000" y="4590000"/>
+            <a:ext cx="3996192" cy="1230000"/>
+          </a:xfrm>
+          <a:prstGeom prst="roundRect">
+            <a:avLst>
+              <a:gd name="adj" fmla="val 5000"/>
+            </a:avLst>
+          </a:prstGeom>
+          <a:solidFill>
+            <a:srgbClr val="FBF9F4"/>
+          </a:solidFill>
+          <a:ln w="6350">
+            <a:solidFill>
+              <a:srgbClr val="D9D2C3"/>
+            </a:solidFill>
+          </a:ln>
+          <a:effectLst/>
+        </p:spPr>
+        <p:style>
+          <a:lnRef idx="1">
+            <a:schemeClr val="accent1"/>
+          </a:lnRef>
+          <a:fillRef idx="3">
+            <a:schemeClr val="accent1"/>
+          </a:fillRef>
+          <a:effectRef idx="2">
+            <a:schemeClr val="accent1"/>
+          </a:effectRef>
+          <a:fontRef idx="minor">
+            <a:schemeClr val="lt1"/>
+          </a:fontRef>
+        </p:style>
+        <p:txBody>
+          <a:bodyPr rtlCol="0" anchor="ctr"/>
+          <a:lstStyle/>
+          <a:p>
+            <a:pPr algn="ctr"/>
+          </a:p>
+        </p:txBody>
+      </p:sp>
+      <p:sp>
+        <p:nvSpPr>
+          <p:cNvPr id="16" name="TextBox 15"/>
+          <p:cNvSpPr txBox="1"/>
+          <p:nvPr/>
+        </p:nvSpPr>
+        <p:spPr>
+          <a:xfrm>
+            <a:off x="7930000" y="4710000"/>
+            <a:ext cx="3536192" cy="420000"/>
+          </a:xfrm>
+          <a:prstGeom prst="rect">
+            <a:avLst/>
+          </a:prstGeom>
+          <a:noFill/>
+        </p:spPr>
+        <p:txBody>
+          <a:bodyPr wrap="square" lIns="0" rIns="0" tIns="0" bIns="0" anchor="t">
+            <a:spAutoFit/>
+          </a:bodyPr>
+          <a:lstStyle/>
+          <a:p>
+            <a:pPr algn="l"/>
+            <a:r>
+              <a:rPr sz="2400" b="0">
+                <a:solidFill>
+                  <a:srgbClr val="A4521D"/>
+                </a:solidFill>
+                <a:latin typeface="Source Serif 4"/>
+              </a:rPr>
+              <a:t>5,5 barobar</a:t>
+            </a:r>
+          </a:p>
+        </p:txBody>
+      </p:sp>
+      <p:sp>
+        <p:nvSpPr>
+          <p:cNvPr id="17" name="TextBox 16"/>
+          <p:cNvSpPr txBox="1"/>
+          <p:nvPr/>
+        </p:nvSpPr>
+        <p:spPr>
+          <a:xfrm>
+            <a:off x="7930000" y="5150000"/>
+            <a:ext cx="3536192" cy="620000"/>
+          </a:xfrm>
+          <a:prstGeom prst="rect">
+            <a:avLst/>
+          </a:prstGeom>
+          <a:noFill/>
+        </p:spPr>
+        <p:txBody>
+          <a:bodyPr wrap="square" lIns="0" rIns="0" tIns="0" bIns="0" anchor="t">
+            <a:spAutoFit/>
+          </a:bodyPr>
+          <a:lstStyle/>
+          <a:p>
+            <a:pPr algn="l"/>
+            <a:r>
+              <a:rPr sz="1200" b="0">
+                <a:solidFill>
+                  <a:srgbClr val="4C5852"/>
+                </a:solidFill>
+                <a:latin typeface="Inter"/>
+              </a:rPr>
+              <a:t>Sholi 1 ga ga 31,6 ming m³ suv sarflaydi (paxta — 5,7 ming m³), 1 m³ dan 0,14 kg hosil</a:t>
+            </a:r>
+          </a:p>
+        </p:txBody>
+      </p:sp>
+      <p:sp>
+        <p:nvSpPr>
+          <p:cNvPr id="18" name="TextBox 17"/>
+          <p:cNvSpPr txBox="1"/>
+          <p:nvPr/>
+        </p:nvSpPr>
+        <p:spPr>
+          <a:xfrm>
+            <a:off x="812800" y="6238280"/>
+            <a:ext cx="9800000" cy="240000"/>
+          </a:xfrm>
+          <a:prstGeom prst="rect">
+            <a:avLst/>
+          </a:prstGeom>
+          <a:noFill/>
+        </p:spPr>
+        <p:txBody>
+          <a:bodyPr wrap="square" lIns="0" rIns="0" tIns="0" bIns="0" anchor="t">
+            <a:spAutoFit/>
+          </a:bodyPr>
+          <a:lstStyle/>
+          <a:p>
+            <a:pPr algn="l"/>
+            <a:r>
+              <a:rPr sz="1200" b="0">
+                <a:solidFill>
+                  <a:srgbClr val="5F6B64"/>
+                </a:solidFill>
+                <a:latin typeface="Inter"/>
+              </a:rPr>
+              <a:t>Manba: Andijon viloyati boʻyicha 1 m³ suv bilan olingan qishloq xoʻjalik mahsulotlari (2021 yil nusxa boʻlgani uchun chiqarilgan)</a:t>
+            </a:r>
+          </a:p>
+        </p:txBody>
+      </p:sp>
+    </p:spTree>
+  </p:cSld>
+  <p:clrMapOvr>
+    <a:masterClrMapping/>
+  </p:clrMapOvr>
+</p:sld>
+</file>
+
+<file path=ppt/slides/slide34.xml><?xml version="1.0" encoding="utf-8"?>
+<p:sld xmlns:a="http://schemas.openxmlformats.org/drawingml/2006/main" xmlns:p="http://schemas.openxmlformats.org/presentationml/2006/main" xmlns:r="http://schemas.openxmlformats.org/officeDocument/2006/relationships">
+  <p:cSld>
+    <p:bg>
+      <p:bgPr>
+        <a:solidFill>
+          <a:srgbClr val="F4F1EA"/>
+        </a:solidFill>
+      </p:bgPr>
+    </p:bg>
+    <p:spTree>
+      <p:nvGrpSpPr>
+        <p:cNvPr id="1" name=""/>
+        <p:cNvGrpSpPr/>
+        <p:nvPr/>
+      </p:nvGrpSpPr>
+      <p:grpSpPr/>
+      <p:sp>
+        <p:nvSpPr>
+          <p:cNvPr id="2" name="Text 0"/>
+          <p:cNvSpPr/>
+          <p:nvPr/>
+        </p:nvSpPr>
+        <p:spPr>
+          <a:xfrm>
+            <a:off x="812800" y="812800"/>
+            <a:ext cx="10883392" cy="238720"/>
+          </a:xfrm>
+          <a:prstGeom prst="rect">
+            <a:avLst/>
+          </a:prstGeom>
+          <a:noFill/>
+          <a:ln/>
+        </p:spPr>
+        <p:txBody>
+          <a:bodyPr wrap="square" lIns="0" tIns="0" rIns="0" bIns="0" rtlCol="0" anchor="t">
+            <a:normAutofit/>
+          </a:bodyPr>
+          <a:lstStyle/>
+          <a:p>
+            <a:pPr algn="l" indent="0" marL="0">
+              <a:lnSpc>
+                <a:spcPts val="1680"/>
+              </a:lnSpc>
+              <a:buNone/>
+            </a:pPr>
+            <a:r>
+              <a:rPr lang="en-US" sz="1200" b="1" spc="150" kern="0" dirty="0">
+                <a:solidFill>
+                  <a:srgbClr val="2C6A85"/>
+                </a:solidFill>
+                <a:latin typeface="Inter" pitchFamily="34" charset="0"/>
+                <a:ea typeface="Inter" pitchFamily="34" charset="-122"/>
+                <a:cs typeface="Inter" pitchFamily="34" charset="-120"/>
+              </a:rPr>
+              <a:t>26 · ADABIYOT TAHLILI</a:t>
+            </a:r>
+            <a:endParaRPr lang="en-US" sz="1200" dirty="0"/>
+          </a:p>
+        </p:txBody>
+      </p:sp>
+      <p:sp>
+        <p:nvSpPr>
+          <p:cNvPr id="3" name="Text 1"/>
+          <p:cNvSpPr/>
+          <p:nvPr>
+            <p:ph type="title"/>
+          </p:nvPr>
+        </p:nvSpPr>
+        <p:spPr>
+          <a:xfrm>
+            <a:off x="812800" y="1127720"/>
+            <a:ext cx="10883392" cy="472430"/>
+          </a:xfrm>
+          <a:prstGeom prst="rect">
+            <a:avLst/>
+          </a:prstGeom>
+          <a:noFill/>
+          <a:ln/>
+        </p:spPr>
+        <p:txBody>
+          <a:bodyPr wrap="square" lIns="0" tIns="0" rIns="0" bIns="0" rtlCol="0" anchor="t">
+            <a:normAutofit/>
+          </a:bodyPr>
+          <a:lstStyle/>
+          <a:p>
+            <a:pPr algn="l" indent="0" marL="0">
+              <a:lnSpc>
+                <a:spcPts val="3520"/>
+              </a:lnSpc>
+              <a:buNone/>
+            </a:pPr>
+            <a:r>
+              <a:rPr lang="en-US" sz="3200" b="0" i="0" dirty="0">
+                <a:solidFill>
+                  <a:srgbClr val="1D2A24"/>
+                </a:solidFill>
+                <a:latin typeface="Source Serif 4" pitchFamily="18" charset="0"/>
+                <a:ea typeface="Source Serif 4" pitchFamily="18" charset="-122"/>
+                <a:cs typeface="Source Serif 4" pitchFamily="18" charset="-120"/>
+              </a:rPr>
+              <a:t>Markaziy Fargʻona tuproqlari: oldingi tadqiqot</a:t>
+            </a:r>
+            <a:endParaRPr lang="en-US" sz="3200" dirty="0"/>
+          </a:p>
+        </p:txBody>
+      </p:sp>
+      <p:sp>
+        <p:nvSpPr>
+          <p:cNvPr id="6" name="Text 3"/>
+          <p:cNvSpPr/>
+          <p:nvPr/>
+        </p:nvSpPr>
+        <p:spPr>
+          <a:xfrm>
+            <a:off x="11137950" y="6238280"/>
+            <a:ext cx="241250" cy="238720"/>
+          </a:xfrm>
+          <a:prstGeom prst="rect">
+            <a:avLst/>
+          </a:prstGeom>
+          <a:noFill/>
+          <a:ln/>
+        </p:spPr>
+        <p:txBody>
+          <a:bodyPr wrap="square" lIns="0" tIns="0" rIns="0" bIns="0" rtlCol="0" anchor="t">
+            <a:normAutofit/>
+          </a:bodyPr>
+          <a:lstStyle/>
+          <a:p>
+            <a:pPr algn="r" indent="0" marL="0">
+              <a:lnSpc>
+                <a:spcPts val="1680"/>
+              </a:lnSpc>
+              <a:buNone/>
+            </a:pPr>
+            <a:r>
+              <a:rPr lang="en-US" sz="1200" dirty="0">
+                <a:solidFill>
+                  <a:srgbClr val="5F6B64"/>
+                </a:solidFill>
+                <a:latin typeface="Inter" pitchFamily="34" charset="0"/>
+                <a:ea typeface="Inter" pitchFamily="34" charset="-122"/>
+                <a:cs typeface="Inter" pitchFamily="34" charset="-120"/>
+              </a:rPr>
+              <a:t>27</a:t>
+            </a:r>
+            <a:endParaRPr lang="en-US" sz="1200" dirty="0"/>
+          </a:p>
+        </p:txBody>
+      </p:sp>
+      <p:sp>
+        <p:nvSpPr>
+          <p:cNvPr id="7" name="Rounded Rectangle 6"/>
+          <p:cNvSpPr/>
+          <p:nvPr/>
+        </p:nvSpPr>
+        <p:spPr>
+          <a:xfrm>
+            <a:off x="812800" y="1830000"/>
+            <a:ext cx="5341696" cy="1700000"/>
+          </a:xfrm>
+          <a:prstGeom prst="roundRect">
+            <a:avLst>
+              <a:gd name="adj" fmla="val 5000"/>
+            </a:avLst>
+          </a:prstGeom>
+          <a:solidFill>
+            <a:srgbClr val="FBF9F4"/>
+          </a:solidFill>
+          <a:ln w="6350">
+            <a:solidFill>
+              <a:srgbClr val="D9D2C3"/>
+            </a:solidFill>
+          </a:ln>
+          <a:effectLst/>
+        </p:spPr>
+        <p:style>
+          <a:lnRef idx="1">
+            <a:schemeClr val="accent1"/>
+          </a:lnRef>
+          <a:fillRef idx="3">
+            <a:schemeClr val="accent1"/>
+          </a:fillRef>
+          <a:effectRef idx="2">
+            <a:schemeClr val="accent1"/>
+          </a:effectRef>
+          <a:fontRef idx="minor">
+            <a:schemeClr val="lt1"/>
+          </a:fontRef>
+        </p:style>
+        <p:txBody>
+          <a:bodyPr rtlCol="0" anchor="ctr"/>
+          <a:lstStyle/>
+          <a:p>
+            <a:pPr algn="ctr"/>
+          </a:p>
+        </p:txBody>
+      </p:sp>
+      <p:sp>
+        <p:nvSpPr>
+          <p:cNvPr id="8" name="TextBox 7"/>
+          <p:cNvSpPr txBox="1"/>
+          <p:nvPr/>
+        </p:nvSpPr>
+        <p:spPr>
+          <a:xfrm>
+            <a:off x="1062800" y="2000000"/>
+            <a:ext cx="4841696" cy="480000"/>
+          </a:xfrm>
+          <a:prstGeom prst="rect">
+            <a:avLst/>
+          </a:prstGeom>
+          <a:noFill/>
+        </p:spPr>
+        <p:txBody>
+          <a:bodyPr wrap="square" lIns="0" rIns="0" tIns="0" bIns="0" anchor="t">
+            <a:spAutoFit/>
+          </a:bodyPr>
+          <a:lstStyle/>
+          <a:p>
+            <a:pPr algn="l"/>
+            <a:r>
+              <a:rPr sz="2800" b="0">
+                <a:solidFill>
+                  <a:srgbClr val="A4521D"/>
+                </a:solidFill>
+                <a:latin typeface="Source Serif 4"/>
+              </a:rPr>
+              <a:t>0,86–0,96</a:t>
+            </a:r>
+          </a:p>
+        </p:txBody>
+      </p:sp>
+      <p:sp>
+        <p:nvSpPr>
+          <p:cNvPr id="9" name="TextBox 8"/>
+          <p:cNvSpPr txBox="1"/>
+          <p:nvPr/>
+        </p:nvSpPr>
+        <p:spPr>
+          <a:xfrm>
+            <a:off x="1062800" y="2610000"/>
+            <a:ext cx="4841696" cy="800000"/>
+          </a:xfrm>
+          <a:prstGeom prst="rect">
+            <a:avLst/>
+          </a:prstGeom>
+          <a:noFill/>
+        </p:spPr>
+        <p:txBody>
+          <a:bodyPr wrap="square" lIns="0" rIns="0" tIns="0" bIns="0" anchor="t">
+            <a:spAutoFit/>
+          </a:bodyPr>
+          <a:lstStyle/>
+          <a:p>
+            <a:pPr algn="l"/>
+            <a:r>
+              <a:rPr sz="1300" b="0">
+                <a:solidFill>
+                  <a:srgbClr val="4C5852"/>
+                </a:solidFill>
+                <a:latin typeface="Inter"/>
+              </a:rPr>
+              <a:t>Gumus miqdori bilan gʻoʻza hosildorligi orasidagi korrelyatsiya (r): oʻtloqi 0,92, oʻtloqi-saz 0,96, choʻl-oʻtloqi 0,86</a:t>
+            </a:r>
+          </a:p>
+        </p:txBody>
+      </p:sp>
+      <p:sp>
+        <p:nvSpPr>
+          <p:cNvPr id="10" name="Rounded Rectangle 9"/>
+          <p:cNvSpPr/>
+          <p:nvPr/>
+        </p:nvSpPr>
+        <p:spPr>
+          <a:xfrm>
+            <a:off x="6354496" y="1830000"/>
+            <a:ext cx="5341696" cy="1700000"/>
+          </a:xfrm>
+          <a:prstGeom prst="roundRect">
+            <a:avLst>
+              <a:gd name="adj" fmla="val 5000"/>
+            </a:avLst>
+          </a:prstGeom>
+          <a:solidFill>
+            <a:srgbClr val="FBF9F4"/>
+          </a:solidFill>
+          <a:ln w="6350">
+            <a:solidFill>
+              <a:srgbClr val="D9D2C3"/>
+            </a:solidFill>
+          </a:ln>
+          <a:effectLst/>
+        </p:spPr>
+        <p:style>
+          <a:lnRef idx="1">
+            <a:schemeClr val="accent1"/>
+          </a:lnRef>
+          <a:fillRef idx="3">
+            <a:schemeClr val="accent1"/>
+          </a:fillRef>
+          <a:effectRef idx="2">
+            <a:schemeClr val="accent1"/>
+          </a:effectRef>
+          <a:fontRef idx="minor">
+            <a:schemeClr val="lt1"/>
+          </a:fontRef>
+        </p:style>
+        <p:txBody>
+          <a:bodyPr rtlCol="0" anchor="ctr"/>
+          <a:lstStyle/>
+          <a:p>
+            <a:pPr algn="ctr"/>
+          </a:p>
+        </p:txBody>
+      </p:sp>
+      <p:sp>
+        <p:nvSpPr>
+          <p:cNvPr id="11" name="TextBox 10"/>
+          <p:cNvSpPr txBox="1"/>
+          <p:nvPr/>
+        </p:nvSpPr>
+        <p:spPr>
+          <a:xfrm>
+            <a:off x="6604496" y="2000000"/>
+            <a:ext cx="4841696" cy="480000"/>
+          </a:xfrm>
+          <a:prstGeom prst="rect">
+            <a:avLst/>
+          </a:prstGeom>
+          <a:noFill/>
+        </p:spPr>
+        <p:txBody>
+          <a:bodyPr wrap="square" lIns="0" rIns="0" tIns="0" bIns="0" anchor="t">
+            <a:spAutoFit/>
+          </a:bodyPr>
+          <a:lstStyle/>
+          <a:p>
+            <a:pPr algn="l"/>
+            <a:r>
+              <a:rPr sz="2800" b="0">
+                <a:solidFill>
+                  <a:srgbClr val="2C6A85"/>
+                </a:solidFill>
+                <a:latin typeface="Source Serif 4"/>
+              </a:rPr>
+              <a:t>1,5–2 m</a:t>
+            </a:r>
+          </a:p>
+        </p:txBody>
+      </p:sp>
+      <p:sp>
+        <p:nvSpPr>
+          <p:cNvPr id="12" name="TextBox 11"/>
+          <p:cNvSpPr txBox="1"/>
+          <p:nvPr/>
+        </p:nvSpPr>
+        <p:spPr>
+          <a:xfrm>
+            <a:off x="6604496" y="2610000"/>
+            <a:ext cx="4841696" cy="800000"/>
+          </a:xfrm>
+          <a:prstGeom prst="rect">
+            <a:avLst/>
+          </a:prstGeom>
+          <a:noFill/>
+        </p:spPr>
+        <p:txBody>
+          <a:bodyPr wrap="square" lIns="0" rIns="0" tIns="0" bIns="0" anchor="t">
+            <a:spAutoFit/>
+          </a:bodyPr>
+          <a:lstStyle/>
+          <a:p>
+            <a:pPr algn="l"/>
+            <a:r>
+              <a:rPr sz="1300" b="0">
+                <a:solidFill>
+                  <a:srgbClr val="4C5852"/>
+                </a:solidFill>
+                <a:latin typeface="Inter"/>
+              </a:rPr>
+              <a:t>Qoʻshtepa tumanida botqoq-oʻtloqi tuproqlarda sizot suvlari sathi pasaygan va tuproqlar oʻtloqi tomon oʻzgargan</a:t>
+            </a:r>
+          </a:p>
+        </p:txBody>
+      </p:sp>
+      <p:sp>
+        <p:nvSpPr>
+          <p:cNvPr id="13" name="Rounded Rectangle 12"/>
+          <p:cNvSpPr/>
+          <p:nvPr/>
+        </p:nvSpPr>
+        <p:spPr>
+          <a:xfrm>
+            <a:off x="812800" y="3710000"/>
+            <a:ext cx="5341696" cy="1700000"/>
+          </a:xfrm>
+          <a:prstGeom prst="roundRect">
+            <a:avLst>
+              <a:gd name="adj" fmla="val 5000"/>
+            </a:avLst>
+          </a:prstGeom>
+          <a:solidFill>
+            <a:srgbClr val="FBF9F4"/>
+          </a:solidFill>
+          <a:ln w="6350">
+            <a:solidFill>
+              <a:srgbClr val="D9D2C3"/>
+            </a:solidFill>
+          </a:ln>
+          <a:effectLst/>
+        </p:spPr>
+        <p:style>
+          <a:lnRef idx="1">
+            <a:schemeClr val="accent1"/>
+          </a:lnRef>
+          <a:fillRef idx="3">
+            <a:schemeClr val="accent1"/>
+          </a:fillRef>
+          <a:effectRef idx="2">
+            <a:schemeClr val="accent1"/>
+          </a:effectRef>
+          <a:fontRef idx="minor">
+            <a:schemeClr val="lt1"/>
+          </a:fontRef>
+        </p:style>
+        <p:txBody>
+          <a:bodyPr rtlCol="0" anchor="ctr"/>
+          <a:lstStyle/>
+          <a:p>
+            <a:pPr algn="ctr"/>
+          </a:p>
+        </p:txBody>
+      </p:sp>
+      <p:sp>
+        <p:nvSpPr>
+          <p:cNvPr id="14" name="TextBox 13"/>
+          <p:cNvSpPr txBox="1"/>
+          <p:nvPr/>
+        </p:nvSpPr>
+        <p:spPr>
+          <a:xfrm>
+            <a:off x="1062800" y="3880000"/>
+            <a:ext cx="4841696" cy="480000"/>
+          </a:xfrm>
+          <a:prstGeom prst="rect">
+            <a:avLst/>
+          </a:prstGeom>
+          <a:noFill/>
+        </p:spPr>
+        <p:txBody>
+          <a:bodyPr wrap="square" lIns="0" rIns="0" tIns="0" bIns="0" anchor="t">
+            <a:spAutoFit/>
+          </a:bodyPr>
+          <a:lstStyle/>
+          <a:p>
+            <a:pPr algn="l"/>
+            <a:r>
+              <a:rPr sz="2800" b="0">
+                <a:solidFill>
+                  <a:srgbClr val="2C6A85"/>
+                </a:solidFill>
+                <a:latin typeface="Source Serif 4"/>
+              </a:rPr>
+              <a:t>1999 → 2023</a:t>
+            </a:r>
+          </a:p>
+        </p:txBody>
+      </p:sp>
+      <p:sp>
+        <p:nvSpPr>
+          <p:cNvPr id="15" name="TextBox 14"/>
+          <p:cNvSpPr txBox="1"/>
+          <p:nvPr/>
+        </p:nvSpPr>
+        <p:spPr>
+          <a:xfrm>
+            <a:off x="1062800" y="4490000"/>
+            <a:ext cx="4841696" cy="800000"/>
+          </a:xfrm>
+          <a:prstGeom prst="rect">
+            <a:avLst/>
+          </a:prstGeom>
+          <a:noFill/>
+        </p:spPr>
+        <p:txBody>
+          <a:bodyPr wrap="square" lIns="0" rIns="0" tIns="0" bIns="0" anchor="t">
+            <a:spAutoFit/>
+          </a:bodyPr>
+          <a:lstStyle/>
+          <a:p>
+            <a:pPr algn="l"/>
+            <a:r>
+              <a:rPr sz="1300" b="0">
+                <a:solidFill>
+                  <a:srgbClr val="4C5852"/>
+                </a:solidFill>
+                <a:latin typeface="Inter"/>
+              </a:rPr>
+              <a:t>Choʻl-oʻtloqi tuproqlarda gumus 0,19–0,51% dan 0,39–0,92% gacha oshgan; bonitet 1,0–4,7 ballga yaxshilangan</a:t>
+            </a:r>
+          </a:p>
+        </p:txBody>
+      </p:sp>
+      <p:sp>
+        <p:nvSpPr>
+          <p:cNvPr id="16" name="Rounded Rectangle 15"/>
+          <p:cNvSpPr/>
+          <p:nvPr/>
+        </p:nvSpPr>
+        <p:spPr>
+          <a:xfrm>
+            <a:off x="6354496" y="3710000"/>
+            <a:ext cx="5341696" cy="1700000"/>
+          </a:xfrm>
+          <a:prstGeom prst="roundRect">
+            <a:avLst>
+              <a:gd name="adj" fmla="val 5000"/>
+            </a:avLst>
+          </a:prstGeom>
+          <a:solidFill>
+            <a:srgbClr val="FBF9F4"/>
+          </a:solidFill>
+          <a:ln w="6350">
+            <a:solidFill>
+              <a:srgbClr val="D9D2C3"/>
+            </a:solidFill>
+          </a:ln>
+          <a:effectLst/>
+        </p:spPr>
+        <p:style>
+          <a:lnRef idx="1">
+            <a:schemeClr val="accent1"/>
+          </a:lnRef>
+          <a:fillRef idx="3">
+            <a:schemeClr val="accent1"/>
+          </a:fillRef>
+          <a:effectRef idx="2">
+            <a:schemeClr val="accent1"/>
+          </a:effectRef>
+          <a:fontRef idx="minor">
+            <a:schemeClr val="lt1"/>
+          </a:fontRef>
+        </p:style>
+        <p:txBody>
+          <a:bodyPr rtlCol="0" anchor="ctr"/>
+          <a:lstStyle/>
+          <a:p>
+            <a:pPr algn="ctr"/>
+          </a:p>
+        </p:txBody>
+      </p:sp>
+      <p:sp>
+        <p:nvSpPr>
+          <p:cNvPr id="17" name="TextBox 16"/>
+          <p:cNvSpPr txBox="1"/>
+          <p:nvPr/>
+        </p:nvSpPr>
+        <p:spPr>
+          <a:xfrm>
+            <a:off x="6604496" y="3880000"/>
+            <a:ext cx="4841696" cy="480000"/>
+          </a:xfrm>
+          <a:prstGeom prst="rect">
+            <a:avLst/>
+          </a:prstGeom>
+          <a:noFill/>
+        </p:spPr>
+        <p:txBody>
+          <a:bodyPr wrap="square" lIns="0" rIns="0" tIns="0" bIns="0" anchor="t">
+            <a:spAutoFit/>
+          </a:bodyPr>
+          <a:lstStyle/>
+          <a:p>
+            <a:pPr algn="l"/>
+            <a:r>
+              <a:rPr sz="2800" b="0">
+                <a:solidFill>
+                  <a:srgbClr val="A4521D"/>
+                </a:solidFill>
+                <a:latin typeface="Source Serif 4"/>
+              </a:rPr>
+              <a:t>96,7–199,9 t/ga</a:t>
+            </a:r>
+          </a:p>
+        </p:txBody>
+      </p:sp>
+      <p:sp>
+        <p:nvSpPr>
+          <p:cNvPr id="18" name="TextBox 17"/>
+          <p:cNvSpPr txBox="1"/>
+          <p:nvPr/>
+        </p:nvSpPr>
+        <p:spPr>
+          <a:xfrm>
+            <a:off x="6604496" y="4490000"/>
+            <a:ext cx="4841696" cy="800000"/>
+          </a:xfrm>
+          <a:prstGeom prst="rect">
+            <a:avLst/>
+          </a:prstGeom>
+          <a:noFill/>
+        </p:spPr>
+        <p:txBody>
+          <a:bodyPr wrap="square" lIns="0" rIns="0" tIns="0" bIns="0" anchor="t">
+            <a:spAutoFit/>
+          </a:bodyPr>
+          <a:lstStyle/>
+          <a:p>
+            <a:pPr algn="l"/>
+            <a:r>
+              <a:rPr sz="1300" b="0">
+                <a:solidFill>
+                  <a:srgbClr val="4C5852"/>
+                </a:solidFill>
+                <a:latin typeface="Inter"/>
+              </a:rPr>
+              <a:t>Tuproqning 0–1 m qatlamida tuzlar zahirasi; 1:10 000 miqyosli shoʻrlanish kartogrammalari tuzilgan</a:t>
+            </a:r>
+          </a:p>
+        </p:txBody>
+      </p:sp>
+      <p:sp>
+        <p:nvSpPr>
+          <p:cNvPr id="19" name="TextBox 18"/>
+          <p:cNvSpPr txBox="1"/>
+          <p:nvPr/>
+        </p:nvSpPr>
+        <p:spPr>
+          <a:xfrm>
+            <a:off x="812800" y="5700000"/>
+            <a:ext cx="10883392" cy="420000"/>
+          </a:xfrm>
+          <a:prstGeom prst="rect">
+            <a:avLst/>
+          </a:prstGeom>
+          <a:noFill/>
+        </p:spPr>
+        <p:txBody>
+          <a:bodyPr wrap="square" lIns="0" rIns="0" tIns="0" bIns="0" anchor="t">
+            <a:spAutoFit/>
+          </a:bodyPr>
+          <a:lstStyle/>
+          <a:p>
+            <a:pPr algn="l"/>
+            <a:r>
+              <a:rPr sz="1200" b="0">
+                <a:solidFill>
+                  <a:srgbClr val="4C5852"/>
+                </a:solidFill>
+                <a:latin typeface="Inter"/>
+              </a:rPr>
+              <a:t>Fargʻona viloyati misolida; ish GAT texnologiyalari asosida gipsli tuproqlar xaritasi loyihasi doirasida bajarilgan.</a:t>
+            </a:r>
+          </a:p>
+        </p:txBody>
+      </p:sp>
+      <p:sp>
+        <p:nvSpPr>
+          <p:cNvPr id="20" name="TextBox 19"/>
+          <p:cNvSpPr txBox="1"/>
+          <p:nvPr/>
+        </p:nvSpPr>
+        <p:spPr>
+          <a:xfrm>
+            <a:off x="812800" y="6238280"/>
+            <a:ext cx="9800000" cy="240000"/>
+          </a:xfrm>
+          <a:prstGeom prst="rect">
+            <a:avLst/>
+          </a:prstGeom>
+          <a:noFill/>
+        </p:spPr>
+        <p:txBody>
+          <a:bodyPr wrap="square" lIns="0" rIns="0" tIns="0" bIns="0" anchor="t">
+            <a:spAutoFit/>
+          </a:bodyPr>
+          <a:lstStyle/>
+          <a:p>
+            <a:pPr algn="l"/>
+            <a:r>
+              <a:rPr sz="1200" b="0">
+                <a:solidFill>
+                  <a:srgbClr val="5F6B64"/>
+                </a:solidFill>
+                <a:latin typeface="Inter"/>
+              </a:rPr>
+              <a:t>Manba: M.K.Pulatov, PhD avtoreferati (Markaziy Fargʻona tuproqlari), Toshkent, 2025</a:t>
             </a:r>
           </a:p>
         </p:txBody>

</xml_diff>

<commit_message>
Add Fergana soil humus, salt-leaching dynamics and reservoir status slides
Co-Authored-By: Claude Sonnet 5.5 <noreply@anthropic.com>
Claude-Session: https://claude.ai/code/session_01M4MZatV28utL9zTp7saaUz
</commit_message>
<xml_diff>
--- a/Garbiy_Farg_ona_tuproqlari_GAT_asosida_bashoratlash.pptx
+++ b/Garbiy_Farg_ona_tuproqlari_GAT_asosida_bashoratlash.pptx
@@ -32,6 +32,9 @@
     <p:sldId id="287" r:id="rId38"/>
     <p:sldId id="288" r:id="rId39"/>
     <p:sldId id="289" r:id="rId40"/>
+    <p:sldId id="290" r:id="rId41"/>
+    <p:sldId id="291" r:id="rId42"/>
+    <p:sldId id="292" r:id="rId43"/>
     <p:sldId id="265" r:id="rId11"/>
     <p:sldId id="266" r:id="rId12"/>
     <p:sldId id="267" r:id="rId13"/>
@@ -3653,6 +3656,995 @@
         <c:crosses val="autoZero"/>
       </c:valAx>
     </c:plotArea>
+    <c:dispBlanksAs val="gap"/>
+  </c:chart>
+  <c:txPr>
+    <a:bodyPr/>
+    <a:lstStyle/>
+    <a:p>
+      <a:pPr>
+        <a:defRPr sz="1200">
+          <a:solidFill>
+            <a:srgbClr val="4C5852"/>
+          </a:solidFill>
+          <a:latin typeface="Inter"/>
+        </a:defRPr>
+      </a:pPr>
+      <a:endParaRPr lang="en-US"/>
+    </a:p>
+  </c:txPr>
+  <c:externalData r:id="rId1">
+    <c:autoUpdate val="0"/>
+  </c:externalData>
+</c:chartSpace>
+</file>
+
+<file path=ppt/charts/chart20.xml><?xml version="1.0" encoding="utf-8"?>
+<c:chartSpace xmlns:c="http://schemas.openxmlformats.org/drawingml/2006/chart" xmlns:a="http://schemas.openxmlformats.org/drawingml/2006/main" xmlns:r="http://schemas.openxmlformats.org/officeDocument/2006/relationships">
+  <c:date1904 val="0"/>
+  <c:chart>
+    <c:autoTitleDeleted val="1"/>
+    <c:plotArea>
+      <c:barChart>
+        <c:barDir val="bar"/>
+        <c:grouping val="clustered"/>
+        <c:ser>
+          <c:idx val="0"/>
+          <c:order val="0"/>
+          <c:tx>
+            <c:strRef>
+              <c:f>Sheet1!$B$1</c:f>
+              <c:strCache>
+                <c:ptCount val="1"/>
+                <c:pt idx="0">
+                  <c:v>Ulush</c:v>
+                </c:pt>
+              </c:strCache>
+            </c:strRef>
+          </c:tx>
+          <c:spPr>
+            <a:solidFill>
+              <a:srgbClr val="2C6A85"/>
+            </a:solidFill>
+          </c:spPr>
+          <c:dPt>
+            <c:idx val="0"/>
+            <c:spPr>
+              <a:solidFill>
+                <a:srgbClr val="A4521D"/>
+              </a:solidFill>
+            </c:spPr>
+          </c:dPt>
+          <c:dPt>
+            <c:idx val="9"/>
+            <c:spPr>
+              <a:solidFill>
+                <a:srgbClr val="A9C4D1"/>
+              </a:solidFill>
+            </c:spPr>
+          </c:dPt>
+          <c:cat>
+            <c:strRef>
+              <c:f>Sheet1!$A$2:$A$11</c:f>
+              <c:strCache>
+                <c:ptCount val="10"/>
+                <c:pt idx="0">
+                  <c:v>Dangʻara</c:v>
+                </c:pt>
+                <c:pt idx="1">
+                  <c:v>Uchkoʻprik</c:v>
+                </c:pt>
+                <c:pt idx="2">
+                  <c:v>Yozyovon</c:v>
+                </c:pt>
+                <c:pt idx="3">
+                  <c:v>Bogʻdod</c:v>
+                </c:pt>
+                <c:pt idx="4">
+                  <c:v>Buvayda</c:v>
+                </c:pt>
+                <c:pt idx="5">
+                  <c:v>Rishton</c:v>
+                </c:pt>
+                <c:pt idx="6">
+                  <c:v>Qoʻshtepa</c:v>
+                </c:pt>
+                <c:pt idx="7">
+                  <c:v>Oltiariq</c:v>
+                </c:pt>
+                <c:pt idx="8">
+                  <c:v>Toshloq</c:v>
+                </c:pt>
+                <c:pt idx="9">
+                  <c:v>Quva</c:v>
+                </c:pt>
+              </c:strCache>
+            </c:strRef>
+          </c:cat>
+          <c:val>
+            <c:numRef>
+              <c:f>Sheet1!$B$2:$B$11</c:f>
+              <c:numCache>
+                <c:formatCode>General</c:formatCode>
+                <c:ptCount val="10"/>
+                <c:pt idx="0">
+                  <c:v>64.0</c:v>
+                </c:pt>
+                <c:pt idx="1">
+                  <c:v>57.3</c:v>
+                </c:pt>
+                <c:pt idx="2">
+                  <c:v>56.8</c:v>
+                </c:pt>
+                <c:pt idx="3">
+                  <c:v>53.3</c:v>
+                </c:pt>
+                <c:pt idx="4">
+                  <c:v>53.0</c:v>
+                </c:pt>
+                <c:pt idx="5">
+                  <c:v>46.7</c:v>
+                </c:pt>
+                <c:pt idx="6">
+                  <c:v>40.0</c:v>
+                </c:pt>
+                <c:pt idx="7">
+                  <c:v>33.5</c:v>
+                </c:pt>
+                <c:pt idx="8">
+                  <c:v>24.6</c:v>
+                </c:pt>
+                <c:pt idx="9">
+                  <c:v>17.2</c:v>
+                </c:pt>
+              </c:numCache>
+            </c:numRef>
+          </c:val>
+        </c:ser>
+        <c:dLbls>
+          <c:numFmt formatCode="0.0&quot;%&quot;" sourceLinked="0"/>
+          <c:txPr>
+            <a:bodyPr/>
+            <a:lstStyle/>
+            <a:p>
+              <a:pPr>
+                <a:defRPr sz="1200">
+                  <a:solidFill>
+                    <a:srgbClr val="1D2A24"/>
+                  </a:solidFill>
+                  <a:latin typeface="Inter"/>
+                </a:defRPr>
+              </a:pPr>
+            </a:p>
+          </c:txPr>
+          <c:dLblPos val="outEnd"/>
+          <c:showLegendKey val="0"/>
+          <c:showVal val="1"/>
+          <c:showCatName val="0"/>
+          <c:showSerName val="0"/>
+          <c:showPercent val="0"/>
+          <c:showBubbleSize val="0"/>
+          <c:showLeaderLines val="1"/>
+        </c:dLbls>
+        <c:gapWidth val="35"/>
+        <c:axId val="-2068027336"/>
+        <c:axId val="-2113994440"/>
+      </c:barChart>
+      <c:catAx>
+        <c:axId val="-2068027336"/>
+        <c:scaling>
+          <c:orientation val="maxMin"/>
+        </c:scaling>
+        <c:delete val="0"/>
+        <c:axPos val="l"/>
+        <c:majorTickMark val="out"/>
+        <c:minorTickMark val="none"/>
+        <c:tickLblPos val="nextTo"/>
+        <c:spPr>
+          <a:ln>
+            <a:solidFill>
+              <a:srgbClr val="B5B2AD"/>
+            </a:solidFill>
+          </a:ln>
+        </c:spPr>
+        <c:txPr>
+          <a:bodyPr/>
+          <a:lstStyle/>
+          <a:p>
+            <a:pPr>
+              <a:defRPr sz="1200">
+                <a:solidFill>
+                  <a:srgbClr val="4C5852"/>
+                </a:solidFill>
+                <a:latin typeface="Inter"/>
+              </a:defRPr>
+            </a:pPr>
+          </a:p>
+        </c:txPr>
+        <c:crossAx val="-2113994440"/>
+        <c:crosses val="autoZero"/>
+        <c:auto val="1"/>
+        <c:lblAlgn val="ctr"/>
+        <c:lblOffset val="100"/>
+        <c:noMultiLvlLbl val="0"/>
+      </c:catAx>
+      <c:valAx>
+        <c:axId val="-2113994440"/>
+        <c:scaling>
+          <c:max val="75.0"/>
+          <c:min val="0.0"/>
+        </c:scaling>
+        <c:delete/>
+        <c:axPos val="b"/>
+        <c:majorTickMark val="out"/>
+        <c:minorTickMark val="none"/>
+        <c:tickLblPos val="nextTo"/>
+        <c:crossAx val="-2068027336"/>
+        <c:crosses val="autoZero"/>
+      </c:valAx>
+    </c:plotArea>
+    <c:dispBlanksAs val="gap"/>
+  </c:chart>
+  <c:txPr>
+    <a:bodyPr/>
+    <a:lstStyle/>
+    <a:p>
+      <a:pPr>
+        <a:defRPr sz="1200">
+          <a:solidFill>
+            <a:srgbClr val="4C5852"/>
+          </a:solidFill>
+          <a:latin typeface="Inter"/>
+        </a:defRPr>
+      </a:pPr>
+      <a:endParaRPr lang="en-US"/>
+    </a:p>
+  </c:txPr>
+  <c:externalData r:id="rId1">
+    <c:autoUpdate val="0"/>
+  </c:externalData>
+</c:chartSpace>
+</file>
+
+<file path=ppt/charts/chart21.xml><?xml version="1.0" encoding="utf-8"?>
+<c:chartSpace xmlns:c="http://schemas.openxmlformats.org/drawingml/2006/chart" xmlns:a="http://schemas.openxmlformats.org/drawingml/2006/main" xmlns:r="http://schemas.openxmlformats.org/officeDocument/2006/relationships">
+  <c:date1904 val="0"/>
+  <c:chart>
+    <c:autoTitleDeleted val="1"/>
+    <c:plotArea>
+      <c:barChart>
+        <c:barDir val="col"/>
+        <c:grouping val="stacked"/>
+        <c:ser>
+          <c:idx val="0"/>
+          <c:order val="0"/>
+          <c:tx>
+            <c:strRef>
+              <c:f>Sheet1!$B$1</c:f>
+              <c:strCache>
+                <c:ptCount val="1"/>
+                <c:pt idx="0">
+                  <c:v>Kuchsiz shoʻrlangan</c:v>
+                </c:pt>
+              </c:strCache>
+            </c:strRef>
+          </c:tx>
+          <c:spPr>
+            <a:solidFill>
+              <a:srgbClr val="A9C4D1"/>
+            </a:solidFill>
+          </c:spPr>
+          <c:cat>
+            <c:strRef>
+              <c:f>Sheet1!$A$2:$A$4</c:f>
+              <c:strCache>
+                <c:ptCount val="3"/>
+                <c:pt idx="0">
+                  <c:v>2023–24</c:v>
+                </c:pt>
+                <c:pt idx="1">
+                  <c:v>2024–25</c:v>
+                </c:pt>
+                <c:pt idx="2">
+                  <c:v>2025–26 (reja)</c:v>
+                </c:pt>
+              </c:strCache>
+            </c:strRef>
+          </c:cat>
+          <c:val>
+            <c:numRef>
+              <c:f>Sheet1!$B$2:$B$4</c:f>
+              <c:numCache>
+                <c:formatCode>General</c:formatCode>
+                <c:ptCount val="3"/>
+                <c:pt idx="0">
+                  <c:v>23.0</c:v>
+                </c:pt>
+                <c:pt idx="1">
+                  <c:v>28.9</c:v>
+                </c:pt>
+                <c:pt idx="2">
+                  <c:v>0</c:v>
+                </c:pt>
+              </c:numCache>
+            </c:numRef>
+          </c:val>
+        </c:ser>
+        <c:ser>
+          <c:idx val="1"/>
+          <c:order val="1"/>
+          <c:tx>
+            <c:strRef>
+              <c:f>Sheet1!$C$1</c:f>
+              <c:strCache>
+                <c:ptCount val="1"/>
+                <c:pt idx="0">
+                  <c:v>Oʻrta shoʻrlangan</c:v>
+                </c:pt>
+              </c:strCache>
+            </c:strRef>
+          </c:tx>
+          <c:spPr>
+            <a:solidFill>
+              <a:srgbClr val="2C6A85"/>
+            </a:solidFill>
+          </c:spPr>
+          <c:cat>
+            <c:strRef>
+              <c:f>Sheet1!$A$2:$A$4</c:f>
+              <c:strCache>
+                <c:ptCount val="3"/>
+                <c:pt idx="0">
+                  <c:v>2023–24</c:v>
+                </c:pt>
+                <c:pt idx="1">
+                  <c:v>2024–25</c:v>
+                </c:pt>
+                <c:pt idx="2">
+                  <c:v>2025–26 (reja)</c:v>
+                </c:pt>
+              </c:strCache>
+            </c:strRef>
+          </c:cat>
+          <c:val>
+            <c:numRef>
+              <c:f>Sheet1!$C$2:$C$4</c:f>
+              <c:numCache>
+                <c:formatCode>General</c:formatCode>
+                <c:ptCount val="3"/>
+                <c:pt idx="0">
+                  <c:v>7.7</c:v>
+                </c:pt>
+                <c:pt idx="1">
+                  <c:v>3.9</c:v>
+                </c:pt>
+                <c:pt idx="2">
+                  <c:v>0</c:v>
+                </c:pt>
+              </c:numCache>
+            </c:numRef>
+          </c:val>
+        </c:ser>
+        <c:ser>
+          <c:idx val="2"/>
+          <c:order val="2"/>
+          <c:tx>
+            <c:strRef>
+              <c:f>Sheet1!$D$1</c:f>
+              <c:strCache>
+                <c:ptCount val="1"/>
+                <c:pt idx="0">
+                  <c:v>Kuchli shoʻrlangan</c:v>
+                </c:pt>
+              </c:strCache>
+            </c:strRef>
+          </c:tx>
+          <c:spPr>
+            <a:solidFill>
+              <a:srgbClr val="A4521D"/>
+            </a:solidFill>
+          </c:spPr>
+          <c:cat>
+            <c:strRef>
+              <c:f>Sheet1!$A$2:$A$4</c:f>
+              <c:strCache>
+                <c:ptCount val="3"/>
+                <c:pt idx="0">
+                  <c:v>2023–24</c:v>
+                </c:pt>
+                <c:pt idx="1">
+                  <c:v>2024–25</c:v>
+                </c:pt>
+                <c:pt idx="2">
+                  <c:v>2025–26 (reja)</c:v>
+                </c:pt>
+              </c:strCache>
+            </c:strRef>
+          </c:cat>
+          <c:val>
+            <c:numRef>
+              <c:f>Sheet1!$D$2:$D$4</c:f>
+              <c:numCache>
+                <c:formatCode>General</c:formatCode>
+                <c:ptCount val="3"/>
+                <c:pt idx="0">
+                  <c:v>2.9</c:v>
+                </c:pt>
+                <c:pt idx="1">
+                  <c:v>0.3</c:v>
+                </c:pt>
+                <c:pt idx="2">
+                  <c:v>0</c:v>
+                </c:pt>
+              </c:numCache>
+            </c:numRef>
+          </c:val>
+        </c:ser>
+        <c:ser>
+          <c:idx val="3"/>
+          <c:order val="3"/>
+          <c:tx>
+            <c:strRef>
+              <c:f>Sheet1!$E$1</c:f>
+              <c:strCache>
+                <c:ptCount val="1"/>
+                <c:pt idx="0">
+                  <c:v>Tarkibi koʻrsatilmagan</c:v>
+                </c:pt>
+              </c:strCache>
+            </c:strRef>
+          </c:tx>
+          <c:spPr>
+            <a:solidFill>
+              <a:srgbClr val="B5B2AD"/>
+            </a:solidFill>
+          </c:spPr>
+          <c:cat>
+            <c:strRef>
+              <c:f>Sheet1!$A$2:$A$4</c:f>
+              <c:strCache>
+                <c:ptCount val="3"/>
+                <c:pt idx="0">
+                  <c:v>2023–24</c:v>
+                </c:pt>
+                <c:pt idx="1">
+                  <c:v>2024–25</c:v>
+                </c:pt>
+                <c:pt idx="2">
+                  <c:v>2025–26 (reja)</c:v>
+                </c:pt>
+              </c:strCache>
+            </c:strRef>
+          </c:cat>
+          <c:val>
+            <c:numRef>
+              <c:f>Sheet1!$E$2:$E$4</c:f>
+              <c:numCache>
+                <c:formatCode>General</c:formatCode>
+                <c:ptCount val="3"/>
+                <c:pt idx="0">
+                  <c:v>0</c:v>
+                </c:pt>
+                <c:pt idx="1">
+                  <c:v>0</c:v>
+                </c:pt>
+                <c:pt idx="2">
+                  <c:v>26.2</c:v>
+                </c:pt>
+              </c:numCache>
+            </c:numRef>
+          </c:val>
+        </c:ser>
+        <c:gapWidth val="40"/>
+        <c:overlap val="100"/>
+        <c:axId val="-2068027336"/>
+        <c:axId val="-2113994440"/>
+      </c:barChart>
+      <c:catAx>
+        <c:axId val="-2068027336"/>
+        <c:scaling>
+          <c:orientation val="minMax"/>
+        </c:scaling>
+        <c:delete val="0"/>
+        <c:axPos val="b"/>
+        <c:majorTickMark val="out"/>
+        <c:minorTickMark val="none"/>
+        <c:tickLblPos val="nextTo"/>
+        <c:spPr>
+          <a:ln>
+            <a:solidFill>
+              <a:srgbClr val="B5B2AD"/>
+            </a:solidFill>
+          </a:ln>
+        </c:spPr>
+        <c:txPr>
+          <a:bodyPr/>
+          <a:lstStyle/>
+          <a:p>
+            <a:pPr>
+              <a:defRPr sz="1200">
+                <a:solidFill>
+                  <a:srgbClr val="4C5852"/>
+                </a:solidFill>
+                <a:latin typeface="Inter"/>
+              </a:defRPr>
+            </a:pPr>
+          </a:p>
+        </c:txPr>
+        <c:crossAx val="-2113994440"/>
+        <c:crosses val="autoZero"/>
+        <c:auto val="1"/>
+        <c:lblAlgn val="ctr"/>
+        <c:lblOffset val="100"/>
+        <c:noMultiLvlLbl val="0"/>
+      </c:catAx>
+      <c:valAx>
+        <c:axId val="-2113994440"/>
+        <c:scaling>
+          <c:max val="40.0"/>
+          <c:min val="0.0"/>
+        </c:scaling>
+        <c:delete val="0"/>
+        <c:axPos val="l"/>
+        <c:majorGridlines>
+          <c:spPr>
+            <a:ln>
+              <a:solidFill>
+                <a:srgbClr val="D9D2C3"/>
+              </a:solidFill>
+            </a:ln>
+          </c:spPr>
+        </c:majorGridlines>
+        <c:numFmt formatCode="#,##0" sourceLinked="0"/>
+        <c:majorTickMark val="out"/>
+        <c:minorTickMark val="none"/>
+        <c:tickLblPos val="nextTo"/>
+        <c:spPr>
+          <a:ln>
+            <a:noFill/>
+          </a:ln>
+        </c:spPr>
+        <c:txPr>
+          <a:bodyPr/>
+          <a:lstStyle/>
+          <a:p>
+            <a:pPr>
+              <a:defRPr sz="1200">
+                <a:solidFill>
+                  <a:srgbClr val="4C5852"/>
+                </a:solidFill>
+                <a:latin typeface="Inter"/>
+              </a:defRPr>
+            </a:pPr>
+          </a:p>
+        </c:txPr>
+        <c:crossAx val="-2068027336"/>
+        <c:crosses val="autoZero"/>
+      </c:valAx>
+    </c:plotArea>
+    <c:legend>
+      <c:legendPos val="t"/>
+      <c:overlay val="0"/>
+      <c:txPr>
+        <a:bodyPr/>
+        <a:lstStyle/>
+        <a:p>
+          <a:pPr>
+            <a:defRPr sz="1200">
+              <a:solidFill>
+                <a:srgbClr val="4C5852"/>
+              </a:solidFill>
+              <a:latin typeface="Inter"/>
+            </a:defRPr>
+          </a:pPr>
+        </a:p>
+      </c:txPr>
+    </c:legend>
+    <c:dispBlanksAs val="gap"/>
+  </c:chart>
+  <c:txPr>
+    <a:bodyPr/>
+    <a:lstStyle/>
+    <a:p>
+      <a:pPr>
+        <a:defRPr sz="1200">
+          <a:solidFill>
+            <a:srgbClr val="4C5852"/>
+          </a:solidFill>
+          <a:latin typeface="Inter"/>
+        </a:defRPr>
+      </a:pPr>
+      <a:endParaRPr lang="en-US"/>
+    </a:p>
+  </c:txPr>
+  <c:externalData r:id="rId1">
+    <c:autoUpdate val="0"/>
+  </c:externalData>
+</c:chartSpace>
+</file>
+
+<file path=ppt/charts/chart22.xml><?xml version="1.0" encoding="utf-8"?>
+<c:chartSpace xmlns:c="http://schemas.openxmlformats.org/drawingml/2006/chart" xmlns:a="http://schemas.openxmlformats.org/drawingml/2006/main" xmlns:r="http://schemas.openxmlformats.org/officeDocument/2006/relationships">
+  <c:date1904 val="0"/>
+  <c:chart>
+    <c:autoTitleDeleted val="1"/>
+    <c:plotArea>
+      <c:barChart>
+        <c:barDir val="col"/>
+        <c:grouping val="clustered"/>
+        <c:ser>
+          <c:idx val="0"/>
+          <c:order val="0"/>
+          <c:tx>
+            <c:strRef>
+              <c:f>Sheet1!$B$1</c:f>
+              <c:strCache>
+                <c:ptCount val="1"/>
+                <c:pt idx="0">
+                  <c:v>2023</c:v>
+                </c:pt>
+              </c:strCache>
+            </c:strRef>
+          </c:tx>
+          <c:spPr>
+            <a:solidFill>
+              <a:srgbClr val="D9D2C3"/>
+            </a:solidFill>
+          </c:spPr>
+          <c:cat>
+            <c:strRef>
+              <c:f>Sheet1!$A$2:$A$6</c:f>
+              <c:strCache>
+                <c:ptCount val="5"/>
+                <c:pt idx="0">
+                  <c:v>Karkidon</c:v>
+                </c:pt>
+                <c:pt idx="1">
+                  <c:v>Rezaksoy</c:v>
+                </c:pt>
+                <c:pt idx="2">
+                  <c:v>Kosonsoy</c:v>
+                </c:pt>
+                <c:pt idx="3">
+                  <c:v>Chortoq</c:v>
+                </c:pt>
+                <c:pt idx="4">
+                  <c:v>Jiydalisoy</c:v>
+                </c:pt>
+              </c:strCache>
+            </c:strRef>
+          </c:cat>
+          <c:val>
+            <c:numRef>
+              <c:f>Sheet1!$B$2:$B$6</c:f>
+              <c:numCache>
+                <c:formatCode>General</c:formatCode>
+                <c:ptCount val="5"/>
+                <c:pt idx="0">
+                  <c:v>40</c:v>
+                </c:pt>
+                <c:pt idx="1">
+                  <c:v>110</c:v>
+                </c:pt>
+                <c:pt idx="2">
+                  <c:v>73</c:v>
+                </c:pt>
+                <c:pt idx="3">
+                  <c:v>28</c:v>
+                </c:pt>
+                <c:pt idx="4">
+                  <c:v>7</c:v>
+                </c:pt>
+              </c:numCache>
+            </c:numRef>
+          </c:val>
+        </c:ser>
+        <c:ser>
+          <c:idx val="1"/>
+          <c:order val="1"/>
+          <c:tx>
+            <c:strRef>
+              <c:f>Sheet1!$C$1</c:f>
+              <c:strCache>
+                <c:ptCount val="1"/>
+                <c:pt idx="0">
+                  <c:v>2024</c:v>
+                </c:pt>
+              </c:strCache>
+            </c:strRef>
+          </c:tx>
+          <c:spPr>
+            <a:solidFill>
+              <a:srgbClr val="A9C4D1"/>
+            </a:solidFill>
+          </c:spPr>
+          <c:cat>
+            <c:strRef>
+              <c:f>Sheet1!$A$2:$A$6</c:f>
+              <c:strCache>
+                <c:ptCount val="5"/>
+                <c:pt idx="0">
+                  <c:v>Karkidon</c:v>
+                </c:pt>
+                <c:pt idx="1">
+                  <c:v>Rezaksoy</c:v>
+                </c:pt>
+                <c:pt idx="2">
+                  <c:v>Kosonsoy</c:v>
+                </c:pt>
+                <c:pt idx="3">
+                  <c:v>Chortoq</c:v>
+                </c:pt>
+                <c:pt idx="4">
+                  <c:v>Jiydalisoy</c:v>
+                </c:pt>
+              </c:strCache>
+            </c:strRef>
+          </c:cat>
+          <c:val>
+            <c:numRef>
+              <c:f>Sheet1!$C$2:$C$6</c:f>
+              <c:numCache>
+                <c:formatCode>General</c:formatCode>
+                <c:ptCount val="5"/>
+                <c:pt idx="0">
+                  <c:v>25</c:v>
+                </c:pt>
+                <c:pt idx="1">
+                  <c:v>109</c:v>
+                </c:pt>
+                <c:pt idx="2">
+                  <c:v>30</c:v>
+                </c:pt>
+                <c:pt idx="3">
+                  <c:v>21</c:v>
+                </c:pt>
+                <c:pt idx="4">
+                  <c:v>7</c:v>
+                </c:pt>
+              </c:numCache>
+            </c:numRef>
+          </c:val>
+        </c:ser>
+        <c:ser>
+          <c:idx val="2"/>
+          <c:order val="2"/>
+          <c:tx>
+            <c:strRef>
+              <c:f>Sheet1!$D$1</c:f>
+              <c:strCache>
+                <c:ptCount val="1"/>
+                <c:pt idx="0">
+                  <c:v>2025</c:v>
+                </c:pt>
+              </c:strCache>
+            </c:strRef>
+          </c:tx>
+          <c:spPr>
+            <a:solidFill>
+              <a:srgbClr val="6E9DB3"/>
+            </a:solidFill>
+          </c:spPr>
+          <c:cat>
+            <c:strRef>
+              <c:f>Sheet1!$A$2:$A$6</c:f>
+              <c:strCache>
+                <c:ptCount val="5"/>
+                <c:pt idx="0">
+                  <c:v>Karkidon</c:v>
+                </c:pt>
+                <c:pt idx="1">
+                  <c:v>Rezaksoy</c:v>
+                </c:pt>
+                <c:pt idx="2">
+                  <c:v>Kosonsoy</c:v>
+                </c:pt>
+                <c:pt idx="3">
+                  <c:v>Chortoq</c:v>
+                </c:pt>
+                <c:pt idx="4">
+                  <c:v>Jiydalisoy</c:v>
+                </c:pt>
+              </c:strCache>
+            </c:strRef>
+          </c:cat>
+          <c:val>
+            <c:numRef>
+              <c:f>Sheet1!$D$2:$D$6</c:f>
+              <c:numCache>
+                <c:formatCode>General</c:formatCode>
+                <c:ptCount val="5"/>
+                <c:pt idx="0">
+                  <c:v>76</c:v>
+                </c:pt>
+                <c:pt idx="1">
+                  <c:v>127</c:v>
+                </c:pt>
+                <c:pt idx="2">
+                  <c:v>65</c:v>
+                </c:pt>
+                <c:pt idx="3">
+                  <c:v>25</c:v>
+                </c:pt>
+                <c:pt idx="4">
+                  <c:v>12</c:v>
+                </c:pt>
+              </c:numCache>
+            </c:numRef>
+          </c:val>
+        </c:ser>
+        <c:ser>
+          <c:idx val="3"/>
+          <c:order val="3"/>
+          <c:tx>
+            <c:strRef>
+              <c:f>Sheet1!$E$1</c:f>
+              <c:strCache>
+                <c:ptCount val="1"/>
+                <c:pt idx="0">
+                  <c:v>2026</c:v>
+                </c:pt>
+              </c:strCache>
+            </c:strRef>
+          </c:tx>
+          <c:spPr>
+            <a:solidFill>
+              <a:srgbClr val="A4521D"/>
+            </a:solidFill>
+          </c:spPr>
+          <c:cat>
+            <c:strRef>
+              <c:f>Sheet1!$A$2:$A$6</c:f>
+              <c:strCache>
+                <c:ptCount val="5"/>
+                <c:pt idx="0">
+                  <c:v>Karkidon</c:v>
+                </c:pt>
+                <c:pt idx="1">
+                  <c:v>Rezaksoy</c:v>
+                </c:pt>
+                <c:pt idx="2">
+                  <c:v>Kosonsoy</c:v>
+                </c:pt>
+                <c:pt idx="3">
+                  <c:v>Chortoq</c:v>
+                </c:pt>
+                <c:pt idx="4">
+                  <c:v>Jiydalisoy</c:v>
+                </c:pt>
+              </c:strCache>
+            </c:strRef>
+          </c:cat>
+          <c:val>
+            <c:numRef>
+              <c:f>Sheet1!$E$2:$E$6</c:f>
+              <c:numCache>
+                <c:formatCode>General</c:formatCode>
+                <c:ptCount val="5"/>
+                <c:pt idx="0">
+                  <c:v>51.6</c:v>
+                </c:pt>
+                <c:pt idx="1">
+                  <c:v>110.9</c:v>
+                </c:pt>
+                <c:pt idx="2">
+                  <c:v>22.1</c:v>
+                </c:pt>
+                <c:pt idx="3">
+                  <c:v>22.8</c:v>
+                </c:pt>
+                <c:pt idx="4">
+                  <c:v>11.1</c:v>
+                </c:pt>
+              </c:numCache>
+            </c:numRef>
+          </c:val>
+        </c:ser>
+        <c:gapWidth val="50"/>
+        <c:overlap val="-5"/>
+        <c:axId val="-2068027336"/>
+        <c:axId val="-2113994440"/>
+      </c:barChart>
+      <c:catAx>
+        <c:axId val="-2068027336"/>
+        <c:scaling>
+          <c:orientation val="minMax"/>
+        </c:scaling>
+        <c:delete val="0"/>
+        <c:axPos val="b"/>
+        <c:majorTickMark val="out"/>
+        <c:minorTickMark val="none"/>
+        <c:tickLblPos val="nextTo"/>
+        <c:spPr>
+          <a:ln>
+            <a:solidFill>
+              <a:srgbClr val="B5B2AD"/>
+            </a:solidFill>
+          </a:ln>
+        </c:spPr>
+        <c:txPr>
+          <a:bodyPr/>
+          <a:lstStyle/>
+          <a:p>
+            <a:pPr>
+              <a:defRPr sz="1200">
+                <a:solidFill>
+                  <a:srgbClr val="4C5852"/>
+                </a:solidFill>
+                <a:latin typeface="Inter"/>
+              </a:defRPr>
+            </a:pPr>
+          </a:p>
+        </c:txPr>
+        <c:crossAx val="-2113994440"/>
+        <c:crosses val="autoZero"/>
+        <c:auto val="1"/>
+        <c:lblAlgn val="ctr"/>
+        <c:lblOffset val="100"/>
+        <c:noMultiLvlLbl val="0"/>
+      </c:catAx>
+      <c:valAx>
+        <c:axId val="-2113994440"/>
+        <c:scaling>
+          <c:max val="140.0"/>
+          <c:min val="0.0"/>
+        </c:scaling>
+        <c:delete val="0"/>
+        <c:axPos val="l"/>
+        <c:majorGridlines>
+          <c:spPr>
+            <a:ln>
+              <a:solidFill>
+                <a:srgbClr val="D9D2C3"/>
+              </a:solidFill>
+            </a:ln>
+          </c:spPr>
+        </c:majorGridlines>
+        <c:majorTickMark val="out"/>
+        <c:minorTickMark val="none"/>
+        <c:tickLblPos val="nextTo"/>
+        <c:spPr>
+          <a:ln>
+            <a:noFill/>
+          </a:ln>
+        </c:spPr>
+        <c:txPr>
+          <a:bodyPr/>
+          <a:lstStyle/>
+          <a:p>
+            <a:pPr>
+              <a:defRPr sz="1200">
+                <a:solidFill>
+                  <a:srgbClr val="4C5852"/>
+                </a:solidFill>
+                <a:latin typeface="Inter"/>
+              </a:defRPr>
+            </a:pPr>
+          </a:p>
+        </c:txPr>
+        <c:crossAx val="-2068027336"/>
+        <c:crosses val="autoZero"/>
+        <c:majorUnit val="35.0"/>
+      </c:valAx>
+    </c:plotArea>
+    <c:legend>
+      <c:legendPos val="t"/>
+      <c:overlay val="0"/>
+      <c:txPr>
+        <a:bodyPr/>
+        <a:lstStyle/>
+        <a:p>
+          <a:pPr>
+            <a:defRPr sz="1200">
+              <a:solidFill>
+                <a:srgbClr val="4C5852"/>
+              </a:solidFill>
+              <a:latin typeface="Inter"/>
+            </a:defRPr>
+          </a:pPr>
+        </a:p>
+      </c:txPr>
+    </c:legend>
     <c:dispBlanksAs val="gap"/>
   </c:chart>
   <c:txPr>
@@ -8087,7 +9079,7 @@
                 <a:ea typeface="Inter" pitchFamily="34" charset="-122"/>
                 <a:cs typeface="Inter" pitchFamily="34" charset="-120"/>
               </a:rPr>
-              <a:t>27 · DISSERTATSIYA TUZILISHI</a:t>
+              <a:t>30 · DISSERTATSIYA TUZILISHI</a:t>
             </a:r>
             <a:endParaRPr lang="en-US" sz="1200" dirty="0"/>
           </a:p>
@@ -8886,7 +9878,7 @@
                 <a:ea typeface="Inter" pitchFamily="34" charset="-122"/>
                 <a:cs typeface="Inter" pitchFamily="34" charset="-120"/>
               </a:rPr>
-              <a:t>28</a:t>
+              <a:t>31</a:t>
             </a:r>
             <a:endParaRPr lang="en-US" sz="1200" dirty="0"/>
           </a:p>
@@ -8962,7 +9954,7 @@
                 <a:ea typeface="Inter" pitchFamily="34" charset="-122"/>
                 <a:cs typeface="Inter" pitchFamily="34" charset="-120"/>
               </a:rPr>
-              <a:t>28 · DISSERTATSIYA TUZILISHI</a:t>
+              <a:t>31 · DISSERTATSIYA TUZILISHI</a:t>
             </a:r>
             <a:endParaRPr lang="en-US" sz="1200" dirty="0"/>
           </a:p>
@@ -9994,7 +10986,7 @@
                 <a:ea typeface="Inter" pitchFamily="34" charset="-122"/>
                 <a:cs typeface="Inter" pitchFamily="34" charset="-120"/>
               </a:rPr>
-              <a:t>29</a:t>
+              <a:t>32</a:t>
             </a:r>
             <a:endParaRPr lang="en-US" sz="1200" dirty="0"/>
           </a:p>
@@ -10070,7 +11062,7 @@
                 <a:ea typeface="Inter" pitchFamily="34" charset="-122"/>
                 <a:cs typeface="Inter" pitchFamily="34" charset="-120"/>
               </a:rPr>
-              <a:t>29 · DISSERTATSIYA TUZILISHI</a:t>
+              <a:t>32 · DISSERTATSIYA TUZILISHI</a:t>
             </a:r>
             <a:endParaRPr lang="en-US" sz="1200" dirty="0"/>
           </a:p>
@@ -11097,7 +12089,7 @@
                 <a:ea typeface="Inter" pitchFamily="34" charset="-122"/>
                 <a:cs typeface="Inter" pitchFamily="34" charset="-120"/>
               </a:rPr>
-              <a:t>30</a:t>
+              <a:t>33</a:t>
             </a:r>
             <a:endParaRPr lang="en-US" sz="1200" dirty="0"/>
           </a:p>
@@ -11173,7 +12165,7 @@
                 <a:ea typeface="Inter" pitchFamily="34" charset="-122"/>
                 <a:cs typeface="Inter" pitchFamily="34" charset="-120"/>
               </a:rPr>
-              <a:t>30 · NATIJALAR VA REJA</a:t>
+              <a:t>33 · NATIJALAR VA REJA</a:t>
             </a:r>
             <a:endParaRPr lang="en-US" sz="1200" dirty="0"/>
           </a:p>
@@ -11911,7 +12903,7 @@
                 <a:ea typeface="Inter" pitchFamily="34" charset="-122"/>
                 <a:cs typeface="Inter" pitchFamily="34" charset="-120"/>
               </a:rPr>
-              <a:t>31</a:t>
+              <a:t>34</a:t>
             </a:r>
             <a:endParaRPr lang="en-US" sz="1200" dirty="0"/>
           </a:p>
@@ -11987,7 +12979,7 @@
                 <a:ea typeface="Inter" pitchFamily="34" charset="-122"/>
                 <a:cs typeface="Inter" pitchFamily="34" charset="-120"/>
               </a:rPr>
-              <a:t>31 · NATIJALAR VA REJA</a:t>
+              <a:t>34 · NATIJALAR VA REJA</a:t>
             </a:r>
             <a:endParaRPr lang="en-US" sz="1200" dirty="0"/>
           </a:p>
@@ -13013,7 +14005,7 @@
                 <a:ea typeface="Inter" pitchFamily="34" charset="-122"/>
                 <a:cs typeface="Inter" pitchFamily="34" charset="-120"/>
               </a:rPr>
-              <a:t>32</a:t>
+              <a:t>35</a:t>
             </a:r>
             <a:endParaRPr lang="en-US" sz="1200" dirty="0"/>
           </a:p>
@@ -13089,7 +14081,7 @@
                 <a:ea typeface="Inter" pitchFamily="34" charset="-122"/>
                 <a:cs typeface="Inter" pitchFamily="34" charset="-120"/>
               </a:rPr>
-              <a:t>32 · NATIJALAR VA REJA</a:t>
+              <a:t>35 · NATIJALAR VA REJA</a:t>
             </a:r>
             <a:endParaRPr lang="en-US" sz="1200" dirty="0"/>
           </a:p>
@@ -13701,7 +14693,7 @@
                 <a:ea typeface="Inter" pitchFamily="34" charset="-122"/>
                 <a:cs typeface="Inter" pitchFamily="34" charset="-120"/>
               </a:rPr>
-              <a:t>33</a:t>
+              <a:t>36</a:t>
             </a:r>
             <a:endParaRPr lang="en-US" sz="1200" dirty="0"/>
           </a:p>
@@ -25316,7 +26308,7 @@
                 <a:ea typeface="Inter" pitchFamily="34" charset="-122"/>
                 <a:cs typeface="Inter" pitchFamily="34" charset="-120"/>
               </a:rPr>
-              <a:t>26 · ADABIYOT TAHLILI</a:t>
+              <a:t>26 · DASTLABKI MAʼLUMOTLAR</a:t>
             </a:r>
             <a:endParaRPr lang="en-US" sz="1200" dirty="0"/>
           </a:p>
@@ -25362,7 +26354,7 @@
                 <a:ea typeface="Source Serif 4" pitchFamily="18" charset="-122"/>
                 <a:cs typeface="Source Serif 4" pitchFamily="18" charset="-120"/>
               </a:rPr>
-              <a:t>Markaziy Fargʻona tuproqlari: oldingi tadqiqot</a:t>
+              <a:t>Fargʻona viloyati: tuproqdagi gumus</a:t>
             </a:r>
             <a:endParaRPr lang="en-US" sz="3200" dirty="0"/>
           </a:p>
@@ -25407,6 +26399,1809 @@
                 <a:cs typeface="Inter" pitchFamily="34" charset="-120"/>
               </a:rPr>
               <a:t>27</a:t>
+            </a:r>
+            <a:endParaRPr lang="en-US" sz="1200" dirty="0"/>
+          </a:p>
+        </p:txBody>
+      </p:sp>
+      <p:sp>
+        <p:nvSpPr>
+          <p:cNvPr id="7" name="TextBox 6"/>
+          <p:cNvSpPr txBox="1"/>
+          <p:nvPr/>
+        </p:nvSpPr>
+        <p:spPr>
+          <a:xfrm>
+            <a:off x="812800" y="1830000"/>
+            <a:ext cx="6200000" cy="260000"/>
+          </a:xfrm>
+          <a:prstGeom prst="rect">
+            <a:avLst/>
+          </a:prstGeom>
+          <a:noFill/>
+        </p:spPr>
+        <p:txBody>
+          <a:bodyPr wrap="square" lIns="0" rIns="0" tIns="0" bIns="0" anchor="t">
+            <a:spAutoFit/>
+          </a:bodyPr>
+          <a:lstStyle/>
+          <a:p>
+            <a:pPr algn="l"/>
+            <a:r>
+              <a:rPr sz="1300" b="1">
+                <a:solidFill>
+                  <a:srgbClr val="2C6A85"/>
+                </a:solidFill>
+                <a:latin typeface="Inter"/>
+              </a:rPr>
+              <a:t>Gumus miqdori ≤0,80% boʻlgan yerlar ulushi, % (10 tuman)</a:t>
+            </a:r>
+          </a:p>
+        </p:txBody>
+      </p:sp>
+      <p:graphicFrame>
+        <p:nvGraphicFramePr>
+          <p:cNvPr id="8" name="Chart 7"/>
+          <p:cNvGraphicFramePr>
+            <a:graphicFrameLocks noGrp="1"/>
+          </p:cNvGraphicFramePr>
+          <p:nvPr/>
+        </p:nvGraphicFramePr>
+        <p:xfrm>
+          <a:off x="752800" y="2100000"/>
+          <a:ext cx="6500000" cy="3950000"/>
+        </p:xfrm>
+        <a:graphic>
+          <a:graphicData uri="http://schemas.openxmlformats.org/drawingml/2006/chart">
+            <c:chart xmlns:c="http://schemas.openxmlformats.org/drawingml/2006/chart" r:id="rId2"/>
+          </a:graphicData>
+        </a:graphic>
+      </p:graphicFrame>
+      <p:sp>
+        <p:nvSpPr>
+          <p:cNvPr id="9" name="Rounded Rectangle 8"/>
+          <p:cNvSpPr/>
+          <p:nvPr/>
+        </p:nvSpPr>
+        <p:spPr>
+          <a:xfrm>
+            <a:off x="7700000" y="1830000"/>
+            <a:ext cx="3996192" cy="1230000"/>
+          </a:xfrm>
+          <a:prstGeom prst="roundRect">
+            <a:avLst>
+              <a:gd name="adj" fmla="val 5000"/>
+            </a:avLst>
+          </a:prstGeom>
+          <a:solidFill>
+            <a:srgbClr val="FBF9F4"/>
+          </a:solidFill>
+          <a:ln w="6350">
+            <a:solidFill>
+              <a:srgbClr val="D9D2C3"/>
+            </a:solidFill>
+          </a:ln>
+          <a:effectLst/>
+        </p:spPr>
+        <p:style>
+          <a:lnRef idx="1">
+            <a:schemeClr val="accent1"/>
+          </a:lnRef>
+          <a:fillRef idx="3">
+            <a:schemeClr val="accent1"/>
+          </a:fillRef>
+          <a:effectRef idx="2">
+            <a:schemeClr val="accent1"/>
+          </a:effectRef>
+          <a:fontRef idx="minor">
+            <a:schemeClr val="lt1"/>
+          </a:fontRef>
+        </p:style>
+        <p:txBody>
+          <a:bodyPr rtlCol="0" anchor="ctr"/>
+          <a:lstStyle/>
+          <a:p>
+            <a:pPr algn="ctr"/>
+          </a:p>
+        </p:txBody>
+      </p:sp>
+      <p:sp>
+        <p:nvSpPr>
+          <p:cNvPr id="10" name="TextBox 9"/>
+          <p:cNvSpPr txBox="1"/>
+          <p:nvPr/>
+        </p:nvSpPr>
+        <p:spPr>
+          <a:xfrm>
+            <a:off x="7930000" y="1950000"/>
+            <a:ext cx="3536192" cy="420000"/>
+          </a:xfrm>
+          <a:prstGeom prst="rect">
+            <a:avLst/>
+          </a:prstGeom>
+          <a:noFill/>
+        </p:spPr>
+        <p:txBody>
+          <a:bodyPr wrap="square" lIns="0" rIns="0" tIns="0" bIns="0" anchor="t">
+            <a:spAutoFit/>
+          </a:bodyPr>
+          <a:lstStyle/>
+          <a:p>
+            <a:pPr algn="l"/>
+            <a:r>
+              <a:rPr sz="2400" b="0">
+                <a:solidFill>
+                  <a:srgbClr val="A4521D"/>
+                </a:solidFill>
+                <a:latin typeface="Source Serif 4"/>
+              </a:rPr>
+              <a:t>191,7 ming ga</a:t>
+            </a:r>
+          </a:p>
+        </p:txBody>
+      </p:sp>
+      <p:sp>
+        <p:nvSpPr>
+          <p:cNvPr id="11" name="TextBox 10"/>
+          <p:cNvSpPr txBox="1"/>
+          <p:nvPr/>
+        </p:nvSpPr>
+        <p:spPr>
+          <a:xfrm>
+            <a:off x="7930000" y="2390000"/>
+            <a:ext cx="3536192" cy="620000"/>
+          </a:xfrm>
+          <a:prstGeom prst="rect">
+            <a:avLst/>
+          </a:prstGeom>
+          <a:noFill/>
+        </p:spPr>
+        <p:txBody>
+          <a:bodyPr wrap="square" lIns="0" rIns="0" tIns="0" bIns="0" anchor="t">
+            <a:spAutoFit/>
+          </a:bodyPr>
+          <a:lstStyle/>
+          <a:p>
+            <a:pPr algn="l"/>
+            <a:r>
+              <a:rPr sz="1200" b="0">
+                <a:solidFill>
+                  <a:srgbClr val="4C5852"/>
+                </a:solidFill>
+                <a:latin typeface="Inter"/>
+              </a:rPr>
+              <a:t>10 tumanda sugʻoriladigan yer konturlari boʻyicha tuproq taʼminlanganligi tahlil qilingan (gumus, fosfor, kaliy)</a:t>
+            </a:r>
+          </a:p>
+        </p:txBody>
+      </p:sp>
+      <p:sp>
+        <p:nvSpPr>
+          <p:cNvPr id="12" name="Rounded Rectangle 11"/>
+          <p:cNvSpPr/>
+          <p:nvPr/>
+        </p:nvSpPr>
+        <p:spPr>
+          <a:xfrm>
+            <a:off x="7700000" y="3210000"/>
+            <a:ext cx="3996192" cy="1230000"/>
+          </a:xfrm>
+          <a:prstGeom prst="roundRect">
+            <a:avLst>
+              <a:gd name="adj" fmla="val 5000"/>
+            </a:avLst>
+          </a:prstGeom>
+          <a:solidFill>
+            <a:srgbClr val="FBF9F4"/>
+          </a:solidFill>
+          <a:ln w="6350">
+            <a:solidFill>
+              <a:srgbClr val="D9D2C3"/>
+            </a:solidFill>
+          </a:ln>
+          <a:effectLst/>
+        </p:spPr>
+        <p:style>
+          <a:lnRef idx="1">
+            <a:schemeClr val="accent1"/>
+          </a:lnRef>
+          <a:fillRef idx="3">
+            <a:schemeClr val="accent1"/>
+          </a:fillRef>
+          <a:effectRef idx="2">
+            <a:schemeClr val="accent1"/>
+          </a:effectRef>
+          <a:fontRef idx="minor">
+            <a:schemeClr val="lt1"/>
+          </a:fontRef>
+        </p:style>
+        <p:txBody>
+          <a:bodyPr rtlCol="0" anchor="ctr"/>
+          <a:lstStyle/>
+          <a:p>
+            <a:pPr algn="ctr"/>
+          </a:p>
+        </p:txBody>
+      </p:sp>
+      <p:sp>
+        <p:nvSpPr>
+          <p:cNvPr id="13" name="TextBox 12"/>
+          <p:cNvSpPr txBox="1"/>
+          <p:nvPr/>
+        </p:nvSpPr>
+        <p:spPr>
+          <a:xfrm>
+            <a:off x="7930000" y="3330000"/>
+            <a:ext cx="3536192" cy="420000"/>
+          </a:xfrm>
+          <a:prstGeom prst="rect">
+            <a:avLst/>
+          </a:prstGeom>
+          <a:noFill/>
+        </p:spPr>
+        <p:txBody>
+          <a:bodyPr wrap="square" lIns="0" rIns="0" tIns="0" bIns="0" anchor="t">
+            <a:spAutoFit/>
+          </a:bodyPr>
+          <a:lstStyle/>
+          <a:p>
+            <a:pPr algn="l"/>
+            <a:r>
+              <a:rPr sz="2400" b="0">
+                <a:solidFill>
+                  <a:srgbClr val="2C6A85"/>
+                </a:solidFill>
+                <a:latin typeface="Source Serif 4"/>
+              </a:rPr>
+              <a:t>44%</a:t>
+            </a:r>
+          </a:p>
+        </p:txBody>
+      </p:sp>
+      <p:sp>
+        <p:nvSpPr>
+          <p:cNvPr id="14" name="TextBox 13"/>
+          <p:cNvSpPr txBox="1"/>
+          <p:nvPr/>
+        </p:nvSpPr>
+        <p:spPr>
+          <a:xfrm>
+            <a:off x="7930000" y="3770000"/>
+            <a:ext cx="3536192" cy="620000"/>
+          </a:xfrm>
+          <a:prstGeom prst="rect">
+            <a:avLst/>
+          </a:prstGeom>
+          <a:noFill/>
+        </p:spPr>
+        <p:txBody>
+          <a:bodyPr wrap="square" lIns="0" rIns="0" tIns="0" bIns="0" anchor="t">
+            <a:spAutoFit/>
+          </a:bodyPr>
+          <a:lstStyle/>
+          <a:p>
+            <a:pPr algn="l"/>
+            <a:r>
+              <a:rPr sz="1200" b="0">
+                <a:solidFill>
+                  <a:srgbClr val="4C5852"/>
+                </a:solidFill>
+                <a:latin typeface="Inter"/>
+              </a:rPr>
+              <a:t>Gumus miqdori 0,80% gacha (juda kam va kam) boʻlgan yerlar — 85,1 ming ga; oʻrtacha (0,81–1,20%) — 36%</a:t>
+            </a:r>
+          </a:p>
+        </p:txBody>
+      </p:sp>
+      <p:sp>
+        <p:nvSpPr>
+          <p:cNvPr id="15" name="Rounded Rectangle 14"/>
+          <p:cNvSpPr/>
+          <p:nvPr/>
+        </p:nvSpPr>
+        <p:spPr>
+          <a:xfrm>
+            <a:off x="7700000" y="4590000"/>
+            <a:ext cx="3996192" cy="1230000"/>
+          </a:xfrm>
+          <a:prstGeom prst="roundRect">
+            <a:avLst>
+              <a:gd name="adj" fmla="val 5000"/>
+            </a:avLst>
+          </a:prstGeom>
+          <a:solidFill>
+            <a:srgbClr val="FBF9F4"/>
+          </a:solidFill>
+          <a:ln w="6350">
+            <a:solidFill>
+              <a:srgbClr val="D9D2C3"/>
+            </a:solidFill>
+          </a:ln>
+          <a:effectLst/>
+        </p:spPr>
+        <p:style>
+          <a:lnRef idx="1">
+            <a:schemeClr val="accent1"/>
+          </a:lnRef>
+          <a:fillRef idx="3">
+            <a:schemeClr val="accent1"/>
+          </a:fillRef>
+          <a:effectRef idx="2">
+            <a:schemeClr val="accent1"/>
+          </a:effectRef>
+          <a:fontRef idx="minor">
+            <a:schemeClr val="lt1"/>
+          </a:fontRef>
+        </p:style>
+        <p:txBody>
+          <a:bodyPr rtlCol="0" anchor="ctr"/>
+          <a:lstStyle/>
+          <a:p>
+            <a:pPr algn="ctr"/>
+          </a:p>
+        </p:txBody>
+      </p:sp>
+      <p:sp>
+        <p:nvSpPr>
+          <p:cNvPr id="16" name="TextBox 15"/>
+          <p:cNvSpPr txBox="1"/>
+          <p:nvPr/>
+        </p:nvSpPr>
+        <p:spPr>
+          <a:xfrm>
+            <a:off x="7930000" y="4710000"/>
+            <a:ext cx="3536192" cy="420000"/>
+          </a:xfrm>
+          <a:prstGeom prst="rect">
+            <a:avLst/>
+          </a:prstGeom>
+          <a:noFill/>
+        </p:spPr>
+        <p:txBody>
+          <a:bodyPr wrap="square" lIns="0" rIns="0" tIns="0" bIns="0" anchor="t">
+            <a:spAutoFit/>
+          </a:bodyPr>
+          <a:lstStyle/>
+          <a:p>
+            <a:pPr algn="l"/>
+            <a:r>
+              <a:rPr sz="2400" b="0">
+                <a:solidFill>
+                  <a:srgbClr val="A4521D"/>
+                </a:solidFill>
+                <a:latin typeface="Source Serif 4"/>
+              </a:rPr>
+              <a:t>64% → 17%</a:t>
+            </a:r>
+          </a:p>
+        </p:txBody>
+      </p:sp>
+      <p:sp>
+        <p:nvSpPr>
+          <p:cNvPr id="17" name="TextBox 16"/>
+          <p:cNvSpPr txBox="1"/>
+          <p:nvPr/>
+        </p:nvSpPr>
+        <p:spPr>
+          <a:xfrm>
+            <a:off x="7930000" y="5150000"/>
+            <a:ext cx="3536192" cy="620000"/>
+          </a:xfrm>
+          <a:prstGeom prst="rect">
+            <a:avLst/>
+          </a:prstGeom>
+          <a:noFill/>
+        </p:spPr>
+        <p:txBody>
+          <a:bodyPr wrap="square" lIns="0" rIns="0" tIns="0" bIns="0" anchor="t">
+            <a:spAutoFit/>
+          </a:bodyPr>
+          <a:lstStyle/>
+          <a:p>
+            <a:pPr algn="l"/>
+            <a:r>
+              <a:rPr sz="1200" b="0">
+                <a:solidFill>
+                  <a:srgbClr val="4C5852"/>
+                </a:solidFill>
+                <a:latin typeface="Inter"/>
+              </a:rPr>
+              <a:t>Kam gumusli yerlar ulushi Dangʻarada eng yuqori, Quvada eng past</a:t>
+            </a:r>
+          </a:p>
+        </p:txBody>
+      </p:sp>
+      <p:sp>
+        <p:nvSpPr>
+          <p:cNvPr id="18" name="TextBox 17"/>
+          <p:cNvSpPr txBox="1"/>
+          <p:nvPr/>
+        </p:nvSpPr>
+        <p:spPr>
+          <a:xfrm>
+            <a:off x="812800" y="6238280"/>
+            <a:ext cx="9800000" cy="240000"/>
+          </a:xfrm>
+          <a:prstGeom prst="rect">
+            <a:avLst/>
+          </a:prstGeom>
+          <a:noFill/>
+        </p:spPr>
+        <p:txBody>
+          <a:bodyPr wrap="square" lIns="0" rIns="0" tIns="0" bIns="0" anchor="t">
+            <a:spAutoFit/>
+          </a:bodyPr>
+          <a:lstStyle/>
+          <a:p>
+            <a:pPr algn="l"/>
+            <a:r>
+              <a:rPr sz="1200" b="0">
+                <a:solidFill>
+                  <a:srgbClr val="5F6B64"/>
+                </a:solidFill>
+                <a:latin typeface="Inter"/>
+              </a:rPr>
+              <a:t>Manba: Fargʻona viloyati tumanlari sugʻoriladigan yerlarining gumus, harakatchan fosfor va almashinuvchi kaliy bilan taʼminlanganligi</a:t>
+            </a:r>
+          </a:p>
+        </p:txBody>
+      </p:sp>
+    </p:spTree>
+  </p:cSld>
+  <p:clrMapOvr>
+    <a:masterClrMapping/>
+  </p:clrMapOvr>
+</p:sld>
+</file>
+
+<file path=ppt/slides/slide35.xml><?xml version="1.0" encoding="utf-8"?>
+<p:sld xmlns:a="http://schemas.openxmlformats.org/drawingml/2006/main" xmlns:p="http://schemas.openxmlformats.org/presentationml/2006/main" xmlns:r="http://schemas.openxmlformats.org/officeDocument/2006/relationships">
+  <p:cSld>
+    <p:bg>
+      <p:bgPr>
+        <a:solidFill>
+          <a:srgbClr val="F4F1EA"/>
+        </a:solidFill>
+      </p:bgPr>
+    </p:bg>
+    <p:spTree>
+      <p:nvGrpSpPr>
+        <p:cNvPr id="1" name=""/>
+        <p:cNvGrpSpPr/>
+        <p:nvPr/>
+      </p:nvGrpSpPr>
+      <p:grpSpPr/>
+      <p:sp>
+        <p:nvSpPr>
+          <p:cNvPr id="2" name="Text 0"/>
+          <p:cNvSpPr/>
+          <p:nvPr/>
+        </p:nvSpPr>
+        <p:spPr>
+          <a:xfrm>
+            <a:off x="812800" y="812800"/>
+            <a:ext cx="10883392" cy="238720"/>
+          </a:xfrm>
+          <a:prstGeom prst="rect">
+            <a:avLst/>
+          </a:prstGeom>
+          <a:noFill/>
+          <a:ln/>
+        </p:spPr>
+        <p:txBody>
+          <a:bodyPr wrap="square" lIns="0" tIns="0" rIns="0" bIns="0" rtlCol="0" anchor="t">
+            <a:normAutofit/>
+          </a:bodyPr>
+          <a:lstStyle/>
+          <a:p>
+            <a:pPr algn="l" indent="0" marL="0">
+              <a:lnSpc>
+                <a:spcPts val="1680"/>
+              </a:lnSpc>
+              <a:buNone/>
+            </a:pPr>
+            <a:r>
+              <a:rPr lang="en-US" sz="1200" b="1" spc="150" kern="0" dirty="0">
+                <a:solidFill>
+                  <a:srgbClr val="2C6A85"/>
+                </a:solidFill>
+                <a:latin typeface="Inter" pitchFamily="34" charset="0"/>
+                <a:ea typeface="Inter" pitchFamily="34" charset="-122"/>
+                <a:cs typeface="Inter" pitchFamily="34" charset="-120"/>
+              </a:rPr>
+              <a:t>27 · DASTLABKI MAʼLUMOTLAR</a:t>
+            </a:r>
+            <a:endParaRPr lang="en-US" sz="1200" dirty="0"/>
+          </a:p>
+        </p:txBody>
+      </p:sp>
+      <p:sp>
+        <p:nvSpPr>
+          <p:cNvPr id="3" name="Text 1"/>
+          <p:cNvSpPr/>
+          <p:nvPr>
+            <p:ph type="title"/>
+          </p:nvPr>
+        </p:nvSpPr>
+        <p:spPr>
+          <a:xfrm>
+            <a:off x="812800" y="1127720"/>
+            <a:ext cx="10883392" cy="472430"/>
+          </a:xfrm>
+          <a:prstGeom prst="rect">
+            <a:avLst/>
+          </a:prstGeom>
+          <a:noFill/>
+          <a:ln/>
+        </p:spPr>
+        <p:txBody>
+          <a:bodyPr wrap="square" lIns="0" tIns="0" rIns="0" bIns="0" rtlCol="0" anchor="t">
+            <a:normAutofit/>
+          </a:bodyPr>
+          <a:lstStyle/>
+          <a:p>
+            <a:pPr algn="l" indent="0" marL="0">
+              <a:lnSpc>
+                <a:spcPts val="3520"/>
+              </a:lnSpc>
+              <a:buNone/>
+            </a:pPr>
+            <a:r>
+              <a:rPr lang="en-US" sz="3200" b="0" i="0" dirty="0">
+                <a:solidFill>
+                  <a:srgbClr val="1D2A24"/>
+                </a:solidFill>
+                <a:latin typeface="Source Serif 4" pitchFamily="18" charset="0"/>
+                <a:ea typeface="Source Serif 4" pitchFamily="18" charset="-122"/>
+                <a:cs typeface="Source Serif 4" pitchFamily="18" charset="-120"/>
+              </a:rPr>
+              <a:t>Fargʻona viloyati: shoʻr yuvish dinamikasi</a:t>
+            </a:r>
+            <a:endParaRPr lang="en-US" sz="3200" dirty="0"/>
+          </a:p>
+        </p:txBody>
+      </p:sp>
+      <p:sp>
+        <p:nvSpPr>
+          <p:cNvPr id="6" name="Text 3"/>
+          <p:cNvSpPr/>
+          <p:nvPr/>
+        </p:nvSpPr>
+        <p:spPr>
+          <a:xfrm>
+            <a:off x="11137950" y="6238280"/>
+            <a:ext cx="241250" cy="238720"/>
+          </a:xfrm>
+          <a:prstGeom prst="rect">
+            <a:avLst/>
+          </a:prstGeom>
+          <a:noFill/>
+          <a:ln/>
+        </p:spPr>
+        <p:txBody>
+          <a:bodyPr wrap="square" lIns="0" tIns="0" rIns="0" bIns="0" rtlCol="0" anchor="t">
+            <a:normAutofit/>
+          </a:bodyPr>
+          <a:lstStyle/>
+          <a:p>
+            <a:pPr algn="r" indent="0" marL="0">
+              <a:lnSpc>
+                <a:spcPts val="1680"/>
+              </a:lnSpc>
+              <a:buNone/>
+            </a:pPr>
+            <a:r>
+              <a:rPr lang="en-US" sz="1200" dirty="0">
+                <a:solidFill>
+                  <a:srgbClr val="5F6B64"/>
+                </a:solidFill>
+                <a:latin typeface="Inter" pitchFamily="34" charset="0"/>
+                <a:ea typeface="Inter" pitchFamily="34" charset="-122"/>
+                <a:cs typeface="Inter" pitchFamily="34" charset="-120"/>
+              </a:rPr>
+              <a:t>28</a:t>
+            </a:r>
+            <a:endParaRPr lang="en-US" sz="1200" dirty="0"/>
+          </a:p>
+        </p:txBody>
+      </p:sp>
+      <p:sp>
+        <p:nvSpPr>
+          <p:cNvPr id="7" name="TextBox 6"/>
+          <p:cNvSpPr txBox="1"/>
+          <p:nvPr/>
+        </p:nvSpPr>
+        <p:spPr>
+          <a:xfrm>
+            <a:off x="812800" y="1830000"/>
+            <a:ext cx="6200000" cy="260000"/>
+          </a:xfrm>
+          <a:prstGeom prst="rect">
+            <a:avLst/>
+          </a:prstGeom>
+          <a:noFill/>
+        </p:spPr>
+        <p:txBody>
+          <a:bodyPr wrap="square" lIns="0" rIns="0" tIns="0" bIns="0" anchor="t">
+            <a:spAutoFit/>
+          </a:bodyPr>
+          <a:lstStyle/>
+          <a:p>
+            <a:pPr algn="l"/>
+            <a:r>
+              <a:rPr sz="1300" b="1">
+                <a:solidFill>
+                  <a:srgbClr val="2C6A85"/>
+                </a:solidFill>
+                <a:latin typeface="Inter"/>
+              </a:rPr>
+              <a:t>Shoʻr yuviladigan maydon, ming ga</a:t>
+            </a:r>
+          </a:p>
+        </p:txBody>
+      </p:sp>
+      <p:graphicFrame>
+        <p:nvGraphicFramePr>
+          <p:cNvPr id="8" name="Chart 7"/>
+          <p:cNvGraphicFramePr>
+            <a:graphicFrameLocks noGrp="1"/>
+          </p:cNvGraphicFramePr>
+          <p:nvPr/>
+        </p:nvGraphicFramePr>
+        <p:xfrm>
+          <a:off x="752800" y="2080000"/>
+          <a:ext cx="6600000" cy="4000000"/>
+        </p:xfrm>
+        <a:graphic>
+          <a:graphicData uri="http://schemas.openxmlformats.org/drawingml/2006/chart">
+            <c:chart xmlns:c="http://schemas.openxmlformats.org/drawingml/2006/chart" r:id="rId2"/>
+          </a:graphicData>
+        </a:graphic>
+      </p:graphicFrame>
+      <p:sp>
+        <p:nvSpPr>
+          <p:cNvPr id="9" name="Rounded Rectangle 8"/>
+          <p:cNvSpPr/>
+          <p:nvPr/>
+        </p:nvSpPr>
+        <p:spPr>
+          <a:xfrm>
+            <a:off x="7700000" y="1830000"/>
+            <a:ext cx="3996192" cy="1230000"/>
+          </a:xfrm>
+          <a:prstGeom prst="roundRect">
+            <a:avLst>
+              <a:gd name="adj" fmla="val 5000"/>
+            </a:avLst>
+          </a:prstGeom>
+          <a:solidFill>
+            <a:srgbClr val="FBF9F4"/>
+          </a:solidFill>
+          <a:ln w="6350">
+            <a:solidFill>
+              <a:srgbClr val="D9D2C3"/>
+            </a:solidFill>
+          </a:ln>
+          <a:effectLst/>
+        </p:spPr>
+        <p:style>
+          <a:lnRef idx="1">
+            <a:schemeClr val="accent1"/>
+          </a:lnRef>
+          <a:fillRef idx="3">
+            <a:schemeClr val="accent1"/>
+          </a:fillRef>
+          <a:effectRef idx="2">
+            <a:schemeClr val="accent1"/>
+          </a:effectRef>
+          <a:fontRef idx="minor">
+            <a:schemeClr val="lt1"/>
+          </a:fontRef>
+        </p:style>
+        <p:txBody>
+          <a:bodyPr rtlCol="0" anchor="ctr"/>
+          <a:lstStyle/>
+          <a:p>
+            <a:pPr algn="ctr"/>
+          </a:p>
+        </p:txBody>
+      </p:sp>
+      <p:sp>
+        <p:nvSpPr>
+          <p:cNvPr id="10" name="TextBox 9"/>
+          <p:cNvSpPr txBox="1"/>
+          <p:nvPr/>
+        </p:nvSpPr>
+        <p:spPr>
+          <a:xfrm>
+            <a:off x="7930000" y="1950000"/>
+            <a:ext cx="3536192" cy="420000"/>
+          </a:xfrm>
+          <a:prstGeom prst="rect">
+            <a:avLst/>
+          </a:prstGeom>
+          <a:noFill/>
+        </p:spPr>
+        <p:txBody>
+          <a:bodyPr wrap="square" lIns="0" rIns="0" tIns="0" bIns="0" anchor="t">
+            <a:spAutoFit/>
+          </a:bodyPr>
+          <a:lstStyle/>
+          <a:p>
+            <a:pPr algn="l"/>
+            <a:r>
+              <a:rPr sz="2200" b="0">
+                <a:solidFill>
+                  <a:srgbClr val="A4521D"/>
+                </a:solidFill>
+                <a:latin typeface="Source Serif 4"/>
+              </a:rPr>
+              <a:t>33,6 → 33,1 → 26,2</a:t>
+            </a:r>
+          </a:p>
+        </p:txBody>
+      </p:sp>
+      <p:sp>
+        <p:nvSpPr>
+          <p:cNvPr id="11" name="TextBox 10"/>
+          <p:cNvSpPr txBox="1"/>
+          <p:nvPr/>
+        </p:nvSpPr>
+        <p:spPr>
+          <a:xfrm>
+            <a:off x="7930000" y="2390000"/>
+            <a:ext cx="3536192" cy="620000"/>
+          </a:xfrm>
+          <a:prstGeom prst="rect">
+            <a:avLst/>
+          </a:prstGeom>
+          <a:noFill/>
+        </p:spPr>
+        <p:txBody>
+          <a:bodyPr wrap="square" lIns="0" rIns="0" tIns="0" bIns="0" anchor="t">
+            <a:spAutoFit/>
+          </a:bodyPr>
+          <a:lstStyle/>
+          <a:p>
+            <a:pPr algn="l"/>
+            <a:r>
+              <a:rPr sz="1200" b="0">
+                <a:solidFill>
+                  <a:srgbClr val="4C5852"/>
+                </a:solidFill>
+                <a:latin typeface="Inter"/>
+              </a:rPr>
+              <a:t>Shoʻr yuvish maydoni, ming ga (2023–24 → 2024–25 → 2025–26 reja); soʻnggi mavsumda reja −22%</a:t>
+            </a:r>
+          </a:p>
+        </p:txBody>
+      </p:sp>
+      <p:sp>
+        <p:nvSpPr>
+          <p:cNvPr id="12" name="Rounded Rectangle 11"/>
+          <p:cNvSpPr/>
+          <p:nvPr/>
+        </p:nvSpPr>
+        <p:spPr>
+          <a:xfrm>
+            <a:off x="7700000" y="3210000"/>
+            <a:ext cx="3996192" cy="1230000"/>
+          </a:xfrm>
+          <a:prstGeom prst="roundRect">
+            <a:avLst>
+              <a:gd name="adj" fmla="val 5000"/>
+            </a:avLst>
+          </a:prstGeom>
+          <a:solidFill>
+            <a:srgbClr val="FBF9F4"/>
+          </a:solidFill>
+          <a:ln w="6350">
+            <a:solidFill>
+              <a:srgbClr val="D9D2C3"/>
+            </a:solidFill>
+          </a:ln>
+          <a:effectLst/>
+        </p:spPr>
+        <p:style>
+          <a:lnRef idx="1">
+            <a:schemeClr val="accent1"/>
+          </a:lnRef>
+          <a:fillRef idx="3">
+            <a:schemeClr val="accent1"/>
+          </a:fillRef>
+          <a:effectRef idx="2">
+            <a:schemeClr val="accent1"/>
+          </a:effectRef>
+          <a:fontRef idx="minor">
+            <a:schemeClr val="lt1"/>
+          </a:fontRef>
+        </p:style>
+        <p:txBody>
+          <a:bodyPr rtlCol="0" anchor="ctr"/>
+          <a:lstStyle/>
+          <a:p>
+            <a:pPr algn="ctr"/>
+          </a:p>
+        </p:txBody>
+      </p:sp>
+      <p:sp>
+        <p:nvSpPr>
+          <p:cNvPr id="13" name="TextBox 12"/>
+          <p:cNvSpPr txBox="1"/>
+          <p:nvPr/>
+        </p:nvSpPr>
+        <p:spPr>
+          <a:xfrm>
+            <a:off x="7930000" y="3330000"/>
+            <a:ext cx="3536192" cy="420000"/>
+          </a:xfrm>
+          <a:prstGeom prst="rect">
+            <a:avLst/>
+          </a:prstGeom>
+          <a:noFill/>
+        </p:spPr>
+        <p:txBody>
+          <a:bodyPr wrap="square" lIns="0" rIns="0" tIns="0" bIns="0" anchor="t">
+            <a:spAutoFit/>
+          </a:bodyPr>
+          <a:lstStyle/>
+          <a:p>
+            <a:pPr algn="l"/>
+            <a:r>
+              <a:rPr sz="2400" b="0">
+                <a:solidFill>
+                  <a:srgbClr val="2C6A85"/>
+                </a:solidFill>
+                <a:latin typeface="Source Serif 4"/>
+              </a:rPr>
+              <a:t>2,9 → 0,3</a:t>
+            </a:r>
+          </a:p>
+        </p:txBody>
+      </p:sp>
+      <p:sp>
+        <p:nvSpPr>
+          <p:cNvPr id="14" name="TextBox 13"/>
+          <p:cNvSpPr txBox="1"/>
+          <p:nvPr/>
+        </p:nvSpPr>
+        <p:spPr>
+          <a:xfrm>
+            <a:off x="7930000" y="3770000"/>
+            <a:ext cx="3536192" cy="620000"/>
+          </a:xfrm>
+          <a:prstGeom prst="rect">
+            <a:avLst/>
+          </a:prstGeom>
+          <a:noFill/>
+        </p:spPr>
+        <p:txBody>
+          <a:bodyPr wrap="square" lIns="0" rIns="0" tIns="0" bIns="0" anchor="t">
+            <a:spAutoFit/>
+          </a:bodyPr>
+          <a:lstStyle/>
+          <a:p>
+            <a:pPr algn="l"/>
+            <a:r>
+              <a:rPr sz="1200" b="0">
+                <a:solidFill>
+                  <a:srgbClr val="4C5852"/>
+                </a:solidFill>
+                <a:latin typeface="Inter"/>
+              </a:rPr>
+              <a:t>Kuchli shoʻrlangan yer, ming ga (2023–24 → 2024–25); oʻrta shoʻrlangan 7,7 dan 3,9 gacha</a:t>
+            </a:r>
+          </a:p>
+        </p:txBody>
+      </p:sp>
+      <p:sp>
+        <p:nvSpPr>
+          <p:cNvPr id="15" name="Rounded Rectangle 14"/>
+          <p:cNvSpPr/>
+          <p:nvPr/>
+        </p:nvSpPr>
+        <p:spPr>
+          <a:xfrm>
+            <a:off x="7700000" y="4590000"/>
+            <a:ext cx="3996192" cy="1230000"/>
+          </a:xfrm>
+          <a:prstGeom prst="roundRect">
+            <a:avLst>
+              <a:gd name="adj" fmla="val 5000"/>
+            </a:avLst>
+          </a:prstGeom>
+          <a:solidFill>
+            <a:srgbClr val="FBF9F4"/>
+          </a:solidFill>
+          <a:ln w="6350">
+            <a:solidFill>
+              <a:srgbClr val="D9D2C3"/>
+            </a:solidFill>
+          </a:ln>
+          <a:effectLst/>
+        </p:spPr>
+        <p:style>
+          <a:lnRef idx="1">
+            <a:schemeClr val="accent1"/>
+          </a:lnRef>
+          <a:fillRef idx="3">
+            <a:schemeClr val="accent1"/>
+          </a:fillRef>
+          <a:effectRef idx="2">
+            <a:schemeClr val="accent1"/>
+          </a:effectRef>
+          <a:fontRef idx="minor">
+            <a:schemeClr val="lt1"/>
+          </a:fontRef>
+        </p:style>
+        <p:txBody>
+          <a:bodyPr rtlCol="0" anchor="ctr"/>
+          <a:lstStyle/>
+          <a:p>
+            <a:pPr algn="ctr"/>
+          </a:p>
+        </p:txBody>
+      </p:sp>
+      <p:sp>
+        <p:nvSpPr>
+          <p:cNvPr id="16" name="TextBox 15"/>
+          <p:cNvSpPr txBox="1"/>
+          <p:nvPr/>
+        </p:nvSpPr>
+        <p:spPr>
+          <a:xfrm>
+            <a:off x="7930000" y="4710000"/>
+            <a:ext cx="3536192" cy="420000"/>
+          </a:xfrm>
+          <a:prstGeom prst="rect">
+            <a:avLst/>
+          </a:prstGeom>
+          <a:noFill/>
+        </p:spPr>
+        <p:txBody>
+          <a:bodyPr wrap="square" lIns="0" rIns="0" tIns="0" bIns="0" anchor="t">
+            <a:spAutoFit/>
+          </a:bodyPr>
+          <a:lstStyle/>
+          <a:p>
+            <a:pPr algn="l"/>
+            <a:r>
+              <a:rPr sz="2400" b="0">
+                <a:solidFill>
+                  <a:srgbClr val="A4521D"/>
+                </a:solidFill>
+                <a:latin typeface="Source Serif 4"/>
+              </a:rPr>
+              <a:t>67%</a:t>
+            </a:r>
+          </a:p>
+        </p:txBody>
+      </p:sp>
+      <p:sp>
+        <p:nvSpPr>
+          <p:cNvPr id="17" name="TextBox 16"/>
+          <p:cNvSpPr txBox="1"/>
+          <p:nvPr/>
+        </p:nvSpPr>
+        <p:spPr>
+          <a:xfrm>
+            <a:off x="7930000" y="5150000"/>
+            <a:ext cx="3536192" cy="620000"/>
+          </a:xfrm>
+          <a:prstGeom prst="rect">
+            <a:avLst/>
+          </a:prstGeom>
+          <a:noFill/>
+        </p:spPr>
+        <p:txBody>
+          <a:bodyPr wrap="square" lIns="0" rIns="0" tIns="0" bIns="0" anchor="t">
+            <a:spAutoFit/>
+          </a:bodyPr>
+          <a:lstStyle/>
+          <a:p>
+            <a:pPr algn="l"/>
+            <a:r>
+              <a:rPr sz="1200" b="0">
+                <a:solidFill>
+                  <a:srgbClr val="4C5852"/>
+                </a:solidFill>
+                <a:latin typeface="Inter"/>
+              </a:rPr>
+              <a:t>2025–26 mavsumida 10.01.2026 gacha 17 474 ga (26 170 ga rejadan) yuvilgan; 1 289 xoʻjalik ish boshlagan, 220 tasi boshlamagan</a:t>
+            </a:r>
+          </a:p>
+        </p:txBody>
+      </p:sp>
+      <p:sp>
+        <p:nvSpPr>
+          <p:cNvPr id="18" name="TextBox 17"/>
+          <p:cNvSpPr txBox="1"/>
+          <p:nvPr/>
+        </p:nvSpPr>
+        <p:spPr>
+          <a:xfrm>
+            <a:off x="812800" y="6238280"/>
+            <a:ext cx="9800000" cy="240000"/>
+          </a:xfrm>
+          <a:prstGeom prst="rect">
+            <a:avLst/>
+          </a:prstGeom>
+          <a:noFill/>
+        </p:spPr>
+        <p:txBody>
+          <a:bodyPr wrap="square" lIns="0" rIns="0" tIns="0" bIns="0" anchor="t">
+            <a:spAutoFit/>
+          </a:bodyPr>
+          <a:lstStyle/>
+          <a:p>
+            <a:pPr algn="l"/>
+            <a:r>
+              <a:rPr sz="1200" b="0">
+                <a:solidFill>
+                  <a:srgbClr val="5F6B64"/>
+                </a:solidFill>
+                <a:latin typeface="Inter"/>
+              </a:rPr>
+              <a:t>Manba: Fargʻona viloyati shoʻr yuvish maʼlumotlari (2023–24, 2024–25 va 10.01.2026 holati); tuman tarkibi yillar boʻyicha farq qiladi</a:t>
+            </a:r>
+          </a:p>
+        </p:txBody>
+      </p:sp>
+    </p:spTree>
+  </p:cSld>
+  <p:clrMapOvr>
+    <a:masterClrMapping/>
+  </p:clrMapOvr>
+</p:sld>
+</file>
+
+<file path=ppt/slides/slide36.xml><?xml version="1.0" encoding="utf-8"?>
+<p:sld xmlns:a="http://schemas.openxmlformats.org/drawingml/2006/main" xmlns:p="http://schemas.openxmlformats.org/presentationml/2006/main" xmlns:r="http://schemas.openxmlformats.org/officeDocument/2006/relationships">
+  <p:cSld>
+    <p:bg>
+      <p:bgPr>
+        <a:solidFill>
+          <a:srgbClr val="F4F1EA"/>
+        </a:solidFill>
+      </p:bgPr>
+    </p:bg>
+    <p:spTree>
+      <p:nvGrpSpPr>
+        <p:cNvPr id="1" name=""/>
+        <p:cNvGrpSpPr/>
+        <p:nvPr/>
+      </p:nvGrpSpPr>
+      <p:grpSpPr/>
+      <p:sp>
+        <p:nvSpPr>
+          <p:cNvPr id="2" name="Text 0"/>
+          <p:cNvSpPr/>
+          <p:nvPr/>
+        </p:nvSpPr>
+        <p:spPr>
+          <a:xfrm>
+            <a:off x="812800" y="812800"/>
+            <a:ext cx="10883392" cy="238720"/>
+          </a:xfrm>
+          <a:prstGeom prst="rect">
+            <a:avLst/>
+          </a:prstGeom>
+          <a:noFill/>
+          <a:ln/>
+        </p:spPr>
+        <p:txBody>
+          <a:bodyPr wrap="square" lIns="0" tIns="0" rIns="0" bIns="0" rtlCol="0" anchor="t">
+            <a:normAutofit/>
+          </a:bodyPr>
+          <a:lstStyle/>
+          <a:p>
+            <a:pPr algn="l" indent="0" marL="0">
+              <a:lnSpc>
+                <a:spcPts val="1680"/>
+              </a:lnSpc>
+              <a:buNone/>
+            </a:pPr>
+            <a:r>
+              <a:rPr lang="en-US" sz="1200" b="1" spc="150" kern="0" dirty="0">
+                <a:solidFill>
+                  <a:srgbClr val="2C6A85"/>
+                </a:solidFill>
+                <a:latin typeface="Inter" pitchFamily="34" charset="0"/>
+                <a:ea typeface="Inter" pitchFamily="34" charset="-122"/>
+                <a:cs typeface="Inter" pitchFamily="34" charset="-120"/>
+              </a:rPr>
+              <a:t>28 · DASTLABKI MAʼLUMOTLAR</a:t>
+            </a:r>
+            <a:endParaRPr lang="en-US" sz="1200" dirty="0"/>
+          </a:p>
+        </p:txBody>
+      </p:sp>
+      <p:sp>
+        <p:nvSpPr>
+          <p:cNvPr id="3" name="Text 1"/>
+          <p:cNvSpPr/>
+          <p:nvPr>
+            <p:ph type="title"/>
+          </p:nvPr>
+        </p:nvSpPr>
+        <p:spPr>
+          <a:xfrm>
+            <a:off x="812800" y="1127720"/>
+            <a:ext cx="10883392" cy="472430"/>
+          </a:xfrm>
+          <a:prstGeom prst="rect">
+            <a:avLst/>
+          </a:prstGeom>
+          <a:noFill/>
+          <a:ln/>
+        </p:spPr>
+        <p:txBody>
+          <a:bodyPr wrap="square" lIns="0" tIns="0" rIns="0" bIns="0" rtlCol="0" anchor="t">
+            <a:normAutofit/>
+          </a:bodyPr>
+          <a:lstStyle/>
+          <a:p>
+            <a:pPr algn="l" indent="0" marL="0">
+              <a:lnSpc>
+                <a:spcPts val="3520"/>
+              </a:lnSpc>
+              <a:buNone/>
+            </a:pPr>
+            <a:r>
+              <a:rPr lang="en-US" sz="3200" b="0" i="0" dirty="0">
+                <a:solidFill>
+                  <a:srgbClr val="1D2A24"/>
+                </a:solidFill>
+                <a:latin typeface="Source Serif 4" pitchFamily="18" charset="0"/>
+                <a:ea typeface="Source Serif 4" pitchFamily="18" charset="-122"/>
+                <a:cs typeface="Source Serif 4" pitchFamily="18" charset="-120"/>
+              </a:rPr>
+              <a:t>Suv omborlari: 9 yanvar holati</a:t>
+            </a:r>
+            <a:endParaRPr lang="en-US" sz="3200" dirty="0"/>
+          </a:p>
+        </p:txBody>
+      </p:sp>
+      <p:sp>
+        <p:nvSpPr>
+          <p:cNvPr id="6" name="Text 3"/>
+          <p:cNvSpPr/>
+          <p:nvPr/>
+        </p:nvSpPr>
+        <p:spPr>
+          <a:xfrm>
+            <a:off x="11137950" y="6238280"/>
+            <a:ext cx="241250" cy="238720"/>
+          </a:xfrm>
+          <a:prstGeom prst="rect">
+            <a:avLst/>
+          </a:prstGeom>
+          <a:noFill/>
+          <a:ln/>
+        </p:spPr>
+        <p:txBody>
+          <a:bodyPr wrap="square" lIns="0" tIns="0" rIns="0" bIns="0" rtlCol="0" anchor="t">
+            <a:normAutofit/>
+          </a:bodyPr>
+          <a:lstStyle/>
+          <a:p>
+            <a:pPr algn="r" indent="0" marL="0">
+              <a:lnSpc>
+                <a:spcPts val="1680"/>
+              </a:lnSpc>
+              <a:buNone/>
+            </a:pPr>
+            <a:r>
+              <a:rPr lang="en-US" sz="1200" dirty="0">
+                <a:solidFill>
+                  <a:srgbClr val="5F6B64"/>
+                </a:solidFill>
+                <a:latin typeface="Inter" pitchFamily="34" charset="0"/>
+                <a:ea typeface="Inter" pitchFamily="34" charset="-122"/>
+                <a:cs typeface="Inter" pitchFamily="34" charset="-120"/>
+              </a:rPr>
+              <a:t>29</a:t>
+            </a:r>
+            <a:endParaRPr lang="en-US" sz="1200" dirty="0"/>
+          </a:p>
+        </p:txBody>
+      </p:sp>
+      <p:sp>
+        <p:nvSpPr>
+          <p:cNvPr id="7" name="TextBox 6"/>
+          <p:cNvSpPr txBox="1"/>
+          <p:nvPr/>
+        </p:nvSpPr>
+        <p:spPr>
+          <a:xfrm>
+            <a:off x="812800" y="1830000"/>
+            <a:ext cx="6200000" cy="260000"/>
+          </a:xfrm>
+          <a:prstGeom prst="rect">
+            <a:avLst/>
+          </a:prstGeom>
+          <a:noFill/>
+        </p:spPr>
+        <p:txBody>
+          <a:bodyPr wrap="square" lIns="0" rIns="0" tIns="0" bIns="0" anchor="t">
+            <a:spAutoFit/>
+          </a:bodyPr>
+          <a:lstStyle/>
+          <a:p>
+            <a:pPr algn="l"/>
+            <a:r>
+              <a:rPr sz="1300" b="1">
+                <a:solidFill>
+                  <a:srgbClr val="2C6A85"/>
+                </a:solidFill>
+                <a:latin typeface="Inter"/>
+              </a:rPr>
+              <a:t>Suv ombori hajmi 9 yanvarda, mln m³</a:t>
+            </a:r>
+          </a:p>
+        </p:txBody>
+      </p:sp>
+      <p:graphicFrame>
+        <p:nvGraphicFramePr>
+          <p:cNvPr id="8" name="Chart 7"/>
+          <p:cNvGraphicFramePr>
+            <a:graphicFrameLocks noGrp="1"/>
+          </p:cNvGraphicFramePr>
+          <p:nvPr/>
+        </p:nvGraphicFramePr>
+        <p:xfrm>
+          <a:off x="752800" y="2080000"/>
+          <a:ext cx="6600000" cy="4000000"/>
+        </p:xfrm>
+        <a:graphic>
+          <a:graphicData uri="http://schemas.openxmlformats.org/drawingml/2006/chart">
+            <c:chart xmlns:c="http://schemas.openxmlformats.org/drawingml/2006/chart" r:id="rId2"/>
+          </a:graphicData>
+        </a:graphic>
+      </p:graphicFrame>
+      <p:sp>
+        <p:nvSpPr>
+          <p:cNvPr id="9" name="Rounded Rectangle 8"/>
+          <p:cNvSpPr/>
+          <p:nvPr/>
+        </p:nvSpPr>
+        <p:spPr>
+          <a:xfrm>
+            <a:off x="7700000" y="1830000"/>
+            <a:ext cx="3996192" cy="1230000"/>
+          </a:xfrm>
+          <a:prstGeom prst="roundRect">
+            <a:avLst>
+              <a:gd name="adj" fmla="val 5000"/>
+            </a:avLst>
+          </a:prstGeom>
+          <a:solidFill>
+            <a:srgbClr val="FBF9F4"/>
+          </a:solidFill>
+          <a:ln w="6350">
+            <a:solidFill>
+              <a:srgbClr val="D9D2C3"/>
+            </a:solidFill>
+          </a:ln>
+          <a:effectLst/>
+        </p:spPr>
+        <p:style>
+          <a:lnRef idx="1">
+            <a:schemeClr val="accent1"/>
+          </a:lnRef>
+          <a:fillRef idx="3">
+            <a:schemeClr val="accent1"/>
+          </a:fillRef>
+          <a:effectRef idx="2">
+            <a:schemeClr val="accent1"/>
+          </a:effectRef>
+          <a:fontRef idx="minor">
+            <a:schemeClr val="lt1"/>
+          </a:fontRef>
+        </p:style>
+        <p:txBody>
+          <a:bodyPr rtlCol="0" anchor="ctr"/>
+          <a:lstStyle/>
+          <a:p>
+            <a:pPr algn="ctr"/>
+          </a:p>
+        </p:txBody>
+      </p:sp>
+      <p:sp>
+        <p:nvSpPr>
+          <p:cNvPr id="10" name="TextBox 9"/>
+          <p:cNvSpPr txBox="1"/>
+          <p:nvPr/>
+        </p:nvSpPr>
+        <p:spPr>
+          <a:xfrm>
+            <a:off x="7930000" y="1950000"/>
+            <a:ext cx="3536192" cy="420000"/>
+          </a:xfrm>
+          <a:prstGeom prst="rect">
+            <a:avLst/>
+          </a:prstGeom>
+          <a:noFill/>
+        </p:spPr>
+        <p:txBody>
+          <a:bodyPr wrap="square" lIns="0" rIns="0" tIns="0" bIns="0" anchor="t">
+            <a:spAutoFit/>
+          </a:bodyPr>
+          <a:lstStyle/>
+          <a:p>
+            <a:pPr algn="l"/>
+            <a:r>
+              <a:rPr sz="2400" b="0">
+                <a:solidFill>
+                  <a:srgbClr val="A4521D"/>
+                </a:solidFill>
+                <a:latin typeface="Source Serif 4"/>
+              </a:rPr>
+              <a:t>909,3 mln m³</a:t>
+            </a:r>
+          </a:p>
+        </p:txBody>
+      </p:sp>
+      <p:sp>
+        <p:nvSpPr>
+          <p:cNvPr id="11" name="TextBox 10"/>
+          <p:cNvSpPr txBox="1"/>
+          <p:nvPr/>
+        </p:nvSpPr>
+        <p:spPr>
+          <a:xfrm>
+            <a:off x="7930000" y="2390000"/>
+            <a:ext cx="3536192" cy="620000"/>
+          </a:xfrm>
+          <a:prstGeom prst="rect">
+            <a:avLst/>
+          </a:prstGeom>
+          <a:noFill/>
+        </p:spPr>
+        <p:txBody>
+          <a:bodyPr wrap="square" lIns="0" rIns="0" tIns="0" bIns="0" anchor="t">
+            <a:spAutoFit/>
+          </a:bodyPr>
+          <a:lstStyle/>
+          <a:p>
+            <a:pPr algn="l"/>
+            <a:r>
+              <a:rPr sz="1200" b="0">
+                <a:solidFill>
+                  <a:srgbClr val="4C5852"/>
+                </a:solidFill>
+                <a:latin typeface="Inter"/>
+              </a:rPr>
+              <a:t>Andijon suv ombori (quvvati 1 900): 2025 yilning shu kuniga nisbatan −20%, 2024 yilga nisbatan +10%</a:t>
+            </a:r>
+          </a:p>
+        </p:txBody>
+      </p:sp>
+      <p:sp>
+        <p:nvSpPr>
+          <p:cNvPr id="12" name="Rounded Rectangle 11"/>
+          <p:cNvSpPr/>
+          <p:nvPr/>
+        </p:nvSpPr>
+        <p:spPr>
+          <a:xfrm>
+            <a:off x="7700000" y="3210000"/>
+            <a:ext cx="3996192" cy="1230000"/>
+          </a:xfrm>
+          <a:prstGeom prst="roundRect">
+            <a:avLst>
+              <a:gd name="adj" fmla="val 5000"/>
+            </a:avLst>
+          </a:prstGeom>
+          <a:solidFill>
+            <a:srgbClr val="FBF9F4"/>
+          </a:solidFill>
+          <a:ln w="6350">
+            <a:solidFill>
+              <a:srgbClr val="D9D2C3"/>
+            </a:solidFill>
+          </a:ln>
+          <a:effectLst/>
+        </p:spPr>
+        <p:style>
+          <a:lnRef idx="1">
+            <a:schemeClr val="accent1"/>
+          </a:lnRef>
+          <a:fillRef idx="3">
+            <a:schemeClr val="accent1"/>
+          </a:fillRef>
+          <a:effectRef idx="2">
+            <a:schemeClr val="accent1"/>
+          </a:effectRef>
+          <a:fontRef idx="minor">
+            <a:schemeClr val="lt1"/>
+          </a:fontRef>
+        </p:style>
+        <p:txBody>
+          <a:bodyPr rtlCol="0" anchor="ctr"/>
+          <a:lstStyle/>
+          <a:p>
+            <a:pPr algn="ctr"/>
+          </a:p>
+        </p:txBody>
+      </p:sp>
+      <p:sp>
+        <p:nvSpPr>
+          <p:cNvPr id="13" name="TextBox 12"/>
+          <p:cNvSpPr txBox="1"/>
+          <p:nvPr/>
+        </p:nvSpPr>
+        <p:spPr>
+          <a:xfrm>
+            <a:off x="7930000" y="3330000"/>
+            <a:ext cx="3536192" cy="420000"/>
+          </a:xfrm>
+          <a:prstGeom prst="rect">
+            <a:avLst/>
+          </a:prstGeom>
+          <a:noFill/>
+        </p:spPr>
+        <p:txBody>
+          <a:bodyPr wrap="square" lIns="0" rIns="0" tIns="0" bIns="0" anchor="t">
+            <a:spAutoFit/>
+          </a:bodyPr>
+          <a:lstStyle/>
+          <a:p>
+            <a:pPr algn="l"/>
+            <a:r>
+              <a:rPr sz="2400" b="0">
+                <a:solidFill>
+                  <a:srgbClr val="2C6A85"/>
+                </a:solidFill>
+                <a:latin typeface="Source Serif 4"/>
+              </a:rPr>
+              <a:t>−66%</a:t>
+            </a:r>
+          </a:p>
+        </p:txBody>
+      </p:sp>
+      <p:sp>
+        <p:nvSpPr>
+          <p:cNvPr id="14" name="TextBox 13"/>
+          <p:cNvSpPr txBox="1"/>
+          <p:nvPr/>
+        </p:nvSpPr>
+        <p:spPr>
+          <a:xfrm>
+            <a:off x="7930000" y="3770000"/>
+            <a:ext cx="3536192" cy="620000"/>
+          </a:xfrm>
+          <a:prstGeom prst="rect">
+            <a:avLst/>
+          </a:prstGeom>
+          <a:noFill/>
+        </p:spPr>
+        <p:txBody>
+          <a:bodyPr wrap="square" lIns="0" rIns="0" tIns="0" bIns="0" anchor="t">
+            <a:spAutoFit/>
+          </a:bodyPr>
+          <a:lstStyle/>
+          <a:p>
+            <a:pPr algn="l"/>
+            <a:r>
+              <a:rPr sz="1200" b="0">
+                <a:solidFill>
+                  <a:srgbClr val="4C5852"/>
+                </a:solidFill>
+                <a:latin typeface="Inter"/>
+              </a:rPr>
+              <a:t>Kosonsoy hajmi 65 dan 22,1 mln m³ gacha kamaygan (2025 → 2026); Karkidon −32%</a:t>
+            </a:r>
+          </a:p>
+        </p:txBody>
+      </p:sp>
+      <p:sp>
+        <p:nvSpPr>
+          <p:cNvPr id="15" name="Rounded Rectangle 14"/>
+          <p:cNvSpPr/>
+          <p:nvPr/>
+        </p:nvSpPr>
+        <p:spPr>
+          <a:xfrm>
+            <a:off x="7700000" y="4590000"/>
+            <a:ext cx="3996192" cy="1230000"/>
+          </a:xfrm>
+          <a:prstGeom prst="roundRect">
+            <a:avLst>
+              <a:gd name="adj" fmla="val 5000"/>
+            </a:avLst>
+          </a:prstGeom>
+          <a:solidFill>
+            <a:srgbClr val="FBF9F4"/>
+          </a:solidFill>
+          <a:ln w="6350">
+            <a:solidFill>
+              <a:srgbClr val="D9D2C3"/>
+            </a:solidFill>
+          </a:ln>
+          <a:effectLst/>
+        </p:spPr>
+        <p:style>
+          <a:lnRef idx="1">
+            <a:schemeClr val="accent1"/>
+          </a:lnRef>
+          <a:fillRef idx="3">
+            <a:schemeClr val="accent1"/>
+          </a:fillRef>
+          <a:effectRef idx="2">
+            <a:schemeClr val="accent1"/>
+          </a:effectRef>
+          <a:fontRef idx="minor">
+            <a:schemeClr val="lt1"/>
+          </a:fontRef>
+        </p:style>
+        <p:txBody>
+          <a:bodyPr rtlCol="0" anchor="ctr"/>
+          <a:lstStyle/>
+          <a:p>
+            <a:pPr algn="ctr"/>
+          </a:p>
+        </p:txBody>
+      </p:sp>
+      <p:sp>
+        <p:nvSpPr>
+          <p:cNvPr id="16" name="TextBox 15"/>
+          <p:cNvSpPr txBox="1"/>
+          <p:nvPr/>
+        </p:nvSpPr>
+        <p:spPr>
+          <a:xfrm>
+            <a:off x="7930000" y="4710000"/>
+            <a:ext cx="3536192" cy="420000"/>
+          </a:xfrm>
+          <a:prstGeom prst="rect">
+            <a:avLst/>
+          </a:prstGeom>
+          <a:noFill/>
+        </p:spPr>
+        <p:txBody>
+          <a:bodyPr wrap="square" lIns="0" rIns="0" tIns="0" bIns="0" anchor="t">
+            <a:spAutoFit/>
+          </a:bodyPr>
+          <a:lstStyle/>
+          <a:p>
+            <a:pPr algn="l"/>
+            <a:r>
+              <a:rPr sz="2400" b="0">
+                <a:solidFill>
+                  <a:srgbClr val="A4521D"/>
+                </a:solidFill>
+                <a:latin typeface="Source Serif 4"/>
+              </a:rPr>
+              <a:t>110,9 mln m³</a:t>
+            </a:r>
+          </a:p>
+        </p:txBody>
+      </p:sp>
+      <p:sp>
+        <p:nvSpPr>
+          <p:cNvPr id="17" name="TextBox 16"/>
+          <p:cNvSpPr txBox="1"/>
+          <p:nvPr/>
+        </p:nvSpPr>
+        <p:spPr>
+          <a:xfrm>
+            <a:off x="7930000" y="5150000"/>
+            <a:ext cx="3536192" cy="620000"/>
+          </a:xfrm>
+          <a:prstGeom prst="rect">
+            <a:avLst/>
+          </a:prstGeom>
+          <a:noFill/>
+        </p:spPr>
+        <p:txBody>
+          <a:bodyPr wrap="square" lIns="0" rIns="0" tIns="0" bIns="0" anchor="t">
+            <a:spAutoFit/>
+          </a:bodyPr>
+          <a:lstStyle/>
+          <a:p>
+            <a:pPr algn="l"/>
+            <a:r>
+              <a:rPr sz="1200" b="0">
+                <a:solidFill>
+                  <a:srgbClr val="4C5852"/>
+                </a:solidFill>
+                <a:latin typeface="Inter"/>
+              </a:rPr>
+              <a:t>Rezaksoy (quvvati 300): 2025 yilda 127, 2024 va 2023 yillarda 109–110 mln m³</a:t>
+            </a:r>
+          </a:p>
+        </p:txBody>
+      </p:sp>
+      <p:sp>
+        <p:nvSpPr>
+          <p:cNvPr id="18" name="TextBox 17"/>
+          <p:cNvSpPr txBox="1"/>
+          <p:nvPr/>
+        </p:nvSpPr>
+        <p:spPr>
+          <a:xfrm>
+            <a:off x="812800" y="6238280"/>
+            <a:ext cx="9800000" cy="240000"/>
+          </a:xfrm>
+          <a:prstGeom prst="rect">
+            <a:avLst/>
+          </a:prstGeom>
+          <a:noFill/>
+        </p:spPr>
+        <p:txBody>
+          <a:bodyPr wrap="square" lIns="0" rIns="0" tIns="0" bIns="0" anchor="t">
+            <a:spAutoFit/>
+          </a:bodyPr>
+          <a:lstStyle/>
+          <a:p>
+            <a:pPr algn="l"/>
+            <a:r>
+              <a:rPr sz="1200" b="0">
+                <a:solidFill>
+                  <a:srgbClr val="5F6B64"/>
+                </a:solidFill>
+                <a:latin typeface="Inter"/>
+              </a:rPr>
+              <a:t>Manba: respublika va respublikalararo suv omborlari ishlashi toʻgʻrisida maʼlumot, 2026-yil 9-yanvar holati</a:t>
+            </a:r>
+          </a:p>
+        </p:txBody>
+      </p:sp>
+    </p:spTree>
+  </p:cSld>
+  <p:clrMapOvr>
+    <a:masterClrMapping/>
+  </p:clrMapOvr>
+</p:sld>
+</file>
+
+<file path=ppt/slides/slide37.xml><?xml version="1.0" encoding="utf-8"?>
+<p:sld xmlns:a="http://schemas.openxmlformats.org/drawingml/2006/main" xmlns:p="http://schemas.openxmlformats.org/presentationml/2006/main" xmlns:r="http://schemas.openxmlformats.org/officeDocument/2006/relationships">
+  <p:cSld>
+    <p:bg>
+      <p:bgPr>
+        <a:solidFill>
+          <a:srgbClr val="F4F1EA"/>
+        </a:solidFill>
+      </p:bgPr>
+    </p:bg>
+    <p:spTree>
+      <p:nvGrpSpPr>
+        <p:cNvPr id="1" name=""/>
+        <p:cNvGrpSpPr/>
+        <p:nvPr/>
+      </p:nvGrpSpPr>
+      <p:grpSpPr/>
+      <p:sp>
+        <p:nvSpPr>
+          <p:cNvPr id="2" name="Text 0"/>
+          <p:cNvSpPr/>
+          <p:nvPr/>
+        </p:nvSpPr>
+        <p:spPr>
+          <a:xfrm>
+            <a:off x="812800" y="812800"/>
+            <a:ext cx="10883392" cy="238720"/>
+          </a:xfrm>
+          <a:prstGeom prst="rect">
+            <a:avLst/>
+          </a:prstGeom>
+          <a:noFill/>
+          <a:ln/>
+        </p:spPr>
+        <p:txBody>
+          <a:bodyPr wrap="square" lIns="0" tIns="0" rIns="0" bIns="0" rtlCol="0" anchor="t">
+            <a:normAutofit/>
+          </a:bodyPr>
+          <a:lstStyle/>
+          <a:p>
+            <a:pPr algn="l" indent="0" marL="0">
+              <a:lnSpc>
+                <a:spcPts val="1680"/>
+              </a:lnSpc>
+              <a:buNone/>
+            </a:pPr>
+            <a:r>
+              <a:rPr lang="en-US" sz="1200" b="1" spc="150" kern="0" dirty="0">
+                <a:solidFill>
+                  <a:srgbClr val="2C6A85"/>
+                </a:solidFill>
+                <a:latin typeface="Inter" pitchFamily="34" charset="0"/>
+                <a:ea typeface="Inter" pitchFamily="34" charset="-122"/>
+                <a:cs typeface="Inter" pitchFamily="34" charset="-120"/>
+              </a:rPr>
+              <a:t>29 · ADABIYOT TAHLILI</a:t>
+            </a:r>
+            <a:endParaRPr lang="en-US" sz="1200" dirty="0"/>
+          </a:p>
+        </p:txBody>
+      </p:sp>
+      <p:sp>
+        <p:nvSpPr>
+          <p:cNvPr id="3" name="Text 1"/>
+          <p:cNvSpPr/>
+          <p:nvPr>
+            <p:ph type="title"/>
+          </p:nvPr>
+        </p:nvSpPr>
+        <p:spPr>
+          <a:xfrm>
+            <a:off x="812800" y="1127720"/>
+            <a:ext cx="10883392" cy="472430"/>
+          </a:xfrm>
+          <a:prstGeom prst="rect">
+            <a:avLst/>
+          </a:prstGeom>
+          <a:noFill/>
+          <a:ln/>
+        </p:spPr>
+        <p:txBody>
+          <a:bodyPr wrap="square" lIns="0" tIns="0" rIns="0" bIns="0" rtlCol="0" anchor="t">
+            <a:normAutofit/>
+          </a:bodyPr>
+          <a:lstStyle/>
+          <a:p>
+            <a:pPr algn="l" indent="0" marL="0">
+              <a:lnSpc>
+                <a:spcPts val="3520"/>
+              </a:lnSpc>
+              <a:buNone/>
+            </a:pPr>
+            <a:r>
+              <a:rPr lang="en-US" sz="3200" b="0" i="0" dirty="0">
+                <a:solidFill>
+                  <a:srgbClr val="1D2A24"/>
+                </a:solidFill>
+                <a:latin typeface="Source Serif 4" pitchFamily="18" charset="0"/>
+                <a:ea typeface="Source Serif 4" pitchFamily="18" charset="-122"/>
+                <a:cs typeface="Source Serif 4" pitchFamily="18" charset="-120"/>
+              </a:rPr>
+              <a:t>Markaziy Fargʻona tuproqlari: oldingi tadqiqot</a:t>
+            </a:r>
+            <a:endParaRPr lang="en-US" sz="3200" dirty="0"/>
+          </a:p>
+        </p:txBody>
+      </p:sp>
+      <p:sp>
+        <p:nvSpPr>
+          <p:cNvPr id="6" name="Text 3"/>
+          <p:cNvSpPr/>
+          <p:nvPr/>
+        </p:nvSpPr>
+        <p:spPr>
+          <a:xfrm>
+            <a:off x="11137950" y="6238280"/>
+            <a:ext cx="241250" cy="238720"/>
+          </a:xfrm>
+          <a:prstGeom prst="rect">
+            <a:avLst/>
+          </a:prstGeom>
+          <a:noFill/>
+          <a:ln/>
+        </p:spPr>
+        <p:txBody>
+          <a:bodyPr wrap="square" lIns="0" tIns="0" rIns="0" bIns="0" rtlCol="0" anchor="t">
+            <a:normAutofit/>
+          </a:bodyPr>
+          <a:lstStyle/>
+          <a:p>
+            <a:pPr algn="r" indent="0" marL="0">
+              <a:lnSpc>
+                <a:spcPts val="1680"/>
+              </a:lnSpc>
+              <a:buNone/>
+            </a:pPr>
+            <a:r>
+              <a:rPr lang="en-US" sz="1200" dirty="0">
+                <a:solidFill>
+                  <a:srgbClr val="5F6B64"/>
+                </a:solidFill>
+                <a:latin typeface="Inter" pitchFamily="34" charset="0"/>
+                <a:ea typeface="Inter" pitchFamily="34" charset="-122"/>
+                <a:cs typeface="Inter" pitchFamily="34" charset="-120"/>
+              </a:rPr>
+              <a:t>30</a:t>
             </a:r>
             <a:endParaRPr lang="en-US" sz="1200" dirty="0"/>
           </a:p>

</xml_diff>

<commit_message>
Extend Fergana crop slide with 2021 and 2025 land data
Co-Authored-By: Claude Sonnet 5.5 <noreply@anthropic.com>
Claude-Session: https://claude.ai/code/session_01M4MZatV28utL9zTp7saaUz
</commit_message>
<xml_diff>
--- a/Garbiy_Farg_ona_tuproqlari_GAT_asosida_bashoratlash.pptx
+++ b/Garbiy_Farg_ona_tuproqlari_GAT_asosida_bashoratlash.pptx
@@ -21511,13 +21511,13 @@
           <a:p>
             <a:pPr algn="l"/>
             <a:r>
-              <a:rPr sz="2400" b="0">
+              <a:rPr sz="2200" b="0">
                 <a:solidFill>
                   <a:srgbClr val="A4521D"/>
                 </a:solidFill>
                 <a:latin typeface="Source Serif 4"/>
               </a:rPr>
-              <a:t>−5%</a:t>
+              <a:t>73,9 → 82,1 → 77,8</a:t>
             </a:r>
           </a:p>
         </p:txBody>
@@ -21552,7 +21552,7 @@
                 </a:solidFill>
                 <a:latin typeface="Inter"/>
               </a:rPr>
-              <a:t>Fargʻona viloyatida gʻoʻza maydoni 82,1 dan 77,8 ming gaga kamaygan (2022 → 2023); donli ekinlar 99,5 dan 95,7 ming gaga</a:t>
+              <a:t>Fargʻona viloyatida gʻoʻza maydoni, ming ga (2021 → 2022 → 2023); donli ekinlar 99,5 → 99,5 → 95,7</a:t>
             </a:r>
           </a:p>
         </p:txBody>
@@ -21629,13 +21629,13 @@
           <a:p>
             <a:pPr algn="l"/>
             <a:r>
-              <a:rPr sz="2400" b="0">
+              <a:rPr sz="2200" b="0">
                 <a:solidFill>
                   <a:srgbClr val="2C6A85"/>
                 </a:solidFill>
                 <a:latin typeface="Source Serif 4"/>
               </a:rPr>
-              <a:t>242,1 ming ga</a:t>
+              <a:t>242,1 → 239,6</a:t>
             </a:r>
           </a:p>
         </p:txBody>
@@ -21670,7 +21670,7 @@
                 </a:solidFill>
                 <a:latin typeface="Inter"/>
               </a:rPr>
-              <a:t>Jami ekin joylashtirish 2022 va 2023 yillarda deyarli oʻzgarmagan; tarkib oʻzgargan</a:t>
+              <a:t>Ekin joylashtirish 2022–2023 yillarda 242,1 ming ga; ekin yeri 2025-yil 1-yanvarda 239,6 ming ga (yer hisobi)</a:t>
             </a:r>
           </a:p>
         </p:txBody>
@@ -21823,7 +21823,7 @@
                 </a:solidFill>
                 <a:latin typeface="Inter"/>
               </a:rPr>
-              <a:t>Manba: Fargʻona viloyati ekin joylashtirish rejalari (2022, 2023) va fermer xoʻjaliklari ixtisosligi</a:t>
+              <a:t>Manba: Fargʻona viloyati ekin joylashtirish rejalari (2021–2023), yer hisobi (2025) va fermer xoʻjaliklari ixtisosligi</a:t>
             </a:r>
           </a:p>
         </p:txBody>

</xml_diff>

<commit_message>
Add Fergana cotton and grain area series 2021-2026
Co-Authored-By: Claude Sonnet 5.5 <noreply@anthropic.com>
Claude-Session: https://claude.ai/code/session_01M4MZatV28utL9zTp7saaUz
</commit_message>
<xml_diff>
--- a/Garbiy_Farg_ona_tuproqlari_GAT_asosida_bashoratlash.pptx
+++ b/Garbiy_Farg_ona_tuproqlari_GAT_asosida_bashoratlash.pptx
@@ -35,6 +35,7 @@
     <p:sldId id="290" r:id="rId41"/>
     <p:sldId id="291" r:id="rId42"/>
     <p:sldId id="292" r:id="rId43"/>
+    <p:sldId id="293" r:id="rId44"/>
     <p:sldId id="265" r:id="rId11"/>
     <p:sldId id="266" r:id="rId12"/>
     <p:sldId id="267" r:id="rId13"/>
@@ -4264,6 +4265,285 @@
 </file>
 
 <file path=ppt/charts/chart22.xml><?xml version="1.0" encoding="utf-8"?>
+<c:chartSpace xmlns:c="http://schemas.openxmlformats.org/drawingml/2006/chart" xmlns:a="http://schemas.openxmlformats.org/drawingml/2006/main" xmlns:r="http://schemas.openxmlformats.org/officeDocument/2006/relationships">
+  <c:date1904 val="0"/>
+  <c:chart>
+    <c:autoTitleDeleted val="1"/>
+    <c:plotArea>
+      <c:barChart>
+        <c:barDir val="col"/>
+        <c:grouping val="clustered"/>
+        <c:ser>
+          <c:idx val="0"/>
+          <c:order val="0"/>
+          <c:tx>
+            <c:strRef>
+              <c:f>Sheet1!$B$1</c:f>
+              <c:strCache>
+                <c:ptCount val="1"/>
+                <c:pt idx="0">
+                  <c:v>Gʻoʻza</c:v>
+                </c:pt>
+              </c:strCache>
+            </c:strRef>
+          </c:tx>
+          <c:spPr>
+            <a:solidFill>
+              <a:srgbClr val="A4521D"/>
+            </a:solidFill>
+          </c:spPr>
+          <c:cat>
+            <c:strRef>
+              <c:f>Sheet1!$A$2:$A$7</c:f>
+              <c:strCache>
+                <c:ptCount val="6"/>
+                <c:pt idx="0">
+                  <c:v>2021</c:v>
+                </c:pt>
+                <c:pt idx="1">
+                  <c:v>2022</c:v>
+                </c:pt>
+                <c:pt idx="2">
+                  <c:v>2023</c:v>
+                </c:pt>
+                <c:pt idx="3">
+                  <c:v>2024</c:v>
+                </c:pt>
+                <c:pt idx="4">
+                  <c:v>2025</c:v>
+                </c:pt>
+                <c:pt idx="5">
+                  <c:v>2026 (reja)</c:v>
+                </c:pt>
+              </c:strCache>
+            </c:strRef>
+          </c:cat>
+          <c:val>
+            <c:numRef>
+              <c:f>Sheet1!$B$2:$B$7</c:f>
+              <c:numCache>
+                <c:formatCode>General</c:formatCode>
+                <c:ptCount val="6"/>
+                <c:pt idx="0">
+                  <c:v>73.9</c:v>
+                </c:pt>
+                <c:pt idx="1">
+                  <c:v>82.1</c:v>
+                </c:pt>
+                <c:pt idx="2">
+                  <c:v>77.8</c:v>
+                </c:pt>
+                <c:pt idx="3">
+                  <c:v>76.0</c:v>
+                </c:pt>
+                <c:pt idx="4">
+                  <c:v>72.0</c:v>
+                </c:pt>
+                <c:pt idx="5">
+                  <c:v>72.0</c:v>
+                </c:pt>
+              </c:numCache>
+            </c:numRef>
+          </c:val>
+        </c:ser>
+        <c:ser>
+          <c:idx val="1"/>
+          <c:order val="1"/>
+          <c:tx>
+            <c:strRef>
+              <c:f>Sheet1!$C$1</c:f>
+              <c:strCache>
+                <c:ptCount val="1"/>
+                <c:pt idx="0">
+                  <c:v>Donli ekinlar</c:v>
+                </c:pt>
+              </c:strCache>
+            </c:strRef>
+          </c:tx>
+          <c:spPr>
+            <a:solidFill>
+              <a:srgbClr val="2C6A85"/>
+            </a:solidFill>
+          </c:spPr>
+          <c:cat>
+            <c:strRef>
+              <c:f>Sheet1!$A$2:$A$7</c:f>
+              <c:strCache>
+                <c:ptCount val="6"/>
+                <c:pt idx="0">
+                  <c:v>2021</c:v>
+                </c:pt>
+                <c:pt idx="1">
+                  <c:v>2022</c:v>
+                </c:pt>
+                <c:pt idx="2">
+                  <c:v>2023</c:v>
+                </c:pt>
+                <c:pt idx="3">
+                  <c:v>2024</c:v>
+                </c:pt>
+                <c:pt idx="4">
+                  <c:v>2025</c:v>
+                </c:pt>
+                <c:pt idx="5">
+                  <c:v>2026 (reja)</c:v>
+                </c:pt>
+              </c:strCache>
+            </c:strRef>
+          </c:cat>
+          <c:val>
+            <c:numRef>
+              <c:f>Sheet1!$C$2:$C$7</c:f>
+              <c:numCache>
+                <c:formatCode>General</c:formatCode>
+                <c:ptCount val="6"/>
+                <c:pt idx="0">
+                  <c:v>99.5</c:v>
+                </c:pt>
+                <c:pt idx="1">
+                  <c:v>99.5</c:v>
+                </c:pt>
+                <c:pt idx="2">
+                  <c:v>95.7</c:v>
+                </c:pt>
+                <c:pt idx="3">
+                  <c:v>95.7</c:v>
+                </c:pt>
+                <c:pt idx="4">
+                  <c:v>94.3</c:v>
+                </c:pt>
+                <c:pt idx="5">
+                  <c:v>92.2</c:v>
+                </c:pt>
+              </c:numCache>
+            </c:numRef>
+          </c:val>
+        </c:ser>
+        <c:dLbls>
+          <c:numFmt formatCode="0.0" sourceLinked="0"/>
+          <c:txPr>
+            <a:bodyPr/>
+            <a:lstStyle/>
+            <a:p>
+              <a:pPr>
+                <a:defRPr sz="1100">
+                  <a:solidFill>
+                    <a:srgbClr val="1D2A24"/>
+                  </a:solidFill>
+                  <a:latin typeface="Inter"/>
+                </a:defRPr>
+              </a:pPr>
+            </a:p>
+          </c:txPr>
+          <c:dLblPos val="outEnd"/>
+          <c:showLegendKey val="0"/>
+          <c:showVal val="1"/>
+          <c:showCatName val="0"/>
+          <c:showSerName val="0"/>
+          <c:showPercent val="0"/>
+          <c:showBubbleSize val="0"/>
+          <c:showLeaderLines val="1"/>
+        </c:dLbls>
+        <c:gapWidth val="45"/>
+        <c:overlap val="-5"/>
+        <c:axId val="-2068027336"/>
+        <c:axId val="-2113994440"/>
+      </c:barChart>
+      <c:catAx>
+        <c:axId val="-2068027336"/>
+        <c:scaling>
+          <c:orientation val="minMax"/>
+        </c:scaling>
+        <c:delete val="0"/>
+        <c:axPos val="b"/>
+        <c:majorTickMark val="out"/>
+        <c:minorTickMark val="none"/>
+        <c:tickLblPos val="nextTo"/>
+        <c:spPr>
+          <a:ln>
+            <a:solidFill>
+              <a:srgbClr val="B5B2AD"/>
+            </a:solidFill>
+          </a:ln>
+        </c:spPr>
+        <c:txPr>
+          <a:bodyPr/>
+          <a:lstStyle/>
+          <a:p>
+            <a:pPr>
+              <a:defRPr sz="1200">
+                <a:solidFill>
+                  <a:srgbClr val="4C5852"/>
+                </a:solidFill>
+                <a:latin typeface="Inter"/>
+              </a:defRPr>
+            </a:pPr>
+          </a:p>
+        </c:txPr>
+        <c:crossAx val="-2113994440"/>
+        <c:crosses val="autoZero"/>
+        <c:auto val="1"/>
+        <c:lblAlgn val="ctr"/>
+        <c:lblOffset val="100"/>
+        <c:noMultiLvlLbl val="0"/>
+      </c:catAx>
+      <c:valAx>
+        <c:axId val="-2113994440"/>
+        <c:scaling>
+          <c:max val="115.0"/>
+          <c:min val="0.0"/>
+        </c:scaling>
+        <c:delete/>
+        <c:axPos val="l"/>
+        <c:majorTickMark val="out"/>
+        <c:minorTickMark val="none"/>
+        <c:tickLblPos val="nextTo"/>
+        <c:crossAx val="-2068027336"/>
+        <c:crosses val="autoZero"/>
+      </c:valAx>
+    </c:plotArea>
+    <c:legend>
+      <c:legendPos val="t"/>
+      <c:overlay val="0"/>
+      <c:txPr>
+        <a:bodyPr/>
+        <a:lstStyle/>
+        <a:p>
+          <a:pPr>
+            <a:defRPr sz="1200">
+              <a:solidFill>
+                <a:srgbClr val="4C5852"/>
+              </a:solidFill>
+              <a:latin typeface="Inter"/>
+            </a:defRPr>
+          </a:pPr>
+        </a:p>
+      </c:txPr>
+    </c:legend>
+    <c:dispBlanksAs val="gap"/>
+  </c:chart>
+  <c:txPr>
+    <a:bodyPr/>
+    <a:lstStyle/>
+    <a:p>
+      <a:pPr>
+        <a:defRPr sz="1200">
+          <a:solidFill>
+            <a:srgbClr val="4C5852"/>
+          </a:solidFill>
+          <a:latin typeface="Inter"/>
+        </a:defRPr>
+      </a:pPr>
+      <a:endParaRPr lang="en-US"/>
+    </a:p>
+  </c:txPr>
+  <c:externalData r:id="rId1">
+    <c:autoUpdate val="0"/>
+  </c:externalData>
+</c:chartSpace>
+</file>
+
+<file path=ppt/charts/chart23.xml><?xml version="1.0" encoding="utf-8"?>
 <c:chartSpace xmlns:c="http://schemas.openxmlformats.org/drawingml/2006/chart" xmlns:a="http://schemas.openxmlformats.org/drawingml/2006/main" xmlns:r="http://schemas.openxmlformats.org/officeDocument/2006/relationships">
   <c:date1904 val="0"/>
   <c:chart>
@@ -9079,7 +9359,7 @@
                 <a:ea typeface="Inter" pitchFamily="34" charset="-122"/>
                 <a:cs typeface="Inter" pitchFamily="34" charset="-120"/>
               </a:rPr>
-              <a:t>30 · DISSERTATSIYA TUZILISHI</a:t>
+              <a:t>31 · DISSERTATSIYA TUZILISHI</a:t>
             </a:r>
             <a:endParaRPr lang="en-US" sz="1200" dirty="0"/>
           </a:p>
@@ -9878,7 +10158,7 @@
                 <a:ea typeface="Inter" pitchFamily="34" charset="-122"/>
                 <a:cs typeface="Inter" pitchFamily="34" charset="-120"/>
               </a:rPr>
-              <a:t>31</a:t>
+              <a:t>32</a:t>
             </a:r>
             <a:endParaRPr lang="en-US" sz="1200" dirty="0"/>
           </a:p>
@@ -9954,7 +10234,7 @@
                 <a:ea typeface="Inter" pitchFamily="34" charset="-122"/>
                 <a:cs typeface="Inter" pitchFamily="34" charset="-120"/>
               </a:rPr>
-              <a:t>31 · DISSERTATSIYA TUZILISHI</a:t>
+              <a:t>32 · DISSERTATSIYA TUZILISHI</a:t>
             </a:r>
             <a:endParaRPr lang="en-US" sz="1200" dirty="0"/>
           </a:p>
@@ -10986,7 +11266,7 @@
                 <a:ea typeface="Inter" pitchFamily="34" charset="-122"/>
                 <a:cs typeface="Inter" pitchFamily="34" charset="-120"/>
               </a:rPr>
-              <a:t>32</a:t>
+              <a:t>33</a:t>
             </a:r>
             <a:endParaRPr lang="en-US" sz="1200" dirty="0"/>
           </a:p>
@@ -11062,7 +11342,7 @@
                 <a:ea typeface="Inter" pitchFamily="34" charset="-122"/>
                 <a:cs typeface="Inter" pitchFamily="34" charset="-120"/>
               </a:rPr>
-              <a:t>32 · DISSERTATSIYA TUZILISHI</a:t>
+              <a:t>33 · DISSERTATSIYA TUZILISHI</a:t>
             </a:r>
             <a:endParaRPr lang="en-US" sz="1200" dirty="0"/>
           </a:p>
@@ -12089,7 +12369,7 @@
                 <a:ea typeface="Inter" pitchFamily="34" charset="-122"/>
                 <a:cs typeface="Inter" pitchFamily="34" charset="-120"/>
               </a:rPr>
-              <a:t>33</a:t>
+              <a:t>34</a:t>
             </a:r>
             <a:endParaRPr lang="en-US" sz="1200" dirty="0"/>
           </a:p>
@@ -12165,7 +12445,7 @@
                 <a:ea typeface="Inter" pitchFamily="34" charset="-122"/>
                 <a:cs typeface="Inter" pitchFamily="34" charset="-120"/>
               </a:rPr>
-              <a:t>33 · NATIJALAR VA REJA</a:t>
+              <a:t>34 · NATIJALAR VA REJA</a:t>
             </a:r>
             <a:endParaRPr lang="en-US" sz="1200" dirty="0"/>
           </a:p>
@@ -12903,7 +13183,7 @@
                 <a:ea typeface="Inter" pitchFamily="34" charset="-122"/>
                 <a:cs typeface="Inter" pitchFamily="34" charset="-120"/>
               </a:rPr>
-              <a:t>34</a:t>
+              <a:t>35</a:t>
             </a:r>
             <a:endParaRPr lang="en-US" sz="1200" dirty="0"/>
           </a:p>
@@ -12979,7 +13259,7 @@
                 <a:ea typeface="Inter" pitchFamily="34" charset="-122"/>
                 <a:cs typeface="Inter" pitchFamily="34" charset="-120"/>
               </a:rPr>
-              <a:t>34 · NATIJALAR VA REJA</a:t>
+              <a:t>35 · NATIJALAR VA REJA</a:t>
             </a:r>
             <a:endParaRPr lang="en-US" sz="1200" dirty="0"/>
           </a:p>
@@ -14005,7 +14285,7 @@
                 <a:ea typeface="Inter" pitchFamily="34" charset="-122"/>
                 <a:cs typeface="Inter" pitchFamily="34" charset="-120"/>
               </a:rPr>
-              <a:t>35</a:t>
+              <a:t>36</a:t>
             </a:r>
             <a:endParaRPr lang="en-US" sz="1200" dirty="0"/>
           </a:p>
@@ -14081,7 +14361,7 @@
                 <a:ea typeface="Inter" pitchFamily="34" charset="-122"/>
                 <a:cs typeface="Inter" pitchFamily="34" charset="-120"/>
               </a:rPr>
-              <a:t>35 · NATIJALAR VA REJA</a:t>
+              <a:t>36 · NATIJALAR VA REJA</a:t>
             </a:r>
             <a:endParaRPr lang="en-US" sz="1200" dirty="0"/>
           </a:p>
@@ -14693,7 +14973,7 @@
                 <a:ea typeface="Inter" pitchFamily="34" charset="-122"/>
                 <a:cs typeface="Inter" pitchFamily="34" charset="-120"/>
               </a:rPr>
-              <a:t>36</a:t>
+              <a:t>37</a:t>
             </a:r>
             <a:endParaRPr lang="en-US" sz="1200" dirty="0"/>
           </a:p>
@@ -27556,7 +27836,7 @@
                 <a:ea typeface="Source Serif 4" pitchFamily="18" charset="-122"/>
                 <a:cs typeface="Source Serif 4" pitchFamily="18" charset="-120"/>
               </a:rPr>
-              <a:t>Suv omborlari: 9 yanvar holati</a:t>
+              <a:t>Fargʻona viloyati: gʻoʻza va donli ekinlar</a:t>
             </a:r>
             <a:endParaRPr lang="en-US" sz="3200" dirty="0"/>
           </a:p>
@@ -27636,7 +27916,7 @@
                 </a:solidFill>
                 <a:latin typeface="Inter"/>
               </a:rPr>
-              <a:t>Suv ombori hajmi 9 yanvarda, mln m³</a:t>
+              <a:t>Gʻoʻza va donli ekinlar maydoni, ming ga (2021–2026)</a:t>
             </a:r>
           </a:p>
         </p:txBody>
@@ -27737,7 +28017,7 @@
                 </a:solidFill>
                 <a:latin typeface="Source Serif 4"/>
               </a:rPr>
-              <a:t>909,3 mln m³</a:t>
+              <a:t>−12%</a:t>
             </a:r>
           </a:p>
         </p:txBody>
@@ -27772,7 +28052,7 @@
                 </a:solidFill>
                 <a:latin typeface="Inter"/>
               </a:rPr>
-              <a:t>Andijon suv ombori (quvvati 1 900): 2025 yilning shu kuniga nisbatan −20%, 2024 yilga nisbatan +10%</a:t>
+              <a:t>Gʻoʻza maydoni 82,1 dan 72,0 ming gaga kamayadi (2022 → 2026 reja); 2025 va 2026 rejalarida bir xil</a:t>
             </a:r>
           </a:p>
         </p:txBody>
@@ -27855,7 +28135,7 @@
                 </a:solidFill>
                 <a:latin typeface="Source Serif 4"/>
               </a:rPr>
-              <a:t>−66%</a:t>
+              <a:t>−7%</a:t>
             </a:r>
           </a:p>
         </p:txBody>
@@ -27890,7 +28170,7 @@
                 </a:solidFill>
                 <a:latin typeface="Inter"/>
               </a:rPr>
-              <a:t>Kosonsoy hajmi 65 dan 22,1 mln m³ gacha kamaygan (2025 → 2026); Karkidon −32%</a:t>
+              <a:t>Donli ekinlar 99,5 dan 92,2 ming gaga (2021 → 2026 reja)</a:t>
             </a:r>
           </a:p>
         </p:txBody>
@@ -27973,7 +28253,7 @@
                 </a:solidFill>
                 <a:latin typeface="Source Serif 4"/>
               </a:rPr>
-              <a:t>110,9 mln m³</a:t>
+              <a:t>3 viloyat</a:t>
             </a:r>
           </a:p>
         </p:txBody>
@@ -28008,7 +28288,7 @@
                 </a:solidFill>
                 <a:latin typeface="Inter"/>
               </a:rPr>
-              <a:t>Rezaksoy (quvvati 300): 2025 yilda 127, 2024 va 2023 yillarda 109–110 mln m³</a:t>
+              <a:t>Andijon, Fargʻona va Namangan: paxta maydoni barchasida qisqarmoqda</a:t>
             </a:r>
           </a:p>
         </p:txBody>
@@ -28043,7 +28323,7 @@
                 </a:solidFill>
                 <a:latin typeface="Inter"/>
               </a:rPr>
-              <a:t>Manba: respublika va respublikalararo suv omborlari ishlashi toʻgʻrisida maʼlumot, 2026-yil 9-yanvar holati</a:t>
+              <a:t>Manba: Fargʻona viloyati ekin joylashtirish rejalari va takliflari (2021–2026); 2025–2026 — taklif/reja</a:t>
             </a:r>
           </a:p>
         </p:txBody>
@@ -28111,7 +28391,7 @@
                 <a:ea typeface="Inter" pitchFamily="34" charset="-122"/>
                 <a:cs typeface="Inter" pitchFamily="34" charset="-120"/>
               </a:rPr>
-              <a:t>29 · ADABIYOT TAHLILI</a:t>
+              <a:t>29 · DASTLABKI MAʼLUMOTLAR</a:t>
             </a:r>
             <a:endParaRPr lang="en-US" sz="1200" dirty="0"/>
           </a:p>
@@ -28157,7 +28437,7 @@
                 <a:ea typeface="Source Serif 4" pitchFamily="18" charset="-122"/>
                 <a:cs typeface="Source Serif 4" pitchFamily="18" charset="-120"/>
               </a:rPr>
-              <a:t>Markaziy Fargʻona tuproqlari: oldingi tadqiqot</a:t>
+              <a:t>Suv omborlari: 9 yanvar holati</a:t>
             </a:r>
             <a:endParaRPr lang="en-US" sz="3200" dirty="0"/>
           </a:p>
@@ -28202,6 +28482,607 @@
                 <a:cs typeface="Inter" pitchFamily="34" charset="-120"/>
               </a:rPr>
               <a:t>30</a:t>
+            </a:r>
+            <a:endParaRPr lang="en-US" sz="1200" dirty="0"/>
+          </a:p>
+        </p:txBody>
+      </p:sp>
+      <p:sp>
+        <p:nvSpPr>
+          <p:cNvPr id="7" name="TextBox 6"/>
+          <p:cNvSpPr txBox="1"/>
+          <p:nvPr/>
+        </p:nvSpPr>
+        <p:spPr>
+          <a:xfrm>
+            <a:off x="812800" y="1830000"/>
+            <a:ext cx="6200000" cy="260000"/>
+          </a:xfrm>
+          <a:prstGeom prst="rect">
+            <a:avLst/>
+          </a:prstGeom>
+          <a:noFill/>
+        </p:spPr>
+        <p:txBody>
+          <a:bodyPr wrap="square" lIns="0" rIns="0" tIns="0" bIns="0" anchor="t">
+            <a:spAutoFit/>
+          </a:bodyPr>
+          <a:lstStyle/>
+          <a:p>
+            <a:pPr algn="l"/>
+            <a:r>
+              <a:rPr sz="1300" b="1">
+                <a:solidFill>
+                  <a:srgbClr val="2C6A85"/>
+                </a:solidFill>
+                <a:latin typeface="Inter"/>
+              </a:rPr>
+              <a:t>Suv ombori hajmi 9 yanvarda, mln m³</a:t>
+            </a:r>
+          </a:p>
+        </p:txBody>
+      </p:sp>
+      <p:graphicFrame>
+        <p:nvGraphicFramePr>
+          <p:cNvPr id="8" name="Chart 7"/>
+          <p:cNvGraphicFramePr>
+            <a:graphicFrameLocks noGrp="1"/>
+          </p:cNvGraphicFramePr>
+          <p:nvPr/>
+        </p:nvGraphicFramePr>
+        <p:xfrm>
+          <a:off x="752800" y="2080000"/>
+          <a:ext cx="6600000" cy="4000000"/>
+        </p:xfrm>
+        <a:graphic>
+          <a:graphicData uri="http://schemas.openxmlformats.org/drawingml/2006/chart">
+            <c:chart xmlns:c="http://schemas.openxmlformats.org/drawingml/2006/chart" r:id="rId2"/>
+          </a:graphicData>
+        </a:graphic>
+      </p:graphicFrame>
+      <p:sp>
+        <p:nvSpPr>
+          <p:cNvPr id="9" name="Rounded Rectangle 8"/>
+          <p:cNvSpPr/>
+          <p:nvPr/>
+        </p:nvSpPr>
+        <p:spPr>
+          <a:xfrm>
+            <a:off x="7700000" y="1830000"/>
+            <a:ext cx="3996192" cy="1230000"/>
+          </a:xfrm>
+          <a:prstGeom prst="roundRect">
+            <a:avLst>
+              <a:gd name="adj" fmla="val 5000"/>
+            </a:avLst>
+          </a:prstGeom>
+          <a:solidFill>
+            <a:srgbClr val="FBF9F4"/>
+          </a:solidFill>
+          <a:ln w="6350">
+            <a:solidFill>
+              <a:srgbClr val="D9D2C3"/>
+            </a:solidFill>
+          </a:ln>
+          <a:effectLst/>
+        </p:spPr>
+        <p:style>
+          <a:lnRef idx="1">
+            <a:schemeClr val="accent1"/>
+          </a:lnRef>
+          <a:fillRef idx="3">
+            <a:schemeClr val="accent1"/>
+          </a:fillRef>
+          <a:effectRef idx="2">
+            <a:schemeClr val="accent1"/>
+          </a:effectRef>
+          <a:fontRef idx="minor">
+            <a:schemeClr val="lt1"/>
+          </a:fontRef>
+        </p:style>
+        <p:txBody>
+          <a:bodyPr rtlCol="0" anchor="ctr"/>
+          <a:lstStyle/>
+          <a:p>
+            <a:pPr algn="ctr"/>
+          </a:p>
+        </p:txBody>
+      </p:sp>
+      <p:sp>
+        <p:nvSpPr>
+          <p:cNvPr id="10" name="TextBox 9"/>
+          <p:cNvSpPr txBox="1"/>
+          <p:nvPr/>
+        </p:nvSpPr>
+        <p:spPr>
+          <a:xfrm>
+            <a:off x="7930000" y="1950000"/>
+            <a:ext cx="3536192" cy="420000"/>
+          </a:xfrm>
+          <a:prstGeom prst="rect">
+            <a:avLst/>
+          </a:prstGeom>
+          <a:noFill/>
+        </p:spPr>
+        <p:txBody>
+          <a:bodyPr wrap="square" lIns="0" rIns="0" tIns="0" bIns="0" anchor="t">
+            <a:spAutoFit/>
+          </a:bodyPr>
+          <a:lstStyle/>
+          <a:p>
+            <a:pPr algn="l"/>
+            <a:r>
+              <a:rPr sz="2400" b="0">
+                <a:solidFill>
+                  <a:srgbClr val="A4521D"/>
+                </a:solidFill>
+                <a:latin typeface="Source Serif 4"/>
+              </a:rPr>
+              <a:t>909,3 mln m³</a:t>
+            </a:r>
+          </a:p>
+        </p:txBody>
+      </p:sp>
+      <p:sp>
+        <p:nvSpPr>
+          <p:cNvPr id="11" name="TextBox 10"/>
+          <p:cNvSpPr txBox="1"/>
+          <p:nvPr/>
+        </p:nvSpPr>
+        <p:spPr>
+          <a:xfrm>
+            <a:off x="7930000" y="2390000"/>
+            <a:ext cx="3536192" cy="620000"/>
+          </a:xfrm>
+          <a:prstGeom prst="rect">
+            <a:avLst/>
+          </a:prstGeom>
+          <a:noFill/>
+        </p:spPr>
+        <p:txBody>
+          <a:bodyPr wrap="square" lIns="0" rIns="0" tIns="0" bIns="0" anchor="t">
+            <a:spAutoFit/>
+          </a:bodyPr>
+          <a:lstStyle/>
+          <a:p>
+            <a:pPr algn="l"/>
+            <a:r>
+              <a:rPr sz="1200" b="0">
+                <a:solidFill>
+                  <a:srgbClr val="4C5852"/>
+                </a:solidFill>
+                <a:latin typeface="Inter"/>
+              </a:rPr>
+              <a:t>Andijon suv ombori (quvvati 1 900): 2025 yilning shu kuniga nisbatan −20%, 2024 yilga nisbatan +10%</a:t>
+            </a:r>
+          </a:p>
+        </p:txBody>
+      </p:sp>
+      <p:sp>
+        <p:nvSpPr>
+          <p:cNvPr id="12" name="Rounded Rectangle 11"/>
+          <p:cNvSpPr/>
+          <p:nvPr/>
+        </p:nvSpPr>
+        <p:spPr>
+          <a:xfrm>
+            <a:off x="7700000" y="3210000"/>
+            <a:ext cx="3996192" cy="1230000"/>
+          </a:xfrm>
+          <a:prstGeom prst="roundRect">
+            <a:avLst>
+              <a:gd name="adj" fmla="val 5000"/>
+            </a:avLst>
+          </a:prstGeom>
+          <a:solidFill>
+            <a:srgbClr val="FBF9F4"/>
+          </a:solidFill>
+          <a:ln w="6350">
+            <a:solidFill>
+              <a:srgbClr val="D9D2C3"/>
+            </a:solidFill>
+          </a:ln>
+          <a:effectLst/>
+        </p:spPr>
+        <p:style>
+          <a:lnRef idx="1">
+            <a:schemeClr val="accent1"/>
+          </a:lnRef>
+          <a:fillRef idx="3">
+            <a:schemeClr val="accent1"/>
+          </a:fillRef>
+          <a:effectRef idx="2">
+            <a:schemeClr val="accent1"/>
+          </a:effectRef>
+          <a:fontRef idx="minor">
+            <a:schemeClr val="lt1"/>
+          </a:fontRef>
+        </p:style>
+        <p:txBody>
+          <a:bodyPr rtlCol="0" anchor="ctr"/>
+          <a:lstStyle/>
+          <a:p>
+            <a:pPr algn="ctr"/>
+          </a:p>
+        </p:txBody>
+      </p:sp>
+      <p:sp>
+        <p:nvSpPr>
+          <p:cNvPr id="13" name="TextBox 12"/>
+          <p:cNvSpPr txBox="1"/>
+          <p:nvPr/>
+        </p:nvSpPr>
+        <p:spPr>
+          <a:xfrm>
+            <a:off x="7930000" y="3330000"/>
+            <a:ext cx="3536192" cy="420000"/>
+          </a:xfrm>
+          <a:prstGeom prst="rect">
+            <a:avLst/>
+          </a:prstGeom>
+          <a:noFill/>
+        </p:spPr>
+        <p:txBody>
+          <a:bodyPr wrap="square" lIns="0" rIns="0" tIns="0" bIns="0" anchor="t">
+            <a:spAutoFit/>
+          </a:bodyPr>
+          <a:lstStyle/>
+          <a:p>
+            <a:pPr algn="l"/>
+            <a:r>
+              <a:rPr sz="2400" b="0">
+                <a:solidFill>
+                  <a:srgbClr val="2C6A85"/>
+                </a:solidFill>
+                <a:latin typeface="Source Serif 4"/>
+              </a:rPr>
+              <a:t>−66%</a:t>
+            </a:r>
+          </a:p>
+        </p:txBody>
+      </p:sp>
+      <p:sp>
+        <p:nvSpPr>
+          <p:cNvPr id="14" name="TextBox 13"/>
+          <p:cNvSpPr txBox="1"/>
+          <p:nvPr/>
+        </p:nvSpPr>
+        <p:spPr>
+          <a:xfrm>
+            <a:off x="7930000" y="3770000"/>
+            <a:ext cx="3536192" cy="620000"/>
+          </a:xfrm>
+          <a:prstGeom prst="rect">
+            <a:avLst/>
+          </a:prstGeom>
+          <a:noFill/>
+        </p:spPr>
+        <p:txBody>
+          <a:bodyPr wrap="square" lIns="0" rIns="0" tIns="0" bIns="0" anchor="t">
+            <a:spAutoFit/>
+          </a:bodyPr>
+          <a:lstStyle/>
+          <a:p>
+            <a:pPr algn="l"/>
+            <a:r>
+              <a:rPr sz="1200" b="0">
+                <a:solidFill>
+                  <a:srgbClr val="4C5852"/>
+                </a:solidFill>
+                <a:latin typeface="Inter"/>
+              </a:rPr>
+              <a:t>Kosonsoy hajmi 65 dan 22,1 mln m³ gacha kamaygan (2025 → 2026); Karkidon −32%</a:t>
+            </a:r>
+          </a:p>
+        </p:txBody>
+      </p:sp>
+      <p:sp>
+        <p:nvSpPr>
+          <p:cNvPr id="15" name="Rounded Rectangle 14"/>
+          <p:cNvSpPr/>
+          <p:nvPr/>
+        </p:nvSpPr>
+        <p:spPr>
+          <a:xfrm>
+            <a:off x="7700000" y="4590000"/>
+            <a:ext cx="3996192" cy="1230000"/>
+          </a:xfrm>
+          <a:prstGeom prst="roundRect">
+            <a:avLst>
+              <a:gd name="adj" fmla="val 5000"/>
+            </a:avLst>
+          </a:prstGeom>
+          <a:solidFill>
+            <a:srgbClr val="FBF9F4"/>
+          </a:solidFill>
+          <a:ln w="6350">
+            <a:solidFill>
+              <a:srgbClr val="D9D2C3"/>
+            </a:solidFill>
+          </a:ln>
+          <a:effectLst/>
+        </p:spPr>
+        <p:style>
+          <a:lnRef idx="1">
+            <a:schemeClr val="accent1"/>
+          </a:lnRef>
+          <a:fillRef idx="3">
+            <a:schemeClr val="accent1"/>
+          </a:fillRef>
+          <a:effectRef idx="2">
+            <a:schemeClr val="accent1"/>
+          </a:effectRef>
+          <a:fontRef idx="minor">
+            <a:schemeClr val="lt1"/>
+          </a:fontRef>
+        </p:style>
+        <p:txBody>
+          <a:bodyPr rtlCol="0" anchor="ctr"/>
+          <a:lstStyle/>
+          <a:p>
+            <a:pPr algn="ctr"/>
+          </a:p>
+        </p:txBody>
+      </p:sp>
+      <p:sp>
+        <p:nvSpPr>
+          <p:cNvPr id="16" name="TextBox 15"/>
+          <p:cNvSpPr txBox="1"/>
+          <p:nvPr/>
+        </p:nvSpPr>
+        <p:spPr>
+          <a:xfrm>
+            <a:off x="7930000" y="4710000"/>
+            <a:ext cx="3536192" cy="420000"/>
+          </a:xfrm>
+          <a:prstGeom prst="rect">
+            <a:avLst/>
+          </a:prstGeom>
+          <a:noFill/>
+        </p:spPr>
+        <p:txBody>
+          <a:bodyPr wrap="square" lIns="0" rIns="0" tIns="0" bIns="0" anchor="t">
+            <a:spAutoFit/>
+          </a:bodyPr>
+          <a:lstStyle/>
+          <a:p>
+            <a:pPr algn="l"/>
+            <a:r>
+              <a:rPr sz="2400" b="0">
+                <a:solidFill>
+                  <a:srgbClr val="A4521D"/>
+                </a:solidFill>
+                <a:latin typeface="Source Serif 4"/>
+              </a:rPr>
+              <a:t>110,9 mln m³</a:t>
+            </a:r>
+          </a:p>
+        </p:txBody>
+      </p:sp>
+      <p:sp>
+        <p:nvSpPr>
+          <p:cNvPr id="17" name="TextBox 16"/>
+          <p:cNvSpPr txBox="1"/>
+          <p:nvPr/>
+        </p:nvSpPr>
+        <p:spPr>
+          <a:xfrm>
+            <a:off x="7930000" y="5150000"/>
+            <a:ext cx="3536192" cy="620000"/>
+          </a:xfrm>
+          <a:prstGeom prst="rect">
+            <a:avLst/>
+          </a:prstGeom>
+          <a:noFill/>
+        </p:spPr>
+        <p:txBody>
+          <a:bodyPr wrap="square" lIns="0" rIns="0" tIns="0" bIns="0" anchor="t">
+            <a:spAutoFit/>
+          </a:bodyPr>
+          <a:lstStyle/>
+          <a:p>
+            <a:pPr algn="l"/>
+            <a:r>
+              <a:rPr sz="1200" b="0">
+                <a:solidFill>
+                  <a:srgbClr val="4C5852"/>
+                </a:solidFill>
+                <a:latin typeface="Inter"/>
+              </a:rPr>
+              <a:t>Rezaksoy (quvvati 300): 2025 yilda 127, 2024 va 2023 yillarda 109–110 mln m³</a:t>
+            </a:r>
+          </a:p>
+        </p:txBody>
+      </p:sp>
+      <p:sp>
+        <p:nvSpPr>
+          <p:cNvPr id="18" name="TextBox 17"/>
+          <p:cNvSpPr txBox="1"/>
+          <p:nvPr/>
+        </p:nvSpPr>
+        <p:spPr>
+          <a:xfrm>
+            <a:off x="812800" y="6238280"/>
+            <a:ext cx="9800000" cy="240000"/>
+          </a:xfrm>
+          <a:prstGeom prst="rect">
+            <a:avLst/>
+          </a:prstGeom>
+          <a:noFill/>
+        </p:spPr>
+        <p:txBody>
+          <a:bodyPr wrap="square" lIns="0" rIns="0" tIns="0" bIns="0" anchor="t">
+            <a:spAutoFit/>
+          </a:bodyPr>
+          <a:lstStyle/>
+          <a:p>
+            <a:pPr algn="l"/>
+            <a:r>
+              <a:rPr sz="1200" b="0">
+                <a:solidFill>
+                  <a:srgbClr val="5F6B64"/>
+                </a:solidFill>
+                <a:latin typeface="Inter"/>
+              </a:rPr>
+              <a:t>Manba: respublika va respublikalararo suv omborlari ishlashi toʻgʻrisida maʼlumot, 2026-yil 9-yanvar holati</a:t>
+            </a:r>
+          </a:p>
+        </p:txBody>
+      </p:sp>
+    </p:spTree>
+  </p:cSld>
+  <p:clrMapOvr>
+    <a:masterClrMapping/>
+  </p:clrMapOvr>
+</p:sld>
+</file>
+
+<file path=ppt/slides/slide38.xml><?xml version="1.0" encoding="utf-8"?>
+<p:sld xmlns:a="http://schemas.openxmlformats.org/drawingml/2006/main" xmlns:p="http://schemas.openxmlformats.org/presentationml/2006/main" xmlns:r="http://schemas.openxmlformats.org/officeDocument/2006/relationships">
+  <p:cSld>
+    <p:bg>
+      <p:bgPr>
+        <a:solidFill>
+          <a:srgbClr val="F4F1EA"/>
+        </a:solidFill>
+      </p:bgPr>
+    </p:bg>
+    <p:spTree>
+      <p:nvGrpSpPr>
+        <p:cNvPr id="1" name=""/>
+        <p:cNvGrpSpPr/>
+        <p:nvPr/>
+      </p:nvGrpSpPr>
+      <p:grpSpPr/>
+      <p:sp>
+        <p:nvSpPr>
+          <p:cNvPr id="2" name="Text 0"/>
+          <p:cNvSpPr/>
+          <p:nvPr/>
+        </p:nvSpPr>
+        <p:spPr>
+          <a:xfrm>
+            <a:off x="812800" y="812800"/>
+            <a:ext cx="10883392" cy="238720"/>
+          </a:xfrm>
+          <a:prstGeom prst="rect">
+            <a:avLst/>
+          </a:prstGeom>
+          <a:noFill/>
+          <a:ln/>
+        </p:spPr>
+        <p:txBody>
+          <a:bodyPr wrap="square" lIns="0" tIns="0" rIns="0" bIns="0" rtlCol="0" anchor="t">
+            <a:normAutofit/>
+          </a:bodyPr>
+          <a:lstStyle/>
+          <a:p>
+            <a:pPr algn="l" indent="0" marL="0">
+              <a:lnSpc>
+                <a:spcPts val="1680"/>
+              </a:lnSpc>
+              <a:buNone/>
+            </a:pPr>
+            <a:r>
+              <a:rPr lang="en-US" sz="1200" b="1" spc="150" kern="0" dirty="0">
+                <a:solidFill>
+                  <a:srgbClr val="2C6A85"/>
+                </a:solidFill>
+                <a:latin typeface="Inter" pitchFamily="34" charset="0"/>
+                <a:ea typeface="Inter" pitchFamily="34" charset="-122"/>
+                <a:cs typeface="Inter" pitchFamily="34" charset="-120"/>
+              </a:rPr>
+              <a:t>30 · ADABIYOT TAHLILI</a:t>
+            </a:r>
+            <a:endParaRPr lang="en-US" sz="1200" dirty="0"/>
+          </a:p>
+        </p:txBody>
+      </p:sp>
+      <p:sp>
+        <p:nvSpPr>
+          <p:cNvPr id="3" name="Text 1"/>
+          <p:cNvSpPr/>
+          <p:nvPr>
+            <p:ph type="title"/>
+          </p:nvPr>
+        </p:nvSpPr>
+        <p:spPr>
+          <a:xfrm>
+            <a:off x="812800" y="1127720"/>
+            <a:ext cx="10883392" cy="472430"/>
+          </a:xfrm>
+          <a:prstGeom prst="rect">
+            <a:avLst/>
+          </a:prstGeom>
+          <a:noFill/>
+          <a:ln/>
+        </p:spPr>
+        <p:txBody>
+          <a:bodyPr wrap="square" lIns="0" tIns="0" rIns="0" bIns="0" rtlCol="0" anchor="t">
+            <a:normAutofit/>
+          </a:bodyPr>
+          <a:lstStyle/>
+          <a:p>
+            <a:pPr algn="l" indent="0" marL="0">
+              <a:lnSpc>
+                <a:spcPts val="3520"/>
+              </a:lnSpc>
+              <a:buNone/>
+            </a:pPr>
+            <a:r>
+              <a:rPr lang="en-US" sz="3200" b="0" i="0" dirty="0">
+                <a:solidFill>
+                  <a:srgbClr val="1D2A24"/>
+                </a:solidFill>
+                <a:latin typeface="Source Serif 4" pitchFamily="18" charset="0"/>
+                <a:ea typeface="Source Serif 4" pitchFamily="18" charset="-122"/>
+                <a:cs typeface="Source Serif 4" pitchFamily="18" charset="-120"/>
+              </a:rPr>
+              <a:t>Markaziy Fargʻona tuproqlari: oldingi tadqiqot</a:t>
+            </a:r>
+            <a:endParaRPr lang="en-US" sz="3200" dirty="0"/>
+          </a:p>
+        </p:txBody>
+      </p:sp>
+      <p:sp>
+        <p:nvSpPr>
+          <p:cNvPr id="6" name="Text 3"/>
+          <p:cNvSpPr/>
+          <p:nvPr/>
+        </p:nvSpPr>
+        <p:spPr>
+          <a:xfrm>
+            <a:off x="11137950" y="6238280"/>
+            <a:ext cx="241250" cy="238720"/>
+          </a:xfrm>
+          <a:prstGeom prst="rect">
+            <a:avLst/>
+          </a:prstGeom>
+          <a:noFill/>
+          <a:ln/>
+        </p:spPr>
+        <p:txBody>
+          <a:bodyPr wrap="square" lIns="0" tIns="0" rIns="0" bIns="0" rtlCol="0" anchor="t">
+            <a:normAutofit/>
+          </a:bodyPr>
+          <a:lstStyle/>
+          <a:p>
+            <a:pPr algn="r" indent="0" marL="0">
+              <a:lnSpc>
+                <a:spcPts val="1680"/>
+              </a:lnSpc>
+              <a:buNone/>
+            </a:pPr>
+            <a:r>
+              <a:rPr lang="en-US" sz="1200" dirty="0">
+                <a:solidFill>
+                  <a:srgbClr val="5F6B64"/>
+                </a:solidFill>
+                <a:latin typeface="Inter" pitchFamily="34" charset="0"/>
+                <a:ea typeface="Inter" pitchFamily="34" charset="-122"/>
+                <a:cs typeface="Inter" pitchFamily="34" charset="-120"/>
+              </a:rPr>
+              <a:t>31</a:t>
             </a:r>
             <a:endParaRPr lang="en-US" sz="1200" dirty="0"/>
           </a:p>

</xml_diff>

<commit_message>
Extend Andijan cotton area district comparison with Baliqchi, Izboskan, Buloqboshi
Co-Authored-By: Claude Sonnet 5.5 <noreply@anthropic.com>
Claude-Session: https://claude.ai/code/session_01M4MZatV28utL9zTp7saaUz
</commit_message>
<xml_diff>
--- a/Garbiy_Farg_ona_tuproqlari_GAT_asosida_bashoratlash.pptx
+++ b/Garbiy_Farg_ona_tuproqlari_GAT_asosida_bashoratlash.pptx
@@ -5627,41 +5627,59 @@
           </c:spPr>
           <c:cat>
             <c:strRef>
-              <c:f>Sheet1!$A$2:$A$5</c:f>
+              <c:f>Sheet1!$A$2:$A$8</c:f>
               <c:strCache>
-                <c:ptCount val="4"/>
+                <c:ptCount val="7"/>
                 <c:pt idx="0">
+                  <c:v>Baliqchi</c:v>
+                </c:pt>
+                <c:pt idx="1">
+                  <c:v>Qoʻrgʻontepa</c:v>
+                </c:pt>
+                <c:pt idx="2">
+                  <c:v>Izboskan</c:v>
+                </c:pt>
+                <c:pt idx="3">
+                  <c:v>Shahrixon</c:v>
+                </c:pt>
+                <c:pt idx="4">
                   <c:v>Jalaquduq</c:v>
                 </c:pt>
-                <c:pt idx="1">
-                  <c:v>Shahrixon</c:v>
-                </c:pt>
-                <c:pt idx="2">
-                  <c:v>Qoʻrgʻontepa</c:v>
-                </c:pt>
-                <c:pt idx="3">
+                <c:pt idx="5">
                   <c:v>Paxtaobod</c:v>
+                </c:pt>
+                <c:pt idx="6">
+                  <c:v>Buloqboshi</c:v>
                 </c:pt>
               </c:strCache>
             </c:strRef>
           </c:cat>
           <c:val>
             <c:numRef>
-              <c:f>Sheet1!$B$2:$B$5</c:f>
+              <c:f>Sheet1!$B$2:$B$8</c:f>
               <c:numCache>
                 <c:formatCode>General</c:formatCode>
-                <c:ptCount val="4"/>
+                <c:ptCount val="7"/>
                 <c:pt idx="0">
+                  <c:v>9026</c:v>
+                </c:pt>
+                <c:pt idx="1">
+                  <c:v>7414</c:v>
+                </c:pt>
+                <c:pt idx="2">
+                  <c:v>7228</c:v>
+                </c:pt>
+                <c:pt idx="3">
+                  <c:v>6341</c:v>
+                </c:pt>
+                <c:pt idx="4">
                   <c:v>5330</c:v>
                 </c:pt>
-                <c:pt idx="1">
-                  <c:v>6341</c:v>
-                </c:pt>
-                <c:pt idx="2">
-                  <c:v>7414</c:v>
-                </c:pt>
-                <c:pt idx="3">
+                <c:pt idx="5">
                   <c:v>5275</c:v>
+                </c:pt>
+                <c:pt idx="6">
+                  <c:v>2403</c:v>
                 </c:pt>
               </c:numCache>
             </c:numRef>
@@ -5688,41 +5706,59 @@
           </c:spPr>
           <c:cat>
             <c:strRef>
-              <c:f>Sheet1!$A$2:$A$5</c:f>
+              <c:f>Sheet1!$A$2:$A$8</c:f>
               <c:strCache>
-                <c:ptCount val="4"/>
+                <c:ptCount val="7"/>
                 <c:pt idx="0">
+                  <c:v>Baliqchi</c:v>
+                </c:pt>
+                <c:pt idx="1">
+                  <c:v>Qoʻrgʻontepa</c:v>
+                </c:pt>
+                <c:pt idx="2">
+                  <c:v>Izboskan</c:v>
+                </c:pt>
+                <c:pt idx="3">
+                  <c:v>Shahrixon</c:v>
+                </c:pt>
+                <c:pt idx="4">
                   <c:v>Jalaquduq</c:v>
                 </c:pt>
-                <c:pt idx="1">
-                  <c:v>Shahrixon</c:v>
-                </c:pt>
-                <c:pt idx="2">
-                  <c:v>Qoʻrgʻontepa</c:v>
-                </c:pt>
-                <c:pt idx="3">
+                <c:pt idx="5">
                   <c:v>Paxtaobod</c:v>
+                </c:pt>
+                <c:pt idx="6">
+                  <c:v>Buloqboshi</c:v>
                 </c:pt>
               </c:strCache>
             </c:strRef>
           </c:cat>
           <c:val>
             <c:numRef>
-              <c:f>Sheet1!$C$2:$C$5</c:f>
+              <c:f>Sheet1!$C$2:$C$8</c:f>
               <c:numCache>
                 <c:formatCode>General</c:formatCode>
-                <c:ptCount val="4"/>
+                <c:ptCount val="7"/>
                 <c:pt idx="0">
+                  <c:v>7800</c:v>
+                </c:pt>
+                <c:pt idx="1">
+                  <c:v>6618</c:v>
+                </c:pt>
+                <c:pt idx="2">
+                  <c:v>6300</c:v>
+                </c:pt>
+                <c:pt idx="3">
+                  <c:v>5650</c:v>
+                </c:pt>
+                <c:pt idx="4">
                   <c:v>4073</c:v>
                 </c:pt>
-                <c:pt idx="1">
-                  <c:v>5650</c:v>
-                </c:pt>
-                <c:pt idx="2">
-                  <c:v>6618</c:v>
-                </c:pt>
-                <c:pt idx="3">
+                <c:pt idx="5">
                   <c:v>4450</c:v>
+                </c:pt>
+                <c:pt idx="6">
+                  <c:v>2214</c:v>
                 </c:pt>
               </c:numCache>
             </c:numRef>
@@ -5735,7 +5771,7 @@
             <a:lstStyle/>
             <a:p>
               <a:pPr>
-                <a:defRPr sz="1200">
+                <a:defRPr sz="1000">
                   <a:solidFill>
                     <a:srgbClr val="1D2A24"/>
                   </a:solidFill>
@@ -5780,7 +5816,7 @@
           <a:lstStyle/>
           <a:p>
             <a:pPr>
-              <a:defRPr sz="1100">
+              <a:defRPr sz="1000">
                 <a:solidFill>
                   <a:srgbClr val="4C5852"/>
                 </a:solidFill>
@@ -18217,7 +18253,7 @@
         <p:spPr>
           <a:xfrm>
             <a:off x="812800" y="1830000"/>
-            <a:ext cx="6000000" cy="260000"/>
+            <a:ext cx="5000000" cy="260000"/>
           </a:xfrm>
           <a:prstGeom prst="rect">
             <a:avLst/>
@@ -18253,7 +18289,7 @@
         </p:nvGraphicFramePr>
         <p:xfrm>
           <a:off x="752800" y="2130000"/>
-          <a:ext cx="6000000" cy="2950000"/>
+          <a:ext cx="5000000" cy="2950000"/>
         </p:xfrm>
         <a:graphic>
           <a:graphicData uri="http://schemas.openxmlformats.org/drawingml/2006/chart">
@@ -18269,8 +18305,8 @@
         </p:nvSpPr>
         <p:spPr>
           <a:xfrm>
-            <a:off x="7196192" y="1830000"/>
-            <a:ext cx="4500000" cy="260000"/>
+            <a:off x="5996192" y="1830000"/>
+            <a:ext cx="5700000" cy="260000"/>
           </a:xfrm>
           <a:prstGeom prst="rect">
             <a:avLst/>
@@ -18305,8 +18341,8 @@
           <p:nvPr/>
         </p:nvGraphicFramePr>
         <p:xfrm>
-          <a:off x="7136192" y="2130000"/>
-          <a:ext cx="4500000" cy="2950000"/>
+          <a:off x="5936192" y="2130000"/>
+          <a:ext cx="5700000" cy="2950000"/>
         </p:xfrm>
         <a:graphic>
           <a:graphicData uri="http://schemas.openxmlformats.org/drawingml/2006/chart">
@@ -18392,7 +18428,7 @@
                 </a:solidFill>
                 <a:latin typeface="Inter"/>
               </a:rPr>
-              <a:t>Viloyatda paxta maydoni 10 yilda 93,4 dan 60,0 ming gagacha (−36%) qisqardi; tuman rejalarida 2026 yil uchun ham pasayish davom etadi: Jalaquduq −24%, Paxtaobod −16%, Shahrixon va Qoʻrgʻontepa −11%. Boʻshagan yerlardagi meliorativ holat 3.3-boʻlimda tahlil qilinadi.</a:t>
+              <a:t>Viloyatda paxta maydoni 10 yilda 93,4 dan 60,0 ming gagacha (−36%) qisqardi; 2026 yil tuman rejalarida pasayish davom etadi (7 tuman: −8% dan −24% gacha, eng koʻp Jalaquduq −24%, Paxtaobod −16%, Baliqchi −14%). Boʻshagan yerlardagi meliorativ holat 3.3-boʻlimda tahlil qilinadi.</a:t>
             </a:r>
           </a:p>
         </p:txBody>

</xml_diff>

<commit_message>
Add Andijan district to cotton area comparison
Co-Authored-By: Claude Sonnet 5.5 <noreply@anthropic.com>
Claude-Session: https://claude.ai/code/session_01M4MZatV28utL9zTp7saaUz
</commit_message>
<xml_diff>
--- a/Garbiy_Farg_ona_tuproqlari_GAT_asosida_bashoratlash.pptx
+++ b/Garbiy_Farg_ona_tuproqlari_GAT_asosida_bashoratlash.pptx
@@ -5627,9 +5627,9 @@
           </c:spPr>
           <c:cat>
             <c:strRef>
-              <c:f>Sheet1!$A$2:$A$8</c:f>
+              <c:f>Sheet1!$A$2:$A$9</c:f>
               <c:strCache>
-                <c:ptCount val="7"/>
+                <c:ptCount val="8"/>
                 <c:pt idx="0">
                   <c:v>Baliqchi</c:v>
                 </c:pt>
@@ -5649,6 +5649,9 @@
                   <c:v>Paxtaobod</c:v>
                 </c:pt>
                 <c:pt idx="6">
+                  <c:v>Andijon</c:v>
+                </c:pt>
+                <c:pt idx="7">
                   <c:v>Buloqboshi</c:v>
                 </c:pt>
               </c:strCache>
@@ -5656,10 +5659,10 @@
           </c:cat>
           <c:val>
             <c:numRef>
-              <c:f>Sheet1!$B$2:$B$8</c:f>
+              <c:f>Sheet1!$B$2:$B$9</c:f>
               <c:numCache>
                 <c:formatCode>General</c:formatCode>
-                <c:ptCount val="7"/>
+                <c:ptCount val="8"/>
                 <c:pt idx="0">
                   <c:v>9026</c:v>
                 </c:pt>
@@ -5679,6 +5682,9 @@
                   <c:v>5275</c:v>
                 </c:pt>
                 <c:pt idx="6">
+                  <c:v>3724</c:v>
+                </c:pt>
+                <c:pt idx="7">
                   <c:v>2403</c:v>
                 </c:pt>
               </c:numCache>
@@ -5706,9 +5712,9 @@
           </c:spPr>
           <c:cat>
             <c:strRef>
-              <c:f>Sheet1!$A$2:$A$8</c:f>
+              <c:f>Sheet1!$A$2:$A$9</c:f>
               <c:strCache>
-                <c:ptCount val="7"/>
+                <c:ptCount val="8"/>
                 <c:pt idx="0">
                   <c:v>Baliqchi</c:v>
                 </c:pt>
@@ -5728,6 +5734,9 @@
                   <c:v>Paxtaobod</c:v>
                 </c:pt>
                 <c:pt idx="6">
+                  <c:v>Andijon</c:v>
+                </c:pt>
+                <c:pt idx="7">
                   <c:v>Buloqboshi</c:v>
                 </c:pt>
               </c:strCache>
@@ -5735,10 +5744,10 @@
           </c:cat>
           <c:val>
             <c:numRef>
-              <c:f>Sheet1!$C$2:$C$8</c:f>
+              <c:f>Sheet1!$C$2:$C$9</c:f>
               <c:numCache>
                 <c:formatCode>General</c:formatCode>
-                <c:ptCount val="7"/>
+                <c:ptCount val="8"/>
                 <c:pt idx="0">
                   <c:v>7800</c:v>
                 </c:pt>
@@ -5758,6 +5767,9 @@
                   <c:v>4450</c:v>
                 </c:pt>
                 <c:pt idx="6">
+                  <c:v>2855</c:v>
+                </c:pt>
+                <c:pt idx="7">
                   <c:v>2214</c:v>
                 </c:pt>
               </c:numCache>
@@ -18428,7 +18440,7 @@
                 </a:solidFill>
                 <a:latin typeface="Inter"/>
               </a:rPr>
-              <a:t>Viloyatda paxta maydoni 10 yilda 93,4 dan 60,0 ming gagacha (−36%) qisqardi; 2026 yil tuman rejalarida pasayish davom etadi (7 tuman: −8% dan −24% gacha, eng koʻp Jalaquduq −24%, Paxtaobod −16%, Baliqchi −14%). Boʻshagan yerlardagi meliorativ holat 3.3-boʻlimda tahlil qilinadi.</a:t>
+              <a:t>Viloyatda paxta maydoni 10 yilda 93,4 dan 60,0 ming gagacha (−36%) qisqardi; 2026 yil tuman rejalarida pasayish davom etadi (8 tuman: −8% dan −24% gacha; eng koʻp Jalaquduq −24%, Andijon −23%, Paxtaobod −16%). Boʻshagan yerlardagi meliorativ holat 3.3-boʻlimda tahlil qilinadi.</a:t>
             </a:r>
           </a:p>
         </p:txBody>

</xml_diff>

<commit_message>
Restructure presentation: main body in standard order, data slides moved to appendix
Co-Authored-By: Claude Sonnet 5.5 <noreply@anthropic.com>
Claude-Session: https://claude.ai/code/session_01M4MZatV28utL9zTp7saaUz
</commit_message>
<xml_diff>
--- a/Garbiy_Farg_ona_tuproqlari_GAT_asosida_bashoratlash.pptx
+++ b/Garbiy_Farg_ona_tuproqlari_GAT_asosida_bashoratlash.pptx
@@ -10,10 +10,21 @@
     <p:sldId id="258" r:id="rId4"/>
     <p:sldId id="259" r:id="rId5"/>
     <p:sldId id="260" r:id="rId6"/>
+    <p:sldId id="293" r:id="rId44"/>
+    <p:sldId id="294" r:id="rId45"/>
+    <p:sldId id="263" r:id="rId9"/>
+    <p:sldId id="264" r:id="rId10"/>
+    <p:sldId id="265" r:id="rId11"/>
+    <p:sldId id="266" r:id="rId12"/>
+    <p:sldId id="267" r:id="rId13"/>
     <p:sldId id="261" r:id="rId7"/>
     <p:sldId id="262" r:id="rId8"/>
-    <p:sldId id="263" r:id="rId9"/>
-    <p:sldId id="264" r:id="rId10"/>
+    <p:sldId id="268" r:id="rId14"/>
+    <p:sldId id="269" r:id="rId15"/>
+    <p:sldId id="270" r:id="rId16"/>
+    <p:sldId id="295" r:id="rId46"/>
+    <p:sldId id="271" r:id="rId17"/>
+    <p:sldId id="296" r:id="rId47"/>
     <p:sldId id="272" r:id="rId23"/>
     <p:sldId id="273" r:id="rId24"/>
     <p:sldId id="274" r:id="rId25"/>
@@ -35,14 +46,6 @@
     <p:sldId id="290" r:id="rId41"/>
     <p:sldId id="291" r:id="rId42"/>
     <p:sldId id="292" r:id="rId43"/>
-    <p:sldId id="293" r:id="rId44"/>
-    <p:sldId id="265" r:id="rId11"/>
-    <p:sldId id="266" r:id="rId12"/>
-    <p:sldId id="267" r:id="rId13"/>
-    <p:sldId id="268" r:id="rId14"/>
-    <p:sldId id="269" r:id="rId15"/>
-    <p:sldId id="270" r:id="rId16"/>
-    <p:sldId id="271" r:id="rId17"/>
   </p:sldIdLst>
   <p:notesMasterIdLst>
     <p:notesMasterId r:id="rId18"/>
@@ -8984,6 +8987,10 @@
             <a:prstDash val="solid"/>
           </a:ln>
         </p:spPr>
+        <p:txBody>
+          <a:bodyPr/>
+          <a:p/>
+        </p:txBody>
       </p:sp>
       <p:sp>
         <p:nvSpPr>
@@ -9407,7 +9414,7 @@
                 <a:ea typeface="Inter" pitchFamily="34" charset="-122"/>
                 <a:cs typeface="Inter" pitchFamily="34" charset="-120"/>
               </a:rPr>
-              <a:t>31 · DISSERTATSIYA TUZILISHI</a:t>
+              <a:t>09 · DISSERTATSIYA TUZILISHI</a:t>
             </a:r>
             <a:endParaRPr lang="en-US" sz="1200" dirty="0"/>
           </a:p>
@@ -10206,7 +10213,7 @@
                 <a:ea typeface="Inter" pitchFamily="34" charset="-122"/>
                 <a:cs typeface="Inter" pitchFamily="34" charset="-120"/>
               </a:rPr>
-              <a:t>32</a:t>
+              <a:t>10</a:t>
             </a:r>
             <a:endParaRPr lang="en-US" sz="1200" dirty="0"/>
           </a:p>
@@ -10282,7 +10289,7 @@
                 <a:ea typeface="Inter" pitchFamily="34" charset="-122"/>
                 <a:cs typeface="Inter" pitchFamily="34" charset="-120"/>
               </a:rPr>
-              <a:t>32 · DISSERTATSIYA TUZILISHI</a:t>
+              <a:t>10 · DISSERTATSIYA TUZILISHI</a:t>
             </a:r>
             <a:endParaRPr lang="en-US" sz="1200" dirty="0"/>
           </a:p>
@@ -11314,7 +11321,7 @@
                 <a:ea typeface="Inter" pitchFamily="34" charset="-122"/>
                 <a:cs typeface="Inter" pitchFamily="34" charset="-120"/>
               </a:rPr>
-              <a:t>33</a:t>
+              <a:t>11</a:t>
             </a:r>
             <a:endParaRPr lang="en-US" sz="1200" dirty="0"/>
           </a:p>
@@ -11390,7 +11397,7 @@
                 <a:ea typeface="Inter" pitchFamily="34" charset="-122"/>
                 <a:cs typeface="Inter" pitchFamily="34" charset="-120"/>
               </a:rPr>
-              <a:t>33 · DISSERTATSIYA TUZILISHI</a:t>
+              <a:t>11 · DISSERTATSIYA TUZILISHI</a:t>
             </a:r>
             <a:endParaRPr lang="en-US" sz="1200" dirty="0"/>
           </a:p>
@@ -12417,7 +12424,7 @@
                 <a:ea typeface="Inter" pitchFamily="34" charset="-122"/>
                 <a:cs typeface="Inter" pitchFamily="34" charset="-120"/>
               </a:rPr>
-              <a:t>34</a:t>
+              <a:t>12</a:t>
             </a:r>
             <a:endParaRPr lang="en-US" sz="1200" dirty="0"/>
           </a:p>
@@ -12493,7 +12500,7 @@
                 <a:ea typeface="Inter" pitchFamily="34" charset="-122"/>
                 <a:cs typeface="Inter" pitchFamily="34" charset="-120"/>
               </a:rPr>
-              <a:t>34 · NATIJALAR VA REJA</a:t>
+              <a:t>14 · NATIJALAR VA REJA</a:t>
             </a:r>
             <a:endParaRPr lang="en-US" sz="1200" dirty="0"/>
           </a:p>
@@ -13231,7 +13238,7 @@
                 <a:ea typeface="Inter" pitchFamily="34" charset="-122"/>
                 <a:cs typeface="Inter" pitchFamily="34" charset="-120"/>
               </a:rPr>
-              <a:t>35</a:t>
+              <a:t>15</a:t>
             </a:r>
             <a:endParaRPr lang="en-US" sz="1200" dirty="0"/>
           </a:p>
@@ -13307,7 +13314,7 @@
                 <a:ea typeface="Inter" pitchFamily="34" charset="-122"/>
                 <a:cs typeface="Inter" pitchFamily="34" charset="-120"/>
               </a:rPr>
-              <a:t>35 · NATIJALAR VA REJA</a:t>
+              <a:t>15 · NATIJALAR VA REJA</a:t>
             </a:r>
             <a:endParaRPr lang="en-US" sz="1200" dirty="0"/>
           </a:p>
@@ -14333,7 +14340,7 @@
                 <a:ea typeface="Inter" pitchFamily="34" charset="-122"/>
                 <a:cs typeface="Inter" pitchFamily="34" charset="-120"/>
               </a:rPr>
-              <a:t>36</a:t>
+              <a:t>16</a:t>
             </a:r>
             <a:endParaRPr lang="en-US" sz="1200" dirty="0"/>
           </a:p>
@@ -14409,7 +14416,7 @@
                 <a:ea typeface="Inter" pitchFamily="34" charset="-122"/>
                 <a:cs typeface="Inter" pitchFamily="34" charset="-120"/>
               </a:rPr>
-              <a:t>36 · NATIJALAR VA REJA</a:t>
+              <a:t>16 · NATIJALAR VA REJA</a:t>
             </a:r>
             <a:endParaRPr lang="en-US" sz="1200" dirty="0"/>
           </a:p>
@@ -15021,7 +15028,7 @@
                 <a:ea typeface="Inter" pitchFamily="34" charset="-122"/>
                 <a:cs typeface="Inter" pitchFamily="34" charset="-120"/>
               </a:rPr>
-              <a:t>37</a:t>
+              <a:t>17</a:t>
             </a:r>
             <a:endParaRPr lang="en-US" sz="1200" dirty="0"/>
           </a:p>
@@ -15323,7 +15330,7 @@
                 <a:ea typeface="Inter" pitchFamily="34" charset="-122"/>
                 <a:cs typeface="Inter" pitchFamily="34" charset="-120"/>
               </a:rPr>
-              <a:t>09 · DASTLABKI MAʼLUMOTLAR</a:t>
+              <a:t>20 · ILOVA · DASTLABKI MAʼLUMOTLAR</a:t>
             </a:r>
             <a:endParaRPr lang="en-US" sz="1200" dirty="0"/>
           </a:p>
@@ -15413,7 +15420,7 @@
                 <a:ea typeface="Inter" pitchFamily="34" charset="-122"/>
                 <a:cs typeface="Inter" pitchFamily="34" charset="-120"/>
               </a:rPr>
-              <a:t>10</a:t>
+              <a:t>21</a:t>
             </a:r>
             <a:endParaRPr lang="en-US" sz="1200" dirty="0"/>
           </a:p>
@@ -15924,7 +15931,7 @@
                 <a:ea typeface="Inter" pitchFamily="34" charset="-122"/>
                 <a:cs typeface="Inter" pitchFamily="34" charset="-120"/>
               </a:rPr>
-              <a:t>10 · DASTLABKI MAʼLUMOTLAR</a:t>
+              <a:t>21 · ILOVA · DASTLABKI MAʼLUMOTLAR</a:t>
             </a:r>
             <a:endParaRPr lang="en-US" sz="1200" dirty="0"/>
           </a:p>
@@ -16014,7 +16021,7 @@
                 <a:ea typeface="Inter" pitchFamily="34" charset="-122"/>
                 <a:cs typeface="Inter" pitchFamily="34" charset="-120"/>
               </a:rPr>
-              <a:t>11</a:t>
+              <a:t>22</a:t>
             </a:r>
             <a:endParaRPr lang="en-US" sz="1200" dirty="0"/>
           </a:p>
@@ -16307,7 +16314,7 @@
                 <a:ea typeface="Inter" pitchFamily="34" charset="-122"/>
                 <a:cs typeface="Inter" pitchFamily="34" charset="-120"/>
               </a:rPr>
-              <a:t>11 · DASTLABKI MAʼLUMOTLAR</a:t>
+              <a:t>22 · ILOVA · DASTLABKI MAʼLUMOTLAR</a:t>
             </a:r>
             <a:endParaRPr lang="en-US" sz="1200" dirty="0"/>
           </a:p>
@@ -16397,7 +16404,7 @@
                 <a:ea typeface="Inter" pitchFamily="34" charset="-122"/>
                 <a:cs typeface="Inter" pitchFamily="34" charset="-120"/>
               </a:rPr>
-              <a:t>12</a:t>
+              <a:t>23</a:t>
             </a:r>
             <a:endParaRPr lang="en-US" sz="1200" dirty="0"/>
           </a:p>
@@ -18160,7 +18167,7 @@
                 <a:ea typeface="Inter" pitchFamily="34" charset="-122"/>
                 <a:cs typeface="Inter" pitchFamily="34" charset="-120"/>
               </a:rPr>
-              <a:t>12 · DASTLABKI MAʼLUMOTLAR</a:t>
+              <a:t>23 · ILOVA · DASTLABKI MAʼLUMOTLAR</a:t>
             </a:r>
             <a:endParaRPr lang="en-US" sz="1200" dirty="0"/>
           </a:p>
@@ -18250,7 +18257,7 @@
                 <a:ea typeface="Inter" pitchFamily="34" charset="-122"/>
                 <a:cs typeface="Inter" pitchFamily="34" charset="-120"/>
               </a:rPr>
-              <a:t>13</a:t>
+              <a:t>24</a:t>
             </a:r>
             <a:endParaRPr lang="en-US" sz="1200" dirty="0"/>
           </a:p>
@@ -18543,7 +18550,7 @@
                 <a:ea typeface="Inter" pitchFamily="34" charset="-122"/>
                 <a:cs typeface="Inter" pitchFamily="34" charset="-120"/>
               </a:rPr>
-              <a:t>13 · DASTLABKI MAʼLUMOTLAR</a:t>
+              <a:t>24 · ILOVA · DASTLABKI MAʼLUMOTLAR</a:t>
             </a:r>
             <a:endParaRPr lang="en-US" sz="1200" dirty="0"/>
           </a:p>
@@ -18633,7 +18640,7 @@
                 <a:ea typeface="Inter" pitchFamily="34" charset="-122"/>
                 <a:cs typeface="Inter" pitchFamily="34" charset="-120"/>
               </a:rPr>
-              <a:t>14</a:t>
+              <a:t>25</a:t>
             </a:r>
             <a:endParaRPr lang="en-US" sz="1200" dirty="0"/>
           </a:p>
@@ -19144,7 +19151,7 @@
                 <a:ea typeface="Inter" pitchFamily="34" charset="-122"/>
                 <a:cs typeface="Inter" pitchFamily="34" charset="-120"/>
               </a:rPr>
-              <a:t>14 · DASTLABKI MAʼLUMOTLAR</a:t>
+              <a:t>25 · ILOVA · DASTLABKI MAʼLUMOTLAR</a:t>
             </a:r>
             <a:endParaRPr lang="en-US" sz="1200" dirty="0"/>
           </a:p>
@@ -19234,7 +19241,7 @@
                 <a:ea typeface="Inter" pitchFamily="34" charset="-122"/>
                 <a:cs typeface="Inter" pitchFamily="34" charset="-120"/>
               </a:rPr>
-              <a:t>15</a:t>
+              <a:t>26</a:t>
             </a:r>
             <a:endParaRPr lang="en-US" sz="1200" dirty="0"/>
           </a:p>
@@ -19780,7 +19787,7 @@
                 <a:ea typeface="Inter" pitchFamily="34" charset="-122"/>
                 <a:cs typeface="Inter" pitchFamily="34" charset="-120"/>
               </a:rPr>
-              <a:t>15 · DASTLABKI MAʼLUMOTLAR</a:t>
+              <a:t>26 · ILOVA · DASTLABKI MAʼLUMOTLAR</a:t>
             </a:r>
             <a:endParaRPr lang="en-US" sz="1200" dirty="0"/>
           </a:p>
@@ -19870,7 +19877,7 @@
                 <a:ea typeface="Inter" pitchFamily="34" charset="-122"/>
                 <a:cs typeface="Inter" pitchFamily="34" charset="-120"/>
               </a:rPr>
-              <a:t>16</a:t>
+              <a:t>27</a:t>
             </a:r>
             <a:endParaRPr lang="en-US" sz="1200" dirty="0"/>
           </a:p>
@@ -20416,7 +20423,7 @@
                 <a:ea typeface="Inter" pitchFamily="34" charset="-122"/>
                 <a:cs typeface="Inter" pitchFamily="34" charset="-120"/>
               </a:rPr>
-              <a:t>16 · DASTLABKI MAʼLUMOTLAR</a:t>
+              <a:t>27 · ILOVA · DASTLABKI MAʼLUMOTLAR</a:t>
             </a:r>
             <a:endParaRPr lang="en-US" sz="1200" dirty="0"/>
           </a:p>
@@ -20506,7 +20513,7 @@
                 <a:ea typeface="Inter" pitchFamily="34" charset="-122"/>
                 <a:cs typeface="Inter" pitchFamily="34" charset="-120"/>
               </a:rPr>
-              <a:t>17</a:t>
+              <a:t>28</a:t>
             </a:r>
             <a:endParaRPr lang="en-US" sz="1200" dirty="0"/>
           </a:p>
@@ -21017,7 +21024,7 @@
                 <a:ea typeface="Inter" pitchFamily="34" charset="-122"/>
                 <a:cs typeface="Inter" pitchFamily="34" charset="-120"/>
               </a:rPr>
-              <a:t>17 · DASTLABKI MAʼLUMOTLAR</a:t>
+              <a:t>28 · ILOVA · DASTLABKI MAʼLUMOTLAR</a:t>
             </a:r>
             <a:endParaRPr lang="en-US" sz="1200" dirty="0"/>
           </a:p>
@@ -21107,7 +21114,7 @@
                 <a:ea typeface="Inter" pitchFamily="34" charset="-122"/>
                 <a:cs typeface="Inter" pitchFamily="34" charset="-120"/>
               </a:rPr>
-              <a:t>18</a:t>
+              <a:t>29</a:t>
             </a:r>
             <a:endParaRPr lang="en-US" sz="1200" dirty="0"/>
           </a:p>
@@ -21618,7 +21625,7 @@
                 <a:ea typeface="Inter" pitchFamily="34" charset="-122"/>
                 <a:cs typeface="Inter" pitchFamily="34" charset="-120"/>
               </a:rPr>
-              <a:t>18 · DASTLABKI MAʼLUMOTLAR</a:t>
+              <a:t>29 · ILOVA · DASTLABKI MAʼLUMOTLAR</a:t>
             </a:r>
             <a:endParaRPr lang="en-US" sz="1200" dirty="0"/>
           </a:p>
@@ -21708,7 +21715,7 @@
                 <a:ea typeface="Inter" pitchFamily="34" charset="-122"/>
                 <a:cs typeface="Inter" pitchFamily="34" charset="-120"/>
               </a:rPr>
-              <a:t>19</a:t>
+              <a:t>30</a:t>
             </a:r>
             <a:endParaRPr lang="en-US" sz="1200" dirty="0"/>
           </a:p>
@@ -22219,7 +22226,7 @@
                 <a:ea typeface="Inter" pitchFamily="34" charset="-122"/>
                 <a:cs typeface="Inter" pitchFamily="34" charset="-120"/>
               </a:rPr>
-              <a:t>19 · DASTLABKI MAʼLUMOTLAR</a:t>
+              <a:t>30 · ILOVA · DASTLABKI MAʼLUMOTLAR</a:t>
             </a:r>
             <a:endParaRPr lang="en-US" sz="1200" dirty="0"/>
           </a:p>
@@ -22309,7 +22316,7 @@
                 <a:ea typeface="Inter" pitchFamily="34" charset="-122"/>
                 <a:cs typeface="Inter" pitchFamily="34" charset="-120"/>
               </a:rPr>
-              <a:t>20</a:t>
+              <a:t>31</a:t>
             </a:r>
             <a:endParaRPr lang="en-US" sz="1200" dirty="0"/>
           </a:p>
@@ -22820,7 +22827,7 @@
                 <a:ea typeface="Inter" pitchFamily="34" charset="-122"/>
                 <a:cs typeface="Inter" pitchFamily="34" charset="-120"/>
               </a:rPr>
-              <a:t>20 · DASTLABKI MAʼLUMOTLAR</a:t>
+              <a:t>31 · ILOVA · DASTLABKI MAʼLUMOTLAR</a:t>
             </a:r>
             <a:endParaRPr lang="en-US" sz="1200" dirty="0"/>
           </a:p>
@@ -22910,7 +22917,7 @@
                 <a:ea typeface="Inter" pitchFamily="34" charset="-122"/>
                 <a:cs typeface="Inter" pitchFamily="34" charset="-120"/>
               </a:rPr>
-              <a:t>21</a:t>
+              <a:t>32</a:t>
             </a:r>
             <a:endParaRPr lang="en-US" sz="1200" dirty="0"/>
           </a:p>
@@ -23421,7 +23428,7 @@
                 <a:ea typeface="Inter" pitchFamily="34" charset="-122"/>
                 <a:cs typeface="Inter" pitchFamily="34" charset="-120"/>
               </a:rPr>
-              <a:t>21 · DASTLABKI MAʼLUMOTLAR</a:t>
+              <a:t>32 · ILOVA · DASTLABKI MAʼLUMOTLAR</a:t>
             </a:r>
             <a:endParaRPr lang="en-US" sz="1200" dirty="0"/>
           </a:p>
@@ -23511,7 +23518,7 @@
                 <a:ea typeface="Inter" pitchFamily="34" charset="-122"/>
                 <a:cs typeface="Inter" pitchFamily="34" charset="-120"/>
               </a:rPr>
-              <a:t>22</a:t>
+              <a:t>33</a:t>
             </a:r>
             <a:endParaRPr lang="en-US" sz="1200" dirty="0"/>
           </a:p>
@@ -24232,7 +24239,7 @@
                 <a:ea typeface="Inter" pitchFamily="34" charset="-122"/>
                 <a:cs typeface="Inter" pitchFamily="34" charset="-120"/>
               </a:rPr>
-              <a:t>22 · DASTLABKI MAʼLUMOTLAR</a:t>
+              <a:t>33 · ILOVA · DASTLABKI MAʼLUMOTLAR</a:t>
             </a:r>
             <a:endParaRPr lang="en-US" sz="1200" dirty="0"/>
           </a:p>
@@ -24322,7 +24329,7 @@
                 <a:ea typeface="Inter" pitchFamily="34" charset="-122"/>
                 <a:cs typeface="Inter" pitchFamily="34" charset="-120"/>
               </a:rPr>
-              <a:t>23</a:t>
+              <a:t>34</a:t>
             </a:r>
             <a:endParaRPr lang="en-US" sz="1200" dirty="0"/>
           </a:p>
@@ -24833,7 +24840,7 @@
                 <a:ea typeface="Inter" pitchFamily="34" charset="-122"/>
                 <a:cs typeface="Inter" pitchFamily="34" charset="-120"/>
               </a:rPr>
-              <a:t>23 · DASTLABKI MAʼLUMOTLAR</a:t>
+              <a:t>34 · ILOVA · DASTLABKI MAʼLUMOTLAR</a:t>
             </a:r>
             <a:endParaRPr lang="en-US" sz="1200" dirty="0"/>
           </a:p>
@@ -24923,7 +24930,7 @@
                 <a:ea typeface="Inter" pitchFamily="34" charset="-122"/>
                 <a:cs typeface="Inter" pitchFamily="34" charset="-120"/>
               </a:rPr>
-              <a:t>24</a:t>
+              <a:t>35</a:t>
             </a:r>
             <a:endParaRPr lang="en-US" sz="1200" dirty="0"/>
           </a:p>
@@ -25434,7 +25441,7 @@
                 <a:ea typeface="Inter" pitchFamily="34" charset="-122"/>
                 <a:cs typeface="Inter" pitchFamily="34" charset="-120"/>
               </a:rPr>
-              <a:t>24 · DASTLABKI MAʼLUMOTLAR</a:t>
+              <a:t>35 · ILOVA · DASTLABKI MAʼLUMOTLAR</a:t>
             </a:r>
             <a:endParaRPr lang="en-US" sz="1200" dirty="0"/>
           </a:p>
@@ -25524,7 +25531,7 @@
                 <a:ea typeface="Inter" pitchFamily="34" charset="-122"/>
                 <a:cs typeface="Inter" pitchFamily="34" charset="-120"/>
               </a:rPr>
-              <a:t>25</a:t>
+              <a:t>36</a:t>
             </a:r>
             <a:endParaRPr lang="en-US" sz="1200" dirty="0"/>
           </a:p>
@@ -26035,7 +26042,7 @@
                 <a:ea typeface="Inter" pitchFamily="34" charset="-122"/>
                 <a:cs typeface="Inter" pitchFamily="34" charset="-120"/>
               </a:rPr>
-              <a:t>25 · DASTLABKI MAʼLUMOTLAR</a:t>
+              <a:t>36 · ILOVA · DASTLABKI MAʼLUMOTLAR</a:t>
             </a:r>
             <a:endParaRPr lang="en-US" sz="1200" dirty="0"/>
           </a:p>
@@ -26125,7 +26132,7 @@
                 <a:ea typeface="Inter" pitchFamily="34" charset="-122"/>
                 <a:cs typeface="Inter" pitchFamily="34" charset="-120"/>
               </a:rPr>
-              <a:t>26</a:t>
+              <a:t>37</a:t>
             </a:r>
             <a:endParaRPr lang="en-US" sz="1200" dirty="0"/>
           </a:p>
@@ -26636,7 +26643,7 @@
                 <a:ea typeface="Inter" pitchFamily="34" charset="-122"/>
                 <a:cs typeface="Inter" pitchFamily="34" charset="-120"/>
               </a:rPr>
-              <a:t>26 · DASTLABKI MAʼLUMOTLAR</a:t>
+              <a:t>37 · ILOVA · DASTLABKI MAʼLUMOTLAR</a:t>
             </a:r>
             <a:endParaRPr lang="en-US" sz="1200" dirty="0"/>
           </a:p>
@@ -26726,7 +26733,7 @@
                 <a:ea typeface="Inter" pitchFamily="34" charset="-122"/>
                 <a:cs typeface="Inter" pitchFamily="34" charset="-120"/>
               </a:rPr>
-              <a:t>27</a:t>
+              <a:t>38</a:t>
             </a:r>
             <a:endParaRPr lang="en-US" sz="1200" dirty="0"/>
           </a:p>
@@ -27237,7 +27244,7 @@
                 <a:ea typeface="Inter" pitchFamily="34" charset="-122"/>
                 <a:cs typeface="Inter" pitchFamily="34" charset="-120"/>
               </a:rPr>
-              <a:t>27 · DASTLABKI MAʼLUMOTLAR</a:t>
+              <a:t>38 · ILOVA · DASTLABKI MAʼLUMOTLAR</a:t>
             </a:r>
             <a:endParaRPr lang="en-US" sz="1200" dirty="0"/>
           </a:p>
@@ -27327,7 +27334,7 @@
                 <a:ea typeface="Inter" pitchFamily="34" charset="-122"/>
                 <a:cs typeface="Inter" pitchFamily="34" charset="-120"/>
               </a:rPr>
-              <a:t>28</a:t>
+              <a:t>39</a:t>
             </a:r>
             <a:endParaRPr lang="en-US" sz="1200" dirty="0"/>
           </a:p>
@@ -27838,7 +27845,7 @@
                 <a:ea typeface="Inter" pitchFamily="34" charset="-122"/>
                 <a:cs typeface="Inter" pitchFamily="34" charset="-120"/>
               </a:rPr>
-              <a:t>28 · DASTLABKI MAʼLUMOTLAR</a:t>
+              <a:t>39 · ILOVA · DASTLABKI MAʼLUMOTLAR</a:t>
             </a:r>
             <a:endParaRPr lang="en-US" sz="1200" dirty="0"/>
           </a:p>
@@ -27928,7 +27935,7 @@
                 <a:ea typeface="Inter" pitchFamily="34" charset="-122"/>
                 <a:cs typeface="Inter" pitchFamily="34" charset="-120"/>
               </a:rPr>
-              <a:t>29</a:t>
+              <a:t>40</a:t>
             </a:r>
             <a:endParaRPr lang="en-US" sz="1200" dirty="0"/>
           </a:p>
@@ -28439,7 +28446,7 @@
                 <a:ea typeface="Inter" pitchFamily="34" charset="-122"/>
                 <a:cs typeface="Inter" pitchFamily="34" charset="-120"/>
               </a:rPr>
-              <a:t>29 · DASTLABKI MAʼLUMOTLAR</a:t>
+              <a:t>40 · ILOVA · DASTLABKI MAʼLUMOTLAR</a:t>
             </a:r>
             <a:endParaRPr lang="en-US" sz="1200" dirty="0"/>
           </a:p>
@@ -28529,7 +28536,7 @@
                 <a:ea typeface="Inter" pitchFamily="34" charset="-122"/>
                 <a:cs typeface="Inter" pitchFamily="34" charset="-120"/>
               </a:rPr>
-              <a:t>30</a:t>
+              <a:t>41</a:t>
             </a:r>
             <a:endParaRPr lang="en-US" sz="1200" dirty="0"/>
           </a:p>
@@ -29040,7 +29047,7 @@
                 <a:ea typeface="Inter" pitchFamily="34" charset="-122"/>
                 <a:cs typeface="Inter" pitchFamily="34" charset="-120"/>
               </a:rPr>
-              <a:t>30 · ADABIYOT TAHLILI</a:t>
+              <a:t>05 · OʻRGANILGANLIK DARAJASI</a:t>
             </a:r>
             <a:endParaRPr lang="en-US" sz="1200" dirty="0"/>
           </a:p>
@@ -29086,7 +29093,7 @@
                 <a:ea typeface="Source Serif 4" pitchFamily="18" charset="-122"/>
                 <a:cs typeface="Source Serif 4" pitchFamily="18" charset="-120"/>
               </a:rPr>
-              <a:t>Markaziy Fargʻona tuproqlari: oldingi tadqiqot</a:t>
+              <a:t>Oʻrganilganlik darajasi: Markaziy Fargʻona</a:t>
             </a:r>
             <a:endParaRPr lang="en-US" sz="3200" dirty="0"/>
           </a:p>
@@ -29130,7 +29137,7 @@
                 <a:ea typeface="Inter" pitchFamily="34" charset="-122"/>
                 <a:cs typeface="Inter" pitchFamily="34" charset="-120"/>
               </a:rPr>
-              <a:t>31</a:t>
+              <a:t>06</a:t>
             </a:r>
             <a:endParaRPr lang="en-US" sz="1200" dirty="0"/>
           </a:p>
@@ -29674,6 +29681,834 @@
                 <a:latin typeface="Inter"/>
               </a:rPr>
               <a:t>Manba: M.K.Pulatov, PhD avtoreferati (Markaziy Fargʻona tuproqlari), Toshkent, 2025</a:t>
+            </a:r>
+          </a:p>
+        </p:txBody>
+      </p:sp>
+    </p:spTree>
+  </p:cSld>
+  <p:clrMapOvr>
+    <a:masterClrMapping/>
+  </p:clrMapOvr>
+</p:sld>
+</file>
+
+<file path=ppt/slides/slide39.xml><?xml version="1.0" encoding="utf-8"?>
+<p:sld xmlns:a="http://schemas.openxmlformats.org/drawingml/2006/main" xmlns:p="http://schemas.openxmlformats.org/presentationml/2006/main" xmlns:r="http://schemas.openxmlformats.org/officeDocument/2006/relationships">
+  <p:cSld>
+    <p:bg>
+      <p:bgPr>
+        <a:solidFill>
+          <a:srgbClr val="F4F1EA"/>
+        </a:solidFill>
+      </p:bgPr>
+    </p:bg>
+    <p:spTree>
+      <p:nvGrpSpPr>
+        <p:cNvPr id="1" name=""/>
+        <p:cNvGrpSpPr/>
+        <p:nvPr/>
+      </p:nvGrpSpPr>
+      <p:grpSpPr/>
+      <p:sp>
+        <p:nvSpPr>
+          <p:cNvPr id="2" name="Text 0"/>
+          <p:cNvSpPr/>
+          <p:nvPr/>
+        </p:nvSpPr>
+        <p:spPr>
+          <a:xfrm>
+            <a:off x="812800" y="812800"/>
+            <a:ext cx="10883392" cy="238720"/>
+          </a:xfrm>
+          <a:prstGeom prst="rect">
+            <a:avLst/>
+          </a:prstGeom>
+          <a:noFill/>
+          <a:ln/>
+        </p:spPr>
+        <p:txBody>
+          <a:bodyPr wrap="square" lIns="0" tIns="0" rIns="0" bIns="0" rtlCol="0" anchor="t">
+            <a:normAutofit/>
+          </a:bodyPr>
+          <a:lstStyle/>
+          <a:p>
+            <a:pPr algn="l" indent="0" marL="0">
+              <a:lnSpc>
+                <a:spcPts val="1680"/>
+              </a:lnSpc>
+              <a:buNone/>
+            </a:pPr>
+            <a:r>
+              <a:rPr lang="en-US" sz="1200" b="1" spc="150" kern="0" dirty="0">
+                <a:solidFill>
+                  <a:srgbClr val="2C6A85"/>
+                </a:solidFill>
+                <a:latin typeface="Inter" pitchFamily="34" charset="0"/>
+                <a:ea typeface="Inter" pitchFamily="34" charset="-122"/>
+                <a:cs typeface="Inter" pitchFamily="34" charset="-120"/>
+              </a:rPr>
+              <a:t>06 · USTUVOR YOʻNALISH</a:t>
+            </a:r>
+            <a:endParaRPr lang="en-US" sz="1200" dirty="0"/>
+          </a:p>
+        </p:txBody>
+      </p:sp>
+      <p:sp>
+        <p:nvSpPr>
+          <p:cNvPr id="3" name="Text 1"/>
+          <p:cNvSpPr/>
+          <p:nvPr>
+            <p:ph type="title"/>
+          </p:nvPr>
+        </p:nvSpPr>
+        <p:spPr>
+          <a:xfrm>
+            <a:off x="812800" y="1127720"/>
+            <a:ext cx="10883392" cy="472430"/>
+          </a:xfrm>
+          <a:prstGeom prst="rect">
+            <a:avLst/>
+          </a:prstGeom>
+          <a:noFill/>
+          <a:ln/>
+        </p:spPr>
+        <p:txBody>
+          <a:bodyPr wrap="square" lIns="0" tIns="0" rIns="0" bIns="0" rtlCol="0" anchor="t">
+            <a:normAutofit/>
+          </a:bodyPr>
+          <a:lstStyle/>
+          <a:p>
+            <a:pPr algn="l" indent="0" marL="0">
+              <a:lnSpc>
+                <a:spcPts val="3520"/>
+              </a:lnSpc>
+              <a:buNone/>
+            </a:pPr>
+            <a:r>
+              <a:rPr lang="en-US" sz="3200" b="0" i="0" dirty="0">
+                <a:solidFill>
+                  <a:srgbClr val="1D2A24"/>
+                </a:solidFill>
+                <a:latin typeface="Source Serif 4" pitchFamily="18" charset="0"/>
+                <a:ea typeface="Source Serif 4" pitchFamily="18" charset="-122"/>
+                <a:cs typeface="Source Serif 4" pitchFamily="18" charset="-120"/>
+              </a:rPr>
+              <a:t>Ustuvor yoʻnalishga muvofiqlik</a:t>
+            </a:r>
+            <a:endParaRPr lang="en-US" sz="3200" dirty="0"/>
+          </a:p>
+        </p:txBody>
+      </p:sp>
+      <p:sp>
+        <p:nvSpPr>
+          <p:cNvPr id="6" name="Text 3"/>
+          <p:cNvSpPr/>
+          <p:nvPr/>
+        </p:nvSpPr>
+        <p:spPr>
+          <a:xfrm>
+            <a:off x="11137950" y="6238280"/>
+            <a:ext cx="241250" cy="238720"/>
+          </a:xfrm>
+          <a:prstGeom prst="rect">
+            <a:avLst/>
+          </a:prstGeom>
+          <a:noFill/>
+          <a:ln/>
+        </p:spPr>
+        <p:txBody>
+          <a:bodyPr wrap="square" lIns="0" tIns="0" rIns="0" bIns="0" rtlCol="0" anchor="t">
+            <a:normAutofit/>
+          </a:bodyPr>
+          <a:lstStyle/>
+          <a:p>
+            <a:pPr algn="r" indent="0" marL="0">
+              <a:lnSpc>
+                <a:spcPts val="1680"/>
+              </a:lnSpc>
+              <a:buNone/>
+            </a:pPr>
+            <a:r>
+              <a:rPr lang="en-US" sz="1200" dirty="0">
+                <a:solidFill>
+                  <a:srgbClr val="5F6B64"/>
+                </a:solidFill>
+                <a:latin typeface="Inter" pitchFamily="34" charset="0"/>
+                <a:ea typeface="Inter" pitchFamily="34" charset="-122"/>
+                <a:cs typeface="Inter" pitchFamily="34" charset="-120"/>
+              </a:rPr>
+              <a:t>07</a:t>
+            </a:r>
+            <a:endParaRPr lang="en-US" sz="1200" dirty="0"/>
+          </a:p>
+        </p:txBody>
+      </p:sp>
+      <p:sp>
+        <p:nvSpPr>
+          <p:cNvPr id="7" name="Rounded Rectangle 6"/>
+          <p:cNvSpPr/>
+          <p:nvPr/>
+        </p:nvSpPr>
+        <p:spPr>
+          <a:xfrm>
+            <a:off x="812800" y="1950000"/>
+            <a:ext cx="3461130" cy="2000000"/>
+          </a:xfrm>
+          <a:prstGeom prst="roundRect">
+            <a:avLst>
+              <a:gd name="adj" fmla="val 5000"/>
+            </a:avLst>
+          </a:prstGeom>
+          <a:solidFill>
+            <a:srgbClr val="FBF9F4"/>
+          </a:solidFill>
+          <a:ln w="6350">
+            <a:solidFill>
+              <a:srgbClr val="D9D2C3"/>
+            </a:solidFill>
+          </a:ln>
+          <a:effectLst/>
+        </p:spPr>
+        <p:style>
+          <a:lnRef idx="1">
+            <a:schemeClr val="accent1"/>
+          </a:lnRef>
+          <a:fillRef idx="3">
+            <a:schemeClr val="accent1"/>
+          </a:fillRef>
+          <a:effectRef idx="2">
+            <a:schemeClr val="accent1"/>
+          </a:effectRef>
+          <a:fontRef idx="minor">
+            <a:schemeClr val="lt1"/>
+          </a:fontRef>
+        </p:style>
+        <p:txBody>
+          <a:bodyPr rtlCol="0" anchor="ctr"/>
+          <a:lstStyle/>
+          <a:p>
+            <a:pPr algn="ctr"/>
+          </a:p>
+        </p:txBody>
+      </p:sp>
+      <p:sp>
+        <p:nvSpPr>
+          <p:cNvPr id="8" name="TextBox 7"/>
+          <p:cNvSpPr txBox="1"/>
+          <p:nvPr/>
+        </p:nvSpPr>
+        <p:spPr>
+          <a:xfrm>
+            <a:off x="1062800" y="2150000"/>
+            <a:ext cx="2961130" cy="320000"/>
+          </a:xfrm>
+          <a:prstGeom prst="rect">
+            <a:avLst/>
+          </a:prstGeom>
+          <a:noFill/>
+        </p:spPr>
+        <p:txBody>
+          <a:bodyPr wrap="square" lIns="0" rIns="0" tIns="0" bIns="0" anchor="t">
+            <a:spAutoFit/>
+          </a:bodyPr>
+          <a:lstStyle/>
+          <a:p>
+            <a:pPr algn="l"/>
+            <a:r>
+              <a:rPr sz="1600" b="1">
+                <a:solidFill>
+                  <a:srgbClr val="1D2A24"/>
+                </a:solidFill>
+                <a:latin typeface="Inter"/>
+              </a:rPr>
+              <a:t>Ilmiy yoʻnalish</a:t>
+            </a:r>
+          </a:p>
+        </p:txBody>
+      </p:sp>
+      <p:sp>
+        <p:nvSpPr>
+          <p:cNvPr id="9" name="TextBox 8"/>
+          <p:cNvSpPr txBox="1"/>
+          <p:nvPr/>
+        </p:nvSpPr>
+        <p:spPr>
+          <a:xfrm>
+            <a:off x="1062800" y="2600000"/>
+            <a:ext cx="2961130" cy="1250000"/>
+          </a:xfrm>
+          <a:prstGeom prst="rect">
+            <a:avLst/>
+          </a:prstGeom>
+          <a:noFill/>
+        </p:spPr>
+        <p:txBody>
+          <a:bodyPr wrap="square" lIns="0" rIns="0" tIns="0" bIns="0" anchor="t">
+            <a:spAutoFit/>
+          </a:bodyPr>
+          <a:lstStyle/>
+          <a:p>
+            <a:pPr algn="l"/>
+            <a:r>
+              <a:rPr sz="1300" b="0">
+                <a:solidFill>
+                  <a:srgbClr val="4C5852"/>
+                </a:solidFill>
+                <a:latin typeface="Inter"/>
+              </a:rPr>
+              <a:t>[ixtisoslik shifri — nomi]: tuproqshunoslik, melioratsiya va geoaxborot tizimlari (GAT) asosida bashoratlash</a:t>
+            </a:r>
+          </a:p>
+        </p:txBody>
+      </p:sp>
+      <p:sp>
+        <p:nvSpPr>
+          <p:cNvPr id="10" name="Rounded Rectangle 9"/>
+          <p:cNvSpPr/>
+          <p:nvPr/>
+        </p:nvSpPr>
+        <p:spPr>
+          <a:xfrm>
+            <a:off x="4523930" y="1950000"/>
+            <a:ext cx="3461130" cy="2000000"/>
+          </a:xfrm>
+          <a:prstGeom prst="roundRect">
+            <a:avLst>
+              <a:gd name="adj" fmla="val 5000"/>
+            </a:avLst>
+          </a:prstGeom>
+          <a:solidFill>
+            <a:srgbClr val="FBF9F4"/>
+          </a:solidFill>
+          <a:ln w="6350">
+            <a:solidFill>
+              <a:srgbClr val="D9D2C3"/>
+            </a:solidFill>
+          </a:ln>
+          <a:effectLst/>
+        </p:spPr>
+        <p:style>
+          <a:lnRef idx="1">
+            <a:schemeClr val="accent1"/>
+          </a:lnRef>
+          <a:fillRef idx="3">
+            <a:schemeClr val="accent1"/>
+          </a:fillRef>
+          <a:effectRef idx="2">
+            <a:schemeClr val="accent1"/>
+          </a:effectRef>
+          <a:fontRef idx="minor">
+            <a:schemeClr val="lt1"/>
+          </a:fontRef>
+        </p:style>
+        <p:txBody>
+          <a:bodyPr rtlCol="0" anchor="ctr"/>
+          <a:lstStyle/>
+          <a:p>
+            <a:pPr algn="ctr"/>
+          </a:p>
+        </p:txBody>
+      </p:sp>
+      <p:sp>
+        <p:nvSpPr>
+          <p:cNvPr id="11" name="TextBox 10"/>
+          <p:cNvSpPr txBox="1"/>
+          <p:nvPr/>
+        </p:nvSpPr>
+        <p:spPr>
+          <a:xfrm>
+            <a:off x="4773930" y="2150000"/>
+            <a:ext cx="2961130" cy="320000"/>
+          </a:xfrm>
+          <a:prstGeom prst="rect">
+            <a:avLst/>
+          </a:prstGeom>
+          <a:noFill/>
+        </p:spPr>
+        <p:txBody>
+          <a:bodyPr wrap="square" lIns="0" rIns="0" tIns="0" bIns="0" anchor="t">
+            <a:spAutoFit/>
+          </a:bodyPr>
+          <a:lstStyle/>
+          <a:p>
+            <a:pPr algn="l"/>
+            <a:r>
+              <a:rPr sz="1600" b="1">
+                <a:solidFill>
+                  <a:srgbClr val="1D2A24"/>
+                </a:solidFill>
+                <a:latin typeface="Inter"/>
+              </a:rPr>
+              <a:t>Ustuvor yoʻnalish</a:t>
+            </a:r>
+          </a:p>
+        </p:txBody>
+      </p:sp>
+      <p:sp>
+        <p:nvSpPr>
+          <p:cNvPr id="12" name="TextBox 11"/>
+          <p:cNvSpPr txBox="1"/>
+          <p:nvPr/>
+        </p:nvSpPr>
+        <p:spPr>
+          <a:xfrm>
+            <a:off x="4773930" y="2600000"/>
+            <a:ext cx="2961130" cy="1250000"/>
+          </a:xfrm>
+          <a:prstGeom prst="rect">
+            <a:avLst/>
+          </a:prstGeom>
+          <a:noFill/>
+        </p:spPr>
+        <p:txBody>
+          <a:bodyPr wrap="square" lIns="0" rIns="0" tIns="0" bIns="0" anchor="t">
+            <a:spAutoFit/>
+          </a:bodyPr>
+          <a:lstStyle/>
+          <a:p>
+            <a:pPr algn="l"/>
+            <a:r>
+              <a:rPr sz="1300" b="0">
+                <a:solidFill>
+                  <a:srgbClr val="4C5852"/>
+                </a:solidFill>
+                <a:latin typeface="Inter"/>
+              </a:rPr>
+              <a:t>[Qishloq xoʻjaligi, ekologiya va atrof-muhit muhofazasi — ilmiy kengash roʻyxati boʻyicha tasdiqlang]</a:t>
+            </a:r>
+          </a:p>
+        </p:txBody>
+      </p:sp>
+      <p:sp>
+        <p:nvSpPr>
+          <p:cNvPr id="13" name="Rounded Rectangle 12"/>
+          <p:cNvSpPr/>
+          <p:nvPr/>
+        </p:nvSpPr>
+        <p:spPr>
+          <a:xfrm>
+            <a:off x="8235060" y="1950000"/>
+            <a:ext cx="3461130" cy="2000000"/>
+          </a:xfrm>
+          <a:prstGeom prst="roundRect">
+            <a:avLst>
+              <a:gd name="adj" fmla="val 5000"/>
+            </a:avLst>
+          </a:prstGeom>
+          <a:solidFill>
+            <a:srgbClr val="FBF9F4"/>
+          </a:solidFill>
+          <a:ln w="6350">
+            <a:solidFill>
+              <a:srgbClr val="D9D2C3"/>
+            </a:solidFill>
+          </a:ln>
+          <a:effectLst/>
+        </p:spPr>
+        <p:style>
+          <a:lnRef idx="1">
+            <a:schemeClr val="accent1"/>
+          </a:lnRef>
+          <a:fillRef idx="3">
+            <a:schemeClr val="accent1"/>
+          </a:fillRef>
+          <a:effectRef idx="2">
+            <a:schemeClr val="accent1"/>
+          </a:effectRef>
+          <a:fontRef idx="minor">
+            <a:schemeClr val="lt1"/>
+          </a:fontRef>
+        </p:style>
+        <p:txBody>
+          <a:bodyPr rtlCol="0" anchor="ctr"/>
+          <a:lstStyle/>
+          <a:p>
+            <a:pPr algn="ctr"/>
+          </a:p>
+        </p:txBody>
+      </p:sp>
+      <p:sp>
+        <p:nvSpPr>
+          <p:cNvPr id="14" name="TextBox 13"/>
+          <p:cNvSpPr txBox="1"/>
+          <p:nvPr/>
+        </p:nvSpPr>
+        <p:spPr>
+          <a:xfrm>
+            <a:off x="8485060" y="2150000"/>
+            <a:ext cx="2961130" cy="320000"/>
+          </a:xfrm>
+          <a:prstGeom prst="rect">
+            <a:avLst/>
+          </a:prstGeom>
+          <a:noFill/>
+        </p:spPr>
+        <p:txBody>
+          <a:bodyPr wrap="square" lIns="0" rIns="0" tIns="0" bIns="0" anchor="t">
+            <a:spAutoFit/>
+          </a:bodyPr>
+          <a:lstStyle/>
+          <a:p>
+            <a:pPr algn="l"/>
+            <a:r>
+              <a:rPr sz="1600" b="1">
+                <a:solidFill>
+                  <a:srgbClr val="1D2A24"/>
+                </a:solidFill>
+                <a:latin typeface="Inter"/>
+              </a:rPr>
+              <a:t>Hal etiladigan muammo</a:t>
+            </a:r>
+          </a:p>
+        </p:txBody>
+      </p:sp>
+      <p:sp>
+        <p:nvSpPr>
+          <p:cNvPr id="15" name="TextBox 14"/>
+          <p:cNvSpPr txBox="1"/>
+          <p:nvPr/>
+        </p:nvSpPr>
+        <p:spPr>
+          <a:xfrm>
+            <a:off x="8485060" y="2600000"/>
+            <a:ext cx="2961130" cy="1250000"/>
+          </a:xfrm>
+          <a:prstGeom prst="rect">
+            <a:avLst/>
+          </a:prstGeom>
+          <a:noFill/>
+        </p:spPr>
+        <p:txBody>
+          <a:bodyPr wrap="square" lIns="0" rIns="0" tIns="0" bIns="0" anchor="t">
+            <a:spAutoFit/>
+          </a:bodyPr>
+          <a:lstStyle/>
+          <a:p>
+            <a:pPr algn="l"/>
+            <a:r>
+              <a:rPr sz="1300" b="0">
+                <a:solidFill>
+                  <a:srgbClr val="4C5852"/>
+                </a:solidFill>
+                <a:latin typeface="Inter"/>
+              </a:rPr>
+              <a:t>Sugʻoriladigan yerlar meliorativ holatini oldindan baholash va yer-suv resurslaridan barqaror foydalanish</a:t>
+            </a:r>
+          </a:p>
+        </p:txBody>
+      </p:sp>
+      <p:sp>
+        <p:nvSpPr>
+          <p:cNvPr id="16" name="TextBox 15"/>
+          <p:cNvSpPr txBox="1"/>
+          <p:nvPr/>
+        </p:nvSpPr>
+        <p:spPr>
+          <a:xfrm>
+            <a:off x="812800" y="4250000"/>
+            <a:ext cx="10883392" cy="260000"/>
+          </a:xfrm>
+          <a:prstGeom prst="rect">
+            <a:avLst/>
+          </a:prstGeom>
+          <a:noFill/>
+        </p:spPr>
+        <p:txBody>
+          <a:bodyPr wrap="square" lIns="0" rIns="0" tIns="0" bIns="0" anchor="t">
+            <a:spAutoFit/>
+          </a:bodyPr>
+          <a:lstStyle/>
+          <a:p>
+            <a:pPr algn="l"/>
+            <a:r>
+              <a:rPr sz="1200" b="1">
+                <a:solidFill>
+                  <a:srgbClr val="2C6A85"/>
+                </a:solidFill>
+                <a:latin typeface="Inter"/>
+              </a:rPr>
+              <a:t>NORMATIV ASOS</a:t>
+            </a:r>
+          </a:p>
+        </p:txBody>
+      </p:sp>
+      <p:sp>
+        <p:nvSpPr>
+          <p:cNvPr id="17" name="TextBox 16"/>
+          <p:cNvSpPr txBox="1"/>
+          <p:nvPr/>
+        </p:nvSpPr>
+        <p:spPr>
+          <a:xfrm>
+            <a:off x="812800" y="4650000"/>
+            <a:ext cx="2608348" cy="300000"/>
+          </a:xfrm>
+          <a:prstGeom prst="rect">
+            <a:avLst/>
+          </a:prstGeom>
+          <a:noFill/>
+        </p:spPr>
+        <p:txBody>
+          <a:bodyPr wrap="square" lIns="0" rIns="0" tIns="0" bIns="0" anchor="t">
+            <a:spAutoFit/>
+          </a:bodyPr>
+          <a:lstStyle/>
+          <a:p>
+            <a:pPr algn="l"/>
+            <a:r>
+              <a:rPr sz="1400" b="1">
+                <a:solidFill>
+                  <a:srgbClr val="A4521D"/>
+                </a:solidFill>
+                <a:latin typeface="Inter"/>
+              </a:rPr>
+              <a:t>PQ-277 (10.06.2022)</a:t>
+            </a:r>
+          </a:p>
+        </p:txBody>
+      </p:sp>
+      <p:sp>
+        <p:nvSpPr>
+          <p:cNvPr id="18" name="TextBox 17"/>
+          <p:cNvSpPr txBox="1"/>
+          <p:nvPr/>
+        </p:nvSpPr>
+        <p:spPr>
+          <a:xfrm>
+            <a:off x="812800" y="5000000"/>
+            <a:ext cx="2608348" cy="1000000"/>
+          </a:xfrm>
+          <a:prstGeom prst="rect">
+            <a:avLst/>
+          </a:prstGeom>
+          <a:noFill/>
+        </p:spPr>
+        <p:txBody>
+          <a:bodyPr wrap="square" lIns="0" rIns="0" tIns="0" bIns="0" anchor="t">
+            <a:spAutoFit/>
+          </a:bodyPr>
+          <a:lstStyle/>
+          <a:p>
+            <a:pPr algn="l"/>
+            <a:r>
+              <a:rPr sz="1200" b="0">
+                <a:solidFill>
+                  <a:srgbClr val="4C5852"/>
+                </a:solidFill>
+                <a:latin typeface="Inter"/>
+              </a:rPr>
+              <a:t>Yerlar degradatsiyasiga qarshi kurashishning samarali tizimini yaratish</a:t>
+            </a:r>
+          </a:p>
+        </p:txBody>
+      </p:sp>
+      <p:sp>
+        <p:nvSpPr>
+          <p:cNvPr id="19" name="TextBox 18"/>
+          <p:cNvSpPr txBox="1"/>
+          <p:nvPr/>
+        </p:nvSpPr>
+        <p:spPr>
+          <a:xfrm>
+            <a:off x="3571148" y="4650000"/>
+            <a:ext cx="2608348" cy="300000"/>
+          </a:xfrm>
+          <a:prstGeom prst="rect">
+            <a:avLst/>
+          </a:prstGeom>
+          <a:noFill/>
+        </p:spPr>
+        <p:txBody>
+          <a:bodyPr wrap="square" lIns="0" rIns="0" tIns="0" bIns="0" anchor="t">
+            <a:spAutoFit/>
+          </a:bodyPr>
+          <a:lstStyle/>
+          <a:p>
+            <a:pPr algn="l"/>
+            <a:r>
+              <a:rPr sz="1400" b="1">
+                <a:solidFill>
+                  <a:srgbClr val="A4521D"/>
+                </a:solidFill>
+                <a:latin typeface="Inter"/>
+              </a:rPr>
+              <a:t>PQ-5006 (24.02.2021)</a:t>
+            </a:r>
+          </a:p>
+        </p:txBody>
+      </p:sp>
+      <p:sp>
+        <p:nvSpPr>
+          <p:cNvPr id="20" name="TextBox 19"/>
+          <p:cNvSpPr txBox="1"/>
+          <p:nvPr/>
+        </p:nvSpPr>
+        <p:spPr>
+          <a:xfrm>
+            <a:off x="3571148" y="5000000"/>
+            <a:ext cx="2608348" cy="1000000"/>
+          </a:xfrm>
+          <a:prstGeom prst="rect">
+            <a:avLst/>
+          </a:prstGeom>
+          <a:noFill/>
+        </p:spPr>
+        <p:txBody>
+          <a:bodyPr wrap="square" lIns="0" rIns="0" tIns="0" bIns="0" anchor="t">
+            <a:spAutoFit/>
+          </a:bodyPr>
+          <a:lstStyle/>
+          <a:p>
+            <a:pPr algn="l"/>
+            <a:r>
+              <a:rPr sz="1200" b="0">
+                <a:solidFill>
+                  <a:srgbClr val="4C5852"/>
+                </a:solidFill>
+                <a:latin typeface="Inter"/>
+              </a:rPr>
+              <a:t>Qishloq xoʻjaligiga moʻljallangan yerlardan foydalanish va muhofaza qilish tizimini takomillashtirish</a:t>
+            </a:r>
+          </a:p>
+        </p:txBody>
+      </p:sp>
+      <p:sp>
+        <p:nvSpPr>
+          <p:cNvPr id="21" name="TextBox 20"/>
+          <p:cNvSpPr txBox="1"/>
+          <p:nvPr/>
+        </p:nvSpPr>
+        <p:spPr>
+          <a:xfrm>
+            <a:off x="6329496" y="4650000"/>
+            <a:ext cx="2608348" cy="300000"/>
+          </a:xfrm>
+          <a:prstGeom prst="rect">
+            <a:avLst/>
+          </a:prstGeom>
+          <a:noFill/>
+        </p:spPr>
+        <p:txBody>
+          <a:bodyPr wrap="square" lIns="0" rIns="0" tIns="0" bIns="0" anchor="t">
+            <a:spAutoFit/>
+          </a:bodyPr>
+          <a:lstStyle/>
+          <a:p>
+            <a:pPr algn="l"/>
+            <a:r>
+              <a:rPr sz="1400" b="1">
+                <a:solidFill>
+                  <a:srgbClr val="A4521D"/>
+                </a:solidFill>
+                <a:latin typeface="Inter"/>
+              </a:rPr>
+              <a:t>PF-130 (12.08.2025)</a:t>
+            </a:r>
+          </a:p>
+        </p:txBody>
+      </p:sp>
+      <p:sp>
+        <p:nvSpPr>
+          <p:cNvPr id="22" name="TextBox 21"/>
+          <p:cNvSpPr txBox="1"/>
+          <p:nvPr/>
+        </p:nvSpPr>
+        <p:spPr>
+          <a:xfrm>
+            <a:off x="6329496" y="5000000"/>
+            <a:ext cx="2608348" cy="1000000"/>
+          </a:xfrm>
+          <a:prstGeom prst="rect">
+            <a:avLst/>
+          </a:prstGeom>
+          <a:noFill/>
+        </p:spPr>
+        <p:txBody>
+          <a:bodyPr wrap="square" lIns="0" rIns="0" tIns="0" bIns="0" anchor="t">
+            <a:spAutoFit/>
+          </a:bodyPr>
+          <a:lstStyle/>
+          <a:p>
+            <a:pPr algn="l"/>
+            <a:r>
+              <a:rPr sz="1200" b="0">
+                <a:solidFill>
+                  <a:srgbClr val="4C5852"/>
+                </a:solidFill>
+                <a:latin typeface="Inter"/>
+              </a:rPr>
+              <a:t>Qishloq xoʻjaligida zamonaviy (raqamli) texnologiyalarni joriy etishni jadallashtirish</a:t>
+            </a:r>
+          </a:p>
+        </p:txBody>
+      </p:sp>
+      <p:sp>
+        <p:nvSpPr>
+          <p:cNvPr id="23" name="TextBox 22"/>
+          <p:cNvSpPr txBox="1"/>
+          <p:nvPr/>
+        </p:nvSpPr>
+        <p:spPr>
+          <a:xfrm>
+            <a:off x="9087844" y="4650000"/>
+            <a:ext cx="2608348" cy="300000"/>
+          </a:xfrm>
+          <a:prstGeom prst="rect">
+            <a:avLst/>
+          </a:prstGeom>
+          <a:noFill/>
+        </p:spPr>
+        <p:txBody>
+          <a:bodyPr wrap="square" lIns="0" rIns="0" tIns="0" bIns="0" anchor="t">
+            <a:spAutoFit/>
+          </a:bodyPr>
+          <a:lstStyle/>
+          <a:p>
+            <a:pPr algn="l"/>
+            <a:r>
+              <a:rPr sz="1400" b="1">
+                <a:solidFill>
+                  <a:srgbClr val="A4521D"/>
+                </a:solidFill>
+                <a:latin typeface="Inter"/>
+              </a:rPr>
+              <a:t>PF-5853 (23.10.2019)</a:t>
+            </a:r>
+          </a:p>
+        </p:txBody>
+      </p:sp>
+      <p:sp>
+        <p:nvSpPr>
+          <p:cNvPr id="24" name="TextBox 23"/>
+          <p:cNvSpPr txBox="1"/>
+          <p:nvPr/>
+        </p:nvSpPr>
+        <p:spPr>
+          <a:xfrm>
+            <a:off x="9087844" y="5000000"/>
+            <a:ext cx="2608348" cy="1000000"/>
+          </a:xfrm>
+          <a:prstGeom prst="rect">
+            <a:avLst/>
+          </a:prstGeom>
+          <a:noFill/>
+        </p:spPr>
+        <p:txBody>
+          <a:bodyPr wrap="square" lIns="0" rIns="0" tIns="0" bIns="0" anchor="t">
+            <a:spAutoFit/>
+          </a:bodyPr>
+          <a:lstStyle/>
+          <a:p>
+            <a:pPr algn="l"/>
+            <a:r>
+              <a:rPr sz="1200" b="0">
+                <a:solidFill>
+                  <a:srgbClr val="4C5852"/>
+                </a:solidFill>
+                <a:latin typeface="Inter"/>
+              </a:rPr>
+              <a:t>Qishloq xoʻjaligini rivojlantirishning 2020–2030 yillarga moʻljallangan strategiyasi</a:t>
             </a:r>
           </a:p>
         </p:txBody>
@@ -29821,6 +30656,10 @@
           </a:solidFill>
           <a:ln/>
         </p:spPr>
+        <p:txBody>
+          <a:bodyPr/>
+          <a:p/>
+        </p:txBody>
       </p:sp>
       <p:sp>
         <p:nvSpPr>
@@ -30523,6 +31362,923 @@
               <a:t>04</a:t>
             </a:r>
             <a:endParaRPr lang="en-US" sz="1200" dirty="0"/>
+          </a:p>
+        </p:txBody>
+      </p:sp>
+    </p:spTree>
+  </p:cSld>
+  <p:clrMapOvr>
+    <a:masterClrMapping/>
+  </p:clrMapOvr>
+</p:sld>
+</file>
+
+<file path=ppt/slides/slide40.xml><?xml version="1.0" encoding="utf-8"?>
+<p:sld xmlns:a="http://schemas.openxmlformats.org/drawingml/2006/main" xmlns:p="http://schemas.openxmlformats.org/presentationml/2006/main" xmlns:r="http://schemas.openxmlformats.org/officeDocument/2006/relationships">
+  <p:cSld>
+    <p:bg>
+      <p:bgPr>
+        <a:solidFill>
+          <a:srgbClr val="F4F1EA"/>
+        </a:solidFill>
+      </p:bgPr>
+    </p:bg>
+    <p:spTree>
+      <p:nvGrpSpPr>
+        <p:cNvPr id="1" name=""/>
+        <p:cNvGrpSpPr/>
+        <p:nvPr/>
+      </p:nvGrpSpPr>
+      <p:grpSpPr/>
+      <p:sp>
+        <p:nvSpPr>
+          <p:cNvPr id="2" name="Text 0"/>
+          <p:cNvSpPr/>
+          <p:nvPr/>
+        </p:nvSpPr>
+        <p:spPr>
+          <a:xfrm>
+            <a:off x="812800" y="812800"/>
+            <a:ext cx="10883392" cy="238720"/>
+          </a:xfrm>
+          <a:prstGeom prst="rect">
+            <a:avLst/>
+          </a:prstGeom>
+          <a:noFill/>
+          <a:ln/>
+        </p:spPr>
+        <p:txBody>
+          <a:bodyPr wrap="square" lIns="0" tIns="0" rIns="0" bIns="0" rtlCol="0" anchor="t">
+            <a:normAutofit/>
+          </a:bodyPr>
+          <a:lstStyle/>
+          <a:p>
+            <a:pPr algn="l" indent="0" marL="0">
+              <a:lnSpc>
+                <a:spcPts val="1680"/>
+              </a:lnSpc>
+              <a:buNone/>
+            </a:pPr>
+            <a:r>
+              <a:rPr lang="en-US" sz="1200" b="1" spc="150" kern="0" dirty="0">
+                <a:solidFill>
+                  <a:srgbClr val="2C6A85"/>
+                </a:solidFill>
+                <a:latin typeface="Inter" pitchFamily="34" charset="0"/>
+                <a:ea typeface="Inter" pitchFamily="34" charset="-122"/>
+                <a:cs typeface="Inter" pitchFamily="34" charset="-120"/>
+              </a:rPr>
+              <a:t>17 · MANBALAR</a:t>
+            </a:r>
+            <a:endParaRPr lang="en-US" sz="1200" dirty="0"/>
+          </a:p>
+        </p:txBody>
+      </p:sp>
+      <p:sp>
+        <p:nvSpPr>
+          <p:cNvPr id="3" name="Text 1"/>
+          <p:cNvSpPr/>
+          <p:nvPr>
+            <p:ph type="title"/>
+          </p:nvPr>
+        </p:nvSpPr>
+        <p:spPr>
+          <a:xfrm>
+            <a:off x="812800" y="1127720"/>
+            <a:ext cx="10883392" cy="472430"/>
+          </a:xfrm>
+          <a:prstGeom prst="rect">
+            <a:avLst/>
+          </a:prstGeom>
+          <a:noFill/>
+          <a:ln/>
+        </p:spPr>
+        <p:txBody>
+          <a:bodyPr wrap="square" lIns="0" tIns="0" rIns="0" bIns="0" rtlCol="0" anchor="t">
+            <a:normAutofit/>
+          </a:bodyPr>
+          <a:lstStyle/>
+          <a:p>
+            <a:pPr algn="l" indent="0" marL="0">
+              <a:lnSpc>
+                <a:spcPts val="3520"/>
+              </a:lnSpc>
+              <a:buNone/>
+            </a:pPr>
+            <a:r>
+              <a:rPr lang="en-US" sz="3200" b="0" i="0" dirty="0">
+                <a:solidFill>
+                  <a:srgbClr val="1D2A24"/>
+                </a:solidFill>
+                <a:latin typeface="Source Serif 4" pitchFamily="18" charset="0"/>
+                <a:ea typeface="Source Serif 4" pitchFamily="18" charset="-122"/>
+                <a:cs typeface="Source Serif 4" pitchFamily="18" charset="-120"/>
+              </a:rPr>
+              <a:t>Foydalanilgan asosiy manbalar</a:t>
+            </a:r>
+            <a:endParaRPr lang="en-US" sz="3200" dirty="0"/>
+          </a:p>
+        </p:txBody>
+      </p:sp>
+      <p:sp>
+        <p:nvSpPr>
+          <p:cNvPr id="6" name="Text 3"/>
+          <p:cNvSpPr/>
+          <p:nvPr/>
+        </p:nvSpPr>
+        <p:spPr>
+          <a:xfrm>
+            <a:off x="11137950" y="6238280"/>
+            <a:ext cx="241250" cy="238720"/>
+          </a:xfrm>
+          <a:prstGeom prst="rect">
+            <a:avLst/>
+          </a:prstGeom>
+          <a:noFill/>
+          <a:ln/>
+        </p:spPr>
+        <p:txBody>
+          <a:bodyPr wrap="square" lIns="0" tIns="0" rIns="0" bIns="0" rtlCol="0" anchor="t">
+            <a:normAutofit/>
+          </a:bodyPr>
+          <a:lstStyle/>
+          <a:p>
+            <a:pPr algn="r" indent="0" marL="0">
+              <a:lnSpc>
+                <a:spcPts val="1680"/>
+              </a:lnSpc>
+              <a:buNone/>
+            </a:pPr>
+            <a:r>
+              <a:rPr lang="en-US" sz="1200" dirty="0">
+                <a:solidFill>
+                  <a:srgbClr val="5F6B64"/>
+                </a:solidFill>
+                <a:latin typeface="Inter" pitchFamily="34" charset="0"/>
+                <a:ea typeface="Inter" pitchFamily="34" charset="-122"/>
+                <a:cs typeface="Inter" pitchFamily="34" charset="-120"/>
+              </a:rPr>
+              <a:t>18</a:t>
+            </a:r>
+            <a:endParaRPr lang="en-US" sz="1200" dirty="0"/>
+          </a:p>
+        </p:txBody>
+      </p:sp>
+      <p:sp>
+        <p:nvSpPr>
+          <p:cNvPr id="7" name="Rounded Rectangle 6"/>
+          <p:cNvSpPr/>
+          <p:nvPr/>
+        </p:nvSpPr>
+        <p:spPr>
+          <a:xfrm>
+            <a:off x="812800" y="1950000"/>
+            <a:ext cx="3461130" cy="3900000"/>
+          </a:xfrm>
+          <a:prstGeom prst="roundRect">
+            <a:avLst>
+              <a:gd name="adj" fmla="val 5000"/>
+            </a:avLst>
+          </a:prstGeom>
+          <a:solidFill>
+            <a:srgbClr val="FBF9F4"/>
+          </a:solidFill>
+          <a:ln w="6350">
+            <a:solidFill>
+              <a:srgbClr val="D9D2C3"/>
+            </a:solidFill>
+          </a:ln>
+          <a:effectLst/>
+        </p:spPr>
+        <p:style>
+          <a:lnRef idx="1">
+            <a:schemeClr val="accent1"/>
+          </a:lnRef>
+          <a:fillRef idx="3">
+            <a:schemeClr val="accent1"/>
+          </a:fillRef>
+          <a:effectRef idx="2">
+            <a:schemeClr val="accent1"/>
+          </a:effectRef>
+          <a:fontRef idx="minor">
+            <a:schemeClr val="lt1"/>
+          </a:fontRef>
+        </p:style>
+        <p:txBody>
+          <a:bodyPr rtlCol="0" anchor="ctr"/>
+          <a:lstStyle/>
+          <a:p>
+            <a:pPr algn="ctr"/>
+          </a:p>
+        </p:txBody>
+      </p:sp>
+      <p:sp>
+        <p:nvSpPr>
+          <p:cNvPr id="8" name="TextBox 7"/>
+          <p:cNvSpPr txBox="1"/>
+          <p:nvPr/>
+        </p:nvSpPr>
+        <p:spPr>
+          <a:xfrm>
+            <a:off x="1062800" y="2150000"/>
+            <a:ext cx="2961130" cy="320000"/>
+          </a:xfrm>
+          <a:prstGeom prst="rect">
+            <a:avLst/>
+          </a:prstGeom>
+          <a:noFill/>
+        </p:spPr>
+        <p:txBody>
+          <a:bodyPr wrap="square" lIns="0" rIns="0" tIns="0" bIns="0" anchor="t">
+            <a:spAutoFit/>
+          </a:bodyPr>
+          <a:lstStyle/>
+          <a:p>
+            <a:pPr algn="l"/>
+            <a:r>
+              <a:rPr sz="1500" b="1">
+                <a:solidFill>
+                  <a:srgbClr val="1D2A24"/>
+                </a:solidFill>
+                <a:latin typeface="Inter"/>
+              </a:rPr>
+              <a:t>Meʼyoriy-huquqiy hujjatlar</a:t>
+            </a:r>
+          </a:p>
+        </p:txBody>
+      </p:sp>
+      <p:sp>
+        <p:nvSpPr>
+          <p:cNvPr id="9" name="TextBox 8"/>
+          <p:cNvSpPr txBox="1"/>
+          <p:nvPr/>
+        </p:nvSpPr>
+        <p:spPr>
+          <a:xfrm>
+            <a:off x="1062800" y="2650000"/>
+            <a:ext cx="2961130" cy="620000"/>
+          </a:xfrm>
+          <a:prstGeom prst="rect">
+            <a:avLst/>
+          </a:prstGeom>
+          <a:noFill/>
+        </p:spPr>
+        <p:txBody>
+          <a:bodyPr wrap="square" lIns="0" rIns="0" tIns="0" bIns="0" anchor="t">
+            <a:spAutoFit/>
+          </a:bodyPr>
+          <a:lstStyle/>
+          <a:p>
+            <a:pPr algn="l"/>
+            <a:r>
+              <a:rPr sz="1200" b="0">
+                <a:solidFill>
+                  <a:srgbClr val="4C5852"/>
+                </a:solidFill>
+                <a:latin typeface="Inter"/>
+              </a:rPr>
+              <a:t>PQ-277 (10.06.2022); PQ-5006 (24.02.2021)</a:t>
+            </a:r>
+          </a:p>
+        </p:txBody>
+      </p:sp>
+      <p:sp>
+        <p:nvSpPr>
+          <p:cNvPr id="10" name="TextBox 9"/>
+          <p:cNvSpPr txBox="1"/>
+          <p:nvPr/>
+        </p:nvSpPr>
+        <p:spPr>
+          <a:xfrm>
+            <a:off x="1062800" y="3350000"/>
+            <a:ext cx="2961130" cy="620000"/>
+          </a:xfrm>
+          <a:prstGeom prst="rect">
+            <a:avLst/>
+          </a:prstGeom>
+          <a:noFill/>
+        </p:spPr>
+        <p:txBody>
+          <a:bodyPr wrap="square" lIns="0" rIns="0" tIns="0" bIns="0" anchor="t">
+            <a:spAutoFit/>
+          </a:bodyPr>
+          <a:lstStyle/>
+          <a:p>
+            <a:pPr algn="l"/>
+            <a:r>
+              <a:rPr sz="1200" b="0">
+                <a:solidFill>
+                  <a:srgbClr val="4C5852"/>
+                </a:solidFill>
+                <a:latin typeface="Inter"/>
+              </a:rPr>
+              <a:t>PF-130 (12.08.2025); PF-5853 (23.10.2019)</a:t>
+            </a:r>
+          </a:p>
+        </p:txBody>
+      </p:sp>
+      <p:sp>
+        <p:nvSpPr>
+          <p:cNvPr id="11" name="TextBox 10"/>
+          <p:cNvSpPr txBox="1"/>
+          <p:nvPr/>
+        </p:nvSpPr>
+        <p:spPr>
+          <a:xfrm>
+            <a:off x="1062800" y="4050000"/>
+            <a:ext cx="2961130" cy="620000"/>
+          </a:xfrm>
+          <a:prstGeom prst="rect">
+            <a:avLst/>
+          </a:prstGeom>
+          <a:noFill/>
+        </p:spPr>
+        <p:txBody>
+          <a:bodyPr wrap="square" lIns="0" rIns="0" tIns="0" bIns="0" anchor="t">
+            <a:spAutoFit/>
+          </a:bodyPr>
+          <a:lstStyle/>
+          <a:p>
+            <a:pPr algn="l"/>
+            <a:r>
+              <a:rPr sz="1200" b="0">
+                <a:solidFill>
+                  <a:srgbClr val="4C5852"/>
+                </a:solidFill>
+                <a:latin typeface="Inter"/>
+              </a:rPr>
+              <a:t>PF-5742 (17.06.2019); PF-6061 (07.09.2020)</a:t>
+            </a:r>
+          </a:p>
+        </p:txBody>
+      </p:sp>
+      <p:sp>
+        <p:nvSpPr>
+          <p:cNvPr id="12" name="Rounded Rectangle 11"/>
+          <p:cNvSpPr/>
+          <p:nvPr/>
+        </p:nvSpPr>
+        <p:spPr>
+          <a:xfrm>
+            <a:off x="4523930" y="1950000"/>
+            <a:ext cx="3461130" cy="3900000"/>
+          </a:xfrm>
+          <a:prstGeom prst="roundRect">
+            <a:avLst>
+              <a:gd name="adj" fmla="val 5000"/>
+            </a:avLst>
+          </a:prstGeom>
+          <a:solidFill>
+            <a:srgbClr val="FBF9F4"/>
+          </a:solidFill>
+          <a:ln w="6350">
+            <a:solidFill>
+              <a:srgbClr val="D9D2C3"/>
+            </a:solidFill>
+          </a:ln>
+          <a:effectLst/>
+        </p:spPr>
+        <p:style>
+          <a:lnRef idx="1">
+            <a:schemeClr val="accent1"/>
+          </a:lnRef>
+          <a:fillRef idx="3">
+            <a:schemeClr val="accent1"/>
+          </a:fillRef>
+          <a:effectRef idx="2">
+            <a:schemeClr val="accent1"/>
+          </a:effectRef>
+          <a:fontRef idx="minor">
+            <a:schemeClr val="lt1"/>
+          </a:fontRef>
+        </p:style>
+        <p:txBody>
+          <a:bodyPr rtlCol="0" anchor="ctr"/>
+          <a:lstStyle/>
+          <a:p>
+            <a:pPr algn="ctr"/>
+          </a:p>
+        </p:txBody>
+      </p:sp>
+      <p:sp>
+        <p:nvSpPr>
+          <p:cNvPr id="13" name="TextBox 12"/>
+          <p:cNvSpPr txBox="1"/>
+          <p:nvPr/>
+        </p:nvSpPr>
+        <p:spPr>
+          <a:xfrm>
+            <a:off x="4773930" y="2150000"/>
+            <a:ext cx="2961130" cy="320000"/>
+          </a:xfrm>
+          <a:prstGeom prst="rect">
+            <a:avLst/>
+          </a:prstGeom>
+          <a:noFill/>
+        </p:spPr>
+        <p:txBody>
+          <a:bodyPr wrap="square" lIns="0" rIns="0" tIns="0" bIns="0" anchor="t">
+            <a:spAutoFit/>
+          </a:bodyPr>
+          <a:lstStyle/>
+          <a:p>
+            <a:pPr algn="l"/>
+            <a:r>
+              <a:rPr sz="1500" b="1">
+                <a:solidFill>
+                  <a:srgbClr val="1D2A24"/>
+                </a:solidFill>
+                <a:latin typeface="Inter"/>
+              </a:rPr>
+              <a:t>Ilmiy manbalar</a:t>
+            </a:r>
+          </a:p>
+        </p:txBody>
+      </p:sp>
+      <p:sp>
+        <p:nvSpPr>
+          <p:cNvPr id="14" name="TextBox 13"/>
+          <p:cNvSpPr txBox="1"/>
+          <p:nvPr/>
+        </p:nvSpPr>
+        <p:spPr>
+          <a:xfrm>
+            <a:off x="4773930" y="2650000"/>
+            <a:ext cx="2961130" cy="1050000"/>
+          </a:xfrm>
+          <a:prstGeom prst="rect">
+            <a:avLst/>
+          </a:prstGeom>
+          <a:noFill/>
+        </p:spPr>
+        <p:txBody>
+          <a:bodyPr wrap="square" lIns="0" rIns="0" tIns="0" bIns="0" anchor="t">
+            <a:spAutoFit/>
+          </a:bodyPr>
+          <a:lstStyle/>
+          <a:p>
+            <a:pPr algn="l"/>
+            <a:r>
+              <a:rPr sz="1200" b="0">
+                <a:solidFill>
+                  <a:srgbClr val="4C5852"/>
+                </a:solidFill>
+                <a:latin typeface="Inter"/>
+              </a:rPr>
+              <a:t>Pulatov M.K. Markaziy Fargʻona sugʻoriladigan tuproqlari, ularning asosiy xossalari va unumdorlik holati (Fargʻona viloyati misolida). PhD avtoreferati. Toshkent, 2025</a:t>
+            </a:r>
+          </a:p>
+        </p:txBody>
+      </p:sp>
+      <p:sp>
+        <p:nvSpPr>
+          <p:cNvPr id="15" name="TextBox 14"/>
+          <p:cNvSpPr txBox="1"/>
+          <p:nvPr/>
+        </p:nvSpPr>
+        <p:spPr>
+          <a:xfrm>
+            <a:off x="4773930" y="3780000"/>
+            <a:ext cx="2961130" cy="620000"/>
+          </a:xfrm>
+          <a:prstGeom prst="rect">
+            <a:avLst/>
+          </a:prstGeom>
+          <a:noFill/>
+        </p:spPr>
+        <p:txBody>
+          <a:bodyPr wrap="square" lIns="0" rIns="0" tIns="0" bIns="0" anchor="t">
+            <a:spAutoFit/>
+          </a:bodyPr>
+          <a:lstStyle/>
+          <a:p>
+            <a:pPr algn="l"/>
+            <a:r>
+              <a:rPr sz="1200" b="0">
+                <a:solidFill>
+                  <a:srgbClr val="4C5852"/>
+                </a:solidFill>
+                <a:latin typeface="Inter"/>
+              </a:rPr>
+              <a:t>[Qoʻshimcha mahalliy va xorijiy ilmiy adabiyotlar — toʻldiriladi]</a:t>
+            </a:r>
+          </a:p>
+        </p:txBody>
+      </p:sp>
+      <p:sp>
+        <p:nvSpPr>
+          <p:cNvPr id="16" name="Rounded Rectangle 15"/>
+          <p:cNvSpPr/>
+          <p:nvPr/>
+        </p:nvSpPr>
+        <p:spPr>
+          <a:xfrm>
+            <a:off x="8235060" y="1950000"/>
+            <a:ext cx="3461130" cy="3900000"/>
+          </a:xfrm>
+          <a:prstGeom prst="roundRect">
+            <a:avLst>
+              <a:gd name="adj" fmla="val 5000"/>
+            </a:avLst>
+          </a:prstGeom>
+          <a:solidFill>
+            <a:srgbClr val="FBF9F4"/>
+          </a:solidFill>
+          <a:ln w="6350">
+            <a:solidFill>
+              <a:srgbClr val="D9D2C3"/>
+            </a:solidFill>
+          </a:ln>
+          <a:effectLst/>
+        </p:spPr>
+        <p:style>
+          <a:lnRef idx="1">
+            <a:schemeClr val="accent1"/>
+          </a:lnRef>
+          <a:fillRef idx="3">
+            <a:schemeClr val="accent1"/>
+          </a:fillRef>
+          <a:effectRef idx="2">
+            <a:schemeClr val="accent1"/>
+          </a:effectRef>
+          <a:fontRef idx="minor">
+            <a:schemeClr val="lt1"/>
+          </a:fontRef>
+        </p:style>
+        <p:txBody>
+          <a:bodyPr rtlCol="0" anchor="ctr"/>
+          <a:lstStyle/>
+          <a:p>
+            <a:pPr algn="ctr"/>
+          </a:p>
+        </p:txBody>
+      </p:sp>
+      <p:sp>
+        <p:nvSpPr>
+          <p:cNvPr id="17" name="TextBox 16"/>
+          <p:cNvSpPr txBox="1"/>
+          <p:nvPr/>
+        </p:nvSpPr>
+        <p:spPr>
+          <a:xfrm>
+            <a:off x="8485060" y="2150000"/>
+            <a:ext cx="2961130" cy="320000"/>
+          </a:xfrm>
+          <a:prstGeom prst="rect">
+            <a:avLst/>
+          </a:prstGeom>
+          <a:noFill/>
+        </p:spPr>
+        <p:txBody>
+          <a:bodyPr wrap="square" lIns="0" rIns="0" tIns="0" bIns="0" anchor="t">
+            <a:spAutoFit/>
+          </a:bodyPr>
+          <a:lstStyle/>
+          <a:p>
+            <a:pPr algn="l"/>
+            <a:r>
+              <a:rPr sz="1500" b="1">
+                <a:solidFill>
+                  <a:srgbClr val="1D2A24"/>
+                </a:solidFill>
+                <a:latin typeface="Inter"/>
+              </a:rPr>
+              <a:t>Statistik maʼlumotlar</a:t>
+            </a:r>
+          </a:p>
+        </p:txBody>
+      </p:sp>
+      <p:sp>
+        <p:nvSpPr>
+          <p:cNvPr id="18" name="TextBox 17"/>
+          <p:cNvSpPr txBox="1"/>
+          <p:nvPr/>
+        </p:nvSpPr>
+        <p:spPr>
+          <a:xfrm>
+            <a:off x="8485060" y="2650000"/>
+            <a:ext cx="2961130" cy="620000"/>
+          </a:xfrm>
+          <a:prstGeom prst="rect">
+            <a:avLst/>
+          </a:prstGeom>
+          <a:noFill/>
+        </p:spPr>
+        <p:txBody>
+          <a:bodyPr wrap="square" lIns="0" rIns="0" tIns="0" bIns="0" anchor="t">
+            <a:spAutoFit/>
+          </a:bodyPr>
+          <a:lstStyle/>
+          <a:p>
+            <a:pPr algn="l"/>
+            <a:r>
+              <a:rPr sz="1200" b="0">
+                <a:solidFill>
+                  <a:srgbClr val="4C5852"/>
+                </a:solidFill>
+                <a:latin typeface="Inter"/>
+              </a:rPr>
+              <a:t>Andijon, Fargʻona va Namangan viloyatlari ekin joylashtirish rejalari (2019–2026)</a:t>
+            </a:r>
+          </a:p>
+        </p:txBody>
+      </p:sp>
+      <p:sp>
+        <p:nvSpPr>
+          <p:cNvPr id="19" name="TextBox 18"/>
+          <p:cNvSpPr txBox="1"/>
+          <p:nvPr/>
+        </p:nvSpPr>
+        <p:spPr>
+          <a:xfrm>
+            <a:off x="8485060" y="3350000"/>
+            <a:ext cx="2961130" cy="620000"/>
+          </a:xfrm>
+          <a:prstGeom prst="rect">
+            <a:avLst/>
+          </a:prstGeom>
+          <a:noFill/>
+        </p:spPr>
+        <p:txBody>
+          <a:bodyPr wrap="square" lIns="0" rIns="0" tIns="0" bIns="0" anchor="t">
+            <a:spAutoFit/>
+          </a:bodyPr>
+          <a:lstStyle/>
+          <a:p>
+            <a:pPr algn="l"/>
+            <a:r>
+              <a:rPr sz="1200" b="0">
+                <a:solidFill>
+                  <a:srgbClr val="4C5852"/>
+                </a:solidFill>
+                <a:latin typeface="Inter"/>
+              </a:rPr>
+              <a:t>Norin-Sirdaryo va Sirdaryo-Soʻx ITHB hisobotlari (2019–2026)</a:t>
+            </a:r>
+          </a:p>
+        </p:txBody>
+      </p:sp>
+      <p:sp>
+        <p:nvSpPr>
+          <p:cNvPr id="20" name="TextBox 19"/>
+          <p:cNvSpPr txBox="1"/>
+          <p:nvPr/>
+        </p:nvSpPr>
+        <p:spPr>
+          <a:xfrm>
+            <a:off x="8485060" y="4050000"/>
+            <a:ext cx="2961130" cy="620000"/>
+          </a:xfrm>
+          <a:prstGeom prst="rect">
+            <a:avLst/>
+          </a:prstGeom>
+          <a:noFill/>
+        </p:spPr>
+        <p:txBody>
+          <a:bodyPr wrap="square" lIns="0" rIns="0" tIns="0" bIns="0" anchor="t">
+            <a:spAutoFit/>
+          </a:bodyPr>
+          <a:lstStyle/>
+          <a:p>
+            <a:pPr algn="l"/>
+            <a:r>
+              <a:rPr sz="1200" b="0">
+                <a:solidFill>
+                  <a:srgbClr val="4C5852"/>
+                </a:solidFill>
+                <a:latin typeface="Inter"/>
+              </a:rPr>
+              <a:t>Meliorativ ekspeditsiya shoʻr yuvish va yer hisobi maʼlumotlari</a:t>
+            </a:r>
+          </a:p>
+        </p:txBody>
+      </p:sp>
+    </p:spTree>
+  </p:cSld>
+  <p:clrMapOvr>
+    <a:masterClrMapping/>
+  </p:clrMapOvr>
+</p:sld>
+</file>
+
+<file path=ppt/slides/slide41.xml><?xml version="1.0" encoding="utf-8"?>
+<p:sld xmlns:a="http://schemas.openxmlformats.org/drawingml/2006/main" xmlns:p="http://schemas.openxmlformats.org/presentationml/2006/main" xmlns:r="http://schemas.openxmlformats.org/officeDocument/2006/relationships">
+  <p:cSld>
+    <p:bg>
+      <p:bgPr>
+        <a:solidFill>
+          <a:srgbClr val="F4F1EA"/>
+        </a:solidFill>
+      </p:bgPr>
+    </p:bg>
+    <p:spTree>
+      <p:nvGrpSpPr>
+        <p:cNvPr id="1" name=""/>
+        <p:cNvGrpSpPr/>
+        <p:nvPr/>
+      </p:nvGrpSpPr>
+      <p:grpSpPr/>
+      <p:sp>
+        <p:nvSpPr>
+          <p:cNvPr id="2" name="Text 0"/>
+          <p:cNvSpPr/>
+          <p:nvPr/>
+        </p:nvSpPr>
+        <p:spPr>
+          <a:xfrm>
+            <a:off x="812800" y="812800"/>
+            <a:ext cx="10883392" cy="238720"/>
+          </a:xfrm>
+          <a:prstGeom prst="rect">
+            <a:avLst/>
+          </a:prstGeom>
+          <a:noFill/>
+          <a:ln/>
+        </p:spPr>
+        <p:txBody>
+          <a:bodyPr wrap="square" lIns="0" tIns="0" rIns="0" bIns="0" rtlCol="0" anchor="t">
+            <a:normAutofit/>
+          </a:bodyPr>
+          <a:lstStyle/>
+          <a:p>
+            <a:pPr algn="l" indent="0" marL="0">
+              <a:lnSpc>
+                <a:spcPts val="1680"/>
+              </a:lnSpc>
+              <a:buNone/>
+            </a:pPr>
+            <a:r>
+              <a:rPr lang="en-US" sz="1200" b="1" spc="150" kern="0" dirty="0">
+                <a:solidFill>
+                  <a:srgbClr val="2C6A85"/>
+                </a:solidFill>
+                <a:latin typeface="Inter" pitchFamily="34" charset="0"/>
+                <a:ea typeface="Inter" pitchFamily="34" charset="-122"/>
+                <a:cs typeface="Inter" pitchFamily="34" charset="-120"/>
+              </a:rPr>
+              <a:t>19 · ILOVA</a:t>
+            </a:r>
+            <a:endParaRPr lang="en-US" sz="1200" dirty="0"/>
+          </a:p>
+        </p:txBody>
+      </p:sp>
+      <p:sp>
+        <p:nvSpPr>
+          <p:cNvPr id="3" name="Text 1"/>
+          <p:cNvSpPr/>
+          <p:nvPr>
+            <p:ph type="title"/>
+          </p:nvPr>
+        </p:nvSpPr>
+        <p:spPr>
+          <a:xfrm>
+            <a:off x="812800" y="1127720"/>
+            <a:ext cx="10883392" cy="472430"/>
+          </a:xfrm>
+          <a:prstGeom prst="rect">
+            <a:avLst/>
+          </a:prstGeom>
+          <a:noFill/>
+          <a:ln/>
+        </p:spPr>
+        <p:txBody>
+          <a:bodyPr wrap="square" lIns="0" tIns="0" rIns="0" bIns="0" rtlCol="0" anchor="t">
+            <a:normAutofit/>
+          </a:bodyPr>
+          <a:lstStyle/>
+          <a:p>
+            <a:pPr algn="l" indent="0" marL="0">
+              <a:lnSpc>
+                <a:spcPts val="3520"/>
+              </a:lnSpc>
+              <a:buNone/>
+            </a:pPr>
+            <a:r>
+              <a:rPr lang="en-US" sz="3200" b="0" i="0" dirty="0">
+                <a:solidFill>
+                  <a:srgbClr val="1D2A24"/>
+                </a:solidFill>
+                <a:latin typeface="Source Serif 4" pitchFamily="18" charset="0"/>
+                <a:ea typeface="Source Serif 4" pitchFamily="18" charset="-122"/>
+                <a:cs typeface="Source Serif 4" pitchFamily="18" charset="-120"/>
+              </a:rPr>
+              <a:t>Ilova: dastlabki maʼlumotlar tahlili</a:t>
+            </a:r>
+            <a:endParaRPr lang="en-US" sz="3200" dirty="0"/>
+          </a:p>
+        </p:txBody>
+      </p:sp>
+      <p:sp>
+        <p:nvSpPr>
+          <p:cNvPr id="6" name="Text 3"/>
+          <p:cNvSpPr/>
+          <p:nvPr/>
+        </p:nvSpPr>
+        <p:spPr>
+          <a:xfrm>
+            <a:off x="11137950" y="6238280"/>
+            <a:ext cx="241250" cy="238720"/>
+          </a:xfrm>
+          <a:prstGeom prst="rect">
+            <a:avLst/>
+          </a:prstGeom>
+          <a:noFill/>
+          <a:ln/>
+        </p:spPr>
+        <p:txBody>
+          <a:bodyPr wrap="square" lIns="0" tIns="0" rIns="0" bIns="0" rtlCol="0" anchor="t">
+            <a:normAutofit/>
+          </a:bodyPr>
+          <a:lstStyle/>
+          <a:p>
+            <a:pPr algn="r" indent="0" marL="0">
+              <a:lnSpc>
+                <a:spcPts val="1680"/>
+              </a:lnSpc>
+              <a:buNone/>
+            </a:pPr>
+            <a:r>
+              <a:rPr lang="en-US" sz="1200" dirty="0">
+                <a:solidFill>
+                  <a:srgbClr val="5F6B64"/>
+                </a:solidFill>
+                <a:latin typeface="Inter" pitchFamily="34" charset="0"/>
+                <a:ea typeface="Inter" pitchFamily="34" charset="-122"/>
+                <a:cs typeface="Inter" pitchFamily="34" charset="-120"/>
+              </a:rPr>
+              <a:t>20</a:t>
+            </a:r>
+            <a:endParaRPr lang="en-US" sz="1200" dirty="0"/>
+          </a:p>
+        </p:txBody>
+      </p:sp>
+      <p:sp>
+        <p:nvSpPr>
+          <p:cNvPr id="7" name="TextBox 6"/>
+          <p:cNvSpPr txBox="1"/>
+          <p:nvPr/>
+        </p:nvSpPr>
+        <p:spPr>
+          <a:xfrm>
+            <a:off x="812800" y="2000000"/>
+            <a:ext cx="9500000" cy="1500000"/>
+          </a:xfrm>
+          <a:prstGeom prst="rect">
+            <a:avLst/>
+          </a:prstGeom>
+          <a:noFill/>
+        </p:spPr>
+        <p:txBody>
+          <a:bodyPr wrap="square" lIns="0" rIns="0" tIns="0" bIns="0" anchor="t">
+            <a:spAutoFit/>
+          </a:bodyPr>
+          <a:lstStyle/>
+          <a:p>
+            <a:pPr algn="l"/>
+            <a:r>
+              <a:rPr sz="1800" b="0">
+                <a:solidFill>
+                  <a:srgbClr val="1D2A24"/>
+                </a:solidFill>
+                <a:latin typeface="Inter"/>
+              </a:rPr>
+              <a:t>Quyidagi slaydlarda Andijon, Namangan va Fargʻona viloyatlari boʻyicha toʻplangan dastlabki maʼlumotlar keltirilgan: sugʻoriladigan yerlar shoʻrlanishi, ekin joylashtirish, suv taʼminoti va shoʻr yuvish, tuproq gumusi va bonitet.</a:t>
+            </a:r>
+          </a:p>
+        </p:txBody>
+      </p:sp>
+      <p:sp>
+        <p:nvSpPr>
+          <p:cNvPr id="8" name="TextBox 7"/>
+          <p:cNvSpPr txBox="1"/>
+          <p:nvPr/>
+        </p:nvSpPr>
+        <p:spPr>
+          <a:xfrm>
+            <a:off x="812800" y="3700000"/>
+            <a:ext cx="9500000" cy="800000"/>
+          </a:xfrm>
+          <a:prstGeom prst="rect">
+            <a:avLst/>
+          </a:prstGeom>
+          <a:noFill/>
+        </p:spPr>
+        <p:txBody>
+          <a:bodyPr wrap="square" lIns="0" rIns="0" tIns="0" bIns="0" anchor="t">
+            <a:spAutoFit/>
+          </a:bodyPr>
+          <a:lstStyle/>
+          <a:p>
+            <a:pPr algn="l"/>
+            <a:r>
+              <a:rPr sz="1400" b="0">
+                <a:solidFill>
+                  <a:srgbClr val="4C5852"/>
+                </a:solidFill>
+                <a:latin typeface="Inter"/>
+              </a:rPr>
+              <a:t>Bu slaydlar asosiy taqdimotga kirmaydi; savollar va muhokama uchun zaxira sifatida foydalaniladi.</a:t>
+            </a:r>
           </a:p>
         </p:txBody>
       </p:sp>
@@ -30674,6 +32430,10 @@
             <a:prstDash val="solid"/>
           </a:ln>
         </p:spPr>
+        <p:txBody>
+          <a:bodyPr/>
+          <a:p/>
+        </p:txBody>
       </p:sp>
       <p:sp>
         <p:nvSpPr>
@@ -30833,6 +32593,10 @@
             <a:prstDash val="solid"/>
           </a:ln>
         </p:spPr>
+        <p:txBody>
+          <a:bodyPr/>
+          <a:p/>
+        </p:txBody>
       </p:sp>
       <p:sp>
         <p:nvSpPr>
@@ -30992,6 +32756,10 @@
             <a:prstDash val="solid"/>
           </a:ln>
         </p:spPr>
+        <p:txBody>
+          <a:bodyPr/>
+          <a:p/>
+        </p:txBody>
       </p:sp>
       <p:sp>
         <p:nvSpPr>
@@ -31239,7 +33007,7 @@
                 <a:ea typeface="Inter" pitchFamily="34" charset="-122"/>
                 <a:cs typeface="Inter" pitchFamily="34" charset="-120"/>
               </a:rPr>
-              <a:t>05 · TADQIQOT ASOSLARI</a:t>
+              <a:t>12 · TADQIQOT ASOSLARI</a:t>
             </a:r>
             <a:endParaRPr lang="en-US" sz="1200" dirty="0"/>
           </a:p>
@@ -31312,6 +33080,10 @@
           </a:solidFill>
           <a:ln/>
         </p:spPr>
+        <p:txBody>
+          <a:bodyPr/>
+          <a:p/>
+        </p:txBody>
       </p:sp>
       <p:sp>
         <p:nvSpPr>
@@ -31422,6 +33194,10 @@
           </a:solidFill>
           <a:ln/>
         </p:spPr>
+        <p:txBody>
+          <a:bodyPr/>
+          <a:p/>
+        </p:txBody>
       </p:sp>
       <p:sp>
         <p:nvSpPr>
@@ -31532,6 +33308,10 @@
           </a:solidFill>
           <a:ln/>
         </p:spPr>
+        <p:txBody>
+          <a:bodyPr/>
+          <a:p/>
+        </p:txBody>
       </p:sp>
       <p:sp>
         <p:nvSpPr>
@@ -31642,6 +33422,10 @@
           </a:solidFill>
           <a:ln/>
         </p:spPr>
+        <p:txBody>
+          <a:bodyPr/>
+          <a:p/>
+        </p:txBody>
       </p:sp>
       <p:sp>
         <p:nvSpPr>
@@ -31769,7 +33553,7 @@
                 <a:ea typeface="Inter" pitchFamily="34" charset="-122"/>
                 <a:cs typeface="Inter" pitchFamily="34" charset="-120"/>
               </a:rPr>
-              <a:t>06</a:t>
+              <a:t>13</a:t>
             </a:r>
             <a:endParaRPr lang="en-US" sz="1200" dirty="0"/>
           </a:p>
@@ -31845,7 +33629,7 @@
                 <a:ea typeface="Inter" pitchFamily="34" charset="-122"/>
                 <a:cs typeface="Inter" pitchFamily="34" charset="-120"/>
               </a:rPr>
-              <a:t>06 · TADQIQOT ASOSLARI</a:t>
+              <a:t>13 · TADQIQOT ASOSLARI</a:t>
             </a:r>
             <a:endParaRPr lang="en-US" sz="1200" dirty="0"/>
           </a:p>
@@ -31919,6 +33703,10 @@
             <a:prstDash val="solid"/>
           </a:ln>
         </p:spPr>
+        <p:txBody>
+          <a:bodyPr/>
+          <a:p/>
+        </p:txBody>
       </p:sp>
       <p:sp>
         <p:nvSpPr>
@@ -32030,6 +33818,10 @@
             <a:prstDash val="solid"/>
           </a:ln>
         </p:spPr>
+        <p:txBody>
+          <a:bodyPr/>
+          <a:p/>
+        </p:txBody>
       </p:sp>
       <p:sp>
         <p:nvSpPr>
@@ -32141,6 +33933,10 @@
             <a:prstDash val="solid"/>
           </a:ln>
         </p:spPr>
+        <p:txBody>
+          <a:bodyPr/>
+          <a:p/>
+        </p:txBody>
       </p:sp>
       <p:sp>
         <p:nvSpPr>
@@ -32164,6 +33960,10 @@
             <a:prstDash val="solid"/>
           </a:ln>
         </p:spPr>
+        <p:txBody>
+          <a:bodyPr/>
+          <a:p/>
+        </p:txBody>
       </p:sp>
       <p:sp>
         <p:nvSpPr>
@@ -32291,7 +34091,7 @@
                 <a:ea typeface="Inter" pitchFamily="34" charset="-122"/>
                 <a:cs typeface="Inter" pitchFamily="34" charset="-120"/>
               </a:rPr>
-              <a:t>07</a:t>
+              <a:t>14</a:t>
             </a:r>
             <a:endParaRPr lang="en-US" sz="1200" dirty="0"/>
           </a:p>
@@ -34349,6 +36149,10 @@
           </a:solidFill>
           <a:ln/>
         </p:spPr>
+        <p:txBody>
+          <a:bodyPr/>
+          <a:p/>
+        </p:txBody>
       </p:sp>
       <p:sp>
         <p:nvSpPr>
@@ -34397,6 +36201,10 @@
           </a:solidFill>
           <a:ln/>
         </p:spPr>
+        <p:txBody>
+          <a:bodyPr/>
+          <a:p/>
+        </p:txBody>
       </p:sp>
       <p:sp>
         <p:nvSpPr>
@@ -34595,6 +36403,10 @@
           </a:solidFill>
           <a:ln/>
         </p:spPr>
+        <p:txBody>
+          <a:bodyPr/>
+          <a:p/>
+        </p:txBody>
       </p:sp>
       <p:sp>
         <p:nvSpPr>
@@ -34643,6 +36455,10 @@
           </a:solidFill>
           <a:ln/>
         </p:spPr>
+        <p:txBody>
+          <a:bodyPr/>
+          <a:p/>
+        </p:txBody>
       </p:sp>
       <p:sp>
         <p:nvSpPr>
@@ -34841,6 +36657,10 @@
           </a:solidFill>
           <a:ln/>
         </p:spPr>
+        <p:txBody>
+          <a:bodyPr/>
+          <a:p/>
+        </p:txBody>
       </p:sp>
       <p:sp>
         <p:nvSpPr>
@@ -34889,6 +36709,10 @@
           </a:solidFill>
           <a:ln/>
         </p:spPr>
+        <p:txBody>
+          <a:bodyPr/>
+          <a:p/>
+        </p:txBody>
       </p:sp>
       <p:sp>
         <p:nvSpPr>
@@ -35087,6 +36911,10 @@
           </a:solidFill>
           <a:ln/>
         </p:spPr>
+        <p:txBody>
+          <a:bodyPr/>
+          <a:p/>
+        </p:txBody>
       </p:sp>
       <p:sp>
         <p:nvSpPr>
@@ -35135,6 +36963,10 @@
           </a:solidFill>
           <a:ln/>
         </p:spPr>
+        <p:txBody>
+          <a:bodyPr/>
+          <a:p/>
+        </p:txBody>
       </p:sp>
       <p:sp>
         <p:nvSpPr>
@@ -35333,6 +37165,10 @@
           </a:solidFill>
           <a:ln/>
         </p:spPr>
+        <p:txBody>
+          <a:bodyPr/>
+          <a:p/>
+        </p:txBody>
       </p:sp>
       <p:sp>
         <p:nvSpPr>
@@ -35381,6 +37217,10 @@
           </a:solidFill>
           <a:ln/>
         </p:spPr>
+        <p:txBody>
+          <a:bodyPr/>
+          <a:p/>
+        </p:txBody>
       </p:sp>
       <p:sp>
         <p:nvSpPr>

</xml_diff>